<commit_message>
Slides: slide 1 uses the report's 30-76 dB radial axis so the red curve can be compared with the 30 Sep one later
Co-Authored-By: Claude Sonnet 5.5 <noreply@anthropic.com>
</commit_message>
<xml_diff>
--- a/docs/analysis/chamber-final-2026-10-01/slides/chamber-slides.pptx
+++ b/docs/analysis/chamber-final-2026-10-01/slides/chamber-slides.pptx
@@ -502,7 +502,7 @@
           <a:p>
             <a:r>
               <a:rPr lang="en-US" dirty="0"/>
-              <a:t>Data: the 31 Aug 2026 horizontal baseline (arc laid flat, propeller axis vertical), propeller at PWM 2000, total level 20-560 Hz per microphone, read with the factory calibration files as it was measured. Rms spread about the mean 2.05 dB, range 6.7 dB (63.9 to 70.6 dB SPL). The radial axis is zoomed to 56-72 dB so the outline is visible; on a 0-80 dB axis the same curve looks much rounder.</a:t>
+              <a:t>Data: the 31 Aug 2026 horizontal baseline (arc laid flat, propeller axis vertical), propeller at PWM 2000, total level 20-560 Hz per microphone, read with the factory calibration files as it was measured. Rms spread about the mean 2.05 dB, range 6.7 dB (63.9 to 70.6 dB SPL). The radial axis is 30-76 dB, the same as the report polars, so the same red curve can be shown against the 30 Sep measurement on a later slide. On a 0-80 dB axis the same curve looks rounder.</a:t>
             </a:r>
             <a:endParaRPr lang="en-US" dirty="0"/>
           </a:p>
@@ -1173,7 +1173,7 @@
                 <a:ea typeface="Calibri" pitchFamily="34" charset="-122"/>
                 <a:cs typeface="Calibri" pitchFamily="34" charset="-120"/>
               </a:rPr>
-              <a:t>31 Aug 2026, 20–560 Hz, motor at 2000 µs. Radial axis zoomed to 56–72 dB.</a:t>
+              <a:t>31 Aug 2026, 20–560 Hz, motor at 2000 µs. Radial axis 30–76 dB, the same as in the report.</a:t>
             </a:r>
             <a:endParaRPr lang="en-US" sz="1100" dirty="0"/>
           </a:p>

</xml_diff>

<commit_message>
Slides: slide 2, the 30 Sep polar over the 31 Aug one on the same axes
Co-Authored-By: Claude Sonnet 5.5 <noreply@anthropic.com>
</commit_message>
<xml_diff>
--- a/docs/analysis/chamber-final-2026-10-01/slides/chamber-slides.pptx
+++ b/docs/analysis/chamber-final-2026-10-01/slides/chamber-slides.pptx
@@ -6,9 +6,10 @@
   </p:sldMasterIdLst>
   <p:sldIdLst>
     <p:sldId id="256" r:id="rId2"/>
+    <p:sldId id="257" r:id="rId3"/>
   </p:sldIdLst>
   <p:notesMasterIdLst>
-    <p:notesMasterId r:id="rId3"/>
+    <p:notesMasterId r:id="rId4"/>
   </p:notesMasterIdLst>
   <p:sldSz cx="12192000" cy="6858000"/>
   <p:notesSz cx="6858000" cy="12192000"/>
@@ -526,6 +527,94 @@
             <a:fld id="{F7021451-1387-4CA6-816F-3879F97B5CBC}" type="slidenum">
               <a:rPr lang="en-US"/>
               <a:t>1</a:t>
+            </a:fld>
+            <a:endParaRPr lang="en-US"/>
+          </a:p>
+        </p:txBody>
+      </p:sp>
+    </p:spTree>
+    <p:extLst>
+      <p:ext uri="{BB962C8B-B14F-4D97-AF65-F5344CB8AC3E}">
+        <p14:creationId xmlns:p14="http://schemas.microsoft.com/office/powerpoint/2010/main" val="1024086991"/>
+      </p:ext>
+    </p:extLst>
+  </p:cSld>
+  <p:clrMapOvr>
+    <a:masterClrMapping/>
+  </p:clrMapOvr>
+</p:notes>
+</file>
+
+<file path=ppt/notesSlides/notesSlide2.xml><?xml version="1.0" encoding="utf-8"?>
+<p:notes xmlns:a="http://schemas.openxmlformats.org/drawingml/2006/main" xmlns:r="http://schemas.openxmlformats.org/officeDocument/2006/relationships" xmlns:p="http://schemas.openxmlformats.org/presentationml/2006/main">
+  <p:cSld>
+    <p:spTree>
+      <p:nvGrpSpPr>
+        <p:cNvPr id="1" name=""/>
+        <p:cNvGrpSpPr/>
+        <p:nvPr/>
+      </p:nvGrpSpPr>
+      <p:grpSpPr>
+        <a:xfrm>
+          <a:off x="0" y="0"/>
+          <a:ext cx="0" cy="0"/>
+          <a:chOff x="0" y="0"/>
+          <a:chExt cx="0" cy="0"/>
+        </a:xfrm>
+      </p:grpSpPr>
+      <p:sp>
+        <p:nvSpPr>
+          <p:cNvPr id="2" name="Slide Image Placeholder 1"/>
+          <p:cNvSpPr>
+            <a:spLocks noGrp="1" noRot="1" noChangeAspect="1"/>
+          </p:cNvSpPr>
+          <p:nvPr>
+            <p:ph type="sldImg"/>
+          </p:nvPr>
+        </p:nvSpPr>
+        <p:spPr/>
+      </p:sp>
+      <p:sp>
+        <p:nvSpPr>
+          <p:cNvPr id="3" name="Notes Placeholder 2"/>
+          <p:cNvSpPr>
+            <a:spLocks noGrp="1"/>
+          </p:cNvSpPr>
+          <p:nvPr>
+            <p:ph type="body" idx="1"/>
+          </p:nvPr>
+        </p:nvSpPr>
+        <p:spPr/>
+        <p:txBody>
+          <a:bodyPr/>
+          <a:lstStyle/>
+          <a:p>
+            <a:r>
+              <a:rPr lang="en-US" dirty="0"/>
+              <a:t>Blue: 30 Sep propeller measurement (11.7 V, 7.3 A, thrust -4 N), read with the 16 Sep microphone corrections. Rms spread about the mean 1.45 dB against 2.05 dB for 31 Aug; range 4.0 dB (55.5 to 59.6 dB SPL) against 6.7 dB. The blue is about 11 dB lower because the motor ran at a different operating point. The 4 dB range of the blue is a bottom-louder trend. Honest caveat: with the same calibration applied to the 1-2 Sep runs, those are about as round as 30 Sep, so most of the improvement against the earlier baselines comes from the microphone calibration, not the room.</a:t>
+            </a:r>
+            <a:endParaRPr lang="en-US" dirty="0"/>
+          </a:p>
+        </p:txBody>
+      </p:sp>
+      <p:sp>
+        <p:nvSpPr>
+          <p:cNvPr id="4" name="Slide Number Placeholder 3"/>
+          <p:cNvSpPr>
+            <a:spLocks noGrp="1"/>
+          </p:cNvSpPr>
+          <p:nvPr>
+            <p:ph type="sldNum" sz="quarter" idx="10"/>
+          </p:nvPr>
+        </p:nvSpPr>
+        <p:spPr/>
+        <p:txBody>
+          <a:bodyPr/>
+          <a:lstStyle/>
+          <a:p>
+            <a:fld id="{F7021451-1387-4CA6-816F-3879F97B5CBC}" type="slidenum">
+              <a:rPr lang="en-US"/>
+              <a:t>2</a:t>
             </a:fld>
             <a:endParaRPr lang="en-US"/>
           </a:p>
@@ -1174,6 +1263,370 @@
                 <a:cs typeface="Calibri" pitchFamily="34" charset="-120"/>
               </a:rPr>
               <a:t>31 Aug 2026, 20–560 Hz, motor at 2000 µs. Radial axis 30–76 dB, the same as in the report.</a:t>
+            </a:r>
+            <a:endParaRPr lang="en-US" sz="1100" dirty="0"/>
+          </a:p>
+        </p:txBody>
+      </p:sp>
+    </p:spTree>
+  </p:cSld>
+  <p:clrMapOvr>
+    <a:masterClrMapping/>
+  </p:clrMapOvr>
+</p:sld>
+</file>
+
+<file path=ppt/slides/slide2.xml><?xml version="1.0" encoding="utf-8"?>
+<p:sld xmlns:a="http://schemas.openxmlformats.org/drawingml/2006/main" xmlns:r="http://schemas.openxmlformats.org/officeDocument/2006/relationships" xmlns:p="http://schemas.openxmlformats.org/presentationml/2006/main">
+  <p:cSld name="Slide 2">
+    <p:bg>
+      <p:bgPr>
+        <a:solidFill>
+          <a:srgbClr val="FFFFFF"/>
+        </a:solidFill>
+      </p:bgPr>
+    </p:bg>
+    <p:spTree>
+      <p:nvGrpSpPr>
+        <p:cNvPr id="1" name=""/>
+        <p:cNvGrpSpPr/>
+        <p:nvPr/>
+      </p:nvGrpSpPr>
+      <p:grpSpPr>
+        <a:xfrm>
+          <a:off x="0" y="0"/>
+          <a:ext cx="0" cy="0"/>
+          <a:chOff x="0" y="0"/>
+          <a:chExt cx="0" cy="0"/>
+        </a:xfrm>
+      </p:grpSpPr>
+      <p:pic>
+        <p:nvPicPr>
+          <p:cNvPr id="2" name="Image 0" descr="Polar plot of 20 to 560 Hz: the jagged red 31 Aug outline and the smoother blue 30 Sep outline">    </p:cNvPr>
+          <p:cNvPicPr>
+            <a:picLocks noChangeAspect="1"/>
+          </p:cNvPicPr>
+          <p:nvPr/>
+        </p:nvPicPr>
+        <p:blipFill>
+          <a:blip r:embed="rId1"/>
+          <a:stretch>
+            <a:fillRect/>
+          </a:stretch>
+        </p:blipFill>
+        <p:spPr>
+          <a:xfrm>
+            <a:off x="548640" y="457200"/>
+            <a:ext cx="5440680" cy="5797296"/>
+          </a:xfrm>
+          <a:prstGeom prst="rect">
+            <a:avLst/>
+          </a:prstGeom>
+        </p:spPr>
+      </p:pic>
+      <p:sp>
+        <p:nvSpPr>
+          <p:cNvPr id="3" name="Text 0"/>
+          <p:cNvSpPr txBox="1"/>
+          <p:nvPr/>
+        </p:nvSpPr>
+        <p:spPr>
+          <a:xfrm>
+            <a:off x="6766560" y="822960"/>
+            <a:ext cx="4846320" cy="365760"/>
+          </a:xfrm>
+          <a:prstGeom prst="rect">
+            <a:avLst/>
+          </a:prstGeom>
+          <a:noFill/>
+          <a:ln/>
+        </p:spPr>
+        <p:txBody>
+          <a:bodyPr wrap="square" lIns="0" tIns="0" rIns="0" bIns="0" rtlCol="0" anchor="ctr"/>
+          <a:lstStyle/>
+          <a:p>
+            <a:pPr indent="0" marL="0">
+              <a:buNone/>
+            </a:pPr>
+            <a:r>
+              <a:rPr lang="en-US" sz="1400" b="1" spc="300" kern="0" dirty="0">
+                <a:solidFill>
+                  <a:srgbClr val="2B6CB0"/>
+                </a:solidFill>
+                <a:latin typeface="Calibri" pitchFamily="34" charset="0"/>
+                <a:ea typeface="Calibri" pitchFamily="34" charset="-122"/>
+                <a:cs typeface="Calibri" pitchFamily="34" charset="-120"/>
+              </a:rPr>
+              <a:t>AFTER</a:t>
+            </a:r>
+            <a:endParaRPr lang="en-US" sz="1400" dirty="0"/>
+          </a:p>
+        </p:txBody>
+      </p:sp>
+      <p:sp>
+        <p:nvSpPr>
+          <p:cNvPr id="4" name="Text 1"/>
+          <p:cNvSpPr txBox="1"/>
+          <p:nvPr/>
+        </p:nvSpPr>
+        <p:spPr>
+          <a:xfrm>
+            <a:off x="6766560" y="1188720"/>
+            <a:ext cx="4846320" cy="1188720"/>
+          </a:xfrm>
+          <a:prstGeom prst="rect">
+            <a:avLst/>
+          </a:prstGeom>
+          <a:noFill/>
+          <a:ln/>
+        </p:spPr>
+        <p:txBody>
+          <a:bodyPr wrap="square" lIns="0" tIns="0" rIns="0" bIns="0" rtlCol="0" anchor="t"/>
+          <a:lstStyle/>
+          <a:p>
+            <a:pPr indent="0" marL="0">
+              <a:buNone/>
+            </a:pPr>
+            <a:r>
+              <a:rPr lang="en-US" sz="3400" b="1" dirty="0">
+                <a:solidFill>
+                  <a:srgbClr val="1F2A44"/>
+                </a:solidFill>
+                <a:latin typeface="Cambria" pitchFamily="34" charset="0"/>
+                <a:ea typeface="Cambria" pitchFamily="34" charset="-122"/>
+                <a:cs typeface="Cambria" pitchFamily="34" charset="-120"/>
+              </a:rPr>
+              <a:t>The new polar is rounder</a:t>
+            </a:r>
+            <a:endParaRPr lang="en-US" sz="3400" dirty="0"/>
+          </a:p>
+        </p:txBody>
+      </p:sp>
+      <p:sp>
+        <p:nvSpPr>
+          <p:cNvPr id="5" name="Text 2"/>
+          <p:cNvSpPr txBox="1"/>
+          <p:nvPr/>
+        </p:nvSpPr>
+        <p:spPr>
+          <a:xfrm>
+            <a:off x="6766560" y="2514600"/>
+            <a:ext cx="4846320" cy="2377440"/>
+          </a:xfrm>
+          <a:prstGeom prst="rect">
+            <a:avLst/>
+          </a:prstGeom>
+          <a:noFill/>
+          <a:ln/>
+        </p:spPr>
+        <p:txBody>
+          <a:bodyPr wrap="square" lIns="0" tIns="0" rIns="0" bIns="0" rtlCol="0" anchor="t"/>
+          <a:lstStyle/>
+          <a:p>
+            <a:pPr marL="342900" indent="-342900">
+              <a:spcAft>
+                <a:spcPts val="1000"/>
+              </a:spcAft>
+              <a:buSzPct val="100000"/>
+              <a:buChar char="•"/>
+            </a:pPr>
+            <a:r>
+              <a:rPr lang="en-US" sz="1600" dirty="0">
+                <a:solidFill>
+                  <a:srgbClr val="1F2A44"/>
+                </a:solidFill>
+                <a:latin typeface="Calibri" pitchFamily="34" charset="0"/>
+                <a:ea typeface="Calibri" pitchFamily="34" charset="-122"/>
+                <a:cs typeface="Calibri" pitchFamily="34" charset="-120"/>
+              </a:rPr>
+              <a:t>Same kind of measurement, same axes, on 30 Sep.</a:t>
+            </a:r>
+            <a:endParaRPr lang="en-US" sz="1600" dirty="0"/>
+          </a:p>
+          <a:p>
+            <a:pPr marL="342900" indent="-342900">
+              <a:spcAft>
+                <a:spcPts val="1000"/>
+              </a:spcAft>
+              <a:buSzPct val="100000"/>
+              <a:buChar char="•"/>
+            </a:pPr>
+            <a:r>
+              <a:rPr lang="en-US" sz="1600" dirty="0">
+                <a:solidFill>
+                  <a:srgbClr val="1F2A44"/>
+                </a:solidFill>
+                <a:latin typeface="Calibri" pitchFamily="34" charset="0"/>
+                <a:ea typeface="Calibri" pitchFamily="34" charset="-122"/>
+                <a:cs typeface="Calibri" pitchFamily="34" charset="-120"/>
+              </a:rPr>
+              <a:t>The microphones now carry their measured corrections, and the room has been treated.</a:t>
+            </a:r>
+            <a:endParaRPr lang="en-US" sz="1600" dirty="0"/>
+          </a:p>
+          <a:p>
+            <a:pPr marL="342900" indent="-342900">
+              <a:spcAft>
+                <a:spcPts val="1000"/>
+              </a:spcAft>
+              <a:buSzPct val="100000"/>
+              <a:buChar char="•"/>
+            </a:pPr>
+            <a:r>
+              <a:rPr lang="en-US" sz="1600" b="1" dirty="0">
+                <a:solidFill>
+                  <a:srgbClr val="1F2A44"/>
+                </a:solidFill>
+                <a:latin typeface="Calibri" pitchFamily="34" charset="0"/>
+                <a:ea typeface="Calibri" pitchFamily="34" charset="-122"/>
+                <a:cs typeface="Calibri" pitchFamily="34" charset="-120"/>
+              </a:rPr>
+              <a:t>The outline is smooth and close to a circle.</a:t>
+            </a:r>
+            <a:endParaRPr lang="en-US" sz="1600" dirty="0"/>
+          </a:p>
+        </p:txBody>
+      </p:sp>
+      <p:sp>
+        <p:nvSpPr>
+          <p:cNvPr id="6" name="Text 3"/>
+          <p:cNvSpPr txBox="1"/>
+          <p:nvPr/>
+        </p:nvSpPr>
+        <p:spPr>
+          <a:xfrm>
+            <a:off x="6766560" y="5029200"/>
+            <a:ext cx="4846320" cy="731520"/>
+          </a:xfrm>
+          <a:prstGeom prst="rect">
+            <a:avLst/>
+          </a:prstGeom>
+          <a:noFill/>
+          <a:ln/>
+        </p:spPr>
+        <p:txBody>
+          <a:bodyPr wrap="square" lIns="0" tIns="0" rIns="0" bIns="0" rtlCol="0" anchor="ctr"/>
+          <a:lstStyle/>
+          <a:p>
+            <a:pPr indent="0" marL="0">
+              <a:buNone/>
+            </a:pPr>
+            <a:r>
+              <a:rPr lang="en-US" sz="4800" b="1" dirty="0">
+                <a:solidFill>
+                  <a:srgbClr val="D6336C"/>
+                </a:solidFill>
+                <a:latin typeface="Cambria" pitchFamily="34" charset="0"/>
+                <a:ea typeface="Cambria" pitchFamily="34" charset="-122"/>
+                <a:cs typeface="Cambria" pitchFamily="34" charset="-120"/>
+              </a:rPr>
+              <a:t>6.7</a:t>
+            </a:r>
+            <a:pPr indent="0" marL="0">
+              <a:buNone/>
+            </a:pPr>
+            <a:r>
+              <a:rPr lang="en-US" sz="4800" b="1" dirty="0">
+                <a:solidFill>
+                  <a:srgbClr val="5B6578"/>
+                </a:solidFill>
+                <a:latin typeface="Cambria" pitchFamily="34" charset="0"/>
+                <a:ea typeface="Cambria" pitchFamily="34" charset="-122"/>
+                <a:cs typeface="Cambria" pitchFamily="34" charset="-120"/>
+              </a:rPr>
+              <a:t> → </a:t>
+            </a:r>
+            <a:pPr indent="0" marL="0">
+              <a:buNone/>
+            </a:pPr>
+            <a:r>
+              <a:rPr lang="en-US" sz="4800" b="1" dirty="0">
+                <a:solidFill>
+                  <a:srgbClr val="2B6CB0"/>
+                </a:solidFill>
+                <a:latin typeface="Cambria" pitchFamily="34" charset="0"/>
+                <a:ea typeface="Cambria" pitchFamily="34" charset="-122"/>
+                <a:cs typeface="Cambria" pitchFamily="34" charset="-120"/>
+              </a:rPr>
+              <a:t>4.0 dB</a:t>
+            </a:r>
+            <a:endParaRPr lang="en-US" sz="4800" dirty="0"/>
+          </a:p>
+        </p:txBody>
+      </p:sp>
+      <p:sp>
+        <p:nvSpPr>
+          <p:cNvPr id="7" name="Text 4"/>
+          <p:cNvSpPr txBox="1"/>
+          <p:nvPr/>
+        </p:nvSpPr>
+        <p:spPr>
+          <a:xfrm>
+            <a:off x="6766560" y="5760720"/>
+            <a:ext cx="4846320" cy="457200"/>
+          </a:xfrm>
+          <a:prstGeom prst="rect">
+            <a:avLst/>
+          </a:prstGeom>
+          <a:noFill/>
+          <a:ln/>
+        </p:spPr>
+        <p:txBody>
+          <a:bodyPr wrap="square" lIns="0" tIns="0" rIns="0" bIns="0" rtlCol="0" anchor="ctr"/>
+          <a:lstStyle/>
+          <a:p>
+            <a:pPr indent="0" marL="0">
+              <a:buNone/>
+            </a:pPr>
+            <a:r>
+              <a:rPr lang="en-US" sz="1400" dirty="0">
+                <a:solidFill>
+                  <a:srgbClr val="5B6578"/>
+                </a:solidFill>
+                <a:latin typeface="Calibri" pitchFamily="34" charset="0"/>
+                <a:ea typeface="Calibri" pitchFamily="34" charset="-122"/>
+                <a:cs typeface="Calibri" pitchFamily="34" charset="-120"/>
+              </a:rPr>
+              <a:t>between the loudest and quietest microphone</a:t>
+            </a:r>
+            <a:endParaRPr lang="en-US" sz="1400" dirty="0"/>
+          </a:p>
+        </p:txBody>
+      </p:sp>
+      <p:sp>
+        <p:nvSpPr>
+          <p:cNvPr id="8" name="Text 5"/>
+          <p:cNvSpPr txBox="1"/>
+          <p:nvPr/>
+        </p:nvSpPr>
+        <p:spPr>
+          <a:xfrm>
+            <a:off x="548640" y="6355080"/>
+            <a:ext cx="11064240" cy="274320"/>
+          </a:xfrm>
+          <a:prstGeom prst="rect">
+            <a:avLst/>
+          </a:prstGeom>
+          <a:noFill/>
+          <a:ln/>
+        </p:spPr>
+        <p:txBody>
+          <a:bodyPr wrap="square" lIns="0" tIns="0" rIns="0" bIns="0" rtlCol="0" anchor="ctr"/>
+          <a:lstStyle/>
+          <a:p>
+            <a:pPr indent="0" marL="0">
+              <a:buNone/>
+            </a:pPr>
+            <a:r>
+              <a:rPr lang="en-US" sz="1100" dirty="0">
+                <a:solidFill>
+                  <a:srgbClr val="5B6578"/>
+                </a:solidFill>
+                <a:latin typeface="Calibri" pitchFamily="34" charset="0"/>
+                <a:ea typeface="Calibri" pitchFamily="34" charset="-122"/>
+                <a:cs typeface="Calibri" pitchFamily="34" charset="-120"/>
+              </a:rPr>
+              <a:t>20–560 Hz, motor at 2000 µs. The two runs had different operating points (7.35 V against 11.7 V), which is why the blue is lower.</a:t>
             </a:r>
             <a:endParaRPr lang="en-US" sz="1100" dirty="0"/>
           </a:p>

</xml_diff>

<commit_message>
Slides: overlay slide gets a numbers table (range, rms spread, level range)
Co-Authored-By: Claude Sonnet 5.5 <noreply@anthropic.com>
</commit_message>
<xml_diff>
--- a/docs/analysis/chamber-final-2026-10-01/slides/chamber-slides.pptx
+++ b/docs/analysis/chamber-final-2026-10-01/slides/chamber-slides.pptx
@@ -1410,8 +1410,8 @@
         </p:nvSpPr>
         <p:spPr>
           <a:xfrm>
-            <a:off x="6766560" y="2514600"/>
-            <a:ext cx="4846320" cy="2377440"/>
+            <a:off x="6766560" y="2377440"/>
+            <a:ext cx="4846320" cy="1371600"/>
           </a:xfrm>
           <a:prstGeom prst="rect">
             <a:avLst/>
@@ -1464,138 +1464,612 @@
             </a:r>
             <a:endParaRPr lang="en-US" sz="1600" dirty="0"/>
           </a:p>
-          <a:p>
-            <a:pPr marL="342900" indent="-342900">
-              <a:spcAft>
-                <a:spcPts val="1000"/>
-              </a:spcAft>
-              <a:buSzPct val="100000"/>
-              <a:buChar char="•"/>
-            </a:pPr>
-            <a:r>
-              <a:rPr lang="en-US" sz="1600" b="1" dirty="0">
-                <a:solidFill>
-                  <a:srgbClr val="1F2A44"/>
-                </a:solidFill>
-                <a:latin typeface="Calibri" pitchFamily="34" charset="0"/>
-                <a:ea typeface="Calibri" pitchFamily="34" charset="-122"/>
-                <a:cs typeface="Calibri" pitchFamily="34" charset="-120"/>
-              </a:rPr>
-              <a:t>The outline is smooth and close to a circle.</a:t>
-            </a:r>
-            <a:endParaRPr lang="en-US" sz="1600" dirty="0"/>
-          </a:p>
         </p:txBody>
       </p:sp>
+      <p:graphicFrame>
+        <p:nvGraphicFramePr>
+          <p:cNvPr id="3" name="Table 0"/>
+          <p:cNvGraphicFramePr>
+            <a:graphicFrameLocks noGrp="1"/>
+          </p:cNvGraphicFramePr>
+          <p:nvPr>
+            <p:extLst>
+              <p:ext uri="{D42A27DB-BD31-4B8C-83A1-F6EECF244321}">
+                <p14:modId xmlns:p14="http://schemas.microsoft.com/office/powerpoint/2010/main" val="1579011935"/>
+              </p:ext>
+            </p:extLst>
+          </p:nvPr>
+        </p:nvGraphicFramePr>
+        <p:xfrm>
+          <a:off x="6766560" y="3931920"/>
+          <a:ext cx="4846320" cy="914400"/>
+        </p:xfrm>
+        <a:graphic>
+          <a:graphicData uri="http://schemas.openxmlformats.org/drawingml/2006/table">
+            <a:tbl>
+              <a:tblPr/>
+              <a:tblGrid>
+                <a:gridCol w="2103120"/>
+                <a:gridCol w="1371600"/>
+                <a:gridCol w="1371600"/>
+              </a:tblGrid>
+              <a:tr h="365760">
+                <a:tc>
+                  <a:txBody>
+                    <a:bodyPr/>
+                    <a:lstStyle/>
+                    <a:p>
+                      <a:pPr algn="l" indent="0" marL="0">
+                        <a:buNone/>
+                      </a:pPr>
+                      <a:endParaRPr lang="en-US" sz="1400" dirty="0">
+                        <a:latin typeface="Calibri" charset="0"/>
+                        <a:ea typeface="Calibri" charset="0"/>
+                        <a:cs typeface="Calibri" charset="0"/>
+                      </a:endParaRPr>
+                    </a:p>
+                  </a:txBody>
+                  <a:tcPr marL="54864" marR="54864" marT="36576" marB="36576">
+                    <a:lnL w="0" cap="flat" cmpd="sng" algn="ctr">
+                      <a:noFill/>
+                    </a:lnL>
+                    <a:lnR w="0" cap="flat" cmpd="sng" algn="ctr">
+                      <a:noFill/>
+                    </a:lnR>
+                    <a:lnT w="0" cap="flat" cmpd="sng" algn="ctr">
+                      <a:noFill/>
+                    </a:lnT>
+                    <a:lnB w="12700" cap="flat" cmpd="sng" algn="ctr">
+                      <a:solidFill>
+                        <a:srgbClr val="C9CFDA"/>
+                      </a:solidFill>
+                      <a:prstDash val="solid"/>
+                      <a:round/>
+                      <a:headEnd type="none" w="med" len="med"/>
+                      <a:tailEnd type="none" w="med" len="med"/>
+                    </a:lnB>
+                    <a:solidFill>
+                      <a:srgbClr val="FFFFFF"/>
+                    </a:solidFill>
+                  </a:tcPr>
+                </a:tc>
+                <a:tc>
+                  <a:txBody>
+                    <a:bodyPr/>
+                    <a:lstStyle/>
+                    <a:p>
+                      <a:pPr algn="r" indent="0" marL="0">
+                        <a:buNone/>
+                      </a:pPr>
+                      <a:r>
+                        <a:rPr lang="en-US" sz="1400" b="1" dirty="0">
+                          <a:solidFill>
+                            <a:srgbClr val="D6336C"/>
+                          </a:solidFill>
+                          <a:latin typeface="Calibri" pitchFamily="34" charset="0"/>
+                          <a:ea typeface="Calibri" pitchFamily="34" charset="-122"/>
+                          <a:cs typeface="Calibri" pitchFamily="34" charset="-120"/>
+                        </a:rPr>
+                        <a:t>31 Aug</a:t>
+                      </a:r>
+                      <a:endParaRPr lang="en-US" sz="1400" dirty="0">
+                        <a:latin typeface="Calibri" charset="0"/>
+                        <a:ea typeface="Calibri" charset="0"/>
+                        <a:cs typeface="Calibri" charset="0"/>
+                      </a:endParaRPr>
+                    </a:p>
+                  </a:txBody>
+                  <a:tcPr marL="54864" marR="54864" marT="36576" marB="36576">
+                    <a:lnL w="0" cap="flat" cmpd="sng" algn="ctr">
+                      <a:noFill/>
+                    </a:lnL>
+                    <a:lnR w="0" cap="flat" cmpd="sng" algn="ctr">
+                      <a:noFill/>
+                    </a:lnR>
+                    <a:lnT w="0" cap="flat" cmpd="sng" algn="ctr">
+                      <a:noFill/>
+                    </a:lnT>
+                    <a:lnB w="12700" cap="flat" cmpd="sng" algn="ctr">
+                      <a:solidFill>
+                        <a:srgbClr val="C9CFDA"/>
+                      </a:solidFill>
+                      <a:prstDash val="solid"/>
+                      <a:round/>
+                      <a:headEnd type="none" w="med" len="med"/>
+                      <a:tailEnd type="none" w="med" len="med"/>
+                    </a:lnB>
+                    <a:solidFill>
+                      <a:srgbClr val="FFFFFF"/>
+                    </a:solidFill>
+                  </a:tcPr>
+                </a:tc>
+                <a:tc>
+                  <a:txBody>
+                    <a:bodyPr/>
+                    <a:lstStyle/>
+                    <a:p>
+                      <a:pPr algn="r" indent="0" marL="0">
+                        <a:buNone/>
+                      </a:pPr>
+                      <a:r>
+                        <a:rPr lang="en-US" sz="1400" b="1" dirty="0">
+                          <a:solidFill>
+                            <a:srgbClr val="2B6CB0"/>
+                          </a:solidFill>
+                          <a:latin typeface="Calibri" pitchFamily="34" charset="0"/>
+                          <a:ea typeface="Calibri" pitchFamily="34" charset="-122"/>
+                          <a:cs typeface="Calibri" pitchFamily="34" charset="-120"/>
+                        </a:rPr>
+                        <a:t>30 Sep</a:t>
+                      </a:r>
+                      <a:endParaRPr lang="en-US" sz="1400" dirty="0">
+                        <a:latin typeface="Calibri" charset="0"/>
+                        <a:ea typeface="Calibri" charset="0"/>
+                        <a:cs typeface="Calibri" charset="0"/>
+                      </a:endParaRPr>
+                    </a:p>
+                  </a:txBody>
+                  <a:tcPr marL="54864" marR="54864" marT="36576" marB="36576">
+                    <a:lnL w="0" cap="flat" cmpd="sng" algn="ctr">
+                      <a:noFill/>
+                    </a:lnL>
+                    <a:lnR w="0" cap="flat" cmpd="sng" algn="ctr">
+                      <a:noFill/>
+                    </a:lnR>
+                    <a:lnT w="0" cap="flat" cmpd="sng" algn="ctr">
+                      <a:noFill/>
+                    </a:lnT>
+                    <a:lnB w="12700" cap="flat" cmpd="sng" algn="ctr">
+                      <a:solidFill>
+                        <a:srgbClr val="C9CFDA"/>
+                      </a:solidFill>
+                      <a:prstDash val="solid"/>
+                      <a:round/>
+                      <a:headEnd type="none" w="med" len="med"/>
+                      <a:tailEnd type="none" w="med" len="med"/>
+                    </a:lnB>
+                    <a:solidFill>
+                      <a:srgbClr val="FFFFFF"/>
+                    </a:solidFill>
+                  </a:tcPr>
+                </a:tc>
+              </a:tr>
+              <a:tr h="502920">
+                <a:tc>
+                  <a:txBody>
+                    <a:bodyPr/>
+                    <a:lstStyle/>
+                    <a:p>
+                      <a:pPr algn="l" indent="0" marL="0">
+                        <a:buNone/>
+                      </a:pPr>
+                      <a:r>
+                        <a:rPr lang="en-US" sz="1500" dirty="0">
+                          <a:solidFill>
+                            <a:srgbClr val="1F2A44"/>
+                          </a:solidFill>
+                          <a:latin typeface="Calibri" pitchFamily="34" charset="0"/>
+                          <a:ea typeface="Calibri" pitchFamily="34" charset="-122"/>
+                          <a:cs typeface="Calibri" pitchFamily="34" charset="-120"/>
+                        </a:rPr>
+                        <a:t>Loudest minus quietest</a:t>
+                      </a:r>
+                      <a:endParaRPr lang="en-US" sz="1500" dirty="0">
+                        <a:latin typeface="Calibri" charset="0"/>
+                        <a:ea typeface="Calibri" charset="0"/>
+                        <a:cs typeface="Calibri" charset="0"/>
+                      </a:endParaRPr>
+                    </a:p>
+                  </a:txBody>
+                  <a:tcPr marL="54864" marR="54864" marT="36576" marB="36576">
+                    <a:lnL w="0" cap="flat" cmpd="sng" algn="ctr">
+                      <a:noFill/>
+                    </a:lnL>
+                    <a:lnR w="0" cap="flat" cmpd="sng" algn="ctr">
+                      <a:noFill/>
+                    </a:lnR>
+                    <a:lnT w="0" cap="flat" cmpd="sng" algn="ctr">
+                      <a:noFill/>
+                    </a:lnT>
+                    <a:lnB w="6350" cap="flat" cmpd="sng" algn="ctr">
+                      <a:solidFill>
+                        <a:srgbClr val="E3E7EE"/>
+                      </a:solidFill>
+                      <a:prstDash val="solid"/>
+                      <a:round/>
+                      <a:headEnd type="none" w="med" len="med"/>
+                      <a:tailEnd type="none" w="med" len="med"/>
+                    </a:lnB>
+                  </a:tcPr>
+                </a:tc>
+                <a:tc>
+                  <a:txBody>
+                    <a:bodyPr/>
+                    <a:lstStyle/>
+                    <a:p>
+                      <a:pPr algn="r" indent="0" marL="0">
+                        <a:buNone/>
+                      </a:pPr>
+                      <a:r>
+                        <a:rPr lang="en-US" sz="2000" b="1" dirty="0">
+                          <a:solidFill>
+                            <a:srgbClr val="D6336C"/>
+                          </a:solidFill>
+                          <a:latin typeface="Calibri" pitchFamily="34" charset="0"/>
+                          <a:ea typeface="Calibri" pitchFamily="34" charset="-122"/>
+                          <a:cs typeface="Calibri" pitchFamily="34" charset="-120"/>
+                        </a:rPr>
+                        <a:t>6.7 dB</a:t>
+                      </a:r>
+                      <a:endParaRPr lang="en-US" sz="2000" dirty="0">
+                        <a:latin typeface="Calibri" charset="0"/>
+                        <a:ea typeface="Calibri" charset="0"/>
+                        <a:cs typeface="Calibri" charset="0"/>
+                      </a:endParaRPr>
+                    </a:p>
+                  </a:txBody>
+                  <a:tcPr marL="54864" marR="54864" marT="36576" marB="36576">
+                    <a:lnL w="0" cap="flat" cmpd="sng" algn="ctr">
+                      <a:noFill/>
+                    </a:lnL>
+                    <a:lnR w="0" cap="flat" cmpd="sng" algn="ctr">
+                      <a:noFill/>
+                    </a:lnR>
+                    <a:lnT w="0" cap="flat" cmpd="sng" algn="ctr">
+                      <a:noFill/>
+                    </a:lnT>
+                    <a:lnB w="6350" cap="flat" cmpd="sng" algn="ctr">
+                      <a:solidFill>
+                        <a:srgbClr val="E3E7EE"/>
+                      </a:solidFill>
+                      <a:prstDash val="solid"/>
+                      <a:round/>
+                      <a:headEnd type="none" w="med" len="med"/>
+                      <a:tailEnd type="none" w="med" len="med"/>
+                    </a:lnB>
+                  </a:tcPr>
+                </a:tc>
+                <a:tc>
+                  <a:txBody>
+                    <a:bodyPr/>
+                    <a:lstStyle/>
+                    <a:p>
+                      <a:pPr algn="r" indent="0" marL="0">
+                        <a:buNone/>
+                      </a:pPr>
+                      <a:r>
+                        <a:rPr lang="en-US" sz="2000" b="1" dirty="0">
+                          <a:solidFill>
+                            <a:srgbClr val="2B6CB0"/>
+                          </a:solidFill>
+                          <a:latin typeface="Calibri" pitchFamily="34" charset="0"/>
+                          <a:ea typeface="Calibri" pitchFamily="34" charset="-122"/>
+                          <a:cs typeface="Calibri" pitchFamily="34" charset="-120"/>
+                        </a:rPr>
+                        <a:t>4.0 dB</a:t>
+                      </a:r>
+                      <a:endParaRPr lang="en-US" sz="2000" dirty="0">
+                        <a:latin typeface="Calibri" charset="0"/>
+                        <a:ea typeface="Calibri" charset="0"/>
+                        <a:cs typeface="Calibri" charset="0"/>
+                      </a:endParaRPr>
+                    </a:p>
+                  </a:txBody>
+                  <a:tcPr marL="54864" marR="54864" marT="36576" marB="36576">
+                    <a:lnL w="0" cap="flat" cmpd="sng" algn="ctr">
+                      <a:noFill/>
+                    </a:lnL>
+                    <a:lnR w="0" cap="flat" cmpd="sng" algn="ctr">
+                      <a:noFill/>
+                    </a:lnR>
+                    <a:lnT w="0" cap="flat" cmpd="sng" algn="ctr">
+                      <a:noFill/>
+                    </a:lnT>
+                    <a:lnB w="6350" cap="flat" cmpd="sng" algn="ctr">
+                      <a:solidFill>
+                        <a:srgbClr val="E3E7EE"/>
+                      </a:solidFill>
+                      <a:prstDash val="solid"/>
+                      <a:round/>
+                      <a:headEnd type="none" w="med" len="med"/>
+                      <a:tailEnd type="none" w="med" len="med"/>
+                    </a:lnB>
+                  </a:tcPr>
+                </a:tc>
+              </a:tr>
+              <a:tr h="502920">
+                <a:tc>
+                  <a:txBody>
+                    <a:bodyPr/>
+                    <a:lstStyle/>
+                    <a:p>
+                      <a:pPr algn="l" indent="0" marL="0">
+                        <a:buNone/>
+                      </a:pPr>
+                      <a:r>
+                        <a:rPr lang="en-US" sz="1500" dirty="0">
+                          <a:solidFill>
+                            <a:srgbClr val="1F2A44"/>
+                          </a:solidFill>
+                          <a:latin typeface="Calibri" pitchFamily="34" charset="0"/>
+                          <a:ea typeface="Calibri" pitchFamily="34" charset="-122"/>
+                          <a:cs typeface="Calibri" pitchFamily="34" charset="-120"/>
+                        </a:rPr>
+                        <a:t>Spread (rms)</a:t>
+                      </a:r>
+                      <a:endParaRPr lang="en-US" sz="1500" dirty="0">
+                        <a:latin typeface="Calibri" charset="0"/>
+                        <a:ea typeface="Calibri" charset="0"/>
+                        <a:cs typeface="Calibri" charset="0"/>
+                      </a:endParaRPr>
+                    </a:p>
+                  </a:txBody>
+                  <a:tcPr marL="54864" marR="54864" marT="36576" marB="36576">
+                    <a:lnL w="0" cap="flat" cmpd="sng" algn="ctr">
+                      <a:noFill/>
+                    </a:lnL>
+                    <a:lnR w="0" cap="flat" cmpd="sng" algn="ctr">
+                      <a:noFill/>
+                    </a:lnR>
+                    <a:lnT w="0" cap="flat" cmpd="sng" algn="ctr">
+                      <a:noFill/>
+                    </a:lnT>
+                    <a:lnB w="6350" cap="flat" cmpd="sng" algn="ctr">
+                      <a:solidFill>
+                        <a:srgbClr val="E3E7EE"/>
+                      </a:solidFill>
+                      <a:prstDash val="solid"/>
+                      <a:round/>
+                      <a:headEnd type="none" w="med" len="med"/>
+                      <a:tailEnd type="none" w="med" len="med"/>
+                    </a:lnB>
+                  </a:tcPr>
+                </a:tc>
+                <a:tc>
+                  <a:txBody>
+                    <a:bodyPr/>
+                    <a:lstStyle/>
+                    <a:p>
+                      <a:pPr algn="r" indent="0" marL="0">
+                        <a:buNone/>
+                      </a:pPr>
+                      <a:r>
+                        <a:rPr lang="en-US" sz="2000" b="1" dirty="0">
+                          <a:solidFill>
+                            <a:srgbClr val="D6336C"/>
+                          </a:solidFill>
+                          <a:latin typeface="Calibri" pitchFamily="34" charset="0"/>
+                          <a:ea typeface="Calibri" pitchFamily="34" charset="-122"/>
+                          <a:cs typeface="Calibri" pitchFamily="34" charset="-120"/>
+                        </a:rPr>
+                        <a:t>2.05 dB</a:t>
+                      </a:r>
+                      <a:endParaRPr lang="en-US" sz="2000" dirty="0">
+                        <a:latin typeface="Calibri" charset="0"/>
+                        <a:ea typeface="Calibri" charset="0"/>
+                        <a:cs typeface="Calibri" charset="0"/>
+                      </a:endParaRPr>
+                    </a:p>
+                  </a:txBody>
+                  <a:tcPr marL="54864" marR="54864" marT="36576" marB="36576">
+                    <a:lnL w="0" cap="flat" cmpd="sng" algn="ctr">
+                      <a:noFill/>
+                    </a:lnL>
+                    <a:lnR w="0" cap="flat" cmpd="sng" algn="ctr">
+                      <a:noFill/>
+                    </a:lnR>
+                    <a:lnT w="0" cap="flat" cmpd="sng" algn="ctr">
+                      <a:noFill/>
+                    </a:lnT>
+                    <a:lnB w="6350" cap="flat" cmpd="sng" algn="ctr">
+                      <a:solidFill>
+                        <a:srgbClr val="E3E7EE"/>
+                      </a:solidFill>
+                      <a:prstDash val="solid"/>
+                      <a:round/>
+                      <a:headEnd type="none" w="med" len="med"/>
+                      <a:tailEnd type="none" w="med" len="med"/>
+                    </a:lnB>
+                  </a:tcPr>
+                </a:tc>
+                <a:tc>
+                  <a:txBody>
+                    <a:bodyPr/>
+                    <a:lstStyle/>
+                    <a:p>
+                      <a:pPr algn="r" indent="0" marL="0">
+                        <a:buNone/>
+                      </a:pPr>
+                      <a:r>
+                        <a:rPr lang="en-US" sz="2000" b="1" dirty="0">
+                          <a:solidFill>
+                            <a:srgbClr val="2B6CB0"/>
+                          </a:solidFill>
+                          <a:latin typeface="Calibri" pitchFamily="34" charset="0"/>
+                          <a:ea typeface="Calibri" pitchFamily="34" charset="-122"/>
+                          <a:cs typeface="Calibri" pitchFamily="34" charset="-120"/>
+                        </a:rPr>
+                        <a:t>1.45 dB</a:t>
+                      </a:r>
+                      <a:endParaRPr lang="en-US" sz="2000" dirty="0">
+                        <a:latin typeface="Calibri" charset="0"/>
+                        <a:ea typeface="Calibri" charset="0"/>
+                        <a:cs typeface="Calibri" charset="0"/>
+                      </a:endParaRPr>
+                    </a:p>
+                  </a:txBody>
+                  <a:tcPr marL="54864" marR="54864" marT="36576" marB="36576">
+                    <a:lnL w="0" cap="flat" cmpd="sng" algn="ctr">
+                      <a:noFill/>
+                    </a:lnL>
+                    <a:lnR w="0" cap="flat" cmpd="sng" algn="ctr">
+                      <a:noFill/>
+                    </a:lnR>
+                    <a:lnT w="0" cap="flat" cmpd="sng" algn="ctr">
+                      <a:noFill/>
+                    </a:lnT>
+                    <a:lnB w="6350" cap="flat" cmpd="sng" algn="ctr">
+                      <a:solidFill>
+                        <a:srgbClr val="E3E7EE"/>
+                      </a:solidFill>
+                      <a:prstDash val="solid"/>
+                      <a:round/>
+                      <a:headEnd type="none" w="med" len="med"/>
+                      <a:tailEnd type="none" w="med" len="med"/>
+                    </a:lnB>
+                  </a:tcPr>
+                </a:tc>
+              </a:tr>
+              <a:tr h="411480">
+                <a:tc>
+                  <a:txBody>
+                    <a:bodyPr/>
+                    <a:lstStyle/>
+                    <a:p>
+                      <a:pPr algn="l" indent="0" marL="0">
+                        <a:buNone/>
+                      </a:pPr>
+                      <a:r>
+                        <a:rPr lang="en-US" sz="1500" dirty="0">
+                          <a:solidFill>
+                            <a:srgbClr val="1F2A44"/>
+                          </a:solidFill>
+                          <a:latin typeface="Calibri" pitchFamily="34" charset="0"/>
+                          <a:ea typeface="Calibri" pitchFamily="34" charset="-122"/>
+                          <a:cs typeface="Calibri" pitchFamily="34" charset="-120"/>
+                        </a:rPr>
+                        <a:t>Level range</a:t>
+                      </a:r>
+                      <a:endParaRPr lang="en-US" sz="1500" dirty="0">
+                        <a:latin typeface="Calibri" charset="0"/>
+                        <a:ea typeface="Calibri" charset="0"/>
+                        <a:cs typeface="Calibri" charset="0"/>
+                      </a:endParaRPr>
+                    </a:p>
+                  </a:txBody>
+                  <a:tcPr marL="54864" marR="54864" marT="36576" marB="36576">
+                    <a:lnL w="0" cap="flat" cmpd="sng" algn="ctr">
+                      <a:noFill/>
+                    </a:lnL>
+                    <a:lnR w="0" cap="flat" cmpd="sng" algn="ctr">
+                      <a:noFill/>
+                    </a:lnR>
+                    <a:lnT w="0" cap="flat" cmpd="sng" algn="ctr">
+                      <a:noFill/>
+                    </a:lnT>
+                    <a:lnB w="6350" cap="flat" cmpd="sng" algn="ctr">
+                      <a:solidFill>
+                        <a:srgbClr val="E3E7EE"/>
+                      </a:solidFill>
+                      <a:prstDash val="solid"/>
+                      <a:round/>
+                      <a:headEnd type="none" w="med" len="med"/>
+                      <a:tailEnd type="none" w="med" len="med"/>
+                    </a:lnB>
+                  </a:tcPr>
+                </a:tc>
+                <a:tc>
+                  <a:txBody>
+                    <a:bodyPr/>
+                    <a:lstStyle/>
+                    <a:p>
+                      <a:pPr algn="r" indent="0" marL="0">
+                        <a:buNone/>
+                      </a:pPr>
+                      <a:r>
+                        <a:rPr lang="en-US" sz="1500" dirty="0">
+                          <a:solidFill>
+                            <a:srgbClr val="D6336C"/>
+                          </a:solidFill>
+                          <a:latin typeface="Calibri" pitchFamily="34" charset="0"/>
+                          <a:ea typeface="Calibri" pitchFamily="34" charset="-122"/>
+                          <a:cs typeface="Calibri" pitchFamily="34" charset="-120"/>
+                        </a:rPr>
+                        <a:t>63.9–70.6 dB</a:t>
+                      </a:r>
+                      <a:endParaRPr lang="en-US" sz="1500" dirty="0">
+                        <a:latin typeface="Calibri" charset="0"/>
+                        <a:ea typeface="Calibri" charset="0"/>
+                        <a:cs typeface="Calibri" charset="0"/>
+                      </a:endParaRPr>
+                    </a:p>
+                  </a:txBody>
+                  <a:tcPr marL="54864" marR="54864" marT="36576" marB="36576">
+                    <a:lnL w="0" cap="flat" cmpd="sng" algn="ctr">
+                      <a:noFill/>
+                    </a:lnL>
+                    <a:lnR w="0" cap="flat" cmpd="sng" algn="ctr">
+                      <a:noFill/>
+                    </a:lnR>
+                    <a:lnT w="0" cap="flat" cmpd="sng" algn="ctr">
+                      <a:noFill/>
+                    </a:lnT>
+                    <a:lnB w="6350" cap="flat" cmpd="sng" algn="ctr">
+                      <a:solidFill>
+                        <a:srgbClr val="E3E7EE"/>
+                      </a:solidFill>
+                      <a:prstDash val="solid"/>
+                      <a:round/>
+                      <a:headEnd type="none" w="med" len="med"/>
+                      <a:tailEnd type="none" w="med" len="med"/>
+                    </a:lnB>
+                  </a:tcPr>
+                </a:tc>
+                <a:tc>
+                  <a:txBody>
+                    <a:bodyPr/>
+                    <a:lstStyle/>
+                    <a:p>
+                      <a:pPr algn="r" indent="0" marL="0">
+                        <a:buNone/>
+                      </a:pPr>
+                      <a:r>
+                        <a:rPr lang="en-US" sz="1500" dirty="0">
+                          <a:solidFill>
+                            <a:srgbClr val="2B6CB0"/>
+                          </a:solidFill>
+                          <a:latin typeface="Calibri" pitchFamily="34" charset="0"/>
+                          <a:ea typeface="Calibri" pitchFamily="34" charset="-122"/>
+                          <a:cs typeface="Calibri" pitchFamily="34" charset="-120"/>
+                        </a:rPr>
+                        <a:t>55.5–59.6 dB</a:t>
+                      </a:r>
+                      <a:endParaRPr lang="en-US" sz="1500" dirty="0">
+                        <a:latin typeface="Calibri" charset="0"/>
+                        <a:ea typeface="Calibri" charset="0"/>
+                        <a:cs typeface="Calibri" charset="0"/>
+                      </a:endParaRPr>
+                    </a:p>
+                  </a:txBody>
+                  <a:tcPr marL="54864" marR="54864" marT="36576" marB="36576">
+                    <a:lnL w="0" cap="flat" cmpd="sng" algn="ctr">
+                      <a:noFill/>
+                    </a:lnL>
+                    <a:lnR w="0" cap="flat" cmpd="sng" algn="ctr">
+                      <a:noFill/>
+                    </a:lnR>
+                    <a:lnT w="0" cap="flat" cmpd="sng" algn="ctr">
+                      <a:noFill/>
+                    </a:lnT>
+                    <a:lnB w="6350" cap="flat" cmpd="sng" algn="ctr">
+                      <a:solidFill>
+                        <a:srgbClr val="E3E7EE"/>
+                      </a:solidFill>
+                      <a:prstDash val="solid"/>
+                      <a:round/>
+                      <a:headEnd type="none" w="med" len="med"/>
+                      <a:tailEnd type="none" w="med" len="med"/>
+                    </a:lnB>
+                  </a:tcPr>
+                </a:tc>
+              </a:tr>
+            </a:tbl>
+          </a:graphicData>
+        </a:graphic>
+      </p:graphicFrame>
       <p:sp>
         <p:nvSpPr>
-          <p:cNvPr id="6" name="Text 3"/>
-          <p:cNvSpPr txBox="1"/>
-          <p:nvPr/>
-        </p:nvSpPr>
-        <p:spPr>
-          <a:xfrm>
-            <a:off x="6766560" y="5029200"/>
-            <a:ext cx="4846320" cy="731520"/>
-          </a:xfrm>
-          <a:prstGeom prst="rect">
-            <a:avLst/>
-          </a:prstGeom>
-          <a:noFill/>
-          <a:ln/>
-        </p:spPr>
-        <p:txBody>
-          <a:bodyPr wrap="square" lIns="0" tIns="0" rIns="0" bIns="0" rtlCol="0" anchor="ctr"/>
-          <a:lstStyle/>
-          <a:p>
-            <a:pPr indent="0" marL="0">
-              <a:buNone/>
-            </a:pPr>
-            <a:r>
-              <a:rPr lang="en-US" sz="4800" b="1" dirty="0">
-                <a:solidFill>
-                  <a:srgbClr val="D6336C"/>
-                </a:solidFill>
-                <a:latin typeface="Cambria" pitchFamily="34" charset="0"/>
-                <a:ea typeface="Cambria" pitchFamily="34" charset="-122"/>
-                <a:cs typeface="Cambria" pitchFamily="34" charset="-120"/>
-              </a:rPr>
-              <a:t>6.7</a:t>
-            </a:r>
-            <a:pPr indent="0" marL="0">
-              <a:buNone/>
-            </a:pPr>
-            <a:r>
-              <a:rPr lang="en-US" sz="4800" b="1" dirty="0">
-                <a:solidFill>
-                  <a:srgbClr val="5B6578"/>
-                </a:solidFill>
-                <a:latin typeface="Cambria" pitchFamily="34" charset="0"/>
-                <a:ea typeface="Cambria" pitchFamily="34" charset="-122"/>
-                <a:cs typeface="Cambria" pitchFamily="34" charset="-120"/>
-              </a:rPr>
-              <a:t> → </a:t>
-            </a:r>
-            <a:pPr indent="0" marL="0">
-              <a:buNone/>
-            </a:pPr>
-            <a:r>
-              <a:rPr lang="en-US" sz="4800" b="1" dirty="0">
-                <a:solidFill>
-                  <a:srgbClr val="2B6CB0"/>
-                </a:solidFill>
-                <a:latin typeface="Cambria" pitchFamily="34" charset="0"/>
-                <a:ea typeface="Cambria" pitchFamily="34" charset="-122"/>
-                <a:cs typeface="Cambria" pitchFamily="34" charset="-120"/>
-              </a:rPr>
-              <a:t>4.0 dB</a:t>
-            </a:r>
-            <a:endParaRPr lang="en-US" sz="4800" dirty="0"/>
-          </a:p>
-        </p:txBody>
-      </p:sp>
-      <p:sp>
-        <p:nvSpPr>
-          <p:cNvPr id="7" name="Text 4"/>
-          <p:cNvSpPr txBox="1"/>
-          <p:nvPr/>
-        </p:nvSpPr>
-        <p:spPr>
-          <a:xfrm>
-            <a:off x="6766560" y="5760720"/>
-            <a:ext cx="4846320" cy="457200"/>
-          </a:xfrm>
-          <a:prstGeom prst="rect">
-            <a:avLst/>
-          </a:prstGeom>
-          <a:noFill/>
-          <a:ln/>
-        </p:spPr>
-        <p:txBody>
-          <a:bodyPr wrap="square" lIns="0" tIns="0" rIns="0" bIns="0" rtlCol="0" anchor="ctr"/>
-          <a:lstStyle/>
-          <a:p>
-            <a:pPr indent="0" marL="0">
-              <a:buNone/>
-            </a:pPr>
-            <a:r>
-              <a:rPr lang="en-US" sz="1400" dirty="0">
-                <a:solidFill>
-                  <a:srgbClr val="5B6578"/>
-                </a:solidFill>
-                <a:latin typeface="Calibri" pitchFamily="34" charset="0"/>
-                <a:ea typeface="Calibri" pitchFamily="34" charset="-122"/>
-                <a:cs typeface="Calibri" pitchFamily="34" charset="-120"/>
-              </a:rPr>
-              <a:t>between the loudest and quietest microphone</a:t>
-            </a:r>
-            <a:endParaRPr lang="en-US" sz="1400" dirty="0"/>
-          </a:p>
-        </p:txBody>
-      </p:sp>
-      <p:sp>
-        <p:nvSpPr>
-          <p:cNvPr id="8" name="Text 5"/>
+          <p:cNvPr id="7" name="Text 3"/>
           <p:cNvSpPr txBox="1"/>
           <p:nvPr/>
         </p:nvSpPr>

</xml_diff>

<commit_message>
Slides: back to the minimal overlay layout, visible slide numbers (overlay labelled 3)
Co-Authored-By: Claude Sonnet 5.5 <noreply@anthropic.com>
</commit_message>
<xml_diff>
--- a/docs/analysis/chamber-final-2026-10-01/slides/chamber-slides.pptx
+++ b/docs/analysis/chamber-final-2026-10-01/slides/chamber-slides.pptx
@@ -1268,6 +1268,45 @@
           </a:p>
         </p:txBody>
       </p:sp>
+      <p:sp>
+        <p:nvSpPr>
+          <p:cNvPr id="9" name="Text 6"/>
+          <p:cNvSpPr txBox="1"/>
+          <p:nvPr/>
+        </p:nvSpPr>
+        <p:spPr>
+          <a:xfrm>
+            <a:off x="11155680" y="6355080"/>
+            <a:ext cx="457200" cy="274320"/>
+          </a:xfrm>
+          <a:prstGeom prst="rect">
+            <a:avLst/>
+          </a:prstGeom>
+          <a:noFill/>
+          <a:ln/>
+        </p:spPr>
+        <p:txBody>
+          <a:bodyPr wrap="square" lIns="0" tIns="0" rIns="0" bIns="0" rtlCol="0" anchor="ctr"/>
+          <a:lstStyle/>
+          <a:p>
+            <a:pPr algn="r" indent="0" marL="0">
+              <a:buNone/>
+            </a:pPr>
+            <a:r>
+              <a:rPr lang="en-US" sz="1200" dirty="0">
+                <a:solidFill>
+                  <a:srgbClr val="5B6578"/>
+                </a:solidFill>
+                <a:latin typeface="Calibri" pitchFamily="34" charset="0"/>
+                <a:ea typeface="Calibri" pitchFamily="34" charset="-122"/>
+                <a:cs typeface="Calibri" pitchFamily="34" charset="-120"/>
+              </a:rPr>
+              <a:t>1</a:t>
+            </a:r>
+            <a:endParaRPr lang="en-US" sz="1200" dirty="0"/>
+          </a:p>
+        </p:txBody>
+      </p:sp>
     </p:spTree>
   </p:cSld>
   <p:clrMapOvr>
@@ -1410,8 +1449,8 @@
         </p:nvSpPr>
         <p:spPr>
           <a:xfrm>
-            <a:off x="6766560" y="2377440"/>
-            <a:ext cx="4846320" cy="1371600"/>
+            <a:off x="6766560" y="2514600"/>
+            <a:ext cx="4846320" cy="2377440"/>
           </a:xfrm>
           <a:prstGeom prst="rect">
             <a:avLst/>
@@ -1464,612 +1503,138 @@
             </a:r>
             <a:endParaRPr lang="en-US" sz="1600" dirty="0"/>
           </a:p>
-        </p:txBody>
-      </p:sp>
-      <p:graphicFrame>
-        <p:nvGraphicFramePr>
-          <p:cNvPr id="3" name="Table 0"/>
-          <p:cNvGraphicFramePr>
-            <a:graphicFrameLocks noGrp="1"/>
-          </p:cNvGraphicFramePr>
-          <p:nvPr>
-            <p:extLst>
-              <p:ext uri="{D42A27DB-BD31-4B8C-83A1-F6EECF244321}">
-                <p14:modId xmlns:p14="http://schemas.microsoft.com/office/powerpoint/2010/main" val="1579011935"/>
-              </p:ext>
-            </p:extLst>
-          </p:nvPr>
-        </p:nvGraphicFramePr>
-        <p:xfrm>
-          <a:off x="6766560" y="3931920"/>
-          <a:ext cx="4846320" cy="914400"/>
-        </p:xfrm>
-        <a:graphic>
-          <a:graphicData uri="http://schemas.openxmlformats.org/drawingml/2006/table">
-            <a:tbl>
-              <a:tblPr/>
-              <a:tblGrid>
-                <a:gridCol w="2103120"/>
-                <a:gridCol w="1371600"/>
-                <a:gridCol w="1371600"/>
-              </a:tblGrid>
-              <a:tr h="365760">
-                <a:tc>
-                  <a:txBody>
-                    <a:bodyPr/>
-                    <a:lstStyle/>
-                    <a:p>
-                      <a:pPr algn="l" indent="0" marL="0">
-                        <a:buNone/>
-                      </a:pPr>
-                      <a:endParaRPr lang="en-US" sz="1400" dirty="0">
-                        <a:latin typeface="Calibri" charset="0"/>
-                        <a:ea typeface="Calibri" charset="0"/>
-                        <a:cs typeface="Calibri" charset="0"/>
-                      </a:endParaRPr>
-                    </a:p>
-                  </a:txBody>
-                  <a:tcPr marL="54864" marR="54864" marT="36576" marB="36576">
-                    <a:lnL w="0" cap="flat" cmpd="sng" algn="ctr">
-                      <a:noFill/>
-                    </a:lnL>
-                    <a:lnR w="0" cap="flat" cmpd="sng" algn="ctr">
-                      <a:noFill/>
-                    </a:lnR>
-                    <a:lnT w="0" cap="flat" cmpd="sng" algn="ctr">
-                      <a:noFill/>
-                    </a:lnT>
-                    <a:lnB w="12700" cap="flat" cmpd="sng" algn="ctr">
-                      <a:solidFill>
-                        <a:srgbClr val="C9CFDA"/>
-                      </a:solidFill>
-                      <a:prstDash val="solid"/>
-                      <a:round/>
-                      <a:headEnd type="none" w="med" len="med"/>
-                      <a:tailEnd type="none" w="med" len="med"/>
-                    </a:lnB>
-                    <a:solidFill>
-                      <a:srgbClr val="FFFFFF"/>
-                    </a:solidFill>
-                  </a:tcPr>
-                </a:tc>
-                <a:tc>
-                  <a:txBody>
-                    <a:bodyPr/>
-                    <a:lstStyle/>
-                    <a:p>
-                      <a:pPr algn="r" indent="0" marL="0">
-                        <a:buNone/>
-                      </a:pPr>
-                      <a:r>
-                        <a:rPr lang="en-US" sz="1400" b="1" dirty="0">
-                          <a:solidFill>
-                            <a:srgbClr val="D6336C"/>
-                          </a:solidFill>
-                          <a:latin typeface="Calibri" pitchFamily="34" charset="0"/>
-                          <a:ea typeface="Calibri" pitchFamily="34" charset="-122"/>
-                          <a:cs typeface="Calibri" pitchFamily="34" charset="-120"/>
-                        </a:rPr>
-                        <a:t>31 Aug</a:t>
-                      </a:r>
-                      <a:endParaRPr lang="en-US" sz="1400" dirty="0">
-                        <a:latin typeface="Calibri" charset="0"/>
-                        <a:ea typeface="Calibri" charset="0"/>
-                        <a:cs typeface="Calibri" charset="0"/>
-                      </a:endParaRPr>
-                    </a:p>
-                  </a:txBody>
-                  <a:tcPr marL="54864" marR="54864" marT="36576" marB="36576">
-                    <a:lnL w="0" cap="flat" cmpd="sng" algn="ctr">
-                      <a:noFill/>
-                    </a:lnL>
-                    <a:lnR w="0" cap="flat" cmpd="sng" algn="ctr">
-                      <a:noFill/>
-                    </a:lnR>
-                    <a:lnT w="0" cap="flat" cmpd="sng" algn="ctr">
-                      <a:noFill/>
-                    </a:lnT>
-                    <a:lnB w="12700" cap="flat" cmpd="sng" algn="ctr">
-                      <a:solidFill>
-                        <a:srgbClr val="C9CFDA"/>
-                      </a:solidFill>
-                      <a:prstDash val="solid"/>
-                      <a:round/>
-                      <a:headEnd type="none" w="med" len="med"/>
-                      <a:tailEnd type="none" w="med" len="med"/>
-                    </a:lnB>
-                    <a:solidFill>
-                      <a:srgbClr val="FFFFFF"/>
-                    </a:solidFill>
-                  </a:tcPr>
-                </a:tc>
-                <a:tc>
-                  <a:txBody>
-                    <a:bodyPr/>
-                    <a:lstStyle/>
-                    <a:p>
-                      <a:pPr algn="r" indent="0" marL="0">
-                        <a:buNone/>
-                      </a:pPr>
-                      <a:r>
-                        <a:rPr lang="en-US" sz="1400" b="1" dirty="0">
-                          <a:solidFill>
-                            <a:srgbClr val="2B6CB0"/>
-                          </a:solidFill>
-                          <a:latin typeface="Calibri" pitchFamily="34" charset="0"/>
-                          <a:ea typeface="Calibri" pitchFamily="34" charset="-122"/>
-                          <a:cs typeface="Calibri" pitchFamily="34" charset="-120"/>
-                        </a:rPr>
-                        <a:t>30 Sep</a:t>
-                      </a:r>
-                      <a:endParaRPr lang="en-US" sz="1400" dirty="0">
-                        <a:latin typeface="Calibri" charset="0"/>
-                        <a:ea typeface="Calibri" charset="0"/>
-                        <a:cs typeface="Calibri" charset="0"/>
-                      </a:endParaRPr>
-                    </a:p>
-                  </a:txBody>
-                  <a:tcPr marL="54864" marR="54864" marT="36576" marB="36576">
-                    <a:lnL w="0" cap="flat" cmpd="sng" algn="ctr">
-                      <a:noFill/>
-                    </a:lnL>
-                    <a:lnR w="0" cap="flat" cmpd="sng" algn="ctr">
-                      <a:noFill/>
-                    </a:lnR>
-                    <a:lnT w="0" cap="flat" cmpd="sng" algn="ctr">
-                      <a:noFill/>
-                    </a:lnT>
-                    <a:lnB w="12700" cap="flat" cmpd="sng" algn="ctr">
-                      <a:solidFill>
-                        <a:srgbClr val="C9CFDA"/>
-                      </a:solidFill>
-                      <a:prstDash val="solid"/>
-                      <a:round/>
-                      <a:headEnd type="none" w="med" len="med"/>
-                      <a:tailEnd type="none" w="med" len="med"/>
-                    </a:lnB>
-                    <a:solidFill>
-                      <a:srgbClr val="FFFFFF"/>
-                    </a:solidFill>
-                  </a:tcPr>
-                </a:tc>
-              </a:tr>
-              <a:tr h="502920">
-                <a:tc>
-                  <a:txBody>
-                    <a:bodyPr/>
-                    <a:lstStyle/>
-                    <a:p>
-                      <a:pPr algn="l" indent="0" marL="0">
-                        <a:buNone/>
-                      </a:pPr>
-                      <a:r>
-                        <a:rPr lang="en-US" sz="1500" dirty="0">
-                          <a:solidFill>
-                            <a:srgbClr val="1F2A44"/>
-                          </a:solidFill>
-                          <a:latin typeface="Calibri" pitchFamily="34" charset="0"/>
-                          <a:ea typeface="Calibri" pitchFamily="34" charset="-122"/>
-                          <a:cs typeface="Calibri" pitchFamily="34" charset="-120"/>
-                        </a:rPr>
-                        <a:t>Loudest minus quietest</a:t>
-                      </a:r>
-                      <a:endParaRPr lang="en-US" sz="1500" dirty="0">
-                        <a:latin typeface="Calibri" charset="0"/>
-                        <a:ea typeface="Calibri" charset="0"/>
-                        <a:cs typeface="Calibri" charset="0"/>
-                      </a:endParaRPr>
-                    </a:p>
-                  </a:txBody>
-                  <a:tcPr marL="54864" marR="54864" marT="36576" marB="36576">
-                    <a:lnL w="0" cap="flat" cmpd="sng" algn="ctr">
-                      <a:noFill/>
-                    </a:lnL>
-                    <a:lnR w="0" cap="flat" cmpd="sng" algn="ctr">
-                      <a:noFill/>
-                    </a:lnR>
-                    <a:lnT w="0" cap="flat" cmpd="sng" algn="ctr">
-                      <a:noFill/>
-                    </a:lnT>
-                    <a:lnB w="6350" cap="flat" cmpd="sng" algn="ctr">
-                      <a:solidFill>
-                        <a:srgbClr val="E3E7EE"/>
-                      </a:solidFill>
-                      <a:prstDash val="solid"/>
-                      <a:round/>
-                      <a:headEnd type="none" w="med" len="med"/>
-                      <a:tailEnd type="none" w="med" len="med"/>
-                    </a:lnB>
-                  </a:tcPr>
-                </a:tc>
-                <a:tc>
-                  <a:txBody>
-                    <a:bodyPr/>
-                    <a:lstStyle/>
-                    <a:p>
-                      <a:pPr algn="r" indent="0" marL="0">
-                        <a:buNone/>
-                      </a:pPr>
-                      <a:r>
-                        <a:rPr lang="en-US" sz="2000" b="1" dirty="0">
-                          <a:solidFill>
-                            <a:srgbClr val="D6336C"/>
-                          </a:solidFill>
-                          <a:latin typeface="Calibri" pitchFamily="34" charset="0"/>
-                          <a:ea typeface="Calibri" pitchFamily="34" charset="-122"/>
-                          <a:cs typeface="Calibri" pitchFamily="34" charset="-120"/>
-                        </a:rPr>
-                        <a:t>6.7 dB</a:t>
-                      </a:r>
-                      <a:endParaRPr lang="en-US" sz="2000" dirty="0">
-                        <a:latin typeface="Calibri" charset="0"/>
-                        <a:ea typeface="Calibri" charset="0"/>
-                        <a:cs typeface="Calibri" charset="0"/>
-                      </a:endParaRPr>
-                    </a:p>
-                  </a:txBody>
-                  <a:tcPr marL="54864" marR="54864" marT="36576" marB="36576">
-                    <a:lnL w="0" cap="flat" cmpd="sng" algn="ctr">
-                      <a:noFill/>
-                    </a:lnL>
-                    <a:lnR w="0" cap="flat" cmpd="sng" algn="ctr">
-                      <a:noFill/>
-                    </a:lnR>
-                    <a:lnT w="0" cap="flat" cmpd="sng" algn="ctr">
-                      <a:noFill/>
-                    </a:lnT>
-                    <a:lnB w="6350" cap="flat" cmpd="sng" algn="ctr">
-                      <a:solidFill>
-                        <a:srgbClr val="E3E7EE"/>
-                      </a:solidFill>
-                      <a:prstDash val="solid"/>
-                      <a:round/>
-                      <a:headEnd type="none" w="med" len="med"/>
-                      <a:tailEnd type="none" w="med" len="med"/>
-                    </a:lnB>
-                  </a:tcPr>
-                </a:tc>
-                <a:tc>
-                  <a:txBody>
-                    <a:bodyPr/>
-                    <a:lstStyle/>
-                    <a:p>
-                      <a:pPr algn="r" indent="0" marL="0">
-                        <a:buNone/>
-                      </a:pPr>
-                      <a:r>
-                        <a:rPr lang="en-US" sz="2000" b="1" dirty="0">
-                          <a:solidFill>
-                            <a:srgbClr val="2B6CB0"/>
-                          </a:solidFill>
-                          <a:latin typeface="Calibri" pitchFamily="34" charset="0"/>
-                          <a:ea typeface="Calibri" pitchFamily="34" charset="-122"/>
-                          <a:cs typeface="Calibri" pitchFamily="34" charset="-120"/>
-                        </a:rPr>
-                        <a:t>4.0 dB</a:t>
-                      </a:r>
-                      <a:endParaRPr lang="en-US" sz="2000" dirty="0">
-                        <a:latin typeface="Calibri" charset="0"/>
-                        <a:ea typeface="Calibri" charset="0"/>
-                        <a:cs typeface="Calibri" charset="0"/>
-                      </a:endParaRPr>
-                    </a:p>
-                  </a:txBody>
-                  <a:tcPr marL="54864" marR="54864" marT="36576" marB="36576">
-                    <a:lnL w="0" cap="flat" cmpd="sng" algn="ctr">
-                      <a:noFill/>
-                    </a:lnL>
-                    <a:lnR w="0" cap="flat" cmpd="sng" algn="ctr">
-                      <a:noFill/>
-                    </a:lnR>
-                    <a:lnT w="0" cap="flat" cmpd="sng" algn="ctr">
-                      <a:noFill/>
-                    </a:lnT>
-                    <a:lnB w="6350" cap="flat" cmpd="sng" algn="ctr">
-                      <a:solidFill>
-                        <a:srgbClr val="E3E7EE"/>
-                      </a:solidFill>
-                      <a:prstDash val="solid"/>
-                      <a:round/>
-                      <a:headEnd type="none" w="med" len="med"/>
-                      <a:tailEnd type="none" w="med" len="med"/>
-                    </a:lnB>
-                  </a:tcPr>
-                </a:tc>
-              </a:tr>
-              <a:tr h="502920">
-                <a:tc>
-                  <a:txBody>
-                    <a:bodyPr/>
-                    <a:lstStyle/>
-                    <a:p>
-                      <a:pPr algn="l" indent="0" marL="0">
-                        <a:buNone/>
-                      </a:pPr>
-                      <a:r>
-                        <a:rPr lang="en-US" sz="1500" dirty="0">
-                          <a:solidFill>
-                            <a:srgbClr val="1F2A44"/>
-                          </a:solidFill>
-                          <a:latin typeface="Calibri" pitchFamily="34" charset="0"/>
-                          <a:ea typeface="Calibri" pitchFamily="34" charset="-122"/>
-                          <a:cs typeface="Calibri" pitchFamily="34" charset="-120"/>
-                        </a:rPr>
-                        <a:t>Spread (rms)</a:t>
-                      </a:r>
-                      <a:endParaRPr lang="en-US" sz="1500" dirty="0">
-                        <a:latin typeface="Calibri" charset="0"/>
-                        <a:ea typeface="Calibri" charset="0"/>
-                        <a:cs typeface="Calibri" charset="0"/>
-                      </a:endParaRPr>
-                    </a:p>
-                  </a:txBody>
-                  <a:tcPr marL="54864" marR="54864" marT="36576" marB="36576">
-                    <a:lnL w="0" cap="flat" cmpd="sng" algn="ctr">
-                      <a:noFill/>
-                    </a:lnL>
-                    <a:lnR w="0" cap="flat" cmpd="sng" algn="ctr">
-                      <a:noFill/>
-                    </a:lnR>
-                    <a:lnT w="0" cap="flat" cmpd="sng" algn="ctr">
-                      <a:noFill/>
-                    </a:lnT>
-                    <a:lnB w="6350" cap="flat" cmpd="sng" algn="ctr">
-                      <a:solidFill>
-                        <a:srgbClr val="E3E7EE"/>
-                      </a:solidFill>
-                      <a:prstDash val="solid"/>
-                      <a:round/>
-                      <a:headEnd type="none" w="med" len="med"/>
-                      <a:tailEnd type="none" w="med" len="med"/>
-                    </a:lnB>
-                  </a:tcPr>
-                </a:tc>
-                <a:tc>
-                  <a:txBody>
-                    <a:bodyPr/>
-                    <a:lstStyle/>
-                    <a:p>
-                      <a:pPr algn="r" indent="0" marL="0">
-                        <a:buNone/>
-                      </a:pPr>
-                      <a:r>
-                        <a:rPr lang="en-US" sz="2000" b="1" dirty="0">
-                          <a:solidFill>
-                            <a:srgbClr val="D6336C"/>
-                          </a:solidFill>
-                          <a:latin typeface="Calibri" pitchFamily="34" charset="0"/>
-                          <a:ea typeface="Calibri" pitchFamily="34" charset="-122"/>
-                          <a:cs typeface="Calibri" pitchFamily="34" charset="-120"/>
-                        </a:rPr>
-                        <a:t>2.05 dB</a:t>
-                      </a:r>
-                      <a:endParaRPr lang="en-US" sz="2000" dirty="0">
-                        <a:latin typeface="Calibri" charset="0"/>
-                        <a:ea typeface="Calibri" charset="0"/>
-                        <a:cs typeface="Calibri" charset="0"/>
-                      </a:endParaRPr>
-                    </a:p>
-                  </a:txBody>
-                  <a:tcPr marL="54864" marR="54864" marT="36576" marB="36576">
-                    <a:lnL w="0" cap="flat" cmpd="sng" algn="ctr">
-                      <a:noFill/>
-                    </a:lnL>
-                    <a:lnR w="0" cap="flat" cmpd="sng" algn="ctr">
-                      <a:noFill/>
-                    </a:lnR>
-                    <a:lnT w="0" cap="flat" cmpd="sng" algn="ctr">
-                      <a:noFill/>
-                    </a:lnT>
-                    <a:lnB w="6350" cap="flat" cmpd="sng" algn="ctr">
-                      <a:solidFill>
-                        <a:srgbClr val="E3E7EE"/>
-                      </a:solidFill>
-                      <a:prstDash val="solid"/>
-                      <a:round/>
-                      <a:headEnd type="none" w="med" len="med"/>
-                      <a:tailEnd type="none" w="med" len="med"/>
-                    </a:lnB>
-                  </a:tcPr>
-                </a:tc>
-                <a:tc>
-                  <a:txBody>
-                    <a:bodyPr/>
-                    <a:lstStyle/>
-                    <a:p>
-                      <a:pPr algn="r" indent="0" marL="0">
-                        <a:buNone/>
-                      </a:pPr>
-                      <a:r>
-                        <a:rPr lang="en-US" sz="2000" b="1" dirty="0">
-                          <a:solidFill>
-                            <a:srgbClr val="2B6CB0"/>
-                          </a:solidFill>
-                          <a:latin typeface="Calibri" pitchFamily="34" charset="0"/>
-                          <a:ea typeface="Calibri" pitchFamily="34" charset="-122"/>
-                          <a:cs typeface="Calibri" pitchFamily="34" charset="-120"/>
-                        </a:rPr>
-                        <a:t>1.45 dB</a:t>
-                      </a:r>
-                      <a:endParaRPr lang="en-US" sz="2000" dirty="0">
-                        <a:latin typeface="Calibri" charset="0"/>
-                        <a:ea typeface="Calibri" charset="0"/>
-                        <a:cs typeface="Calibri" charset="0"/>
-                      </a:endParaRPr>
-                    </a:p>
-                  </a:txBody>
-                  <a:tcPr marL="54864" marR="54864" marT="36576" marB="36576">
-                    <a:lnL w="0" cap="flat" cmpd="sng" algn="ctr">
-                      <a:noFill/>
-                    </a:lnL>
-                    <a:lnR w="0" cap="flat" cmpd="sng" algn="ctr">
-                      <a:noFill/>
-                    </a:lnR>
-                    <a:lnT w="0" cap="flat" cmpd="sng" algn="ctr">
-                      <a:noFill/>
-                    </a:lnT>
-                    <a:lnB w="6350" cap="flat" cmpd="sng" algn="ctr">
-                      <a:solidFill>
-                        <a:srgbClr val="E3E7EE"/>
-                      </a:solidFill>
-                      <a:prstDash val="solid"/>
-                      <a:round/>
-                      <a:headEnd type="none" w="med" len="med"/>
-                      <a:tailEnd type="none" w="med" len="med"/>
-                    </a:lnB>
-                  </a:tcPr>
-                </a:tc>
-              </a:tr>
-              <a:tr h="411480">
-                <a:tc>
-                  <a:txBody>
-                    <a:bodyPr/>
-                    <a:lstStyle/>
-                    <a:p>
-                      <a:pPr algn="l" indent="0" marL="0">
-                        <a:buNone/>
-                      </a:pPr>
-                      <a:r>
-                        <a:rPr lang="en-US" sz="1500" dirty="0">
-                          <a:solidFill>
-                            <a:srgbClr val="1F2A44"/>
-                          </a:solidFill>
-                          <a:latin typeface="Calibri" pitchFamily="34" charset="0"/>
-                          <a:ea typeface="Calibri" pitchFamily="34" charset="-122"/>
-                          <a:cs typeface="Calibri" pitchFamily="34" charset="-120"/>
-                        </a:rPr>
-                        <a:t>Level range</a:t>
-                      </a:r>
-                      <a:endParaRPr lang="en-US" sz="1500" dirty="0">
-                        <a:latin typeface="Calibri" charset="0"/>
-                        <a:ea typeface="Calibri" charset="0"/>
-                        <a:cs typeface="Calibri" charset="0"/>
-                      </a:endParaRPr>
-                    </a:p>
-                  </a:txBody>
-                  <a:tcPr marL="54864" marR="54864" marT="36576" marB="36576">
-                    <a:lnL w="0" cap="flat" cmpd="sng" algn="ctr">
-                      <a:noFill/>
-                    </a:lnL>
-                    <a:lnR w="0" cap="flat" cmpd="sng" algn="ctr">
-                      <a:noFill/>
-                    </a:lnR>
-                    <a:lnT w="0" cap="flat" cmpd="sng" algn="ctr">
-                      <a:noFill/>
-                    </a:lnT>
-                    <a:lnB w="6350" cap="flat" cmpd="sng" algn="ctr">
-                      <a:solidFill>
-                        <a:srgbClr val="E3E7EE"/>
-                      </a:solidFill>
-                      <a:prstDash val="solid"/>
-                      <a:round/>
-                      <a:headEnd type="none" w="med" len="med"/>
-                      <a:tailEnd type="none" w="med" len="med"/>
-                    </a:lnB>
-                  </a:tcPr>
-                </a:tc>
-                <a:tc>
-                  <a:txBody>
-                    <a:bodyPr/>
-                    <a:lstStyle/>
-                    <a:p>
-                      <a:pPr algn="r" indent="0" marL="0">
-                        <a:buNone/>
-                      </a:pPr>
-                      <a:r>
-                        <a:rPr lang="en-US" sz="1500" dirty="0">
-                          <a:solidFill>
-                            <a:srgbClr val="D6336C"/>
-                          </a:solidFill>
-                          <a:latin typeface="Calibri" pitchFamily="34" charset="0"/>
-                          <a:ea typeface="Calibri" pitchFamily="34" charset="-122"/>
-                          <a:cs typeface="Calibri" pitchFamily="34" charset="-120"/>
-                        </a:rPr>
-                        <a:t>63.9–70.6 dB</a:t>
-                      </a:r>
-                      <a:endParaRPr lang="en-US" sz="1500" dirty="0">
-                        <a:latin typeface="Calibri" charset="0"/>
-                        <a:ea typeface="Calibri" charset="0"/>
-                        <a:cs typeface="Calibri" charset="0"/>
-                      </a:endParaRPr>
-                    </a:p>
-                  </a:txBody>
-                  <a:tcPr marL="54864" marR="54864" marT="36576" marB="36576">
-                    <a:lnL w="0" cap="flat" cmpd="sng" algn="ctr">
-                      <a:noFill/>
-                    </a:lnL>
-                    <a:lnR w="0" cap="flat" cmpd="sng" algn="ctr">
-                      <a:noFill/>
-                    </a:lnR>
-                    <a:lnT w="0" cap="flat" cmpd="sng" algn="ctr">
-                      <a:noFill/>
-                    </a:lnT>
-                    <a:lnB w="6350" cap="flat" cmpd="sng" algn="ctr">
-                      <a:solidFill>
-                        <a:srgbClr val="E3E7EE"/>
-                      </a:solidFill>
-                      <a:prstDash val="solid"/>
-                      <a:round/>
-                      <a:headEnd type="none" w="med" len="med"/>
-                      <a:tailEnd type="none" w="med" len="med"/>
-                    </a:lnB>
-                  </a:tcPr>
-                </a:tc>
-                <a:tc>
-                  <a:txBody>
-                    <a:bodyPr/>
-                    <a:lstStyle/>
-                    <a:p>
-                      <a:pPr algn="r" indent="0" marL="0">
-                        <a:buNone/>
-                      </a:pPr>
-                      <a:r>
-                        <a:rPr lang="en-US" sz="1500" dirty="0">
-                          <a:solidFill>
-                            <a:srgbClr val="2B6CB0"/>
-                          </a:solidFill>
-                          <a:latin typeface="Calibri" pitchFamily="34" charset="0"/>
-                          <a:ea typeface="Calibri" pitchFamily="34" charset="-122"/>
-                          <a:cs typeface="Calibri" pitchFamily="34" charset="-120"/>
-                        </a:rPr>
-                        <a:t>55.5–59.6 dB</a:t>
-                      </a:r>
-                      <a:endParaRPr lang="en-US" sz="1500" dirty="0">
-                        <a:latin typeface="Calibri" charset="0"/>
-                        <a:ea typeface="Calibri" charset="0"/>
-                        <a:cs typeface="Calibri" charset="0"/>
-                      </a:endParaRPr>
-                    </a:p>
-                  </a:txBody>
-                  <a:tcPr marL="54864" marR="54864" marT="36576" marB="36576">
-                    <a:lnL w="0" cap="flat" cmpd="sng" algn="ctr">
-                      <a:noFill/>
-                    </a:lnL>
-                    <a:lnR w="0" cap="flat" cmpd="sng" algn="ctr">
-                      <a:noFill/>
-                    </a:lnR>
-                    <a:lnT w="0" cap="flat" cmpd="sng" algn="ctr">
-                      <a:noFill/>
-                    </a:lnT>
-                    <a:lnB w="6350" cap="flat" cmpd="sng" algn="ctr">
-                      <a:solidFill>
-                        <a:srgbClr val="E3E7EE"/>
-                      </a:solidFill>
-                      <a:prstDash val="solid"/>
-                      <a:round/>
-                      <a:headEnd type="none" w="med" len="med"/>
-                      <a:tailEnd type="none" w="med" len="med"/>
-                    </a:lnB>
-                  </a:tcPr>
-                </a:tc>
-              </a:tr>
-            </a:tbl>
-          </a:graphicData>
-        </a:graphic>
-      </p:graphicFrame>
-      <p:sp>
-        <p:nvSpPr>
-          <p:cNvPr id="7" name="Text 3"/>
+          <a:p>
+            <a:pPr marL="342900" indent="-342900">
+              <a:spcAft>
+                <a:spcPts val="1000"/>
+              </a:spcAft>
+              <a:buSzPct val="100000"/>
+              <a:buChar char="•"/>
+            </a:pPr>
+            <a:r>
+              <a:rPr lang="en-US" sz="1600" b="1" dirty="0">
+                <a:solidFill>
+                  <a:srgbClr val="1F2A44"/>
+                </a:solidFill>
+                <a:latin typeface="Calibri" pitchFamily="34" charset="0"/>
+                <a:ea typeface="Calibri" pitchFamily="34" charset="-122"/>
+                <a:cs typeface="Calibri" pitchFamily="34" charset="-120"/>
+              </a:rPr>
+              <a:t>The outline is smooth and close to a circle.</a:t>
+            </a:r>
+            <a:endParaRPr lang="en-US" sz="1600" dirty="0"/>
+          </a:p>
+        </p:txBody>
+      </p:sp>
+      <p:sp>
+        <p:nvSpPr>
+          <p:cNvPr id="6" name="Text 3"/>
+          <p:cNvSpPr txBox="1"/>
+          <p:nvPr/>
+        </p:nvSpPr>
+        <p:spPr>
+          <a:xfrm>
+            <a:off x="6766560" y="5029200"/>
+            <a:ext cx="4846320" cy="731520"/>
+          </a:xfrm>
+          <a:prstGeom prst="rect">
+            <a:avLst/>
+          </a:prstGeom>
+          <a:noFill/>
+          <a:ln/>
+        </p:spPr>
+        <p:txBody>
+          <a:bodyPr wrap="square" lIns="0" tIns="0" rIns="0" bIns="0" rtlCol="0" anchor="ctr"/>
+          <a:lstStyle/>
+          <a:p>
+            <a:pPr indent="0" marL="0">
+              <a:buNone/>
+            </a:pPr>
+            <a:r>
+              <a:rPr lang="en-US" sz="4800" b="1" dirty="0">
+                <a:solidFill>
+                  <a:srgbClr val="D6336C"/>
+                </a:solidFill>
+                <a:latin typeface="Cambria" pitchFamily="34" charset="0"/>
+                <a:ea typeface="Cambria" pitchFamily="34" charset="-122"/>
+                <a:cs typeface="Cambria" pitchFamily="34" charset="-120"/>
+              </a:rPr>
+              <a:t>6.7</a:t>
+            </a:r>
+            <a:pPr indent="0" marL="0">
+              <a:buNone/>
+            </a:pPr>
+            <a:r>
+              <a:rPr lang="en-US" sz="4800" b="1" dirty="0">
+                <a:solidFill>
+                  <a:srgbClr val="5B6578"/>
+                </a:solidFill>
+                <a:latin typeface="Cambria" pitchFamily="34" charset="0"/>
+                <a:ea typeface="Cambria" pitchFamily="34" charset="-122"/>
+                <a:cs typeface="Cambria" pitchFamily="34" charset="-120"/>
+              </a:rPr>
+              <a:t> → </a:t>
+            </a:r>
+            <a:pPr indent="0" marL="0">
+              <a:buNone/>
+            </a:pPr>
+            <a:r>
+              <a:rPr lang="en-US" sz="4800" b="1" dirty="0">
+                <a:solidFill>
+                  <a:srgbClr val="2B6CB0"/>
+                </a:solidFill>
+                <a:latin typeface="Cambria" pitchFamily="34" charset="0"/>
+                <a:ea typeface="Cambria" pitchFamily="34" charset="-122"/>
+                <a:cs typeface="Cambria" pitchFamily="34" charset="-120"/>
+              </a:rPr>
+              <a:t>4.0 dB</a:t>
+            </a:r>
+            <a:endParaRPr lang="en-US" sz="4800" dirty="0"/>
+          </a:p>
+        </p:txBody>
+      </p:sp>
+      <p:sp>
+        <p:nvSpPr>
+          <p:cNvPr id="7" name="Text 4"/>
+          <p:cNvSpPr txBox="1"/>
+          <p:nvPr/>
+        </p:nvSpPr>
+        <p:spPr>
+          <a:xfrm>
+            <a:off x="6766560" y="5760720"/>
+            <a:ext cx="4846320" cy="457200"/>
+          </a:xfrm>
+          <a:prstGeom prst="rect">
+            <a:avLst/>
+          </a:prstGeom>
+          <a:noFill/>
+          <a:ln/>
+        </p:spPr>
+        <p:txBody>
+          <a:bodyPr wrap="square" lIns="0" tIns="0" rIns="0" bIns="0" rtlCol="0" anchor="ctr"/>
+          <a:lstStyle/>
+          <a:p>
+            <a:pPr indent="0" marL="0">
+              <a:buNone/>
+            </a:pPr>
+            <a:r>
+              <a:rPr lang="en-US" sz="1400" dirty="0">
+                <a:solidFill>
+                  <a:srgbClr val="5B6578"/>
+                </a:solidFill>
+                <a:latin typeface="Calibri" pitchFamily="34" charset="0"/>
+                <a:ea typeface="Calibri" pitchFamily="34" charset="-122"/>
+                <a:cs typeface="Calibri" pitchFamily="34" charset="-120"/>
+              </a:rPr>
+              <a:t>between the loudest and quietest microphone</a:t>
+            </a:r>
+            <a:endParaRPr lang="en-US" sz="1400" dirty="0"/>
+          </a:p>
+        </p:txBody>
+      </p:sp>
+      <p:sp>
+        <p:nvSpPr>
+          <p:cNvPr id="8" name="Text 5"/>
           <p:cNvSpPr txBox="1"/>
           <p:nvPr/>
         </p:nvSpPr>
@@ -2103,6 +1668,45 @@
               <a:t>20–560 Hz, motor at 2000 µs. The two runs had different operating points (7.35 V against 11.7 V), which is why the blue is lower.</a:t>
             </a:r>
             <a:endParaRPr lang="en-US" sz="1100" dirty="0"/>
+          </a:p>
+        </p:txBody>
+      </p:sp>
+      <p:sp>
+        <p:nvSpPr>
+          <p:cNvPr id="9" name="Text 6"/>
+          <p:cNvSpPr txBox="1"/>
+          <p:nvPr/>
+        </p:nvSpPr>
+        <p:spPr>
+          <a:xfrm>
+            <a:off x="11155680" y="6355080"/>
+            <a:ext cx="457200" cy="274320"/>
+          </a:xfrm>
+          <a:prstGeom prst="rect">
+            <a:avLst/>
+          </a:prstGeom>
+          <a:noFill/>
+          <a:ln/>
+        </p:spPr>
+        <p:txBody>
+          <a:bodyPr wrap="square" lIns="0" tIns="0" rIns="0" bIns="0" rtlCol="0" anchor="ctr"/>
+          <a:lstStyle/>
+          <a:p>
+            <a:pPr algn="r" indent="0" marL="0">
+              <a:buNone/>
+            </a:pPr>
+            <a:r>
+              <a:rPr lang="en-US" sz="1200" dirty="0">
+                <a:solidFill>
+                  <a:srgbClr val="5B6578"/>
+                </a:solidFill>
+                <a:latin typeface="Calibri" pitchFamily="34" charset="0"/>
+                <a:ea typeface="Calibri" pitchFamily="34" charset="-122"/>
+                <a:cs typeface="Calibri" pitchFamily="34" charset="-120"/>
+              </a:rPr>
+              <a:t>3</a:t>
+            </a:r>
+            <a:endParaRPr lang="en-US" sz="1200" dirty="0"/>
           </a:p>
         </p:txBody>
       </p:sp>

</xml_diff>

<commit_message>
Slides: slide 2, what we did (loudspeaker photo, microphone swap diagram, sweep settings, calibration results); overlay is now slide 3
Co-Authored-By: Claude Sonnet 5.5 <noreply@anthropic.com>
</commit_message>
<xml_diff>
--- a/docs/analysis/chamber-final-2026-10-01/slides/chamber-slides.pptx
+++ b/docs/analysis/chamber-final-2026-10-01/slides/chamber-slides.pptx
@@ -7,9 +7,10 @@
   <p:sldIdLst>
     <p:sldId id="256" r:id="rId2"/>
     <p:sldId id="257" r:id="rId3"/>
+    <p:sldId id="258" r:id="rId4"/>
   </p:sldIdLst>
   <p:notesMasterIdLst>
-    <p:notesMasterId r:id="rId4"/>
+    <p:notesMasterId r:id="rId5"/>
   </p:notesMasterIdLst>
   <p:sldSz cx="12192000" cy="6858000"/>
   <p:notesSz cx="6858000" cy="12192000"/>
@@ -106,6 +107,298 @@
     </a:lvl9pPr>
   </p:defaultTextStyle>
 </p:presentation>
+</file>
+
+<file path=ppt/charts/chart1.xml><?xml version="1.0" encoding="utf-8"?>
+<c:chartSpace xmlns:c="http://schemas.openxmlformats.org/drawingml/2006/chart" xmlns:a="http://schemas.openxmlformats.org/drawingml/2006/main" xmlns:r="http://schemas.openxmlformats.org/officeDocument/2006/relationships">
+  <c:date1904 val="0"/>
+  <c:roundedCorners val="1"/>
+  <c:chart>
+    <c:autoTitleDeleted val="1"/>
+    <c:plotArea>
+      <c:layout/>
+      <c:barChart>
+        <c:barDir val="bar"/>
+        <c:grouping val="clustered"/>
+        <c:varyColors val="0"/>
+        <c:ser>
+          <c:idx val="0"/>
+          <c:order val="0"/>
+          <c:tx>
+            <c:strRef>
+              <c:f>Sheet1!$B$1</c:f>
+              <c:strCache>
+                <c:ptCount val="1"/>
+                <c:pt idx="0">
+                  <c:v>Mean offset (dB)</c:v>
+                </c:pt>
+              </c:strCache>
+            </c:strRef>
+          </c:tx>
+          <c:spPr>
+            <a:solidFill>
+              <a:srgbClr val="2B6CB0"/>
+            </a:solidFill>
+            <a:effectLst/>
+          </c:spPr>
+          <c:invertIfNegative val="0"/>
+          <c:dLbls>
+            <c:numFmt formatCode="0.0" sourceLinked="0"/>
+            <c:txPr>
+              <a:bodyPr/>
+              <a:lstStyle/>
+              <a:p>
+                <a:pPr>
+                  <a:defRPr b="0" i="0" strike="noStrike" sz="1000" u="none">
+                    <a:solidFill>
+                      <a:srgbClr val="1F2A44"/>
+                    </a:solidFill>
+                    <a:latin typeface="Calibri"/>
+                  </a:defRPr>
+                </a:pPr>
+              </a:p>
+            </c:txPr>
+            <c:showLegendKey val="0"/>
+            <c:showVal val="1"/>
+            <c:showCatName val="0"/>
+            <c:showSerName val="0"/>
+            <c:showPercent val="0"/>
+            <c:showBubbleSize val="0"/>
+            <c:showLeaderLines val="0"/>
+          </c:dLbls>
+          <c:cat>
+            <c:multiLvlStrRef>
+              <c:f>Sheet1!$A$2:$A$12</c:f>
+              <c:multiLvlStrCache>
+                <c:ptCount val="11"/>
+                <c:lvl>
+                  <c:pt idx="0">
+                    <c:v>810-8893</c:v>
+                  </c:pt>
+                  <c:pt idx="1">
+                    <c:v>810-8904</c:v>
+                  </c:pt>
+                  <c:pt idx="2">
+                    <c:v>810-8901</c:v>
+                  </c:pt>
+                  <c:pt idx="3">
+                    <c:v>810-8897</c:v>
+                  </c:pt>
+                  <c:pt idx="4">
+                    <c:v>810-8900</c:v>
+                  </c:pt>
+                  <c:pt idx="5">
+                    <c:v>811-1896</c:v>
+                  </c:pt>
+                  <c:pt idx="6">
+                    <c:v>811-2321</c:v>
+                  </c:pt>
+                  <c:pt idx="7">
+                    <c:v>810-8903</c:v>
+                  </c:pt>
+                  <c:pt idx="8">
+                    <c:v>811-2310</c:v>
+                  </c:pt>
+                  <c:pt idx="9">
+                    <c:v>811-1897</c:v>
+                  </c:pt>
+                  <c:pt idx="10">
+                    <c:v>811-1892</c:v>
+                  </c:pt>
+                </c:lvl>
+              </c:multiLvlStrCache>
+            </c:multiLvlStrRef>
+          </c:cat>
+          <c:val>
+            <c:numRef>
+              <c:f>Sheet1!$B$2:$B$12</c:f>
+              <c:numCache>
+                <c:formatCode>General</c:formatCode>
+                <c:ptCount val="11"/>
+                <c:pt idx="0">
+                  <c:v>1.25</c:v>
+                </c:pt>
+                <c:pt idx="1">
+                  <c:v>0.85</c:v>
+                </c:pt>
+                <c:pt idx="2">
+                  <c:v>0.84</c:v>
+                </c:pt>
+                <c:pt idx="3">
+                  <c:v>0.76</c:v>
+                </c:pt>
+                <c:pt idx="4">
+                  <c:v>0.23</c:v>
+                </c:pt>
+                <c:pt idx="5">
+                  <c:v>0</c:v>
+                </c:pt>
+                <c:pt idx="6">
+                  <c:v>-0.09</c:v>
+                </c:pt>
+                <c:pt idx="7">
+                  <c:v>-0.14</c:v>
+                </c:pt>
+                <c:pt idx="8">
+                  <c:v>-0.78</c:v>
+                </c:pt>
+                <c:pt idx="9">
+                  <c:v>-1.39</c:v>
+                </c:pt>
+                <c:pt idx="10">
+                  <c:v>-2.59</c:v>
+                </c:pt>
+              </c:numCache>
+            </c:numRef>
+          </c:val>
+        </c:ser>
+        <c:dLbls>
+          <c:numFmt formatCode="0.0" sourceLinked="0"/>
+          <c:txPr>
+            <a:bodyPr/>
+            <a:lstStyle/>
+            <a:p>
+              <a:pPr>
+                <a:defRPr b="0" i="0" strike="noStrike" sz="1000" u="none">
+                  <a:solidFill>
+                    <a:srgbClr val="1F2A44"/>
+                  </a:solidFill>
+                  <a:latin typeface="Calibri"/>
+                </a:defRPr>
+              </a:pPr>
+            </a:p>
+          </c:txPr>
+          <c:showLegendKey val="0"/>
+          <c:showVal val="1"/>
+          <c:showCatName val="0"/>
+          <c:showSerName val="0"/>
+          <c:showPercent val="0"/>
+          <c:showBubbleSize val="0"/>
+          <c:showLeaderLines val="0"/>
+        </c:dLbls>
+        <c:gapWidth val="40"/>
+        <c:overlap val="0"/>
+        <c:axId val="2094734554"/>
+        <c:axId val="2094734552"/>
+        <c:axId val="2094734556"/>
+      </c:barChart>
+      <c:catAx>
+        <c:axId val="2094734554"/>
+        <c:scaling>
+          <c:orientation val="minMax"/>
+        </c:scaling>
+        <c:delete val="0"/>
+        <c:axPos val="l"/>
+        <c:numFmt formatCode="General" sourceLinked="1"/>
+        <c:majorTickMark val="out"/>
+        <c:minorTickMark val="none"/>
+        <c:tickLblPos val="low"/>
+        <c:spPr>
+          <a:ln w="12700" cap="flat">
+            <a:solidFill>
+              <a:srgbClr val="888888"/>
+            </a:solidFill>
+            <a:prstDash val="solid"/>
+            <a:round/>
+          </a:ln>
+        </c:spPr>
+        <c:txPr>
+          <a:bodyPr/>
+          <a:lstStyle/>
+          <a:p>
+            <a:pPr>
+              <a:defRPr sz="1000" b="0" i="0" u="none" strike="noStrike">
+                <a:solidFill>
+                  <a:srgbClr val="1F2A44"/>
+                </a:solidFill>
+                <a:latin typeface="Calibri"/>
+              </a:defRPr>
+            </a:pPr>
+            <a:endParaRPr lang="en-US"/>
+          </a:p>
+        </c:txPr>
+        <c:crossAx val="2094734552"/>
+        <c:crosses val="autoZero"/>
+        <c:auto val="1"/>
+        <c:lblAlgn val="ctr"/>
+        <c:noMultiLvlLbl val="1"/>
+        <c:tickLblSkip val="1"/>
+      </c:catAx>
+      <c:valAx>
+        <c:axId val="2094734552"/>
+        <c:scaling>
+          <c:orientation val="minMax"/>
+          <c:max val="2"/>
+          <c:min val="-3"/>
+        </c:scaling>
+        <c:delete val="0"/>
+        <c:axPos val="b"/>
+        <c:majorGridlines>
+          <c:spPr>
+            <a:ln w="6350" cap="flat">
+              <a:solidFill>
+                <a:srgbClr val="E3E7EE"/>
+              </a:solidFill>
+              <a:prstDash val="solid"/>
+              <a:round/>
+            </a:ln>
+          </c:spPr>
+        </c:majorGridlines>
+        <c:numFmt formatCode="General" sourceLinked="0"/>
+        <c:majorTickMark val="out"/>
+        <c:minorTickMark val="none"/>
+        <c:tickLblPos val="low"/>
+        <c:spPr>
+          <a:ln w="12700" cap="flat">
+            <a:solidFill>
+              <a:srgbClr val="888888"/>
+            </a:solidFill>
+            <a:prstDash val="solid"/>
+            <a:round/>
+          </a:ln>
+        </c:spPr>
+        <c:txPr>
+          <a:bodyPr/>
+          <a:lstStyle/>
+          <a:p>
+            <a:pPr>
+              <a:defRPr sz="1000" b="0" i="0" u="none" strike="noStrike">
+                <a:solidFill>
+                  <a:srgbClr val="5B6578"/>
+                </a:solidFill>
+                <a:latin typeface="Calibri"/>
+              </a:defRPr>
+            </a:pPr>
+            <a:endParaRPr lang="en-US"/>
+          </a:p>
+        </c:txPr>
+        <c:crossAx val="2094734554"/>
+        <c:crosses val="autoZero"/>
+        <c:crossBetween val="between"/>
+        <c:majorUnit val="1"/>
+      </c:valAx>
+      <c:spPr>
+        <a:noFill/>
+        <a:ln>
+          <a:noFill/>
+        </a:ln>
+        <a:effectLst/>
+      </c:spPr>
+    </c:plotArea>
+    <c:plotVisOnly val="1"/>
+    <c:dispBlanksAs val="span"/>
+  </c:chart>
+  <c:spPr>
+    <a:noFill/>
+    <a:ln>
+      <a:noFill/>
+    </a:ln>
+    <a:effectLst/>
+  </c:spPr>
+  <c:externalData r:id="rId1">
+    <c:autoUpdate val="0"/>
+  </c:externalData>
+</c:chartSpace>
 </file>
 
 <file path=ppt/notesMasters/notesMaster1.xml><?xml version="1.0" encoding="utf-8"?>
@@ -591,7 +884,7 @@
           <a:p>
             <a:r>
               <a:rPr lang="en-US" dirty="0"/>
-              <a:t>Blue: 30 Sep propeller measurement (11.7 V, 7.3 A, thrust -4 N), read with the 16 Sep microphone corrections. Rms spread about the mean 1.45 dB against 2.05 dB for 31 Aug; range 4.0 dB (55.5 to 59.6 dB SPL) against 6.7 dB. The blue is about 11 dB lower because the motor ran at a different operating point. The 4 dB range of the blue is a bottom-louder trend. Honest caveat: with the same calibration applied to the 1-2 Sep runs, those are about as round as 30 Sep, so most of the improvement against the earlier baselines comes from the microphone calibration, not the room.</a:t>
+              <a:t>Procedure (calibrator/session.py, 2026-09-16 session): each of the eleven UMIK-2 capsules was plugged in at the same mounting point in front of the loudspeaker and measured over 97 stepped tones, 62 Hz to 16 kHz (about 12 per octave), amplitude 0.03, 48 kHz sampling, 0.7 s settle and 2 s capture per tone (6 s below 250 Hz). Capsule 810-8904 was measured three full times (18:21, 18:30, 20:43) as the reference. The difference of each capsule from the reference was folded into its calibration curve; Sens Factors kept as in the factory files. The datum is the mean of four capsules whose factory files agree with measurement (810-8900, 810-8903, 811-1896, 811-2321). Bars: mean over frequency of how far each capsule read from that datum with its factory file (calibrator corrections csv). Spread 4.01 to 0.02 dB and 7 of 11 files wrong by 0.6-3.6 dB are from the project notes. Absolute level is not anchored: that needs a 94 dB calibrator.</a:t>
             </a:r>
             <a:endParaRPr lang="en-US" dirty="0"/>
           </a:p>
@@ -615,6 +908,94 @@
             <a:fld id="{F7021451-1387-4CA6-816F-3879F97B5CBC}" type="slidenum">
               <a:rPr lang="en-US"/>
               <a:t>2</a:t>
+            </a:fld>
+            <a:endParaRPr lang="en-US"/>
+          </a:p>
+        </p:txBody>
+      </p:sp>
+    </p:spTree>
+    <p:extLst>
+      <p:ext uri="{BB962C8B-B14F-4D97-AF65-F5344CB8AC3E}">
+        <p14:creationId xmlns:p14="http://schemas.microsoft.com/office/powerpoint/2010/main" val="1024086991"/>
+      </p:ext>
+    </p:extLst>
+  </p:cSld>
+  <p:clrMapOvr>
+    <a:masterClrMapping/>
+  </p:clrMapOvr>
+</p:notes>
+</file>
+
+<file path=ppt/notesSlides/notesSlide3.xml><?xml version="1.0" encoding="utf-8"?>
+<p:notes xmlns:a="http://schemas.openxmlformats.org/drawingml/2006/main" xmlns:r="http://schemas.openxmlformats.org/officeDocument/2006/relationships" xmlns:p="http://schemas.openxmlformats.org/presentationml/2006/main">
+  <p:cSld>
+    <p:spTree>
+      <p:nvGrpSpPr>
+        <p:cNvPr id="1" name=""/>
+        <p:cNvGrpSpPr/>
+        <p:nvPr/>
+      </p:nvGrpSpPr>
+      <p:grpSpPr>
+        <a:xfrm>
+          <a:off x="0" y="0"/>
+          <a:ext cx="0" cy="0"/>
+          <a:chOff x="0" y="0"/>
+          <a:chExt cx="0" cy="0"/>
+        </a:xfrm>
+      </p:grpSpPr>
+      <p:sp>
+        <p:nvSpPr>
+          <p:cNvPr id="2" name="Slide Image Placeholder 1"/>
+          <p:cNvSpPr>
+            <a:spLocks noGrp="1" noRot="1" noChangeAspect="1"/>
+          </p:cNvSpPr>
+          <p:nvPr>
+            <p:ph type="sldImg"/>
+          </p:nvPr>
+        </p:nvSpPr>
+        <p:spPr/>
+      </p:sp>
+      <p:sp>
+        <p:nvSpPr>
+          <p:cNvPr id="3" name="Notes Placeholder 2"/>
+          <p:cNvSpPr>
+            <a:spLocks noGrp="1"/>
+          </p:cNvSpPr>
+          <p:nvPr>
+            <p:ph type="body" idx="1"/>
+          </p:nvPr>
+        </p:nvSpPr>
+        <p:spPr/>
+        <p:txBody>
+          <a:bodyPr/>
+          <a:lstStyle/>
+          <a:p>
+            <a:r>
+              <a:rPr lang="en-US" dirty="0"/>
+              <a:t>Blue: 30 Sep propeller measurement (11.7 V, 7.3 A, thrust -4 N), read with the 16 Sep microphone corrections. Rms spread about the mean 1.45 dB against 2.05 dB for 31 Aug; range 4.0 dB (55.5 to 59.6 dB SPL) against 6.7 dB. The blue is about 11 dB lower because the motor ran at a different operating point. The 4 dB range of the blue is a bottom-louder trend. Honest caveat: with the same calibration applied to the 1-2 Sep runs, those are about as round as 30 Sep, so most of the improvement against the earlier baselines comes from the microphone calibration, not the room.</a:t>
+            </a:r>
+            <a:endParaRPr lang="en-US" dirty="0"/>
+          </a:p>
+        </p:txBody>
+      </p:sp>
+      <p:sp>
+        <p:nvSpPr>
+          <p:cNvPr id="4" name="Slide Number Placeholder 3"/>
+          <p:cNvSpPr>
+            <a:spLocks noGrp="1"/>
+          </p:cNvSpPr>
+          <p:nvPr>
+            <p:ph type="sldNum" sz="quarter" idx="10"/>
+          </p:nvPr>
+        </p:nvSpPr>
+        <p:spPr/>
+        <p:txBody>
+          <a:bodyPr/>
+          <a:lstStyle/>
+          <a:p>
+            <a:fld id="{F7021451-1387-4CA6-816F-3879F97B5CBC}" type="slidenum">
+              <a:rPr lang="en-US"/>
+              <a:t>3</a:t>
             </a:fld>
             <a:endParaRPr lang="en-US"/>
           </a:p>
@@ -1339,6 +1720,892 @@
           <a:chExt cx="0" cy="0"/>
         </a:xfrm>
       </p:grpSpPr>
+      <p:sp>
+        <p:nvSpPr>
+          <p:cNvPr id="2" name="Text 0"/>
+          <p:cNvSpPr txBox="1"/>
+          <p:nvPr/>
+        </p:nvSpPr>
+        <p:spPr>
+          <a:xfrm>
+            <a:off x="548640" y="457200"/>
+            <a:ext cx="5486400" cy="365760"/>
+          </a:xfrm>
+          <a:prstGeom prst="rect">
+            <a:avLst/>
+          </a:prstGeom>
+          <a:noFill/>
+          <a:ln/>
+        </p:spPr>
+        <p:txBody>
+          <a:bodyPr wrap="square" lIns="0" tIns="0" rIns="0" bIns="0" rtlCol="0" anchor="ctr"/>
+          <a:lstStyle/>
+          <a:p>
+            <a:pPr indent="0" marL="0">
+              <a:buNone/>
+            </a:pPr>
+            <a:r>
+              <a:rPr lang="en-US" sz="1400" b="1" spc="300" kern="0" dirty="0">
+                <a:solidFill>
+                  <a:srgbClr val="2B6CB0"/>
+                </a:solidFill>
+                <a:latin typeface="Calibri" pitchFamily="34" charset="0"/>
+                <a:ea typeface="Calibri" pitchFamily="34" charset="-122"/>
+                <a:cs typeface="Calibri" pitchFamily="34" charset="-120"/>
+              </a:rPr>
+              <a:t>THE FIX</a:t>
+            </a:r>
+            <a:endParaRPr lang="en-US" sz="1400" dirty="0"/>
+          </a:p>
+        </p:txBody>
+      </p:sp>
+      <p:sp>
+        <p:nvSpPr>
+          <p:cNvPr id="3" name="Text 1"/>
+          <p:cNvSpPr txBox="1"/>
+          <p:nvPr/>
+        </p:nvSpPr>
+        <p:spPr>
+          <a:xfrm>
+            <a:off x="548640" y="822960"/>
+            <a:ext cx="11064240" cy="731520"/>
+          </a:xfrm>
+          <a:prstGeom prst="rect">
+            <a:avLst/>
+          </a:prstGeom>
+          <a:noFill/>
+          <a:ln/>
+        </p:spPr>
+        <p:txBody>
+          <a:bodyPr wrap="square" lIns="0" tIns="0" rIns="0" bIns="0" rtlCol="0" anchor="t"/>
+          <a:lstStyle/>
+          <a:p>
+            <a:pPr indent="0" marL="0">
+              <a:buNone/>
+            </a:pPr>
+            <a:r>
+              <a:rPr lang="en-US" sz="3200" b="1" dirty="0">
+                <a:solidFill>
+                  <a:srgbClr val="1F2A44"/>
+                </a:solidFill>
+                <a:latin typeface="Cambria" pitchFamily="34" charset="0"/>
+                <a:ea typeface="Cambria" pitchFamily="34" charset="-122"/>
+                <a:cs typeface="Cambria" pitchFamily="34" charset="-120"/>
+              </a:rPr>
+              <a:t>What we did: every microphone, one loudspeaker</a:t>
+            </a:r>
+            <a:endParaRPr lang="en-US" sz="3200" dirty="0"/>
+          </a:p>
+        </p:txBody>
+      </p:sp>
+      <p:pic>
+        <p:nvPicPr>
+          <p:cNvPr id="4" name="Image 0" descr="Our loudspeaker: a printed sphere with an 8 cm driver">    </p:cNvPr>
+          <p:cNvPicPr>
+            <a:picLocks noChangeAspect="1"/>
+          </p:cNvPicPr>
+          <p:nvPr/>
+        </p:nvPicPr>
+        <p:blipFill>
+          <a:blip r:embed="rId1"/>
+          <a:srcRect l="0" r="0" t="0" b="0"/>
+          <a:stretch/>
+        </p:blipFill>
+        <p:spPr>
+          <a:xfrm>
+            <a:off x="640080" y="2057400"/>
+            <a:ext cx="1417320" cy="1600200"/>
+          </a:xfrm>
+          <a:prstGeom prst="rect">
+            <a:avLst/>
+          </a:prstGeom>
+        </p:spPr>
+      </p:pic>
+      <p:sp>
+        <p:nvSpPr>
+          <p:cNvPr id="5" name="Text 2"/>
+          <p:cNvSpPr txBox="1"/>
+          <p:nvPr/>
+        </p:nvSpPr>
+        <p:spPr>
+          <a:xfrm>
+            <a:off x="411480" y="3703320"/>
+            <a:ext cx="1874520" cy="274320"/>
+          </a:xfrm>
+          <a:prstGeom prst="rect">
+            <a:avLst/>
+          </a:prstGeom>
+          <a:noFill/>
+          <a:ln/>
+        </p:spPr>
+        <p:txBody>
+          <a:bodyPr wrap="square" lIns="0" tIns="0" rIns="0" bIns="0" rtlCol="0" anchor="ctr"/>
+          <a:lstStyle/>
+          <a:p>
+            <a:pPr algn="ctr" indent="0" marL="0">
+              <a:buNone/>
+            </a:pPr>
+            <a:r>
+              <a:rPr lang="en-US" sz="1400" dirty="0">
+                <a:solidFill>
+                  <a:srgbClr val="1F2A44"/>
+                </a:solidFill>
+                <a:latin typeface="Calibri" pitchFamily="34" charset="0"/>
+                <a:ea typeface="Calibri" pitchFamily="34" charset="-122"/>
+                <a:cs typeface="Calibri" pitchFamily="34" charset="-120"/>
+              </a:rPr>
+              <a:t>Our loudspeaker</a:t>
+            </a:r>
+            <a:endParaRPr lang="en-US" sz="1400" dirty="0"/>
+          </a:p>
+        </p:txBody>
+      </p:sp>
+      <p:sp>
+        <p:nvSpPr>
+          <p:cNvPr id="6" name="Text 3"/>
+          <p:cNvSpPr txBox="1"/>
+          <p:nvPr/>
+        </p:nvSpPr>
+        <p:spPr>
+          <a:xfrm>
+            <a:off x="2011680" y="2514600"/>
+            <a:ext cx="2377440" cy="274320"/>
+          </a:xfrm>
+          <a:prstGeom prst="rect">
+            <a:avLst/>
+          </a:prstGeom>
+          <a:noFill/>
+          <a:ln/>
+        </p:spPr>
+        <p:txBody>
+          <a:bodyPr wrap="square" lIns="0" tIns="0" rIns="0" bIns="0" rtlCol="0" anchor="ctr"/>
+          <a:lstStyle/>
+          <a:p>
+            <a:pPr algn="ctr" indent="0" marL="0">
+              <a:buNone/>
+            </a:pPr>
+            <a:r>
+              <a:rPr lang="en-US" sz="1200" dirty="0">
+                <a:solidFill>
+                  <a:srgbClr val="5B6578"/>
+                </a:solidFill>
+                <a:latin typeface="Calibri" pitchFamily="34" charset="0"/>
+                <a:ea typeface="Calibri" pitchFamily="34" charset="-122"/>
+                <a:cs typeface="Calibri" pitchFamily="34" charset="-120"/>
+              </a:rPr>
+              <a:t>stepped tones, 62 Hz to 16 kHz</a:t>
+            </a:r>
+            <a:endParaRPr lang="en-US" sz="1200" dirty="0"/>
+          </a:p>
+        </p:txBody>
+      </p:sp>
+      <p:sp>
+        <p:nvSpPr>
+          <p:cNvPr id="7" name="Shape 4"/>
+          <p:cNvSpPr/>
+          <p:nvPr/>
+        </p:nvSpPr>
+        <p:spPr>
+          <a:xfrm>
+            <a:off x="2194560" y="2926080"/>
+            <a:ext cx="2011680" cy="0"/>
+          </a:xfrm>
+          <a:prstGeom prst="line">
+            <a:avLst/>
+          </a:prstGeom>
+          <a:noFill/>
+          <a:ln w="31750">
+            <a:solidFill>
+              <a:srgbClr val="D6336C"/>
+            </a:solidFill>
+            <a:prstDash val="dash"/>
+            <a:tailEnd type="triangle"/>
+          </a:ln>
+        </p:spPr>
+      </p:sp>
+      <p:sp>
+        <p:nvSpPr>
+          <p:cNvPr id="8" name="Shape 5"/>
+          <p:cNvSpPr/>
+          <p:nvPr/>
+        </p:nvSpPr>
+        <p:spPr>
+          <a:xfrm>
+            <a:off x="4297680" y="2651760"/>
+            <a:ext cx="502920" cy="502920"/>
+          </a:xfrm>
+          <a:prstGeom prst="ellipse">
+            <a:avLst/>
+          </a:prstGeom>
+          <a:solidFill>
+            <a:srgbClr val="2B6CB0"/>
+          </a:solidFill>
+          <a:ln w="12700">
+            <a:solidFill>
+              <a:srgbClr val="2B6CB0"/>
+            </a:solidFill>
+            <a:prstDash val="solid"/>
+          </a:ln>
+        </p:spPr>
+      </p:sp>
+      <p:sp>
+        <p:nvSpPr>
+          <p:cNvPr id="9" name="Shape 6"/>
+          <p:cNvSpPr/>
+          <p:nvPr/>
+        </p:nvSpPr>
+        <p:spPr>
+          <a:xfrm>
+            <a:off x="4498848" y="3108960"/>
+            <a:ext cx="100584" cy="548640"/>
+          </a:xfrm>
+          <a:prstGeom prst="rect">
+            <a:avLst/>
+          </a:prstGeom>
+          <a:solidFill>
+            <a:srgbClr val="2B6CB0"/>
+          </a:solidFill>
+          <a:ln w="12700">
+            <a:solidFill>
+              <a:srgbClr val="2B6CB0"/>
+            </a:solidFill>
+            <a:prstDash val="solid"/>
+          </a:ln>
+        </p:spPr>
+      </p:sp>
+      <p:sp>
+        <p:nvSpPr>
+          <p:cNvPr id="10" name="Text 7"/>
+          <p:cNvSpPr txBox="1"/>
+          <p:nvPr/>
+        </p:nvSpPr>
+        <p:spPr>
+          <a:xfrm>
+            <a:off x="3383280" y="3749040"/>
+            <a:ext cx="2148840" cy="274320"/>
+          </a:xfrm>
+          <a:prstGeom prst="rect">
+            <a:avLst/>
+          </a:prstGeom>
+          <a:noFill/>
+          <a:ln/>
+        </p:spPr>
+        <p:txBody>
+          <a:bodyPr wrap="square" lIns="0" tIns="0" rIns="0" bIns="0" rtlCol="0" anchor="ctr"/>
+          <a:lstStyle/>
+          <a:p>
+            <a:pPr algn="ctr" indent="0" marL="0">
+              <a:buNone/>
+            </a:pPr>
+            <a:r>
+              <a:rPr lang="en-US" sz="1400" dirty="0">
+                <a:solidFill>
+                  <a:srgbClr val="1F2A44"/>
+                </a:solidFill>
+                <a:latin typeface="Calibri" pitchFamily="34" charset="0"/>
+                <a:ea typeface="Calibri" pitchFamily="34" charset="-122"/>
+                <a:cs typeface="Calibri" pitchFamily="34" charset="-120"/>
+              </a:rPr>
+              <a:t>UMIK-2 microphone</a:t>
+            </a:r>
+            <a:endParaRPr lang="en-US" sz="1400" dirty="0"/>
+          </a:p>
+        </p:txBody>
+      </p:sp>
+      <p:sp>
+        <p:nvSpPr>
+          <p:cNvPr id="11" name="Text 8"/>
+          <p:cNvSpPr txBox="1"/>
+          <p:nvPr/>
+        </p:nvSpPr>
+        <p:spPr>
+          <a:xfrm>
+            <a:off x="4892040" y="2606040"/>
+            <a:ext cx="731520" cy="274320"/>
+          </a:xfrm>
+          <a:prstGeom prst="rect">
+            <a:avLst/>
+          </a:prstGeom>
+          <a:noFill/>
+          <a:ln/>
+        </p:spPr>
+        <p:txBody>
+          <a:bodyPr wrap="square" lIns="0" tIns="0" rIns="0" bIns="0" rtlCol="0" anchor="ctr"/>
+          <a:lstStyle/>
+          <a:p>
+            <a:pPr algn="ctr" indent="0" marL="0">
+              <a:buNone/>
+            </a:pPr>
+            <a:r>
+              <a:rPr lang="en-US" sz="1200" b="1" dirty="0">
+                <a:solidFill>
+                  <a:srgbClr val="1F2A44"/>
+                </a:solidFill>
+                <a:latin typeface="Calibri" pitchFamily="34" charset="0"/>
+                <a:ea typeface="Calibri" pitchFamily="34" charset="-122"/>
+                <a:cs typeface="Calibri" pitchFamily="34" charset="-120"/>
+              </a:rPr>
+              <a:t>swap</a:t>
+            </a:r>
+            <a:endParaRPr lang="en-US" sz="1200" dirty="0"/>
+          </a:p>
+        </p:txBody>
+      </p:sp>
+      <p:sp>
+        <p:nvSpPr>
+          <p:cNvPr id="12" name="Shape 9"/>
+          <p:cNvSpPr/>
+          <p:nvPr/>
+        </p:nvSpPr>
+        <p:spPr>
+          <a:xfrm>
+            <a:off x="4937760" y="2926080"/>
+            <a:ext cx="640080" cy="0"/>
+          </a:xfrm>
+          <a:prstGeom prst="line">
+            <a:avLst/>
+          </a:prstGeom>
+          <a:noFill/>
+          <a:ln w="25400">
+            <a:solidFill>
+              <a:srgbClr val="1F2A44"/>
+            </a:solidFill>
+            <a:prstDash val="solid"/>
+            <a:headEnd type="triangle"/>
+            <a:tailEnd type="triangle"/>
+          </a:ln>
+        </p:spPr>
+      </p:sp>
+      <p:sp>
+        <p:nvSpPr>
+          <p:cNvPr id="13" name="Shape 10"/>
+          <p:cNvSpPr/>
+          <p:nvPr/>
+        </p:nvSpPr>
+        <p:spPr>
+          <a:xfrm>
+            <a:off x="5760720" y="2240280"/>
+            <a:ext cx="384048" cy="384048"/>
+          </a:xfrm>
+          <a:prstGeom prst="ellipse">
+            <a:avLst/>
+          </a:prstGeom>
+          <a:solidFill>
+            <a:srgbClr val="C9CFDA"/>
+          </a:solidFill>
+          <a:ln w="12700">
+            <a:solidFill>
+              <a:srgbClr val="C9CFDA"/>
+            </a:solidFill>
+            <a:prstDash val="solid"/>
+          </a:ln>
+        </p:spPr>
+      </p:sp>
+      <p:sp>
+        <p:nvSpPr>
+          <p:cNvPr id="14" name="Shape 11"/>
+          <p:cNvSpPr/>
+          <p:nvPr/>
+        </p:nvSpPr>
+        <p:spPr>
+          <a:xfrm>
+            <a:off x="5760720" y="2697480"/>
+            <a:ext cx="384048" cy="384048"/>
+          </a:xfrm>
+          <a:prstGeom prst="ellipse">
+            <a:avLst/>
+          </a:prstGeom>
+          <a:solidFill>
+            <a:srgbClr val="C9CFDA"/>
+          </a:solidFill>
+          <a:ln w="12700">
+            <a:solidFill>
+              <a:srgbClr val="C9CFDA"/>
+            </a:solidFill>
+            <a:prstDash val="solid"/>
+          </a:ln>
+        </p:spPr>
+      </p:sp>
+      <p:sp>
+        <p:nvSpPr>
+          <p:cNvPr id="15" name="Shape 12"/>
+          <p:cNvSpPr/>
+          <p:nvPr/>
+        </p:nvSpPr>
+        <p:spPr>
+          <a:xfrm>
+            <a:off x="5760720" y="3154680"/>
+            <a:ext cx="384048" cy="384048"/>
+          </a:xfrm>
+          <a:prstGeom prst="ellipse">
+            <a:avLst/>
+          </a:prstGeom>
+          <a:solidFill>
+            <a:srgbClr val="C9CFDA"/>
+          </a:solidFill>
+          <a:ln w="12700">
+            <a:solidFill>
+              <a:srgbClr val="C9CFDA"/>
+            </a:solidFill>
+            <a:prstDash val="solid"/>
+          </a:ln>
+        </p:spPr>
+      </p:sp>
+      <p:sp>
+        <p:nvSpPr>
+          <p:cNvPr id="16" name="Text 13"/>
+          <p:cNvSpPr txBox="1"/>
+          <p:nvPr/>
+        </p:nvSpPr>
+        <p:spPr>
+          <a:xfrm>
+            <a:off x="5577840" y="3749040"/>
+            <a:ext cx="1188720" cy="274320"/>
+          </a:xfrm>
+          <a:prstGeom prst="rect">
+            <a:avLst/>
+          </a:prstGeom>
+          <a:noFill/>
+          <a:ln/>
+        </p:spPr>
+        <p:txBody>
+          <a:bodyPr wrap="square" lIns="0" tIns="0" rIns="0" bIns="0" rtlCol="0" anchor="ctr"/>
+          <a:lstStyle/>
+          <a:p>
+            <a:pPr algn="ctr" indent="0" marL="0">
+              <a:buNone/>
+            </a:pPr>
+            <a:r>
+              <a:rPr lang="en-US" sz="1400" dirty="0">
+                <a:solidFill>
+                  <a:srgbClr val="1F2A44"/>
+                </a:solidFill>
+                <a:latin typeface="Calibri" pitchFamily="34" charset="0"/>
+                <a:ea typeface="Calibri" pitchFamily="34" charset="-122"/>
+                <a:cs typeface="Calibri" pitchFamily="34" charset="-120"/>
+              </a:rPr>
+              <a:t>all 11 in turn</a:t>
+            </a:r>
+            <a:endParaRPr lang="en-US" sz="1400" dirty="0"/>
+          </a:p>
+        </p:txBody>
+      </p:sp>
+      <p:sp>
+        <p:nvSpPr>
+          <p:cNvPr id="17" name="Text 14"/>
+          <p:cNvSpPr txBox="1"/>
+          <p:nvPr/>
+        </p:nvSpPr>
+        <p:spPr>
+          <a:xfrm>
+            <a:off x="548640" y="4434840"/>
+            <a:ext cx="6126480" cy="1783080"/>
+          </a:xfrm>
+          <a:prstGeom prst="rect">
+            <a:avLst/>
+          </a:prstGeom>
+          <a:noFill/>
+          <a:ln/>
+        </p:spPr>
+        <p:txBody>
+          <a:bodyPr wrap="square" lIns="0" tIns="0" rIns="0" bIns="0" rtlCol="0" anchor="t"/>
+          <a:lstStyle/>
+          <a:p>
+            <a:pPr marL="342900" indent="-342900">
+              <a:spcAft>
+                <a:spcPts val="600"/>
+              </a:spcAft>
+              <a:buSzPct val="100000"/>
+              <a:buChar char="•"/>
+            </a:pPr>
+            <a:r>
+              <a:rPr lang="en-US" sz="1400" dirty="0">
+                <a:solidFill>
+                  <a:srgbClr val="1F2A44"/>
+                </a:solidFill>
+                <a:latin typeface="Calibri" pitchFamily="34" charset="0"/>
+                <a:ea typeface="Calibri" pitchFamily="34" charset="-122"/>
+                <a:cs typeface="Calibri" pitchFamily="34" charset="-120"/>
+              </a:rPr>
+              <a:t>97 tones per microphone, 62 Hz to 16 kHz, 12 per octave (a stepped sweep)</a:t>
+            </a:r>
+            <a:endParaRPr lang="en-US" sz="1400" dirty="0"/>
+          </a:p>
+          <a:p>
+            <a:pPr marL="342900" indent="-342900">
+              <a:spcAft>
+                <a:spcPts val="600"/>
+              </a:spcAft>
+              <a:buSzPct val="100000"/>
+              <a:buChar char="•"/>
+            </a:pPr>
+            <a:r>
+              <a:rPr lang="en-US" sz="1400" dirty="0">
+                <a:solidFill>
+                  <a:srgbClr val="1F2A44"/>
+                </a:solidFill>
+                <a:latin typeface="Calibri" pitchFamily="34" charset="0"/>
+                <a:ea typeface="Calibri" pitchFamily="34" charset="-122"/>
+                <a:cs typeface="Calibri" pitchFamily="34" charset="-120"/>
+              </a:rPr>
+              <a:t>One tone at a time: 0.7 s to settle, then 2 s recorded (6 s below 250 Hz)</a:t>
+            </a:r>
+            <a:endParaRPr lang="en-US" sz="1400" dirty="0"/>
+          </a:p>
+          <a:p>
+            <a:pPr marL="342900" indent="-342900">
+              <a:spcAft>
+                <a:spcPts val="600"/>
+              </a:spcAft>
+              <a:buSzPct val="100000"/>
+              <a:buChar char="•"/>
+            </a:pPr>
+            <a:r>
+              <a:rPr lang="en-US" sz="1400" dirty="0">
+                <a:solidFill>
+                  <a:srgbClr val="1F2A44"/>
+                </a:solidFill>
+                <a:latin typeface="Calibri" pitchFamily="34" charset="0"/>
+                <a:ea typeface="Calibri" pitchFamily="34" charset="-122"/>
+                <a:cs typeface="Calibri" pitchFamily="34" charset="-120"/>
+              </a:rPr>
+              <a:t>Same position, same loudspeaker, same level for every microphone</a:t>
+            </a:r>
+            <a:endParaRPr lang="en-US" sz="1400" dirty="0"/>
+          </a:p>
+          <a:p>
+            <a:pPr marL="342900" indent="-342900">
+              <a:spcAft>
+                <a:spcPts val="600"/>
+              </a:spcAft>
+              <a:buSzPct val="100000"/>
+              <a:buChar char="•"/>
+            </a:pPr>
+            <a:r>
+              <a:rPr lang="en-US" sz="1400" dirty="0">
+                <a:solidFill>
+                  <a:srgbClr val="1F2A44"/>
+                </a:solidFill>
+                <a:latin typeface="Calibri" pitchFamily="34" charset="0"/>
+                <a:ea typeface="Calibri" pitchFamily="34" charset="-122"/>
+                <a:cs typeface="Calibri" pitchFamily="34" charset="-120"/>
+              </a:rPr>
+              <a:t>One microphone measured three times as the reference</a:t>
+            </a:r>
+            <a:endParaRPr lang="en-US" sz="1400" dirty="0"/>
+          </a:p>
+        </p:txBody>
+      </p:sp>
+      <p:sp>
+        <p:nvSpPr>
+          <p:cNvPr id="18" name="Text 15"/>
+          <p:cNvSpPr txBox="1"/>
+          <p:nvPr/>
+        </p:nvSpPr>
+        <p:spPr>
+          <a:xfrm>
+            <a:off x="7223760" y="1783080"/>
+            <a:ext cx="4480560" cy="731520"/>
+          </a:xfrm>
+          <a:prstGeom prst="rect">
+            <a:avLst/>
+          </a:prstGeom>
+          <a:noFill/>
+          <a:ln/>
+        </p:spPr>
+        <p:txBody>
+          <a:bodyPr wrap="square" lIns="0" tIns="0" rIns="0" bIns="0" rtlCol="0" anchor="ctr"/>
+          <a:lstStyle/>
+          <a:p>
+            <a:pPr indent="0" marL="0">
+              <a:buNone/>
+            </a:pPr>
+            <a:r>
+              <a:rPr lang="en-US" sz="4400" b="1" dirty="0">
+                <a:solidFill>
+                  <a:srgbClr val="D6336C"/>
+                </a:solidFill>
+                <a:latin typeface="Cambria" pitchFamily="34" charset="0"/>
+                <a:ea typeface="Cambria" pitchFamily="34" charset="-122"/>
+                <a:cs typeface="Cambria" pitchFamily="34" charset="-120"/>
+              </a:rPr>
+              <a:t>4.01</a:t>
+            </a:r>
+            <a:pPr indent="0" marL="0">
+              <a:buNone/>
+            </a:pPr>
+            <a:r>
+              <a:rPr lang="en-US" sz="4400" b="1" dirty="0">
+                <a:solidFill>
+                  <a:srgbClr val="5B6578"/>
+                </a:solidFill>
+                <a:latin typeface="Cambria" pitchFamily="34" charset="0"/>
+                <a:ea typeface="Cambria" pitchFamily="34" charset="-122"/>
+                <a:cs typeface="Cambria" pitchFamily="34" charset="-120"/>
+              </a:rPr>
+              <a:t> → </a:t>
+            </a:r>
+            <a:pPr indent="0" marL="0">
+              <a:buNone/>
+            </a:pPr>
+            <a:r>
+              <a:rPr lang="en-US" sz="4400" b="1" dirty="0">
+                <a:solidFill>
+                  <a:srgbClr val="2B6CB0"/>
+                </a:solidFill>
+                <a:latin typeface="Cambria" pitchFamily="34" charset="0"/>
+                <a:ea typeface="Cambria" pitchFamily="34" charset="-122"/>
+                <a:cs typeface="Cambria" pitchFamily="34" charset="-120"/>
+              </a:rPr>
+              <a:t>0.02 dB</a:t>
+            </a:r>
+            <a:endParaRPr lang="en-US" sz="4400" dirty="0"/>
+          </a:p>
+        </p:txBody>
+      </p:sp>
+      <p:sp>
+        <p:nvSpPr>
+          <p:cNvPr id="19" name="Text 16"/>
+          <p:cNvSpPr txBox="1"/>
+          <p:nvPr/>
+        </p:nvSpPr>
+        <p:spPr>
+          <a:xfrm>
+            <a:off x="7223760" y="2514600"/>
+            <a:ext cx="4480560" cy="502920"/>
+          </a:xfrm>
+          <a:prstGeom prst="rect">
+            <a:avLst/>
+          </a:prstGeom>
+          <a:noFill/>
+          <a:ln/>
+        </p:spPr>
+        <p:txBody>
+          <a:bodyPr wrap="square" lIns="0" tIns="0" rIns="0" bIns="0" rtlCol="0" anchor="t"/>
+          <a:lstStyle/>
+          <a:p>
+            <a:pPr indent="0" marL="0">
+              <a:buNone/>
+            </a:pPr>
+            <a:r>
+              <a:rPr lang="en-US" sz="1400" dirty="0">
+                <a:solidFill>
+                  <a:srgbClr val="5B6578"/>
+                </a:solidFill>
+                <a:latin typeface="Calibri" pitchFamily="34" charset="0"/>
+                <a:ea typeface="Calibri" pitchFamily="34" charset="-122"/>
+                <a:cs typeface="Calibri" pitchFamily="34" charset="-120"/>
+              </a:rPr>
+              <a:t>spread across the eleven microphones for the same sound</a:t>
+            </a:r>
+            <a:endParaRPr lang="en-US" sz="1400" dirty="0"/>
+          </a:p>
+        </p:txBody>
+      </p:sp>
+      <p:sp>
+        <p:nvSpPr>
+          <p:cNvPr id="20" name="Text 17"/>
+          <p:cNvSpPr txBox="1"/>
+          <p:nvPr/>
+        </p:nvSpPr>
+        <p:spPr>
+          <a:xfrm>
+            <a:off x="7223760" y="3017520"/>
+            <a:ext cx="4480560" cy="320040"/>
+          </a:xfrm>
+          <a:prstGeom prst="rect">
+            <a:avLst/>
+          </a:prstGeom>
+          <a:noFill/>
+          <a:ln/>
+        </p:spPr>
+        <p:txBody>
+          <a:bodyPr wrap="square" lIns="0" tIns="0" rIns="0" bIns="0" rtlCol="0" anchor="ctr"/>
+          <a:lstStyle/>
+          <a:p>
+            <a:pPr indent="0" marL="0">
+              <a:buNone/>
+            </a:pPr>
+            <a:r>
+              <a:rPr lang="en-US" sz="1400" b="1" dirty="0">
+                <a:solidFill>
+                  <a:srgbClr val="1F2A44"/>
+                </a:solidFill>
+                <a:latin typeface="Calibri" pitchFamily="34" charset="0"/>
+                <a:ea typeface="Calibri" pitchFamily="34" charset="-122"/>
+                <a:cs typeface="Calibri" pitchFamily="34" charset="-120"/>
+              </a:rPr>
+              <a:t>7 of 11 factory files were wrong by 0.6–3.6 dB</a:t>
+            </a:r>
+            <a:endParaRPr lang="en-US" sz="1400" dirty="0"/>
+          </a:p>
+        </p:txBody>
+      </p:sp>
+      <p:sp>
+        <p:nvSpPr>
+          <p:cNvPr id="21" name="Text 18"/>
+          <p:cNvSpPr txBox="1"/>
+          <p:nvPr/>
+        </p:nvSpPr>
+        <p:spPr>
+          <a:xfrm>
+            <a:off x="7223760" y="3383280"/>
+            <a:ext cx="4480560" cy="411480"/>
+          </a:xfrm>
+          <a:prstGeom prst="rect">
+            <a:avLst/>
+          </a:prstGeom>
+          <a:noFill/>
+          <a:ln/>
+        </p:spPr>
+        <p:txBody>
+          <a:bodyPr wrap="square" lIns="0" tIns="0" rIns="0" bIns="0" rtlCol="0" anchor="t"/>
+          <a:lstStyle/>
+          <a:p>
+            <a:pPr indent="0" marL="0">
+              <a:buNone/>
+            </a:pPr>
+            <a:r>
+              <a:rPr lang="en-US" sz="1100" dirty="0">
+                <a:solidFill>
+                  <a:srgbClr val="5B6578"/>
+                </a:solidFill>
+                <a:latin typeface="Calibri" pitchFamily="34" charset="0"/>
+                <a:ea typeface="Calibri" pitchFamily="34" charset="-122"/>
+                <a:cs typeface="Calibri" pitchFamily="34" charset="-120"/>
+              </a:rPr>
+              <a:t>Each factory file against the common reference, mean over frequency (dB): below 0 reads too quiet, above 0 too loud</a:t>
+            </a:r>
+            <a:endParaRPr lang="en-US" sz="1100" dirty="0"/>
+          </a:p>
+        </p:txBody>
+      </p:sp>
+      <p:graphicFrame>
+        <p:nvGraphicFramePr>
+          <p:cNvPr id="22" name="Chart 0" descr=""/>
+          <p:cNvGraphicFramePr/>
+          <p:nvPr/>
+        </p:nvGraphicFramePr>
+        <p:xfrm>
+          <a:off x="7132320" y="3749040"/>
+          <a:ext cx="4572000" cy="2606040"/>
+        </p:xfrm>
+        <a:graphic xmlns:a="http://schemas.openxmlformats.org/drawingml/2006/main">
+          <a:graphicData uri="http://schemas.openxmlformats.org/drawingml/2006/chart">
+            <c:chart xmlns:c="http://schemas.openxmlformats.org/drawingml/2006/chart" r:id="rId2"/>
+          </a:graphicData>
+        </a:graphic>
+      </p:graphicFrame>
+      <p:sp>
+        <p:nvSpPr>
+          <p:cNvPr id="23" name="Text 19"/>
+          <p:cNvSpPr txBox="1"/>
+          <p:nvPr/>
+        </p:nvSpPr>
+        <p:spPr>
+          <a:xfrm>
+            <a:off x="548640" y="6355080"/>
+            <a:ext cx="10332720" cy="274320"/>
+          </a:xfrm>
+          <a:prstGeom prst="rect">
+            <a:avLst/>
+          </a:prstGeom>
+          <a:noFill/>
+          <a:ln/>
+        </p:spPr>
+        <p:txBody>
+          <a:bodyPr wrap="square" lIns="0" tIns="0" rIns="0" bIns="0" rtlCol="0" anchor="ctr"/>
+          <a:lstStyle/>
+          <a:p>
+            <a:pPr indent="0" marL="0">
+              <a:buNone/>
+            </a:pPr>
+            <a:r>
+              <a:rPr lang="en-US" sz="1100" dirty="0">
+                <a:solidFill>
+                  <a:srgbClr val="5B6578"/>
+                </a:solidFill>
+                <a:latin typeface="Calibri" pitchFamily="34" charset="0"/>
+                <a:ea typeface="Calibri" pitchFamily="34" charset="-122"/>
+                <a:cs typeface="Calibri" pitchFamily="34" charset="-120"/>
+              </a:rPr>
+              <a:t>Calibration session 16 Sep 2026, one microphone plugged in at a time, loudspeaker amplitude 0.03 of full scale.</a:t>
+            </a:r>
+            <a:endParaRPr lang="en-US" sz="1100" dirty="0"/>
+          </a:p>
+        </p:txBody>
+      </p:sp>
+      <p:sp>
+        <p:nvSpPr>
+          <p:cNvPr id="24" name="Text 20"/>
+          <p:cNvSpPr txBox="1"/>
+          <p:nvPr/>
+        </p:nvSpPr>
+        <p:spPr>
+          <a:xfrm>
+            <a:off x="11155680" y="6355080"/>
+            <a:ext cx="457200" cy="274320"/>
+          </a:xfrm>
+          <a:prstGeom prst="rect">
+            <a:avLst/>
+          </a:prstGeom>
+          <a:noFill/>
+          <a:ln/>
+        </p:spPr>
+        <p:txBody>
+          <a:bodyPr wrap="square" lIns="0" tIns="0" rIns="0" bIns="0" rtlCol="0" anchor="ctr"/>
+          <a:lstStyle/>
+          <a:p>
+            <a:pPr algn="r" indent="0" marL="0">
+              <a:buNone/>
+            </a:pPr>
+            <a:r>
+              <a:rPr lang="en-US" sz="1200" dirty="0">
+                <a:solidFill>
+                  <a:srgbClr val="5B6578"/>
+                </a:solidFill>
+                <a:latin typeface="Calibri" pitchFamily="34" charset="0"/>
+                <a:ea typeface="Calibri" pitchFamily="34" charset="-122"/>
+                <a:cs typeface="Calibri" pitchFamily="34" charset="-120"/>
+              </a:rPr>
+              <a:t>2</a:t>
+            </a:r>
+            <a:endParaRPr lang="en-US" sz="1200" dirty="0"/>
+          </a:p>
+        </p:txBody>
+      </p:sp>
+    </p:spTree>
+  </p:cSld>
+  <p:clrMapOvr>
+    <a:masterClrMapping/>
+  </p:clrMapOvr>
+</p:sld>
+</file>
+
+<file path=ppt/slides/slide3.xml><?xml version="1.0" encoding="utf-8"?>
+<p:sld xmlns:a="http://schemas.openxmlformats.org/drawingml/2006/main" xmlns:r="http://schemas.openxmlformats.org/officeDocument/2006/relationships" xmlns:p="http://schemas.openxmlformats.org/presentationml/2006/main">
+  <p:cSld name="Slide 3">
+    <p:bg>
+      <p:bgPr>
+        <a:solidFill>
+          <a:srgbClr val="FFFFFF"/>
+        </a:solidFill>
+      </p:bgPr>
+    </p:bg>
+    <p:spTree>
+      <p:nvGrpSpPr>
+        <p:cNvPr id="1" name=""/>
+        <p:cNvGrpSpPr/>
+        <p:nvPr/>
+      </p:nvGrpSpPr>
+      <p:grpSpPr>
+        <a:xfrm>
+          <a:off x="0" y="0"/>
+          <a:ext cx="0" cy="0"/>
+          <a:chOff x="0" y="0"/>
+          <a:chExt cx="0" cy="0"/>
+        </a:xfrm>
+      </p:grpSpPr>
       <p:pic>
         <p:nvPicPr>
           <p:cNvPr id="2" name="Image 0" descr="Polar plot of 20 to 560 Hz: the jagged red 31 Aug outline and the smoother blue 30 Sep outline">    </p:cNvPr>

</xml_diff>

<commit_message>
Slides: clearer microphone diagram (UMIK lying on its side, capsule facing the loudspeaker, row of numbered units instead of the grey circles)
Co-Authored-By: Claude Sonnet 5.5 <noreply@anthropic.com>
</commit_message>
<xml_diff>
--- a/docs/analysis/chamber-final-2026-10-01/slides/chamber-slides.pptx
+++ b/docs/analysis/chamber-final-2026-10-01/slides/chamber-slides.pptx
@@ -1829,8 +1829,8 @@
         </p:nvSpPr>
         <p:spPr>
           <a:xfrm>
-            <a:off x="411480" y="3703320"/>
-            <a:ext cx="1874520" cy="274320"/>
+            <a:off x="2103120" y="2468880"/>
+            <a:ext cx="1828800" cy="274320"/>
           </a:xfrm>
           <a:prstGeom prst="rect">
             <a:avLst/>
@@ -1846,54 +1846,15 @@
               <a:buNone/>
             </a:pPr>
             <a:r>
-              <a:rPr lang="en-US" sz="1400" dirty="0">
-                <a:solidFill>
-                  <a:srgbClr val="1F2A44"/>
+              <a:rPr lang="en-US" sz="1200" dirty="0">
+                <a:solidFill>
+                  <a:srgbClr val="5B6578"/>
                 </a:solidFill>
                 <a:latin typeface="Calibri" pitchFamily="34" charset="0"/>
                 <a:ea typeface="Calibri" pitchFamily="34" charset="-122"/>
                 <a:cs typeface="Calibri" pitchFamily="34" charset="-120"/>
               </a:rPr>
-              <a:t>Our loudspeaker</a:t>
-            </a:r>
-            <a:endParaRPr lang="en-US" sz="1400" dirty="0"/>
-          </a:p>
-        </p:txBody>
-      </p:sp>
-      <p:sp>
-        <p:nvSpPr>
-          <p:cNvPr id="6" name="Text 3"/>
-          <p:cNvSpPr txBox="1"/>
-          <p:nvPr/>
-        </p:nvSpPr>
-        <p:spPr>
-          <a:xfrm>
-            <a:off x="2011680" y="2514600"/>
-            <a:ext cx="2377440" cy="274320"/>
-          </a:xfrm>
-          <a:prstGeom prst="rect">
-            <a:avLst/>
-          </a:prstGeom>
-          <a:noFill/>
-          <a:ln/>
-        </p:spPr>
-        <p:txBody>
-          <a:bodyPr wrap="square" lIns="0" tIns="0" rIns="0" bIns="0" rtlCol="0" anchor="ctr"/>
-          <a:lstStyle/>
-          <a:p>
-            <a:pPr algn="ctr" indent="0" marL="0">
-              <a:buNone/>
-            </a:pPr>
-            <a:r>
-              <a:rPr lang="en-US" sz="1200" dirty="0">
-                <a:solidFill>
-                  <a:srgbClr val="5B6578"/>
-                </a:solidFill>
-                <a:latin typeface="Calibri" pitchFamily="34" charset="0"/>
-                <a:ea typeface="Calibri" pitchFamily="34" charset="-122"/>
-                <a:cs typeface="Calibri" pitchFamily="34" charset="-120"/>
-              </a:rPr>
-              <a:t>stepped tones, 62 Hz to 16 kHz</a:t>
+              <a:t>tones, 62 Hz–16 kHz</a:t>
             </a:r>
             <a:endParaRPr lang="en-US" sz="1200" dirty="0"/>
           </a:p>
@@ -1901,14 +1862,14 @@
       </p:sp>
       <p:sp>
         <p:nvSpPr>
-          <p:cNvPr id="7" name="Shape 4"/>
+          <p:cNvPr id="6" name="Shape 3"/>
           <p:cNvSpPr/>
           <p:nvPr/>
         </p:nvSpPr>
         <p:spPr>
           <a:xfrm>
-            <a:off x="2194560" y="2926080"/>
-            <a:ext cx="2011680" cy="0"/>
+            <a:off x="2194560" y="2788920"/>
+            <a:ext cx="1783080" cy="0"/>
           </a:xfrm>
           <a:prstGeom prst="line">
             <a:avLst/>
@@ -1925,14 +1886,41 @@
       </p:sp>
       <p:sp>
         <p:nvSpPr>
+          <p:cNvPr id="7" name="Shape 4"/>
+          <p:cNvSpPr/>
+          <p:nvPr/>
+        </p:nvSpPr>
+        <p:spPr>
+          <a:xfrm>
+            <a:off x="4325112" y="2670048"/>
+            <a:ext cx="1920240" cy="237744"/>
+          </a:xfrm>
+          <a:prstGeom prst="roundRect">
+            <a:avLst>
+              <a:gd name="adj" fmla="val 19231"/>
+            </a:avLst>
+          </a:prstGeom>
+          <a:solidFill>
+            <a:srgbClr val="4A5568"/>
+          </a:solidFill>
+          <a:ln w="12700">
+            <a:solidFill>
+              <a:srgbClr val="4A5568"/>
+            </a:solidFill>
+            <a:prstDash val="solid"/>
+          </a:ln>
+        </p:spPr>
+      </p:sp>
+      <p:sp>
+        <p:nvSpPr>
           <p:cNvPr id="8" name="Shape 5"/>
           <p:cNvSpPr/>
           <p:nvPr/>
         </p:nvSpPr>
         <p:spPr>
           <a:xfrm>
-            <a:off x="4297680" y="2651760"/>
-            <a:ext cx="502920" cy="502920"/>
+            <a:off x="4069080" y="2615184"/>
+            <a:ext cx="310896" cy="347472"/>
           </a:xfrm>
           <a:prstGeom prst="ellipse">
             <a:avLst/>
@@ -1950,39 +1938,14 @@
       </p:sp>
       <p:sp>
         <p:nvSpPr>
-          <p:cNvPr id="9" name="Shape 6"/>
-          <p:cNvSpPr/>
-          <p:nvPr/>
-        </p:nvSpPr>
-        <p:spPr>
-          <a:xfrm>
-            <a:off x="4498848" y="3108960"/>
-            <a:ext cx="100584" cy="548640"/>
-          </a:xfrm>
-          <a:prstGeom prst="rect">
-            <a:avLst/>
-          </a:prstGeom>
-          <a:solidFill>
-            <a:srgbClr val="2B6CB0"/>
-          </a:solidFill>
-          <a:ln w="12700">
-            <a:solidFill>
-              <a:srgbClr val="2B6CB0"/>
-            </a:solidFill>
-            <a:prstDash val="solid"/>
-          </a:ln>
-        </p:spPr>
-      </p:sp>
-      <p:sp>
-        <p:nvSpPr>
-          <p:cNvPr id="10" name="Text 7"/>
+          <p:cNvPr id="9" name="Text 6"/>
           <p:cNvSpPr txBox="1"/>
           <p:nvPr/>
         </p:nvSpPr>
         <p:spPr>
           <a:xfrm>
-            <a:off x="3383280" y="3749040"/>
-            <a:ext cx="2148840" cy="274320"/>
+            <a:off x="3840480" y="3063240"/>
+            <a:ext cx="2377440" cy="274320"/>
           </a:xfrm>
           <a:prstGeom prst="rect">
             <a:avLst/>
@@ -1994,34 +1957,34 @@
           <a:bodyPr wrap="square" lIns="0" tIns="0" rIns="0" bIns="0" rtlCol="0" anchor="ctr"/>
           <a:lstStyle/>
           <a:p>
-            <a:pPr algn="ctr" indent="0" marL="0">
+            <a:pPr algn="l" indent="0" marL="0">
               <a:buNone/>
             </a:pPr>
             <a:r>
-              <a:rPr lang="en-US" sz="1400" dirty="0">
-                <a:solidFill>
-                  <a:srgbClr val="1F2A44"/>
+              <a:rPr lang="en-US" sz="1200" b="1" dirty="0">
+                <a:solidFill>
+                  <a:srgbClr val="2B6CB0"/>
                 </a:solidFill>
                 <a:latin typeface="Calibri" pitchFamily="34" charset="0"/>
                 <a:ea typeface="Calibri" pitchFamily="34" charset="-122"/>
                 <a:cs typeface="Calibri" pitchFamily="34" charset="-120"/>
               </a:rPr>
-              <a:t>UMIK-2 microphone</a:t>
-            </a:r>
-            <a:endParaRPr lang="en-US" sz="1400" dirty="0"/>
-          </a:p>
-        </p:txBody>
-      </p:sp>
-      <p:sp>
-        <p:nvSpPr>
-          <p:cNvPr id="11" name="Text 8"/>
+              <a:t>capsule faces the loudspeaker</a:t>
+            </a:r>
+            <a:endParaRPr lang="en-US" sz="1200" dirty="0"/>
+          </a:p>
+        </p:txBody>
+      </p:sp>
+      <p:sp>
+        <p:nvSpPr>
+          <p:cNvPr id="10" name="Text 7"/>
           <p:cNvSpPr txBox="1"/>
           <p:nvPr/>
         </p:nvSpPr>
         <p:spPr>
           <a:xfrm>
-            <a:off x="4892040" y="2606040"/>
-            <a:ext cx="731520" cy="274320"/>
+            <a:off x="4069080" y="2194560"/>
+            <a:ext cx="2377440" cy="274320"/>
           </a:xfrm>
           <a:prstGeom prst="rect">
             <a:avLst/>
@@ -2033,11 +1996,11 @@
           <a:bodyPr wrap="square" lIns="0" tIns="0" rIns="0" bIns="0" rtlCol="0" anchor="ctr"/>
           <a:lstStyle/>
           <a:p>
-            <a:pPr algn="ctr" indent="0" marL="0">
+            <a:pPr indent="0" marL="0">
               <a:buNone/>
             </a:pPr>
             <a:r>
-              <a:rPr lang="en-US" sz="1200" b="1" dirty="0">
+              <a:rPr lang="en-US" sz="1400" dirty="0">
                 <a:solidFill>
                   <a:srgbClr val="1F2A44"/>
                 </a:solidFill>
@@ -2045,22 +2008,22 @@
                 <a:ea typeface="Calibri" pitchFamily="34" charset="-122"/>
                 <a:cs typeface="Calibri" pitchFamily="34" charset="-120"/>
               </a:rPr>
-              <a:t>swap</a:t>
-            </a:r>
-            <a:endParaRPr lang="en-US" sz="1200" dirty="0"/>
-          </a:p>
-        </p:txBody>
-      </p:sp>
-      <p:sp>
-        <p:nvSpPr>
-          <p:cNvPr id="12" name="Shape 9"/>
+              <a:t>UMIK-2 microphone</a:t>
+            </a:r>
+            <a:endParaRPr lang="en-US" sz="1400" dirty="0"/>
+          </a:p>
+        </p:txBody>
+      </p:sp>
+      <p:sp>
+        <p:nvSpPr>
+          <p:cNvPr id="11" name="Shape 8"/>
           <p:cNvSpPr/>
           <p:nvPr/>
         </p:nvSpPr>
         <p:spPr>
           <a:xfrm>
-            <a:off x="4937760" y="2926080"/>
-            <a:ext cx="640080" cy="0"/>
+            <a:off x="4754880" y="3383280"/>
+            <a:ext cx="0" cy="274320"/>
           </a:xfrm>
           <a:prstGeom prst="line">
             <a:avLst/>
@@ -2078,24 +2041,65 @@
       </p:sp>
       <p:sp>
         <p:nvSpPr>
+          <p:cNvPr id="12" name="Text 9"/>
+          <p:cNvSpPr txBox="1"/>
+          <p:nvPr/>
+        </p:nvSpPr>
+        <p:spPr>
+          <a:xfrm>
+            <a:off x="4846320" y="3401568"/>
+            <a:ext cx="731520" cy="237744"/>
+          </a:xfrm>
+          <a:prstGeom prst="rect">
+            <a:avLst/>
+          </a:prstGeom>
+          <a:noFill/>
+          <a:ln/>
+        </p:spPr>
+        <p:txBody>
+          <a:bodyPr wrap="square" lIns="0" tIns="0" rIns="0" bIns="0" rtlCol="0" anchor="ctr"/>
+          <a:lstStyle/>
+          <a:p>
+            <a:pPr indent="0" marL="0">
+              <a:buNone/>
+            </a:pPr>
+            <a:r>
+              <a:rPr lang="en-US" sz="1200" b="1" dirty="0">
+                <a:solidFill>
+                  <a:srgbClr val="1F2A44"/>
+                </a:solidFill>
+                <a:latin typeface="Calibri" pitchFamily="34" charset="0"/>
+                <a:ea typeface="Calibri" pitchFamily="34" charset="-122"/>
+                <a:cs typeface="Calibri" pitchFamily="34" charset="-120"/>
+              </a:rPr>
+              <a:t>swap</a:t>
+            </a:r>
+            <a:endParaRPr lang="en-US" sz="1200" dirty="0"/>
+          </a:p>
+        </p:txBody>
+      </p:sp>
+      <p:sp>
+        <p:nvSpPr>
           <p:cNvPr id="13" name="Shape 10"/>
           <p:cNvSpPr/>
           <p:nvPr/>
         </p:nvSpPr>
         <p:spPr>
           <a:xfrm>
-            <a:off x="5760720" y="2240280"/>
-            <a:ext cx="384048" cy="384048"/>
-          </a:xfrm>
-          <a:prstGeom prst="ellipse">
-            <a:avLst/>
+            <a:off x="4145890" y="3811219"/>
+            <a:ext cx="576072" cy="71323"/>
+          </a:xfrm>
+          <a:prstGeom prst="roundRect">
+            <a:avLst>
+              <a:gd name="adj" fmla="val 19231"/>
+            </a:avLst>
           </a:prstGeom>
           <a:solidFill>
-            <a:srgbClr val="C9CFDA"/>
+            <a:srgbClr val="4A5568"/>
           </a:solidFill>
           <a:ln w="12700">
             <a:solidFill>
-              <a:srgbClr val="C9CFDA"/>
+              <a:srgbClr val="4A5568"/>
             </a:solidFill>
             <a:prstDash val="solid"/>
           </a:ln>
@@ -2109,18 +2113,18 @@
         </p:nvSpPr>
         <p:spPr>
           <a:xfrm>
-            <a:off x="5760720" y="2697480"/>
-            <a:ext cx="384048" cy="384048"/>
+            <a:off x="4069080" y="3794760"/>
+            <a:ext cx="93269" cy="104242"/>
           </a:xfrm>
           <a:prstGeom prst="ellipse">
             <a:avLst/>
           </a:prstGeom>
           <a:solidFill>
-            <a:srgbClr val="C9CFDA"/>
+            <a:srgbClr val="9AA5B8"/>
           </a:solidFill>
           <a:ln w="12700">
             <a:solidFill>
-              <a:srgbClr val="C9CFDA"/>
+              <a:srgbClr val="9AA5B8"/>
             </a:solidFill>
             <a:prstDash val="solid"/>
           </a:ln>
@@ -2128,24 +2132,65 @@
       </p:sp>
       <p:sp>
         <p:nvSpPr>
-          <p:cNvPr id="15" name="Shape 12"/>
+          <p:cNvPr id="15" name="Text 12"/>
+          <p:cNvSpPr txBox="1"/>
+          <p:nvPr/>
+        </p:nvSpPr>
+        <p:spPr>
+          <a:xfrm>
+            <a:off x="4069080" y="4005072"/>
+            <a:ext cx="685800" cy="228600"/>
+          </a:xfrm>
+          <a:prstGeom prst="rect">
+            <a:avLst/>
+          </a:prstGeom>
+          <a:noFill/>
+          <a:ln/>
+        </p:spPr>
+        <p:txBody>
+          <a:bodyPr wrap="square" lIns="0" tIns="0" rIns="0" bIns="0" rtlCol="0" anchor="ctr"/>
+          <a:lstStyle/>
+          <a:p>
+            <a:pPr algn="ctr" indent="0" marL="0">
+              <a:buNone/>
+            </a:pPr>
+            <a:r>
+              <a:rPr lang="en-US" sz="1200" dirty="0">
+                <a:solidFill>
+                  <a:srgbClr val="5B6578"/>
+                </a:solidFill>
+                <a:latin typeface="Calibri" pitchFamily="34" charset="0"/>
+                <a:ea typeface="Calibri" pitchFamily="34" charset="-122"/>
+                <a:cs typeface="Calibri" pitchFamily="34" charset="-120"/>
+              </a:rPr>
+              <a:t>1</a:t>
+            </a:r>
+            <a:endParaRPr lang="en-US" sz="1200" dirty="0"/>
+          </a:p>
+        </p:txBody>
+      </p:sp>
+      <p:sp>
+        <p:nvSpPr>
+          <p:cNvPr id="16" name="Shape 13"/>
           <p:cNvSpPr/>
           <p:nvPr/>
         </p:nvSpPr>
         <p:spPr>
           <a:xfrm>
-            <a:off x="5760720" y="3154680"/>
-            <a:ext cx="384048" cy="384048"/>
-          </a:xfrm>
-          <a:prstGeom prst="ellipse">
-            <a:avLst/>
+            <a:off x="4968850" y="3811219"/>
+            <a:ext cx="576072" cy="71323"/>
+          </a:xfrm>
+          <a:prstGeom prst="roundRect">
+            <a:avLst>
+              <a:gd name="adj" fmla="val 19231"/>
+            </a:avLst>
           </a:prstGeom>
           <a:solidFill>
-            <a:srgbClr val="C9CFDA"/>
+            <a:srgbClr val="4A5568"/>
           </a:solidFill>
           <a:ln w="12700">
             <a:solidFill>
-              <a:srgbClr val="C9CFDA"/>
+              <a:srgbClr val="4A5568"/>
             </a:solidFill>
             <a:prstDash val="solid"/>
           </a:ln>
@@ -2153,14 +2198,39 @@
       </p:sp>
       <p:sp>
         <p:nvSpPr>
-          <p:cNvPr id="16" name="Text 13"/>
+          <p:cNvPr id="17" name="Shape 14"/>
+          <p:cNvSpPr/>
+          <p:nvPr/>
+        </p:nvSpPr>
+        <p:spPr>
+          <a:xfrm>
+            <a:off x="4892040" y="3794760"/>
+            <a:ext cx="93269" cy="104242"/>
+          </a:xfrm>
+          <a:prstGeom prst="ellipse">
+            <a:avLst/>
+          </a:prstGeom>
+          <a:solidFill>
+            <a:srgbClr val="9AA5B8"/>
+          </a:solidFill>
+          <a:ln w="12700">
+            <a:solidFill>
+              <a:srgbClr val="9AA5B8"/>
+            </a:solidFill>
+            <a:prstDash val="solid"/>
+          </a:ln>
+        </p:spPr>
+      </p:sp>
+      <p:sp>
+        <p:nvSpPr>
+          <p:cNvPr id="18" name="Text 15"/>
           <p:cNvSpPr txBox="1"/>
           <p:nvPr/>
         </p:nvSpPr>
         <p:spPr>
           <a:xfrm>
-            <a:off x="5577840" y="3749040"/>
-            <a:ext cx="1188720" cy="274320"/>
+            <a:off x="4892040" y="4005072"/>
+            <a:ext cx="685800" cy="228600"/>
           </a:xfrm>
           <a:prstGeom prst="rect">
             <a:avLst/>
@@ -2176,15 +2246,145 @@
               <a:buNone/>
             </a:pPr>
             <a:r>
-              <a:rPr lang="en-US" sz="1400" dirty="0">
-                <a:solidFill>
-                  <a:srgbClr val="1F2A44"/>
+              <a:rPr lang="en-US" sz="1200" dirty="0">
+                <a:solidFill>
+                  <a:srgbClr val="5B6578"/>
                 </a:solidFill>
                 <a:latin typeface="Calibri" pitchFamily="34" charset="0"/>
                 <a:ea typeface="Calibri" pitchFamily="34" charset="-122"/>
                 <a:cs typeface="Calibri" pitchFamily="34" charset="-120"/>
               </a:rPr>
-              <a:t>all 11 in turn</a:t>
+              <a:t>2</a:t>
+            </a:r>
+            <a:endParaRPr lang="en-US" sz="1200" dirty="0"/>
+          </a:p>
+        </p:txBody>
+      </p:sp>
+      <p:sp>
+        <p:nvSpPr>
+          <p:cNvPr id="19" name="Shape 16"/>
+          <p:cNvSpPr/>
+          <p:nvPr/>
+        </p:nvSpPr>
+        <p:spPr>
+          <a:xfrm>
+            <a:off x="6020410" y="3811219"/>
+            <a:ext cx="576072" cy="71323"/>
+          </a:xfrm>
+          <a:prstGeom prst="roundRect">
+            <a:avLst>
+              <a:gd name="adj" fmla="val 19231"/>
+            </a:avLst>
+          </a:prstGeom>
+          <a:solidFill>
+            <a:srgbClr val="4A5568"/>
+          </a:solidFill>
+          <a:ln w="12700">
+            <a:solidFill>
+              <a:srgbClr val="4A5568"/>
+            </a:solidFill>
+            <a:prstDash val="solid"/>
+          </a:ln>
+        </p:spPr>
+      </p:sp>
+      <p:sp>
+        <p:nvSpPr>
+          <p:cNvPr id="20" name="Shape 17"/>
+          <p:cNvSpPr/>
+          <p:nvPr/>
+        </p:nvSpPr>
+        <p:spPr>
+          <a:xfrm>
+            <a:off x="5943600" y="3794760"/>
+            <a:ext cx="93269" cy="104242"/>
+          </a:xfrm>
+          <a:prstGeom prst="ellipse">
+            <a:avLst/>
+          </a:prstGeom>
+          <a:solidFill>
+            <a:srgbClr val="9AA5B8"/>
+          </a:solidFill>
+          <a:ln w="12700">
+            <a:solidFill>
+              <a:srgbClr val="9AA5B8"/>
+            </a:solidFill>
+            <a:prstDash val="solid"/>
+          </a:ln>
+        </p:spPr>
+      </p:sp>
+      <p:sp>
+        <p:nvSpPr>
+          <p:cNvPr id="21" name="Text 18"/>
+          <p:cNvSpPr txBox="1"/>
+          <p:nvPr/>
+        </p:nvSpPr>
+        <p:spPr>
+          <a:xfrm>
+            <a:off x="5943600" y="4005072"/>
+            <a:ext cx="685800" cy="228600"/>
+          </a:xfrm>
+          <a:prstGeom prst="rect">
+            <a:avLst/>
+          </a:prstGeom>
+          <a:noFill/>
+          <a:ln/>
+        </p:spPr>
+        <p:txBody>
+          <a:bodyPr wrap="square" lIns="0" tIns="0" rIns="0" bIns="0" rtlCol="0" anchor="ctr"/>
+          <a:lstStyle/>
+          <a:p>
+            <a:pPr algn="ctr" indent="0" marL="0">
+              <a:buNone/>
+            </a:pPr>
+            <a:r>
+              <a:rPr lang="en-US" sz="1200" dirty="0">
+                <a:solidFill>
+                  <a:srgbClr val="5B6578"/>
+                </a:solidFill>
+                <a:latin typeface="Calibri" pitchFamily="34" charset="0"/>
+                <a:ea typeface="Calibri" pitchFamily="34" charset="-122"/>
+                <a:cs typeface="Calibri" pitchFamily="34" charset="-120"/>
+              </a:rPr>
+              <a:t>11</a:t>
+            </a:r>
+            <a:endParaRPr lang="en-US" sz="1200" dirty="0"/>
+          </a:p>
+        </p:txBody>
+      </p:sp>
+      <p:sp>
+        <p:nvSpPr>
+          <p:cNvPr id="22" name="Text 19"/>
+          <p:cNvSpPr txBox="1"/>
+          <p:nvPr/>
+        </p:nvSpPr>
+        <p:spPr>
+          <a:xfrm>
+            <a:off x="5577840" y="3703320"/>
+            <a:ext cx="365760" cy="274320"/>
+          </a:xfrm>
+          <a:prstGeom prst="rect">
+            <a:avLst/>
+          </a:prstGeom>
+          <a:noFill/>
+          <a:ln/>
+        </p:spPr>
+        <p:txBody>
+          <a:bodyPr wrap="square" lIns="0" tIns="0" rIns="0" bIns="0" rtlCol="0" anchor="ctr"/>
+          <a:lstStyle/>
+          <a:p>
+            <a:pPr algn="ctr" indent="0" marL="0">
+              <a:buNone/>
+            </a:pPr>
+            <a:r>
+              <a:rPr lang="en-US" sz="1400" dirty="0">
+                <a:solidFill>
+                  <a:srgbClr val="5B6578"/>
+                </a:solidFill>
+                <a:latin typeface="Calibri" pitchFamily="34" charset="0"/>
+                <a:ea typeface="Calibri" pitchFamily="34" charset="-122"/>
+                <a:cs typeface="Calibri" pitchFamily="34" charset="-120"/>
+              </a:rPr>
+              <a:t>…</a:t>
             </a:r>
             <a:endParaRPr lang="en-US" sz="1400" dirty="0"/>
           </a:p>
@@ -2192,7 +2392,46 @@
       </p:sp>
       <p:sp>
         <p:nvSpPr>
-          <p:cNvPr id="17" name="Text 14"/>
+          <p:cNvPr id="23" name="Text 20"/>
+          <p:cNvSpPr txBox="1"/>
+          <p:nvPr/>
+        </p:nvSpPr>
+        <p:spPr>
+          <a:xfrm>
+            <a:off x="411480" y="3703320"/>
+            <a:ext cx="1874520" cy="274320"/>
+          </a:xfrm>
+          <a:prstGeom prst="rect">
+            <a:avLst/>
+          </a:prstGeom>
+          <a:noFill/>
+          <a:ln/>
+        </p:spPr>
+        <p:txBody>
+          <a:bodyPr wrap="square" lIns="0" tIns="0" rIns="0" bIns="0" rtlCol="0" anchor="ctr"/>
+          <a:lstStyle/>
+          <a:p>
+            <a:pPr algn="ctr" indent="0" marL="0">
+              <a:buNone/>
+            </a:pPr>
+            <a:r>
+              <a:rPr lang="en-US" sz="1400" dirty="0">
+                <a:solidFill>
+                  <a:srgbClr val="1F2A44"/>
+                </a:solidFill>
+                <a:latin typeface="Calibri" pitchFamily="34" charset="0"/>
+                <a:ea typeface="Calibri" pitchFamily="34" charset="-122"/>
+                <a:cs typeface="Calibri" pitchFamily="34" charset="-120"/>
+              </a:rPr>
+              <a:t>Our loudspeaker</a:t>
+            </a:r>
+            <a:endParaRPr lang="en-US" sz="1400" dirty="0"/>
+          </a:p>
+        </p:txBody>
+      </p:sp>
+      <p:sp>
+        <p:nvSpPr>
+          <p:cNvPr id="24" name="Text 21"/>
           <p:cNvSpPr txBox="1"/>
           <p:nvPr/>
         </p:nvSpPr>
@@ -2298,7 +2537,7 @@
       </p:sp>
       <p:sp>
         <p:nvSpPr>
-          <p:cNvPr id="18" name="Text 15"/>
+          <p:cNvPr id="25" name="Text 22"/>
           <p:cNvSpPr txBox="1"/>
           <p:nvPr/>
         </p:nvSpPr>
@@ -2365,7 +2604,7 @@
       </p:sp>
       <p:sp>
         <p:nvSpPr>
-          <p:cNvPr id="19" name="Text 16"/>
+          <p:cNvPr id="26" name="Text 23"/>
           <p:cNvSpPr txBox="1"/>
           <p:nvPr/>
         </p:nvSpPr>
@@ -2404,7 +2643,7 @@
       </p:sp>
       <p:sp>
         <p:nvSpPr>
-          <p:cNvPr id="20" name="Text 17"/>
+          <p:cNvPr id="27" name="Text 24"/>
           <p:cNvSpPr txBox="1"/>
           <p:nvPr/>
         </p:nvSpPr>
@@ -2443,7 +2682,7 @@
       </p:sp>
       <p:sp>
         <p:nvSpPr>
-          <p:cNvPr id="21" name="Text 18"/>
+          <p:cNvPr id="28" name="Text 25"/>
           <p:cNvSpPr txBox="1"/>
           <p:nvPr/>
         </p:nvSpPr>
@@ -2482,7 +2721,7 @@
       </p:sp>
       <p:graphicFrame>
         <p:nvGraphicFramePr>
-          <p:cNvPr id="22" name="Chart 0" descr=""/>
+          <p:cNvPr id="29" name="Chart 0" descr=""/>
           <p:cNvGraphicFramePr/>
           <p:nvPr/>
         </p:nvGraphicFramePr>
@@ -2498,7 +2737,7 @@
       </p:graphicFrame>
       <p:sp>
         <p:nvSpPr>
-          <p:cNvPr id="23" name="Text 19"/>
+          <p:cNvPr id="30" name="Text 26"/>
           <p:cNvSpPr txBox="1"/>
           <p:nvPr/>
         </p:nvSpPr>
@@ -2537,7 +2776,7 @@
       </p:sp>
       <p:sp>
         <p:nvSpPr>
-          <p:cNvPr id="24" name="Text 20"/>
+          <p:cNvPr id="31" name="Text 27"/>
           <p:cNvSpPr txBox="1"/>
           <p:nvPr/>
         </p:nvSpPr>

</xml_diff>

<commit_message>
Slides: slide 2 uses the real UMIK-2 photo (miniDSP product brief) and serial-number swap pills
Co-Authored-By: Claude Sonnet 5.5 <noreply@anthropic.com>
</commit_message>
<xml_diff>
--- a/docs/analysis/chamber-final-2026-10-01/slides/chamber-slides.pptx
+++ b/docs/analysis/chamber-final-2026-10-01/slides/chamber-slides.pptx
@@ -1868,7 +1868,7 @@
         </p:nvSpPr>
         <p:spPr>
           <a:xfrm>
-            <a:off x="2194560" y="2788920"/>
+            <a:off x="2194560" y="2926080"/>
             <a:ext cx="1783080" cy="0"/>
           </a:xfrm>
           <a:prstGeom prst="line">
@@ -1886,65 +1886,13 @@
       </p:sp>
       <p:sp>
         <p:nvSpPr>
-          <p:cNvPr id="7" name="Shape 4"/>
-          <p:cNvSpPr/>
-          <p:nvPr/>
-        </p:nvSpPr>
-        <p:spPr>
-          <a:xfrm>
-            <a:off x="4325112" y="2670048"/>
-            <a:ext cx="1920240" cy="237744"/>
-          </a:xfrm>
-          <a:prstGeom prst="roundRect">
-            <a:avLst>
-              <a:gd name="adj" fmla="val 19231"/>
-            </a:avLst>
-          </a:prstGeom>
-          <a:solidFill>
-            <a:srgbClr val="4A5568"/>
-          </a:solidFill>
-          <a:ln w="12700">
-            <a:solidFill>
-              <a:srgbClr val="4A5568"/>
-            </a:solidFill>
-            <a:prstDash val="solid"/>
-          </a:ln>
-        </p:spPr>
-      </p:sp>
-      <p:sp>
-        <p:nvSpPr>
-          <p:cNvPr id="8" name="Shape 5"/>
-          <p:cNvSpPr/>
-          <p:nvPr/>
-        </p:nvSpPr>
-        <p:spPr>
-          <a:xfrm>
-            <a:off x="4069080" y="2615184"/>
-            <a:ext cx="310896" cy="347472"/>
-          </a:xfrm>
-          <a:prstGeom prst="ellipse">
-            <a:avLst/>
-          </a:prstGeom>
-          <a:solidFill>
-            <a:srgbClr val="2B6CB0"/>
-          </a:solidFill>
-          <a:ln w="12700">
-            <a:solidFill>
-              <a:srgbClr val="2B6CB0"/>
-            </a:solidFill>
-            <a:prstDash val="solid"/>
-          </a:ln>
-        </p:spPr>
-      </p:sp>
-      <p:sp>
-        <p:nvSpPr>
-          <p:cNvPr id="9" name="Text 6"/>
+          <p:cNvPr id="7" name="Text 4"/>
           <p:cNvSpPr txBox="1"/>
           <p:nvPr/>
         </p:nvSpPr>
         <p:spPr>
           <a:xfrm>
-            <a:off x="3840480" y="3063240"/>
+            <a:off x="4069080" y="2148840"/>
             <a:ext cx="2377440" cy="274320"/>
           </a:xfrm>
           <a:prstGeom prst="rect">
@@ -1957,34 +1905,58 @@
           <a:bodyPr wrap="square" lIns="0" tIns="0" rIns="0" bIns="0" rtlCol="0" anchor="ctr"/>
           <a:lstStyle/>
           <a:p>
-            <a:pPr algn="l" indent="0" marL="0">
+            <a:pPr indent="0" marL="0">
               <a:buNone/>
             </a:pPr>
             <a:r>
-              <a:rPr lang="en-US" sz="1200" b="1" dirty="0">
-                <a:solidFill>
-                  <a:srgbClr val="2B6CB0"/>
+              <a:rPr lang="en-US" sz="1400" dirty="0">
+                <a:solidFill>
+                  <a:srgbClr val="1F2A44"/>
                 </a:solidFill>
                 <a:latin typeface="Calibri" pitchFamily="34" charset="0"/>
                 <a:ea typeface="Calibri" pitchFamily="34" charset="-122"/>
                 <a:cs typeface="Calibri" pitchFamily="34" charset="-120"/>
               </a:rPr>
-              <a:t>capsule faces the loudspeaker</a:t>
-            </a:r>
-            <a:endParaRPr lang="en-US" sz="1200" dirty="0"/>
-          </a:p>
-        </p:txBody>
-      </p:sp>
-      <p:sp>
-        <p:nvSpPr>
-          <p:cNvPr id="10" name="Text 7"/>
+              <a:t>UMIK-2 microphone</a:t>
+            </a:r>
+            <a:endParaRPr lang="en-US" sz="1400" dirty="0"/>
+          </a:p>
+        </p:txBody>
+      </p:sp>
+      <p:pic>
+        <p:nvPicPr>
+          <p:cNvPr id="8" name="Image 1" descr="UMIK-2 measurement microphone, capsule end on the left facing the loudspeaker">    </p:cNvPr>
+          <p:cNvPicPr>
+            <a:picLocks noChangeAspect="1"/>
+          </p:cNvPicPr>
+          <p:nvPr/>
+        </p:nvPicPr>
+        <p:blipFill>
+          <a:blip r:embed="rId2"/>
+          <a:stretch>
+            <a:fillRect/>
+          </a:stretch>
+        </p:blipFill>
+        <p:spPr>
+          <a:xfrm>
+            <a:off x="4069080" y="2560320"/>
+            <a:ext cx="2514600" cy="679399"/>
+          </a:xfrm>
+          <a:prstGeom prst="rect">
+            <a:avLst/>
+          </a:prstGeom>
+        </p:spPr>
+      </p:pic>
+      <p:sp>
+        <p:nvSpPr>
+          <p:cNvPr id="9" name="Text 5"/>
           <p:cNvSpPr txBox="1"/>
           <p:nvPr/>
         </p:nvSpPr>
         <p:spPr>
           <a:xfrm>
-            <a:off x="4069080" y="2194560"/>
-            <a:ext cx="2377440" cy="274320"/>
+            <a:off x="4069080" y="3310128"/>
+            <a:ext cx="2651760" cy="256032"/>
           </a:xfrm>
           <a:prstGeom prst="rect">
             <a:avLst/>
@@ -2000,55 +1972,30 @@
               <a:buNone/>
             </a:pPr>
             <a:r>
-              <a:rPr lang="en-US" sz="1400" dirty="0">
-                <a:solidFill>
-                  <a:srgbClr val="1F2A44"/>
+              <a:rPr lang="en-US" sz="1200" b="1" dirty="0">
+                <a:solidFill>
+                  <a:srgbClr val="2B6CB0"/>
                 </a:solidFill>
                 <a:latin typeface="Calibri" pitchFamily="34" charset="0"/>
                 <a:ea typeface="Calibri" pitchFamily="34" charset="-122"/>
                 <a:cs typeface="Calibri" pitchFamily="34" charset="-120"/>
               </a:rPr>
-              <a:t>UMIK-2 microphone</a:t>
-            </a:r>
-            <a:endParaRPr lang="en-US" sz="1400" dirty="0"/>
-          </a:p>
-        </p:txBody>
-      </p:sp>
-      <p:sp>
-        <p:nvSpPr>
-          <p:cNvPr id="11" name="Shape 8"/>
-          <p:cNvSpPr/>
-          <p:nvPr/>
-        </p:nvSpPr>
-        <p:spPr>
-          <a:xfrm>
-            <a:off x="4754880" y="3383280"/>
-            <a:ext cx="0" cy="274320"/>
-          </a:xfrm>
-          <a:prstGeom prst="line">
-            <a:avLst/>
-          </a:prstGeom>
-          <a:noFill/>
-          <a:ln w="25400">
-            <a:solidFill>
-              <a:srgbClr val="1F2A44"/>
-            </a:solidFill>
-            <a:prstDash val="solid"/>
-            <a:headEnd type="triangle"/>
-            <a:tailEnd type="triangle"/>
-          </a:ln>
-        </p:spPr>
-      </p:sp>
-      <p:sp>
-        <p:nvSpPr>
-          <p:cNvPr id="12" name="Text 9"/>
+              <a:t>capsule end faces the loudspeaker</a:t>
+            </a:r>
+            <a:endParaRPr lang="en-US" sz="1200" dirty="0"/>
+          </a:p>
+        </p:txBody>
+      </p:sp>
+      <p:sp>
+        <p:nvSpPr>
+          <p:cNvPr id="10" name="Text 6"/>
           <p:cNvSpPr txBox="1"/>
           <p:nvPr/>
         </p:nvSpPr>
         <p:spPr>
           <a:xfrm>
-            <a:off x="4846320" y="3401568"/>
-            <a:ext cx="731520" cy="237744"/>
+            <a:off x="4069080" y="3657600"/>
+            <a:ext cx="2651760" cy="237744"/>
           </a:xfrm>
           <a:prstGeom prst="rect">
             <a:avLst/>
@@ -2072,7 +2019,7 @@
                 <a:ea typeface="Calibri" pitchFamily="34" charset="-122"/>
                 <a:cs typeface="Calibri" pitchFamily="34" charset="-120"/>
               </a:rPr>
-              <a:t>swap</a:t>
+              <a:t>swap, one unit at a time</a:t>
             </a:r>
             <a:endParaRPr lang="en-US" sz="1200" dirty="0"/>
           </a:p>
@@ -2080,72 +2027,28 @@
       </p:sp>
       <p:sp>
         <p:nvSpPr>
-          <p:cNvPr id="13" name="Shape 10"/>
+          <p:cNvPr id="11" name="Text 7"/>
           <p:cNvSpPr/>
           <p:nvPr/>
         </p:nvSpPr>
         <p:spPr>
           <a:xfrm>
-            <a:off x="4145890" y="3811219"/>
-            <a:ext cx="576072" cy="71323"/>
+            <a:off x="4069080" y="3931920"/>
+            <a:ext cx="841248" cy="292608"/>
           </a:xfrm>
           <a:prstGeom prst="roundRect">
             <a:avLst>
-              <a:gd name="adj" fmla="val 19231"/>
+              <a:gd name="adj" fmla="val 31250"/>
             </a:avLst>
           </a:prstGeom>
           <a:solidFill>
-            <a:srgbClr val="4A5568"/>
+            <a:srgbClr val="EEF1F6"/>
           </a:solidFill>
-          <a:ln w="12700">
+          <a:ln w="9525">
             <a:solidFill>
-              <a:srgbClr val="4A5568"/>
+              <a:srgbClr val="C9CFDA"/>
             </a:solidFill>
-            <a:prstDash val="solid"/>
           </a:ln>
-        </p:spPr>
-      </p:sp>
-      <p:sp>
-        <p:nvSpPr>
-          <p:cNvPr id="14" name="Shape 11"/>
-          <p:cNvSpPr/>
-          <p:nvPr/>
-        </p:nvSpPr>
-        <p:spPr>
-          <a:xfrm>
-            <a:off x="4069080" y="3794760"/>
-            <a:ext cx="93269" cy="104242"/>
-          </a:xfrm>
-          <a:prstGeom prst="ellipse">
-            <a:avLst/>
-          </a:prstGeom>
-          <a:solidFill>
-            <a:srgbClr val="9AA5B8"/>
-          </a:solidFill>
-          <a:ln w="12700">
-            <a:solidFill>
-              <a:srgbClr val="9AA5B8"/>
-            </a:solidFill>
-            <a:prstDash val="solid"/>
-          </a:ln>
-        </p:spPr>
-      </p:sp>
-      <p:sp>
-        <p:nvSpPr>
-          <p:cNvPr id="15" name="Text 12"/>
-          <p:cNvSpPr txBox="1"/>
-          <p:nvPr/>
-        </p:nvSpPr>
-        <p:spPr>
-          <a:xfrm>
-            <a:off x="4069080" y="4005072"/>
-            <a:ext cx="685800" cy="228600"/>
-          </a:xfrm>
-          <a:prstGeom prst="rect">
-            <a:avLst/>
-          </a:prstGeom>
-          <a:noFill/>
-          <a:ln/>
         </p:spPr>
         <p:txBody>
           <a:bodyPr wrap="square" lIns="0" tIns="0" rIns="0" bIns="0" rtlCol="0" anchor="ctr"/>
@@ -2157,13 +2060,13 @@
             <a:r>
               <a:rPr lang="en-US" sz="1200" dirty="0">
                 <a:solidFill>
-                  <a:srgbClr val="5B6578"/>
+                  <a:srgbClr val="1F2A44"/>
                 </a:solidFill>
                 <a:latin typeface="Calibri" pitchFamily="34" charset="0"/>
                 <a:ea typeface="Calibri" pitchFamily="34" charset="-122"/>
                 <a:cs typeface="Calibri" pitchFamily="34" charset="-120"/>
               </a:rPr>
-              <a:t>1</a:t>
+              <a:t>810-8904</a:t>
             </a:r>
             <a:endParaRPr lang="en-US" sz="1200" dirty="0"/>
           </a:p>
@@ -2171,72 +2074,28 @@
       </p:sp>
       <p:sp>
         <p:nvSpPr>
-          <p:cNvPr id="16" name="Shape 13"/>
+          <p:cNvPr id="12" name="Text 8"/>
           <p:cNvSpPr/>
           <p:nvPr/>
         </p:nvSpPr>
         <p:spPr>
           <a:xfrm>
-            <a:off x="4968850" y="3811219"/>
-            <a:ext cx="576072" cy="71323"/>
+            <a:off x="5074920" y="3931920"/>
+            <a:ext cx="841248" cy="292608"/>
           </a:xfrm>
           <a:prstGeom prst="roundRect">
             <a:avLst>
-              <a:gd name="adj" fmla="val 19231"/>
+              <a:gd name="adj" fmla="val 31250"/>
             </a:avLst>
           </a:prstGeom>
           <a:solidFill>
-            <a:srgbClr val="4A5568"/>
+            <a:srgbClr val="EEF1F6"/>
           </a:solidFill>
-          <a:ln w="12700">
+          <a:ln w="9525">
             <a:solidFill>
-              <a:srgbClr val="4A5568"/>
+              <a:srgbClr val="C9CFDA"/>
             </a:solidFill>
-            <a:prstDash val="solid"/>
           </a:ln>
-        </p:spPr>
-      </p:sp>
-      <p:sp>
-        <p:nvSpPr>
-          <p:cNvPr id="17" name="Shape 14"/>
-          <p:cNvSpPr/>
-          <p:nvPr/>
-        </p:nvSpPr>
-        <p:spPr>
-          <a:xfrm>
-            <a:off x="4892040" y="3794760"/>
-            <a:ext cx="93269" cy="104242"/>
-          </a:xfrm>
-          <a:prstGeom prst="ellipse">
-            <a:avLst/>
-          </a:prstGeom>
-          <a:solidFill>
-            <a:srgbClr val="9AA5B8"/>
-          </a:solidFill>
-          <a:ln w="12700">
-            <a:solidFill>
-              <a:srgbClr val="9AA5B8"/>
-            </a:solidFill>
-            <a:prstDash val="solid"/>
-          </a:ln>
-        </p:spPr>
-      </p:sp>
-      <p:sp>
-        <p:nvSpPr>
-          <p:cNvPr id="18" name="Text 15"/>
-          <p:cNvSpPr txBox="1"/>
-          <p:nvPr/>
-        </p:nvSpPr>
-        <p:spPr>
-          <a:xfrm>
-            <a:off x="4892040" y="4005072"/>
-            <a:ext cx="685800" cy="228600"/>
-          </a:xfrm>
-          <a:prstGeom prst="rect">
-            <a:avLst/>
-          </a:prstGeom>
-          <a:noFill/>
-          <a:ln/>
         </p:spPr>
         <p:txBody>
           <a:bodyPr wrap="square" lIns="0" tIns="0" rIns="0" bIns="0" rtlCol="0" anchor="ctr"/>
@@ -2248,13 +2107,13 @@
             <a:r>
               <a:rPr lang="en-US" sz="1200" dirty="0">
                 <a:solidFill>
-                  <a:srgbClr val="5B6578"/>
+                  <a:srgbClr val="1F2A44"/>
                 </a:solidFill>
                 <a:latin typeface="Calibri" pitchFamily="34" charset="0"/>
                 <a:ea typeface="Calibri" pitchFamily="34" charset="-122"/>
                 <a:cs typeface="Calibri" pitchFamily="34" charset="-120"/>
               </a:rPr>
-              <a:t>2</a:t>
+              <a:t>811-1896</a:t>
             </a:r>
             <a:endParaRPr lang="en-US" sz="1200" dirty="0"/>
           </a:p>
@@ -2262,72 +2121,28 @@
       </p:sp>
       <p:sp>
         <p:nvSpPr>
-          <p:cNvPr id="19" name="Shape 16"/>
+          <p:cNvPr id="13" name="Text 9"/>
           <p:cNvSpPr/>
           <p:nvPr/>
         </p:nvSpPr>
         <p:spPr>
           <a:xfrm>
-            <a:off x="6020410" y="3811219"/>
-            <a:ext cx="576072" cy="71323"/>
+            <a:off x="6080760" y="3931920"/>
+            <a:ext cx="841248" cy="292608"/>
           </a:xfrm>
           <a:prstGeom prst="roundRect">
             <a:avLst>
-              <a:gd name="adj" fmla="val 19231"/>
+              <a:gd name="adj" fmla="val 31250"/>
             </a:avLst>
           </a:prstGeom>
           <a:solidFill>
-            <a:srgbClr val="4A5568"/>
+            <a:srgbClr val="EEF1F6"/>
           </a:solidFill>
-          <a:ln w="12700">
+          <a:ln w="9525">
             <a:solidFill>
-              <a:srgbClr val="4A5568"/>
+              <a:srgbClr val="C9CFDA"/>
             </a:solidFill>
-            <a:prstDash val="solid"/>
           </a:ln>
-        </p:spPr>
-      </p:sp>
-      <p:sp>
-        <p:nvSpPr>
-          <p:cNvPr id="20" name="Shape 17"/>
-          <p:cNvSpPr/>
-          <p:nvPr/>
-        </p:nvSpPr>
-        <p:spPr>
-          <a:xfrm>
-            <a:off x="5943600" y="3794760"/>
-            <a:ext cx="93269" cy="104242"/>
-          </a:xfrm>
-          <a:prstGeom prst="ellipse">
-            <a:avLst/>
-          </a:prstGeom>
-          <a:solidFill>
-            <a:srgbClr val="9AA5B8"/>
-          </a:solidFill>
-          <a:ln w="12700">
-            <a:solidFill>
-              <a:srgbClr val="9AA5B8"/>
-            </a:solidFill>
-            <a:prstDash val="solid"/>
-          </a:ln>
-        </p:spPr>
-      </p:sp>
-      <p:sp>
-        <p:nvSpPr>
-          <p:cNvPr id="21" name="Text 18"/>
-          <p:cNvSpPr txBox="1"/>
-          <p:nvPr/>
-        </p:nvSpPr>
-        <p:spPr>
-          <a:xfrm>
-            <a:off x="5943600" y="4005072"/>
-            <a:ext cx="685800" cy="228600"/>
-          </a:xfrm>
-          <a:prstGeom prst="rect">
-            <a:avLst/>
-          </a:prstGeom>
-          <a:noFill/>
-          <a:ln/>
         </p:spPr>
         <p:txBody>
           <a:bodyPr wrap="square" lIns="0" tIns="0" rIns="0" bIns="0" rtlCol="0" anchor="ctr"/>
@@ -2339,13 +2154,13 @@
             <a:r>
               <a:rPr lang="en-US" sz="1200" dirty="0">
                 <a:solidFill>
-                  <a:srgbClr val="5B6578"/>
+                  <a:srgbClr val="1F2A44"/>
                 </a:solidFill>
                 <a:latin typeface="Calibri" pitchFamily="34" charset="0"/>
                 <a:ea typeface="Calibri" pitchFamily="34" charset="-122"/>
                 <a:cs typeface="Calibri" pitchFamily="34" charset="-120"/>
               </a:rPr>
-              <a:t>11</a:t>
+              <a:t>811-1892</a:t>
             </a:r>
             <a:endParaRPr lang="en-US" sz="1200" dirty="0"/>
           </a:p>
@@ -2353,14 +2168,14 @@
       </p:sp>
       <p:sp>
         <p:nvSpPr>
-          <p:cNvPr id="22" name="Text 19"/>
+          <p:cNvPr id="14" name="Text 10"/>
           <p:cNvSpPr txBox="1"/>
           <p:nvPr/>
         </p:nvSpPr>
         <p:spPr>
           <a:xfrm>
-            <a:off x="5577840" y="3703320"/>
-            <a:ext cx="365760" cy="274320"/>
+            <a:off x="4910328" y="3913632"/>
+            <a:ext cx="182880" cy="320040"/>
           </a:xfrm>
           <a:prstGeom prst="rect">
             <a:avLst/>
@@ -2376,15 +2191,15 @@
               <a:buNone/>
             </a:pPr>
             <a:r>
-              <a:rPr lang="en-US" sz="1400" dirty="0">
-                <a:solidFill>
-                  <a:srgbClr val="5B6578"/>
+              <a:rPr lang="en-US" sz="1400" b="1" dirty="0">
+                <a:solidFill>
+                  <a:srgbClr val="1F2A44"/>
                 </a:solidFill>
                 <a:latin typeface="Calibri" pitchFamily="34" charset="0"/>
                 <a:ea typeface="Calibri" pitchFamily="34" charset="-122"/>
                 <a:cs typeface="Calibri" pitchFamily="34" charset="-120"/>
               </a:rPr>
-              <a:t>…</a:t>
+              <a:t>⇄</a:t>
             </a:r>
             <a:endParaRPr lang="en-US" sz="1400" dirty="0"/>
           </a:p>
@@ -2392,14 +2207,14 @@
       </p:sp>
       <p:sp>
         <p:nvSpPr>
-          <p:cNvPr id="23" name="Text 20"/>
+          <p:cNvPr id="15" name="Text 11"/>
           <p:cNvSpPr txBox="1"/>
           <p:nvPr/>
         </p:nvSpPr>
         <p:spPr>
           <a:xfrm>
-            <a:off x="411480" y="3703320"/>
-            <a:ext cx="1874520" cy="274320"/>
+            <a:off x="5916168" y="3913632"/>
+            <a:ext cx="182880" cy="320040"/>
           </a:xfrm>
           <a:prstGeom prst="rect">
             <a:avLst/>
@@ -2415,7 +2230,7 @@
               <a:buNone/>
             </a:pPr>
             <a:r>
-              <a:rPr lang="en-US" sz="1400" dirty="0">
+              <a:rPr lang="en-US" sz="1400" b="1" dirty="0">
                 <a:solidFill>
                   <a:srgbClr val="1F2A44"/>
                 </a:solidFill>
@@ -2423,6 +2238,45 @@
                 <a:ea typeface="Calibri" pitchFamily="34" charset="-122"/>
                 <a:cs typeface="Calibri" pitchFamily="34" charset="-120"/>
               </a:rPr>
+              <a:t>⇄</a:t>
+            </a:r>
+            <a:endParaRPr lang="en-US" sz="1400" dirty="0"/>
+          </a:p>
+        </p:txBody>
+      </p:sp>
+      <p:sp>
+        <p:nvSpPr>
+          <p:cNvPr id="16" name="Text 12"/>
+          <p:cNvSpPr txBox="1"/>
+          <p:nvPr/>
+        </p:nvSpPr>
+        <p:spPr>
+          <a:xfrm>
+            <a:off x="411480" y="3703320"/>
+            <a:ext cx="1874520" cy="274320"/>
+          </a:xfrm>
+          <a:prstGeom prst="rect">
+            <a:avLst/>
+          </a:prstGeom>
+          <a:noFill/>
+          <a:ln/>
+        </p:spPr>
+        <p:txBody>
+          <a:bodyPr wrap="square" lIns="0" tIns="0" rIns="0" bIns="0" rtlCol="0" anchor="ctr"/>
+          <a:lstStyle/>
+          <a:p>
+            <a:pPr algn="ctr" indent="0" marL="0">
+              <a:buNone/>
+            </a:pPr>
+            <a:r>
+              <a:rPr lang="en-US" sz="1400" dirty="0">
+                <a:solidFill>
+                  <a:srgbClr val="1F2A44"/>
+                </a:solidFill>
+                <a:latin typeface="Calibri" pitchFamily="34" charset="0"/>
+                <a:ea typeface="Calibri" pitchFamily="34" charset="-122"/>
+                <a:cs typeface="Calibri" pitchFamily="34" charset="-120"/>
+              </a:rPr>
               <a:t>Our loudspeaker</a:t>
             </a:r>
             <a:endParaRPr lang="en-US" sz="1400" dirty="0"/>
@@ -2431,7 +2285,7 @@
       </p:sp>
       <p:sp>
         <p:nvSpPr>
-          <p:cNvPr id="24" name="Text 21"/>
+          <p:cNvPr id="17" name="Text 13"/>
           <p:cNvSpPr txBox="1"/>
           <p:nvPr/>
         </p:nvSpPr>
@@ -2537,7 +2391,7 @@
       </p:sp>
       <p:sp>
         <p:nvSpPr>
-          <p:cNvPr id="25" name="Text 22"/>
+          <p:cNvPr id="18" name="Text 14"/>
           <p:cNvSpPr txBox="1"/>
           <p:nvPr/>
         </p:nvSpPr>
@@ -2604,7 +2458,7 @@
       </p:sp>
       <p:sp>
         <p:nvSpPr>
-          <p:cNvPr id="26" name="Text 23"/>
+          <p:cNvPr id="19" name="Text 15"/>
           <p:cNvSpPr txBox="1"/>
           <p:nvPr/>
         </p:nvSpPr>
@@ -2643,7 +2497,7 @@
       </p:sp>
       <p:sp>
         <p:nvSpPr>
-          <p:cNvPr id="27" name="Text 24"/>
+          <p:cNvPr id="20" name="Text 16"/>
           <p:cNvSpPr txBox="1"/>
           <p:nvPr/>
         </p:nvSpPr>
@@ -2682,7 +2536,7 @@
       </p:sp>
       <p:sp>
         <p:nvSpPr>
-          <p:cNvPr id="28" name="Text 25"/>
+          <p:cNvPr id="21" name="Text 17"/>
           <p:cNvSpPr txBox="1"/>
           <p:nvPr/>
         </p:nvSpPr>
@@ -2721,7 +2575,7 @@
       </p:sp>
       <p:graphicFrame>
         <p:nvGraphicFramePr>
-          <p:cNvPr id="29" name="Chart 0" descr=""/>
+          <p:cNvPr id="22" name="Chart 0" descr=""/>
           <p:cNvGraphicFramePr/>
           <p:nvPr/>
         </p:nvGraphicFramePr>
@@ -2731,13 +2585,13 @@
         </p:xfrm>
         <a:graphic xmlns:a="http://schemas.openxmlformats.org/drawingml/2006/main">
           <a:graphicData uri="http://schemas.openxmlformats.org/drawingml/2006/chart">
-            <c:chart xmlns:c="http://schemas.openxmlformats.org/drawingml/2006/chart" r:id="rId2"/>
+            <c:chart xmlns:c="http://schemas.openxmlformats.org/drawingml/2006/chart" r:id="rId3"/>
           </a:graphicData>
         </a:graphic>
       </p:graphicFrame>
       <p:sp>
         <p:nvSpPr>
-          <p:cNvPr id="30" name="Text 26"/>
+          <p:cNvPr id="23" name="Text 18"/>
           <p:cNvSpPr txBox="1"/>
           <p:nvPr/>
         </p:nvSpPr>
@@ -2768,7 +2622,7 @@
                 <a:ea typeface="Calibri" pitchFamily="34" charset="-122"/>
                 <a:cs typeface="Calibri" pitchFamily="34" charset="-120"/>
               </a:rPr>
-              <a:t>Calibration session 16 Sep 2026, one microphone plugged in at a time, loudspeaker amplitude 0.03 of full scale.</a:t>
+              <a:t>Calibration session 16 Sep 2026, loudspeaker amplitude 0.03 of full scale. UMIK-2 photo: miniDSP product brief.</a:t>
             </a:r>
             <a:endParaRPr lang="en-US" sz="1100" dirty="0"/>
           </a:p>
@@ -2776,7 +2630,7 @@
       </p:sp>
       <p:sp>
         <p:nvSpPr>
-          <p:cNvPr id="31" name="Text 27"/>
+          <p:cNvPr id="24" name="Text 19"/>
           <p:cNvSpPr txBox="1"/>
           <p:nvPr/>
         </p:nvSpPr>

</xml_diff>

<commit_message>
Slides: remove the swap graphic from slide 2; the swap is carried by the bullets
Co-Authored-By: Claude Sonnet 5.5 <noreply@anthropic.com>
</commit_message>
<xml_diff>
--- a/docs/analysis/chamber-final-2026-10-01/slides/chamber-slides.pptx
+++ b/docs/analysis/chamber-final-2026-10-01/slides/chamber-slides.pptx
@@ -1813,8 +1813,8 @@
         </p:blipFill>
         <p:spPr>
           <a:xfrm>
-            <a:off x="640080" y="2057400"/>
-            <a:ext cx="1417320" cy="1600200"/>
+            <a:off x="548640" y="2103120"/>
+            <a:ext cx="1325880" cy="1508760"/>
           </a:xfrm>
           <a:prstGeom prst="rect">
             <a:avLst/>
@@ -1829,8 +1829,8 @@
         </p:nvSpPr>
         <p:spPr>
           <a:xfrm>
-            <a:off x="2103120" y="2468880"/>
-            <a:ext cx="1828800" cy="274320"/>
+            <a:off x="1874520" y="2514600"/>
+            <a:ext cx="1234440" cy="457200"/>
           </a:xfrm>
           <a:prstGeom prst="rect">
             <a:avLst/>
@@ -1839,7 +1839,7 @@
           <a:ln/>
         </p:spPr>
         <p:txBody>
-          <a:bodyPr wrap="square" lIns="0" tIns="0" rIns="0" bIns="0" rtlCol="0" anchor="ctr"/>
+          <a:bodyPr wrap="square" lIns="0" tIns="0" rIns="0" bIns="0" rtlCol="0" anchor="b"/>
           <a:lstStyle/>
           <a:p>
             <a:pPr algn="ctr" indent="0" marL="0">
@@ -1854,7 +1854,24 @@
                 <a:ea typeface="Calibri" pitchFamily="34" charset="-122"/>
                 <a:cs typeface="Calibri" pitchFamily="34" charset="-120"/>
               </a:rPr>
-              <a:t>tones, 62 Hz–16 kHz</a:t>
+              <a:t>tones</a:t>
+            </a:r>
+            <a:endParaRPr lang="en-US" sz="1200" dirty="0"/>
+          </a:p>
+          <a:p>
+            <a:pPr algn="ctr" indent="0" marL="0">
+              <a:buNone/>
+            </a:pPr>
+            <a:r>
+              <a:rPr lang="en-US" sz="1200" dirty="0">
+                <a:solidFill>
+                  <a:srgbClr val="5B6578"/>
+                </a:solidFill>
+                <a:latin typeface="Calibri" pitchFamily="34" charset="0"/>
+                <a:ea typeface="Calibri" pitchFamily="34" charset="-122"/>
+                <a:cs typeface="Calibri" pitchFamily="34" charset="-120"/>
+              </a:rPr>
+              <a:t>62 Hz–16 kHz</a:t>
             </a:r>
             <a:endParaRPr lang="en-US" sz="1200" dirty="0"/>
           </a:p>
@@ -1868,8 +1885,8 @@
         </p:nvSpPr>
         <p:spPr>
           <a:xfrm>
-            <a:off x="2194560" y="2926080"/>
-            <a:ext cx="1783080" cy="0"/>
+            <a:off x="1965960" y="3063240"/>
+            <a:ext cx="1234440" cy="0"/>
           </a:xfrm>
           <a:prstGeom prst="line">
             <a:avLst/>
@@ -1892,8 +1909,8 @@
         </p:nvSpPr>
         <p:spPr>
           <a:xfrm>
-            <a:off x="4069080" y="2148840"/>
-            <a:ext cx="2377440" cy="274320"/>
+            <a:off x="3291840" y="2194560"/>
+            <a:ext cx="2286000" cy="274320"/>
           </a:xfrm>
           <a:prstGeom prst="rect">
             <a:avLst/>
@@ -1925,7 +1942,7 @@
       </p:sp>
       <p:pic>
         <p:nvPicPr>
-          <p:cNvPr id="8" name="Image 1" descr="UMIK-2 measurement microphone, capsule end on the left facing the loudspeaker">    </p:cNvPr>
+          <p:cNvPr id="8" name="Image 1" descr="UMIK-2 measurement microphone at the mounting point, capsule end on the left facing the loudspeaker">    </p:cNvPr>
           <p:cNvPicPr>
             <a:picLocks noChangeAspect="1"/>
           </p:cNvPicPr>
@@ -1939,8 +1956,8 @@
         </p:blipFill>
         <p:spPr>
           <a:xfrm>
-            <a:off x="4069080" y="2560320"/>
-            <a:ext cx="2514600" cy="679399"/>
+            <a:off x="3291840" y="2697480"/>
+            <a:ext cx="2743200" cy="741578"/>
           </a:xfrm>
           <a:prstGeom prst="rect">
             <a:avLst/>
@@ -1955,8 +1972,8 @@
         </p:nvSpPr>
         <p:spPr>
           <a:xfrm>
-            <a:off x="4069080" y="3310128"/>
-            <a:ext cx="2651760" cy="256032"/>
+            <a:off x="3291840" y="3547872"/>
+            <a:ext cx="2926080" cy="256032"/>
           </a:xfrm>
           <a:prstGeom prst="rect">
             <a:avLst/>
@@ -1972,7 +1989,7 @@
               <a:buNone/>
             </a:pPr>
             <a:r>
-              <a:rPr lang="en-US" sz="1200" b="1" dirty="0">
+              <a:rPr lang="en-US" sz="1300" b="1" dirty="0">
                 <a:solidFill>
                   <a:srgbClr val="2B6CB0"/>
                 </a:solidFill>
@@ -1980,9 +1997,9 @@
                 <a:ea typeface="Calibri" pitchFamily="34" charset="-122"/>
                 <a:cs typeface="Calibri" pitchFamily="34" charset="-120"/>
               </a:rPr>
-              <a:t>capsule end faces the loudspeaker</a:t>
-            </a:r>
-            <a:endParaRPr lang="en-US" sz="1200" dirty="0"/>
+              <a:t>capsule faces the loudspeaker</a:t>
+            </a:r>
+            <a:endParaRPr lang="en-US" sz="1300" dirty="0"/>
           </a:p>
         </p:txBody>
       </p:sp>
@@ -1994,8 +2011,8 @@
         </p:nvSpPr>
         <p:spPr>
           <a:xfrm>
-            <a:off x="4069080" y="3657600"/>
-            <a:ext cx="2651760" cy="237744"/>
+            <a:off x="365760" y="3703320"/>
+            <a:ext cx="1691640" cy="274320"/>
           </a:xfrm>
           <a:prstGeom prst="rect">
             <a:avLst/>
@@ -2007,11 +2024,11 @@
           <a:bodyPr wrap="square" lIns="0" tIns="0" rIns="0" bIns="0" rtlCol="0" anchor="ctr"/>
           <a:lstStyle/>
           <a:p>
-            <a:pPr indent="0" marL="0">
+            <a:pPr algn="ctr" indent="0" marL="0">
               <a:buNone/>
             </a:pPr>
             <a:r>
-              <a:rPr lang="en-US" sz="1200" b="1" dirty="0">
+              <a:rPr lang="en-US" sz="1400" dirty="0">
                 <a:solidFill>
                   <a:srgbClr val="1F2A44"/>
                 </a:solidFill>
@@ -2019,273 +2036,15 @@
                 <a:ea typeface="Calibri" pitchFamily="34" charset="-122"/>
                 <a:cs typeface="Calibri" pitchFamily="34" charset="-120"/>
               </a:rPr>
-              <a:t>swap, one unit at a time</a:t>
-            </a:r>
-            <a:endParaRPr lang="en-US" sz="1200" dirty="0"/>
+              <a:t>Our loudspeaker</a:t>
+            </a:r>
+            <a:endParaRPr lang="en-US" sz="1400" dirty="0"/>
           </a:p>
         </p:txBody>
       </p:sp>
       <p:sp>
         <p:nvSpPr>
           <p:cNvPr id="11" name="Text 7"/>
-          <p:cNvSpPr/>
-          <p:nvPr/>
-        </p:nvSpPr>
-        <p:spPr>
-          <a:xfrm>
-            <a:off x="4069080" y="3931920"/>
-            <a:ext cx="841248" cy="292608"/>
-          </a:xfrm>
-          <a:prstGeom prst="roundRect">
-            <a:avLst>
-              <a:gd name="adj" fmla="val 31250"/>
-            </a:avLst>
-          </a:prstGeom>
-          <a:solidFill>
-            <a:srgbClr val="EEF1F6"/>
-          </a:solidFill>
-          <a:ln w="9525">
-            <a:solidFill>
-              <a:srgbClr val="C9CFDA"/>
-            </a:solidFill>
-          </a:ln>
-        </p:spPr>
-        <p:txBody>
-          <a:bodyPr wrap="square" lIns="0" tIns="0" rIns="0" bIns="0" rtlCol="0" anchor="ctr"/>
-          <a:lstStyle/>
-          <a:p>
-            <a:pPr algn="ctr" indent="0" marL="0">
-              <a:buNone/>
-            </a:pPr>
-            <a:r>
-              <a:rPr lang="en-US" sz="1200" dirty="0">
-                <a:solidFill>
-                  <a:srgbClr val="1F2A44"/>
-                </a:solidFill>
-                <a:latin typeface="Calibri" pitchFamily="34" charset="0"/>
-                <a:ea typeface="Calibri" pitchFamily="34" charset="-122"/>
-                <a:cs typeface="Calibri" pitchFamily="34" charset="-120"/>
-              </a:rPr>
-              <a:t>810-8904</a:t>
-            </a:r>
-            <a:endParaRPr lang="en-US" sz="1200" dirty="0"/>
-          </a:p>
-        </p:txBody>
-      </p:sp>
-      <p:sp>
-        <p:nvSpPr>
-          <p:cNvPr id="12" name="Text 8"/>
-          <p:cNvSpPr/>
-          <p:nvPr/>
-        </p:nvSpPr>
-        <p:spPr>
-          <a:xfrm>
-            <a:off x="5074920" y="3931920"/>
-            <a:ext cx="841248" cy="292608"/>
-          </a:xfrm>
-          <a:prstGeom prst="roundRect">
-            <a:avLst>
-              <a:gd name="adj" fmla="val 31250"/>
-            </a:avLst>
-          </a:prstGeom>
-          <a:solidFill>
-            <a:srgbClr val="EEF1F6"/>
-          </a:solidFill>
-          <a:ln w="9525">
-            <a:solidFill>
-              <a:srgbClr val="C9CFDA"/>
-            </a:solidFill>
-          </a:ln>
-        </p:spPr>
-        <p:txBody>
-          <a:bodyPr wrap="square" lIns="0" tIns="0" rIns="0" bIns="0" rtlCol="0" anchor="ctr"/>
-          <a:lstStyle/>
-          <a:p>
-            <a:pPr algn="ctr" indent="0" marL="0">
-              <a:buNone/>
-            </a:pPr>
-            <a:r>
-              <a:rPr lang="en-US" sz="1200" dirty="0">
-                <a:solidFill>
-                  <a:srgbClr val="1F2A44"/>
-                </a:solidFill>
-                <a:latin typeface="Calibri" pitchFamily="34" charset="0"/>
-                <a:ea typeface="Calibri" pitchFamily="34" charset="-122"/>
-                <a:cs typeface="Calibri" pitchFamily="34" charset="-120"/>
-              </a:rPr>
-              <a:t>811-1896</a:t>
-            </a:r>
-            <a:endParaRPr lang="en-US" sz="1200" dirty="0"/>
-          </a:p>
-        </p:txBody>
-      </p:sp>
-      <p:sp>
-        <p:nvSpPr>
-          <p:cNvPr id="13" name="Text 9"/>
-          <p:cNvSpPr/>
-          <p:nvPr/>
-        </p:nvSpPr>
-        <p:spPr>
-          <a:xfrm>
-            <a:off x="6080760" y="3931920"/>
-            <a:ext cx="841248" cy="292608"/>
-          </a:xfrm>
-          <a:prstGeom prst="roundRect">
-            <a:avLst>
-              <a:gd name="adj" fmla="val 31250"/>
-            </a:avLst>
-          </a:prstGeom>
-          <a:solidFill>
-            <a:srgbClr val="EEF1F6"/>
-          </a:solidFill>
-          <a:ln w="9525">
-            <a:solidFill>
-              <a:srgbClr val="C9CFDA"/>
-            </a:solidFill>
-          </a:ln>
-        </p:spPr>
-        <p:txBody>
-          <a:bodyPr wrap="square" lIns="0" tIns="0" rIns="0" bIns="0" rtlCol="0" anchor="ctr"/>
-          <a:lstStyle/>
-          <a:p>
-            <a:pPr algn="ctr" indent="0" marL="0">
-              <a:buNone/>
-            </a:pPr>
-            <a:r>
-              <a:rPr lang="en-US" sz="1200" dirty="0">
-                <a:solidFill>
-                  <a:srgbClr val="1F2A44"/>
-                </a:solidFill>
-                <a:latin typeface="Calibri" pitchFamily="34" charset="0"/>
-                <a:ea typeface="Calibri" pitchFamily="34" charset="-122"/>
-                <a:cs typeface="Calibri" pitchFamily="34" charset="-120"/>
-              </a:rPr>
-              <a:t>811-1892</a:t>
-            </a:r>
-            <a:endParaRPr lang="en-US" sz="1200" dirty="0"/>
-          </a:p>
-        </p:txBody>
-      </p:sp>
-      <p:sp>
-        <p:nvSpPr>
-          <p:cNvPr id="14" name="Text 10"/>
-          <p:cNvSpPr txBox="1"/>
-          <p:nvPr/>
-        </p:nvSpPr>
-        <p:spPr>
-          <a:xfrm>
-            <a:off x="4910328" y="3913632"/>
-            <a:ext cx="182880" cy="320040"/>
-          </a:xfrm>
-          <a:prstGeom prst="rect">
-            <a:avLst/>
-          </a:prstGeom>
-          <a:noFill/>
-          <a:ln/>
-        </p:spPr>
-        <p:txBody>
-          <a:bodyPr wrap="square" lIns="0" tIns="0" rIns="0" bIns="0" rtlCol="0" anchor="ctr"/>
-          <a:lstStyle/>
-          <a:p>
-            <a:pPr algn="ctr" indent="0" marL="0">
-              <a:buNone/>
-            </a:pPr>
-            <a:r>
-              <a:rPr lang="en-US" sz="1400" b="1" dirty="0">
-                <a:solidFill>
-                  <a:srgbClr val="1F2A44"/>
-                </a:solidFill>
-                <a:latin typeface="Calibri" pitchFamily="34" charset="0"/>
-                <a:ea typeface="Calibri" pitchFamily="34" charset="-122"/>
-                <a:cs typeface="Calibri" pitchFamily="34" charset="-120"/>
-              </a:rPr>
-              <a:t>⇄</a:t>
-            </a:r>
-            <a:endParaRPr lang="en-US" sz="1400" dirty="0"/>
-          </a:p>
-        </p:txBody>
-      </p:sp>
-      <p:sp>
-        <p:nvSpPr>
-          <p:cNvPr id="15" name="Text 11"/>
-          <p:cNvSpPr txBox="1"/>
-          <p:nvPr/>
-        </p:nvSpPr>
-        <p:spPr>
-          <a:xfrm>
-            <a:off x="5916168" y="3913632"/>
-            <a:ext cx="182880" cy="320040"/>
-          </a:xfrm>
-          <a:prstGeom prst="rect">
-            <a:avLst/>
-          </a:prstGeom>
-          <a:noFill/>
-          <a:ln/>
-        </p:spPr>
-        <p:txBody>
-          <a:bodyPr wrap="square" lIns="0" tIns="0" rIns="0" bIns="0" rtlCol="0" anchor="ctr"/>
-          <a:lstStyle/>
-          <a:p>
-            <a:pPr algn="ctr" indent="0" marL="0">
-              <a:buNone/>
-            </a:pPr>
-            <a:r>
-              <a:rPr lang="en-US" sz="1400" b="1" dirty="0">
-                <a:solidFill>
-                  <a:srgbClr val="1F2A44"/>
-                </a:solidFill>
-                <a:latin typeface="Calibri" pitchFamily="34" charset="0"/>
-                <a:ea typeface="Calibri" pitchFamily="34" charset="-122"/>
-                <a:cs typeface="Calibri" pitchFamily="34" charset="-120"/>
-              </a:rPr>
-              <a:t>⇄</a:t>
-            </a:r>
-            <a:endParaRPr lang="en-US" sz="1400" dirty="0"/>
-          </a:p>
-        </p:txBody>
-      </p:sp>
-      <p:sp>
-        <p:nvSpPr>
-          <p:cNvPr id="16" name="Text 12"/>
-          <p:cNvSpPr txBox="1"/>
-          <p:nvPr/>
-        </p:nvSpPr>
-        <p:spPr>
-          <a:xfrm>
-            <a:off x="411480" y="3703320"/>
-            <a:ext cx="1874520" cy="274320"/>
-          </a:xfrm>
-          <a:prstGeom prst="rect">
-            <a:avLst/>
-          </a:prstGeom>
-          <a:noFill/>
-          <a:ln/>
-        </p:spPr>
-        <p:txBody>
-          <a:bodyPr wrap="square" lIns="0" tIns="0" rIns="0" bIns="0" rtlCol="0" anchor="ctr"/>
-          <a:lstStyle/>
-          <a:p>
-            <a:pPr algn="ctr" indent="0" marL="0">
-              <a:buNone/>
-            </a:pPr>
-            <a:r>
-              <a:rPr lang="en-US" sz="1400" dirty="0">
-                <a:solidFill>
-                  <a:srgbClr val="1F2A44"/>
-                </a:solidFill>
-                <a:latin typeface="Calibri" pitchFamily="34" charset="0"/>
-                <a:ea typeface="Calibri" pitchFamily="34" charset="-122"/>
-                <a:cs typeface="Calibri" pitchFamily="34" charset="-120"/>
-              </a:rPr>
-              <a:t>Our loudspeaker</a:t>
-            </a:r>
-            <a:endParaRPr lang="en-US" sz="1400" dirty="0"/>
-          </a:p>
-        </p:txBody>
-      </p:sp>
-      <p:sp>
-        <p:nvSpPr>
-          <p:cNvPr id="17" name="Text 13"/>
           <p:cNvSpPr txBox="1"/>
           <p:nvPr/>
         </p:nvSpPr>
@@ -2362,7 +2121,7 @@
                 <a:ea typeface="Calibri" pitchFamily="34" charset="-122"/>
                 <a:cs typeface="Calibri" pitchFamily="34" charset="-120"/>
               </a:rPr>
-              <a:t>Same position, same loudspeaker, same level for every microphone</a:t>
+              <a:t>Microphones swapped in turn: same position, same loudspeaker, same level</a:t>
             </a:r>
             <a:endParaRPr lang="en-US" sz="1400" dirty="0"/>
           </a:p>
@@ -2391,7 +2150,7 @@
       </p:sp>
       <p:sp>
         <p:nvSpPr>
-          <p:cNvPr id="18" name="Text 14"/>
+          <p:cNvPr id="12" name="Text 8"/>
           <p:cNvSpPr txBox="1"/>
           <p:nvPr/>
         </p:nvSpPr>
@@ -2458,7 +2217,7 @@
       </p:sp>
       <p:sp>
         <p:nvSpPr>
-          <p:cNvPr id="19" name="Text 15"/>
+          <p:cNvPr id="13" name="Text 9"/>
           <p:cNvSpPr txBox="1"/>
           <p:nvPr/>
         </p:nvSpPr>
@@ -2497,7 +2256,7 @@
       </p:sp>
       <p:sp>
         <p:nvSpPr>
-          <p:cNvPr id="20" name="Text 16"/>
+          <p:cNvPr id="14" name="Text 10"/>
           <p:cNvSpPr txBox="1"/>
           <p:nvPr/>
         </p:nvSpPr>
@@ -2536,7 +2295,7 @@
       </p:sp>
       <p:sp>
         <p:nvSpPr>
-          <p:cNvPr id="21" name="Text 17"/>
+          <p:cNvPr id="15" name="Text 11"/>
           <p:cNvSpPr txBox="1"/>
           <p:nvPr/>
         </p:nvSpPr>
@@ -2575,7 +2334,7 @@
       </p:sp>
       <p:graphicFrame>
         <p:nvGraphicFramePr>
-          <p:cNvPr id="22" name="Chart 0" descr=""/>
+          <p:cNvPr id="16" name="Chart 0" descr=""/>
           <p:cNvGraphicFramePr/>
           <p:nvPr/>
         </p:nvGraphicFramePr>
@@ -2591,7 +2350,7 @@
       </p:graphicFrame>
       <p:sp>
         <p:nvSpPr>
-          <p:cNvPr id="23" name="Text 18"/>
+          <p:cNvPr id="17" name="Text 12"/>
           <p:cNvSpPr txBox="1"/>
           <p:nvPr/>
         </p:nvSpPr>
@@ -2630,7 +2389,7 @@
       </p:sp>
       <p:sp>
         <p:nvSpPr>
-          <p:cNvPr id="24" name="Text 19"/>
+          <p:cNvPr id="18" name="Text 13"/>
           <p:cNvSpPr txBox="1"/>
           <p:nvPr/>
         </p:nvSpPr>

</xml_diff>

<commit_message>
Slides: spread chart removed, slide 2 re-laid out; new slide 3 with the calibration waterfalls; overlay is slide 4
Co-Authored-By: Claude Sonnet 5.5 <noreply@anthropic.com>
</commit_message>
<xml_diff>
--- a/docs/analysis/chamber-final-2026-10-01/slides/chamber-slides.pptx
+++ b/docs/analysis/chamber-final-2026-10-01/slides/chamber-slides.pptx
@@ -8,9 +8,10 @@
     <p:sldId id="256" r:id="rId2"/>
     <p:sldId id="257" r:id="rId3"/>
     <p:sldId id="258" r:id="rId4"/>
+    <p:sldId id="259" r:id="rId5"/>
   </p:sldIdLst>
   <p:notesMasterIdLst>
-    <p:notesMasterId r:id="rId5"/>
+    <p:notesMasterId r:id="rId6"/>
   </p:notesMasterIdLst>
   <p:sldSz cx="12192000" cy="6858000"/>
   <p:notesSz cx="6858000" cy="12192000"/>
@@ -107,298 +108,6 @@
     </a:lvl9pPr>
   </p:defaultTextStyle>
 </p:presentation>
-</file>
-
-<file path=ppt/charts/chart1.xml><?xml version="1.0" encoding="utf-8"?>
-<c:chartSpace xmlns:c="http://schemas.openxmlformats.org/drawingml/2006/chart" xmlns:a="http://schemas.openxmlformats.org/drawingml/2006/main" xmlns:r="http://schemas.openxmlformats.org/officeDocument/2006/relationships">
-  <c:date1904 val="0"/>
-  <c:roundedCorners val="1"/>
-  <c:chart>
-    <c:autoTitleDeleted val="1"/>
-    <c:plotArea>
-      <c:layout/>
-      <c:barChart>
-        <c:barDir val="bar"/>
-        <c:grouping val="clustered"/>
-        <c:varyColors val="0"/>
-        <c:ser>
-          <c:idx val="0"/>
-          <c:order val="0"/>
-          <c:tx>
-            <c:strRef>
-              <c:f>Sheet1!$B$1</c:f>
-              <c:strCache>
-                <c:ptCount val="1"/>
-                <c:pt idx="0">
-                  <c:v>Mean offset (dB)</c:v>
-                </c:pt>
-              </c:strCache>
-            </c:strRef>
-          </c:tx>
-          <c:spPr>
-            <a:solidFill>
-              <a:srgbClr val="2B6CB0"/>
-            </a:solidFill>
-            <a:effectLst/>
-          </c:spPr>
-          <c:invertIfNegative val="0"/>
-          <c:dLbls>
-            <c:numFmt formatCode="0.0" sourceLinked="0"/>
-            <c:txPr>
-              <a:bodyPr/>
-              <a:lstStyle/>
-              <a:p>
-                <a:pPr>
-                  <a:defRPr b="0" i="0" strike="noStrike" sz="1000" u="none">
-                    <a:solidFill>
-                      <a:srgbClr val="1F2A44"/>
-                    </a:solidFill>
-                    <a:latin typeface="Calibri"/>
-                  </a:defRPr>
-                </a:pPr>
-              </a:p>
-            </c:txPr>
-            <c:showLegendKey val="0"/>
-            <c:showVal val="1"/>
-            <c:showCatName val="0"/>
-            <c:showSerName val="0"/>
-            <c:showPercent val="0"/>
-            <c:showBubbleSize val="0"/>
-            <c:showLeaderLines val="0"/>
-          </c:dLbls>
-          <c:cat>
-            <c:multiLvlStrRef>
-              <c:f>Sheet1!$A$2:$A$12</c:f>
-              <c:multiLvlStrCache>
-                <c:ptCount val="11"/>
-                <c:lvl>
-                  <c:pt idx="0">
-                    <c:v>810-8893</c:v>
-                  </c:pt>
-                  <c:pt idx="1">
-                    <c:v>810-8904</c:v>
-                  </c:pt>
-                  <c:pt idx="2">
-                    <c:v>810-8901</c:v>
-                  </c:pt>
-                  <c:pt idx="3">
-                    <c:v>810-8897</c:v>
-                  </c:pt>
-                  <c:pt idx="4">
-                    <c:v>810-8900</c:v>
-                  </c:pt>
-                  <c:pt idx="5">
-                    <c:v>811-1896</c:v>
-                  </c:pt>
-                  <c:pt idx="6">
-                    <c:v>811-2321</c:v>
-                  </c:pt>
-                  <c:pt idx="7">
-                    <c:v>810-8903</c:v>
-                  </c:pt>
-                  <c:pt idx="8">
-                    <c:v>811-2310</c:v>
-                  </c:pt>
-                  <c:pt idx="9">
-                    <c:v>811-1897</c:v>
-                  </c:pt>
-                  <c:pt idx="10">
-                    <c:v>811-1892</c:v>
-                  </c:pt>
-                </c:lvl>
-              </c:multiLvlStrCache>
-            </c:multiLvlStrRef>
-          </c:cat>
-          <c:val>
-            <c:numRef>
-              <c:f>Sheet1!$B$2:$B$12</c:f>
-              <c:numCache>
-                <c:formatCode>General</c:formatCode>
-                <c:ptCount val="11"/>
-                <c:pt idx="0">
-                  <c:v>1.25</c:v>
-                </c:pt>
-                <c:pt idx="1">
-                  <c:v>0.85</c:v>
-                </c:pt>
-                <c:pt idx="2">
-                  <c:v>0.84</c:v>
-                </c:pt>
-                <c:pt idx="3">
-                  <c:v>0.76</c:v>
-                </c:pt>
-                <c:pt idx="4">
-                  <c:v>0.23</c:v>
-                </c:pt>
-                <c:pt idx="5">
-                  <c:v>0</c:v>
-                </c:pt>
-                <c:pt idx="6">
-                  <c:v>-0.09</c:v>
-                </c:pt>
-                <c:pt idx="7">
-                  <c:v>-0.14</c:v>
-                </c:pt>
-                <c:pt idx="8">
-                  <c:v>-0.78</c:v>
-                </c:pt>
-                <c:pt idx="9">
-                  <c:v>-1.39</c:v>
-                </c:pt>
-                <c:pt idx="10">
-                  <c:v>-2.59</c:v>
-                </c:pt>
-              </c:numCache>
-            </c:numRef>
-          </c:val>
-        </c:ser>
-        <c:dLbls>
-          <c:numFmt formatCode="0.0" sourceLinked="0"/>
-          <c:txPr>
-            <a:bodyPr/>
-            <a:lstStyle/>
-            <a:p>
-              <a:pPr>
-                <a:defRPr b="0" i="0" strike="noStrike" sz="1000" u="none">
-                  <a:solidFill>
-                    <a:srgbClr val="1F2A44"/>
-                  </a:solidFill>
-                  <a:latin typeface="Calibri"/>
-                </a:defRPr>
-              </a:pPr>
-            </a:p>
-          </c:txPr>
-          <c:showLegendKey val="0"/>
-          <c:showVal val="1"/>
-          <c:showCatName val="0"/>
-          <c:showSerName val="0"/>
-          <c:showPercent val="0"/>
-          <c:showBubbleSize val="0"/>
-          <c:showLeaderLines val="0"/>
-        </c:dLbls>
-        <c:gapWidth val="40"/>
-        <c:overlap val="0"/>
-        <c:axId val="2094734554"/>
-        <c:axId val="2094734552"/>
-        <c:axId val="2094734556"/>
-      </c:barChart>
-      <c:catAx>
-        <c:axId val="2094734554"/>
-        <c:scaling>
-          <c:orientation val="minMax"/>
-        </c:scaling>
-        <c:delete val="0"/>
-        <c:axPos val="l"/>
-        <c:numFmt formatCode="General" sourceLinked="1"/>
-        <c:majorTickMark val="out"/>
-        <c:minorTickMark val="none"/>
-        <c:tickLblPos val="low"/>
-        <c:spPr>
-          <a:ln w="12700" cap="flat">
-            <a:solidFill>
-              <a:srgbClr val="888888"/>
-            </a:solidFill>
-            <a:prstDash val="solid"/>
-            <a:round/>
-          </a:ln>
-        </c:spPr>
-        <c:txPr>
-          <a:bodyPr/>
-          <a:lstStyle/>
-          <a:p>
-            <a:pPr>
-              <a:defRPr sz="1000" b="0" i="0" u="none" strike="noStrike">
-                <a:solidFill>
-                  <a:srgbClr val="1F2A44"/>
-                </a:solidFill>
-                <a:latin typeface="Calibri"/>
-              </a:defRPr>
-            </a:pPr>
-            <a:endParaRPr lang="en-US"/>
-          </a:p>
-        </c:txPr>
-        <c:crossAx val="2094734552"/>
-        <c:crosses val="autoZero"/>
-        <c:auto val="1"/>
-        <c:lblAlgn val="ctr"/>
-        <c:noMultiLvlLbl val="1"/>
-        <c:tickLblSkip val="1"/>
-      </c:catAx>
-      <c:valAx>
-        <c:axId val="2094734552"/>
-        <c:scaling>
-          <c:orientation val="minMax"/>
-          <c:max val="2"/>
-          <c:min val="-3"/>
-        </c:scaling>
-        <c:delete val="0"/>
-        <c:axPos val="b"/>
-        <c:majorGridlines>
-          <c:spPr>
-            <a:ln w="6350" cap="flat">
-              <a:solidFill>
-                <a:srgbClr val="E3E7EE"/>
-              </a:solidFill>
-              <a:prstDash val="solid"/>
-              <a:round/>
-            </a:ln>
-          </c:spPr>
-        </c:majorGridlines>
-        <c:numFmt formatCode="General" sourceLinked="0"/>
-        <c:majorTickMark val="out"/>
-        <c:minorTickMark val="none"/>
-        <c:tickLblPos val="low"/>
-        <c:spPr>
-          <a:ln w="12700" cap="flat">
-            <a:solidFill>
-              <a:srgbClr val="888888"/>
-            </a:solidFill>
-            <a:prstDash val="solid"/>
-            <a:round/>
-          </a:ln>
-        </c:spPr>
-        <c:txPr>
-          <a:bodyPr/>
-          <a:lstStyle/>
-          <a:p>
-            <a:pPr>
-              <a:defRPr sz="1000" b="0" i="0" u="none" strike="noStrike">
-                <a:solidFill>
-                  <a:srgbClr val="5B6578"/>
-                </a:solidFill>
-                <a:latin typeface="Calibri"/>
-              </a:defRPr>
-            </a:pPr>
-            <a:endParaRPr lang="en-US"/>
-          </a:p>
-        </c:txPr>
-        <c:crossAx val="2094734554"/>
-        <c:crosses val="autoZero"/>
-        <c:crossBetween val="between"/>
-        <c:majorUnit val="1"/>
-      </c:valAx>
-      <c:spPr>
-        <a:noFill/>
-        <a:ln>
-          <a:noFill/>
-        </a:ln>
-        <a:effectLst/>
-      </c:spPr>
-    </c:plotArea>
-    <c:plotVisOnly val="1"/>
-    <c:dispBlanksAs val="span"/>
-  </c:chart>
-  <c:spPr>
-    <a:noFill/>
-    <a:ln>
-      <a:noFill/>
-    </a:ln>
-    <a:effectLst/>
-  </c:spPr>
-  <c:externalData r:id="rId1">
-    <c:autoUpdate val="0"/>
-  </c:externalData>
-</c:chartSpace>
 </file>
 
 <file path=ppt/notesMasters/notesMaster1.xml><?xml version="1.0" encoding="utf-8"?>
@@ -884,7 +593,7 @@
           <a:p>
             <a:r>
               <a:rPr lang="en-US" dirty="0"/>
-              <a:t>Procedure (calibrator/session.py, 2026-09-16 session): each of the eleven UMIK-2 capsules was plugged in at the same mounting point in front of the loudspeaker and measured over 97 stepped tones, 62 Hz to 16 kHz (about 12 per octave), amplitude 0.03, 48 kHz sampling, 0.7 s settle and 2 s capture per tone (6 s below 250 Hz). Capsule 810-8904 was measured three full times (18:21, 18:30, 20:43) as the reference. The difference of each capsule from the reference was folded into its calibration curve; Sens Factors kept as in the factory files. The datum is the mean of four capsules whose factory files agree with measurement (810-8900, 810-8903, 811-1896, 811-2321). Bars: mean over frequency of how far each capsule read from that datum with its factory file (calibrator corrections csv). Spread 4.01 to 0.02 dB and 7 of 11 files wrong by 0.6-3.6 dB are from the project notes. Absolute level is not anchored: that needs a 94 dB calibrator.</a:t>
+              <a:t>Procedure (calibrator/session.py, 2026-09-16 session): each of the eleven UMIK-2 capsules was plugged in at the same mounting point in front of the loudspeaker and measured over 97 stepped tones, 62 Hz to 16 kHz (about 12 per octave), amplitude 0.03, 48 kHz sampling, 0.7 s settle and 2 s capture per tone (6 s below 250 Hz). Capsule 810-8904 was measured three full times (18:21, 18:30, 20:43) as the reference. The difference of each capsule from the reference was folded into its calibration curve; Sens Factors kept as in the factory files. The datum is the mean of four capsules whose factory files agree with measurement (810-8900, 810-8903, 811-1896, 811-2321). Spread 4.01 to 0.02 dB and 7 of 11 files wrong by 0.6-3.6 dB are from the project notes. Seven capsules had a mean offset beyond 0.6 dB (811-1892 -2.6, 811-1897 -1.4, 811-2310 -0.8, 810-8897 +0.8, 810-8901 +0.8, 810-8904 +0.9, 810-8893 +1.3). Absolute level is not anchored: that needs a 94 dB calibrator.</a:t>
             </a:r>
             <a:endParaRPr lang="en-US" dirty="0"/>
           </a:p>
@@ -972,7 +681,7 @@
           <a:p>
             <a:r>
               <a:rPr lang="en-US" dirty="0"/>
-              <a:t>Blue: 30 Sep propeller measurement (11.7 V, 7.3 A, thrust -4 N), read with the 16 Sep microphone corrections. Rms spread about the mean 1.45 dB against 2.05 dB for 31 Aug; range 4.0 dB (55.5 to 59.6 dB SPL) against 6.7 dB. The blue is about 11 dB lower because the motor ran at a different operating point. The 4 dB range of the blue is a bottom-louder trend. Honest caveat: with the same calibration applied to the 1-2 Sep runs, those are about as round as 30 Sep, so most of the improvement against the earlier baselines comes from the microphone calibration, not the room.</a:t>
+              <a:t>Same figure as chapter 1 of the report. The same two captures were calibrated two ways: with the factory files and with the corrections measured on 16 Sep. The span is the range of the capsules mean levels: 4.3 to 0.8 dB at the start of day 3, 4.1 to 1.0 dB in the final configuration. Room error below 3 kHz: 2.277 to 1.997 dB and 1.736 to 1.387 dB. The change is mainly a per-capsule offset, so it mainly moves whole rows.</a:t>
             </a:r>
             <a:endParaRPr lang="en-US" dirty="0"/>
           </a:p>
@@ -996,6 +705,94 @@
             <a:fld id="{F7021451-1387-4CA6-816F-3879F97B5CBC}" type="slidenum">
               <a:rPr lang="en-US"/>
               <a:t>3</a:t>
+            </a:fld>
+            <a:endParaRPr lang="en-US"/>
+          </a:p>
+        </p:txBody>
+      </p:sp>
+    </p:spTree>
+    <p:extLst>
+      <p:ext uri="{BB962C8B-B14F-4D97-AF65-F5344CB8AC3E}">
+        <p14:creationId xmlns:p14="http://schemas.microsoft.com/office/powerpoint/2010/main" val="1024086991"/>
+      </p:ext>
+    </p:extLst>
+  </p:cSld>
+  <p:clrMapOvr>
+    <a:masterClrMapping/>
+  </p:clrMapOvr>
+</p:notes>
+</file>
+
+<file path=ppt/notesSlides/notesSlide4.xml><?xml version="1.0" encoding="utf-8"?>
+<p:notes xmlns:a="http://schemas.openxmlformats.org/drawingml/2006/main" xmlns:r="http://schemas.openxmlformats.org/officeDocument/2006/relationships" xmlns:p="http://schemas.openxmlformats.org/presentationml/2006/main">
+  <p:cSld>
+    <p:spTree>
+      <p:nvGrpSpPr>
+        <p:cNvPr id="1" name=""/>
+        <p:cNvGrpSpPr/>
+        <p:nvPr/>
+      </p:nvGrpSpPr>
+      <p:grpSpPr>
+        <a:xfrm>
+          <a:off x="0" y="0"/>
+          <a:ext cx="0" cy="0"/>
+          <a:chOff x="0" y="0"/>
+          <a:chExt cx="0" cy="0"/>
+        </a:xfrm>
+      </p:grpSpPr>
+      <p:sp>
+        <p:nvSpPr>
+          <p:cNvPr id="2" name="Slide Image Placeholder 1"/>
+          <p:cNvSpPr>
+            <a:spLocks noGrp="1" noRot="1" noChangeAspect="1"/>
+          </p:cNvSpPr>
+          <p:nvPr>
+            <p:ph type="sldImg"/>
+          </p:nvPr>
+        </p:nvSpPr>
+        <p:spPr/>
+      </p:sp>
+      <p:sp>
+        <p:nvSpPr>
+          <p:cNvPr id="3" name="Notes Placeholder 2"/>
+          <p:cNvSpPr>
+            <a:spLocks noGrp="1"/>
+          </p:cNvSpPr>
+          <p:nvPr>
+            <p:ph type="body" idx="1"/>
+          </p:nvPr>
+        </p:nvSpPr>
+        <p:spPr/>
+        <p:txBody>
+          <a:bodyPr/>
+          <a:lstStyle/>
+          <a:p>
+            <a:r>
+              <a:rPr lang="en-US" dirty="0"/>
+              <a:t>Blue: 30 Sep propeller measurement (11.7 V, 7.3 A, thrust -4 N), read with the 16 Sep microphone corrections. Rms spread about the mean 1.45 dB against 2.05 dB for 31 Aug; range 4.0 dB (55.5 to 59.6 dB SPL) against 6.7 dB. The blue is about 11 dB lower because the motor ran at a different operating point. The 4 dB range of the blue is a bottom-louder trend. Honest caveat: with the same calibration applied to the 1-2 Sep runs, those are about as round as 30 Sep, so most of the improvement against the earlier baselines comes from the microphone calibration, not the room.</a:t>
+            </a:r>
+            <a:endParaRPr lang="en-US" dirty="0"/>
+          </a:p>
+        </p:txBody>
+      </p:sp>
+      <p:sp>
+        <p:nvSpPr>
+          <p:cNvPr id="4" name="Slide Number Placeholder 3"/>
+          <p:cNvSpPr>
+            <a:spLocks noGrp="1"/>
+          </p:cNvSpPr>
+          <p:nvPr>
+            <p:ph type="sldNum" sz="quarter" idx="10"/>
+          </p:nvPr>
+        </p:nvSpPr>
+        <p:spPr/>
+        <p:txBody>
+          <a:bodyPr/>
+          <a:lstStyle/>
+          <a:p>
+            <a:fld id="{F7021451-1387-4CA6-816F-3879F97B5CBC}" type="slidenum">
+              <a:rPr lang="en-US"/>
+              <a:t>4</a:t>
             </a:fld>
             <a:endParaRPr lang="en-US"/>
           </a:p>
@@ -1813,8 +1610,8 @@
         </p:blipFill>
         <p:spPr>
           <a:xfrm>
-            <a:off x="548640" y="2103120"/>
-            <a:ext cx="1325880" cy="1508760"/>
+            <a:off x="822960" y="1828800"/>
+            <a:ext cx="1920240" cy="2240280"/>
           </a:xfrm>
           <a:prstGeom prst="rect">
             <a:avLst/>
@@ -1829,8 +1626,8 @@
         </p:nvSpPr>
         <p:spPr>
           <a:xfrm>
-            <a:off x="1874520" y="2514600"/>
-            <a:ext cx="1234440" cy="457200"/>
+            <a:off x="548640" y="4160520"/>
+            <a:ext cx="2468880" cy="320040"/>
           </a:xfrm>
           <a:prstGeom prst="rect">
             <a:avLst/>
@@ -1839,31 +1636,53 @@
           <a:ln/>
         </p:spPr>
         <p:txBody>
-          <a:bodyPr wrap="square" lIns="0" tIns="0" rIns="0" bIns="0" rtlCol="0" anchor="b"/>
+          <a:bodyPr wrap="square" lIns="0" tIns="0" rIns="0" bIns="0" rtlCol="0" anchor="ctr"/>
           <a:lstStyle/>
           <a:p>
             <a:pPr algn="ctr" indent="0" marL="0">
               <a:buNone/>
             </a:pPr>
             <a:r>
-              <a:rPr lang="en-US" sz="1200" dirty="0">
-                <a:solidFill>
-                  <a:srgbClr val="5B6578"/>
+              <a:rPr lang="en-US" sz="1600" dirty="0">
+                <a:solidFill>
+                  <a:srgbClr val="1F2A44"/>
                 </a:solidFill>
                 <a:latin typeface="Calibri" pitchFamily="34" charset="0"/>
                 <a:ea typeface="Calibri" pitchFamily="34" charset="-122"/>
                 <a:cs typeface="Calibri" pitchFamily="34" charset="-120"/>
               </a:rPr>
-              <a:t>tones</a:t>
-            </a:r>
-            <a:endParaRPr lang="en-US" sz="1200" dirty="0"/>
-          </a:p>
+              <a:t>Our loudspeaker</a:t>
+            </a:r>
+            <a:endParaRPr lang="en-US" sz="1600" dirty="0"/>
+          </a:p>
+        </p:txBody>
+      </p:sp>
+      <p:sp>
+        <p:nvSpPr>
+          <p:cNvPr id="6" name="Text 3"/>
+          <p:cNvSpPr txBox="1"/>
+          <p:nvPr/>
+        </p:nvSpPr>
+        <p:spPr>
+          <a:xfrm>
+            <a:off x="3063240" y="2331720"/>
+            <a:ext cx="2194560" cy="320040"/>
+          </a:xfrm>
+          <a:prstGeom prst="rect">
+            <a:avLst/>
+          </a:prstGeom>
+          <a:noFill/>
+          <a:ln/>
+        </p:spPr>
+        <p:txBody>
+          <a:bodyPr wrap="square" lIns="0" tIns="0" rIns="0" bIns="0" rtlCol="0" anchor="ctr"/>
+          <a:lstStyle/>
           <a:p>
             <a:pPr algn="ctr" indent="0" marL="0">
               <a:buNone/>
             </a:pPr>
             <a:r>
-              <a:rPr lang="en-US" sz="1200" dirty="0">
+              <a:rPr lang="en-US" sz="1400" dirty="0">
                 <a:solidFill>
                   <a:srgbClr val="5B6578"/>
                 </a:solidFill>
@@ -1871,28 +1690,28 @@
                 <a:ea typeface="Calibri" pitchFamily="34" charset="-122"/>
                 <a:cs typeface="Calibri" pitchFamily="34" charset="-120"/>
               </a:rPr>
-              <a:t>62 Hz–16 kHz</a:t>
-            </a:r>
-            <a:endParaRPr lang="en-US" sz="1200" dirty="0"/>
-          </a:p>
-        </p:txBody>
-      </p:sp>
-      <p:sp>
-        <p:nvSpPr>
-          <p:cNvPr id="6" name="Shape 3"/>
+              <a:t>tones, 62 Hz–16 kHz</a:t>
+            </a:r>
+            <a:endParaRPr lang="en-US" sz="1400" dirty="0"/>
+          </a:p>
+        </p:txBody>
+      </p:sp>
+      <p:sp>
+        <p:nvSpPr>
+          <p:cNvPr id="7" name="Shape 4"/>
           <p:cNvSpPr/>
           <p:nvPr/>
         </p:nvSpPr>
         <p:spPr>
           <a:xfrm>
-            <a:off x="1965960" y="3063240"/>
-            <a:ext cx="1234440" cy="0"/>
+            <a:off x="3154680" y="2971800"/>
+            <a:ext cx="2011680" cy="0"/>
           </a:xfrm>
           <a:prstGeom prst="line">
             <a:avLst/>
           </a:prstGeom>
           <a:noFill/>
-          <a:ln w="31750">
+          <a:ln w="38100">
             <a:solidFill>
               <a:srgbClr val="D6336C"/>
             </a:solidFill>
@@ -1901,48 +1720,9 @@
           </a:ln>
         </p:spPr>
       </p:sp>
-      <p:sp>
-        <p:nvSpPr>
-          <p:cNvPr id="7" name="Text 4"/>
-          <p:cNvSpPr txBox="1"/>
-          <p:nvPr/>
-        </p:nvSpPr>
-        <p:spPr>
-          <a:xfrm>
-            <a:off x="3291840" y="2194560"/>
-            <a:ext cx="2286000" cy="274320"/>
-          </a:xfrm>
-          <a:prstGeom prst="rect">
-            <a:avLst/>
-          </a:prstGeom>
-          <a:noFill/>
-          <a:ln/>
-        </p:spPr>
-        <p:txBody>
-          <a:bodyPr wrap="square" lIns="0" tIns="0" rIns="0" bIns="0" rtlCol="0" anchor="ctr"/>
-          <a:lstStyle/>
-          <a:p>
-            <a:pPr indent="0" marL="0">
-              <a:buNone/>
-            </a:pPr>
-            <a:r>
-              <a:rPr lang="en-US" sz="1400" dirty="0">
-                <a:solidFill>
-                  <a:srgbClr val="1F2A44"/>
-                </a:solidFill>
-                <a:latin typeface="Calibri" pitchFamily="34" charset="0"/>
-                <a:ea typeface="Calibri" pitchFamily="34" charset="-122"/>
-                <a:cs typeface="Calibri" pitchFamily="34" charset="-120"/>
-              </a:rPr>
-              <a:t>UMIK-2 microphone</a:t>
-            </a:r>
-            <a:endParaRPr lang="en-US" sz="1400" dirty="0"/>
-          </a:p>
-        </p:txBody>
-      </p:sp>
       <p:pic>
         <p:nvPicPr>
-          <p:cNvPr id="8" name="Image 1" descr="UMIK-2 measurement microphone at the mounting point, capsule end on the left facing the loudspeaker">    </p:cNvPr>
+          <p:cNvPr id="8" name="Image 1" descr="UMIK-2 measurement microphone, capsule end on the left facing the loudspeaker">    </p:cNvPr>
           <p:cNvPicPr>
             <a:picLocks noChangeAspect="1"/>
           </p:cNvPicPr>
@@ -1956,8 +1736,8 @@
         </p:blipFill>
         <p:spPr>
           <a:xfrm>
-            <a:off x="3291840" y="2697480"/>
-            <a:ext cx="2743200" cy="741578"/>
+            <a:off x="5394960" y="2514600"/>
+            <a:ext cx="4754880" cy="1284732"/>
           </a:xfrm>
           <a:prstGeom prst="rect">
             <a:avLst/>
@@ -1972,8 +1752,8 @@
         </p:nvSpPr>
         <p:spPr>
           <a:xfrm>
-            <a:off x="3291840" y="3547872"/>
-            <a:ext cx="2926080" cy="256032"/>
+            <a:off x="5394960" y="3931920"/>
+            <a:ext cx="6217920" cy="320040"/>
           </a:xfrm>
           <a:prstGeom prst="rect">
             <a:avLst/>
@@ -1989,7 +1769,7 @@
               <a:buNone/>
             </a:pPr>
             <a:r>
-              <a:rPr lang="en-US" sz="1300" b="1" dirty="0">
+              <a:rPr lang="en-US" sz="1600" b="1" dirty="0">
                 <a:solidFill>
                   <a:srgbClr val="2B6CB0"/>
                 </a:solidFill>
@@ -1997,9 +1777,9 @@
                 <a:ea typeface="Calibri" pitchFamily="34" charset="-122"/>
                 <a:cs typeface="Calibri" pitchFamily="34" charset="-120"/>
               </a:rPr>
-              <a:t>capsule faces the loudspeaker</a:t>
-            </a:r>
-            <a:endParaRPr lang="en-US" sz="1300" dirty="0"/>
+              <a:t>UMIK-2 microphone, capsule faces the loudspeaker</a:t>
+            </a:r>
+            <a:endParaRPr lang="en-US" sz="1600" dirty="0"/>
           </a:p>
         </p:txBody>
       </p:sp>
@@ -2011,8 +1791,8 @@
         </p:nvSpPr>
         <p:spPr>
           <a:xfrm>
-            <a:off x="365760" y="3703320"/>
-            <a:ext cx="1691640" cy="274320"/>
+            <a:off x="548640" y="4754880"/>
+            <a:ext cx="6400800" cy="1508760"/>
           </a:xfrm>
           <a:prstGeom prst="rect">
             <a:avLst/>
@@ -2021,11 +1801,15 @@
           <a:ln/>
         </p:spPr>
         <p:txBody>
-          <a:bodyPr wrap="square" lIns="0" tIns="0" rIns="0" bIns="0" rtlCol="0" anchor="ctr"/>
-          <a:lstStyle/>
-          <a:p>
-            <a:pPr algn="ctr" indent="0" marL="0">
-              <a:buNone/>
+          <a:bodyPr wrap="square" lIns="0" tIns="0" rIns="0" bIns="0" rtlCol="0" anchor="t"/>
+          <a:lstStyle/>
+          <a:p>
+            <a:pPr marL="342900" indent="-342900">
+              <a:spcAft>
+                <a:spcPts val="500"/>
+              </a:spcAft>
+              <a:buSzPct val="100000"/>
+              <a:buChar char="•"/>
             </a:pPr>
             <a:r>
               <a:rPr lang="en-US" sz="1400" dirty="0">
@@ -2036,36 +1820,14 @@
                 <a:ea typeface="Calibri" pitchFamily="34" charset="-122"/>
                 <a:cs typeface="Calibri" pitchFamily="34" charset="-120"/>
               </a:rPr>
-              <a:t>Our loudspeaker</a:t>
+              <a:t>97 tones per microphone, 62 Hz to 16 kHz, 12 per octave (a stepped sweep)</a:t>
             </a:r>
             <a:endParaRPr lang="en-US" sz="1400" dirty="0"/>
           </a:p>
-        </p:txBody>
-      </p:sp>
-      <p:sp>
-        <p:nvSpPr>
-          <p:cNvPr id="11" name="Text 7"/>
-          <p:cNvSpPr txBox="1"/>
-          <p:nvPr/>
-        </p:nvSpPr>
-        <p:spPr>
-          <a:xfrm>
-            <a:off x="548640" y="4434840"/>
-            <a:ext cx="6126480" cy="1783080"/>
-          </a:xfrm>
-          <a:prstGeom prst="rect">
-            <a:avLst/>
-          </a:prstGeom>
-          <a:noFill/>
-          <a:ln/>
-        </p:spPr>
-        <p:txBody>
-          <a:bodyPr wrap="square" lIns="0" tIns="0" rIns="0" bIns="0" rtlCol="0" anchor="t"/>
-          <a:lstStyle/>
           <a:p>
             <a:pPr marL="342900" indent="-342900">
               <a:spcAft>
-                <a:spcPts val="600"/>
+                <a:spcPts val="500"/>
               </a:spcAft>
               <a:buSzPct val="100000"/>
               <a:buChar char="•"/>
@@ -2079,14 +1841,14 @@
                 <a:ea typeface="Calibri" pitchFamily="34" charset="-122"/>
                 <a:cs typeface="Calibri" pitchFamily="34" charset="-120"/>
               </a:rPr>
-              <a:t>97 tones per microphone, 62 Hz to 16 kHz, 12 per octave (a stepped sweep)</a:t>
+              <a:t>One tone at a time: 0.7 s to settle, then 2 s recorded (6 s below 250 Hz)</a:t>
             </a:r>
             <a:endParaRPr lang="en-US" sz="1400" dirty="0"/>
           </a:p>
           <a:p>
             <a:pPr marL="342900" indent="-342900">
               <a:spcAft>
-                <a:spcPts val="600"/>
+                <a:spcPts val="500"/>
               </a:spcAft>
               <a:buSzPct val="100000"/>
               <a:buChar char="•"/>
@@ -2100,14 +1862,14 @@
                 <a:ea typeface="Calibri" pitchFamily="34" charset="-122"/>
                 <a:cs typeface="Calibri" pitchFamily="34" charset="-120"/>
               </a:rPr>
-              <a:t>One tone at a time: 0.7 s to settle, then 2 s recorded (6 s below 250 Hz)</a:t>
+              <a:t>Microphones swapped in turn: same position, same loudspeaker, same level</a:t>
             </a:r>
             <a:endParaRPr lang="en-US" sz="1400" dirty="0"/>
           </a:p>
           <a:p>
             <a:pPr marL="342900" indent="-342900">
               <a:spcAft>
-                <a:spcPts val="600"/>
+                <a:spcPts val="500"/>
               </a:spcAft>
               <a:buSzPct val="100000"/>
               <a:buChar char="•"/>
@@ -2121,97 +1883,115 @@
                 <a:ea typeface="Calibri" pitchFamily="34" charset="-122"/>
                 <a:cs typeface="Calibri" pitchFamily="34" charset="-120"/>
               </a:rPr>
-              <a:t>Microphones swapped in turn: same position, same loudspeaker, same level</a:t>
+              <a:t>One microphone measured three times as the reference</a:t>
             </a:r>
             <a:endParaRPr lang="en-US" sz="1400" dirty="0"/>
           </a:p>
-          <a:p>
-            <a:pPr marL="342900" indent="-342900">
-              <a:spcAft>
-                <a:spcPts val="600"/>
-              </a:spcAft>
-              <a:buSzPct val="100000"/>
-              <a:buChar char="•"/>
+        </p:txBody>
+      </p:sp>
+      <p:sp>
+        <p:nvSpPr>
+          <p:cNvPr id="11" name="Text 7"/>
+          <p:cNvSpPr txBox="1"/>
+          <p:nvPr/>
+        </p:nvSpPr>
+        <p:spPr>
+          <a:xfrm>
+            <a:off x="7498080" y="4617720"/>
+            <a:ext cx="4206240" cy="685800"/>
+          </a:xfrm>
+          <a:prstGeom prst="rect">
+            <a:avLst/>
+          </a:prstGeom>
+          <a:noFill/>
+          <a:ln/>
+        </p:spPr>
+        <p:txBody>
+          <a:bodyPr wrap="square" lIns="0" tIns="0" rIns="0" bIns="0" rtlCol="0" anchor="ctr"/>
+          <a:lstStyle/>
+          <a:p>
+            <a:pPr indent="0" marL="0">
+              <a:buNone/>
+            </a:pPr>
+            <a:r>
+              <a:rPr lang="en-US" sz="4000" b="1" dirty="0">
+                <a:solidFill>
+                  <a:srgbClr val="D6336C"/>
+                </a:solidFill>
+                <a:latin typeface="Cambria" pitchFamily="34" charset="0"/>
+                <a:ea typeface="Cambria" pitchFamily="34" charset="-122"/>
+                <a:cs typeface="Cambria" pitchFamily="34" charset="-120"/>
+              </a:rPr>
+              <a:t>4.01</a:t>
+            </a:r>
+            <a:pPr indent="0" marL="0">
+              <a:buNone/>
+            </a:pPr>
+            <a:r>
+              <a:rPr lang="en-US" sz="4000" b="1" dirty="0">
+                <a:solidFill>
+                  <a:srgbClr val="5B6578"/>
+                </a:solidFill>
+                <a:latin typeface="Cambria" pitchFamily="34" charset="0"/>
+                <a:ea typeface="Cambria" pitchFamily="34" charset="-122"/>
+                <a:cs typeface="Cambria" pitchFamily="34" charset="-120"/>
+              </a:rPr>
+              <a:t> → </a:t>
+            </a:r>
+            <a:pPr indent="0" marL="0">
+              <a:buNone/>
+            </a:pPr>
+            <a:r>
+              <a:rPr lang="en-US" sz="4000" b="1" dirty="0">
+                <a:solidFill>
+                  <a:srgbClr val="2B6CB0"/>
+                </a:solidFill>
+                <a:latin typeface="Cambria" pitchFamily="34" charset="0"/>
+                <a:ea typeface="Cambria" pitchFamily="34" charset="-122"/>
+                <a:cs typeface="Cambria" pitchFamily="34" charset="-120"/>
+              </a:rPr>
+              <a:t>0.02 dB</a:t>
+            </a:r>
+            <a:endParaRPr lang="en-US" sz="4000" dirty="0"/>
+          </a:p>
+        </p:txBody>
+      </p:sp>
+      <p:sp>
+        <p:nvSpPr>
+          <p:cNvPr id="12" name="Text 8"/>
+          <p:cNvSpPr txBox="1"/>
+          <p:nvPr/>
+        </p:nvSpPr>
+        <p:spPr>
+          <a:xfrm>
+            <a:off x="7498080" y="5303520"/>
+            <a:ext cx="4206240" cy="457200"/>
+          </a:xfrm>
+          <a:prstGeom prst="rect">
+            <a:avLst/>
+          </a:prstGeom>
+          <a:noFill/>
+          <a:ln/>
+        </p:spPr>
+        <p:txBody>
+          <a:bodyPr wrap="square" lIns="0" tIns="0" rIns="0" bIns="0" rtlCol="0" anchor="t"/>
+          <a:lstStyle/>
+          <a:p>
+            <a:pPr indent="0" marL="0">
+              <a:buNone/>
             </a:pPr>
             <a:r>
               <a:rPr lang="en-US" sz="1400" dirty="0">
                 <a:solidFill>
-                  <a:srgbClr val="1F2A44"/>
+                  <a:srgbClr val="5B6578"/>
                 </a:solidFill>
                 <a:latin typeface="Calibri" pitchFamily="34" charset="0"/>
                 <a:ea typeface="Calibri" pitchFamily="34" charset="-122"/>
                 <a:cs typeface="Calibri" pitchFamily="34" charset="-120"/>
               </a:rPr>
-              <a:t>One microphone measured three times as the reference</a:t>
+              <a:t>spread across the eleven microphones for the same sound</a:t>
             </a:r>
             <a:endParaRPr lang="en-US" sz="1400" dirty="0"/>
-          </a:p>
-        </p:txBody>
-      </p:sp>
-      <p:sp>
-        <p:nvSpPr>
-          <p:cNvPr id="12" name="Text 8"/>
-          <p:cNvSpPr txBox="1"/>
-          <p:nvPr/>
-        </p:nvSpPr>
-        <p:spPr>
-          <a:xfrm>
-            <a:off x="7223760" y="1783080"/>
-            <a:ext cx="4480560" cy="731520"/>
-          </a:xfrm>
-          <a:prstGeom prst="rect">
-            <a:avLst/>
-          </a:prstGeom>
-          <a:noFill/>
-          <a:ln/>
-        </p:spPr>
-        <p:txBody>
-          <a:bodyPr wrap="square" lIns="0" tIns="0" rIns="0" bIns="0" rtlCol="0" anchor="ctr"/>
-          <a:lstStyle/>
-          <a:p>
-            <a:pPr indent="0" marL="0">
-              <a:buNone/>
-            </a:pPr>
-            <a:r>
-              <a:rPr lang="en-US" sz="4400" b="1" dirty="0">
-                <a:solidFill>
-                  <a:srgbClr val="D6336C"/>
-                </a:solidFill>
-                <a:latin typeface="Cambria" pitchFamily="34" charset="0"/>
-                <a:ea typeface="Cambria" pitchFamily="34" charset="-122"/>
-                <a:cs typeface="Cambria" pitchFamily="34" charset="-120"/>
-              </a:rPr>
-              <a:t>4.01</a:t>
-            </a:r>
-            <a:pPr indent="0" marL="0">
-              <a:buNone/>
-            </a:pPr>
-            <a:r>
-              <a:rPr lang="en-US" sz="4400" b="1" dirty="0">
-                <a:solidFill>
-                  <a:srgbClr val="5B6578"/>
-                </a:solidFill>
-                <a:latin typeface="Cambria" pitchFamily="34" charset="0"/>
-                <a:ea typeface="Cambria" pitchFamily="34" charset="-122"/>
-                <a:cs typeface="Cambria" pitchFamily="34" charset="-120"/>
-              </a:rPr>
-              <a:t> → </a:t>
-            </a:r>
-            <a:pPr indent="0" marL="0">
-              <a:buNone/>
-            </a:pPr>
-            <a:r>
-              <a:rPr lang="en-US" sz="4400" b="1" dirty="0">
-                <a:solidFill>
-                  <a:srgbClr val="2B6CB0"/>
-                </a:solidFill>
-                <a:latin typeface="Cambria" pitchFamily="34" charset="0"/>
-                <a:ea typeface="Cambria" pitchFamily="34" charset="-122"/>
-                <a:cs typeface="Cambria" pitchFamily="34" charset="-120"/>
-              </a:rPr>
-              <a:t>0.02 dB</a:t>
-            </a:r>
-            <a:endParaRPr lang="en-US" sz="4400" dirty="0"/>
           </a:p>
         </p:txBody>
       </p:sp>
@@ -2223,8 +2003,8 @@
         </p:nvSpPr>
         <p:spPr>
           <a:xfrm>
-            <a:off x="7223760" y="2514600"/>
-            <a:ext cx="4480560" cy="502920"/>
+            <a:off x="7498080" y="5806440"/>
+            <a:ext cx="4206240" cy="457200"/>
           </a:xfrm>
           <a:prstGeom prst="rect">
             <a:avLst/>
@@ -2240,15 +2020,15 @@
               <a:buNone/>
             </a:pPr>
             <a:r>
-              <a:rPr lang="en-US" sz="1400" dirty="0">
-                <a:solidFill>
-                  <a:srgbClr val="5B6578"/>
+              <a:rPr lang="en-US" sz="1400" b="1" dirty="0">
+                <a:solidFill>
+                  <a:srgbClr val="1F2A44"/>
                 </a:solidFill>
                 <a:latin typeface="Calibri" pitchFamily="34" charset="0"/>
                 <a:ea typeface="Calibri" pitchFamily="34" charset="-122"/>
                 <a:cs typeface="Calibri" pitchFamily="34" charset="-120"/>
               </a:rPr>
-              <a:t>spread across the eleven microphones for the same sound</a:t>
+              <a:t>7 of 11 factory files were wrong by 0.6–3.6 dB</a:t>
             </a:r>
             <a:endParaRPr lang="en-US" sz="1400" dirty="0"/>
           </a:p>
@@ -2262,8 +2042,8 @@
         </p:nvSpPr>
         <p:spPr>
           <a:xfrm>
-            <a:off x="7223760" y="3017520"/>
-            <a:ext cx="4480560" cy="320040"/>
+            <a:off x="548640" y="6355080"/>
+            <a:ext cx="10332720" cy="274320"/>
           </a:xfrm>
           <a:prstGeom prst="rect">
             <a:avLst/>
@@ -2279,117 +2059,23 @@
               <a:buNone/>
             </a:pPr>
             <a:r>
-              <a:rPr lang="en-US" sz="1400" b="1" dirty="0">
-                <a:solidFill>
-                  <a:srgbClr val="1F2A44"/>
+              <a:rPr lang="en-US" sz="1100" dirty="0">
+                <a:solidFill>
+                  <a:srgbClr val="5B6578"/>
                 </a:solidFill>
                 <a:latin typeface="Calibri" pitchFamily="34" charset="0"/>
                 <a:ea typeface="Calibri" pitchFamily="34" charset="-122"/>
                 <a:cs typeface="Calibri" pitchFamily="34" charset="-120"/>
               </a:rPr>
-              <a:t>7 of 11 factory files were wrong by 0.6–3.6 dB</a:t>
-            </a:r>
-            <a:endParaRPr lang="en-US" sz="1400" dirty="0"/>
+              <a:t>Calibration session 16 Sep 2026, loudspeaker amplitude 0.03 of full scale. UMIK-2 photo: miniDSP product brief.</a:t>
+            </a:r>
+            <a:endParaRPr lang="en-US" sz="1100" dirty="0"/>
           </a:p>
         </p:txBody>
       </p:sp>
       <p:sp>
         <p:nvSpPr>
           <p:cNvPr id="15" name="Text 11"/>
-          <p:cNvSpPr txBox="1"/>
-          <p:nvPr/>
-        </p:nvSpPr>
-        <p:spPr>
-          <a:xfrm>
-            <a:off x="7223760" y="3383280"/>
-            <a:ext cx="4480560" cy="411480"/>
-          </a:xfrm>
-          <a:prstGeom prst="rect">
-            <a:avLst/>
-          </a:prstGeom>
-          <a:noFill/>
-          <a:ln/>
-        </p:spPr>
-        <p:txBody>
-          <a:bodyPr wrap="square" lIns="0" tIns="0" rIns="0" bIns="0" rtlCol="0" anchor="t"/>
-          <a:lstStyle/>
-          <a:p>
-            <a:pPr indent="0" marL="0">
-              <a:buNone/>
-            </a:pPr>
-            <a:r>
-              <a:rPr lang="en-US" sz="1100" dirty="0">
-                <a:solidFill>
-                  <a:srgbClr val="5B6578"/>
-                </a:solidFill>
-                <a:latin typeface="Calibri" pitchFamily="34" charset="0"/>
-                <a:ea typeface="Calibri" pitchFamily="34" charset="-122"/>
-                <a:cs typeface="Calibri" pitchFamily="34" charset="-120"/>
-              </a:rPr>
-              <a:t>Each factory file against the common reference, mean over frequency (dB): below 0 reads too quiet, above 0 too loud</a:t>
-            </a:r>
-            <a:endParaRPr lang="en-US" sz="1100" dirty="0"/>
-          </a:p>
-        </p:txBody>
-      </p:sp>
-      <p:graphicFrame>
-        <p:nvGraphicFramePr>
-          <p:cNvPr id="16" name="Chart 0" descr=""/>
-          <p:cNvGraphicFramePr/>
-          <p:nvPr/>
-        </p:nvGraphicFramePr>
-        <p:xfrm>
-          <a:off x="7132320" y="3749040"/>
-          <a:ext cx="4572000" cy="2606040"/>
-        </p:xfrm>
-        <a:graphic xmlns:a="http://schemas.openxmlformats.org/drawingml/2006/main">
-          <a:graphicData uri="http://schemas.openxmlformats.org/drawingml/2006/chart">
-            <c:chart xmlns:c="http://schemas.openxmlformats.org/drawingml/2006/chart" r:id="rId3"/>
-          </a:graphicData>
-        </a:graphic>
-      </p:graphicFrame>
-      <p:sp>
-        <p:nvSpPr>
-          <p:cNvPr id="17" name="Text 12"/>
-          <p:cNvSpPr txBox="1"/>
-          <p:nvPr/>
-        </p:nvSpPr>
-        <p:spPr>
-          <a:xfrm>
-            <a:off x="548640" y="6355080"/>
-            <a:ext cx="10332720" cy="274320"/>
-          </a:xfrm>
-          <a:prstGeom prst="rect">
-            <a:avLst/>
-          </a:prstGeom>
-          <a:noFill/>
-          <a:ln/>
-        </p:spPr>
-        <p:txBody>
-          <a:bodyPr wrap="square" lIns="0" tIns="0" rIns="0" bIns="0" rtlCol="0" anchor="ctr"/>
-          <a:lstStyle/>
-          <a:p>
-            <a:pPr indent="0" marL="0">
-              <a:buNone/>
-            </a:pPr>
-            <a:r>
-              <a:rPr lang="en-US" sz="1100" dirty="0">
-                <a:solidFill>
-                  <a:srgbClr val="5B6578"/>
-                </a:solidFill>
-                <a:latin typeface="Calibri" pitchFamily="34" charset="0"/>
-                <a:ea typeface="Calibri" pitchFamily="34" charset="-122"/>
-                <a:cs typeface="Calibri" pitchFamily="34" charset="-120"/>
-              </a:rPr>
-              <a:t>Calibration session 16 Sep 2026, loudspeaker amplitude 0.03 of full scale. UMIK-2 photo: miniDSP product brief.</a:t>
-            </a:r>
-            <a:endParaRPr lang="en-US" sz="1100" dirty="0"/>
-          </a:p>
-        </p:txBody>
-      </p:sp>
-      <p:sp>
-        <p:nvSpPr>
-          <p:cNvPr id="18" name="Text 13"/>
           <p:cNvSpPr txBox="1"/>
           <p:nvPr/>
         </p:nvSpPr>
@@ -2460,7 +2146,7 @@
       </p:grpSpPr>
       <p:pic>
         <p:nvPicPr>
-          <p:cNvPr id="2" name="Image 0" descr="Polar plot of 20 to 560 Hz: the jagged red 31 Aug outline and the smoother blue 30 Sep outline">    </p:cNvPr>
+          <p:cNvPr id="2" name="Image 0" descr="Maps of each microphone against frequency for two captures: factory files (top), corrected (middle), effect of the correction (bottom)">    </p:cNvPr>
           <p:cNvPicPr>
             <a:picLocks noChangeAspect="1"/>
           </p:cNvPicPr>
@@ -2474,8 +2160,8 @@
         </p:blipFill>
         <p:spPr>
           <a:xfrm>
-            <a:off x="548640" y="457200"/>
-            <a:ext cx="5440680" cy="5797296"/>
+            <a:off x="457200" y="411480"/>
+            <a:ext cx="5623560" cy="5669280"/>
           </a:xfrm>
           <a:prstGeom prst="rect">
             <a:avLst/>
@@ -2490,8 +2176,8 @@
         </p:nvSpPr>
         <p:spPr>
           <a:xfrm>
-            <a:off x="6766560" y="822960"/>
-            <a:ext cx="4846320" cy="365760"/>
+            <a:off x="6583680" y="822960"/>
+            <a:ext cx="5029200" cy="365760"/>
           </a:xfrm>
           <a:prstGeom prst="rect">
             <a:avLst/>
@@ -2515,7 +2201,7 @@
                 <a:ea typeface="Calibri" pitchFamily="34" charset="-122"/>
                 <a:cs typeface="Calibri" pitchFamily="34" charset="-120"/>
               </a:rPr>
-              <a:t>AFTER</a:t>
+              <a:t>THE RESULT</a:t>
             </a:r>
             <a:endParaRPr lang="en-US" sz="1400" dirty="0"/>
           </a:p>
@@ -2529,8 +2215,8 @@
         </p:nvSpPr>
         <p:spPr>
           <a:xfrm>
-            <a:off x="6766560" y="1188720"/>
-            <a:ext cx="4846320" cy="1188720"/>
+            <a:off x="6583680" y="1188720"/>
+            <a:ext cx="5029200" cy="1280160"/>
           </a:xfrm>
           <a:prstGeom prst="rect">
             <a:avLst/>
@@ -2546,7 +2232,7 @@
               <a:buNone/>
             </a:pPr>
             <a:r>
-              <a:rPr lang="en-US" sz="3400" b="1" dirty="0">
+              <a:rPr lang="en-US" sz="3200" b="1" dirty="0">
                 <a:solidFill>
                   <a:srgbClr val="1F2A44"/>
                 </a:solidFill>
@@ -2554,9 +2240,9 @@
                 <a:ea typeface="Cambria" pitchFamily="34" charset="-122"/>
                 <a:cs typeface="Cambria" pitchFamily="34" charset="-120"/>
               </a:rPr>
-              <a:t>The new polar is rounder</a:t>
-            </a:r>
-            <a:endParaRPr lang="en-US" sz="3400" dirty="0"/>
+              <a:t>The correction removes the microphone offsets</a:t>
+            </a:r>
+            <a:endParaRPr lang="en-US" sz="3200" dirty="0"/>
           </a:p>
         </p:txBody>
       </p:sp>
@@ -2568,8 +2254,8 @@
         </p:nvSpPr>
         <p:spPr>
           <a:xfrm>
-            <a:off x="6766560" y="2514600"/>
-            <a:ext cx="4846320" cy="2377440"/>
+            <a:off x="6583680" y="2606040"/>
+            <a:ext cx="5029200" cy="2286000"/>
           </a:xfrm>
           <a:prstGeom prst="rect">
             <a:avLst/>
@@ -2597,7 +2283,7 @@
                 <a:ea typeface="Calibri" pitchFamily="34" charset="-122"/>
                 <a:cs typeface="Calibri" pitchFamily="34" charset="-120"/>
               </a:rPr>
-              <a:t>Same kind of measurement, same axes, on 30 Sep.</a:t>
+              <a:t>Top row: read with the factory files. Middle row: read with the measured corrections. Bottom row: what the correction changed.</a:t>
             </a:r>
             <a:endParaRPr lang="en-US" sz="1600" dirty="0"/>
           </a:p>
@@ -2618,7 +2304,7 @@
                 <a:ea typeface="Calibri" pitchFamily="34" charset="-122"/>
                 <a:cs typeface="Calibri" pitchFamily="34" charset="-120"/>
               </a:rPr>
-              <a:t>The microphones now carry their measured corrections, and the room has been treated.</a:t>
+              <a:t>Horizontal stripes across all frequencies are one microphone reading too loud or too quiet. They are gone in the middle row.</a:t>
             </a:r>
             <a:endParaRPr lang="en-US" sz="1600" dirty="0"/>
           </a:p>
@@ -2631,7 +2317,7 @@
               <a:buChar char="•"/>
             </a:pPr>
             <a:r>
-              <a:rPr lang="en-US" sz="1600" b="1" dirty="0">
+              <a:rPr lang="en-US" sz="1600" dirty="0">
                 <a:solidFill>
                   <a:srgbClr val="1F2A44"/>
                 </a:solidFill>
@@ -2639,7 +2325,7 @@
                 <a:ea typeface="Calibri" pitchFamily="34" charset="-122"/>
                 <a:cs typeface="Calibri" pitchFamily="34" charset="-120"/>
               </a:rPr>
-              <a:t>The outline is smooth and close to a circle.</a:t>
+              <a:t>The pattern of the room stays: the correction moves whole rows, not the frequency structure.</a:t>
             </a:r>
             <a:endParaRPr lang="en-US" sz="1600" dirty="0"/>
           </a:p>
@@ -2653,8 +2339,8 @@
         </p:nvSpPr>
         <p:spPr>
           <a:xfrm>
-            <a:off x="6766560" y="5029200"/>
-            <a:ext cx="4846320" cy="731520"/>
+            <a:off x="6583680" y="5029200"/>
+            <a:ext cx="5029200" cy="731520"/>
           </a:xfrm>
           <a:prstGeom prst="rect">
             <a:avLst/>
@@ -2670,7 +2356,7 @@
               <a:buNone/>
             </a:pPr>
             <a:r>
-              <a:rPr lang="en-US" sz="4800" b="1" dirty="0">
+              <a:rPr lang="en-US" sz="4400" b="1" dirty="0">
                 <a:solidFill>
                   <a:srgbClr val="D6336C"/>
                 </a:solidFill>
@@ -2678,13 +2364,13 @@
                 <a:ea typeface="Cambria" pitchFamily="34" charset="-122"/>
                 <a:cs typeface="Cambria" pitchFamily="34" charset="-120"/>
               </a:rPr>
-              <a:t>6.7</a:t>
+              <a:t>4.3</a:t>
             </a:r>
             <a:pPr indent="0" marL="0">
               <a:buNone/>
             </a:pPr>
             <a:r>
-              <a:rPr lang="en-US" sz="4800" b="1" dirty="0">
+              <a:rPr lang="en-US" sz="4400" b="1" dirty="0">
                 <a:solidFill>
                   <a:srgbClr val="5B6578"/>
                 </a:solidFill>
@@ -2698,7 +2384,7 @@
               <a:buNone/>
             </a:pPr>
             <a:r>
-              <a:rPr lang="en-US" sz="4800" b="1" dirty="0">
+              <a:rPr lang="en-US" sz="4400" b="1" dirty="0">
                 <a:solidFill>
                   <a:srgbClr val="2B6CB0"/>
                 </a:solidFill>
@@ -2706,9 +2392,9 @@
                 <a:ea typeface="Cambria" pitchFamily="34" charset="-122"/>
                 <a:cs typeface="Cambria" pitchFamily="34" charset="-120"/>
               </a:rPr>
-              <a:t>4.0 dB</a:t>
-            </a:r>
-            <a:endParaRPr lang="en-US" sz="4800" dirty="0"/>
+              <a:t>0.8 dB</a:t>
+            </a:r>
+            <a:endParaRPr lang="en-US" sz="4400" dirty="0"/>
           </a:p>
         </p:txBody>
       </p:sp>
@@ -2720,8 +2406,8 @@
         </p:nvSpPr>
         <p:spPr>
           <a:xfrm>
-            <a:off x="6766560" y="5760720"/>
-            <a:ext cx="4846320" cy="457200"/>
+            <a:off x="6583680" y="5760720"/>
+            <a:ext cx="5029200" cy="457200"/>
           </a:xfrm>
           <a:prstGeom prst="rect">
             <a:avLst/>
@@ -2730,7 +2416,7 @@
           <a:ln/>
         </p:spPr>
         <p:txBody>
-          <a:bodyPr wrap="square" lIns="0" tIns="0" rIns="0" bIns="0" rtlCol="0" anchor="ctr"/>
+          <a:bodyPr wrap="square" lIns="0" tIns="0" rIns="0" bIns="0" rtlCol="0" anchor="t"/>
           <a:lstStyle/>
           <a:p>
             <a:pPr indent="0" marL="0">
@@ -2745,7 +2431,7 @@
                 <a:ea typeface="Calibri" pitchFamily="34" charset="-122"/>
                 <a:cs typeface="Calibri" pitchFamily="34" charset="-120"/>
               </a:rPr>
-              <a:t>between the loudest and quietest microphone</a:t>
+              <a:t>range of the microphones’ mean levels, start of day 3 (final state: 4.1 → 1.0 dB)</a:t>
             </a:r>
             <a:endParaRPr lang="en-US" sz="1400" dirty="0"/>
           </a:p>
@@ -2760,7 +2446,7 @@
         <p:spPr>
           <a:xfrm>
             <a:off x="548640" y="6355080"/>
-            <a:ext cx="11064240" cy="274320"/>
+            <a:ext cx="10332720" cy="274320"/>
           </a:xfrm>
           <a:prstGeom prst="rect">
             <a:avLst/>
@@ -2784,7 +2470,7 @@
                 <a:ea typeface="Calibri" pitchFamily="34" charset="-122"/>
                 <a:cs typeface="Calibri" pitchFamily="34" charset="-120"/>
               </a:rPr>
-              <a:t>20–560 Hz, motor at 2000 µs. The two runs had different operating points (7.35 V against 11.7 V), which is why the blue is lower.</a:t>
+              <a:t>Captures from 25 Sep 2026: day3-a (left) and carpet-reordered (right), 257 Hz–6 kHz, 3–5 kHz omitted.</a:t>
             </a:r>
             <a:endParaRPr lang="en-US" sz="1100" dirty="0"/>
           </a:p>
@@ -2824,6 +2510,409 @@
                 <a:cs typeface="Calibri" pitchFamily="34" charset="-120"/>
               </a:rPr>
               <a:t>3</a:t>
+            </a:r>
+            <a:endParaRPr lang="en-US" sz="1200" dirty="0"/>
+          </a:p>
+        </p:txBody>
+      </p:sp>
+    </p:spTree>
+  </p:cSld>
+  <p:clrMapOvr>
+    <a:masterClrMapping/>
+  </p:clrMapOvr>
+</p:sld>
+</file>
+
+<file path=ppt/slides/slide4.xml><?xml version="1.0" encoding="utf-8"?>
+<p:sld xmlns:a="http://schemas.openxmlformats.org/drawingml/2006/main" xmlns:r="http://schemas.openxmlformats.org/officeDocument/2006/relationships" xmlns:p="http://schemas.openxmlformats.org/presentationml/2006/main">
+  <p:cSld name="Slide 4">
+    <p:bg>
+      <p:bgPr>
+        <a:solidFill>
+          <a:srgbClr val="FFFFFF"/>
+        </a:solidFill>
+      </p:bgPr>
+    </p:bg>
+    <p:spTree>
+      <p:nvGrpSpPr>
+        <p:cNvPr id="1" name=""/>
+        <p:cNvGrpSpPr/>
+        <p:nvPr/>
+      </p:nvGrpSpPr>
+      <p:grpSpPr>
+        <a:xfrm>
+          <a:off x="0" y="0"/>
+          <a:ext cx="0" cy="0"/>
+          <a:chOff x="0" y="0"/>
+          <a:chExt cx="0" cy="0"/>
+        </a:xfrm>
+      </p:grpSpPr>
+      <p:pic>
+        <p:nvPicPr>
+          <p:cNvPr id="2" name="Image 0" descr="Polar plot of 20 to 560 Hz: the jagged red 31 Aug outline and the smoother blue 30 Sep outline">    </p:cNvPr>
+          <p:cNvPicPr>
+            <a:picLocks noChangeAspect="1"/>
+          </p:cNvPicPr>
+          <p:nvPr/>
+        </p:nvPicPr>
+        <p:blipFill>
+          <a:blip r:embed="rId1"/>
+          <a:stretch>
+            <a:fillRect/>
+          </a:stretch>
+        </p:blipFill>
+        <p:spPr>
+          <a:xfrm>
+            <a:off x="548640" y="457200"/>
+            <a:ext cx="5440680" cy="5797296"/>
+          </a:xfrm>
+          <a:prstGeom prst="rect">
+            <a:avLst/>
+          </a:prstGeom>
+        </p:spPr>
+      </p:pic>
+      <p:sp>
+        <p:nvSpPr>
+          <p:cNvPr id="3" name="Text 0"/>
+          <p:cNvSpPr txBox="1"/>
+          <p:nvPr/>
+        </p:nvSpPr>
+        <p:spPr>
+          <a:xfrm>
+            <a:off x="6766560" y="822960"/>
+            <a:ext cx="4846320" cy="365760"/>
+          </a:xfrm>
+          <a:prstGeom prst="rect">
+            <a:avLst/>
+          </a:prstGeom>
+          <a:noFill/>
+          <a:ln/>
+        </p:spPr>
+        <p:txBody>
+          <a:bodyPr wrap="square" lIns="0" tIns="0" rIns="0" bIns="0" rtlCol="0" anchor="ctr"/>
+          <a:lstStyle/>
+          <a:p>
+            <a:pPr indent="0" marL="0">
+              <a:buNone/>
+            </a:pPr>
+            <a:r>
+              <a:rPr lang="en-US" sz="1400" b="1" spc="300" kern="0" dirty="0">
+                <a:solidFill>
+                  <a:srgbClr val="2B6CB0"/>
+                </a:solidFill>
+                <a:latin typeface="Calibri" pitchFamily="34" charset="0"/>
+                <a:ea typeface="Calibri" pitchFamily="34" charset="-122"/>
+                <a:cs typeface="Calibri" pitchFamily="34" charset="-120"/>
+              </a:rPr>
+              <a:t>AFTER</a:t>
+            </a:r>
+            <a:endParaRPr lang="en-US" sz="1400" dirty="0"/>
+          </a:p>
+        </p:txBody>
+      </p:sp>
+      <p:sp>
+        <p:nvSpPr>
+          <p:cNvPr id="4" name="Text 1"/>
+          <p:cNvSpPr txBox="1"/>
+          <p:nvPr/>
+        </p:nvSpPr>
+        <p:spPr>
+          <a:xfrm>
+            <a:off x="6766560" y="1188720"/>
+            <a:ext cx="4846320" cy="1188720"/>
+          </a:xfrm>
+          <a:prstGeom prst="rect">
+            <a:avLst/>
+          </a:prstGeom>
+          <a:noFill/>
+          <a:ln/>
+        </p:spPr>
+        <p:txBody>
+          <a:bodyPr wrap="square" lIns="0" tIns="0" rIns="0" bIns="0" rtlCol="0" anchor="t"/>
+          <a:lstStyle/>
+          <a:p>
+            <a:pPr indent="0" marL="0">
+              <a:buNone/>
+            </a:pPr>
+            <a:r>
+              <a:rPr lang="en-US" sz="3400" b="1" dirty="0">
+                <a:solidFill>
+                  <a:srgbClr val="1F2A44"/>
+                </a:solidFill>
+                <a:latin typeface="Cambria" pitchFamily="34" charset="0"/>
+                <a:ea typeface="Cambria" pitchFamily="34" charset="-122"/>
+                <a:cs typeface="Cambria" pitchFamily="34" charset="-120"/>
+              </a:rPr>
+              <a:t>The new polar is rounder</a:t>
+            </a:r>
+            <a:endParaRPr lang="en-US" sz="3400" dirty="0"/>
+          </a:p>
+        </p:txBody>
+      </p:sp>
+      <p:sp>
+        <p:nvSpPr>
+          <p:cNvPr id="5" name="Text 2"/>
+          <p:cNvSpPr txBox="1"/>
+          <p:nvPr/>
+        </p:nvSpPr>
+        <p:spPr>
+          <a:xfrm>
+            <a:off x="6766560" y="2514600"/>
+            <a:ext cx="4846320" cy="2377440"/>
+          </a:xfrm>
+          <a:prstGeom prst="rect">
+            <a:avLst/>
+          </a:prstGeom>
+          <a:noFill/>
+          <a:ln/>
+        </p:spPr>
+        <p:txBody>
+          <a:bodyPr wrap="square" lIns="0" tIns="0" rIns="0" bIns="0" rtlCol="0" anchor="t"/>
+          <a:lstStyle/>
+          <a:p>
+            <a:pPr marL="342900" indent="-342900">
+              <a:spcAft>
+                <a:spcPts val="1000"/>
+              </a:spcAft>
+              <a:buSzPct val="100000"/>
+              <a:buChar char="•"/>
+            </a:pPr>
+            <a:r>
+              <a:rPr lang="en-US" sz="1600" dirty="0">
+                <a:solidFill>
+                  <a:srgbClr val="1F2A44"/>
+                </a:solidFill>
+                <a:latin typeface="Calibri" pitchFamily="34" charset="0"/>
+                <a:ea typeface="Calibri" pitchFamily="34" charset="-122"/>
+                <a:cs typeface="Calibri" pitchFamily="34" charset="-120"/>
+              </a:rPr>
+              <a:t>Same kind of measurement, same axes, on 30 Sep.</a:t>
+            </a:r>
+            <a:endParaRPr lang="en-US" sz="1600" dirty="0"/>
+          </a:p>
+          <a:p>
+            <a:pPr marL="342900" indent="-342900">
+              <a:spcAft>
+                <a:spcPts val="1000"/>
+              </a:spcAft>
+              <a:buSzPct val="100000"/>
+              <a:buChar char="•"/>
+            </a:pPr>
+            <a:r>
+              <a:rPr lang="en-US" sz="1600" dirty="0">
+                <a:solidFill>
+                  <a:srgbClr val="1F2A44"/>
+                </a:solidFill>
+                <a:latin typeface="Calibri" pitchFamily="34" charset="0"/>
+                <a:ea typeface="Calibri" pitchFamily="34" charset="-122"/>
+                <a:cs typeface="Calibri" pitchFamily="34" charset="-120"/>
+              </a:rPr>
+              <a:t>The microphones now carry their measured corrections, and the room has been treated.</a:t>
+            </a:r>
+            <a:endParaRPr lang="en-US" sz="1600" dirty="0"/>
+          </a:p>
+          <a:p>
+            <a:pPr marL="342900" indent="-342900">
+              <a:spcAft>
+                <a:spcPts val="1000"/>
+              </a:spcAft>
+              <a:buSzPct val="100000"/>
+              <a:buChar char="•"/>
+            </a:pPr>
+            <a:r>
+              <a:rPr lang="en-US" sz="1600" b="1" dirty="0">
+                <a:solidFill>
+                  <a:srgbClr val="1F2A44"/>
+                </a:solidFill>
+                <a:latin typeface="Calibri" pitchFamily="34" charset="0"/>
+                <a:ea typeface="Calibri" pitchFamily="34" charset="-122"/>
+                <a:cs typeface="Calibri" pitchFamily="34" charset="-120"/>
+              </a:rPr>
+              <a:t>The outline is smooth and close to a circle.</a:t>
+            </a:r>
+            <a:endParaRPr lang="en-US" sz="1600" dirty="0"/>
+          </a:p>
+        </p:txBody>
+      </p:sp>
+      <p:sp>
+        <p:nvSpPr>
+          <p:cNvPr id="6" name="Text 3"/>
+          <p:cNvSpPr txBox="1"/>
+          <p:nvPr/>
+        </p:nvSpPr>
+        <p:spPr>
+          <a:xfrm>
+            <a:off x="6766560" y="5029200"/>
+            <a:ext cx="4846320" cy="731520"/>
+          </a:xfrm>
+          <a:prstGeom prst="rect">
+            <a:avLst/>
+          </a:prstGeom>
+          <a:noFill/>
+          <a:ln/>
+        </p:spPr>
+        <p:txBody>
+          <a:bodyPr wrap="square" lIns="0" tIns="0" rIns="0" bIns="0" rtlCol="0" anchor="ctr"/>
+          <a:lstStyle/>
+          <a:p>
+            <a:pPr indent="0" marL="0">
+              <a:buNone/>
+            </a:pPr>
+            <a:r>
+              <a:rPr lang="en-US" sz="4800" b="1" dirty="0">
+                <a:solidFill>
+                  <a:srgbClr val="D6336C"/>
+                </a:solidFill>
+                <a:latin typeface="Cambria" pitchFamily="34" charset="0"/>
+                <a:ea typeface="Cambria" pitchFamily="34" charset="-122"/>
+                <a:cs typeface="Cambria" pitchFamily="34" charset="-120"/>
+              </a:rPr>
+              <a:t>6.7</a:t>
+            </a:r>
+            <a:pPr indent="0" marL="0">
+              <a:buNone/>
+            </a:pPr>
+            <a:r>
+              <a:rPr lang="en-US" sz="4800" b="1" dirty="0">
+                <a:solidFill>
+                  <a:srgbClr val="5B6578"/>
+                </a:solidFill>
+                <a:latin typeface="Cambria" pitchFamily="34" charset="0"/>
+                <a:ea typeface="Cambria" pitchFamily="34" charset="-122"/>
+                <a:cs typeface="Cambria" pitchFamily="34" charset="-120"/>
+              </a:rPr>
+              <a:t> → </a:t>
+            </a:r>
+            <a:pPr indent="0" marL="0">
+              <a:buNone/>
+            </a:pPr>
+            <a:r>
+              <a:rPr lang="en-US" sz="4800" b="1" dirty="0">
+                <a:solidFill>
+                  <a:srgbClr val="2B6CB0"/>
+                </a:solidFill>
+                <a:latin typeface="Cambria" pitchFamily="34" charset="0"/>
+                <a:ea typeface="Cambria" pitchFamily="34" charset="-122"/>
+                <a:cs typeface="Cambria" pitchFamily="34" charset="-120"/>
+              </a:rPr>
+              <a:t>4.0 dB</a:t>
+            </a:r>
+            <a:endParaRPr lang="en-US" sz="4800" dirty="0"/>
+          </a:p>
+        </p:txBody>
+      </p:sp>
+      <p:sp>
+        <p:nvSpPr>
+          <p:cNvPr id="7" name="Text 4"/>
+          <p:cNvSpPr txBox="1"/>
+          <p:nvPr/>
+        </p:nvSpPr>
+        <p:spPr>
+          <a:xfrm>
+            <a:off x="6766560" y="5760720"/>
+            <a:ext cx="4846320" cy="457200"/>
+          </a:xfrm>
+          <a:prstGeom prst="rect">
+            <a:avLst/>
+          </a:prstGeom>
+          <a:noFill/>
+          <a:ln/>
+        </p:spPr>
+        <p:txBody>
+          <a:bodyPr wrap="square" lIns="0" tIns="0" rIns="0" bIns="0" rtlCol="0" anchor="ctr"/>
+          <a:lstStyle/>
+          <a:p>
+            <a:pPr indent="0" marL="0">
+              <a:buNone/>
+            </a:pPr>
+            <a:r>
+              <a:rPr lang="en-US" sz="1400" dirty="0">
+                <a:solidFill>
+                  <a:srgbClr val="5B6578"/>
+                </a:solidFill>
+                <a:latin typeface="Calibri" pitchFamily="34" charset="0"/>
+                <a:ea typeface="Calibri" pitchFamily="34" charset="-122"/>
+                <a:cs typeface="Calibri" pitchFamily="34" charset="-120"/>
+              </a:rPr>
+              <a:t>between the loudest and quietest microphone</a:t>
+            </a:r>
+            <a:endParaRPr lang="en-US" sz="1400" dirty="0"/>
+          </a:p>
+        </p:txBody>
+      </p:sp>
+      <p:sp>
+        <p:nvSpPr>
+          <p:cNvPr id="8" name="Text 5"/>
+          <p:cNvSpPr txBox="1"/>
+          <p:nvPr/>
+        </p:nvSpPr>
+        <p:spPr>
+          <a:xfrm>
+            <a:off x="548640" y="6355080"/>
+            <a:ext cx="11064240" cy="274320"/>
+          </a:xfrm>
+          <a:prstGeom prst="rect">
+            <a:avLst/>
+          </a:prstGeom>
+          <a:noFill/>
+          <a:ln/>
+        </p:spPr>
+        <p:txBody>
+          <a:bodyPr wrap="square" lIns="0" tIns="0" rIns="0" bIns="0" rtlCol="0" anchor="ctr"/>
+          <a:lstStyle/>
+          <a:p>
+            <a:pPr indent="0" marL="0">
+              <a:buNone/>
+            </a:pPr>
+            <a:r>
+              <a:rPr lang="en-US" sz="1100" dirty="0">
+                <a:solidFill>
+                  <a:srgbClr val="5B6578"/>
+                </a:solidFill>
+                <a:latin typeface="Calibri" pitchFamily="34" charset="0"/>
+                <a:ea typeface="Calibri" pitchFamily="34" charset="-122"/>
+                <a:cs typeface="Calibri" pitchFamily="34" charset="-120"/>
+              </a:rPr>
+              <a:t>20–560 Hz, motor at 2000 µs. The two runs had different operating points (7.35 V against 11.7 V), which is why the blue is lower.</a:t>
+            </a:r>
+            <a:endParaRPr lang="en-US" sz="1100" dirty="0"/>
+          </a:p>
+        </p:txBody>
+      </p:sp>
+      <p:sp>
+        <p:nvSpPr>
+          <p:cNvPr id="9" name="Text 6"/>
+          <p:cNvSpPr txBox="1"/>
+          <p:nvPr/>
+        </p:nvSpPr>
+        <p:spPr>
+          <a:xfrm>
+            <a:off x="11155680" y="6355080"/>
+            <a:ext cx="457200" cy="274320"/>
+          </a:xfrm>
+          <a:prstGeom prst="rect">
+            <a:avLst/>
+          </a:prstGeom>
+          <a:noFill/>
+          <a:ln/>
+        </p:spPr>
+        <p:txBody>
+          <a:bodyPr wrap="square" lIns="0" tIns="0" rIns="0" bIns="0" rtlCol="0" anchor="ctr"/>
+          <a:lstStyle/>
+          <a:p>
+            <a:pPr algn="r" indent="0" marL="0">
+              <a:buNone/>
+            </a:pPr>
+            <a:r>
+              <a:rPr lang="en-US" sz="1200" dirty="0">
+                <a:solidFill>
+                  <a:srgbClr val="5B6578"/>
+                </a:solidFill>
+                <a:latin typeface="Calibri" pitchFamily="34" charset="0"/>
+                <a:ea typeface="Calibri" pitchFamily="34" charset="-122"/>
+                <a:cs typeface="Calibri" pitchFamily="34" charset="-120"/>
+              </a:rPr>
+              <a:t>4</a:t>
             </a:r>
             <a:endParaRPr lang="en-US" sz="1200" dirty="0"/>
           </a:p>

</xml_diff>

<commit_message>
Slides: larger, redrawn calibration waterfalls on slide 3 (bigger type, 8.2 in wide); fig_mic takes size and font scale
Co-Authored-By: Claude Sonnet 5.5 <noreply@anthropic.com>
</commit_message>
<xml_diff>
--- a/docs/analysis/chamber-final-2026-10-01/slides/chamber-slides.pptx
+++ b/docs/analysis/chamber-final-2026-10-01/slides/chamber-slides.pptx
@@ -681,7 +681,7 @@
           <a:p>
             <a:r>
               <a:rPr lang="en-US" dirty="0"/>
-              <a:t>Same figure as chapter 1 of the report. The same two captures were calibrated two ways: with the factory files and with the corrections measured on 16 Sep. The span is the range of the capsules mean levels: 4.3 to 0.8 dB at the start of day 3, 4.1 to 1.0 dB in the final configuration. Room error below 3 kHz: 2.277 to 1.997 dB and 1.736 to 1.387 dB. The change is mainly a per-capsule offset, so it mainly moves whole rows.</a:t>
+              <a:t>Same figure as chapter 1 of the report, redrawn larger. The same two captures were calibrated two ways: with the factory files and with the corrections measured on 16 Sep. The span is the range of the capsules mean levels: 4.3 to 0.8 dB at the start of day 3, 4.1 to 1.0 dB in the final configuration. Room error below 3 kHz: 2.277 to 1.997 dB and 1.736 to 1.387 dB. The change is mainly a per-capsule offset, so it mainly moves whole rows.</a:t>
             </a:r>
             <a:endParaRPr lang="en-US" dirty="0"/>
           </a:p>
@@ -2160,8 +2160,8 @@
         </p:blipFill>
         <p:spPr>
           <a:xfrm>
-            <a:off x="457200" y="411480"/>
-            <a:ext cx="5623560" cy="5669280"/>
+            <a:off x="320040" y="274320"/>
+            <a:ext cx="7498080" cy="5833872"/>
           </a:xfrm>
           <a:prstGeom prst="rect">
             <a:avLst/>
@@ -2176,8 +2176,8 @@
         </p:nvSpPr>
         <p:spPr>
           <a:xfrm>
-            <a:off x="6583680" y="822960"/>
-            <a:ext cx="5029200" cy="365760"/>
+            <a:off x="8183880" y="640080"/>
+            <a:ext cx="3566160" cy="320040"/>
           </a:xfrm>
           <a:prstGeom prst="rect">
             <a:avLst/>
@@ -2215,8 +2215,8 @@
         </p:nvSpPr>
         <p:spPr>
           <a:xfrm>
-            <a:off x="6583680" y="1188720"/>
-            <a:ext cx="5029200" cy="1280160"/>
+            <a:off x="8183880" y="960120"/>
+            <a:ext cx="3566160" cy="1554480"/>
           </a:xfrm>
           <a:prstGeom prst="rect">
             <a:avLst/>
@@ -2232,7 +2232,7 @@
               <a:buNone/>
             </a:pPr>
             <a:r>
-              <a:rPr lang="en-US" sz="3200" b="1" dirty="0">
+              <a:rPr lang="en-US" sz="2800" b="1" dirty="0">
                 <a:solidFill>
                   <a:srgbClr val="1F2A44"/>
                 </a:solidFill>
@@ -2242,7 +2242,7 @@
               </a:rPr>
               <a:t>The correction removes the microphone offsets</a:t>
             </a:r>
-            <a:endParaRPr lang="en-US" sz="3200" dirty="0"/>
+            <a:endParaRPr lang="en-US" sz="2800" dirty="0"/>
           </a:p>
         </p:txBody>
       </p:sp>
@@ -2254,8 +2254,8 @@
         </p:nvSpPr>
         <p:spPr>
           <a:xfrm>
-            <a:off x="6583680" y="2606040"/>
-            <a:ext cx="5029200" cy="2286000"/>
+            <a:off x="8183880" y="2606040"/>
+            <a:ext cx="3566160" cy="2468880"/>
           </a:xfrm>
           <a:prstGeom prst="rect">
             <a:avLst/>
@@ -2269,13 +2269,13 @@
           <a:p>
             <a:pPr marL="342900" indent="-342900">
               <a:spcAft>
-                <a:spcPts val="1000"/>
+                <a:spcPts val="800"/>
               </a:spcAft>
               <a:buSzPct val="100000"/>
               <a:buChar char="•"/>
             </a:pPr>
             <a:r>
-              <a:rPr lang="en-US" sz="1600" dirty="0">
+              <a:rPr lang="en-US" sz="1400" dirty="0">
                 <a:solidFill>
                   <a:srgbClr val="1F2A44"/>
                 </a:solidFill>
@@ -2283,20 +2283,20 @@
                 <a:ea typeface="Calibri" pitchFamily="34" charset="-122"/>
                 <a:cs typeface="Calibri" pitchFamily="34" charset="-120"/>
               </a:rPr>
-              <a:t>Top row: read with the factory files. Middle row: read with the measured corrections. Bottom row: what the correction changed.</a:t>
-            </a:r>
-            <a:endParaRPr lang="en-US" sz="1600" dirty="0"/>
+              <a:t>Top: factory files. Middle: corrected. Bottom: what the correction changed.</a:t>
+            </a:r>
+            <a:endParaRPr lang="en-US" sz="1400" dirty="0"/>
           </a:p>
           <a:p>
             <a:pPr marL="342900" indent="-342900">
               <a:spcAft>
-                <a:spcPts val="1000"/>
+                <a:spcPts val="800"/>
               </a:spcAft>
               <a:buSzPct val="100000"/>
               <a:buChar char="•"/>
             </a:pPr>
             <a:r>
-              <a:rPr lang="en-US" sz="1600" dirty="0">
+              <a:rPr lang="en-US" sz="1400" dirty="0">
                 <a:solidFill>
                   <a:srgbClr val="1F2A44"/>
                 </a:solidFill>
@@ -2304,20 +2304,20 @@
                 <a:ea typeface="Calibri" pitchFamily="34" charset="-122"/>
                 <a:cs typeface="Calibri" pitchFamily="34" charset="-120"/>
               </a:rPr>
-              <a:t>Horizontal stripes across all frequencies are one microphone reading too loud or too quiet. They are gone in the middle row.</a:t>
-            </a:r>
-            <a:endParaRPr lang="en-US" sz="1600" dirty="0"/>
+              <a:t>A stripe across all frequencies is one microphone reading too loud or too quiet. The middle row has none.</a:t>
+            </a:r>
+            <a:endParaRPr lang="en-US" sz="1400" dirty="0"/>
           </a:p>
           <a:p>
             <a:pPr marL="342900" indent="-342900">
               <a:spcAft>
-                <a:spcPts val="1000"/>
+                <a:spcPts val="800"/>
               </a:spcAft>
               <a:buSzPct val="100000"/>
               <a:buChar char="•"/>
             </a:pPr>
             <a:r>
-              <a:rPr lang="en-US" sz="1600" dirty="0">
+              <a:rPr lang="en-US" sz="1400" dirty="0">
                 <a:solidFill>
                   <a:srgbClr val="1F2A44"/>
                 </a:solidFill>
@@ -2325,9 +2325,9 @@
                 <a:ea typeface="Calibri" pitchFamily="34" charset="-122"/>
                 <a:cs typeface="Calibri" pitchFamily="34" charset="-120"/>
               </a:rPr>
-              <a:t>The pattern of the room stays: the correction moves whole rows, not the frequency structure.</a:t>
-            </a:r>
-            <a:endParaRPr lang="en-US" sz="1600" dirty="0"/>
+              <a:t>The room pattern stays: whole rows move, not the frequency structure.</a:t>
+            </a:r>
+            <a:endParaRPr lang="en-US" sz="1400" dirty="0"/>
           </a:p>
         </p:txBody>
       </p:sp>
@@ -2339,8 +2339,8 @@
         </p:nvSpPr>
         <p:spPr>
           <a:xfrm>
-            <a:off x="6583680" y="5029200"/>
-            <a:ext cx="5029200" cy="731520"/>
+            <a:off x="8183880" y="5074920"/>
+            <a:ext cx="3566160" cy="640080"/>
           </a:xfrm>
           <a:prstGeom prst="rect">
             <a:avLst/>
@@ -2356,7 +2356,7 @@
               <a:buNone/>
             </a:pPr>
             <a:r>
-              <a:rPr lang="en-US" sz="4400" b="1" dirty="0">
+              <a:rPr lang="en-US" sz="3600" b="1" dirty="0">
                 <a:solidFill>
                   <a:srgbClr val="D6336C"/>
                 </a:solidFill>
@@ -2370,7 +2370,7 @@
               <a:buNone/>
             </a:pPr>
             <a:r>
-              <a:rPr lang="en-US" sz="4400" b="1" dirty="0">
+              <a:rPr lang="en-US" sz="3600" b="1" dirty="0">
                 <a:solidFill>
                   <a:srgbClr val="5B6578"/>
                 </a:solidFill>
@@ -2384,7 +2384,7 @@
               <a:buNone/>
             </a:pPr>
             <a:r>
-              <a:rPr lang="en-US" sz="4400" b="1" dirty="0">
+              <a:rPr lang="en-US" sz="3600" b="1" dirty="0">
                 <a:solidFill>
                   <a:srgbClr val="2B6CB0"/>
                 </a:solidFill>
@@ -2394,7 +2394,7 @@
               </a:rPr>
               <a:t>0.8 dB</a:t>
             </a:r>
-            <a:endParaRPr lang="en-US" sz="4400" dirty="0"/>
+            <a:endParaRPr lang="en-US" sz="3600" dirty="0"/>
           </a:p>
         </p:txBody>
       </p:sp>
@@ -2406,8 +2406,8 @@
         </p:nvSpPr>
         <p:spPr>
           <a:xfrm>
-            <a:off x="6583680" y="5760720"/>
-            <a:ext cx="5029200" cy="457200"/>
+            <a:off x="8183880" y="5715000"/>
+            <a:ext cx="3566160" cy="548640"/>
           </a:xfrm>
           <a:prstGeom prst="rect">
             <a:avLst/>
@@ -2423,7 +2423,7 @@
               <a:buNone/>
             </a:pPr>
             <a:r>
-              <a:rPr lang="en-US" sz="1400" dirty="0">
+              <a:rPr lang="en-US" sz="1200" dirty="0">
                 <a:solidFill>
                   <a:srgbClr val="5B6578"/>
                 </a:solidFill>
@@ -2433,7 +2433,7 @@
               </a:rPr>
               <a:t>range of the microphones’ mean levels, start of day 3 (final state: 4.1 → 1.0 dB)</a:t>
             </a:r>
-            <a:endParaRPr lang="en-US" sz="1400" dirty="0"/>
+            <a:endParaRPr lang="en-US" sz="1200" dirty="0"/>
           </a:p>
         </p:txBody>
       </p:sp>
@@ -2446,7 +2446,7 @@
         <p:spPr>
           <a:xfrm>
             <a:off x="548640" y="6355080"/>
-            <a:ext cx="10332720" cy="274320"/>
+            <a:ext cx="7315200" cy="274320"/>
           </a:xfrm>
           <a:prstGeom prst="rect">
             <a:avLst/>
@@ -2470,7 +2470,7 @@
                 <a:ea typeface="Calibri" pitchFamily="34" charset="-122"/>
                 <a:cs typeface="Calibri" pitchFamily="34" charset="-120"/>
               </a:rPr>
-              <a:t>Captures from 25 Sep 2026: day3-a (left) and carpet-reordered (right), 257 Hz–6 kHz, 3–5 kHz omitted.</a:t>
+              <a:t>Captures from 25 Sep 2026: day3-a (left) and carpet-reordered (right).</a:t>
             </a:r>
             <a:endParaRPr lang="en-US" sz="1100" dirty="0"/>
           </a:p>

</xml_diff>

<commit_message>
Slides: bold, coloured TOP / MIDDLE / BOTTOM key on slide 3
Co-Authored-By: Claude Sonnet 5.5 <noreply@anthropic.com>
</commit_message>
<xml_diff>
--- a/docs/analysis/chamber-final-2026-10-01/slides/chamber-slides.pptx
+++ b/docs/analysis/chamber-final-2026-10-01/slides/chamber-slides.pptx
@@ -2254,8 +2254,141 @@
         </p:nvSpPr>
         <p:spPr>
           <a:xfrm>
-            <a:off x="8183880" y="2606040"/>
-            <a:ext cx="3566160" cy="2468880"/>
+            <a:off x="8183880" y="2560320"/>
+            <a:ext cx="3566160" cy="1051560"/>
+          </a:xfrm>
+          <a:prstGeom prst="rect">
+            <a:avLst/>
+          </a:prstGeom>
+          <a:noFill/>
+          <a:ln/>
+        </p:spPr>
+        <p:txBody>
+          <a:bodyPr wrap="square" lIns="0" tIns="0" rIns="0" bIns="0" rtlCol="0" anchor="t"/>
+          <a:lstStyle/>
+          <a:p>
+            <a:pPr indent="0" marL="0">
+              <a:spcAft>
+                <a:spcPts val="400"/>
+              </a:spcAft>
+              <a:buNone/>
+            </a:pPr>
+            <a:r>
+              <a:rPr lang="en-US" sz="1800" b="1" dirty="0">
+                <a:solidFill>
+                  <a:srgbClr val="D6336C"/>
+                </a:solidFill>
+                <a:latin typeface="Calibri" pitchFamily="34" charset="0"/>
+                <a:ea typeface="Calibri" pitchFamily="34" charset="-122"/>
+                <a:cs typeface="Calibri" pitchFamily="34" charset="-120"/>
+              </a:rPr>
+              <a:t>TOP</a:t>
+            </a:r>
+            <a:pPr indent="0" marL="0">
+              <a:spcAft>
+                <a:spcPts val="400"/>
+              </a:spcAft>
+              <a:buNone/>
+            </a:pPr>
+            <a:r>
+              <a:rPr lang="en-US" sz="1500" dirty="0">
+                <a:solidFill>
+                  <a:srgbClr val="1F2A44"/>
+                </a:solidFill>
+                <a:latin typeface="Calibri" pitchFamily="34" charset="0"/>
+                <a:ea typeface="Calibri" pitchFamily="34" charset="-122"/>
+                <a:cs typeface="Calibri" pitchFamily="34" charset="-120"/>
+              </a:rPr>
+              <a:t>  factory files</a:t>
+            </a:r>
+            <a:endParaRPr lang="en-US" sz="1500" dirty="0"/>
+          </a:p>
+          <a:p>
+            <a:pPr indent="0" marL="0">
+              <a:spcAft>
+                <a:spcPts val="400"/>
+              </a:spcAft>
+              <a:buNone/>
+            </a:pPr>
+            <a:r>
+              <a:rPr lang="en-US" sz="1800" b="1" dirty="0">
+                <a:solidFill>
+                  <a:srgbClr val="2B6CB0"/>
+                </a:solidFill>
+                <a:latin typeface="Calibri" pitchFamily="34" charset="0"/>
+                <a:ea typeface="Calibri" pitchFamily="34" charset="-122"/>
+                <a:cs typeface="Calibri" pitchFamily="34" charset="-120"/>
+              </a:rPr>
+              <a:t>MIDDLE</a:t>
+            </a:r>
+            <a:pPr indent="0" marL="0">
+              <a:spcAft>
+                <a:spcPts val="400"/>
+              </a:spcAft>
+              <a:buNone/>
+            </a:pPr>
+            <a:r>
+              <a:rPr lang="en-US" sz="1500" dirty="0">
+                <a:solidFill>
+                  <a:srgbClr val="1F2A44"/>
+                </a:solidFill>
+                <a:latin typeface="Calibri" pitchFamily="34" charset="0"/>
+                <a:ea typeface="Calibri" pitchFamily="34" charset="-122"/>
+                <a:cs typeface="Calibri" pitchFamily="34" charset="-120"/>
+              </a:rPr>
+              <a:t>  corrected</a:t>
+            </a:r>
+            <a:endParaRPr lang="en-US" sz="1500" dirty="0"/>
+          </a:p>
+          <a:p>
+            <a:pPr indent="0" marL="0">
+              <a:spcAft>
+                <a:spcPts val="400"/>
+              </a:spcAft>
+              <a:buNone/>
+            </a:pPr>
+            <a:r>
+              <a:rPr lang="en-US" sz="1800" b="1" dirty="0">
+                <a:solidFill>
+                  <a:srgbClr val="1F2A44"/>
+                </a:solidFill>
+                <a:latin typeface="Calibri" pitchFamily="34" charset="0"/>
+                <a:ea typeface="Calibri" pitchFamily="34" charset="-122"/>
+                <a:cs typeface="Calibri" pitchFamily="34" charset="-120"/>
+              </a:rPr>
+              <a:t>BOTTOM</a:t>
+            </a:r>
+            <a:pPr indent="0" marL="0">
+              <a:spcAft>
+                <a:spcPts val="400"/>
+              </a:spcAft>
+              <a:buNone/>
+            </a:pPr>
+            <a:r>
+              <a:rPr lang="en-US" sz="1500" dirty="0">
+                <a:solidFill>
+                  <a:srgbClr val="1F2A44"/>
+                </a:solidFill>
+                <a:latin typeface="Calibri" pitchFamily="34" charset="0"/>
+                <a:ea typeface="Calibri" pitchFamily="34" charset="-122"/>
+                <a:cs typeface="Calibri" pitchFamily="34" charset="-120"/>
+              </a:rPr>
+              <a:t>  the change</a:t>
+            </a:r>
+            <a:endParaRPr lang="en-US" sz="1500" dirty="0"/>
+          </a:p>
+        </p:txBody>
+      </p:sp>
+      <p:sp>
+        <p:nvSpPr>
+          <p:cNvPr id="6" name="Text 3"/>
+          <p:cNvSpPr txBox="1"/>
+          <p:nvPr/>
+        </p:nvSpPr>
+        <p:spPr>
+          <a:xfrm>
+            <a:off x="8183880" y="3749040"/>
+            <a:ext cx="3566160" cy="1280160"/>
           </a:xfrm>
           <a:prstGeom prst="rect">
             <a:avLst/>
@@ -2283,7 +2416,7 @@
                 <a:ea typeface="Calibri" pitchFamily="34" charset="-122"/>
                 <a:cs typeface="Calibri" pitchFamily="34" charset="-120"/>
               </a:rPr>
-              <a:t>Top: factory files. Middle: corrected. Bottom: what the correction changed.</a:t>
+              <a:t>A stripe across all frequencies is one microphone reading too loud or too quiet. The middle row has none.</a:t>
             </a:r>
             <a:endParaRPr lang="en-US" sz="1400" dirty="0"/>
           </a:p>
@@ -2304,36 +2437,15 @@
                 <a:ea typeface="Calibri" pitchFamily="34" charset="-122"/>
                 <a:cs typeface="Calibri" pitchFamily="34" charset="-120"/>
               </a:rPr>
-              <a:t>A stripe across all frequencies is one microphone reading too loud or too quiet. The middle row has none.</a:t>
+              <a:t>The room pattern stays: whole rows move, not the frequency structure.</a:t>
             </a:r>
             <a:endParaRPr lang="en-US" sz="1400" dirty="0"/>
           </a:p>
-          <a:p>
-            <a:pPr marL="342900" indent="-342900">
-              <a:spcAft>
-                <a:spcPts val="800"/>
-              </a:spcAft>
-              <a:buSzPct val="100000"/>
-              <a:buChar char="•"/>
-            </a:pPr>
-            <a:r>
-              <a:rPr lang="en-US" sz="1400" dirty="0">
-                <a:solidFill>
-                  <a:srgbClr val="1F2A44"/>
-                </a:solidFill>
-                <a:latin typeface="Calibri" pitchFamily="34" charset="0"/>
-                <a:ea typeface="Calibri" pitchFamily="34" charset="-122"/>
-                <a:cs typeface="Calibri" pitchFamily="34" charset="-120"/>
-              </a:rPr>
-              <a:t>The room pattern stays: whole rows move, not the frequency structure.</a:t>
-            </a:r>
-            <a:endParaRPr lang="en-US" sz="1400" dirty="0"/>
-          </a:p>
-        </p:txBody>
-      </p:sp>
-      <p:sp>
-        <p:nvSpPr>
-          <p:cNvPr id="6" name="Text 3"/>
+        </p:txBody>
+      </p:sp>
+      <p:sp>
+        <p:nvSpPr>
+          <p:cNvPr id="7" name="Text 4"/>
           <p:cNvSpPr txBox="1"/>
           <p:nvPr/>
         </p:nvSpPr>
@@ -2400,7 +2512,7 @@
       </p:sp>
       <p:sp>
         <p:nvSpPr>
-          <p:cNvPr id="7" name="Text 4"/>
+          <p:cNvPr id="8" name="Text 5"/>
           <p:cNvSpPr txBox="1"/>
           <p:nvPr/>
         </p:nvSpPr>
@@ -2439,7 +2551,7 @@
       </p:sp>
       <p:sp>
         <p:nvSpPr>
-          <p:cNvPr id="8" name="Text 5"/>
+          <p:cNvPr id="9" name="Text 6"/>
           <p:cNvSpPr txBox="1"/>
           <p:nvPr/>
         </p:nvSpPr>
@@ -2478,7 +2590,7 @@
       </p:sp>
       <p:sp>
         <p:nvSpPr>
-          <p:cNvPr id="9" name="Text 6"/>
+          <p:cNvPr id="10" name="Text 7"/>
           <p:cNvSpPr txBox="1"/>
           <p:nvPr/>
         </p:nvSpPr>

</xml_diff>

<commit_message>
Slides: slide 3 key back to plain text with Top / Middle / Bottom in bold black
Co-Authored-By: Claude Sonnet 5.5 <noreply@anthropic.com>
</commit_message>
<xml_diff>
--- a/docs/analysis/chamber-final-2026-10-01/slides/chamber-slides.pptx
+++ b/docs/analysis/chamber-final-2026-10-01/slides/chamber-slides.pptx
@@ -2254,8 +2254,8 @@
         </p:nvSpPr>
         <p:spPr>
           <a:xfrm>
-            <a:off x="8183880" y="2560320"/>
-            <a:ext cx="3566160" cy="1051560"/>
+            <a:off x="8183880" y="2606040"/>
+            <a:ext cx="3566160" cy="2468880"/>
           </a:xfrm>
           <a:prstGeom prst="rect">
             <a:avLst/>
@@ -2269,29 +2269,29 @@
           <a:p>
             <a:pPr indent="0" marL="0">
               <a:spcAft>
-                <a:spcPts val="400"/>
+                <a:spcPts val="800"/>
               </a:spcAft>
               <a:buNone/>
             </a:pPr>
             <a:r>
-              <a:rPr lang="en-US" sz="1800" b="1" dirty="0">
-                <a:solidFill>
-                  <a:srgbClr val="D6336C"/>
-                </a:solidFill>
-                <a:latin typeface="Calibri" pitchFamily="34" charset="0"/>
-                <a:ea typeface="Calibri" pitchFamily="34" charset="-122"/>
-                <a:cs typeface="Calibri" pitchFamily="34" charset="-120"/>
-              </a:rPr>
-              <a:t>TOP</a:t>
+              <a:rPr lang="en-US" sz="1400" b="1" dirty="0">
+                <a:solidFill>
+                  <a:srgbClr val="1F2A44"/>
+                </a:solidFill>
+                <a:latin typeface="Calibri" pitchFamily="34" charset="0"/>
+                <a:ea typeface="Calibri" pitchFamily="34" charset="-122"/>
+                <a:cs typeface="Calibri" pitchFamily="34" charset="-120"/>
+              </a:rPr>
+              <a:t>Top</a:t>
             </a:r>
             <a:pPr indent="0" marL="0">
               <a:spcAft>
-                <a:spcPts val="400"/>
+                <a:spcPts val="800"/>
               </a:spcAft>
               <a:buNone/>
             </a:pPr>
             <a:r>
-              <a:rPr lang="en-US" sz="1500" dirty="0">
+              <a:rPr lang="en-US" sz="1400" dirty="0">
                 <a:solidFill>
                   <a:srgbClr val="1F2A44"/>
                 </a:solidFill>
@@ -2299,36 +2299,33 @@
                 <a:ea typeface="Calibri" pitchFamily="34" charset="-122"/>
                 <a:cs typeface="Calibri" pitchFamily="34" charset="-120"/>
               </a:rPr>
-              <a:t>  factory files</a:t>
-            </a:r>
-            <a:endParaRPr lang="en-US" sz="1500" dirty="0"/>
-          </a:p>
-          <a:p>
+              <a:t>: factory files. </a:t>
+            </a:r>
             <a:pPr indent="0" marL="0">
               <a:spcAft>
-                <a:spcPts val="400"/>
+                <a:spcPts val="800"/>
               </a:spcAft>
               <a:buNone/>
             </a:pPr>
             <a:r>
-              <a:rPr lang="en-US" sz="1800" b="1" dirty="0">
-                <a:solidFill>
-                  <a:srgbClr val="2B6CB0"/>
-                </a:solidFill>
-                <a:latin typeface="Calibri" pitchFamily="34" charset="0"/>
-                <a:ea typeface="Calibri" pitchFamily="34" charset="-122"/>
-                <a:cs typeface="Calibri" pitchFamily="34" charset="-120"/>
-              </a:rPr>
-              <a:t>MIDDLE</a:t>
+              <a:rPr lang="en-US" sz="1400" b="1" dirty="0">
+                <a:solidFill>
+                  <a:srgbClr val="1F2A44"/>
+                </a:solidFill>
+                <a:latin typeface="Calibri" pitchFamily="34" charset="0"/>
+                <a:ea typeface="Calibri" pitchFamily="34" charset="-122"/>
+                <a:cs typeface="Calibri" pitchFamily="34" charset="-120"/>
+              </a:rPr>
+              <a:t>Middle</a:t>
             </a:r>
             <a:pPr indent="0" marL="0">
               <a:spcAft>
-                <a:spcPts val="400"/>
+                <a:spcPts val="800"/>
               </a:spcAft>
               <a:buNone/>
             </a:pPr>
             <a:r>
-              <a:rPr lang="en-US" sz="1500" dirty="0">
+              <a:rPr lang="en-US" sz="1400" dirty="0">
                 <a:solidFill>
                   <a:srgbClr val="1F2A44"/>
                 </a:solidFill>
@@ -2336,19 +2333,16 @@
                 <a:ea typeface="Calibri" pitchFamily="34" charset="-122"/>
                 <a:cs typeface="Calibri" pitchFamily="34" charset="-120"/>
               </a:rPr>
-              <a:t>  corrected</a:t>
-            </a:r>
-            <a:endParaRPr lang="en-US" sz="1500" dirty="0"/>
-          </a:p>
-          <a:p>
+              <a:t>: corrected. </a:t>
+            </a:r>
             <a:pPr indent="0" marL="0">
               <a:spcAft>
-                <a:spcPts val="400"/>
+                <a:spcPts val="800"/>
               </a:spcAft>
               <a:buNone/>
             </a:pPr>
             <a:r>
-              <a:rPr lang="en-US" sz="1800" b="1" dirty="0">
+              <a:rPr lang="en-US" sz="1400" b="1" dirty="0">
                 <a:solidFill>
                   <a:srgbClr val="1F2A44"/>
                 </a:solidFill>
@@ -2356,16 +2350,16 @@
                 <a:ea typeface="Calibri" pitchFamily="34" charset="-122"/>
                 <a:cs typeface="Calibri" pitchFamily="34" charset="-120"/>
               </a:rPr>
-              <a:t>BOTTOM</a:t>
+              <a:t>Bottom</a:t>
             </a:r>
             <a:pPr indent="0" marL="0">
               <a:spcAft>
-                <a:spcPts val="400"/>
+                <a:spcPts val="800"/>
               </a:spcAft>
               <a:buNone/>
             </a:pPr>
             <a:r>
-              <a:rPr lang="en-US" sz="1500" dirty="0">
+              <a:rPr lang="en-US" sz="1400" dirty="0">
                 <a:solidFill>
                   <a:srgbClr val="1F2A44"/>
                 </a:solidFill>
@@ -2373,32 +2367,10 @@
                 <a:ea typeface="Calibri" pitchFamily="34" charset="-122"/>
                 <a:cs typeface="Calibri" pitchFamily="34" charset="-120"/>
               </a:rPr>
-              <a:t>  the change</a:t>
-            </a:r>
-            <a:endParaRPr lang="en-US" sz="1500" dirty="0"/>
-          </a:p>
-        </p:txBody>
-      </p:sp>
-      <p:sp>
-        <p:nvSpPr>
-          <p:cNvPr id="6" name="Text 3"/>
-          <p:cNvSpPr txBox="1"/>
-          <p:nvPr/>
-        </p:nvSpPr>
-        <p:spPr>
-          <a:xfrm>
-            <a:off x="8183880" y="3749040"/>
-            <a:ext cx="3566160" cy="1280160"/>
-          </a:xfrm>
-          <a:prstGeom prst="rect">
-            <a:avLst/>
-          </a:prstGeom>
-          <a:noFill/>
-          <a:ln/>
-        </p:spPr>
-        <p:txBody>
-          <a:bodyPr wrap="square" lIns="0" tIns="0" rIns="0" bIns="0" rtlCol="0" anchor="t"/>
-          <a:lstStyle/>
+              <a:t>: what the correction changed.</a:t>
+            </a:r>
+            <a:endParaRPr lang="en-US" sz="1400" dirty="0"/>
+          </a:p>
           <a:p>
             <a:pPr marL="342900" indent="-342900">
               <a:spcAft>
@@ -2445,7 +2417,7 @@
       </p:sp>
       <p:sp>
         <p:nvSpPr>
-          <p:cNvPr id="7" name="Text 4"/>
+          <p:cNvPr id="6" name="Text 3"/>
           <p:cNvSpPr txBox="1"/>
           <p:nvPr/>
         </p:nvSpPr>
@@ -2512,14 +2484,53 @@
       </p:sp>
       <p:sp>
         <p:nvSpPr>
+          <p:cNvPr id="7" name="Text 4"/>
+          <p:cNvSpPr txBox="1"/>
+          <p:nvPr/>
+        </p:nvSpPr>
+        <p:spPr>
+          <a:xfrm>
+            <a:off x="8183880" y="5715000"/>
+            <a:ext cx="3566160" cy="548640"/>
+          </a:xfrm>
+          <a:prstGeom prst="rect">
+            <a:avLst/>
+          </a:prstGeom>
+          <a:noFill/>
+          <a:ln/>
+        </p:spPr>
+        <p:txBody>
+          <a:bodyPr wrap="square" lIns="0" tIns="0" rIns="0" bIns="0" rtlCol="0" anchor="t"/>
+          <a:lstStyle/>
+          <a:p>
+            <a:pPr indent="0" marL="0">
+              <a:buNone/>
+            </a:pPr>
+            <a:r>
+              <a:rPr lang="en-US" sz="1200" dirty="0">
+                <a:solidFill>
+                  <a:srgbClr val="5B6578"/>
+                </a:solidFill>
+                <a:latin typeface="Calibri" pitchFamily="34" charset="0"/>
+                <a:ea typeface="Calibri" pitchFamily="34" charset="-122"/>
+                <a:cs typeface="Calibri" pitchFamily="34" charset="-120"/>
+              </a:rPr>
+              <a:t>range of the microphones’ mean levels, start of day 3 (final state: 4.1 → 1.0 dB)</a:t>
+            </a:r>
+            <a:endParaRPr lang="en-US" sz="1200" dirty="0"/>
+          </a:p>
+        </p:txBody>
+      </p:sp>
+      <p:sp>
+        <p:nvSpPr>
           <p:cNvPr id="8" name="Text 5"/>
           <p:cNvSpPr txBox="1"/>
           <p:nvPr/>
         </p:nvSpPr>
         <p:spPr>
           <a:xfrm>
-            <a:off x="8183880" y="5715000"/>
-            <a:ext cx="3566160" cy="548640"/>
+            <a:off x="548640" y="6355080"/>
+            <a:ext cx="7315200" cy="274320"/>
           </a:xfrm>
           <a:prstGeom prst="rect">
             <a:avLst/>
@@ -2528,14 +2539,14 @@
           <a:ln/>
         </p:spPr>
         <p:txBody>
-          <a:bodyPr wrap="square" lIns="0" tIns="0" rIns="0" bIns="0" rtlCol="0" anchor="t"/>
+          <a:bodyPr wrap="square" lIns="0" tIns="0" rIns="0" bIns="0" rtlCol="0" anchor="ctr"/>
           <a:lstStyle/>
           <a:p>
             <a:pPr indent="0" marL="0">
               <a:buNone/>
             </a:pPr>
             <a:r>
-              <a:rPr lang="en-US" sz="1200" dirty="0">
+              <a:rPr lang="en-US" sz="1100" dirty="0">
                 <a:solidFill>
                   <a:srgbClr val="5B6578"/>
                 </a:solidFill>
@@ -2543,54 +2554,15 @@
                 <a:ea typeface="Calibri" pitchFamily="34" charset="-122"/>
                 <a:cs typeface="Calibri" pitchFamily="34" charset="-120"/>
               </a:rPr>
-              <a:t>range of the microphones’ mean levels, start of day 3 (final state: 4.1 → 1.0 dB)</a:t>
-            </a:r>
-            <a:endParaRPr lang="en-US" sz="1200" dirty="0"/>
+              <a:t>Captures from 25 Sep 2026: day3-a (left) and carpet-reordered (right).</a:t>
+            </a:r>
+            <a:endParaRPr lang="en-US" sz="1100" dirty="0"/>
           </a:p>
         </p:txBody>
       </p:sp>
       <p:sp>
         <p:nvSpPr>
           <p:cNvPr id="9" name="Text 6"/>
-          <p:cNvSpPr txBox="1"/>
-          <p:nvPr/>
-        </p:nvSpPr>
-        <p:spPr>
-          <a:xfrm>
-            <a:off x="548640" y="6355080"/>
-            <a:ext cx="7315200" cy="274320"/>
-          </a:xfrm>
-          <a:prstGeom prst="rect">
-            <a:avLst/>
-          </a:prstGeom>
-          <a:noFill/>
-          <a:ln/>
-        </p:spPr>
-        <p:txBody>
-          <a:bodyPr wrap="square" lIns="0" tIns="0" rIns="0" bIns="0" rtlCol="0" anchor="ctr"/>
-          <a:lstStyle/>
-          <a:p>
-            <a:pPr indent="0" marL="0">
-              <a:buNone/>
-            </a:pPr>
-            <a:r>
-              <a:rPr lang="en-US" sz="1100" dirty="0">
-                <a:solidFill>
-                  <a:srgbClr val="5B6578"/>
-                </a:solidFill>
-                <a:latin typeface="Calibri" pitchFamily="34" charset="0"/>
-                <a:ea typeface="Calibri" pitchFamily="34" charset="-122"/>
-                <a:cs typeface="Calibri" pitchFamily="34" charset="-120"/>
-              </a:rPr>
-              <a:t>Captures from 25 Sep 2026: day3-a (left) and carpet-reordered (right).</a:t>
-            </a:r>
-            <a:endParaRPr lang="en-US" sz="1100" dirty="0"/>
-          </a:p>
-        </p:txBody>
-      </p:sp>
-      <p:sp>
-        <p:nvSpPr>
-          <p:cNvPr id="10" name="Text 7"/>
           <p:cNvSpPr txBox="1"/>
           <p:nvPr/>
         </p:nvSpPr>

</xml_diff>

<commit_message>
Slides: bullet dot on the slide 3 legend line (post-fix also removes the repeated paragraph properties pptxgenjs writes)
Co-Authored-By: Claude Sonnet 5.5 <noreply@anthropic.com>
</commit_message>
<xml_diff>
--- a/docs/analysis/chamber-final-2026-10-01/slides/chamber-slides.pptx
+++ b/docs/analysis/chamber-final-2026-10-01/slides/chamber-slides.pptx
@@ -1924,9 +1924,6 @@
               </a:rPr>
               <a:t>4.01</a:t>
             </a:r>
-            <a:pPr indent="0" marL="0">
-              <a:buNone/>
-            </a:pPr>
             <a:r>
               <a:rPr lang="en-US" sz="4000" b="1" dirty="0">
                 <a:solidFill>
@@ -1938,9 +1935,6 @@
               </a:rPr>
               <a:t> → </a:t>
             </a:r>
-            <a:pPr indent="0" marL="0">
-              <a:buNone/>
-            </a:pPr>
             <a:r>
               <a:rPr lang="en-US" sz="4000" b="1" dirty="0">
                 <a:solidFill>
@@ -2267,111 +2261,6 @@
           <a:bodyPr wrap="square" lIns="0" tIns="0" rIns="0" bIns="0" rtlCol="0" anchor="t"/>
           <a:lstStyle/>
           <a:p>
-            <a:pPr indent="0" marL="0">
-              <a:spcAft>
-                <a:spcPts val="800"/>
-              </a:spcAft>
-              <a:buNone/>
-            </a:pPr>
-            <a:r>
-              <a:rPr lang="en-US" sz="1400" b="1" dirty="0">
-                <a:solidFill>
-                  <a:srgbClr val="1F2A44"/>
-                </a:solidFill>
-                <a:latin typeface="Calibri" pitchFamily="34" charset="0"/>
-                <a:ea typeface="Calibri" pitchFamily="34" charset="-122"/>
-                <a:cs typeface="Calibri" pitchFamily="34" charset="-120"/>
-              </a:rPr>
-              <a:t>Top</a:t>
-            </a:r>
-            <a:pPr indent="0" marL="0">
-              <a:spcAft>
-                <a:spcPts val="800"/>
-              </a:spcAft>
-              <a:buNone/>
-            </a:pPr>
-            <a:r>
-              <a:rPr lang="en-US" sz="1400" dirty="0">
-                <a:solidFill>
-                  <a:srgbClr val="1F2A44"/>
-                </a:solidFill>
-                <a:latin typeface="Calibri" pitchFamily="34" charset="0"/>
-                <a:ea typeface="Calibri" pitchFamily="34" charset="-122"/>
-                <a:cs typeface="Calibri" pitchFamily="34" charset="-120"/>
-              </a:rPr>
-              <a:t>: factory files. </a:t>
-            </a:r>
-            <a:pPr indent="0" marL="0">
-              <a:spcAft>
-                <a:spcPts val="800"/>
-              </a:spcAft>
-              <a:buNone/>
-            </a:pPr>
-            <a:r>
-              <a:rPr lang="en-US" sz="1400" b="1" dirty="0">
-                <a:solidFill>
-                  <a:srgbClr val="1F2A44"/>
-                </a:solidFill>
-                <a:latin typeface="Calibri" pitchFamily="34" charset="0"/>
-                <a:ea typeface="Calibri" pitchFamily="34" charset="-122"/>
-                <a:cs typeface="Calibri" pitchFamily="34" charset="-120"/>
-              </a:rPr>
-              <a:t>Middle</a:t>
-            </a:r>
-            <a:pPr indent="0" marL="0">
-              <a:spcAft>
-                <a:spcPts val="800"/>
-              </a:spcAft>
-              <a:buNone/>
-            </a:pPr>
-            <a:r>
-              <a:rPr lang="en-US" sz="1400" dirty="0">
-                <a:solidFill>
-                  <a:srgbClr val="1F2A44"/>
-                </a:solidFill>
-                <a:latin typeface="Calibri" pitchFamily="34" charset="0"/>
-                <a:ea typeface="Calibri" pitchFamily="34" charset="-122"/>
-                <a:cs typeface="Calibri" pitchFamily="34" charset="-120"/>
-              </a:rPr>
-              <a:t>: corrected. </a:t>
-            </a:r>
-            <a:pPr indent="0" marL="0">
-              <a:spcAft>
-                <a:spcPts val="800"/>
-              </a:spcAft>
-              <a:buNone/>
-            </a:pPr>
-            <a:r>
-              <a:rPr lang="en-US" sz="1400" b="1" dirty="0">
-                <a:solidFill>
-                  <a:srgbClr val="1F2A44"/>
-                </a:solidFill>
-                <a:latin typeface="Calibri" pitchFamily="34" charset="0"/>
-                <a:ea typeface="Calibri" pitchFamily="34" charset="-122"/>
-                <a:cs typeface="Calibri" pitchFamily="34" charset="-120"/>
-              </a:rPr>
-              <a:t>Bottom</a:t>
-            </a:r>
-            <a:pPr indent="0" marL="0">
-              <a:spcAft>
-                <a:spcPts val="800"/>
-              </a:spcAft>
-              <a:buNone/>
-            </a:pPr>
-            <a:r>
-              <a:rPr lang="en-US" sz="1400" dirty="0">
-                <a:solidFill>
-                  <a:srgbClr val="1F2A44"/>
-                </a:solidFill>
-                <a:latin typeface="Calibri" pitchFamily="34" charset="0"/>
-                <a:ea typeface="Calibri" pitchFamily="34" charset="-122"/>
-                <a:cs typeface="Calibri" pitchFamily="34" charset="-120"/>
-              </a:rPr>
-              <a:t>: what the correction changed.</a:t>
-            </a:r>
-            <a:endParaRPr lang="en-US" sz="1400" dirty="0"/>
-          </a:p>
-          <a:p>
             <a:pPr marL="342900" indent="-342900">
               <a:spcAft>
                 <a:spcPts val="800"/>
@@ -2380,6 +2269,17 @@
               <a:buChar char="•"/>
             </a:pPr>
             <a:r>
+              <a:rPr lang="en-US" sz="1400" b="1" dirty="0">
+                <a:solidFill>
+                  <a:srgbClr val="1F2A44"/>
+                </a:solidFill>
+                <a:latin typeface="Calibri" pitchFamily="34" charset="0"/>
+                <a:ea typeface="Calibri" pitchFamily="34" charset="-122"/>
+                <a:cs typeface="Calibri" pitchFamily="34" charset="-120"/>
+              </a:rPr>
+              <a:t>Top</a:t>
+            </a:r>
+            <a:r>
               <a:rPr lang="en-US" sz="1400" dirty="0">
                 <a:solidFill>
                   <a:srgbClr val="1F2A44"/>
@@ -2388,7 +2288,51 @@
                 <a:ea typeface="Calibri" pitchFamily="34" charset="-122"/>
                 <a:cs typeface="Calibri" pitchFamily="34" charset="-120"/>
               </a:rPr>
-              <a:t>A stripe across all frequencies is one microphone reading too loud or too quiet. The middle row has none.</a:t>
+              <a:t>: factory files. </a:t>
+            </a:r>
+            <a:r>
+              <a:rPr lang="en-US" sz="1400" b="1" dirty="0">
+                <a:solidFill>
+                  <a:srgbClr val="1F2A44"/>
+                </a:solidFill>
+                <a:latin typeface="Calibri" pitchFamily="34" charset="0"/>
+                <a:ea typeface="Calibri" pitchFamily="34" charset="-122"/>
+                <a:cs typeface="Calibri" pitchFamily="34" charset="-120"/>
+              </a:rPr>
+              <a:t>Middle</a:t>
+            </a:r>
+            <a:r>
+              <a:rPr lang="en-US" sz="1400" dirty="0">
+                <a:solidFill>
+                  <a:srgbClr val="1F2A44"/>
+                </a:solidFill>
+                <a:latin typeface="Calibri" pitchFamily="34" charset="0"/>
+                <a:ea typeface="Calibri" pitchFamily="34" charset="-122"/>
+                <a:cs typeface="Calibri" pitchFamily="34" charset="-120"/>
+              </a:rPr>
+              <a:t>: corrected. </a:t>
+            </a:r>
+            <a:r>
+              <a:rPr lang="en-US" sz="1400" b="1" dirty="0">
+                <a:solidFill>
+                  <a:srgbClr val="1F2A44"/>
+                </a:solidFill>
+                <a:latin typeface="Calibri" pitchFamily="34" charset="0"/>
+                <a:ea typeface="Calibri" pitchFamily="34" charset="-122"/>
+                <a:cs typeface="Calibri" pitchFamily="34" charset="-120"/>
+              </a:rPr>
+              <a:t>Bottom</a:t>
+            </a:r>
+            <a:r>
+              <a:rPr lang="en-US" sz="1400" dirty="0">
+                <a:solidFill>
+                  <a:srgbClr val="1F2A44"/>
+                </a:solidFill>
+                <a:latin typeface="Calibri" pitchFamily="34" charset="0"/>
+                <a:ea typeface="Calibri" pitchFamily="34" charset="-122"/>
+                <a:cs typeface="Calibri" pitchFamily="34" charset="-120"/>
+              </a:rPr>
+              <a:t>: what the correction changed.</a:t>
             </a:r>
             <a:endParaRPr lang="en-US" sz="1400" dirty="0"/>
           </a:p>
@@ -2409,6 +2353,27 @@
                 <a:ea typeface="Calibri" pitchFamily="34" charset="-122"/>
                 <a:cs typeface="Calibri" pitchFamily="34" charset="-120"/>
               </a:rPr>
+              <a:t>A stripe across all frequencies is one microphone reading too loud or too quiet. The middle row has none.</a:t>
+            </a:r>
+            <a:endParaRPr lang="en-US" sz="1400" dirty="0"/>
+          </a:p>
+          <a:p>
+            <a:pPr marL="342900" indent="-342900">
+              <a:spcAft>
+                <a:spcPts val="800"/>
+              </a:spcAft>
+              <a:buSzPct val="100000"/>
+              <a:buChar char="•"/>
+            </a:pPr>
+            <a:r>
+              <a:rPr lang="en-US" sz="1400" dirty="0">
+                <a:solidFill>
+                  <a:srgbClr val="1F2A44"/>
+                </a:solidFill>
+                <a:latin typeface="Calibri" pitchFamily="34" charset="0"/>
+                <a:ea typeface="Calibri" pitchFamily="34" charset="-122"/>
+                <a:cs typeface="Calibri" pitchFamily="34" charset="-120"/>
+              </a:rPr>
               <a:t>The room pattern stays: whole rows move, not the frequency structure.</a:t>
             </a:r>
             <a:endParaRPr lang="en-US" sz="1400" dirty="0"/>
@@ -2450,9 +2415,6 @@
               </a:rPr>
               <a:t>4.3</a:t>
             </a:r>
-            <a:pPr indent="0" marL="0">
-              <a:buNone/>
-            </a:pPr>
             <a:r>
               <a:rPr lang="en-US" sz="3600" b="1" dirty="0">
                 <a:solidFill>
@@ -2464,9 +2426,6 @@
               </a:rPr>
               <a:t> → </a:t>
             </a:r>
-            <a:pPr indent="0" marL="0">
-              <a:buNone/>
-            </a:pPr>
             <a:r>
               <a:rPr lang="en-US" sz="3600" b="1" dirty="0">
                 <a:solidFill>
@@ -2853,9 +2812,6 @@
               </a:rPr>
               <a:t>6.7</a:t>
             </a:r>
-            <a:pPr indent="0" marL="0">
-              <a:buNone/>
-            </a:pPr>
             <a:r>
               <a:rPr lang="en-US" sz="4800" b="1" dirty="0">
                 <a:solidFill>
@@ -2867,9 +2823,6 @@
               </a:rPr>
               <a:t> → </a:t>
             </a:r>
-            <a:pPr indent="0" marL="0">
-              <a:buNone/>
-            </a:pPr>
             <a:r>
               <a:rPr lang="en-US" sz="4800" b="1" dirty="0">
                 <a:solidFill>

</xml_diff>

<commit_message>
Slides: new slide 4, the chamber-treatment waterfall (day3-a to carpet-reordered) with a native per-band chart; the polar overlay becomes the last slide (5)
Co-Authored-By: Claude Sonnet 5.5 <noreply@anthropic.com>
</commit_message>
<xml_diff>
--- a/docs/analysis/chamber-final-2026-10-01/slides/chamber-slides.pptx
+++ b/docs/analysis/chamber-final-2026-10-01/slides/chamber-slides.pptx
@@ -9,9 +9,10 @@
     <p:sldId id="257" r:id="rId3"/>
     <p:sldId id="258" r:id="rId4"/>
     <p:sldId id="259" r:id="rId5"/>
+    <p:sldId id="260" r:id="rId6"/>
   </p:sldIdLst>
   <p:notesMasterIdLst>
-    <p:notesMasterId r:id="rId6"/>
+    <p:notesMasterId r:id="rId7"/>
   </p:notesMasterIdLst>
   <p:sldSz cx="12192000" cy="6858000"/>
   <p:notesSz cx="6858000" cy="12192000"/>
@@ -108,6 +109,417 @@
     </a:lvl9pPr>
   </p:defaultTextStyle>
 </p:presentation>
+</file>
+
+<file path=ppt/charts/chart1.xml><?xml version="1.0" encoding="utf-8"?>
+<c:chartSpace xmlns:c="http://schemas.openxmlformats.org/drawingml/2006/chart" xmlns:a="http://schemas.openxmlformats.org/drawingml/2006/main" xmlns:r="http://schemas.openxmlformats.org/officeDocument/2006/relationships">
+  <c:date1904 val="0"/>
+  <c:roundedCorners val="1"/>
+  <c:chart>
+    <c:title>
+      <c:tx>
+        <c:rich>
+          <a:bodyPr/>
+          <a:lstStyle/>
+          <a:p>
+            <a:pPr>
+              <a:defRPr sz="1200" b="0" i="0" u="none" strike="noStrike">
+                <a:solidFill>
+                  <a:srgbClr val="1F2A44"/>
+                </a:solidFill>
+                <a:latin typeface="Calibri"/>
+              </a:defRPr>
+            </a:pPr>
+            <a:r>
+              <a:rPr sz="1200" b="0" i="0" u="none" strike="noStrike">
+                <a:solidFill>
+                  <a:srgbClr val="1F2A44"/>
+                </a:solidFill>
+                <a:latin typeface="Calibri"/>
+              </a:rPr>
+              <a:t>Room error per band (dB, band in Hz)</a:t>
+            </a:r>
+          </a:p>
+        </c:rich>
+      </c:tx>
+      <c:layout/>
+      <c:overlay val="0"/>
+    </c:title>
+    <c:autoTitleDeleted val="0"/>
+    <c:plotArea>
+      <c:layout/>
+      <c:barChart>
+        <c:barDir val="col"/>
+        <c:grouping val="clustered"/>
+        <c:varyColors val="0"/>
+        <c:ser>
+          <c:idx val="0"/>
+          <c:order val="0"/>
+          <c:tx>
+            <c:strRef>
+              <c:f>Sheet1!$B$1</c:f>
+              <c:strCache>
+                <c:ptCount val="1"/>
+                <c:pt idx="0">
+                  <c:v>Start of day 3</c:v>
+                </c:pt>
+              </c:strCache>
+            </c:strRef>
+          </c:tx>
+          <c:spPr>
+            <a:solidFill>
+              <a:srgbClr val="9AA5B8"/>
+            </a:solidFill>
+            <a:effectLst/>
+          </c:spPr>
+          <c:invertIfNegative val="0"/>
+          <c:dLbls>
+            <c:numFmt formatCode="0.0" sourceLinked="0"/>
+            <c:txPr>
+              <a:bodyPr/>
+              <a:lstStyle/>
+              <a:p>
+                <a:pPr>
+                  <a:defRPr b="0" i="0" strike="noStrike" sz="900" u="none">
+                    <a:solidFill>
+                      <a:srgbClr val="1F2A44"/>
+                    </a:solidFill>
+                    <a:latin typeface="Calibri"/>
+                  </a:defRPr>
+                </a:pPr>
+              </a:p>
+            </c:txPr>
+            <c:showLegendKey val="0"/>
+            <c:showVal val="1"/>
+            <c:showCatName val="0"/>
+            <c:showSerName val="0"/>
+            <c:showPercent val="0"/>
+            <c:showBubbleSize val="0"/>
+            <c:showLeaderLines val="0"/>
+          </c:dLbls>
+          <c:cat>
+            <c:multiLvlStrRef>
+              <c:f>Sheet1!$A$2:$A$7</c:f>
+              <c:multiLvlStrCache>
+                <c:ptCount val="6"/>
+                <c:lvl>
+                  <c:pt idx="0">
+                    <c:v>250–400</c:v>
+                  </c:pt>
+                  <c:pt idx="1">
+                    <c:v>400–630</c:v>
+                  </c:pt>
+                  <c:pt idx="2">
+                    <c:v>630–1k</c:v>
+                  </c:pt>
+                  <c:pt idx="3">
+                    <c:v>1k–1.6k</c:v>
+                  </c:pt>
+                  <c:pt idx="4">
+                    <c:v>1.6k–3k</c:v>
+                  </c:pt>
+                  <c:pt idx="5">
+                    <c:v>5k–6.4k</c:v>
+                  </c:pt>
+                </c:lvl>
+              </c:multiLvlStrCache>
+            </c:multiLvlStrRef>
+          </c:cat>
+          <c:val>
+            <c:numRef>
+              <c:f>Sheet1!$B$2:$B$7</c:f>
+              <c:numCache>
+                <c:formatCode>General</c:formatCode>
+                <c:ptCount val="6"/>
+                <c:pt idx="0">
+                  <c:v>3.33</c:v>
+                </c:pt>
+                <c:pt idx="1">
+                  <c:v>2.57</c:v>
+                </c:pt>
+                <c:pt idx="2">
+                  <c:v>1.57</c:v>
+                </c:pt>
+                <c:pt idx="3">
+                  <c:v>0.8</c:v>
+                </c:pt>
+                <c:pt idx="4">
+                  <c:v>0.87</c:v>
+                </c:pt>
+                <c:pt idx="5">
+                  <c:v>1.04</c:v>
+                </c:pt>
+              </c:numCache>
+            </c:numRef>
+          </c:val>
+        </c:ser>
+        <c:ser>
+          <c:idx val="1"/>
+          <c:order val="1"/>
+          <c:tx>
+            <c:strRef>
+              <c:f>Sheet1!$C$1</c:f>
+              <c:strCache>
+                <c:ptCount val="1"/>
+                <c:pt idx="0">
+                  <c:v>Final</c:v>
+                </c:pt>
+              </c:strCache>
+            </c:strRef>
+          </c:tx>
+          <c:spPr>
+            <a:solidFill>
+              <a:srgbClr val="1F2A44"/>
+            </a:solidFill>
+            <a:effectLst/>
+          </c:spPr>
+          <c:invertIfNegative val="0"/>
+          <c:dLbls>
+            <c:numFmt formatCode="0.0" sourceLinked="0"/>
+            <c:txPr>
+              <a:bodyPr/>
+              <a:lstStyle/>
+              <a:p>
+                <a:pPr>
+                  <a:defRPr b="0" i="0" strike="noStrike" sz="900" u="none">
+                    <a:solidFill>
+                      <a:srgbClr val="1F2A44"/>
+                    </a:solidFill>
+                    <a:latin typeface="Calibri"/>
+                  </a:defRPr>
+                </a:pPr>
+              </a:p>
+            </c:txPr>
+            <c:showLegendKey val="0"/>
+            <c:showVal val="1"/>
+            <c:showCatName val="0"/>
+            <c:showSerName val="0"/>
+            <c:showPercent val="0"/>
+            <c:showBubbleSize val="0"/>
+            <c:showLeaderLines val="0"/>
+          </c:dLbls>
+          <c:cat>
+            <c:multiLvlStrRef>
+              <c:f>Sheet1!$A$2:$A$7</c:f>
+              <c:multiLvlStrCache>
+                <c:ptCount val="6"/>
+                <c:lvl>
+                  <c:pt idx="0">
+                    <c:v>250–400</c:v>
+                  </c:pt>
+                  <c:pt idx="1">
+                    <c:v>400–630</c:v>
+                  </c:pt>
+                  <c:pt idx="2">
+                    <c:v>630–1k</c:v>
+                  </c:pt>
+                  <c:pt idx="3">
+                    <c:v>1k–1.6k</c:v>
+                  </c:pt>
+                  <c:pt idx="4">
+                    <c:v>1.6k–3k</c:v>
+                  </c:pt>
+                  <c:pt idx="5">
+                    <c:v>5k–6.4k</c:v>
+                  </c:pt>
+                </c:lvl>
+              </c:multiLvlStrCache>
+            </c:multiLvlStrRef>
+          </c:cat>
+          <c:val>
+            <c:numRef>
+              <c:f>Sheet1!$C$2:$C$7</c:f>
+              <c:numCache>
+                <c:formatCode>General</c:formatCode>
+                <c:ptCount val="6"/>
+                <c:pt idx="0">
+                  <c:v>1.99</c:v>
+                </c:pt>
+                <c:pt idx="1">
+                  <c:v>1.52</c:v>
+                </c:pt>
+                <c:pt idx="2">
+                  <c:v>1.47</c:v>
+                </c:pt>
+                <c:pt idx="3">
+                  <c:v>0.85</c:v>
+                </c:pt>
+                <c:pt idx="4">
+                  <c:v>0.96</c:v>
+                </c:pt>
+                <c:pt idx="5">
+                  <c:v>1.17</c:v>
+                </c:pt>
+              </c:numCache>
+            </c:numRef>
+          </c:val>
+        </c:ser>
+        <c:dLbls>
+          <c:numFmt formatCode="0.0" sourceLinked="0"/>
+          <c:txPr>
+            <a:bodyPr/>
+            <a:lstStyle/>
+            <a:p>
+              <a:pPr>
+                <a:defRPr b="0" i="0" strike="noStrike" sz="900" u="none">
+                  <a:solidFill>
+                    <a:srgbClr val="1F2A44"/>
+                  </a:solidFill>
+                  <a:latin typeface="Calibri"/>
+                </a:defRPr>
+              </a:pPr>
+            </a:p>
+          </c:txPr>
+          <c:showLegendKey val="0"/>
+          <c:showVal val="1"/>
+          <c:showCatName val="0"/>
+          <c:showSerName val="0"/>
+          <c:showPercent val="0"/>
+          <c:showBubbleSize val="0"/>
+          <c:showLeaderLines val="0"/>
+        </c:dLbls>
+        <c:gapWidth val="50"/>
+        <c:overlap val="0"/>
+        <c:axId val="2094734554"/>
+        <c:axId val="2094734552"/>
+        <c:axId val="2094734556"/>
+      </c:barChart>
+      <c:catAx>
+        <c:axId val="2094734554"/>
+        <c:scaling>
+          <c:orientation val="minMax"/>
+        </c:scaling>
+        <c:delete val="0"/>
+        <c:axPos val="b"/>
+        <c:numFmt formatCode="General" sourceLinked="1"/>
+        <c:majorTickMark val="out"/>
+        <c:minorTickMark val="none"/>
+        <c:tickLblPos val="low"/>
+        <c:spPr>
+          <a:ln w="12700" cap="flat">
+            <a:solidFill>
+              <a:srgbClr val="888888"/>
+            </a:solidFill>
+            <a:prstDash val="solid"/>
+            <a:round/>
+          </a:ln>
+        </c:spPr>
+        <c:txPr>
+          <a:bodyPr/>
+          <a:lstStyle/>
+          <a:p>
+            <a:pPr>
+              <a:defRPr sz="1000" b="0" i="0" u="none" strike="noStrike">
+                <a:solidFill>
+                  <a:srgbClr val="1F2A44"/>
+                </a:solidFill>
+                <a:latin typeface="Calibri"/>
+              </a:defRPr>
+            </a:pPr>
+            <a:endParaRPr lang="en-US"/>
+          </a:p>
+        </c:txPr>
+        <c:crossAx val="2094734552"/>
+        <c:crosses val="autoZero"/>
+        <c:auto val="1"/>
+        <c:lblAlgn val="ctr"/>
+        <c:noMultiLvlLbl val="1"/>
+      </c:catAx>
+      <c:valAx>
+        <c:axId val="2094734552"/>
+        <c:scaling>
+          <c:orientation val="minMax"/>
+          <c:max val="4"/>
+          <c:min val="0"/>
+        </c:scaling>
+        <c:delete val="0"/>
+        <c:axPos val="l"/>
+        <c:majorGridlines>
+          <c:spPr>
+            <a:ln w="6350" cap="flat">
+              <a:solidFill>
+                <a:srgbClr val="E3E7EE"/>
+              </a:solidFill>
+              <a:prstDash val="solid"/>
+              <a:round/>
+            </a:ln>
+          </c:spPr>
+        </c:majorGridlines>
+        <c:numFmt formatCode="General" sourceLinked="0"/>
+        <c:majorTickMark val="out"/>
+        <c:minorTickMark val="none"/>
+        <c:tickLblPos val="nextTo"/>
+        <c:spPr>
+          <a:ln w="12700" cap="flat">
+            <a:solidFill>
+              <a:srgbClr val="888888"/>
+            </a:solidFill>
+            <a:prstDash val="solid"/>
+            <a:round/>
+          </a:ln>
+        </c:spPr>
+        <c:txPr>
+          <a:bodyPr/>
+          <a:lstStyle/>
+          <a:p>
+            <a:pPr>
+              <a:defRPr sz="1000" b="0" i="0" u="none" strike="noStrike">
+                <a:solidFill>
+                  <a:srgbClr val="5B6578"/>
+                </a:solidFill>
+                <a:latin typeface="Calibri"/>
+              </a:defRPr>
+            </a:pPr>
+            <a:endParaRPr lang="en-US"/>
+          </a:p>
+        </c:txPr>
+        <c:crossAx val="2094734554"/>
+        <c:crosses val="autoZero"/>
+        <c:crossBetween val="between"/>
+        <c:majorUnit val="1"/>
+      </c:valAx>
+      <c:spPr>
+        <a:noFill/>
+        <a:ln>
+          <a:noFill/>
+        </a:ln>
+        <a:effectLst/>
+      </c:spPr>
+    </c:plotArea>
+    <c:legend>
+      <c:legendPos val="b"/>
+      <c:overlay val="0"/>
+      <c:txPr>
+        <a:bodyPr/>
+        <a:lstStyle/>
+        <a:p>
+          <a:pPr>
+            <a:defRPr sz="1100">
+              <a:solidFill>
+                <a:srgbClr val="1F2A44"/>
+              </a:solidFill>
+              <a:latin typeface="Calibri"/>
+              <a:cs typeface="Calibri"/>
+            </a:defRPr>
+          </a:pPr>
+          <a:endParaRPr lang="en-US"/>
+        </a:p>
+      </c:txPr>
+    </c:legend>
+    <c:plotVisOnly val="1"/>
+    <c:dispBlanksAs val="span"/>
+  </c:chart>
+  <c:spPr>
+    <a:noFill/>
+    <a:ln>
+      <a:noFill/>
+    </a:ln>
+    <a:effectLst/>
+  </c:spPr>
+  <c:externalData r:id="rId1">
+    <c:autoUpdate val="0"/>
+  </c:externalData>
+</c:chartSpace>
 </file>
 
 <file path=ppt/notesMasters/notesMaster1.xml><?xml version="1.0" encoding="utf-8"?>
@@ -769,7 +1181,7 @@
           <a:p>
             <a:r>
               <a:rPr lang="en-US" dirty="0"/>
-              <a:t>Blue: 30 Sep propeller measurement (11.7 V, 7.3 A, thrust -4 N), read with the 16 Sep microphone corrections. Rms spread about the mean 1.45 dB against 2.05 dB for 31 Aug; range 4.0 dB (55.5 to 59.6 dB SPL) against 6.7 dB. The blue is about 11 dB lower because the motor ran at a different operating point. The 4 dB range of the blue is a bottom-louder trend. Honest caveat: with the same calibration applied to the 1-2 Sep runs, those are about as round as 30 Sep, so most of the improvement against the earlier baselines comes from the microphone calibration, not the room.</a:t>
+              <a:t>Same pair as page 3 of the report (day3-a at 13:17, carpet-reordered at 19:15, both 25 Sep), read with the corrected microphone files. Room error is the rms deviation of the eleven microphones from their mean, per band. Start of day 3: 3.33, 2.57, 1.57, 0.80, 0.87, 1.04 dB; final: 1.99, 1.52, 1.47, 0.85, 0.96, 1.17 dB for the bands 250-400, 400-630, 630-1000, 1000-1600, 1600-3000 and 5000-6400 Hz. Caveat from the report: the loudspeaker was moved on purpose during the day (20 cm closer, into the ring plane, 5 cm back) and then returned to about its starting mounting point, which was not recorded. The tilt of the map changed from -0.41 to -0.63 and the mean level rose 1.16 dB, so the gain is the treatments plus a small unknown difference in source position, and part of it may be the louder direct sound. The clean pair with an unmoved source is 24 Sep: empty floor 2.054 to carpet 1.317 dB.</a:t>
             </a:r>
             <a:endParaRPr lang="en-US" dirty="0"/>
           </a:p>
@@ -793,6 +1205,94 @@
             <a:fld id="{F7021451-1387-4CA6-816F-3879F97B5CBC}" type="slidenum">
               <a:rPr lang="en-US"/>
               <a:t>4</a:t>
+            </a:fld>
+            <a:endParaRPr lang="en-US"/>
+          </a:p>
+        </p:txBody>
+      </p:sp>
+    </p:spTree>
+    <p:extLst>
+      <p:ext uri="{BB962C8B-B14F-4D97-AF65-F5344CB8AC3E}">
+        <p14:creationId xmlns:p14="http://schemas.microsoft.com/office/powerpoint/2010/main" val="1024086991"/>
+      </p:ext>
+    </p:extLst>
+  </p:cSld>
+  <p:clrMapOvr>
+    <a:masterClrMapping/>
+  </p:clrMapOvr>
+</p:notes>
+</file>
+
+<file path=ppt/notesSlides/notesSlide5.xml><?xml version="1.0" encoding="utf-8"?>
+<p:notes xmlns:a="http://schemas.openxmlformats.org/drawingml/2006/main" xmlns:r="http://schemas.openxmlformats.org/officeDocument/2006/relationships" xmlns:p="http://schemas.openxmlformats.org/presentationml/2006/main">
+  <p:cSld>
+    <p:spTree>
+      <p:nvGrpSpPr>
+        <p:cNvPr id="1" name=""/>
+        <p:cNvGrpSpPr/>
+        <p:nvPr/>
+      </p:nvGrpSpPr>
+      <p:grpSpPr>
+        <a:xfrm>
+          <a:off x="0" y="0"/>
+          <a:ext cx="0" cy="0"/>
+          <a:chOff x="0" y="0"/>
+          <a:chExt cx="0" cy="0"/>
+        </a:xfrm>
+      </p:grpSpPr>
+      <p:sp>
+        <p:nvSpPr>
+          <p:cNvPr id="2" name="Slide Image Placeholder 1"/>
+          <p:cNvSpPr>
+            <a:spLocks noGrp="1" noRot="1" noChangeAspect="1"/>
+          </p:cNvSpPr>
+          <p:nvPr>
+            <p:ph type="sldImg"/>
+          </p:nvPr>
+        </p:nvSpPr>
+        <p:spPr/>
+      </p:sp>
+      <p:sp>
+        <p:nvSpPr>
+          <p:cNvPr id="3" name="Notes Placeholder 2"/>
+          <p:cNvSpPr>
+            <a:spLocks noGrp="1"/>
+          </p:cNvSpPr>
+          <p:nvPr>
+            <p:ph type="body" idx="1"/>
+          </p:nvPr>
+        </p:nvSpPr>
+        <p:spPr/>
+        <p:txBody>
+          <a:bodyPr/>
+          <a:lstStyle/>
+          <a:p>
+            <a:r>
+              <a:rPr lang="en-US" dirty="0"/>
+              <a:t>Blue: 30 Sep propeller measurement (11.7 V, 7.3 A, thrust -4 N), read with the 16 Sep microphone corrections. Rms spread about the mean 1.45 dB against 2.05 dB for 31 Aug; range 4.0 dB (55.5 to 59.6 dB SPL) against 6.7 dB. The blue is about 11 dB lower because the motor ran at a different operating point. The 4 dB range of the blue is a bottom-louder trend. Honest caveat: with the same calibration applied to the 1-2 Sep runs, those are about as round as 30 Sep, so most of the improvement against the earlier baselines comes from the microphone calibration, not the room.</a:t>
+            </a:r>
+            <a:endParaRPr lang="en-US" dirty="0"/>
+          </a:p>
+        </p:txBody>
+      </p:sp>
+      <p:sp>
+        <p:nvSpPr>
+          <p:cNvPr id="4" name="Slide Number Placeholder 3"/>
+          <p:cNvSpPr>
+            <a:spLocks noGrp="1"/>
+          </p:cNvSpPr>
+          <p:nvPr>
+            <p:ph type="sldNum" sz="quarter" idx="10"/>
+          </p:nvPr>
+        </p:nvSpPr>
+        <p:spPr/>
+        <p:txBody>
+          <a:bodyPr/>
+          <a:lstStyle/>
+          <a:p>
+            <a:fld id="{F7021451-1387-4CA6-816F-3879F97B5CBC}" type="slidenum">
+              <a:rPr lang="en-US"/>
+              <a:t>5</a:t>
             </a:fld>
             <a:endParaRPr lang="en-US"/>
           </a:p>
@@ -2592,7 +3092,7 @@
       </p:grpSpPr>
       <p:pic>
         <p:nvPicPr>
-          <p:cNvPr id="2" name="Image 0" descr="Polar plot of 20 to 560 Hz: the jagged red 31 Aug outline and the smoother blue 30 Sep outline">    </p:cNvPr>
+          <p:cNvPr id="2" name="Image 0" descr="Maps of each microphone against frequency: start of day 3, final state, and the change between them">    </p:cNvPr>
           <p:cNvPicPr>
             <a:picLocks noChangeAspect="1"/>
           </p:cNvPicPr>
@@ -2606,6 +3106,373 @@
         </p:blipFill>
         <p:spPr>
           <a:xfrm>
+            <a:off x="320040" y="274320"/>
+            <a:ext cx="6958584" cy="5897880"/>
+          </a:xfrm>
+          <a:prstGeom prst="rect">
+            <a:avLst/>
+          </a:prstGeom>
+        </p:spPr>
+      </p:pic>
+      <p:sp>
+        <p:nvSpPr>
+          <p:cNvPr id="3" name="Text 0"/>
+          <p:cNvSpPr txBox="1"/>
+          <p:nvPr/>
+        </p:nvSpPr>
+        <p:spPr>
+          <a:xfrm>
+            <a:off x="8183880" y="457200"/>
+            <a:ext cx="3566160" cy="320040"/>
+          </a:xfrm>
+          <a:prstGeom prst="rect">
+            <a:avLst/>
+          </a:prstGeom>
+          <a:noFill/>
+          <a:ln/>
+        </p:spPr>
+        <p:txBody>
+          <a:bodyPr wrap="square" lIns="0" tIns="0" rIns="0" bIns="0" rtlCol="0" anchor="ctr"/>
+          <a:lstStyle/>
+          <a:p>
+            <a:pPr indent="0" marL="0">
+              <a:buNone/>
+            </a:pPr>
+            <a:r>
+              <a:rPr lang="en-US" sz="1400" b="1" spc="300" kern="0" dirty="0">
+                <a:solidFill>
+                  <a:srgbClr val="2B6CB0"/>
+                </a:solidFill>
+                <a:latin typeface="Calibri" pitchFamily="34" charset="0"/>
+                <a:ea typeface="Calibri" pitchFamily="34" charset="-122"/>
+                <a:cs typeface="Calibri" pitchFamily="34" charset="-120"/>
+              </a:rPr>
+              <a:t>THE CHAMBER</a:t>
+            </a:r>
+            <a:endParaRPr lang="en-US" sz="1400" dirty="0"/>
+          </a:p>
+        </p:txBody>
+      </p:sp>
+      <p:sp>
+        <p:nvSpPr>
+          <p:cNvPr id="4" name="Text 1"/>
+          <p:cNvSpPr txBox="1"/>
+          <p:nvPr/>
+        </p:nvSpPr>
+        <p:spPr>
+          <a:xfrm>
+            <a:off x="8183880" y="777240"/>
+            <a:ext cx="3566160" cy="1097280"/>
+          </a:xfrm>
+          <a:prstGeom prst="rect">
+            <a:avLst/>
+          </a:prstGeom>
+          <a:noFill/>
+          <a:ln/>
+        </p:spPr>
+        <p:txBody>
+          <a:bodyPr wrap="square" lIns="0" tIns="0" rIns="0" bIns="0" rtlCol="0" anchor="t"/>
+          <a:lstStyle/>
+          <a:p>
+            <a:pPr indent="0" marL="0">
+              <a:buNone/>
+            </a:pPr>
+            <a:r>
+              <a:rPr lang="en-US" sz="2800" b="1" dirty="0">
+                <a:solidFill>
+                  <a:srgbClr val="1F2A44"/>
+                </a:solidFill>
+                <a:latin typeface="Cambria" pitchFamily="34" charset="0"/>
+                <a:ea typeface="Cambria" pitchFamily="34" charset="-122"/>
+                <a:cs typeface="Cambria" pitchFamily="34" charset="-120"/>
+              </a:rPr>
+              <a:t>The treatments flatten the low end</a:t>
+            </a:r>
+            <a:endParaRPr lang="en-US" sz="2800" dirty="0"/>
+          </a:p>
+        </p:txBody>
+      </p:sp>
+      <p:graphicFrame>
+        <p:nvGraphicFramePr>
+          <p:cNvPr id="5" name="Chart 0" descr=""/>
+          <p:cNvGraphicFramePr/>
+          <p:nvPr/>
+        </p:nvGraphicFramePr>
+        <p:xfrm>
+          <a:off x="8092440" y="1874520"/>
+          <a:ext cx="3749040" cy="2514600"/>
+        </p:xfrm>
+        <a:graphic xmlns:a="http://schemas.openxmlformats.org/drawingml/2006/main">
+          <a:graphicData uri="http://schemas.openxmlformats.org/drawingml/2006/chart">
+            <c:chart xmlns:c="http://schemas.openxmlformats.org/drawingml/2006/chart" r:id="rId2"/>
+          </a:graphicData>
+        </a:graphic>
+      </p:graphicFrame>
+      <p:sp>
+        <p:nvSpPr>
+          <p:cNvPr id="6" name="Text 2"/>
+          <p:cNvSpPr txBox="1"/>
+          <p:nvPr/>
+        </p:nvSpPr>
+        <p:spPr>
+          <a:xfrm>
+            <a:off x="8183880" y="4434840"/>
+            <a:ext cx="3566160" cy="594360"/>
+          </a:xfrm>
+          <a:prstGeom prst="rect">
+            <a:avLst/>
+          </a:prstGeom>
+          <a:noFill/>
+          <a:ln/>
+        </p:spPr>
+        <p:txBody>
+          <a:bodyPr wrap="square" lIns="0" tIns="0" rIns="0" bIns="0" rtlCol="0" anchor="ctr"/>
+          <a:lstStyle/>
+          <a:p>
+            <a:pPr indent="0" marL="0">
+              <a:buNone/>
+            </a:pPr>
+            <a:r>
+              <a:rPr lang="en-US" sz="3400" b="1" dirty="0">
+                <a:solidFill>
+                  <a:srgbClr val="D6336C"/>
+                </a:solidFill>
+                <a:latin typeface="Cambria" pitchFamily="34" charset="0"/>
+                <a:ea typeface="Cambria" pitchFamily="34" charset="-122"/>
+                <a:cs typeface="Cambria" pitchFamily="34" charset="-120"/>
+              </a:rPr>
+              <a:t>2.00</a:t>
+            </a:r>
+            <a:r>
+              <a:rPr lang="en-US" sz="3400" b="1" dirty="0">
+                <a:solidFill>
+                  <a:srgbClr val="5B6578"/>
+                </a:solidFill>
+                <a:latin typeface="Cambria" pitchFamily="34" charset="0"/>
+                <a:ea typeface="Cambria" pitchFamily="34" charset="-122"/>
+                <a:cs typeface="Cambria" pitchFamily="34" charset="-120"/>
+              </a:rPr>
+              <a:t> → </a:t>
+            </a:r>
+            <a:r>
+              <a:rPr lang="en-US" sz="3400" b="1" dirty="0">
+                <a:solidFill>
+                  <a:srgbClr val="2B6CB0"/>
+                </a:solidFill>
+                <a:latin typeface="Cambria" pitchFamily="34" charset="0"/>
+                <a:ea typeface="Cambria" pitchFamily="34" charset="-122"/>
+                <a:cs typeface="Cambria" pitchFamily="34" charset="-120"/>
+              </a:rPr>
+              <a:t>1.39 dB</a:t>
+            </a:r>
+            <a:endParaRPr lang="en-US" sz="3400" dirty="0"/>
+          </a:p>
+        </p:txBody>
+      </p:sp>
+      <p:sp>
+        <p:nvSpPr>
+          <p:cNvPr id="7" name="Text 3"/>
+          <p:cNvSpPr txBox="1"/>
+          <p:nvPr/>
+        </p:nvSpPr>
+        <p:spPr>
+          <a:xfrm>
+            <a:off x="8183880" y="5029200"/>
+            <a:ext cx="3566160" cy="274320"/>
+          </a:xfrm>
+          <a:prstGeom prst="rect">
+            <a:avLst/>
+          </a:prstGeom>
+          <a:noFill/>
+          <a:ln/>
+        </p:spPr>
+        <p:txBody>
+          <a:bodyPr wrap="square" lIns="0" tIns="0" rIns="0" bIns="0" rtlCol="0" anchor="ctr"/>
+          <a:lstStyle/>
+          <a:p>
+            <a:pPr indent="0" marL="0">
+              <a:buNone/>
+            </a:pPr>
+            <a:r>
+              <a:rPr lang="en-US" sz="1200" dirty="0">
+                <a:solidFill>
+                  <a:srgbClr val="5B6578"/>
+                </a:solidFill>
+                <a:latin typeface="Calibri" pitchFamily="34" charset="0"/>
+                <a:ea typeface="Calibri" pitchFamily="34" charset="-122"/>
+                <a:cs typeface="Calibri" pitchFamily="34" charset="-120"/>
+              </a:rPr>
+              <a:t>room error below 3 kHz</a:t>
+            </a:r>
+            <a:endParaRPr lang="en-US" sz="1200" dirty="0"/>
+          </a:p>
+        </p:txBody>
+      </p:sp>
+      <p:sp>
+        <p:nvSpPr>
+          <p:cNvPr id="8" name="Text 4"/>
+          <p:cNvSpPr txBox="1"/>
+          <p:nvPr/>
+        </p:nvSpPr>
+        <p:spPr>
+          <a:xfrm>
+            <a:off x="8183880" y="5349240"/>
+            <a:ext cx="3566160" cy="868680"/>
+          </a:xfrm>
+          <a:prstGeom prst="rect">
+            <a:avLst/>
+          </a:prstGeom>
+          <a:noFill/>
+          <a:ln/>
+        </p:spPr>
+        <p:txBody>
+          <a:bodyPr wrap="square" lIns="0" tIns="0" rIns="0" bIns="0" rtlCol="0" anchor="t"/>
+          <a:lstStyle/>
+          <a:p>
+            <a:pPr indent="0" marL="0">
+              <a:buNone/>
+            </a:pPr>
+            <a:r>
+              <a:rPr lang="en-US" sz="1400" dirty="0">
+                <a:solidFill>
+                  <a:srgbClr val="1F2A44"/>
+                </a:solidFill>
+                <a:latin typeface="Calibri" pitchFamily="34" charset="0"/>
+                <a:ea typeface="Calibri" pitchFamily="34" charset="-122"/>
+                <a:cs typeface="Calibri" pitchFamily="34" charset="-120"/>
+              </a:rPr>
+              <a:t>Below 630 Hz the error falls by 1.3 and 1.0 dB. Above 1 kHz it does not improve.</a:t>
+            </a:r>
+            <a:endParaRPr lang="en-US" sz="1400" dirty="0"/>
+          </a:p>
+        </p:txBody>
+      </p:sp>
+      <p:sp>
+        <p:nvSpPr>
+          <p:cNvPr id="9" name="Text 5"/>
+          <p:cNvSpPr txBox="1"/>
+          <p:nvPr/>
+        </p:nvSpPr>
+        <p:spPr>
+          <a:xfrm>
+            <a:off x="548640" y="6355080"/>
+            <a:ext cx="10332720" cy="274320"/>
+          </a:xfrm>
+          <a:prstGeom prst="rect">
+            <a:avLst/>
+          </a:prstGeom>
+          <a:noFill/>
+          <a:ln/>
+        </p:spPr>
+        <p:txBody>
+          <a:bodyPr wrap="square" lIns="0" tIns="0" rIns="0" bIns="0" rtlCol="0" anchor="ctr"/>
+          <a:lstStyle/>
+          <a:p>
+            <a:pPr indent="0" marL="0">
+              <a:buNone/>
+            </a:pPr>
+            <a:r>
+              <a:rPr lang="en-US" sz="1100" dirty="0">
+                <a:solidFill>
+                  <a:srgbClr val="5B6578"/>
+                </a:solidFill>
+                <a:latin typeface="Calibri" pitchFamily="34" charset="0"/>
+                <a:ea typeface="Calibri" pitchFamily="34" charset="-122"/>
+                <a:cs typeface="Calibri" pitchFamily="34" charset="-120"/>
+              </a:rPr>
+              <a:t>25 Sep 2026. The loudspeaker was moved during the day and returned to about its starting point; the position was not documented.</a:t>
+            </a:r>
+            <a:endParaRPr lang="en-US" sz="1100" dirty="0"/>
+          </a:p>
+        </p:txBody>
+      </p:sp>
+      <p:sp>
+        <p:nvSpPr>
+          <p:cNvPr id="10" name="Text 6"/>
+          <p:cNvSpPr txBox="1"/>
+          <p:nvPr/>
+        </p:nvSpPr>
+        <p:spPr>
+          <a:xfrm>
+            <a:off x="11155680" y="6355080"/>
+            <a:ext cx="457200" cy="274320"/>
+          </a:xfrm>
+          <a:prstGeom prst="rect">
+            <a:avLst/>
+          </a:prstGeom>
+          <a:noFill/>
+          <a:ln/>
+        </p:spPr>
+        <p:txBody>
+          <a:bodyPr wrap="square" lIns="0" tIns="0" rIns="0" bIns="0" rtlCol="0" anchor="ctr"/>
+          <a:lstStyle/>
+          <a:p>
+            <a:pPr algn="r" indent="0" marL="0">
+              <a:buNone/>
+            </a:pPr>
+            <a:r>
+              <a:rPr lang="en-US" sz="1200" dirty="0">
+                <a:solidFill>
+                  <a:srgbClr val="5B6578"/>
+                </a:solidFill>
+                <a:latin typeface="Calibri" pitchFamily="34" charset="0"/>
+                <a:ea typeface="Calibri" pitchFamily="34" charset="-122"/>
+                <a:cs typeface="Calibri" pitchFamily="34" charset="-120"/>
+              </a:rPr>
+              <a:t>4</a:t>
+            </a:r>
+            <a:endParaRPr lang="en-US" sz="1200" dirty="0"/>
+          </a:p>
+        </p:txBody>
+      </p:sp>
+    </p:spTree>
+  </p:cSld>
+  <p:clrMapOvr>
+    <a:masterClrMapping/>
+  </p:clrMapOvr>
+</p:sld>
+</file>
+
+<file path=ppt/slides/slide5.xml><?xml version="1.0" encoding="utf-8"?>
+<p:sld xmlns:a="http://schemas.openxmlformats.org/drawingml/2006/main" xmlns:r="http://schemas.openxmlformats.org/officeDocument/2006/relationships" xmlns:p="http://schemas.openxmlformats.org/presentationml/2006/main">
+  <p:cSld name="Slide 5">
+    <p:bg>
+      <p:bgPr>
+        <a:solidFill>
+          <a:srgbClr val="FFFFFF"/>
+        </a:solidFill>
+      </p:bgPr>
+    </p:bg>
+    <p:spTree>
+      <p:nvGrpSpPr>
+        <p:cNvPr id="1" name=""/>
+        <p:cNvGrpSpPr/>
+        <p:nvPr/>
+      </p:nvGrpSpPr>
+      <p:grpSpPr>
+        <a:xfrm>
+          <a:off x="0" y="0"/>
+          <a:ext cx="0" cy="0"/>
+          <a:chOff x="0" y="0"/>
+          <a:chExt cx="0" cy="0"/>
+        </a:xfrm>
+      </p:grpSpPr>
+      <p:pic>
+        <p:nvPicPr>
+          <p:cNvPr id="2" name="Image 0" descr="Polar plot of 20 to 560 Hz: the jagged red 31 Aug outline and the smoother blue 30 Sep outline">    </p:cNvPr>
+          <p:cNvPicPr>
+            <a:picLocks noChangeAspect="1"/>
+          </p:cNvPicPr>
+          <p:nvPr/>
+        </p:nvPicPr>
+        <p:blipFill>
+          <a:blip r:embed="rId1"/>
+          <a:stretch>
+            <a:fillRect/>
+          </a:stretch>
+        </p:blipFill>
+        <p:spPr>
+          <a:xfrm>
             <a:off x="548640" y="457200"/>
             <a:ext cx="5440680" cy="5797296"/>
           </a:xfrm>
@@ -2949,7 +3816,7 @@
                 <a:ea typeface="Calibri" pitchFamily="34" charset="-122"/>
                 <a:cs typeface="Calibri" pitchFamily="34" charset="-120"/>
               </a:rPr>
-              <a:t>4</a:t>
+              <a:t>5</a:t>
             </a:r>
             <a:endParaRPr lang="en-US" sz="1200" dirty="0"/>
           </a:p>

</xml_diff>

<commit_message>
Slides: slide 5 gets grid lines on the table and loses the 'within the tolerance from' point
Co-Authored-By: Claude Sonnet 5.5 <noreply@anthropic.com>
</commit_message>
<xml_diff>
--- a/docs/analysis/chamber-final-2026-10-01/slides/chamber-slides.pptx
+++ b/docs/analysis/chamber-final-2026-10-01/slides/chamber-slides.pptx
@@ -3683,16 +3683,34 @@
                     </a:p>
                   </a:txBody>
                   <a:tcPr marL="36576" marR="36576" marT="18288" marB="18288" anchor="ctr">
-                    <a:lnL w="0" cap="flat" cmpd="sng" algn="ctr">
-                      <a:noFill/>
+                    <a:lnL w="9525" cap="flat" cmpd="sng" algn="ctr">
+                      <a:solidFill>
+                        <a:srgbClr val="9AA5B8"/>
+                      </a:solidFill>
+                      <a:prstDash val="solid"/>
+                      <a:round/>
+                      <a:headEnd type="none" w="med" len="med"/>
+                      <a:tailEnd type="none" w="med" len="med"/>
                     </a:lnL>
-                    <a:lnR w="0" cap="flat" cmpd="sng" algn="ctr">
-                      <a:noFill/>
+                    <a:lnR w="9525" cap="flat" cmpd="sng" algn="ctr">
+                      <a:solidFill>
+                        <a:srgbClr val="9AA5B8"/>
+                      </a:solidFill>
+                      <a:prstDash val="solid"/>
+                      <a:round/>
+                      <a:headEnd type="none" w="med" len="med"/>
+                      <a:tailEnd type="none" w="med" len="med"/>
                     </a:lnR>
-                    <a:lnT w="0" cap="flat" cmpd="sng" algn="ctr">
-                      <a:noFill/>
+                    <a:lnT w="9525" cap="flat" cmpd="sng" algn="ctr">
+                      <a:solidFill>
+                        <a:srgbClr val="9AA5B8"/>
+                      </a:solidFill>
+                      <a:prstDash val="solid"/>
+                      <a:round/>
+                      <a:headEnd type="none" w="med" len="med"/>
+                      <a:tailEnd type="none" w="med" len="med"/>
                     </a:lnT>
-                    <a:lnB w="6350" cap="flat" cmpd="sng" algn="ctr">
+                    <a:lnB w="9525" cap="flat" cmpd="sng" algn="ctr">
                       <a:solidFill>
                         <a:srgbClr val="9AA5B8"/>
                       </a:solidFill>
@@ -3730,16 +3748,34 @@
                     </a:p>
                   </a:txBody>
                   <a:tcPr marL="36576" marR="36576" marT="18288" marB="18288" anchor="ctr">
-                    <a:lnL w="0" cap="flat" cmpd="sng" algn="ctr">
-                      <a:noFill/>
+                    <a:lnL w="9525" cap="flat" cmpd="sng" algn="ctr">
+                      <a:solidFill>
+                        <a:srgbClr val="9AA5B8"/>
+                      </a:solidFill>
+                      <a:prstDash val="solid"/>
+                      <a:round/>
+                      <a:headEnd type="none" w="med" len="med"/>
+                      <a:tailEnd type="none" w="med" len="med"/>
                     </a:lnL>
-                    <a:lnR w="0" cap="flat" cmpd="sng" algn="ctr">
-                      <a:noFill/>
+                    <a:lnR w="9525" cap="flat" cmpd="sng" algn="ctr">
+                      <a:solidFill>
+                        <a:srgbClr val="9AA5B8"/>
+                      </a:solidFill>
+                      <a:prstDash val="solid"/>
+                      <a:round/>
+                      <a:headEnd type="none" w="med" len="med"/>
+                      <a:tailEnd type="none" w="med" len="med"/>
                     </a:lnR>
-                    <a:lnT w="0" cap="flat" cmpd="sng" algn="ctr">
-                      <a:noFill/>
+                    <a:lnT w="9525" cap="flat" cmpd="sng" algn="ctr">
+                      <a:solidFill>
+                        <a:srgbClr val="9AA5B8"/>
+                      </a:solidFill>
+                      <a:prstDash val="solid"/>
+                      <a:round/>
+                      <a:headEnd type="none" w="med" len="med"/>
+                      <a:tailEnd type="none" w="med" len="med"/>
                     </a:lnT>
-                    <a:lnB w="6350" cap="flat" cmpd="sng" algn="ctr">
+                    <a:lnB w="9525" cap="flat" cmpd="sng" algn="ctr">
                       <a:solidFill>
                         <a:srgbClr val="9AA5B8"/>
                       </a:solidFill>
@@ -3777,16 +3813,34 @@
                     </a:p>
                   </a:txBody>
                   <a:tcPr marL="36576" marR="36576" marT="18288" marB="18288" anchor="ctr">
-                    <a:lnL w="0" cap="flat" cmpd="sng" algn="ctr">
-                      <a:noFill/>
+                    <a:lnL w="9525" cap="flat" cmpd="sng" algn="ctr">
+                      <a:solidFill>
+                        <a:srgbClr val="9AA5B8"/>
+                      </a:solidFill>
+                      <a:prstDash val="solid"/>
+                      <a:round/>
+                      <a:headEnd type="none" w="med" len="med"/>
+                      <a:tailEnd type="none" w="med" len="med"/>
                     </a:lnL>
-                    <a:lnR w="0" cap="flat" cmpd="sng" algn="ctr">
-                      <a:noFill/>
+                    <a:lnR w="9525" cap="flat" cmpd="sng" algn="ctr">
+                      <a:solidFill>
+                        <a:srgbClr val="9AA5B8"/>
+                      </a:solidFill>
+                      <a:prstDash val="solid"/>
+                      <a:round/>
+                      <a:headEnd type="none" w="med" len="med"/>
+                      <a:tailEnd type="none" w="med" len="med"/>
                     </a:lnR>
-                    <a:lnT w="0" cap="flat" cmpd="sng" algn="ctr">
-                      <a:noFill/>
+                    <a:lnT w="9525" cap="flat" cmpd="sng" algn="ctr">
+                      <a:solidFill>
+                        <a:srgbClr val="9AA5B8"/>
+                      </a:solidFill>
+                      <a:prstDash val="solid"/>
+                      <a:round/>
+                      <a:headEnd type="none" w="med" len="med"/>
+                      <a:tailEnd type="none" w="med" len="med"/>
                     </a:lnT>
-                    <a:lnB w="6350" cap="flat" cmpd="sng" algn="ctr">
+                    <a:lnB w="9525" cap="flat" cmpd="sng" algn="ctr">
                       <a:solidFill>
                         <a:srgbClr val="9AA5B8"/>
                       </a:solidFill>
@@ -3824,16 +3878,34 @@
                     </a:p>
                   </a:txBody>
                   <a:tcPr marL="36576" marR="36576" marT="18288" marB="18288" anchor="ctr">
-                    <a:lnL w="0" cap="flat" cmpd="sng" algn="ctr">
-                      <a:noFill/>
+                    <a:lnL w="25400" cap="flat" cmpd="sng" algn="ctr">
+                      <a:solidFill>
+                        <a:srgbClr val="4A5568"/>
+                      </a:solidFill>
+                      <a:prstDash val="solid"/>
+                      <a:round/>
+                      <a:headEnd type="none" w="med" len="med"/>
+                      <a:tailEnd type="none" w="med" len="med"/>
                     </a:lnL>
-                    <a:lnR w="0" cap="flat" cmpd="sng" algn="ctr">
-                      <a:noFill/>
+                    <a:lnR w="9525" cap="flat" cmpd="sng" algn="ctr">
+                      <a:solidFill>
+                        <a:srgbClr val="9AA5B8"/>
+                      </a:solidFill>
+                      <a:prstDash val="solid"/>
+                      <a:round/>
+                      <a:headEnd type="none" w="med" len="med"/>
+                      <a:tailEnd type="none" w="med" len="med"/>
                     </a:lnR>
-                    <a:lnT w="0" cap="flat" cmpd="sng" algn="ctr">
-                      <a:noFill/>
+                    <a:lnT w="9525" cap="flat" cmpd="sng" algn="ctr">
+                      <a:solidFill>
+                        <a:srgbClr val="9AA5B8"/>
+                      </a:solidFill>
+                      <a:prstDash val="solid"/>
+                      <a:round/>
+                      <a:headEnd type="none" w="med" len="med"/>
+                      <a:tailEnd type="none" w="med" len="med"/>
                     </a:lnT>
-                    <a:lnB w="6350" cap="flat" cmpd="sng" algn="ctr">
+                    <a:lnB w="9525" cap="flat" cmpd="sng" algn="ctr">
                       <a:solidFill>
                         <a:srgbClr val="9AA5B8"/>
                       </a:solidFill>
@@ -3874,16 +3946,34 @@
                     </a:p>
                   </a:txBody>
                   <a:tcPr marL="36576" marR="36576" marT="18288" marB="18288" anchor="ctr">
-                    <a:lnL w="0" cap="flat" cmpd="sng" algn="ctr">
-                      <a:noFill/>
+                    <a:lnL w="25400" cap="flat" cmpd="sng" algn="ctr">
+                      <a:solidFill>
+                        <a:srgbClr val="4A5568"/>
+                      </a:solidFill>
+                      <a:prstDash val="solid"/>
+                      <a:round/>
+                      <a:headEnd type="none" w="med" len="med"/>
+                      <a:tailEnd type="none" w="med" len="med"/>
                     </a:lnL>
-                    <a:lnR w="0" cap="flat" cmpd="sng" algn="ctr">
-                      <a:noFill/>
+                    <a:lnR w="9525" cap="flat" cmpd="sng" algn="ctr">
+                      <a:solidFill>
+                        <a:srgbClr val="9AA5B8"/>
+                      </a:solidFill>
+                      <a:prstDash val="solid"/>
+                      <a:round/>
+                      <a:headEnd type="none" w="med" len="med"/>
+                      <a:tailEnd type="none" w="med" len="med"/>
                     </a:lnR>
-                    <a:lnT w="0" cap="flat" cmpd="sng" algn="ctr">
-                      <a:noFill/>
+                    <a:lnT w="9525" cap="flat" cmpd="sng" algn="ctr">
+                      <a:solidFill>
+                        <a:srgbClr val="9AA5B8"/>
+                      </a:solidFill>
+                      <a:prstDash val="solid"/>
+                      <a:round/>
+                      <a:headEnd type="none" w="med" len="med"/>
+                      <a:tailEnd type="none" w="med" len="med"/>
                     </a:lnT>
-                    <a:lnB w="6350" cap="flat" cmpd="sng" algn="ctr">
+                    <a:lnB w="9525" cap="flat" cmpd="sng" algn="ctr">
                       <a:solidFill>
                         <a:srgbClr val="9AA5B8"/>
                       </a:solidFill>
@@ -3926,16 +4016,34 @@
                     </a:p>
                   </a:txBody>
                   <a:tcPr marL="36576" marR="36576" marT="18288" marB="18288" anchor="ctr">
-                    <a:lnL w="0" cap="flat" cmpd="sng" algn="ctr">
-                      <a:noFill/>
+                    <a:lnL w="9525" cap="flat" cmpd="sng" algn="ctr">
+                      <a:solidFill>
+                        <a:srgbClr val="9AA5B8"/>
+                      </a:solidFill>
+                      <a:prstDash val="solid"/>
+                      <a:round/>
+                      <a:headEnd type="none" w="med" len="med"/>
+                      <a:tailEnd type="none" w="med" len="med"/>
                     </a:lnL>
-                    <a:lnR w="0" cap="flat" cmpd="sng" algn="ctr">
-                      <a:noFill/>
+                    <a:lnR w="9525" cap="flat" cmpd="sng" algn="ctr">
+                      <a:solidFill>
+                        <a:srgbClr val="9AA5B8"/>
+                      </a:solidFill>
+                      <a:prstDash val="solid"/>
+                      <a:round/>
+                      <a:headEnd type="none" w="med" len="med"/>
+                      <a:tailEnd type="none" w="med" len="med"/>
                     </a:lnR>
-                    <a:lnT w="0" cap="flat" cmpd="sng" algn="ctr">
-                      <a:noFill/>
+                    <a:lnT w="9525" cap="flat" cmpd="sng" algn="ctr">
+                      <a:solidFill>
+                        <a:srgbClr val="9AA5B8"/>
+                      </a:solidFill>
+                      <a:prstDash val="solid"/>
+                      <a:round/>
+                      <a:headEnd type="none" w="med" len="med"/>
+                      <a:tailEnd type="none" w="med" len="med"/>
                     </a:lnT>
-                    <a:lnB w="6350" cap="flat" cmpd="sng" algn="ctr">
+                    <a:lnB w="9525" cap="flat" cmpd="sng" algn="ctr">
                       <a:solidFill>
                         <a:srgbClr val="9AA5B8"/>
                       </a:solidFill>
@@ -3973,16 +4081,34 @@
                     </a:p>
                   </a:txBody>
                   <a:tcPr marL="36576" marR="36576" marT="18288" marB="18288" anchor="ctr">
-                    <a:lnL w="0" cap="flat" cmpd="sng" algn="ctr">
-                      <a:noFill/>
+                    <a:lnL w="9525" cap="flat" cmpd="sng" algn="ctr">
+                      <a:solidFill>
+                        <a:srgbClr val="9AA5B8"/>
+                      </a:solidFill>
+                      <a:prstDash val="solid"/>
+                      <a:round/>
+                      <a:headEnd type="none" w="med" len="med"/>
+                      <a:tailEnd type="none" w="med" len="med"/>
                     </a:lnL>
-                    <a:lnR w="0" cap="flat" cmpd="sng" algn="ctr">
-                      <a:noFill/>
+                    <a:lnR w="9525" cap="flat" cmpd="sng" algn="ctr">
+                      <a:solidFill>
+                        <a:srgbClr val="9AA5B8"/>
+                      </a:solidFill>
+                      <a:prstDash val="solid"/>
+                      <a:round/>
+                      <a:headEnd type="none" w="med" len="med"/>
+                      <a:tailEnd type="none" w="med" len="med"/>
                     </a:lnR>
-                    <a:lnT w="0" cap="flat" cmpd="sng" algn="ctr">
-                      <a:noFill/>
+                    <a:lnT w="9525" cap="flat" cmpd="sng" algn="ctr">
+                      <a:solidFill>
+                        <a:srgbClr val="9AA5B8"/>
+                      </a:solidFill>
+                      <a:prstDash val="solid"/>
+                      <a:round/>
+                      <a:headEnd type="none" w="med" len="med"/>
+                      <a:tailEnd type="none" w="med" len="med"/>
                     </a:lnT>
-                    <a:lnB w="6350" cap="flat" cmpd="sng" algn="ctr">
+                    <a:lnB w="9525" cap="flat" cmpd="sng" algn="ctr">
                       <a:solidFill>
                         <a:srgbClr val="9AA5B8"/>
                       </a:solidFill>
@@ -4020,16 +4146,34 @@
                     </a:p>
                   </a:txBody>
                   <a:tcPr marL="36576" marR="36576" marT="18288" marB="18288" anchor="ctr">
-                    <a:lnL w="0" cap="flat" cmpd="sng" algn="ctr">
-                      <a:noFill/>
+                    <a:lnL w="9525" cap="flat" cmpd="sng" algn="ctr">
+                      <a:solidFill>
+                        <a:srgbClr val="9AA5B8"/>
+                      </a:solidFill>
+                      <a:prstDash val="solid"/>
+                      <a:round/>
+                      <a:headEnd type="none" w="med" len="med"/>
+                      <a:tailEnd type="none" w="med" len="med"/>
                     </a:lnL>
-                    <a:lnR w="0" cap="flat" cmpd="sng" algn="ctr">
-                      <a:noFill/>
+                    <a:lnR w="9525" cap="flat" cmpd="sng" algn="ctr">
+                      <a:solidFill>
+                        <a:srgbClr val="9AA5B8"/>
+                      </a:solidFill>
+                      <a:prstDash val="solid"/>
+                      <a:round/>
+                      <a:headEnd type="none" w="med" len="med"/>
+                      <a:tailEnd type="none" w="med" len="med"/>
                     </a:lnR>
-                    <a:lnT w="0" cap="flat" cmpd="sng" algn="ctr">
-                      <a:noFill/>
+                    <a:lnT w="9525" cap="flat" cmpd="sng" algn="ctr">
+                      <a:solidFill>
+                        <a:srgbClr val="9AA5B8"/>
+                      </a:solidFill>
+                      <a:prstDash val="solid"/>
+                      <a:round/>
+                      <a:headEnd type="none" w="med" len="med"/>
+                      <a:tailEnd type="none" w="med" len="med"/>
                     </a:lnT>
-                    <a:lnB w="6350" cap="flat" cmpd="sng" algn="ctr">
+                    <a:lnB w="9525" cap="flat" cmpd="sng" algn="ctr">
                       <a:solidFill>
                         <a:srgbClr val="9AA5B8"/>
                       </a:solidFill>
@@ -4067,16 +4211,34 @@
                     </a:p>
                   </a:txBody>
                   <a:tcPr marL="36576" marR="36576" marT="18288" marB="18288" anchor="ctr">
-                    <a:lnL w="0" cap="flat" cmpd="sng" algn="ctr">
-                      <a:noFill/>
+                    <a:lnL w="25400" cap="flat" cmpd="sng" algn="ctr">
+                      <a:solidFill>
+                        <a:srgbClr val="4A5568"/>
+                      </a:solidFill>
+                      <a:prstDash val="solid"/>
+                      <a:round/>
+                      <a:headEnd type="none" w="med" len="med"/>
+                      <a:tailEnd type="none" w="med" len="med"/>
                     </a:lnL>
-                    <a:lnR w="0" cap="flat" cmpd="sng" algn="ctr">
-                      <a:noFill/>
+                    <a:lnR w="9525" cap="flat" cmpd="sng" algn="ctr">
+                      <a:solidFill>
+                        <a:srgbClr val="9AA5B8"/>
+                      </a:solidFill>
+                      <a:prstDash val="solid"/>
+                      <a:round/>
+                      <a:headEnd type="none" w="med" len="med"/>
+                      <a:tailEnd type="none" w="med" len="med"/>
                     </a:lnR>
-                    <a:lnT w="0" cap="flat" cmpd="sng" algn="ctr">
-                      <a:noFill/>
+                    <a:lnT w="9525" cap="flat" cmpd="sng" algn="ctr">
+                      <a:solidFill>
+                        <a:srgbClr val="9AA5B8"/>
+                      </a:solidFill>
+                      <a:prstDash val="solid"/>
+                      <a:round/>
+                      <a:headEnd type="none" w="med" len="med"/>
+                      <a:tailEnd type="none" w="med" len="med"/>
                     </a:lnT>
-                    <a:lnB w="6350" cap="flat" cmpd="sng" algn="ctr">
+                    <a:lnB w="9525" cap="flat" cmpd="sng" algn="ctr">
                       <a:solidFill>
                         <a:srgbClr val="9AA5B8"/>
                       </a:solidFill>
@@ -4114,16 +4276,34 @@
                     </a:p>
                   </a:txBody>
                   <a:tcPr marL="36576" marR="36576" marT="18288" marB="18288" anchor="ctr">
-                    <a:lnL w="0" cap="flat" cmpd="sng" algn="ctr">
-                      <a:noFill/>
+                    <a:lnL w="9525" cap="flat" cmpd="sng" algn="ctr">
+                      <a:solidFill>
+                        <a:srgbClr val="9AA5B8"/>
+                      </a:solidFill>
+                      <a:prstDash val="solid"/>
+                      <a:round/>
+                      <a:headEnd type="none" w="med" len="med"/>
+                      <a:tailEnd type="none" w="med" len="med"/>
                     </a:lnL>
-                    <a:lnR w="0" cap="flat" cmpd="sng" algn="ctr">
-                      <a:noFill/>
+                    <a:lnR w="9525" cap="flat" cmpd="sng" algn="ctr">
+                      <a:solidFill>
+                        <a:srgbClr val="9AA5B8"/>
+                      </a:solidFill>
+                      <a:prstDash val="solid"/>
+                      <a:round/>
+                      <a:headEnd type="none" w="med" len="med"/>
+                      <a:tailEnd type="none" w="med" len="med"/>
                     </a:lnR>
-                    <a:lnT w="0" cap="flat" cmpd="sng" algn="ctr">
-                      <a:noFill/>
+                    <a:lnT w="9525" cap="flat" cmpd="sng" algn="ctr">
+                      <a:solidFill>
+                        <a:srgbClr val="9AA5B8"/>
+                      </a:solidFill>
+                      <a:prstDash val="solid"/>
+                      <a:round/>
+                      <a:headEnd type="none" w="med" len="med"/>
+                      <a:tailEnd type="none" w="med" len="med"/>
                     </a:lnT>
-                    <a:lnB w="6350" cap="flat" cmpd="sng" algn="ctr">
+                    <a:lnB w="9525" cap="flat" cmpd="sng" algn="ctr">
                       <a:solidFill>
                         <a:srgbClr val="9AA5B8"/>
                       </a:solidFill>
@@ -4161,16 +4341,34 @@
                     </a:p>
                   </a:txBody>
                   <a:tcPr marL="36576" marR="36576" marT="18288" marB="18288" anchor="ctr">
-                    <a:lnL w="0" cap="flat" cmpd="sng" algn="ctr">
-                      <a:noFill/>
+                    <a:lnL w="25400" cap="flat" cmpd="sng" algn="ctr">
+                      <a:solidFill>
+                        <a:srgbClr val="4A5568"/>
+                      </a:solidFill>
+                      <a:prstDash val="solid"/>
+                      <a:round/>
+                      <a:headEnd type="none" w="med" len="med"/>
+                      <a:tailEnd type="none" w="med" len="med"/>
                     </a:lnL>
-                    <a:lnR w="0" cap="flat" cmpd="sng" algn="ctr">
-                      <a:noFill/>
+                    <a:lnR w="9525" cap="flat" cmpd="sng" algn="ctr">
+                      <a:solidFill>
+                        <a:srgbClr val="9AA5B8"/>
+                      </a:solidFill>
+                      <a:prstDash val="solid"/>
+                      <a:round/>
+                      <a:headEnd type="none" w="med" len="med"/>
+                      <a:tailEnd type="none" w="med" len="med"/>
                     </a:lnR>
-                    <a:lnT w="0" cap="flat" cmpd="sng" algn="ctr">
-                      <a:noFill/>
+                    <a:lnT w="9525" cap="flat" cmpd="sng" algn="ctr">
+                      <a:solidFill>
+                        <a:srgbClr val="9AA5B8"/>
+                      </a:solidFill>
+                      <a:prstDash val="solid"/>
+                      <a:round/>
+                      <a:headEnd type="none" w="med" len="med"/>
+                      <a:tailEnd type="none" w="med" len="med"/>
                     </a:lnT>
-                    <a:lnB w="6350" cap="flat" cmpd="sng" algn="ctr">
+                    <a:lnB w="9525" cap="flat" cmpd="sng" algn="ctr">
                       <a:solidFill>
                         <a:srgbClr val="9AA5B8"/>
                       </a:solidFill>
@@ -4208,16 +4406,34 @@
                     </a:p>
                   </a:txBody>
                   <a:tcPr marL="36576" marR="36576" marT="18288" marB="18288" anchor="ctr">
-                    <a:lnL w="0" cap="flat" cmpd="sng" algn="ctr">
-                      <a:noFill/>
+                    <a:lnL w="9525" cap="flat" cmpd="sng" algn="ctr">
+                      <a:solidFill>
+                        <a:srgbClr val="9AA5B8"/>
+                      </a:solidFill>
+                      <a:prstDash val="solid"/>
+                      <a:round/>
+                      <a:headEnd type="none" w="med" len="med"/>
+                      <a:tailEnd type="none" w="med" len="med"/>
                     </a:lnL>
-                    <a:lnR w="0" cap="flat" cmpd="sng" algn="ctr">
-                      <a:noFill/>
+                    <a:lnR w="9525" cap="flat" cmpd="sng" algn="ctr">
+                      <a:solidFill>
+                        <a:srgbClr val="9AA5B8"/>
+                      </a:solidFill>
+                      <a:prstDash val="solid"/>
+                      <a:round/>
+                      <a:headEnd type="none" w="med" len="med"/>
+                      <a:tailEnd type="none" w="med" len="med"/>
                     </a:lnR>
-                    <a:lnT w="0" cap="flat" cmpd="sng" algn="ctr">
-                      <a:noFill/>
+                    <a:lnT w="9525" cap="flat" cmpd="sng" algn="ctr">
+                      <a:solidFill>
+                        <a:srgbClr val="9AA5B8"/>
+                      </a:solidFill>
+                      <a:prstDash val="solid"/>
+                      <a:round/>
+                      <a:headEnd type="none" w="med" len="med"/>
+                      <a:tailEnd type="none" w="med" len="med"/>
                     </a:lnT>
-                    <a:lnB w="6350" cap="flat" cmpd="sng" algn="ctr">
+                    <a:lnB w="9525" cap="flat" cmpd="sng" algn="ctr">
                       <a:solidFill>
                         <a:srgbClr val="9AA5B8"/>
                       </a:solidFill>
@@ -4257,36 +4473,36 @@
                     </a:p>
                   </a:txBody>
                   <a:tcPr marL="36576" marR="36576" marT="18288" marB="18288" anchor="ctr">
-                    <a:lnL w="19050" cap="flat" cmpd="sng" algn="ctr">
-                      <a:solidFill>
-                        <a:srgbClr val="FFFFFF"/>
+                    <a:lnL w="9525" cap="flat" cmpd="sng" algn="ctr">
+                      <a:solidFill>
+                        <a:srgbClr val="9AA5B8"/>
                       </a:solidFill>
                       <a:prstDash val="solid"/>
                       <a:round/>
                       <a:headEnd type="none" w="med" len="med"/>
                       <a:tailEnd type="none" w="med" len="med"/>
                     </a:lnL>
-                    <a:lnR w="19050" cap="flat" cmpd="sng" algn="ctr">
-                      <a:solidFill>
-                        <a:srgbClr val="FFFFFF"/>
+                    <a:lnR w="9525" cap="flat" cmpd="sng" algn="ctr">
+                      <a:solidFill>
+                        <a:srgbClr val="9AA5B8"/>
                       </a:solidFill>
                       <a:prstDash val="solid"/>
                       <a:round/>
                       <a:headEnd type="none" w="med" len="med"/>
                       <a:tailEnd type="none" w="med" len="med"/>
                     </a:lnR>
-                    <a:lnT w="19050" cap="flat" cmpd="sng" algn="ctr">
-                      <a:solidFill>
-                        <a:srgbClr val="FFFFFF"/>
+                    <a:lnT w="9525" cap="flat" cmpd="sng" algn="ctr">
+                      <a:solidFill>
+                        <a:srgbClr val="9AA5B8"/>
                       </a:solidFill>
                       <a:prstDash val="solid"/>
                       <a:round/>
                       <a:headEnd type="none" w="med" len="med"/>
                       <a:tailEnd type="none" w="med" len="med"/>
                     </a:lnT>
-                    <a:lnB w="19050" cap="flat" cmpd="sng" algn="ctr">
-                      <a:solidFill>
-                        <a:srgbClr val="FFFFFF"/>
+                    <a:lnB w="9525" cap="flat" cmpd="sng" algn="ctr">
+                      <a:solidFill>
+                        <a:srgbClr val="9AA5B8"/>
                       </a:solidFill>
                       <a:prstDash val="solid"/>
                       <a:round/>
@@ -4322,36 +4538,36 @@
                     </a:p>
                   </a:txBody>
                   <a:tcPr marL="36576" marR="36576" marT="18288" marB="18288" anchor="ctr">
-                    <a:lnL w="19050" cap="flat" cmpd="sng" algn="ctr">
-                      <a:solidFill>
-                        <a:srgbClr val="FFFFFF"/>
+                    <a:lnL w="9525" cap="flat" cmpd="sng" algn="ctr">
+                      <a:solidFill>
+                        <a:srgbClr val="9AA5B8"/>
                       </a:solidFill>
                       <a:prstDash val="solid"/>
                       <a:round/>
                       <a:headEnd type="none" w="med" len="med"/>
                       <a:tailEnd type="none" w="med" len="med"/>
                     </a:lnL>
-                    <a:lnR w="19050" cap="flat" cmpd="sng" algn="ctr">
-                      <a:solidFill>
-                        <a:srgbClr val="FFFFFF"/>
+                    <a:lnR w="9525" cap="flat" cmpd="sng" algn="ctr">
+                      <a:solidFill>
+                        <a:srgbClr val="9AA5B8"/>
                       </a:solidFill>
                       <a:prstDash val="solid"/>
                       <a:round/>
                       <a:headEnd type="none" w="med" len="med"/>
                       <a:tailEnd type="none" w="med" len="med"/>
                     </a:lnR>
-                    <a:lnT w="19050" cap="flat" cmpd="sng" algn="ctr">
-                      <a:solidFill>
-                        <a:srgbClr val="FFFFFF"/>
+                    <a:lnT w="9525" cap="flat" cmpd="sng" algn="ctr">
+                      <a:solidFill>
+                        <a:srgbClr val="9AA5B8"/>
                       </a:solidFill>
                       <a:prstDash val="solid"/>
                       <a:round/>
                       <a:headEnd type="none" w="med" len="med"/>
                       <a:tailEnd type="none" w="med" len="med"/>
                     </a:lnT>
-                    <a:lnB w="19050" cap="flat" cmpd="sng" algn="ctr">
-                      <a:solidFill>
-                        <a:srgbClr val="FFFFFF"/>
+                    <a:lnB w="9525" cap="flat" cmpd="sng" algn="ctr">
+                      <a:solidFill>
+                        <a:srgbClr val="9AA5B8"/>
                       </a:solidFill>
                       <a:prstDash val="solid"/>
                       <a:round/>
@@ -4387,36 +4603,36 @@
                     </a:p>
                   </a:txBody>
                   <a:tcPr marL="36576" marR="36576" marT="18288" marB="18288" anchor="ctr">
-                    <a:lnL w="19050" cap="flat" cmpd="sng" algn="ctr">
-                      <a:solidFill>
-                        <a:srgbClr val="FFFFFF"/>
+                    <a:lnL w="9525" cap="flat" cmpd="sng" algn="ctr">
+                      <a:solidFill>
+                        <a:srgbClr val="9AA5B8"/>
                       </a:solidFill>
                       <a:prstDash val="solid"/>
                       <a:round/>
                       <a:headEnd type="none" w="med" len="med"/>
                       <a:tailEnd type="none" w="med" len="med"/>
                     </a:lnL>
-                    <a:lnR w="19050" cap="flat" cmpd="sng" algn="ctr">
-                      <a:solidFill>
-                        <a:srgbClr val="FFFFFF"/>
+                    <a:lnR w="9525" cap="flat" cmpd="sng" algn="ctr">
+                      <a:solidFill>
+                        <a:srgbClr val="9AA5B8"/>
                       </a:solidFill>
                       <a:prstDash val="solid"/>
                       <a:round/>
                       <a:headEnd type="none" w="med" len="med"/>
                       <a:tailEnd type="none" w="med" len="med"/>
                     </a:lnR>
-                    <a:lnT w="19050" cap="flat" cmpd="sng" algn="ctr">
-                      <a:solidFill>
-                        <a:srgbClr val="FFFFFF"/>
+                    <a:lnT w="9525" cap="flat" cmpd="sng" algn="ctr">
+                      <a:solidFill>
+                        <a:srgbClr val="9AA5B8"/>
                       </a:solidFill>
                       <a:prstDash val="solid"/>
                       <a:round/>
                       <a:headEnd type="none" w="med" len="med"/>
                       <a:tailEnd type="none" w="med" len="med"/>
                     </a:lnT>
-                    <a:lnB w="19050" cap="flat" cmpd="sng" algn="ctr">
-                      <a:solidFill>
-                        <a:srgbClr val="FFFFFF"/>
+                    <a:lnB w="9525" cap="flat" cmpd="sng" algn="ctr">
+                      <a:solidFill>
+                        <a:srgbClr val="9AA5B8"/>
                       </a:solidFill>
                       <a:prstDash val="solid"/>
                       <a:round/>
@@ -4452,36 +4668,36 @@
                     </a:p>
                   </a:txBody>
                   <a:tcPr marL="36576" marR="36576" marT="18288" marB="18288" anchor="ctr">
-                    <a:lnL w="19050" cap="flat" cmpd="sng" algn="ctr">
-                      <a:solidFill>
-                        <a:srgbClr val="FFFFFF"/>
+                    <a:lnL w="25400" cap="flat" cmpd="sng" algn="ctr">
+                      <a:solidFill>
+                        <a:srgbClr val="4A5568"/>
                       </a:solidFill>
                       <a:prstDash val="solid"/>
                       <a:round/>
                       <a:headEnd type="none" w="med" len="med"/>
                       <a:tailEnd type="none" w="med" len="med"/>
                     </a:lnL>
-                    <a:lnR w="19050" cap="flat" cmpd="sng" algn="ctr">
-                      <a:solidFill>
-                        <a:srgbClr val="FFFFFF"/>
+                    <a:lnR w="9525" cap="flat" cmpd="sng" algn="ctr">
+                      <a:solidFill>
+                        <a:srgbClr val="9AA5B8"/>
                       </a:solidFill>
                       <a:prstDash val="solid"/>
                       <a:round/>
                       <a:headEnd type="none" w="med" len="med"/>
                       <a:tailEnd type="none" w="med" len="med"/>
                     </a:lnR>
-                    <a:lnT w="19050" cap="flat" cmpd="sng" algn="ctr">
-                      <a:solidFill>
-                        <a:srgbClr val="FFFFFF"/>
+                    <a:lnT w="9525" cap="flat" cmpd="sng" algn="ctr">
+                      <a:solidFill>
+                        <a:srgbClr val="9AA5B8"/>
                       </a:solidFill>
                       <a:prstDash val="solid"/>
                       <a:round/>
                       <a:headEnd type="none" w="med" len="med"/>
                       <a:tailEnd type="none" w="med" len="med"/>
                     </a:lnT>
-                    <a:lnB w="19050" cap="flat" cmpd="sng" algn="ctr">
-                      <a:solidFill>
-                        <a:srgbClr val="FFFFFF"/>
+                    <a:lnB w="9525" cap="flat" cmpd="sng" algn="ctr">
+                      <a:solidFill>
+                        <a:srgbClr val="9AA5B8"/>
                       </a:solidFill>
                       <a:prstDash val="solid"/>
                       <a:round/>
@@ -4520,36 +4736,36 @@
                     </a:p>
                   </a:txBody>
                   <a:tcPr marL="36576" marR="36576" marT="18288" marB="18288" anchor="ctr">
-                    <a:lnL w="19050" cap="flat" cmpd="sng" algn="ctr">
-                      <a:solidFill>
-                        <a:srgbClr val="FFFFFF"/>
+                    <a:lnL w="9525" cap="flat" cmpd="sng" algn="ctr">
+                      <a:solidFill>
+                        <a:srgbClr val="9AA5B8"/>
                       </a:solidFill>
                       <a:prstDash val="solid"/>
                       <a:round/>
                       <a:headEnd type="none" w="med" len="med"/>
                       <a:tailEnd type="none" w="med" len="med"/>
                     </a:lnL>
-                    <a:lnR w="19050" cap="flat" cmpd="sng" algn="ctr">
-                      <a:solidFill>
-                        <a:srgbClr val="FFFFFF"/>
+                    <a:lnR w="9525" cap="flat" cmpd="sng" algn="ctr">
+                      <a:solidFill>
+                        <a:srgbClr val="9AA5B8"/>
                       </a:solidFill>
                       <a:prstDash val="solid"/>
                       <a:round/>
                       <a:headEnd type="none" w="med" len="med"/>
                       <a:tailEnd type="none" w="med" len="med"/>
                     </a:lnR>
-                    <a:lnT w="19050" cap="flat" cmpd="sng" algn="ctr">
-                      <a:solidFill>
-                        <a:srgbClr val="FFFFFF"/>
+                    <a:lnT w="9525" cap="flat" cmpd="sng" algn="ctr">
+                      <a:solidFill>
+                        <a:srgbClr val="9AA5B8"/>
                       </a:solidFill>
                       <a:prstDash val="solid"/>
                       <a:round/>
                       <a:headEnd type="none" w="med" len="med"/>
                       <a:tailEnd type="none" w="med" len="med"/>
                     </a:lnT>
-                    <a:lnB w="19050" cap="flat" cmpd="sng" algn="ctr">
-                      <a:solidFill>
-                        <a:srgbClr val="FFFFFF"/>
+                    <a:lnB w="9525" cap="flat" cmpd="sng" algn="ctr">
+                      <a:solidFill>
+                        <a:srgbClr val="9AA5B8"/>
                       </a:solidFill>
                       <a:prstDash val="solid"/>
                       <a:round/>
@@ -4588,36 +4804,36 @@
                     </a:p>
                   </a:txBody>
                   <a:tcPr marL="36576" marR="36576" marT="18288" marB="18288" anchor="ctr">
-                    <a:lnL w="19050" cap="flat" cmpd="sng" algn="ctr">
-                      <a:solidFill>
-                        <a:srgbClr val="FFFFFF"/>
+                    <a:lnL w="25400" cap="flat" cmpd="sng" algn="ctr">
+                      <a:solidFill>
+                        <a:srgbClr val="4A5568"/>
                       </a:solidFill>
                       <a:prstDash val="solid"/>
                       <a:round/>
                       <a:headEnd type="none" w="med" len="med"/>
                       <a:tailEnd type="none" w="med" len="med"/>
                     </a:lnL>
-                    <a:lnR w="19050" cap="flat" cmpd="sng" algn="ctr">
-                      <a:solidFill>
-                        <a:srgbClr val="FFFFFF"/>
+                    <a:lnR w="9525" cap="flat" cmpd="sng" algn="ctr">
+                      <a:solidFill>
+                        <a:srgbClr val="9AA5B8"/>
                       </a:solidFill>
                       <a:prstDash val="solid"/>
                       <a:round/>
                       <a:headEnd type="none" w="med" len="med"/>
                       <a:tailEnd type="none" w="med" len="med"/>
                     </a:lnR>
-                    <a:lnT w="19050" cap="flat" cmpd="sng" algn="ctr">
-                      <a:solidFill>
-                        <a:srgbClr val="FFFFFF"/>
+                    <a:lnT w="9525" cap="flat" cmpd="sng" algn="ctr">
+                      <a:solidFill>
+                        <a:srgbClr val="9AA5B8"/>
                       </a:solidFill>
                       <a:prstDash val="solid"/>
                       <a:round/>
                       <a:headEnd type="none" w="med" len="med"/>
                       <a:tailEnd type="none" w="med" len="med"/>
                     </a:lnT>
-                    <a:lnB w="19050" cap="flat" cmpd="sng" algn="ctr">
-                      <a:solidFill>
-                        <a:srgbClr val="FFFFFF"/>
+                    <a:lnB w="9525" cap="flat" cmpd="sng" algn="ctr">
+                      <a:solidFill>
+                        <a:srgbClr val="9AA5B8"/>
                       </a:solidFill>
                       <a:prstDash val="solid"/>
                       <a:round/>
@@ -4656,36 +4872,36 @@
                     </a:p>
                   </a:txBody>
                   <a:tcPr marL="36576" marR="36576" marT="18288" marB="18288" anchor="ctr">
-                    <a:lnL w="19050" cap="flat" cmpd="sng" algn="ctr">
-                      <a:solidFill>
-                        <a:srgbClr val="FFFFFF"/>
+                    <a:lnL w="9525" cap="flat" cmpd="sng" algn="ctr">
+                      <a:solidFill>
+                        <a:srgbClr val="9AA5B8"/>
                       </a:solidFill>
                       <a:prstDash val="solid"/>
                       <a:round/>
                       <a:headEnd type="none" w="med" len="med"/>
                       <a:tailEnd type="none" w="med" len="med"/>
                     </a:lnL>
-                    <a:lnR w="19050" cap="flat" cmpd="sng" algn="ctr">
-                      <a:solidFill>
-                        <a:srgbClr val="FFFFFF"/>
+                    <a:lnR w="9525" cap="flat" cmpd="sng" algn="ctr">
+                      <a:solidFill>
+                        <a:srgbClr val="9AA5B8"/>
                       </a:solidFill>
                       <a:prstDash val="solid"/>
                       <a:round/>
                       <a:headEnd type="none" w="med" len="med"/>
                       <a:tailEnd type="none" w="med" len="med"/>
                     </a:lnR>
-                    <a:lnT w="19050" cap="flat" cmpd="sng" algn="ctr">
-                      <a:solidFill>
-                        <a:srgbClr val="FFFFFF"/>
+                    <a:lnT w="9525" cap="flat" cmpd="sng" algn="ctr">
+                      <a:solidFill>
+                        <a:srgbClr val="9AA5B8"/>
                       </a:solidFill>
                       <a:prstDash val="solid"/>
                       <a:round/>
                       <a:headEnd type="none" w="med" len="med"/>
                       <a:tailEnd type="none" w="med" len="med"/>
                     </a:lnT>
-                    <a:lnB w="19050" cap="flat" cmpd="sng" algn="ctr">
-                      <a:solidFill>
-                        <a:srgbClr val="FFFFFF"/>
+                    <a:lnB w="9525" cap="flat" cmpd="sng" algn="ctr">
+                      <a:solidFill>
+                        <a:srgbClr val="9AA5B8"/>
                       </a:solidFill>
                       <a:prstDash val="solid"/>
                       <a:round/>
@@ -4726,36 +4942,36 @@
                     </a:p>
                   </a:txBody>
                   <a:tcPr marL="36576" marR="36576" marT="18288" marB="18288" anchor="ctr">
-                    <a:lnL w="19050" cap="flat" cmpd="sng" algn="ctr">
-                      <a:solidFill>
-                        <a:srgbClr val="FFFFFF"/>
+                    <a:lnL w="9525" cap="flat" cmpd="sng" algn="ctr">
+                      <a:solidFill>
+                        <a:srgbClr val="9AA5B8"/>
                       </a:solidFill>
                       <a:prstDash val="solid"/>
                       <a:round/>
                       <a:headEnd type="none" w="med" len="med"/>
                       <a:tailEnd type="none" w="med" len="med"/>
                     </a:lnL>
-                    <a:lnR w="19050" cap="flat" cmpd="sng" algn="ctr">
-                      <a:solidFill>
-                        <a:srgbClr val="FFFFFF"/>
+                    <a:lnR w="9525" cap="flat" cmpd="sng" algn="ctr">
+                      <a:solidFill>
+                        <a:srgbClr val="9AA5B8"/>
                       </a:solidFill>
                       <a:prstDash val="solid"/>
                       <a:round/>
                       <a:headEnd type="none" w="med" len="med"/>
                       <a:tailEnd type="none" w="med" len="med"/>
                     </a:lnR>
-                    <a:lnT w="19050" cap="flat" cmpd="sng" algn="ctr">
-                      <a:solidFill>
-                        <a:srgbClr val="FFFFFF"/>
+                    <a:lnT w="9525" cap="flat" cmpd="sng" algn="ctr">
+                      <a:solidFill>
+                        <a:srgbClr val="9AA5B8"/>
                       </a:solidFill>
                       <a:prstDash val="solid"/>
                       <a:round/>
                       <a:headEnd type="none" w="med" len="med"/>
                       <a:tailEnd type="none" w="med" len="med"/>
                     </a:lnT>
-                    <a:lnB w="19050" cap="flat" cmpd="sng" algn="ctr">
-                      <a:solidFill>
-                        <a:srgbClr val="FFFFFF"/>
+                    <a:lnB w="9525" cap="flat" cmpd="sng" algn="ctr">
+                      <a:solidFill>
+                        <a:srgbClr val="9AA5B8"/>
                       </a:solidFill>
                       <a:prstDash val="solid"/>
                       <a:round/>
@@ -4791,36 +5007,36 @@
                     </a:p>
                   </a:txBody>
                   <a:tcPr marL="36576" marR="36576" marT="18288" marB="18288" anchor="ctr">
-                    <a:lnL w="19050" cap="flat" cmpd="sng" algn="ctr">
-                      <a:solidFill>
-                        <a:srgbClr val="FFFFFF"/>
+                    <a:lnL w="9525" cap="flat" cmpd="sng" algn="ctr">
+                      <a:solidFill>
+                        <a:srgbClr val="9AA5B8"/>
                       </a:solidFill>
                       <a:prstDash val="solid"/>
                       <a:round/>
                       <a:headEnd type="none" w="med" len="med"/>
                       <a:tailEnd type="none" w="med" len="med"/>
                     </a:lnL>
-                    <a:lnR w="19050" cap="flat" cmpd="sng" algn="ctr">
-                      <a:solidFill>
-                        <a:srgbClr val="FFFFFF"/>
+                    <a:lnR w="9525" cap="flat" cmpd="sng" algn="ctr">
+                      <a:solidFill>
+                        <a:srgbClr val="9AA5B8"/>
                       </a:solidFill>
                       <a:prstDash val="solid"/>
                       <a:round/>
                       <a:headEnd type="none" w="med" len="med"/>
                       <a:tailEnd type="none" w="med" len="med"/>
                     </a:lnR>
-                    <a:lnT w="19050" cap="flat" cmpd="sng" algn="ctr">
-                      <a:solidFill>
-                        <a:srgbClr val="FFFFFF"/>
+                    <a:lnT w="9525" cap="flat" cmpd="sng" algn="ctr">
+                      <a:solidFill>
+                        <a:srgbClr val="9AA5B8"/>
                       </a:solidFill>
                       <a:prstDash val="solid"/>
                       <a:round/>
                       <a:headEnd type="none" w="med" len="med"/>
                       <a:tailEnd type="none" w="med" len="med"/>
                     </a:lnT>
-                    <a:lnB w="19050" cap="flat" cmpd="sng" algn="ctr">
-                      <a:solidFill>
-                        <a:srgbClr val="FFFFFF"/>
+                    <a:lnB w="9525" cap="flat" cmpd="sng" algn="ctr">
+                      <a:solidFill>
+                        <a:srgbClr val="9AA5B8"/>
                       </a:solidFill>
                       <a:prstDash val="solid"/>
                       <a:round/>
@@ -4856,36 +5072,36 @@
                     </a:p>
                   </a:txBody>
                   <a:tcPr marL="36576" marR="36576" marT="18288" marB="18288" anchor="ctr">
-                    <a:lnL w="19050" cap="flat" cmpd="sng" algn="ctr">
-                      <a:solidFill>
-                        <a:srgbClr val="FFFFFF"/>
+                    <a:lnL w="9525" cap="flat" cmpd="sng" algn="ctr">
+                      <a:solidFill>
+                        <a:srgbClr val="9AA5B8"/>
                       </a:solidFill>
                       <a:prstDash val="solid"/>
                       <a:round/>
                       <a:headEnd type="none" w="med" len="med"/>
                       <a:tailEnd type="none" w="med" len="med"/>
                     </a:lnL>
-                    <a:lnR w="19050" cap="flat" cmpd="sng" algn="ctr">
-                      <a:solidFill>
-                        <a:srgbClr val="FFFFFF"/>
+                    <a:lnR w="9525" cap="flat" cmpd="sng" algn="ctr">
+                      <a:solidFill>
+                        <a:srgbClr val="9AA5B8"/>
                       </a:solidFill>
                       <a:prstDash val="solid"/>
                       <a:round/>
                       <a:headEnd type="none" w="med" len="med"/>
                       <a:tailEnd type="none" w="med" len="med"/>
                     </a:lnR>
-                    <a:lnT w="19050" cap="flat" cmpd="sng" algn="ctr">
-                      <a:solidFill>
-                        <a:srgbClr val="FFFFFF"/>
+                    <a:lnT w="9525" cap="flat" cmpd="sng" algn="ctr">
+                      <a:solidFill>
+                        <a:srgbClr val="9AA5B8"/>
                       </a:solidFill>
                       <a:prstDash val="solid"/>
                       <a:round/>
                       <a:headEnd type="none" w="med" len="med"/>
                       <a:tailEnd type="none" w="med" len="med"/>
                     </a:lnT>
-                    <a:lnB w="19050" cap="flat" cmpd="sng" algn="ctr">
-                      <a:solidFill>
-                        <a:srgbClr val="FFFFFF"/>
+                    <a:lnB w="9525" cap="flat" cmpd="sng" algn="ctr">
+                      <a:solidFill>
+                        <a:srgbClr val="9AA5B8"/>
                       </a:solidFill>
                       <a:prstDash val="solid"/>
                       <a:round/>
@@ -4921,36 +5137,36 @@
                     </a:p>
                   </a:txBody>
                   <a:tcPr marL="36576" marR="36576" marT="18288" marB="18288" anchor="ctr">
-                    <a:lnL w="19050" cap="flat" cmpd="sng" algn="ctr">
-                      <a:solidFill>
-                        <a:srgbClr val="FFFFFF"/>
+                    <a:lnL w="25400" cap="flat" cmpd="sng" algn="ctr">
+                      <a:solidFill>
+                        <a:srgbClr val="4A5568"/>
                       </a:solidFill>
                       <a:prstDash val="solid"/>
                       <a:round/>
                       <a:headEnd type="none" w="med" len="med"/>
                       <a:tailEnd type="none" w="med" len="med"/>
                     </a:lnL>
-                    <a:lnR w="19050" cap="flat" cmpd="sng" algn="ctr">
-                      <a:solidFill>
-                        <a:srgbClr val="FFFFFF"/>
+                    <a:lnR w="9525" cap="flat" cmpd="sng" algn="ctr">
+                      <a:solidFill>
+                        <a:srgbClr val="9AA5B8"/>
                       </a:solidFill>
                       <a:prstDash val="solid"/>
                       <a:round/>
                       <a:headEnd type="none" w="med" len="med"/>
                       <a:tailEnd type="none" w="med" len="med"/>
                     </a:lnR>
-                    <a:lnT w="19050" cap="flat" cmpd="sng" algn="ctr">
-                      <a:solidFill>
-                        <a:srgbClr val="FFFFFF"/>
+                    <a:lnT w="9525" cap="flat" cmpd="sng" algn="ctr">
+                      <a:solidFill>
+                        <a:srgbClr val="9AA5B8"/>
                       </a:solidFill>
                       <a:prstDash val="solid"/>
                       <a:round/>
                       <a:headEnd type="none" w="med" len="med"/>
                       <a:tailEnd type="none" w="med" len="med"/>
                     </a:lnT>
-                    <a:lnB w="19050" cap="flat" cmpd="sng" algn="ctr">
-                      <a:solidFill>
-                        <a:srgbClr val="FFFFFF"/>
+                    <a:lnB w="9525" cap="flat" cmpd="sng" algn="ctr">
+                      <a:solidFill>
+                        <a:srgbClr val="9AA5B8"/>
                       </a:solidFill>
                       <a:prstDash val="solid"/>
                       <a:round/>
@@ -4989,36 +5205,36 @@
                     </a:p>
                   </a:txBody>
                   <a:tcPr marL="36576" marR="36576" marT="18288" marB="18288" anchor="ctr">
-                    <a:lnL w="19050" cap="flat" cmpd="sng" algn="ctr">
-                      <a:solidFill>
-                        <a:srgbClr val="FFFFFF"/>
+                    <a:lnL w="9525" cap="flat" cmpd="sng" algn="ctr">
+                      <a:solidFill>
+                        <a:srgbClr val="9AA5B8"/>
                       </a:solidFill>
                       <a:prstDash val="solid"/>
                       <a:round/>
                       <a:headEnd type="none" w="med" len="med"/>
                       <a:tailEnd type="none" w="med" len="med"/>
                     </a:lnL>
-                    <a:lnR w="19050" cap="flat" cmpd="sng" algn="ctr">
-                      <a:solidFill>
-                        <a:srgbClr val="FFFFFF"/>
+                    <a:lnR w="9525" cap="flat" cmpd="sng" algn="ctr">
+                      <a:solidFill>
+                        <a:srgbClr val="9AA5B8"/>
                       </a:solidFill>
                       <a:prstDash val="solid"/>
                       <a:round/>
                       <a:headEnd type="none" w="med" len="med"/>
                       <a:tailEnd type="none" w="med" len="med"/>
                     </a:lnR>
-                    <a:lnT w="19050" cap="flat" cmpd="sng" algn="ctr">
-                      <a:solidFill>
-                        <a:srgbClr val="FFFFFF"/>
+                    <a:lnT w="9525" cap="flat" cmpd="sng" algn="ctr">
+                      <a:solidFill>
+                        <a:srgbClr val="9AA5B8"/>
                       </a:solidFill>
                       <a:prstDash val="solid"/>
                       <a:round/>
                       <a:headEnd type="none" w="med" len="med"/>
                       <a:tailEnd type="none" w="med" len="med"/>
                     </a:lnT>
-                    <a:lnB w="19050" cap="flat" cmpd="sng" algn="ctr">
-                      <a:solidFill>
-                        <a:srgbClr val="FFFFFF"/>
+                    <a:lnB w="9525" cap="flat" cmpd="sng" algn="ctr">
+                      <a:solidFill>
+                        <a:srgbClr val="9AA5B8"/>
                       </a:solidFill>
                       <a:prstDash val="solid"/>
                       <a:round/>
@@ -5057,36 +5273,36 @@
                     </a:p>
                   </a:txBody>
                   <a:tcPr marL="36576" marR="36576" marT="18288" marB="18288" anchor="ctr">
-                    <a:lnL w="19050" cap="flat" cmpd="sng" algn="ctr">
-                      <a:solidFill>
-                        <a:srgbClr val="FFFFFF"/>
+                    <a:lnL w="25400" cap="flat" cmpd="sng" algn="ctr">
+                      <a:solidFill>
+                        <a:srgbClr val="4A5568"/>
                       </a:solidFill>
                       <a:prstDash val="solid"/>
                       <a:round/>
                       <a:headEnd type="none" w="med" len="med"/>
                       <a:tailEnd type="none" w="med" len="med"/>
                     </a:lnL>
-                    <a:lnR w="19050" cap="flat" cmpd="sng" algn="ctr">
-                      <a:solidFill>
-                        <a:srgbClr val="FFFFFF"/>
+                    <a:lnR w="9525" cap="flat" cmpd="sng" algn="ctr">
+                      <a:solidFill>
+                        <a:srgbClr val="9AA5B8"/>
                       </a:solidFill>
                       <a:prstDash val="solid"/>
                       <a:round/>
                       <a:headEnd type="none" w="med" len="med"/>
                       <a:tailEnd type="none" w="med" len="med"/>
                     </a:lnR>
-                    <a:lnT w="19050" cap="flat" cmpd="sng" algn="ctr">
-                      <a:solidFill>
-                        <a:srgbClr val="FFFFFF"/>
+                    <a:lnT w="9525" cap="flat" cmpd="sng" algn="ctr">
+                      <a:solidFill>
+                        <a:srgbClr val="9AA5B8"/>
                       </a:solidFill>
                       <a:prstDash val="solid"/>
                       <a:round/>
                       <a:headEnd type="none" w="med" len="med"/>
                       <a:tailEnd type="none" w="med" len="med"/>
                     </a:lnT>
-                    <a:lnB w="19050" cap="flat" cmpd="sng" algn="ctr">
-                      <a:solidFill>
-                        <a:srgbClr val="FFFFFF"/>
+                    <a:lnB w="9525" cap="flat" cmpd="sng" algn="ctr">
+                      <a:solidFill>
+                        <a:srgbClr val="9AA5B8"/>
                       </a:solidFill>
                       <a:prstDash val="solid"/>
                       <a:round/>
@@ -5125,36 +5341,36 @@
                     </a:p>
                   </a:txBody>
                   <a:tcPr marL="36576" marR="36576" marT="18288" marB="18288" anchor="ctr">
-                    <a:lnL w="19050" cap="flat" cmpd="sng" algn="ctr">
-                      <a:solidFill>
-                        <a:srgbClr val="FFFFFF"/>
+                    <a:lnL w="9525" cap="flat" cmpd="sng" algn="ctr">
+                      <a:solidFill>
+                        <a:srgbClr val="9AA5B8"/>
                       </a:solidFill>
                       <a:prstDash val="solid"/>
                       <a:round/>
                       <a:headEnd type="none" w="med" len="med"/>
                       <a:tailEnd type="none" w="med" len="med"/>
                     </a:lnL>
-                    <a:lnR w="19050" cap="flat" cmpd="sng" algn="ctr">
-                      <a:solidFill>
-                        <a:srgbClr val="FFFFFF"/>
+                    <a:lnR w="9525" cap="flat" cmpd="sng" algn="ctr">
+                      <a:solidFill>
+                        <a:srgbClr val="9AA5B8"/>
                       </a:solidFill>
                       <a:prstDash val="solid"/>
                       <a:round/>
                       <a:headEnd type="none" w="med" len="med"/>
                       <a:tailEnd type="none" w="med" len="med"/>
                     </a:lnR>
-                    <a:lnT w="19050" cap="flat" cmpd="sng" algn="ctr">
-                      <a:solidFill>
-                        <a:srgbClr val="FFFFFF"/>
+                    <a:lnT w="9525" cap="flat" cmpd="sng" algn="ctr">
+                      <a:solidFill>
+                        <a:srgbClr val="9AA5B8"/>
                       </a:solidFill>
                       <a:prstDash val="solid"/>
                       <a:round/>
                       <a:headEnd type="none" w="med" len="med"/>
                       <a:tailEnd type="none" w="med" len="med"/>
                     </a:lnT>
-                    <a:lnB w="19050" cap="flat" cmpd="sng" algn="ctr">
-                      <a:solidFill>
-                        <a:srgbClr val="FFFFFF"/>
+                    <a:lnB w="9525" cap="flat" cmpd="sng" algn="ctr">
+                      <a:solidFill>
+                        <a:srgbClr val="9AA5B8"/>
                       </a:solidFill>
                       <a:prstDash val="solid"/>
                       <a:round/>
@@ -5195,36 +5411,36 @@
                     </a:p>
                   </a:txBody>
                   <a:tcPr marL="36576" marR="36576" marT="18288" marB="18288" anchor="ctr">
-                    <a:lnL w="19050" cap="flat" cmpd="sng" algn="ctr">
-                      <a:solidFill>
-                        <a:srgbClr val="FFFFFF"/>
+                    <a:lnL w="9525" cap="flat" cmpd="sng" algn="ctr">
+                      <a:solidFill>
+                        <a:srgbClr val="9AA5B8"/>
                       </a:solidFill>
                       <a:prstDash val="solid"/>
                       <a:round/>
                       <a:headEnd type="none" w="med" len="med"/>
                       <a:tailEnd type="none" w="med" len="med"/>
                     </a:lnL>
-                    <a:lnR w="19050" cap="flat" cmpd="sng" algn="ctr">
-                      <a:solidFill>
-                        <a:srgbClr val="FFFFFF"/>
+                    <a:lnR w="9525" cap="flat" cmpd="sng" algn="ctr">
+                      <a:solidFill>
+                        <a:srgbClr val="9AA5B8"/>
                       </a:solidFill>
                       <a:prstDash val="solid"/>
                       <a:round/>
                       <a:headEnd type="none" w="med" len="med"/>
                       <a:tailEnd type="none" w="med" len="med"/>
                     </a:lnR>
-                    <a:lnT w="19050" cap="flat" cmpd="sng" algn="ctr">
-                      <a:solidFill>
-                        <a:srgbClr val="FFFFFF"/>
+                    <a:lnT w="9525" cap="flat" cmpd="sng" algn="ctr">
+                      <a:solidFill>
+                        <a:srgbClr val="9AA5B8"/>
                       </a:solidFill>
                       <a:prstDash val="solid"/>
                       <a:round/>
                       <a:headEnd type="none" w="med" len="med"/>
                       <a:tailEnd type="none" w="med" len="med"/>
                     </a:lnT>
-                    <a:lnB w="19050" cap="flat" cmpd="sng" algn="ctr">
-                      <a:solidFill>
-                        <a:srgbClr val="FFFFFF"/>
+                    <a:lnB w="9525" cap="flat" cmpd="sng" algn="ctr">
+                      <a:solidFill>
+                        <a:srgbClr val="9AA5B8"/>
                       </a:solidFill>
                       <a:prstDash val="solid"/>
                       <a:round/>
@@ -5260,36 +5476,36 @@
                     </a:p>
                   </a:txBody>
                   <a:tcPr marL="36576" marR="36576" marT="18288" marB="18288" anchor="ctr">
-                    <a:lnL w="19050" cap="flat" cmpd="sng" algn="ctr">
-                      <a:solidFill>
-                        <a:srgbClr val="FFFFFF"/>
+                    <a:lnL w="9525" cap="flat" cmpd="sng" algn="ctr">
+                      <a:solidFill>
+                        <a:srgbClr val="9AA5B8"/>
                       </a:solidFill>
                       <a:prstDash val="solid"/>
                       <a:round/>
                       <a:headEnd type="none" w="med" len="med"/>
                       <a:tailEnd type="none" w="med" len="med"/>
                     </a:lnL>
-                    <a:lnR w="19050" cap="flat" cmpd="sng" algn="ctr">
-                      <a:solidFill>
-                        <a:srgbClr val="FFFFFF"/>
+                    <a:lnR w="9525" cap="flat" cmpd="sng" algn="ctr">
+                      <a:solidFill>
+                        <a:srgbClr val="9AA5B8"/>
                       </a:solidFill>
                       <a:prstDash val="solid"/>
                       <a:round/>
                       <a:headEnd type="none" w="med" len="med"/>
                       <a:tailEnd type="none" w="med" len="med"/>
                     </a:lnR>
-                    <a:lnT w="19050" cap="flat" cmpd="sng" algn="ctr">
-                      <a:solidFill>
-                        <a:srgbClr val="FFFFFF"/>
+                    <a:lnT w="9525" cap="flat" cmpd="sng" algn="ctr">
+                      <a:solidFill>
+                        <a:srgbClr val="9AA5B8"/>
                       </a:solidFill>
                       <a:prstDash val="solid"/>
                       <a:round/>
                       <a:headEnd type="none" w="med" len="med"/>
                       <a:tailEnd type="none" w="med" len="med"/>
                     </a:lnT>
-                    <a:lnB w="19050" cap="flat" cmpd="sng" algn="ctr">
-                      <a:solidFill>
-                        <a:srgbClr val="FFFFFF"/>
+                    <a:lnB w="9525" cap="flat" cmpd="sng" algn="ctr">
+                      <a:solidFill>
+                        <a:srgbClr val="9AA5B8"/>
                       </a:solidFill>
                       <a:prstDash val="solid"/>
                       <a:round/>
@@ -5325,36 +5541,36 @@
                     </a:p>
                   </a:txBody>
                   <a:tcPr marL="36576" marR="36576" marT="18288" marB="18288" anchor="ctr">
-                    <a:lnL w="19050" cap="flat" cmpd="sng" algn="ctr">
-                      <a:solidFill>
-                        <a:srgbClr val="FFFFFF"/>
+                    <a:lnL w="9525" cap="flat" cmpd="sng" algn="ctr">
+                      <a:solidFill>
+                        <a:srgbClr val="9AA5B8"/>
                       </a:solidFill>
                       <a:prstDash val="solid"/>
                       <a:round/>
                       <a:headEnd type="none" w="med" len="med"/>
                       <a:tailEnd type="none" w="med" len="med"/>
                     </a:lnL>
-                    <a:lnR w="19050" cap="flat" cmpd="sng" algn="ctr">
-                      <a:solidFill>
-                        <a:srgbClr val="FFFFFF"/>
+                    <a:lnR w="9525" cap="flat" cmpd="sng" algn="ctr">
+                      <a:solidFill>
+                        <a:srgbClr val="9AA5B8"/>
                       </a:solidFill>
                       <a:prstDash val="solid"/>
                       <a:round/>
                       <a:headEnd type="none" w="med" len="med"/>
                       <a:tailEnd type="none" w="med" len="med"/>
                     </a:lnR>
-                    <a:lnT w="19050" cap="flat" cmpd="sng" algn="ctr">
-                      <a:solidFill>
-                        <a:srgbClr val="FFFFFF"/>
+                    <a:lnT w="9525" cap="flat" cmpd="sng" algn="ctr">
+                      <a:solidFill>
+                        <a:srgbClr val="9AA5B8"/>
                       </a:solidFill>
                       <a:prstDash val="solid"/>
                       <a:round/>
                       <a:headEnd type="none" w="med" len="med"/>
                       <a:tailEnd type="none" w="med" len="med"/>
                     </a:lnT>
-                    <a:lnB w="19050" cap="flat" cmpd="sng" algn="ctr">
-                      <a:solidFill>
-                        <a:srgbClr val="FFFFFF"/>
+                    <a:lnB w="9525" cap="flat" cmpd="sng" algn="ctr">
+                      <a:solidFill>
+                        <a:srgbClr val="9AA5B8"/>
                       </a:solidFill>
                       <a:prstDash val="solid"/>
                       <a:round/>
@@ -5390,36 +5606,36 @@
                     </a:p>
                   </a:txBody>
                   <a:tcPr marL="36576" marR="36576" marT="18288" marB="18288" anchor="ctr">
-                    <a:lnL w="19050" cap="flat" cmpd="sng" algn="ctr">
-                      <a:solidFill>
-                        <a:srgbClr val="FFFFFF"/>
+                    <a:lnL w="25400" cap="flat" cmpd="sng" algn="ctr">
+                      <a:solidFill>
+                        <a:srgbClr val="4A5568"/>
                       </a:solidFill>
                       <a:prstDash val="solid"/>
                       <a:round/>
                       <a:headEnd type="none" w="med" len="med"/>
                       <a:tailEnd type="none" w="med" len="med"/>
                     </a:lnL>
-                    <a:lnR w="19050" cap="flat" cmpd="sng" algn="ctr">
-                      <a:solidFill>
-                        <a:srgbClr val="FFFFFF"/>
+                    <a:lnR w="9525" cap="flat" cmpd="sng" algn="ctr">
+                      <a:solidFill>
+                        <a:srgbClr val="9AA5B8"/>
                       </a:solidFill>
                       <a:prstDash val="solid"/>
                       <a:round/>
                       <a:headEnd type="none" w="med" len="med"/>
                       <a:tailEnd type="none" w="med" len="med"/>
                     </a:lnR>
-                    <a:lnT w="19050" cap="flat" cmpd="sng" algn="ctr">
-                      <a:solidFill>
-                        <a:srgbClr val="FFFFFF"/>
+                    <a:lnT w="9525" cap="flat" cmpd="sng" algn="ctr">
+                      <a:solidFill>
+                        <a:srgbClr val="9AA5B8"/>
                       </a:solidFill>
                       <a:prstDash val="solid"/>
                       <a:round/>
                       <a:headEnd type="none" w="med" len="med"/>
                       <a:tailEnd type="none" w="med" len="med"/>
                     </a:lnT>
-                    <a:lnB w="19050" cap="flat" cmpd="sng" algn="ctr">
-                      <a:solidFill>
-                        <a:srgbClr val="FFFFFF"/>
+                    <a:lnB w="9525" cap="flat" cmpd="sng" algn="ctr">
+                      <a:solidFill>
+                        <a:srgbClr val="9AA5B8"/>
                       </a:solidFill>
                       <a:prstDash val="solid"/>
                       <a:round/>
@@ -5458,36 +5674,36 @@
                     </a:p>
                   </a:txBody>
                   <a:tcPr marL="36576" marR="36576" marT="18288" marB="18288" anchor="ctr">
-                    <a:lnL w="19050" cap="flat" cmpd="sng" algn="ctr">
-                      <a:solidFill>
-                        <a:srgbClr val="FFFFFF"/>
+                    <a:lnL w="9525" cap="flat" cmpd="sng" algn="ctr">
+                      <a:solidFill>
+                        <a:srgbClr val="9AA5B8"/>
                       </a:solidFill>
                       <a:prstDash val="solid"/>
                       <a:round/>
                       <a:headEnd type="none" w="med" len="med"/>
                       <a:tailEnd type="none" w="med" len="med"/>
                     </a:lnL>
-                    <a:lnR w="19050" cap="flat" cmpd="sng" algn="ctr">
-                      <a:solidFill>
-                        <a:srgbClr val="FFFFFF"/>
+                    <a:lnR w="9525" cap="flat" cmpd="sng" algn="ctr">
+                      <a:solidFill>
+                        <a:srgbClr val="9AA5B8"/>
                       </a:solidFill>
                       <a:prstDash val="solid"/>
                       <a:round/>
                       <a:headEnd type="none" w="med" len="med"/>
                       <a:tailEnd type="none" w="med" len="med"/>
                     </a:lnR>
-                    <a:lnT w="19050" cap="flat" cmpd="sng" algn="ctr">
-                      <a:solidFill>
-                        <a:srgbClr val="FFFFFF"/>
+                    <a:lnT w="9525" cap="flat" cmpd="sng" algn="ctr">
+                      <a:solidFill>
+                        <a:srgbClr val="9AA5B8"/>
                       </a:solidFill>
                       <a:prstDash val="solid"/>
                       <a:round/>
                       <a:headEnd type="none" w="med" len="med"/>
                       <a:tailEnd type="none" w="med" len="med"/>
                     </a:lnT>
-                    <a:lnB w="19050" cap="flat" cmpd="sng" algn="ctr">
-                      <a:solidFill>
-                        <a:srgbClr val="FFFFFF"/>
+                    <a:lnB w="9525" cap="flat" cmpd="sng" algn="ctr">
+                      <a:solidFill>
+                        <a:srgbClr val="9AA5B8"/>
                       </a:solidFill>
                       <a:prstDash val="solid"/>
                       <a:round/>
@@ -5526,36 +5742,36 @@
                     </a:p>
                   </a:txBody>
                   <a:tcPr marL="36576" marR="36576" marT="18288" marB="18288" anchor="ctr">
-                    <a:lnL w="19050" cap="flat" cmpd="sng" algn="ctr">
-                      <a:solidFill>
-                        <a:srgbClr val="FFFFFF"/>
+                    <a:lnL w="25400" cap="flat" cmpd="sng" algn="ctr">
+                      <a:solidFill>
+                        <a:srgbClr val="4A5568"/>
                       </a:solidFill>
                       <a:prstDash val="solid"/>
                       <a:round/>
                       <a:headEnd type="none" w="med" len="med"/>
                       <a:tailEnd type="none" w="med" len="med"/>
                     </a:lnL>
-                    <a:lnR w="19050" cap="flat" cmpd="sng" algn="ctr">
-                      <a:solidFill>
-                        <a:srgbClr val="FFFFFF"/>
+                    <a:lnR w="9525" cap="flat" cmpd="sng" algn="ctr">
+                      <a:solidFill>
+                        <a:srgbClr val="9AA5B8"/>
                       </a:solidFill>
                       <a:prstDash val="solid"/>
                       <a:round/>
                       <a:headEnd type="none" w="med" len="med"/>
                       <a:tailEnd type="none" w="med" len="med"/>
                     </a:lnR>
-                    <a:lnT w="19050" cap="flat" cmpd="sng" algn="ctr">
-                      <a:solidFill>
-                        <a:srgbClr val="FFFFFF"/>
+                    <a:lnT w="9525" cap="flat" cmpd="sng" algn="ctr">
+                      <a:solidFill>
+                        <a:srgbClr val="9AA5B8"/>
                       </a:solidFill>
                       <a:prstDash val="solid"/>
                       <a:round/>
                       <a:headEnd type="none" w="med" len="med"/>
                       <a:tailEnd type="none" w="med" len="med"/>
                     </a:lnT>
-                    <a:lnB w="19050" cap="flat" cmpd="sng" algn="ctr">
-                      <a:solidFill>
-                        <a:srgbClr val="FFFFFF"/>
+                    <a:lnB w="9525" cap="flat" cmpd="sng" algn="ctr">
+                      <a:solidFill>
+                        <a:srgbClr val="9AA5B8"/>
                       </a:solidFill>
                       <a:prstDash val="solid"/>
                       <a:round/>
@@ -5594,36 +5810,36 @@
                     </a:p>
                   </a:txBody>
                   <a:tcPr marL="36576" marR="36576" marT="18288" marB="18288" anchor="ctr">
-                    <a:lnL w="19050" cap="flat" cmpd="sng" algn="ctr">
-                      <a:solidFill>
-                        <a:srgbClr val="FFFFFF"/>
+                    <a:lnL w="9525" cap="flat" cmpd="sng" algn="ctr">
+                      <a:solidFill>
+                        <a:srgbClr val="9AA5B8"/>
                       </a:solidFill>
                       <a:prstDash val="solid"/>
                       <a:round/>
                       <a:headEnd type="none" w="med" len="med"/>
                       <a:tailEnd type="none" w="med" len="med"/>
                     </a:lnL>
-                    <a:lnR w="19050" cap="flat" cmpd="sng" algn="ctr">
-                      <a:solidFill>
-                        <a:srgbClr val="FFFFFF"/>
+                    <a:lnR w="9525" cap="flat" cmpd="sng" algn="ctr">
+                      <a:solidFill>
+                        <a:srgbClr val="9AA5B8"/>
                       </a:solidFill>
                       <a:prstDash val="solid"/>
                       <a:round/>
                       <a:headEnd type="none" w="med" len="med"/>
                       <a:tailEnd type="none" w="med" len="med"/>
                     </a:lnR>
-                    <a:lnT w="19050" cap="flat" cmpd="sng" algn="ctr">
-                      <a:solidFill>
-                        <a:srgbClr val="FFFFFF"/>
+                    <a:lnT w="9525" cap="flat" cmpd="sng" algn="ctr">
+                      <a:solidFill>
+                        <a:srgbClr val="9AA5B8"/>
                       </a:solidFill>
                       <a:prstDash val="solid"/>
                       <a:round/>
                       <a:headEnd type="none" w="med" len="med"/>
                       <a:tailEnd type="none" w="med" len="med"/>
                     </a:lnT>
-                    <a:lnB w="19050" cap="flat" cmpd="sng" algn="ctr">
-                      <a:solidFill>
-                        <a:srgbClr val="FFFFFF"/>
+                    <a:lnB w="9525" cap="flat" cmpd="sng" algn="ctr">
+                      <a:solidFill>
+                        <a:srgbClr val="9AA5B8"/>
                       </a:solidFill>
                       <a:prstDash val="solid"/>
                       <a:round/>
@@ -5664,36 +5880,36 @@
                     </a:p>
                   </a:txBody>
                   <a:tcPr marL="36576" marR="36576" marT="18288" marB="18288" anchor="ctr">
-                    <a:lnL w="19050" cap="flat" cmpd="sng" algn="ctr">
-                      <a:solidFill>
-                        <a:srgbClr val="FFFFFF"/>
+                    <a:lnL w="9525" cap="flat" cmpd="sng" algn="ctr">
+                      <a:solidFill>
+                        <a:srgbClr val="9AA5B8"/>
                       </a:solidFill>
                       <a:prstDash val="solid"/>
                       <a:round/>
                       <a:headEnd type="none" w="med" len="med"/>
                       <a:tailEnd type="none" w="med" len="med"/>
                     </a:lnL>
-                    <a:lnR w="19050" cap="flat" cmpd="sng" algn="ctr">
-                      <a:solidFill>
-                        <a:srgbClr val="FFFFFF"/>
+                    <a:lnR w="9525" cap="flat" cmpd="sng" algn="ctr">
+                      <a:solidFill>
+                        <a:srgbClr val="9AA5B8"/>
                       </a:solidFill>
                       <a:prstDash val="solid"/>
                       <a:round/>
                       <a:headEnd type="none" w="med" len="med"/>
                       <a:tailEnd type="none" w="med" len="med"/>
                     </a:lnR>
-                    <a:lnT w="19050" cap="flat" cmpd="sng" algn="ctr">
-                      <a:solidFill>
-                        <a:srgbClr val="FFFFFF"/>
+                    <a:lnT w="9525" cap="flat" cmpd="sng" algn="ctr">
+                      <a:solidFill>
+                        <a:srgbClr val="9AA5B8"/>
                       </a:solidFill>
                       <a:prstDash val="solid"/>
                       <a:round/>
                       <a:headEnd type="none" w="med" len="med"/>
                       <a:tailEnd type="none" w="med" len="med"/>
                     </a:lnT>
-                    <a:lnB w="19050" cap="flat" cmpd="sng" algn="ctr">
-                      <a:solidFill>
-                        <a:srgbClr val="FFFFFF"/>
+                    <a:lnB w="9525" cap="flat" cmpd="sng" algn="ctr">
+                      <a:solidFill>
+                        <a:srgbClr val="9AA5B8"/>
                       </a:solidFill>
                       <a:prstDash val="solid"/>
                       <a:round/>
@@ -5729,36 +5945,36 @@
                     </a:p>
                   </a:txBody>
                   <a:tcPr marL="36576" marR="36576" marT="18288" marB="18288" anchor="ctr">
-                    <a:lnL w="19050" cap="flat" cmpd="sng" algn="ctr">
-                      <a:solidFill>
-                        <a:srgbClr val="FFFFFF"/>
+                    <a:lnL w="9525" cap="flat" cmpd="sng" algn="ctr">
+                      <a:solidFill>
+                        <a:srgbClr val="9AA5B8"/>
                       </a:solidFill>
                       <a:prstDash val="solid"/>
                       <a:round/>
                       <a:headEnd type="none" w="med" len="med"/>
                       <a:tailEnd type="none" w="med" len="med"/>
                     </a:lnL>
-                    <a:lnR w="19050" cap="flat" cmpd="sng" algn="ctr">
-                      <a:solidFill>
-                        <a:srgbClr val="FFFFFF"/>
+                    <a:lnR w="9525" cap="flat" cmpd="sng" algn="ctr">
+                      <a:solidFill>
+                        <a:srgbClr val="9AA5B8"/>
                       </a:solidFill>
                       <a:prstDash val="solid"/>
                       <a:round/>
                       <a:headEnd type="none" w="med" len="med"/>
                       <a:tailEnd type="none" w="med" len="med"/>
                     </a:lnR>
-                    <a:lnT w="19050" cap="flat" cmpd="sng" algn="ctr">
-                      <a:solidFill>
-                        <a:srgbClr val="FFFFFF"/>
+                    <a:lnT w="9525" cap="flat" cmpd="sng" algn="ctr">
+                      <a:solidFill>
+                        <a:srgbClr val="9AA5B8"/>
                       </a:solidFill>
                       <a:prstDash val="solid"/>
                       <a:round/>
                       <a:headEnd type="none" w="med" len="med"/>
                       <a:tailEnd type="none" w="med" len="med"/>
                     </a:lnT>
-                    <a:lnB w="19050" cap="flat" cmpd="sng" algn="ctr">
-                      <a:solidFill>
-                        <a:srgbClr val="FFFFFF"/>
+                    <a:lnB w="9525" cap="flat" cmpd="sng" algn="ctr">
+                      <a:solidFill>
+                        <a:srgbClr val="9AA5B8"/>
                       </a:solidFill>
                       <a:prstDash val="solid"/>
                       <a:round/>
@@ -5794,36 +6010,36 @@
                     </a:p>
                   </a:txBody>
                   <a:tcPr marL="36576" marR="36576" marT="18288" marB="18288" anchor="ctr">
-                    <a:lnL w="19050" cap="flat" cmpd="sng" algn="ctr">
-                      <a:solidFill>
-                        <a:srgbClr val="FFFFFF"/>
+                    <a:lnL w="9525" cap="flat" cmpd="sng" algn="ctr">
+                      <a:solidFill>
+                        <a:srgbClr val="9AA5B8"/>
                       </a:solidFill>
                       <a:prstDash val="solid"/>
                       <a:round/>
                       <a:headEnd type="none" w="med" len="med"/>
                       <a:tailEnd type="none" w="med" len="med"/>
                     </a:lnL>
-                    <a:lnR w="19050" cap="flat" cmpd="sng" algn="ctr">
-                      <a:solidFill>
-                        <a:srgbClr val="FFFFFF"/>
+                    <a:lnR w="9525" cap="flat" cmpd="sng" algn="ctr">
+                      <a:solidFill>
+                        <a:srgbClr val="9AA5B8"/>
                       </a:solidFill>
                       <a:prstDash val="solid"/>
                       <a:round/>
                       <a:headEnd type="none" w="med" len="med"/>
                       <a:tailEnd type="none" w="med" len="med"/>
                     </a:lnR>
-                    <a:lnT w="19050" cap="flat" cmpd="sng" algn="ctr">
-                      <a:solidFill>
-                        <a:srgbClr val="FFFFFF"/>
+                    <a:lnT w="9525" cap="flat" cmpd="sng" algn="ctr">
+                      <a:solidFill>
+                        <a:srgbClr val="9AA5B8"/>
                       </a:solidFill>
                       <a:prstDash val="solid"/>
                       <a:round/>
                       <a:headEnd type="none" w="med" len="med"/>
                       <a:tailEnd type="none" w="med" len="med"/>
                     </a:lnT>
-                    <a:lnB w="19050" cap="flat" cmpd="sng" algn="ctr">
-                      <a:solidFill>
-                        <a:srgbClr val="FFFFFF"/>
+                    <a:lnB w="9525" cap="flat" cmpd="sng" algn="ctr">
+                      <a:solidFill>
+                        <a:srgbClr val="9AA5B8"/>
                       </a:solidFill>
                       <a:prstDash val="solid"/>
                       <a:round/>
@@ -5859,36 +6075,36 @@
                     </a:p>
                   </a:txBody>
                   <a:tcPr marL="36576" marR="36576" marT="18288" marB="18288" anchor="ctr">
-                    <a:lnL w="19050" cap="flat" cmpd="sng" algn="ctr">
-                      <a:solidFill>
-                        <a:srgbClr val="FFFFFF"/>
+                    <a:lnL w="25400" cap="flat" cmpd="sng" algn="ctr">
+                      <a:solidFill>
+                        <a:srgbClr val="4A5568"/>
                       </a:solidFill>
                       <a:prstDash val="solid"/>
                       <a:round/>
                       <a:headEnd type="none" w="med" len="med"/>
                       <a:tailEnd type="none" w="med" len="med"/>
                     </a:lnL>
-                    <a:lnR w="19050" cap="flat" cmpd="sng" algn="ctr">
-                      <a:solidFill>
-                        <a:srgbClr val="FFFFFF"/>
+                    <a:lnR w="9525" cap="flat" cmpd="sng" algn="ctr">
+                      <a:solidFill>
+                        <a:srgbClr val="9AA5B8"/>
                       </a:solidFill>
                       <a:prstDash val="solid"/>
                       <a:round/>
                       <a:headEnd type="none" w="med" len="med"/>
                       <a:tailEnd type="none" w="med" len="med"/>
                     </a:lnR>
-                    <a:lnT w="19050" cap="flat" cmpd="sng" algn="ctr">
-                      <a:solidFill>
-                        <a:srgbClr val="FFFFFF"/>
+                    <a:lnT w="9525" cap="flat" cmpd="sng" algn="ctr">
+                      <a:solidFill>
+                        <a:srgbClr val="9AA5B8"/>
                       </a:solidFill>
                       <a:prstDash val="solid"/>
                       <a:round/>
                       <a:headEnd type="none" w="med" len="med"/>
                       <a:tailEnd type="none" w="med" len="med"/>
                     </a:lnT>
-                    <a:lnB w="19050" cap="flat" cmpd="sng" algn="ctr">
-                      <a:solidFill>
-                        <a:srgbClr val="FFFFFF"/>
+                    <a:lnB w="9525" cap="flat" cmpd="sng" algn="ctr">
+                      <a:solidFill>
+                        <a:srgbClr val="9AA5B8"/>
                       </a:solidFill>
                       <a:prstDash val="solid"/>
                       <a:round/>
@@ -5927,36 +6143,36 @@
                     </a:p>
                   </a:txBody>
                   <a:tcPr marL="36576" marR="36576" marT="18288" marB="18288" anchor="ctr">
-                    <a:lnL w="19050" cap="flat" cmpd="sng" algn="ctr">
-                      <a:solidFill>
-                        <a:srgbClr val="FFFFFF"/>
+                    <a:lnL w="9525" cap="flat" cmpd="sng" algn="ctr">
+                      <a:solidFill>
+                        <a:srgbClr val="9AA5B8"/>
                       </a:solidFill>
                       <a:prstDash val="solid"/>
                       <a:round/>
                       <a:headEnd type="none" w="med" len="med"/>
                       <a:tailEnd type="none" w="med" len="med"/>
                     </a:lnL>
-                    <a:lnR w="19050" cap="flat" cmpd="sng" algn="ctr">
-                      <a:solidFill>
-                        <a:srgbClr val="FFFFFF"/>
+                    <a:lnR w="9525" cap="flat" cmpd="sng" algn="ctr">
+                      <a:solidFill>
+                        <a:srgbClr val="9AA5B8"/>
                       </a:solidFill>
                       <a:prstDash val="solid"/>
                       <a:round/>
                       <a:headEnd type="none" w="med" len="med"/>
                       <a:tailEnd type="none" w="med" len="med"/>
                     </a:lnR>
-                    <a:lnT w="19050" cap="flat" cmpd="sng" algn="ctr">
-                      <a:solidFill>
-                        <a:srgbClr val="FFFFFF"/>
+                    <a:lnT w="9525" cap="flat" cmpd="sng" algn="ctr">
+                      <a:solidFill>
+                        <a:srgbClr val="9AA5B8"/>
                       </a:solidFill>
                       <a:prstDash val="solid"/>
                       <a:round/>
                       <a:headEnd type="none" w="med" len="med"/>
                       <a:tailEnd type="none" w="med" len="med"/>
                     </a:lnT>
-                    <a:lnB w="19050" cap="flat" cmpd="sng" algn="ctr">
-                      <a:solidFill>
-                        <a:srgbClr val="FFFFFF"/>
+                    <a:lnB w="9525" cap="flat" cmpd="sng" algn="ctr">
+                      <a:solidFill>
+                        <a:srgbClr val="9AA5B8"/>
                       </a:solidFill>
                       <a:prstDash val="solid"/>
                       <a:round/>
@@ -5995,36 +6211,36 @@
                     </a:p>
                   </a:txBody>
                   <a:tcPr marL="36576" marR="36576" marT="18288" marB="18288" anchor="ctr">
-                    <a:lnL w="19050" cap="flat" cmpd="sng" algn="ctr">
-                      <a:solidFill>
-                        <a:srgbClr val="FFFFFF"/>
+                    <a:lnL w="25400" cap="flat" cmpd="sng" algn="ctr">
+                      <a:solidFill>
+                        <a:srgbClr val="4A5568"/>
                       </a:solidFill>
                       <a:prstDash val="solid"/>
                       <a:round/>
                       <a:headEnd type="none" w="med" len="med"/>
                       <a:tailEnd type="none" w="med" len="med"/>
                     </a:lnL>
-                    <a:lnR w="19050" cap="flat" cmpd="sng" algn="ctr">
-                      <a:solidFill>
-                        <a:srgbClr val="FFFFFF"/>
+                    <a:lnR w="9525" cap="flat" cmpd="sng" algn="ctr">
+                      <a:solidFill>
+                        <a:srgbClr val="9AA5B8"/>
                       </a:solidFill>
                       <a:prstDash val="solid"/>
                       <a:round/>
                       <a:headEnd type="none" w="med" len="med"/>
                       <a:tailEnd type="none" w="med" len="med"/>
                     </a:lnR>
-                    <a:lnT w="19050" cap="flat" cmpd="sng" algn="ctr">
-                      <a:solidFill>
-                        <a:srgbClr val="FFFFFF"/>
+                    <a:lnT w="9525" cap="flat" cmpd="sng" algn="ctr">
+                      <a:solidFill>
+                        <a:srgbClr val="9AA5B8"/>
                       </a:solidFill>
                       <a:prstDash val="solid"/>
                       <a:round/>
                       <a:headEnd type="none" w="med" len="med"/>
                       <a:tailEnd type="none" w="med" len="med"/>
                     </a:lnT>
-                    <a:lnB w="19050" cap="flat" cmpd="sng" algn="ctr">
-                      <a:solidFill>
-                        <a:srgbClr val="FFFFFF"/>
+                    <a:lnB w="9525" cap="flat" cmpd="sng" algn="ctr">
+                      <a:solidFill>
+                        <a:srgbClr val="9AA5B8"/>
                       </a:solidFill>
                       <a:prstDash val="solid"/>
                       <a:round/>
@@ -6063,36 +6279,36 @@
                     </a:p>
                   </a:txBody>
                   <a:tcPr marL="36576" marR="36576" marT="18288" marB="18288" anchor="ctr">
-                    <a:lnL w="19050" cap="flat" cmpd="sng" algn="ctr">
-                      <a:solidFill>
-                        <a:srgbClr val="FFFFFF"/>
+                    <a:lnL w="9525" cap="flat" cmpd="sng" algn="ctr">
+                      <a:solidFill>
+                        <a:srgbClr val="9AA5B8"/>
                       </a:solidFill>
                       <a:prstDash val="solid"/>
                       <a:round/>
                       <a:headEnd type="none" w="med" len="med"/>
                       <a:tailEnd type="none" w="med" len="med"/>
                     </a:lnL>
-                    <a:lnR w="19050" cap="flat" cmpd="sng" algn="ctr">
-                      <a:solidFill>
-                        <a:srgbClr val="FFFFFF"/>
+                    <a:lnR w="9525" cap="flat" cmpd="sng" algn="ctr">
+                      <a:solidFill>
+                        <a:srgbClr val="9AA5B8"/>
                       </a:solidFill>
                       <a:prstDash val="solid"/>
                       <a:round/>
                       <a:headEnd type="none" w="med" len="med"/>
                       <a:tailEnd type="none" w="med" len="med"/>
                     </a:lnR>
-                    <a:lnT w="19050" cap="flat" cmpd="sng" algn="ctr">
-                      <a:solidFill>
-                        <a:srgbClr val="FFFFFF"/>
+                    <a:lnT w="9525" cap="flat" cmpd="sng" algn="ctr">
+                      <a:solidFill>
+                        <a:srgbClr val="9AA5B8"/>
                       </a:solidFill>
                       <a:prstDash val="solid"/>
                       <a:round/>
                       <a:headEnd type="none" w="med" len="med"/>
                       <a:tailEnd type="none" w="med" len="med"/>
                     </a:lnT>
-                    <a:lnB w="19050" cap="flat" cmpd="sng" algn="ctr">
-                      <a:solidFill>
-                        <a:srgbClr val="FFFFFF"/>
+                    <a:lnB w="9525" cap="flat" cmpd="sng" algn="ctr">
+                      <a:solidFill>
+                        <a:srgbClr val="9AA5B8"/>
                       </a:solidFill>
                       <a:prstDash val="solid"/>
                       <a:round/>
@@ -6133,36 +6349,36 @@
                     </a:p>
                   </a:txBody>
                   <a:tcPr marL="36576" marR="36576" marT="18288" marB="18288" anchor="ctr">
-                    <a:lnL w="19050" cap="flat" cmpd="sng" algn="ctr">
-                      <a:solidFill>
-                        <a:srgbClr val="FFFFFF"/>
+                    <a:lnL w="9525" cap="flat" cmpd="sng" algn="ctr">
+                      <a:solidFill>
+                        <a:srgbClr val="9AA5B8"/>
                       </a:solidFill>
                       <a:prstDash val="solid"/>
                       <a:round/>
                       <a:headEnd type="none" w="med" len="med"/>
                       <a:tailEnd type="none" w="med" len="med"/>
                     </a:lnL>
-                    <a:lnR w="19050" cap="flat" cmpd="sng" algn="ctr">
-                      <a:solidFill>
-                        <a:srgbClr val="FFFFFF"/>
+                    <a:lnR w="9525" cap="flat" cmpd="sng" algn="ctr">
+                      <a:solidFill>
+                        <a:srgbClr val="9AA5B8"/>
                       </a:solidFill>
                       <a:prstDash val="solid"/>
                       <a:round/>
                       <a:headEnd type="none" w="med" len="med"/>
                       <a:tailEnd type="none" w="med" len="med"/>
                     </a:lnR>
-                    <a:lnT w="19050" cap="flat" cmpd="sng" algn="ctr">
-                      <a:solidFill>
-                        <a:srgbClr val="FFFFFF"/>
+                    <a:lnT w="9525" cap="flat" cmpd="sng" algn="ctr">
+                      <a:solidFill>
+                        <a:srgbClr val="9AA5B8"/>
                       </a:solidFill>
                       <a:prstDash val="solid"/>
                       <a:round/>
                       <a:headEnd type="none" w="med" len="med"/>
                       <a:tailEnd type="none" w="med" len="med"/>
                     </a:lnT>
-                    <a:lnB w="19050" cap="flat" cmpd="sng" algn="ctr">
-                      <a:solidFill>
-                        <a:srgbClr val="FFFFFF"/>
+                    <a:lnB w="9525" cap="flat" cmpd="sng" algn="ctr">
+                      <a:solidFill>
+                        <a:srgbClr val="9AA5B8"/>
                       </a:solidFill>
                       <a:prstDash val="solid"/>
                       <a:round/>
@@ -6198,36 +6414,36 @@
                     </a:p>
                   </a:txBody>
                   <a:tcPr marL="36576" marR="36576" marT="18288" marB="18288" anchor="ctr">
-                    <a:lnL w="19050" cap="flat" cmpd="sng" algn="ctr">
-                      <a:solidFill>
-                        <a:srgbClr val="FFFFFF"/>
+                    <a:lnL w="9525" cap="flat" cmpd="sng" algn="ctr">
+                      <a:solidFill>
+                        <a:srgbClr val="9AA5B8"/>
                       </a:solidFill>
                       <a:prstDash val="solid"/>
                       <a:round/>
                       <a:headEnd type="none" w="med" len="med"/>
                       <a:tailEnd type="none" w="med" len="med"/>
                     </a:lnL>
-                    <a:lnR w="19050" cap="flat" cmpd="sng" algn="ctr">
-                      <a:solidFill>
-                        <a:srgbClr val="FFFFFF"/>
+                    <a:lnR w="9525" cap="flat" cmpd="sng" algn="ctr">
+                      <a:solidFill>
+                        <a:srgbClr val="9AA5B8"/>
                       </a:solidFill>
                       <a:prstDash val="solid"/>
                       <a:round/>
                       <a:headEnd type="none" w="med" len="med"/>
                       <a:tailEnd type="none" w="med" len="med"/>
                     </a:lnR>
-                    <a:lnT w="19050" cap="flat" cmpd="sng" algn="ctr">
-                      <a:solidFill>
-                        <a:srgbClr val="FFFFFF"/>
+                    <a:lnT w="9525" cap="flat" cmpd="sng" algn="ctr">
+                      <a:solidFill>
+                        <a:srgbClr val="9AA5B8"/>
                       </a:solidFill>
                       <a:prstDash val="solid"/>
                       <a:round/>
                       <a:headEnd type="none" w="med" len="med"/>
                       <a:tailEnd type="none" w="med" len="med"/>
                     </a:lnT>
-                    <a:lnB w="19050" cap="flat" cmpd="sng" algn="ctr">
-                      <a:solidFill>
-                        <a:srgbClr val="FFFFFF"/>
+                    <a:lnB w="9525" cap="flat" cmpd="sng" algn="ctr">
+                      <a:solidFill>
+                        <a:srgbClr val="9AA5B8"/>
                       </a:solidFill>
                       <a:prstDash val="solid"/>
                       <a:round/>
@@ -6263,36 +6479,36 @@
                     </a:p>
                   </a:txBody>
                   <a:tcPr marL="36576" marR="36576" marT="18288" marB="18288" anchor="ctr">
-                    <a:lnL w="19050" cap="flat" cmpd="sng" algn="ctr">
-                      <a:solidFill>
-                        <a:srgbClr val="FFFFFF"/>
+                    <a:lnL w="9525" cap="flat" cmpd="sng" algn="ctr">
+                      <a:solidFill>
+                        <a:srgbClr val="9AA5B8"/>
                       </a:solidFill>
                       <a:prstDash val="solid"/>
                       <a:round/>
                       <a:headEnd type="none" w="med" len="med"/>
                       <a:tailEnd type="none" w="med" len="med"/>
                     </a:lnL>
-                    <a:lnR w="19050" cap="flat" cmpd="sng" algn="ctr">
-                      <a:solidFill>
-                        <a:srgbClr val="FFFFFF"/>
+                    <a:lnR w="9525" cap="flat" cmpd="sng" algn="ctr">
+                      <a:solidFill>
+                        <a:srgbClr val="9AA5B8"/>
                       </a:solidFill>
                       <a:prstDash val="solid"/>
                       <a:round/>
                       <a:headEnd type="none" w="med" len="med"/>
                       <a:tailEnd type="none" w="med" len="med"/>
                     </a:lnR>
-                    <a:lnT w="19050" cap="flat" cmpd="sng" algn="ctr">
-                      <a:solidFill>
-                        <a:srgbClr val="FFFFFF"/>
+                    <a:lnT w="9525" cap="flat" cmpd="sng" algn="ctr">
+                      <a:solidFill>
+                        <a:srgbClr val="9AA5B8"/>
                       </a:solidFill>
                       <a:prstDash val="solid"/>
                       <a:round/>
                       <a:headEnd type="none" w="med" len="med"/>
                       <a:tailEnd type="none" w="med" len="med"/>
                     </a:lnT>
-                    <a:lnB w="19050" cap="flat" cmpd="sng" algn="ctr">
-                      <a:solidFill>
-                        <a:srgbClr val="FFFFFF"/>
+                    <a:lnB w="9525" cap="flat" cmpd="sng" algn="ctr">
+                      <a:solidFill>
+                        <a:srgbClr val="9AA5B8"/>
                       </a:solidFill>
                       <a:prstDash val="solid"/>
                       <a:round/>
@@ -6328,36 +6544,36 @@
                     </a:p>
                   </a:txBody>
                   <a:tcPr marL="36576" marR="36576" marT="18288" marB="18288" anchor="ctr">
-                    <a:lnL w="19050" cap="flat" cmpd="sng" algn="ctr">
-                      <a:solidFill>
-                        <a:srgbClr val="FFFFFF"/>
+                    <a:lnL w="25400" cap="flat" cmpd="sng" algn="ctr">
+                      <a:solidFill>
+                        <a:srgbClr val="4A5568"/>
                       </a:solidFill>
                       <a:prstDash val="solid"/>
                       <a:round/>
                       <a:headEnd type="none" w="med" len="med"/>
                       <a:tailEnd type="none" w="med" len="med"/>
                     </a:lnL>
-                    <a:lnR w="19050" cap="flat" cmpd="sng" algn="ctr">
-                      <a:solidFill>
-                        <a:srgbClr val="FFFFFF"/>
+                    <a:lnR w="9525" cap="flat" cmpd="sng" algn="ctr">
+                      <a:solidFill>
+                        <a:srgbClr val="9AA5B8"/>
                       </a:solidFill>
                       <a:prstDash val="solid"/>
                       <a:round/>
                       <a:headEnd type="none" w="med" len="med"/>
                       <a:tailEnd type="none" w="med" len="med"/>
                     </a:lnR>
-                    <a:lnT w="19050" cap="flat" cmpd="sng" algn="ctr">
-                      <a:solidFill>
-                        <a:srgbClr val="FFFFFF"/>
+                    <a:lnT w="9525" cap="flat" cmpd="sng" algn="ctr">
+                      <a:solidFill>
+                        <a:srgbClr val="9AA5B8"/>
                       </a:solidFill>
                       <a:prstDash val="solid"/>
                       <a:round/>
                       <a:headEnd type="none" w="med" len="med"/>
                       <a:tailEnd type="none" w="med" len="med"/>
                     </a:lnT>
-                    <a:lnB w="19050" cap="flat" cmpd="sng" algn="ctr">
-                      <a:solidFill>
-                        <a:srgbClr val="FFFFFF"/>
+                    <a:lnB w="9525" cap="flat" cmpd="sng" algn="ctr">
+                      <a:solidFill>
+                        <a:srgbClr val="9AA5B8"/>
                       </a:solidFill>
                       <a:prstDash val="solid"/>
                       <a:round/>
@@ -6396,36 +6612,36 @@
                     </a:p>
                   </a:txBody>
                   <a:tcPr marL="36576" marR="36576" marT="18288" marB="18288" anchor="ctr">
-                    <a:lnL w="19050" cap="flat" cmpd="sng" algn="ctr">
-                      <a:solidFill>
-                        <a:srgbClr val="FFFFFF"/>
+                    <a:lnL w="9525" cap="flat" cmpd="sng" algn="ctr">
+                      <a:solidFill>
+                        <a:srgbClr val="9AA5B8"/>
                       </a:solidFill>
                       <a:prstDash val="solid"/>
                       <a:round/>
                       <a:headEnd type="none" w="med" len="med"/>
                       <a:tailEnd type="none" w="med" len="med"/>
                     </a:lnL>
-                    <a:lnR w="19050" cap="flat" cmpd="sng" algn="ctr">
-                      <a:solidFill>
-                        <a:srgbClr val="FFFFFF"/>
+                    <a:lnR w="9525" cap="flat" cmpd="sng" algn="ctr">
+                      <a:solidFill>
+                        <a:srgbClr val="9AA5B8"/>
                       </a:solidFill>
                       <a:prstDash val="solid"/>
                       <a:round/>
                       <a:headEnd type="none" w="med" len="med"/>
                       <a:tailEnd type="none" w="med" len="med"/>
                     </a:lnR>
-                    <a:lnT w="19050" cap="flat" cmpd="sng" algn="ctr">
-                      <a:solidFill>
-                        <a:srgbClr val="FFFFFF"/>
+                    <a:lnT w="9525" cap="flat" cmpd="sng" algn="ctr">
+                      <a:solidFill>
+                        <a:srgbClr val="9AA5B8"/>
                       </a:solidFill>
                       <a:prstDash val="solid"/>
                       <a:round/>
                       <a:headEnd type="none" w="med" len="med"/>
                       <a:tailEnd type="none" w="med" len="med"/>
                     </a:lnT>
-                    <a:lnB w="19050" cap="flat" cmpd="sng" algn="ctr">
-                      <a:solidFill>
-                        <a:srgbClr val="FFFFFF"/>
+                    <a:lnB w="9525" cap="flat" cmpd="sng" algn="ctr">
+                      <a:solidFill>
+                        <a:srgbClr val="9AA5B8"/>
                       </a:solidFill>
                       <a:prstDash val="solid"/>
                       <a:round/>
@@ -6464,36 +6680,36 @@
                     </a:p>
                   </a:txBody>
                   <a:tcPr marL="36576" marR="36576" marT="18288" marB="18288" anchor="ctr">
-                    <a:lnL w="19050" cap="flat" cmpd="sng" algn="ctr">
-                      <a:solidFill>
-                        <a:srgbClr val="FFFFFF"/>
+                    <a:lnL w="25400" cap="flat" cmpd="sng" algn="ctr">
+                      <a:solidFill>
+                        <a:srgbClr val="4A5568"/>
                       </a:solidFill>
                       <a:prstDash val="solid"/>
                       <a:round/>
                       <a:headEnd type="none" w="med" len="med"/>
                       <a:tailEnd type="none" w="med" len="med"/>
                     </a:lnL>
-                    <a:lnR w="19050" cap="flat" cmpd="sng" algn="ctr">
-                      <a:solidFill>
-                        <a:srgbClr val="FFFFFF"/>
+                    <a:lnR w="9525" cap="flat" cmpd="sng" algn="ctr">
+                      <a:solidFill>
+                        <a:srgbClr val="9AA5B8"/>
                       </a:solidFill>
                       <a:prstDash val="solid"/>
                       <a:round/>
                       <a:headEnd type="none" w="med" len="med"/>
                       <a:tailEnd type="none" w="med" len="med"/>
                     </a:lnR>
-                    <a:lnT w="19050" cap="flat" cmpd="sng" algn="ctr">
-                      <a:solidFill>
-                        <a:srgbClr val="FFFFFF"/>
+                    <a:lnT w="9525" cap="flat" cmpd="sng" algn="ctr">
+                      <a:solidFill>
+                        <a:srgbClr val="9AA5B8"/>
                       </a:solidFill>
                       <a:prstDash val="solid"/>
                       <a:round/>
                       <a:headEnd type="none" w="med" len="med"/>
                       <a:tailEnd type="none" w="med" len="med"/>
                     </a:lnT>
-                    <a:lnB w="19050" cap="flat" cmpd="sng" algn="ctr">
-                      <a:solidFill>
-                        <a:srgbClr val="FFFFFF"/>
+                    <a:lnB w="9525" cap="flat" cmpd="sng" algn="ctr">
+                      <a:solidFill>
+                        <a:srgbClr val="9AA5B8"/>
                       </a:solidFill>
                       <a:prstDash val="solid"/>
                       <a:round/>
@@ -6532,36 +6748,36 @@
                     </a:p>
                   </a:txBody>
                   <a:tcPr marL="36576" marR="36576" marT="18288" marB="18288" anchor="ctr">
-                    <a:lnL w="19050" cap="flat" cmpd="sng" algn="ctr">
-                      <a:solidFill>
-                        <a:srgbClr val="FFFFFF"/>
+                    <a:lnL w="9525" cap="flat" cmpd="sng" algn="ctr">
+                      <a:solidFill>
+                        <a:srgbClr val="9AA5B8"/>
                       </a:solidFill>
                       <a:prstDash val="solid"/>
                       <a:round/>
                       <a:headEnd type="none" w="med" len="med"/>
                       <a:tailEnd type="none" w="med" len="med"/>
                     </a:lnL>
-                    <a:lnR w="19050" cap="flat" cmpd="sng" algn="ctr">
-                      <a:solidFill>
-                        <a:srgbClr val="FFFFFF"/>
+                    <a:lnR w="9525" cap="flat" cmpd="sng" algn="ctr">
+                      <a:solidFill>
+                        <a:srgbClr val="9AA5B8"/>
                       </a:solidFill>
                       <a:prstDash val="solid"/>
                       <a:round/>
                       <a:headEnd type="none" w="med" len="med"/>
                       <a:tailEnd type="none" w="med" len="med"/>
                     </a:lnR>
-                    <a:lnT w="19050" cap="flat" cmpd="sng" algn="ctr">
-                      <a:solidFill>
-                        <a:srgbClr val="FFFFFF"/>
+                    <a:lnT w="9525" cap="flat" cmpd="sng" algn="ctr">
+                      <a:solidFill>
+                        <a:srgbClr val="9AA5B8"/>
                       </a:solidFill>
                       <a:prstDash val="solid"/>
                       <a:round/>
                       <a:headEnd type="none" w="med" len="med"/>
                       <a:tailEnd type="none" w="med" len="med"/>
                     </a:lnT>
-                    <a:lnB w="19050" cap="flat" cmpd="sng" algn="ctr">
-                      <a:solidFill>
-                        <a:srgbClr val="FFFFFF"/>
+                    <a:lnB w="9525" cap="flat" cmpd="sng" algn="ctr">
+                      <a:solidFill>
+                        <a:srgbClr val="9AA5B8"/>
                       </a:solidFill>
                       <a:prstDash val="solid"/>
                       <a:round/>
@@ -6602,36 +6818,36 @@
                     </a:p>
                   </a:txBody>
                   <a:tcPr marL="36576" marR="36576" marT="18288" marB="18288" anchor="ctr">
-                    <a:lnL w="19050" cap="flat" cmpd="sng" algn="ctr">
-                      <a:solidFill>
-                        <a:srgbClr val="FFFFFF"/>
+                    <a:lnL w="9525" cap="flat" cmpd="sng" algn="ctr">
+                      <a:solidFill>
+                        <a:srgbClr val="9AA5B8"/>
                       </a:solidFill>
                       <a:prstDash val="solid"/>
                       <a:round/>
                       <a:headEnd type="none" w="med" len="med"/>
                       <a:tailEnd type="none" w="med" len="med"/>
                     </a:lnL>
-                    <a:lnR w="19050" cap="flat" cmpd="sng" algn="ctr">
-                      <a:solidFill>
-                        <a:srgbClr val="FFFFFF"/>
+                    <a:lnR w="9525" cap="flat" cmpd="sng" algn="ctr">
+                      <a:solidFill>
+                        <a:srgbClr val="9AA5B8"/>
                       </a:solidFill>
                       <a:prstDash val="solid"/>
                       <a:round/>
                       <a:headEnd type="none" w="med" len="med"/>
                       <a:tailEnd type="none" w="med" len="med"/>
                     </a:lnR>
-                    <a:lnT w="19050" cap="flat" cmpd="sng" algn="ctr">
-                      <a:solidFill>
-                        <a:srgbClr val="FFFFFF"/>
+                    <a:lnT w="9525" cap="flat" cmpd="sng" algn="ctr">
+                      <a:solidFill>
+                        <a:srgbClr val="9AA5B8"/>
                       </a:solidFill>
                       <a:prstDash val="solid"/>
                       <a:round/>
                       <a:headEnd type="none" w="med" len="med"/>
                       <a:tailEnd type="none" w="med" len="med"/>
                     </a:lnT>
-                    <a:lnB w="19050" cap="flat" cmpd="sng" algn="ctr">
-                      <a:solidFill>
-                        <a:srgbClr val="FFFFFF"/>
+                    <a:lnB w="9525" cap="flat" cmpd="sng" algn="ctr">
+                      <a:solidFill>
+                        <a:srgbClr val="9AA5B8"/>
                       </a:solidFill>
                       <a:prstDash val="solid"/>
                       <a:round/>
@@ -6667,36 +6883,36 @@
                     </a:p>
                   </a:txBody>
                   <a:tcPr marL="36576" marR="36576" marT="18288" marB="18288" anchor="ctr">
-                    <a:lnL w="19050" cap="flat" cmpd="sng" algn="ctr">
-                      <a:solidFill>
-                        <a:srgbClr val="FFFFFF"/>
+                    <a:lnL w="9525" cap="flat" cmpd="sng" algn="ctr">
+                      <a:solidFill>
+                        <a:srgbClr val="9AA5B8"/>
                       </a:solidFill>
                       <a:prstDash val="solid"/>
                       <a:round/>
                       <a:headEnd type="none" w="med" len="med"/>
                       <a:tailEnd type="none" w="med" len="med"/>
                     </a:lnL>
-                    <a:lnR w="19050" cap="flat" cmpd="sng" algn="ctr">
-                      <a:solidFill>
-                        <a:srgbClr val="FFFFFF"/>
+                    <a:lnR w="9525" cap="flat" cmpd="sng" algn="ctr">
+                      <a:solidFill>
+                        <a:srgbClr val="9AA5B8"/>
                       </a:solidFill>
                       <a:prstDash val="solid"/>
                       <a:round/>
                       <a:headEnd type="none" w="med" len="med"/>
                       <a:tailEnd type="none" w="med" len="med"/>
                     </a:lnR>
-                    <a:lnT w="19050" cap="flat" cmpd="sng" algn="ctr">
-                      <a:solidFill>
-                        <a:srgbClr val="FFFFFF"/>
+                    <a:lnT w="9525" cap="flat" cmpd="sng" algn="ctr">
+                      <a:solidFill>
+                        <a:srgbClr val="9AA5B8"/>
                       </a:solidFill>
                       <a:prstDash val="solid"/>
                       <a:round/>
                       <a:headEnd type="none" w="med" len="med"/>
                       <a:tailEnd type="none" w="med" len="med"/>
                     </a:lnT>
-                    <a:lnB w="19050" cap="flat" cmpd="sng" algn="ctr">
-                      <a:solidFill>
-                        <a:srgbClr val="FFFFFF"/>
+                    <a:lnB w="9525" cap="flat" cmpd="sng" algn="ctr">
+                      <a:solidFill>
+                        <a:srgbClr val="9AA5B8"/>
                       </a:solidFill>
                       <a:prstDash val="solid"/>
                       <a:round/>
@@ -6732,36 +6948,36 @@
                     </a:p>
                   </a:txBody>
                   <a:tcPr marL="36576" marR="36576" marT="18288" marB="18288" anchor="ctr">
-                    <a:lnL w="19050" cap="flat" cmpd="sng" algn="ctr">
-                      <a:solidFill>
-                        <a:srgbClr val="FFFFFF"/>
+                    <a:lnL w="9525" cap="flat" cmpd="sng" algn="ctr">
+                      <a:solidFill>
+                        <a:srgbClr val="9AA5B8"/>
                       </a:solidFill>
                       <a:prstDash val="solid"/>
                       <a:round/>
                       <a:headEnd type="none" w="med" len="med"/>
                       <a:tailEnd type="none" w="med" len="med"/>
                     </a:lnL>
-                    <a:lnR w="19050" cap="flat" cmpd="sng" algn="ctr">
-                      <a:solidFill>
-                        <a:srgbClr val="FFFFFF"/>
+                    <a:lnR w="9525" cap="flat" cmpd="sng" algn="ctr">
+                      <a:solidFill>
+                        <a:srgbClr val="9AA5B8"/>
                       </a:solidFill>
                       <a:prstDash val="solid"/>
                       <a:round/>
                       <a:headEnd type="none" w="med" len="med"/>
                       <a:tailEnd type="none" w="med" len="med"/>
                     </a:lnR>
-                    <a:lnT w="19050" cap="flat" cmpd="sng" algn="ctr">
-                      <a:solidFill>
-                        <a:srgbClr val="FFFFFF"/>
+                    <a:lnT w="9525" cap="flat" cmpd="sng" algn="ctr">
+                      <a:solidFill>
+                        <a:srgbClr val="9AA5B8"/>
                       </a:solidFill>
                       <a:prstDash val="solid"/>
                       <a:round/>
                       <a:headEnd type="none" w="med" len="med"/>
                       <a:tailEnd type="none" w="med" len="med"/>
                     </a:lnT>
-                    <a:lnB w="19050" cap="flat" cmpd="sng" algn="ctr">
-                      <a:solidFill>
-                        <a:srgbClr val="FFFFFF"/>
+                    <a:lnB w="9525" cap="flat" cmpd="sng" algn="ctr">
+                      <a:solidFill>
+                        <a:srgbClr val="9AA5B8"/>
                       </a:solidFill>
                       <a:prstDash val="solid"/>
                       <a:round/>
@@ -6797,36 +7013,36 @@
                     </a:p>
                   </a:txBody>
                   <a:tcPr marL="36576" marR="36576" marT="18288" marB="18288" anchor="ctr">
-                    <a:lnL w="19050" cap="flat" cmpd="sng" algn="ctr">
-                      <a:solidFill>
-                        <a:srgbClr val="FFFFFF"/>
+                    <a:lnL w="25400" cap="flat" cmpd="sng" algn="ctr">
+                      <a:solidFill>
+                        <a:srgbClr val="4A5568"/>
                       </a:solidFill>
                       <a:prstDash val="solid"/>
                       <a:round/>
                       <a:headEnd type="none" w="med" len="med"/>
                       <a:tailEnd type="none" w="med" len="med"/>
                     </a:lnL>
-                    <a:lnR w="19050" cap="flat" cmpd="sng" algn="ctr">
-                      <a:solidFill>
-                        <a:srgbClr val="FFFFFF"/>
+                    <a:lnR w="9525" cap="flat" cmpd="sng" algn="ctr">
+                      <a:solidFill>
+                        <a:srgbClr val="9AA5B8"/>
                       </a:solidFill>
                       <a:prstDash val="solid"/>
                       <a:round/>
                       <a:headEnd type="none" w="med" len="med"/>
                       <a:tailEnd type="none" w="med" len="med"/>
                     </a:lnR>
-                    <a:lnT w="19050" cap="flat" cmpd="sng" algn="ctr">
-                      <a:solidFill>
-                        <a:srgbClr val="FFFFFF"/>
+                    <a:lnT w="9525" cap="flat" cmpd="sng" algn="ctr">
+                      <a:solidFill>
+                        <a:srgbClr val="9AA5B8"/>
                       </a:solidFill>
                       <a:prstDash val="solid"/>
                       <a:round/>
                       <a:headEnd type="none" w="med" len="med"/>
                       <a:tailEnd type="none" w="med" len="med"/>
                     </a:lnT>
-                    <a:lnB w="19050" cap="flat" cmpd="sng" algn="ctr">
-                      <a:solidFill>
-                        <a:srgbClr val="FFFFFF"/>
+                    <a:lnB w="9525" cap="flat" cmpd="sng" algn="ctr">
+                      <a:solidFill>
+                        <a:srgbClr val="9AA5B8"/>
                       </a:solidFill>
                       <a:prstDash val="solid"/>
                       <a:round/>
@@ -6865,36 +7081,36 @@
                     </a:p>
                   </a:txBody>
                   <a:tcPr marL="36576" marR="36576" marT="18288" marB="18288" anchor="ctr">
-                    <a:lnL w="19050" cap="flat" cmpd="sng" algn="ctr">
-                      <a:solidFill>
-                        <a:srgbClr val="FFFFFF"/>
+                    <a:lnL w="9525" cap="flat" cmpd="sng" algn="ctr">
+                      <a:solidFill>
+                        <a:srgbClr val="9AA5B8"/>
                       </a:solidFill>
                       <a:prstDash val="solid"/>
                       <a:round/>
                       <a:headEnd type="none" w="med" len="med"/>
                       <a:tailEnd type="none" w="med" len="med"/>
                     </a:lnL>
-                    <a:lnR w="19050" cap="flat" cmpd="sng" algn="ctr">
-                      <a:solidFill>
-                        <a:srgbClr val="FFFFFF"/>
+                    <a:lnR w="9525" cap="flat" cmpd="sng" algn="ctr">
+                      <a:solidFill>
+                        <a:srgbClr val="9AA5B8"/>
                       </a:solidFill>
                       <a:prstDash val="solid"/>
                       <a:round/>
                       <a:headEnd type="none" w="med" len="med"/>
                       <a:tailEnd type="none" w="med" len="med"/>
                     </a:lnR>
-                    <a:lnT w="19050" cap="flat" cmpd="sng" algn="ctr">
-                      <a:solidFill>
-                        <a:srgbClr val="FFFFFF"/>
+                    <a:lnT w="9525" cap="flat" cmpd="sng" algn="ctr">
+                      <a:solidFill>
+                        <a:srgbClr val="9AA5B8"/>
                       </a:solidFill>
                       <a:prstDash val="solid"/>
                       <a:round/>
                       <a:headEnd type="none" w="med" len="med"/>
                       <a:tailEnd type="none" w="med" len="med"/>
                     </a:lnT>
-                    <a:lnB w="19050" cap="flat" cmpd="sng" algn="ctr">
-                      <a:solidFill>
-                        <a:srgbClr val="FFFFFF"/>
+                    <a:lnB w="9525" cap="flat" cmpd="sng" algn="ctr">
+                      <a:solidFill>
+                        <a:srgbClr val="9AA5B8"/>
                       </a:solidFill>
                       <a:prstDash val="solid"/>
                       <a:round/>
@@ -6933,36 +7149,36 @@
                     </a:p>
                   </a:txBody>
                   <a:tcPr marL="36576" marR="36576" marT="18288" marB="18288" anchor="ctr">
-                    <a:lnL w="19050" cap="flat" cmpd="sng" algn="ctr">
-                      <a:solidFill>
-                        <a:srgbClr val="FFFFFF"/>
+                    <a:lnL w="25400" cap="flat" cmpd="sng" algn="ctr">
+                      <a:solidFill>
+                        <a:srgbClr val="4A5568"/>
                       </a:solidFill>
                       <a:prstDash val="solid"/>
                       <a:round/>
                       <a:headEnd type="none" w="med" len="med"/>
                       <a:tailEnd type="none" w="med" len="med"/>
                     </a:lnL>
-                    <a:lnR w="19050" cap="flat" cmpd="sng" algn="ctr">
-                      <a:solidFill>
-                        <a:srgbClr val="FFFFFF"/>
+                    <a:lnR w="9525" cap="flat" cmpd="sng" algn="ctr">
+                      <a:solidFill>
+                        <a:srgbClr val="9AA5B8"/>
                       </a:solidFill>
                       <a:prstDash val="solid"/>
                       <a:round/>
                       <a:headEnd type="none" w="med" len="med"/>
                       <a:tailEnd type="none" w="med" len="med"/>
                     </a:lnR>
-                    <a:lnT w="19050" cap="flat" cmpd="sng" algn="ctr">
-                      <a:solidFill>
-                        <a:srgbClr val="FFFFFF"/>
+                    <a:lnT w="9525" cap="flat" cmpd="sng" algn="ctr">
+                      <a:solidFill>
+                        <a:srgbClr val="9AA5B8"/>
                       </a:solidFill>
                       <a:prstDash val="solid"/>
                       <a:round/>
                       <a:headEnd type="none" w="med" len="med"/>
                       <a:tailEnd type="none" w="med" len="med"/>
                     </a:lnT>
-                    <a:lnB w="19050" cap="flat" cmpd="sng" algn="ctr">
-                      <a:solidFill>
-                        <a:srgbClr val="FFFFFF"/>
+                    <a:lnB w="9525" cap="flat" cmpd="sng" algn="ctr">
+                      <a:solidFill>
+                        <a:srgbClr val="9AA5B8"/>
                       </a:solidFill>
                       <a:prstDash val="solid"/>
                       <a:round/>
@@ -7001,36 +7217,36 @@
                     </a:p>
                   </a:txBody>
                   <a:tcPr marL="36576" marR="36576" marT="18288" marB="18288" anchor="ctr">
-                    <a:lnL w="19050" cap="flat" cmpd="sng" algn="ctr">
-                      <a:solidFill>
-                        <a:srgbClr val="FFFFFF"/>
+                    <a:lnL w="9525" cap="flat" cmpd="sng" algn="ctr">
+                      <a:solidFill>
+                        <a:srgbClr val="9AA5B8"/>
                       </a:solidFill>
                       <a:prstDash val="solid"/>
                       <a:round/>
                       <a:headEnd type="none" w="med" len="med"/>
                       <a:tailEnd type="none" w="med" len="med"/>
                     </a:lnL>
-                    <a:lnR w="19050" cap="flat" cmpd="sng" algn="ctr">
-                      <a:solidFill>
-                        <a:srgbClr val="FFFFFF"/>
+                    <a:lnR w="9525" cap="flat" cmpd="sng" algn="ctr">
+                      <a:solidFill>
+                        <a:srgbClr val="9AA5B8"/>
                       </a:solidFill>
                       <a:prstDash val="solid"/>
                       <a:round/>
                       <a:headEnd type="none" w="med" len="med"/>
                       <a:tailEnd type="none" w="med" len="med"/>
                     </a:lnR>
-                    <a:lnT w="19050" cap="flat" cmpd="sng" algn="ctr">
-                      <a:solidFill>
-                        <a:srgbClr val="FFFFFF"/>
+                    <a:lnT w="9525" cap="flat" cmpd="sng" algn="ctr">
+                      <a:solidFill>
+                        <a:srgbClr val="9AA5B8"/>
                       </a:solidFill>
                       <a:prstDash val="solid"/>
                       <a:round/>
                       <a:headEnd type="none" w="med" len="med"/>
                       <a:tailEnd type="none" w="med" len="med"/>
                     </a:lnT>
-                    <a:lnB w="19050" cap="flat" cmpd="sng" algn="ctr">
-                      <a:solidFill>
-                        <a:srgbClr val="FFFFFF"/>
+                    <a:lnB w="9525" cap="flat" cmpd="sng" algn="ctr">
+                      <a:solidFill>
+                        <a:srgbClr val="9AA5B8"/>
                       </a:solidFill>
                       <a:prstDash val="solid"/>
                       <a:round/>
@@ -7071,36 +7287,36 @@
                     </a:p>
                   </a:txBody>
                   <a:tcPr marL="36576" marR="36576" marT="18288" marB="18288" anchor="ctr">
-                    <a:lnL w="19050" cap="flat" cmpd="sng" algn="ctr">
-                      <a:solidFill>
-                        <a:srgbClr val="FFFFFF"/>
+                    <a:lnL w="9525" cap="flat" cmpd="sng" algn="ctr">
+                      <a:solidFill>
+                        <a:srgbClr val="9AA5B8"/>
                       </a:solidFill>
                       <a:prstDash val="solid"/>
                       <a:round/>
                       <a:headEnd type="none" w="med" len="med"/>
                       <a:tailEnd type="none" w="med" len="med"/>
                     </a:lnL>
-                    <a:lnR w="19050" cap="flat" cmpd="sng" algn="ctr">
-                      <a:solidFill>
-                        <a:srgbClr val="FFFFFF"/>
+                    <a:lnR w="9525" cap="flat" cmpd="sng" algn="ctr">
+                      <a:solidFill>
+                        <a:srgbClr val="9AA5B8"/>
                       </a:solidFill>
                       <a:prstDash val="solid"/>
                       <a:round/>
                       <a:headEnd type="none" w="med" len="med"/>
                       <a:tailEnd type="none" w="med" len="med"/>
                     </a:lnR>
-                    <a:lnT w="19050" cap="flat" cmpd="sng" algn="ctr">
-                      <a:solidFill>
-                        <a:srgbClr val="FFFFFF"/>
+                    <a:lnT w="9525" cap="flat" cmpd="sng" algn="ctr">
+                      <a:solidFill>
+                        <a:srgbClr val="9AA5B8"/>
                       </a:solidFill>
                       <a:prstDash val="solid"/>
                       <a:round/>
                       <a:headEnd type="none" w="med" len="med"/>
                       <a:tailEnd type="none" w="med" len="med"/>
                     </a:lnT>
-                    <a:lnB w="19050" cap="flat" cmpd="sng" algn="ctr">
-                      <a:solidFill>
-                        <a:srgbClr val="FFFFFF"/>
+                    <a:lnB w="9525" cap="flat" cmpd="sng" algn="ctr">
+                      <a:solidFill>
+                        <a:srgbClr val="9AA5B8"/>
                       </a:solidFill>
                       <a:prstDash val="solid"/>
                       <a:round/>
@@ -7136,36 +7352,36 @@
                     </a:p>
                   </a:txBody>
                   <a:tcPr marL="36576" marR="36576" marT="18288" marB="18288" anchor="ctr">
-                    <a:lnL w="19050" cap="flat" cmpd="sng" algn="ctr">
-                      <a:solidFill>
-                        <a:srgbClr val="FFFFFF"/>
+                    <a:lnL w="9525" cap="flat" cmpd="sng" algn="ctr">
+                      <a:solidFill>
+                        <a:srgbClr val="9AA5B8"/>
                       </a:solidFill>
                       <a:prstDash val="solid"/>
                       <a:round/>
                       <a:headEnd type="none" w="med" len="med"/>
                       <a:tailEnd type="none" w="med" len="med"/>
                     </a:lnL>
-                    <a:lnR w="19050" cap="flat" cmpd="sng" algn="ctr">
-                      <a:solidFill>
-                        <a:srgbClr val="FFFFFF"/>
+                    <a:lnR w="9525" cap="flat" cmpd="sng" algn="ctr">
+                      <a:solidFill>
+                        <a:srgbClr val="9AA5B8"/>
                       </a:solidFill>
                       <a:prstDash val="solid"/>
                       <a:round/>
                       <a:headEnd type="none" w="med" len="med"/>
                       <a:tailEnd type="none" w="med" len="med"/>
                     </a:lnR>
-                    <a:lnT w="19050" cap="flat" cmpd="sng" algn="ctr">
-                      <a:solidFill>
-                        <a:srgbClr val="FFFFFF"/>
+                    <a:lnT w="9525" cap="flat" cmpd="sng" algn="ctr">
+                      <a:solidFill>
+                        <a:srgbClr val="9AA5B8"/>
                       </a:solidFill>
                       <a:prstDash val="solid"/>
                       <a:round/>
                       <a:headEnd type="none" w="med" len="med"/>
                       <a:tailEnd type="none" w="med" len="med"/>
                     </a:lnT>
-                    <a:lnB w="19050" cap="flat" cmpd="sng" algn="ctr">
-                      <a:solidFill>
-                        <a:srgbClr val="FFFFFF"/>
+                    <a:lnB w="9525" cap="flat" cmpd="sng" algn="ctr">
+                      <a:solidFill>
+                        <a:srgbClr val="9AA5B8"/>
                       </a:solidFill>
                       <a:prstDash val="solid"/>
                       <a:round/>
@@ -7201,36 +7417,36 @@
                     </a:p>
                   </a:txBody>
                   <a:tcPr marL="36576" marR="36576" marT="18288" marB="18288" anchor="ctr">
-                    <a:lnL w="19050" cap="flat" cmpd="sng" algn="ctr">
-                      <a:solidFill>
-                        <a:srgbClr val="FFFFFF"/>
+                    <a:lnL w="9525" cap="flat" cmpd="sng" algn="ctr">
+                      <a:solidFill>
+                        <a:srgbClr val="9AA5B8"/>
                       </a:solidFill>
                       <a:prstDash val="solid"/>
                       <a:round/>
                       <a:headEnd type="none" w="med" len="med"/>
                       <a:tailEnd type="none" w="med" len="med"/>
                     </a:lnL>
-                    <a:lnR w="19050" cap="flat" cmpd="sng" algn="ctr">
-                      <a:solidFill>
-                        <a:srgbClr val="FFFFFF"/>
+                    <a:lnR w="9525" cap="flat" cmpd="sng" algn="ctr">
+                      <a:solidFill>
+                        <a:srgbClr val="9AA5B8"/>
                       </a:solidFill>
                       <a:prstDash val="solid"/>
                       <a:round/>
                       <a:headEnd type="none" w="med" len="med"/>
                       <a:tailEnd type="none" w="med" len="med"/>
                     </a:lnR>
-                    <a:lnT w="19050" cap="flat" cmpd="sng" algn="ctr">
-                      <a:solidFill>
-                        <a:srgbClr val="FFFFFF"/>
+                    <a:lnT w="9525" cap="flat" cmpd="sng" algn="ctr">
+                      <a:solidFill>
+                        <a:srgbClr val="9AA5B8"/>
                       </a:solidFill>
                       <a:prstDash val="solid"/>
                       <a:round/>
                       <a:headEnd type="none" w="med" len="med"/>
                       <a:tailEnd type="none" w="med" len="med"/>
                     </a:lnT>
-                    <a:lnB w="19050" cap="flat" cmpd="sng" algn="ctr">
-                      <a:solidFill>
-                        <a:srgbClr val="FFFFFF"/>
+                    <a:lnB w="9525" cap="flat" cmpd="sng" algn="ctr">
+                      <a:solidFill>
+                        <a:srgbClr val="9AA5B8"/>
                       </a:solidFill>
                       <a:prstDash val="solid"/>
                       <a:round/>
@@ -7266,36 +7482,36 @@
                     </a:p>
                   </a:txBody>
                   <a:tcPr marL="36576" marR="36576" marT="18288" marB="18288" anchor="ctr">
-                    <a:lnL w="19050" cap="flat" cmpd="sng" algn="ctr">
-                      <a:solidFill>
-                        <a:srgbClr val="FFFFFF"/>
+                    <a:lnL w="25400" cap="flat" cmpd="sng" algn="ctr">
+                      <a:solidFill>
+                        <a:srgbClr val="4A5568"/>
                       </a:solidFill>
                       <a:prstDash val="solid"/>
                       <a:round/>
                       <a:headEnd type="none" w="med" len="med"/>
                       <a:tailEnd type="none" w="med" len="med"/>
                     </a:lnL>
-                    <a:lnR w="19050" cap="flat" cmpd="sng" algn="ctr">
-                      <a:solidFill>
-                        <a:srgbClr val="FFFFFF"/>
+                    <a:lnR w="9525" cap="flat" cmpd="sng" algn="ctr">
+                      <a:solidFill>
+                        <a:srgbClr val="9AA5B8"/>
                       </a:solidFill>
                       <a:prstDash val="solid"/>
                       <a:round/>
                       <a:headEnd type="none" w="med" len="med"/>
                       <a:tailEnd type="none" w="med" len="med"/>
                     </a:lnR>
-                    <a:lnT w="19050" cap="flat" cmpd="sng" algn="ctr">
-                      <a:solidFill>
-                        <a:srgbClr val="FFFFFF"/>
+                    <a:lnT w="9525" cap="flat" cmpd="sng" algn="ctr">
+                      <a:solidFill>
+                        <a:srgbClr val="9AA5B8"/>
                       </a:solidFill>
                       <a:prstDash val="solid"/>
                       <a:round/>
                       <a:headEnd type="none" w="med" len="med"/>
                       <a:tailEnd type="none" w="med" len="med"/>
                     </a:lnT>
-                    <a:lnB w="19050" cap="flat" cmpd="sng" algn="ctr">
-                      <a:solidFill>
-                        <a:srgbClr val="FFFFFF"/>
+                    <a:lnB w="9525" cap="flat" cmpd="sng" algn="ctr">
+                      <a:solidFill>
+                        <a:srgbClr val="9AA5B8"/>
                       </a:solidFill>
                       <a:prstDash val="solid"/>
                       <a:round/>
@@ -7334,36 +7550,36 @@
                     </a:p>
                   </a:txBody>
                   <a:tcPr marL="36576" marR="36576" marT="18288" marB="18288" anchor="ctr">
-                    <a:lnL w="19050" cap="flat" cmpd="sng" algn="ctr">
-                      <a:solidFill>
-                        <a:srgbClr val="FFFFFF"/>
+                    <a:lnL w="9525" cap="flat" cmpd="sng" algn="ctr">
+                      <a:solidFill>
+                        <a:srgbClr val="9AA5B8"/>
                       </a:solidFill>
                       <a:prstDash val="solid"/>
                       <a:round/>
                       <a:headEnd type="none" w="med" len="med"/>
                       <a:tailEnd type="none" w="med" len="med"/>
                     </a:lnL>
-                    <a:lnR w="19050" cap="flat" cmpd="sng" algn="ctr">
-                      <a:solidFill>
-                        <a:srgbClr val="FFFFFF"/>
+                    <a:lnR w="9525" cap="flat" cmpd="sng" algn="ctr">
+                      <a:solidFill>
+                        <a:srgbClr val="9AA5B8"/>
                       </a:solidFill>
                       <a:prstDash val="solid"/>
                       <a:round/>
                       <a:headEnd type="none" w="med" len="med"/>
                       <a:tailEnd type="none" w="med" len="med"/>
                     </a:lnR>
-                    <a:lnT w="19050" cap="flat" cmpd="sng" algn="ctr">
-                      <a:solidFill>
-                        <a:srgbClr val="FFFFFF"/>
+                    <a:lnT w="9525" cap="flat" cmpd="sng" algn="ctr">
+                      <a:solidFill>
+                        <a:srgbClr val="9AA5B8"/>
                       </a:solidFill>
                       <a:prstDash val="solid"/>
                       <a:round/>
                       <a:headEnd type="none" w="med" len="med"/>
                       <a:tailEnd type="none" w="med" len="med"/>
                     </a:lnT>
-                    <a:lnB w="19050" cap="flat" cmpd="sng" algn="ctr">
-                      <a:solidFill>
-                        <a:srgbClr val="FFFFFF"/>
+                    <a:lnB w="9525" cap="flat" cmpd="sng" algn="ctr">
+                      <a:solidFill>
+                        <a:srgbClr val="9AA5B8"/>
                       </a:solidFill>
                       <a:prstDash val="solid"/>
                       <a:round/>
@@ -7402,36 +7618,36 @@
                     </a:p>
                   </a:txBody>
                   <a:tcPr marL="36576" marR="36576" marT="18288" marB="18288" anchor="ctr">
-                    <a:lnL w="19050" cap="flat" cmpd="sng" algn="ctr">
-                      <a:solidFill>
-                        <a:srgbClr val="FFFFFF"/>
+                    <a:lnL w="25400" cap="flat" cmpd="sng" algn="ctr">
+                      <a:solidFill>
+                        <a:srgbClr val="4A5568"/>
                       </a:solidFill>
                       <a:prstDash val="solid"/>
                       <a:round/>
                       <a:headEnd type="none" w="med" len="med"/>
                       <a:tailEnd type="none" w="med" len="med"/>
                     </a:lnL>
-                    <a:lnR w="19050" cap="flat" cmpd="sng" algn="ctr">
-                      <a:solidFill>
-                        <a:srgbClr val="FFFFFF"/>
+                    <a:lnR w="9525" cap="flat" cmpd="sng" algn="ctr">
+                      <a:solidFill>
+                        <a:srgbClr val="9AA5B8"/>
                       </a:solidFill>
                       <a:prstDash val="solid"/>
                       <a:round/>
                       <a:headEnd type="none" w="med" len="med"/>
                       <a:tailEnd type="none" w="med" len="med"/>
                     </a:lnR>
-                    <a:lnT w="19050" cap="flat" cmpd="sng" algn="ctr">
-                      <a:solidFill>
-                        <a:srgbClr val="FFFFFF"/>
+                    <a:lnT w="9525" cap="flat" cmpd="sng" algn="ctr">
+                      <a:solidFill>
+                        <a:srgbClr val="9AA5B8"/>
                       </a:solidFill>
                       <a:prstDash val="solid"/>
                       <a:round/>
                       <a:headEnd type="none" w="med" len="med"/>
                       <a:tailEnd type="none" w="med" len="med"/>
                     </a:lnT>
-                    <a:lnB w="19050" cap="flat" cmpd="sng" algn="ctr">
-                      <a:solidFill>
-                        <a:srgbClr val="FFFFFF"/>
+                    <a:lnB w="9525" cap="flat" cmpd="sng" algn="ctr">
+                      <a:solidFill>
+                        <a:srgbClr val="9AA5B8"/>
                       </a:solidFill>
                       <a:prstDash val="solid"/>
                       <a:round/>
@@ -7470,36 +7686,36 @@
                     </a:p>
                   </a:txBody>
                   <a:tcPr marL="36576" marR="36576" marT="18288" marB="18288" anchor="ctr">
-                    <a:lnL w="19050" cap="flat" cmpd="sng" algn="ctr">
-                      <a:solidFill>
-                        <a:srgbClr val="FFFFFF"/>
+                    <a:lnL w="9525" cap="flat" cmpd="sng" algn="ctr">
+                      <a:solidFill>
+                        <a:srgbClr val="9AA5B8"/>
                       </a:solidFill>
                       <a:prstDash val="solid"/>
                       <a:round/>
                       <a:headEnd type="none" w="med" len="med"/>
                       <a:tailEnd type="none" w="med" len="med"/>
                     </a:lnL>
-                    <a:lnR w="19050" cap="flat" cmpd="sng" algn="ctr">
-                      <a:solidFill>
-                        <a:srgbClr val="FFFFFF"/>
+                    <a:lnR w="9525" cap="flat" cmpd="sng" algn="ctr">
+                      <a:solidFill>
+                        <a:srgbClr val="9AA5B8"/>
                       </a:solidFill>
                       <a:prstDash val="solid"/>
                       <a:round/>
                       <a:headEnd type="none" w="med" len="med"/>
                       <a:tailEnd type="none" w="med" len="med"/>
                     </a:lnR>
-                    <a:lnT w="19050" cap="flat" cmpd="sng" algn="ctr">
-                      <a:solidFill>
-                        <a:srgbClr val="FFFFFF"/>
+                    <a:lnT w="9525" cap="flat" cmpd="sng" algn="ctr">
+                      <a:solidFill>
+                        <a:srgbClr val="9AA5B8"/>
                       </a:solidFill>
                       <a:prstDash val="solid"/>
                       <a:round/>
                       <a:headEnd type="none" w="med" len="med"/>
                       <a:tailEnd type="none" w="med" len="med"/>
                     </a:lnT>
-                    <a:lnB w="19050" cap="flat" cmpd="sng" algn="ctr">
-                      <a:solidFill>
-                        <a:srgbClr val="FFFFFF"/>
+                    <a:lnB w="9525" cap="flat" cmpd="sng" algn="ctr">
+                      <a:solidFill>
+                        <a:srgbClr val="9AA5B8"/>
                       </a:solidFill>
                       <a:prstDash val="solid"/>
                       <a:round/>
@@ -7540,36 +7756,36 @@
                     </a:p>
                   </a:txBody>
                   <a:tcPr marL="36576" marR="36576" marT="18288" marB="18288" anchor="ctr">
-                    <a:lnL w="19050" cap="flat" cmpd="sng" algn="ctr">
-                      <a:solidFill>
-                        <a:srgbClr val="FFFFFF"/>
+                    <a:lnL w="9525" cap="flat" cmpd="sng" algn="ctr">
+                      <a:solidFill>
+                        <a:srgbClr val="9AA5B8"/>
                       </a:solidFill>
                       <a:prstDash val="solid"/>
                       <a:round/>
                       <a:headEnd type="none" w="med" len="med"/>
                       <a:tailEnd type="none" w="med" len="med"/>
                     </a:lnL>
-                    <a:lnR w="19050" cap="flat" cmpd="sng" algn="ctr">
-                      <a:solidFill>
-                        <a:srgbClr val="FFFFFF"/>
+                    <a:lnR w="9525" cap="flat" cmpd="sng" algn="ctr">
+                      <a:solidFill>
+                        <a:srgbClr val="9AA5B8"/>
                       </a:solidFill>
                       <a:prstDash val="solid"/>
                       <a:round/>
                       <a:headEnd type="none" w="med" len="med"/>
                       <a:tailEnd type="none" w="med" len="med"/>
                     </a:lnR>
-                    <a:lnT w="19050" cap="flat" cmpd="sng" algn="ctr">
-                      <a:solidFill>
-                        <a:srgbClr val="FFFFFF"/>
+                    <a:lnT w="9525" cap="flat" cmpd="sng" algn="ctr">
+                      <a:solidFill>
+                        <a:srgbClr val="9AA5B8"/>
                       </a:solidFill>
                       <a:prstDash val="solid"/>
                       <a:round/>
                       <a:headEnd type="none" w="med" len="med"/>
                       <a:tailEnd type="none" w="med" len="med"/>
                     </a:lnT>
-                    <a:lnB w="19050" cap="flat" cmpd="sng" algn="ctr">
-                      <a:solidFill>
-                        <a:srgbClr val="FFFFFF"/>
+                    <a:lnB w="9525" cap="flat" cmpd="sng" algn="ctr">
+                      <a:solidFill>
+                        <a:srgbClr val="9AA5B8"/>
                       </a:solidFill>
                       <a:prstDash val="solid"/>
                       <a:round/>
@@ -7605,36 +7821,36 @@
                     </a:p>
                   </a:txBody>
                   <a:tcPr marL="36576" marR="36576" marT="18288" marB="18288" anchor="ctr">
-                    <a:lnL w="19050" cap="flat" cmpd="sng" algn="ctr">
-                      <a:solidFill>
-                        <a:srgbClr val="FFFFFF"/>
+                    <a:lnL w="9525" cap="flat" cmpd="sng" algn="ctr">
+                      <a:solidFill>
+                        <a:srgbClr val="9AA5B8"/>
                       </a:solidFill>
                       <a:prstDash val="solid"/>
                       <a:round/>
                       <a:headEnd type="none" w="med" len="med"/>
                       <a:tailEnd type="none" w="med" len="med"/>
                     </a:lnL>
-                    <a:lnR w="19050" cap="flat" cmpd="sng" algn="ctr">
-                      <a:solidFill>
-                        <a:srgbClr val="FFFFFF"/>
+                    <a:lnR w="9525" cap="flat" cmpd="sng" algn="ctr">
+                      <a:solidFill>
+                        <a:srgbClr val="9AA5B8"/>
                       </a:solidFill>
                       <a:prstDash val="solid"/>
                       <a:round/>
                       <a:headEnd type="none" w="med" len="med"/>
                       <a:tailEnd type="none" w="med" len="med"/>
                     </a:lnR>
-                    <a:lnT w="19050" cap="flat" cmpd="sng" algn="ctr">
-                      <a:solidFill>
-                        <a:srgbClr val="FFFFFF"/>
+                    <a:lnT w="9525" cap="flat" cmpd="sng" algn="ctr">
+                      <a:solidFill>
+                        <a:srgbClr val="9AA5B8"/>
                       </a:solidFill>
                       <a:prstDash val="solid"/>
                       <a:round/>
                       <a:headEnd type="none" w="med" len="med"/>
                       <a:tailEnd type="none" w="med" len="med"/>
                     </a:lnT>
-                    <a:lnB w="19050" cap="flat" cmpd="sng" algn="ctr">
-                      <a:solidFill>
-                        <a:srgbClr val="FFFFFF"/>
+                    <a:lnB w="9525" cap="flat" cmpd="sng" algn="ctr">
+                      <a:solidFill>
+                        <a:srgbClr val="9AA5B8"/>
                       </a:solidFill>
                       <a:prstDash val="solid"/>
                       <a:round/>
@@ -7670,36 +7886,36 @@
                     </a:p>
                   </a:txBody>
                   <a:tcPr marL="36576" marR="36576" marT="18288" marB="18288" anchor="ctr">
-                    <a:lnL w="19050" cap="flat" cmpd="sng" algn="ctr">
-                      <a:solidFill>
-                        <a:srgbClr val="FFFFFF"/>
+                    <a:lnL w="9525" cap="flat" cmpd="sng" algn="ctr">
+                      <a:solidFill>
+                        <a:srgbClr val="9AA5B8"/>
                       </a:solidFill>
                       <a:prstDash val="solid"/>
                       <a:round/>
                       <a:headEnd type="none" w="med" len="med"/>
                       <a:tailEnd type="none" w="med" len="med"/>
                     </a:lnL>
-                    <a:lnR w="19050" cap="flat" cmpd="sng" algn="ctr">
-                      <a:solidFill>
-                        <a:srgbClr val="FFFFFF"/>
+                    <a:lnR w="9525" cap="flat" cmpd="sng" algn="ctr">
+                      <a:solidFill>
+                        <a:srgbClr val="9AA5B8"/>
                       </a:solidFill>
                       <a:prstDash val="solid"/>
                       <a:round/>
                       <a:headEnd type="none" w="med" len="med"/>
                       <a:tailEnd type="none" w="med" len="med"/>
                     </a:lnR>
-                    <a:lnT w="19050" cap="flat" cmpd="sng" algn="ctr">
-                      <a:solidFill>
-                        <a:srgbClr val="FFFFFF"/>
+                    <a:lnT w="9525" cap="flat" cmpd="sng" algn="ctr">
+                      <a:solidFill>
+                        <a:srgbClr val="9AA5B8"/>
                       </a:solidFill>
                       <a:prstDash val="solid"/>
                       <a:round/>
                       <a:headEnd type="none" w="med" len="med"/>
                       <a:tailEnd type="none" w="med" len="med"/>
                     </a:lnT>
-                    <a:lnB w="19050" cap="flat" cmpd="sng" algn="ctr">
-                      <a:solidFill>
-                        <a:srgbClr val="FFFFFF"/>
+                    <a:lnB w="9525" cap="flat" cmpd="sng" algn="ctr">
+                      <a:solidFill>
+                        <a:srgbClr val="9AA5B8"/>
                       </a:solidFill>
                       <a:prstDash val="solid"/>
                       <a:round/>
@@ -7735,36 +7951,36 @@
                     </a:p>
                   </a:txBody>
                   <a:tcPr marL="36576" marR="36576" marT="18288" marB="18288" anchor="ctr">
-                    <a:lnL w="19050" cap="flat" cmpd="sng" algn="ctr">
-                      <a:solidFill>
-                        <a:srgbClr val="FFFFFF"/>
+                    <a:lnL w="25400" cap="flat" cmpd="sng" algn="ctr">
+                      <a:solidFill>
+                        <a:srgbClr val="4A5568"/>
                       </a:solidFill>
                       <a:prstDash val="solid"/>
                       <a:round/>
                       <a:headEnd type="none" w="med" len="med"/>
                       <a:tailEnd type="none" w="med" len="med"/>
                     </a:lnL>
-                    <a:lnR w="19050" cap="flat" cmpd="sng" algn="ctr">
-                      <a:solidFill>
-                        <a:srgbClr val="FFFFFF"/>
+                    <a:lnR w="9525" cap="flat" cmpd="sng" algn="ctr">
+                      <a:solidFill>
+                        <a:srgbClr val="9AA5B8"/>
                       </a:solidFill>
                       <a:prstDash val="solid"/>
                       <a:round/>
                       <a:headEnd type="none" w="med" len="med"/>
                       <a:tailEnd type="none" w="med" len="med"/>
                     </a:lnR>
-                    <a:lnT w="19050" cap="flat" cmpd="sng" algn="ctr">
-                      <a:solidFill>
-                        <a:srgbClr val="FFFFFF"/>
+                    <a:lnT w="9525" cap="flat" cmpd="sng" algn="ctr">
+                      <a:solidFill>
+                        <a:srgbClr val="9AA5B8"/>
                       </a:solidFill>
                       <a:prstDash val="solid"/>
                       <a:round/>
                       <a:headEnd type="none" w="med" len="med"/>
                       <a:tailEnd type="none" w="med" len="med"/>
                     </a:lnT>
-                    <a:lnB w="19050" cap="flat" cmpd="sng" algn="ctr">
-                      <a:solidFill>
-                        <a:srgbClr val="FFFFFF"/>
+                    <a:lnB w="9525" cap="flat" cmpd="sng" algn="ctr">
+                      <a:solidFill>
+                        <a:srgbClr val="9AA5B8"/>
                       </a:solidFill>
                       <a:prstDash val="solid"/>
                       <a:round/>
@@ -7803,36 +8019,36 @@
                     </a:p>
                   </a:txBody>
                   <a:tcPr marL="36576" marR="36576" marT="18288" marB="18288" anchor="ctr">
-                    <a:lnL w="19050" cap="flat" cmpd="sng" algn="ctr">
-                      <a:solidFill>
-                        <a:srgbClr val="FFFFFF"/>
+                    <a:lnL w="9525" cap="flat" cmpd="sng" algn="ctr">
+                      <a:solidFill>
+                        <a:srgbClr val="9AA5B8"/>
                       </a:solidFill>
                       <a:prstDash val="solid"/>
                       <a:round/>
                       <a:headEnd type="none" w="med" len="med"/>
                       <a:tailEnd type="none" w="med" len="med"/>
                     </a:lnL>
-                    <a:lnR w="19050" cap="flat" cmpd="sng" algn="ctr">
-                      <a:solidFill>
-                        <a:srgbClr val="FFFFFF"/>
+                    <a:lnR w="9525" cap="flat" cmpd="sng" algn="ctr">
+                      <a:solidFill>
+                        <a:srgbClr val="9AA5B8"/>
                       </a:solidFill>
                       <a:prstDash val="solid"/>
                       <a:round/>
                       <a:headEnd type="none" w="med" len="med"/>
                       <a:tailEnd type="none" w="med" len="med"/>
                     </a:lnR>
-                    <a:lnT w="19050" cap="flat" cmpd="sng" algn="ctr">
-                      <a:solidFill>
-                        <a:srgbClr val="FFFFFF"/>
+                    <a:lnT w="9525" cap="flat" cmpd="sng" algn="ctr">
+                      <a:solidFill>
+                        <a:srgbClr val="9AA5B8"/>
                       </a:solidFill>
                       <a:prstDash val="solid"/>
                       <a:round/>
                       <a:headEnd type="none" w="med" len="med"/>
                       <a:tailEnd type="none" w="med" len="med"/>
                     </a:lnT>
-                    <a:lnB w="19050" cap="flat" cmpd="sng" algn="ctr">
-                      <a:solidFill>
-                        <a:srgbClr val="FFFFFF"/>
+                    <a:lnB w="9525" cap="flat" cmpd="sng" algn="ctr">
+                      <a:solidFill>
+                        <a:srgbClr val="9AA5B8"/>
                       </a:solidFill>
                       <a:prstDash val="solid"/>
                       <a:round/>
@@ -7871,36 +8087,36 @@
                     </a:p>
                   </a:txBody>
                   <a:tcPr marL="36576" marR="36576" marT="18288" marB="18288" anchor="ctr">
-                    <a:lnL w="19050" cap="flat" cmpd="sng" algn="ctr">
-                      <a:solidFill>
-                        <a:srgbClr val="FFFFFF"/>
+                    <a:lnL w="25400" cap="flat" cmpd="sng" algn="ctr">
+                      <a:solidFill>
+                        <a:srgbClr val="4A5568"/>
                       </a:solidFill>
                       <a:prstDash val="solid"/>
                       <a:round/>
                       <a:headEnd type="none" w="med" len="med"/>
                       <a:tailEnd type="none" w="med" len="med"/>
                     </a:lnL>
-                    <a:lnR w="19050" cap="flat" cmpd="sng" algn="ctr">
-                      <a:solidFill>
-                        <a:srgbClr val="FFFFFF"/>
+                    <a:lnR w="9525" cap="flat" cmpd="sng" algn="ctr">
+                      <a:solidFill>
+                        <a:srgbClr val="9AA5B8"/>
                       </a:solidFill>
                       <a:prstDash val="solid"/>
                       <a:round/>
                       <a:headEnd type="none" w="med" len="med"/>
                       <a:tailEnd type="none" w="med" len="med"/>
                     </a:lnR>
-                    <a:lnT w="19050" cap="flat" cmpd="sng" algn="ctr">
-                      <a:solidFill>
-                        <a:srgbClr val="FFFFFF"/>
+                    <a:lnT w="9525" cap="flat" cmpd="sng" algn="ctr">
+                      <a:solidFill>
+                        <a:srgbClr val="9AA5B8"/>
                       </a:solidFill>
                       <a:prstDash val="solid"/>
                       <a:round/>
                       <a:headEnd type="none" w="med" len="med"/>
                       <a:tailEnd type="none" w="med" len="med"/>
                     </a:lnT>
-                    <a:lnB w="19050" cap="flat" cmpd="sng" algn="ctr">
-                      <a:solidFill>
-                        <a:srgbClr val="FFFFFF"/>
+                    <a:lnB w="9525" cap="flat" cmpd="sng" algn="ctr">
+                      <a:solidFill>
+                        <a:srgbClr val="9AA5B8"/>
                       </a:solidFill>
                       <a:prstDash val="solid"/>
                       <a:round/>
@@ -7939,36 +8155,36 @@
                     </a:p>
                   </a:txBody>
                   <a:tcPr marL="36576" marR="36576" marT="18288" marB="18288" anchor="ctr">
-                    <a:lnL w="19050" cap="flat" cmpd="sng" algn="ctr">
-                      <a:solidFill>
-                        <a:srgbClr val="FFFFFF"/>
+                    <a:lnL w="9525" cap="flat" cmpd="sng" algn="ctr">
+                      <a:solidFill>
+                        <a:srgbClr val="9AA5B8"/>
                       </a:solidFill>
                       <a:prstDash val="solid"/>
                       <a:round/>
                       <a:headEnd type="none" w="med" len="med"/>
                       <a:tailEnd type="none" w="med" len="med"/>
                     </a:lnL>
-                    <a:lnR w="19050" cap="flat" cmpd="sng" algn="ctr">
-                      <a:solidFill>
-                        <a:srgbClr val="FFFFFF"/>
+                    <a:lnR w="9525" cap="flat" cmpd="sng" algn="ctr">
+                      <a:solidFill>
+                        <a:srgbClr val="9AA5B8"/>
                       </a:solidFill>
                       <a:prstDash val="solid"/>
                       <a:round/>
                       <a:headEnd type="none" w="med" len="med"/>
                       <a:tailEnd type="none" w="med" len="med"/>
                     </a:lnR>
-                    <a:lnT w="19050" cap="flat" cmpd="sng" algn="ctr">
-                      <a:solidFill>
-                        <a:srgbClr val="FFFFFF"/>
+                    <a:lnT w="9525" cap="flat" cmpd="sng" algn="ctr">
+                      <a:solidFill>
+                        <a:srgbClr val="9AA5B8"/>
                       </a:solidFill>
                       <a:prstDash val="solid"/>
                       <a:round/>
                       <a:headEnd type="none" w="med" len="med"/>
                       <a:tailEnd type="none" w="med" len="med"/>
                     </a:lnT>
-                    <a:lnB w="19050" cap="flat" cmpd="sng" algn="ctr">
-                      <a:solidFill>
-                        <a:srgbClr val="FFFFFF"/>
+                    <a:lnB w="9525" cap="flat" cmpd="sng" algn="ctr">
+                      <a:solidFill>
+                        <a:srgbClr val="9AA5B8"/>
                       </a:solidFill>
                       <a:prstDash val="solid"/>
                       <a:round/>
@@ -8009,36 +8225,36 @@
                     </a:p>
                   </a:txBody>
                   <a:tcPr marL="36576" marR="36576" marT="18288" marB="18288" anchor="ctr">
-                    <a:lnL w="19050" cap="flat" cmpd="sng" algn="ctr">
-                      <a:solidFill>
-                        <a:srgbClr val="FFFFFF"/>
+                    <a:lnL w="9525" cap="flat" cmpd="sng" algn="ctr">
+                      <a:solidFill>
+                        <a:srgbClr val="9AA5B8"/>
                       </a:solidFill>
                       <a:prstDash val="solid"/>
                       <a:round/>
                       <a:headEnd type="none" w="med" len="med"/>
                       <a:tailEnd type="none" w="med" len="med"/>
                     </a:lnL>
-                    <a:lnR w="19050" cap="flat" cmpd="sng" algn="ctr">
-                      <a:solidFill>
-                        <a:srgbClr val="FFFFFF"/>
+                    <a:lnR w="9525" cap="flat" cmpd="sng" algn="ctr">
+                      <a:solidFill>
+                        <a:srgbClr val="9AA5B8"/>
                       </a:solidFill>
                       <a:prstDash val="solid"/>
                       <a:round/>
                       <a:headEnd type="none" w="med" len="med"/>
                       <a:tailEnd type="none" w="med" len="med"/>
                     </a:lnR>
-                    <a:lnT w="19050" cap="flat" cmpd="sng" algn="ctr">
-                      <a:solidFill>
-                        <a:srgbClr val="FFFFFF"/>
+                    <a:lnT w="9525" cap="flat" cmpd="sng" algn="ctr">
+                      <a:solidFill>
+                        <a:srgbClr val="9AA5B8"/>
                       </a:solidFill>
                       <a:prstDash val="solid"/>
                       <a:round/>
                       <a:headEnd type="none" w="med" len="med"/>
                       <a:tailEnd type="none" w="med" len="med"/>
                     </a:lnT>
-                    <a:lnB w="19050" cap="flat" cmpd="sng" algn="ctr">
-                      <a:solidFill>
-                        <a:srgbClr val="FFFFFF"/>
+                    <a:lnB w="9525" cap="flat" cmpd="sng" algn="ctr">
+                      <a:solidFill>
+                        <a:srgbClr val="9AA5B8"/>
                       </a:solidFill>
                       <a:prstDash val="solid"/>
                       <a:round/>
@@ -8074,36 +8290,36 @@
                     </a:p>
                   </a:txBody>
                   <a:tcPr marL="36576" marR="36576" marT="18288" marB="18288" anchor="ctr">
-                    <a:lnL w="19050" cap="flat" cmpd="sng" algn="ctr">
-                      <a:solidFill>
-                        <a:srgbClr val="FFFFFF"/>
+                    <a:lnL w="9525" cap="flat" cmpd="sng" algn="ctr">
+                      <a:solidFill>
+                        <a:srgbClr val="9AA5B8"/>
                       </a:solidFill>
                       <a:prstDash val="solid"/>
                       <a:round/>
                       <a:headEnd type="none" w="med" len="med"/>
                       <a:tailEnd type="none" w="med" len="med"/>
                     </a:lnL>
-                    <a:lnR w="19050" cap="flat" cmpd="sng" algn="ctr">
-                      <a:solidFill>
-                        <a:srgbClr val="FFFFFF"/>
+                    <a:lnR w="9525" cap="flat" cmpd="sng" algn="ctr">
+                      <a:solidFill>
+                        <a:srgbClr val="9AA5B8"/>
                       </a:solidFill>
                       <a:prstDash val="solid"/>
                       <a:round/>
                       <a:headEnd type="none" w="med" len="med"/>
                       <a:tailEnd type="none" w="med" len="med"/>
                     </a:lnR>
-                    <a:lnT w="19050" cap="flat" cmpd="sng" algn="ctr">
-                      <a:solidFill>
-                        <a:srgbClr val="FFFFFF"/>
+                    <a:lnT w="9525" cap="flat" cmpd="sng" algn="ctr">
+                      <a:solidFill>
+                        <a:srgbClr val="9AA5B8"/>
                       </a:solidFill>
                       <a:prstDash val="solid"/>
                       <a:round/>
                       <a:headEnd type="none" w="med" len="med"/>
                       <a:tailEnd type="none" w="med" len="med"/>
                     </a:lnT>
-                    <a:lnB w="19050" cap="flat" cmpd="sng" algn="ctr">
-                      <a:solidFill>
-                        <a:srgbClr val="FFFFFF"/>
+                    <a:lnB w="9525" cap="flat" cmpd="sng" algn="ctr">
+                      <a:solidFill>
+                        <a:srgbClr val="9AA5B8"/>
                       </a:solidFill>
                       <a:prstDash val="solid"/>
                       <a:round/>
@@ -8139,36 +8355,36 @@
                     </a:p>
                   </a:txBody>
                   <a:tcPr marL="36576" marR="36576" marT="18288" marB="18288" anchor="ctr">
-                    <a:lnL w="19050" cap="flat" cmpd="sng" algn="ctr">
-                      <a:solidFill>
-                        <a:srgbClr val="FFFFFF"/>
+                    <a:lnL w="9525" cap="flat" cmpd="sng" algn="ctr">
+                      <a:solidFill>
+                        <a:srgbClr val="9AA5B8"/>
                       </a:solidFill>
                       <a:prstDash val="solid"/>
                       <a:round/>
                       <a:headEnd type="none" w="med" len="med"/>
                       <a:tailEnd type="none" w="med" len="med"/>
                     </a:lnL>
-                    <a:lnR w="19050" cap="flat" cmpd="sng" algn="ctr">
-                      <a:solidFill>
-                        <a:srgbClr val="FFFFFF"/>
+                    <a:lnR w="9525" cap="flat" cmpd="sng" algn="ctr">
+                      <a:solidFill>
+                        <a:srgbClr val="9AA5B8"/>
                       </a:solidFill>
                       <a:prstDash val="solid"/>
                       <a:round/>
                       <a:headEnd type="none" w="med" len="med"/>
                       <a:tailEnd type="none" w="med" len="med"/>
                     </a:lnR>
-                    <a:lnT w="19050" cap="flat" cmpd="sng" algn="ctr">
-                      <a:solidFill>
-                        <a:srgbClr val="FFFFFF"/>
+                    <a:lnT w="9525" cap="flat" cmpd="sng" algn="ctr">
+                      <a:solidFill>
+                        <a:srgbClr val="9AA5B8"/>
                       </a:solidFill>
                       <a:prstDash val="solid"/>
                       <a:round/>
                       <a:headEnd type="none" w="med" len="med"/>
                       <a:tailEnd type="none" w="med" len="med"/>
                     </a:lnT>
-                    <a:lnB w="19050" cap="flat" cmpd="sng" algn="ctr">
-                      <a:solidFill>
-                        <a:srgbClr val="FFFFFF"/>
+                    <a:lnB w="9525" cap="flat" cmpd="sng" algn="ctr">
+                      <a:solidFill>
+                        <a:srgbClr val="9AA5B8"/>
                       </a:solidFill>
                       <a:prstDash val="solid"/>
                       <a:round/>
@@ -8204,36 +8420,36 @@
                     </a:p>
                   </a:txBody>
                   <a:tcPr marL="36576" marR="36576" marT="18288" marB="18288" anchor="ctr">
-                    <a:lnL w="19050" cap="flat" cmpd="sng" algn="ctr">
-                      <a:solidFill>
-                        <a:srgbClr val="FFFFFF"/>
+                    <a:lnL w="25400" cap="flat" cmpd="sng" algn="ctr">
+                      <a:solidFill>
+                        <a:srgbClr val="4A5568"/>
                       </a:solidFill>
                       <a:prstDash val="solid"/>
                       <a:round/>
                       <a:headEnd type="none" w="med" len="med"/>
                       <a:tailEnd type="none" w="med" len="med"/>
                     </a:lnL>
-                    <a:lnR w="19050" cap="flat" cmpd="sng" algn="ctr">
-                      <a:solidFill>
-                        <a:srgbClr val="FFFFFF"/>
+                    <a:lnR w="9525" cap="flat" cmpd="sng" algn="ctr">
+                      <a:solidFill>
+                        <a:srgbClr val="9AA5B8"/>
                       </a:solidFill>
                       <a:prstDash val="solid"/>
                       <a:round/>
                       <a:headEnd type="none" w="med" len="med"/>
                       <a:tailEnd type="none" w="med" len="med"/>
                     </a:lnR>
-                    <a:lnT w="19050" cap="flat" cmpd="sng" algn="ctr">
-                      <a:solidFill>
-                        <a:srgbClr val="FFFFFF"/>
+                    <a:lnT w="9525" cap="flat" cmpd="sng" algn="ctr">
+                      <a:solidFill>
+                        <a:srgbClr val="9AA5B8"/>
                       </a:solidFill>
                       <a:prstDash val="solid"/>
                       <a:round/>
                       <a:headEnd type="none" w="med" len="med"/>
                       <a:tailEnd type="none" w="med" len="med"/>
                     </a:lnT>
-                    <a:lnB w="19050" cap="flat" cmpd="sng" algn="ctr">
-                      <a:solidFill>
-                        <a:srgbClr val="FFFFFF"/>
+                    <a:lnB w="9525" cap="flat" cmpd="sng" algn="ctr">
+                      <a:solidFill>
+                        <a:srgbClr val="9AA5B8"/>
                       </a:solidFill>
                       <a:prstDash val="solid"/>
                       <a:round/>
@@ -8272,36 +8488,36 @@
                     </a:p>
                   </a:txBody>
                   <a:tcPr marL="36576" marR="36576" marT="18288" marB="18288" anchor="ctr">
-                    <a:lnL w="19050" cap="flat" cmpd="sng" algn="ctr">
-                      <a:solidFill>
-                        <a:srgbClr val="FFFFFF"/>
+                    <a:lnL w="9525" cap="flat" cmpd="sng" algn="ctr">
+                      <a:solidFill>
+                        <a:srgbClr val="9AA5B8"/>
                       </a:solidFill>
                       <a:prstDash val="solid"/>
                       <a:round/>
                       <a:headEnd type="none" w="med" len="med"/>
                       <a:tailEnd type="none" w="med" len="med"/>
                     </a:lnL>
-                    <a:lnR w="19050" cap="flat" cmpd="sng" algn="ctr">
-                      <a:solidFill>
-                        <a:srgbClr val="FFFFFF"/>
+                    <a:lnR w="9525" cap="flat" cmpd="sng" algn="ctr">
+                      <a:solidFill>
+                        <a:srgbClr val="9AA5B8"/>
                       </a:solidFill>
                       <a:prstDash val="solid"/>
                       <a:round/>
                       <a:headEnd type="none" w="med" len="med"/>
                       <a:tailEnd type="none" w="med" len="med"/>
                     </a:lnR>
-                    <a:lnT w="19050" cap="flat" cmpd="sng" algn="ctr">
-                      <a:solidFill>
-                        <a:srgbClr val="FFFFFF"/>
+                    <a:lnT w="9525" cap="flat" cmpd="sng" algn="ctr">
+                      <a:solidFill>
+                        <a:srgbClr val="9AA5B8"/>
                       </a:solidFill>
                       <a:prstDash val="solid"/>
                       <a:round/>
                       <a:headEnd type="none" w="med" len="med"/>
                       <a:tailEnd type="none" w="med" len="med"/>
                     </a:lnT>
-                    <a:lnB w="19050" cap="flat" cmpd="sng" algn="ctr">
-                      <a:solidFill>
-                        <a:srgbClr val="FFFFFF"/>
+                    <a:lnB w="9525" cap="flat" cmpd="sng" algn="ctr">
+                      <a:solidFill>
+                        <a:srgbClr val="9AA5B8"/>
                       </a:solidFill>
                       <a:prstDash val="solid"/>
                       <a:round/>
@@ -8340,36 +8556,36 @@
                     </a:p>
                   </a:txBody>
                   <a:tcPr marL="36576" marR="36576" marT="18288" marB="18288" anchor="ctr">
-                    <a:lnL w="19050" cap="flat" cmpd="sng" algn="ctr">
-                      <a:solidFill>
-                        <a:srgbClr val="FFFFFF"/>
+                    <a:lnL w="25400" cap="flat" cmpd="sng" algn="ctr">
+                      <a:solidFill>
+                        <a:srgbClr val="4A5568"/>
                       </a:solidFill>
                       <a:prstDash val="solid"/>
                       <a:round/>
                       <a:headEnd type="none" w="med" len="med"/>
                       <a:tailEnd type="none" w="med" len="med"/>
                     </a:lnL>
-                    <a:lnR w="19050" cap="flat" cmpd="sng" algn="ctr">
-                      <a:solidFill>
-                        <a:srgbClr val="FFFFFF"/>
+                    <a:lnR w="9525" cap="flat" cmpd="sng" algn="ctr">
+                      <a:solidFill>
+                        <a:srgbClr val="9AA5B8"/>
                       </a:solidFill>
                       <a:prstDash val="solid"/>
                       <a:round/>
                       <a:headEnd type="none" w="med" len="med"/>
                       <a:tailEnd type="none" w="med" len="med"/>
                     </a:lnR>
-                    <a:lnT w="19050" cap="flat" cmpd="sng" algn="ctr">
-                      <a:solidFill>
-                        <a:srgbClr val="FFFFFF"/>
+                    <a:lnT w="9525" cap="flat" cmpd="sng" algn="ctr">
+                      <a:solidFill>
+                        <a:srgbClr val="9AA5B8"/>
                       </a:solidFill>
                       <a:prstDash val="solid"/>
                       <a:round/>
                       <a:headEnd type="none" w="med" len="med"/>
                       <a:tailEnd type="none" w="med" len="med"/>
                     </a:lnT>
-                    <a:lnB w="19050" cap="flat" cmpd="sng" algn="ctr">
-                      <a:solidFill>
-                        <a:srgbClr val="FFFFFF"/>
+                    <a:lnB w="9525" cap="flat" cmpd="sng" algn="ctr">
+                      <a:solidFill>
+                        <a:srgbClr val="9AA5B8"/>
                       </a:solidFill>
                       <a:prstDash val="solid"/>
                       <a:round/>
@@ -8408,36 +8624,36 @@
                     </a:p>
                   </a:txBody>
                   <a:tcPr marL="36576" marR="36576" marT="18288" marB="18288" anchor="ctr">
-                    <a:lnL w="19050" cap="flat" cmpd="sng" algn="ctr">
-                      <a:solidFill>
-                        <a:srgbClr val="FFFFFF"/>
+                    <a:lnL w="9525" cap="flat" cmpd="sng" algn="ctr">
+                      <a:solidFill>
+                        <a:srgbClr val="9AA5B8"/>
                       </a:solidFill>
                       <a:prstDash val="solid"/>
                       <a:round/>
                       <a:headEnd type="none" w="med" len="med"/>
                       <a:tailEnd type="none" w="med" len="med"/>
                     </a:lnL>
-                    <a:lnR w="19050" cap="flat" cmpd="sng" algn="ctr">
-                      <a:solidFill>
-                        <a:srgbClr val="FFFFFF"/>
+                    <a:lnR w="9525" cap="flat" cmpd="sng" algn="ctr">
+                      <a:solidFill>
+                        <a:srgbClr val="9AA5B8"/>
                       </a:solidFill>
                       <a:prstDash val="solid"/>
                       <a:round/>
                       <a:headEnd type="none" w="med" len="med"/>
                       <a:tailEnd type="none" w="med" len="med"/>
                     </a:lnR>
-                    <a:lnT w="19050" cap="flat" cmpd="sng" algn="ctr">
-                      <a:solidFill>
-                        <a:srgbClr val="FFFFFF"/>
+                    <a:lnT w="9525" cap="flat" cmpd="sng" algn="ctr">
+                      <a:solidFill>
+                        <a:srgbClr val="9AA5B8"/>
                       </a:solidFill>
                       <a:prstDash val="solid"/>
                       <a:round/>
                       <a:headEnd type="none" w="med" len="med"/>
                       <a:tailEnd type="none" w="med" len="med"/>
                     </a:lnT>
-                    <a:lnB w="19050" cap="flat" cmpd="sng" algn="ctr">
-                      <a:solidFill>
-                        <a:srgbClr val="FFFFFF"/>
+                    <a:lnB w="9525" cap="flat" cmpd="sng" algn="ctr">
+                      <a:solidFill>
+                        <a:srgbClr val="9AA5B8"/>
                       </a:solidFill>
                       <a:prstDash val="solid"/>
                       <a:round/>
@@ -8478,36 +8694,36 @@
                     </a:p>
                   </a:txBody>
                   <a:tcPr marL="36576" marR="36576" marT="18288" marB="18288" anchor="ctr">
-                    <a:lnL w="19050" cap="flat" cmpd="sng" algn="ctr">
-                      <a:solidFill>
-                        <a:srgbClr val="FFFFFF"/>
+                    <a:lnL w="9525" cap="flat" cmpd="sng" algn="ctr">
+                      <a:solidFill>
+                        <a:srgbClr val="9AA5B8"/>
                       </a:solidFill>
                       <a:prstDash val="solid"/>
                       <a:round/>
                       <a:headEnd type="none" w="med" len="med"/>
                       <a:tailEnd type="none" w="med" len="med"/>
                     </a:lnL>
-                    <a:lnR w="19050" cap="flat" cmpd="sng" algn="ctr">
-                      <a:solidFill>
-                        <a:srgbClr val="FFFFFF"/>
+                    <a:lnR w="9525" cap="flat" cmpd="sng" algn="ctr">
+                      <a:solidFill>
+                        <a:srgbClr val="9AA5B8"/>
                       </a:solidFill>
                       <a:prstDash val="solid"/>
                       <a:round/>
                       <a:headEnd type="none" w="med" len="med"/>
                       <a:tailEnd type="none" w="med" len="med"/>
                     </a:lnR>
-                    <a:lnT w="19050" cap="flat" cmpd="sng" algn="ctr">
-                      <a:solidFill>
-                        <a:srgbClr val="FFFFFF"/>
+                    <a:lnT w="9525" cap="flat" cmpd="sng" algn="ctr">
+                      <a:solidFill>
+                        <a:srgbClr val="9AA5B8"/>
                       </a:solidFill>
                       <a:prstDash val="solid"/>
                       <a:round/>
                       <a:headEnd type="none" w="med" len="med"/>
                       <a:tailEnd type="none" w="med" len="med"/>
                     </a:lnT>
-                    <a:lnB w="19050" cap="flat" cmpd="sng" algn="ctr">
-                      <a:solidFill>
-                        <a:srgbClr val="FFFFFF"/>
+                    <a:lnB w="9525" cap="flat" cmpd="sng" algn="ctr">
+                      <a:solidFill>
+                        <a:srgbClr val="9AA5B8"/>
                       </a:solidFill>
                       <a:prstDash val="solid"/>
                       <a:round/>
@@ -8543,36 +8759,36 @@
                     </a:p>
                   </a:txBody>
                   <a:tcPr marL="36576" marR="36576" marT="18288" marB="18288" anchor="ctr">
-                    <a:lnL w="19050" cap="flat" cmpd="sng" algn="ctr">
-                      <a:solidFill>
-                        <a:srgbClr val="FFFFFF"/>
+                    <a:lnL w="9525" cap="flat" cmpd="sng" algn="ctr">
+                      <a:solidFill>
+                        <a:srgbClr val="9AA5B8"/>
                       </a:solidFill>
                       <a:prstDash val="solid"/>
                       <a:round/>
                       <a:headEnd type="none" w="med" len="med"/>
                       <a:tailEnd type="none" w="med" len="med"/>
                     </a:lnL>
-                    <a:lnR w="19050" cap="flat" cmpd="sng" algn="ctr">
-                      <a:solidFill>
-                        <a:srgbClr val="FFFFFF"/>
+                    <a:lnR w="9525" cap="flat" cmpd="sng" algn="ctr">
+                      <a:solidFill>
+                        <a:srgbClr val="9AA5B8"/>
                       </a:solidFill>
                       <a:prstDash val="solid"/>
                       <a:round/>
                       <a:headEnd type="none" w="med" len="med"/>
                       <a:tailEnd type="none" w="med" len="med"/>
                     </a:lnR>
-                    <a:lnT w="19050" cap="flat" cmpd="sng" algn="ctr">
-                      <a:solidFill>
-                        <a:srgbClr val="FFFFFF"/>
+                    <a:lnT w="9525" cap="flat" cmpd="sng" algn="ctr">
+                      <a:solidFill>
+                        <a:srgbClr val="9AA5B8"/>
                       </a:solidFill>
                       <a:prstDash val="solid"/>
                       <a:round/>
                       <a:headEnd type="none" w="med" len="med"/>
                       <a:tailEnd type="none" w="med" len="med"/>
                     </a:lnT>
-                    <a:lnB w="19050" cap="flat" cmpd="sng" algn="ctr">
-                      <a:solidFill>
-                        <a:srgbClr val="FFFFFF"/>
+                    <a:lnB w="9525" cap="flat" cmpd="sng" algn="ctr">
+                      <a:solidFill>
+                        <a:srgbClr val="9AA5B8"/>
                       </a:solidFill>
                       <a:prstDash val="solid"/>
                       <a:round/>
@@ -8608,36 +8824,36 @@
                     </a:p>
                   </a:txBody>
                   <a:tcPr marL="36576" marR="36576" marT="18288" marB="18288" anchor="ctr">
-                    <a:lnL w="19050" cap="flat" cmpd="sng" algn="ctr">
-                      <a:solidFill>
-                        <a:srgbClr val="FFFFFF"/>
+                    <a:lnL w="9525" cap="flat" cmpd="sng" algn="ctr">
+                      <a:solidFill>
+                        <a:srgbClr val="9AA5B8"/>
                       </a:solidFill>
                       <a:prstDash val="solid"/>
                       <a:round/>
                       <a:headEnd type="none" w="med" len="med"/>
                       <a:tailEnd type="none" w="med" len="med"/>
                     </a:lnL>
-                    <a:lnR w="19050" cap="flat" cmpd="sng" algn="ctr">
-                      <a:solidFill>
-                        <a:srgbClr val="FFFFFF"/>
+                    <a:lnR w="9525" cap="flat" cmpd="sng" algn="ctr">
+                      <a:solidFill>
+                        <a:srgbClr val="9AA5B8"/>
                       </a:solidFill>
                       <a:prstDash val="solid"/>
                       <a:round/>
                       <a:headEnd type="none" w="med" len="med"/>
                       <a:tailEnd type="none" w="med" len="med"/>
                     </a:lnR>
-                    <a:lnT w="19050" cap="flat" cmpd="sng" algn="ctr">
-                      <a:solidFill>
-                        <a:srgbClr val="FFFFFF"/>
+                    <a:lnT w="9525" cap="flat" cmpd="sng" algn="ctr">
+                      <a:solidFill>
+                        <a:srgbClr val="9AA5B8"/>
                       </a:solidFill>
                       <a:prstDash val="solid"/>
                       <a:round/>
                       <a:headEnd type="none" w="med" len="med"/>
                       <a:tailEnd type="none" w="med" len="med"/>
                     </a:lnT>
-                    <a:lnB w="19050" cap="flat" cmpd="sng" algn="ctr">
-                      <a:solidFill>
-                        <a:srgbClr val="FFFFFF"/>
+                    <a:lnB w="9525" cap="flat" cmpd="sng" algn="ctr">
+                      <a:solidFill>
+                        <a:srgbClr val="9AA5B8"/>
                       </a:solidFill>
                       <a:prstDash val="solid"/>
                       <a:round/>
@@ -8673,36 +8889,36 @@
                     </a:p>
                   </a:txBody>
                   <a:tcPr marL="36576" marR="36576" marT="18288" marB="18288" anchor="ctr">
-                    <a:lnL w="19050" cap="flat" cmpd="sng" algn="ctr">
-                      <a:solidFill>
-                        <a:srgbClr val="FFFFFF"/>
+                    <a:lnL w="25400" cap="flat" cmpd="sng" algn="ctr">
+                      <a:solidFill>
+                        <a:srgbClr val="4A5568"/>
                       </a:solidFill>
                       <a:prstDash val="solid"/>
                       <a:round/>
                       <a:headEnd type="none" w="med" len="med"/>
                       <a:tailEnd type="none" w="med" len="med"/>
                     </a:lnL>
-                    <a:lnR w="19050" cap="flat" cmpd="sng" algn="ctr">
-                      <a:solidFill>
-                        <a:srgbClr val="FFFFFF"/>
+                    <a:lnR w="9525" cap="flat" cmpd="sng" algn="ctr">
+                      <a:solidFill>
+                        <a:srgbClr val="9AA5B8"/>
                       </a:solidFill>
                       <a:prstDash val="solid"/>
                       <a:round/>
                       <a:headEnd type="none" w="med" len="med"/>
                       <a:tailEnd type="none" w="med" len="med"/>
                     </a:lnR>
-                    <a:lnT w="19050" cap="flat" cmpd="sng" algn="ctr">
-                      <a:solidFill>
-                        <a:srgbClr val="FFFFFF"/>
+                    <a:lnT w="9525" cap="flat" cmpd="sng" algn="ctr">
+                      <a:solidFill>
+                        <a:srgbClr val="9AA5B8"/>
                       </a:solidFill>
                       <a:prstDash val="solid"/>
                       <a:round/>
                       <a:headEnd type="none" w="med" len="med"/>
                       <a:tailEnd type="none" w="med" len="med"/>
                     </a:lnT>
-                    <a:lnB w="19050" cap="flat" cmpd="sng" algn="ctr">
-                      <a:solidFill>
-                        <a:srgbClr val="FFFFFF"/>
+                    <a:lnB w="9525" cap="flat" cmpd="sng" algn="ctr">
+                      <a:solidFill>
+                        <a:srgbClr val="9AA5B8"/>
                       </a:solidFill>
                       <a:prstDash val="solid"/>
                       <a:round/>
@@ -8741,36 +8957,36 @@
                     </a:p>
                   </a:txBody>
                   <a:tcPr marL="36576" marR="36576" marT="18288" marB="18288" anchor="ctr">
-                    <a:lnL w="19050" cap="flat" cmpd="sng" algn="ctr">
-                      <a:solidFill>
-                        <a:srgbClr val="FFFFFF"/>
+                    <a:lnL w="9525" cap="flat" cmpd="sng" algn="ctr">
+                      <a:solidFill>
+                        <a:srgbClr val="9AA5B8"/>
                       </a:solidFill>
                       <a:prstDash val="solid"/>
                       <a:round/>
                       <a:headEnd type="none" w="med" len="med"/>
                       <a:tailEnd type="none" w="med" len="med"/>
                     </a:lnL>
-                    <a:lnR w="19050" cap="flat" cmpd="sng" algn="ctr">
-                      <a:solidFill>
-                        <a:srgbClr val="FFFFFF"/>
+                    <a:lnR w="9525" cap="flat" cmpd="sng" algn="ctr">
+                      <a:solidFill>
+                        <a:srgbClr val="9AA5B8"/>
                       </a:solidFill>
                       <a:prstDash val="solid"/>
                       <a:round/>
                       <a:headEnd type="none" w="med" len="med"/>
                       <a:tailEnd type="none" w="med" len="med"/>
                     </a:lnR>
-                    <a:lnT w="19050" cap="flat" cmpd="sng" algn="ctr">
-                      <a:solidFill>
-                        <a:srgbClr val="FFFFFF"/>
+                    <a:lnT w="9525" cap="flat" cmpd="sng" algn="ctr">
+                      <a:solidFill>
+                        <a:srgbClr val="9AA5B8"/>
                       </a:solidFill>
                       <a:prstDash val="solid"/>
                       <a:round/>
                       <a:headEnd type="none" w="med" len="med"/>
                       <a:tailEnd type="none" w="med" len="med"/>
                     </a:lnT>
-                    <a:lnB w="19050" cap="flat" cmpd="sng" algn="ctr">
-                      <a:solidFill>
-                        <a:srgbClr val="FFFFFF"/>
+                    <a:lnB w="9525" cap="flat" cmpd="sng" algn="ctr">
+                      <a:solidFill>
+                        <a:srgbClr val="9AA5B8"/>
                       </a:solidFill>
                       <a:prstDash val="solid"/>
                       <a:round/>
@@ -8809,36 +9025,36 @@
                     </a:p>
                   </a:txBody>
                   <a:tcPr marL="36576" marR="36576" marT="18288" marB="18288" anchor="ctr">
-                    <a:lnL w="19050" cap="flat" cmpd="sng" algn="ctr">
-                      <a:solidFill>
-                        <a:srgbClr val="FFFFFF"/>
+                    <a:lnL w="25400" cap="flat" cmpd="sng" algn="ctr">
+                      <a:solidFill>
+                        <a:srgbClr val="4A5568"/>
                       </a:solidFill>
                       <a:prstDash val="solid"/>
                       <a:round/>
                       <a:headEnd type="none" w="med" len="med"/>
                       <a:tailEnd type="none" w="med" len="med"/>
                     </a:lnL>
-                    <a:lnR w="19050" cap="flat" cmpd="sng" algn="ctr">
-                      <a:solidFill>
-                        <a:srgbClr val="FFFFFF"/>
+                    <a:lnR w="9525" cap="flat" cmpd="sng" algn="ctr">
+                      <a:solidFill>
+                        <a:srgbClr val="9AA5B8"/>
                       </a:solidFill>
                       <a:prstDash val="solid"/>
                       <a:round/>
                       <a:headEnd type="none" w="med" len="med"/>
                       <a:tailEnd type="none" w="med" len="med"/>
                     </a:lnR>
-                    <a:lnT w="19050" cap="flat" cmpd="sng" algn="ctr">
-                      <a:solidFill>
-                        <a:srgbClr val="FFFFFF"/>
+                    <a:lnT w="9525" cap="flat" cmpd="sng" algn="ctr">
+                      <a:solidFill>
+                        <a:srgbClr val="9AA5B8"/>
                       </a:solidFill>
                       <a:prstDash val="solid"/>
                       <a:round/>
                       <a:headEnd type="none" w="med" len="med"/>
                       <a:tailEnd type="none" w="med" len="med"/>
                     </a:lnT>
-                    <a:lnB w="19050" cap="flat" cmpd="sng" algn="ctr">
-                      <a:solidFill>
-                        <a:srgbClr val="FFFFFF"/>
+                    <a:lnB w="9525" cap="flat" cmpd="sng" algn="ctr">
+                      <a:solidFill>
+                        <a:srgbClr val="9AA5B8"/>
                       </a:solidFill>
                       <a:prstDash val="solid"/>
                       <a:round/>
@@ -8877,36 +9093,36 @@
                     </a:p>
                   </a:txBody>
                   <a:tcPr marL="36576" marR="36576" marT="18288" marB="18288" anchor="ctr">
-                    <a:lnL w="19050" cap="flat" cmpd="sng" algn="ctr">
-                      <a:solidFill>
-                        <a:srgbClr val="FFFFFF"/>
+                    <a:lnL w="9525" cap="flat" cmpd="sng" algn="ctr">
+                      <a:solidFill>
+                        <a:srgbClr val="9AA5B8"/>
                       </a:solidFill>
                       <a:prstDash val="solid"/>
                       <a:round/>
                       <a:headEnd type="none" w="med" len="med"/>
                       <a:tailEnd type="none" w="med" len="med"/>
                     </a:lnL>
-                    <a:lnR w="19050" cap="flat" cmpd="sng" algn="ctr">
-                      <a:solidFill>
-                        <a:srgbClr val="FFFFFF"/>
+                    <a:lnR w="9525" cap="flat" cmpd="sng" algn="ctr">
+                      <a:solidFill>
+                        <a:srgbClr val="9AA5B8"/>
                       </a:solidFill>
                       <a:prstDash val="solid"/>
                       <a:round/>
                       <a:headEnd type="none" w="med" len="med"/>
                       <a:tailEnd type="none" w="med" len="med"/>
                     </a:lnR>
-                    <a:lnT w="19050" cap="flat" cmpd="sng" algn="ctr">
-                      <a:solidFill>
-                        <a:srgbClr val="FFFFFF"/>
+                    <a:lnT w="9525" cap="flat" cmpd="sng" algn="ctr">
+                      <a:solidFill>
+                        <a:srgbClr val="9AA5B8"/>
                       </a:solidFill>
                       <a:prstDash val="solid"/>
                       <a:round/>
                       <a:headEnd type="none" w="med" len="med"/>
                       <a:tailEnd type="none" w="med" len="med"/>
                     </a:lnT>
-                    <a:lnB w="19050" cap="flat" cmpd="sng" algn="ctr">
-                      <a:solidFill>
-                        <a:srgbClr val="FFFFFF"/>
+                    <a:lnB w="9525" cap="flat" cmpd="sng" algn="ctr">
+                      <a:solidFill>
+                        <a:srgbClr val="9AA5B8"/>
                       </a:solidFill>
                       <a:prstDash val="solid"/>
                       <a:round/>
@@ -8947,36 +9163,36 @@
                     </a:p>
                   </a:txBody>
                   <a:tcPr marL="36576" marR="36576" marT="18288" marB="18288" anchor="ctr">
-                    <a:lnL w="19050" cap="flat" cmpd="sng" algn="ctr">
-                      <a:solidFill>
-                        <a:srgbClr val="FFFFFF"/>
+                    <a:lnL w="9525" cap="flat" cmpd="sng" algn="ctr">
+                      <a:solidFill>
+                        <a:srgbClr val="9AA5B8"/>
                       </a:solidFill>
                       <a:prstDash val="solid"/>
                       <a:round/>
                       <a:headEnd type="none" w="med" len="med"/>
                       <a:tailEnd type="none" w="med" len="med"/>
                     </a:lnL>
-                    <a:lnR w="19050" cap="flat" cmpd="sng" algn="ctr">
-                      <a:solidFill>
-                        <a:srgbClr val="FFFFFF"/>
+                    <a:lnR w="9525" cap="flat" cmpd="sng" algn="ctr">
+                      <a:solidFill>
+                        <a:srgbClr val="9AA5B8"/>
                       </a:solidFill>
                       <a:prstDash val="solid"/>
                       <a:round/>
                       <a:headEnd type="none" w="med" len="med"/>
                       <a:tailEnd type="none" w="med" len="med"/>
                     </a:lnR>
-                    <a:lnT w="19050" cap="flat" cmpd="sng" algn="ctr">
-                      <a:solidFill>
-                        <a:srgbClr val="FFFFFF"/>
+                    <a:lnT w="9525" cap="flat" cmpd="sng" algn="ctr">
+                      <a:solidFill>
+                        <a:srgbClr val="9AA5B8"/>
                       </a:solidFill>
                       <a:prstDash val="solid"/>
                       <a:round/>
                       <a:headEnd type="none" w="med" len="med"/>
                       <a:tailEnd type="none" w="med" len="med"/>
                     </a:lnT>
-                    <a:lnB w="19050" cap="flat" cmpd="sng" algn="ctr">
-                      <a:solidFill>
-                        <a:srgbClr val="FFFFFF"/>
+                    <a:lnB w="9525" cap="flat" cmpd="sng" algn="ctr">
+                      <a:solidFill>
+                        <a:srgbClr val="9AA5B8"/>
                       </a:solidFill>
                       <a:prstDash val="solid"/>
                       <a:round/>
@@ -9012,36 +9228,36 @@
                     </a:p>
                   </a:txBody>
                   <a:tcPr marL="36576" marR="36576" marT="18288" marB="18288" anchor="ctr">
-                    <a:lnL w="19050" cap="flat" cmpd="sng" algn="ctr">
-                      <a:solidFill>
-                        <a:srgbClr val="FFFFFF"/>
+                    <a:lnL w="9525" cap="flat" cmpd="sng" algn="ctr">
+                      <a:solidFill>
+                        <a:srgbClr val="9AA5B8"/>
                       </a:solidFill>
                       <a:prstDash val="solid"/>
                       <a:round/>
                       <a:headEnd type="none" w="med" len="med"/>
                       <a:tailEnd type="none" w="med" len="med"/>
                     </a:lnL>
-                    <a:lnR w="19050" cap="flat" cmpd="sng" algn="ctr">
-                      <a:solidFill>
-                        <a:srgbClr val="FFFFFF"/>
+                    <a:lnR w="9525" cap="flat" cmpd="sng" algn="ctr">
+                      <a:solidFill>
+                        <a:srgbClr val="9AA5B8"/>
                       </a:solidFill>
                       <a:prstDash val="solid"/>
                       <a:round/>
                       <a:headEnd type="none" w="med" len="med"/>
                       <a:tailEnd type="none" w="med" len="med"/>
                     </a:lnR>
-                    <a:lnT w="19050" cap="flat" cmpd="sng" algn="ctr">
-                      <a:solidFill>
-                        <a:srgbClr val="FFFFFF"/>
+                    <a:lnT w="9525" cap="flat" cmpd="sng" algn="ctr">
+                      <a:solidFill>
+                        <a:srgbClr val="9AA5B8"/>
                       </a:solidFill>
                       <a:prstDash val="solid"/>
                       <a:round/>
                       <a:headEnd type="none" w="med" len="med"/>
                       <a:tailEnd type="none" w="med" len="med"/>
                     </a:lnT>
-                    <a:lnB w="19050" cap="flat" cmpd="sng" algn="ctr">
-                      <a:solidFill>
-                        <a:srgbClr val="FFFFFF"/>
+                    <a:lnB w="9525" cap="flat" cmpd="sng" algn="ctr">
+                      <a:solidFill>
+                        <a:srgbClr val="9AA5B8"/>
                       </a:solidFill>
                       <a:prstDash val="solid"/>
                       <a:round/>
@@ -9077,36 +9293,36 @@
                     </a:p>
                   </a:txBody>
                   <a:tcPr marL="36576" marR="36576" marT="18288" marB="18288" anchor="ctr">
-                    <a:lnL w="19050" cap="flat" cmpd="sng" algn="ctr">
-                      <a:solidFill>
-                        <a:srgbClr val="FFFFFF"/>
+                    <a:lnL w="9525" cap="flat" cmpd="sng" algn="ctr">
+                      <a:solidFill>
+                        <a:srgbClr val="9AA5B8"/>
                       </a:solidFill>
                       <a:prstDash val="solid"/>
                       <a:round/>
                       <a:headEnd type="none" w="med" len="med"/>
                       <a:tailEnd type="none" w="med" len="med"/>
                     </a:lnL>
-                    <a:lnR w="19050" cap="flat" cmpd="sng" algn="ctr">
-                      <a:solidFill>
-                        <a:srgbClr val="FFFFFF"/>
+                    <a:lnR w="9525" cap="flat" cmpd="sng" algn="ctr">
+                      <a:solidFill>
+                        <a:srgbClr val="9AA5B8"/>
                       </a:solidFill>
                       <a:prstDash val="solid"/>
                       <a:round/>
                       <a:headEnd type="none" w="med" len="med"/>
                       <a:tailEnd type="none" w="med" len="med"/>
                     </a:lnR>
-                    <a:lnT w="19050" cap="flat" cmpd="sng" algn="ctr">
-                      <a:solidFill>
-                        <a:srgbClr val="FFFFFF"/>
+                    <a:lnT w="9525" cap="flat" cmpd="sng" algn="ctr">
+                      <a:solidFill>
+                        <a:srgbClr val="9AA5B8"/>
                       </a:solidFill>
                       <a:prstDash val="solid"/>
                       <a:round/>
                       <a:headEnd type="none" w="med" len="med"/>
                       <a:tailEnd type="none" w="med" len="med"/>
                     </a:lnT>
-                    <a:lnB w="19050" cap="flat" cmpd="sng" algn="ctr">
-                      <a:solidFill>
-                        <a:srgbClr val="FFFFFF"/>
+                    <a:lnB w="9525" cap="flat" cmpd="sng" algn="ctr">
+                      <a:solidFill>
+                        <a:srgbClr val="9AA5B8"/>
                       </a:solidFill>
                       <a:prstDash val="solid"/>
                       <a:round/>
@@ -9142,36 +9358,36 @@
                     </a:p>
                   </a:txBody>
                   <a:tcPr marL="36576" marR="36576" marT="18288" marB="18288" anchor="ctr">
-                    <a:lnL w="19050" cap="flat" cmpd="sng" algn="ctr">
-                      <a:solidFill>
-                        <a:srgbClr val="FFFFFF"/>
+                    <a:lnL w="25400" cap="flat" cmpd="sng" algn="ctr">
+                      <a:solidFill>
+                        <a:srgbClr val="4A5568"/>
                       </a:solidFill>
                       <a:prstDash val="solid"/>
                       <a:round/>
                       <a:headEnd type="none" w="med" len="med"/>
                       <a:tailEnd type="none" w="med" len="med"/>
                     </a:lnL>
-                    <a:lnR w="19050" cap="flat" cmpd="sng" algn="ctr">
-                      <a:solidFill>
-                        <a:srgbClr val="FFFFFF"/>
+                    <a:lnR w="9525" cap="flat" cmpd="sng" algn="ctr">
+                      <a:solidFill>
+                        <a:srgbClr val="9AA5B8"/>
                       </a:solidFill>
                       <a:prstDash val="solid"/>
                       <a:round/>
                       <a:headEnd type="none" w="med" len="med"/>
                       <a:tailEnd type="none" w="med" len="med"/>
                     </a:lnR>
-                    <a:lnT w="19050" cap="flat" cmpd="sng" algn="ctr">
-                      <a:solidFill>
-                        <a:srgbClr val="FFFFFF"/>
+                    <a:lnT w="9525" cap="flat" cmpd="sng" algn="ctr">
+                      <a:solidFill>
+                        <a:srgbClr val="9AA5B8"/>
                       </a:solidFill>
                       <a:prstDash val="solid"/>
                       <a:round/>
                       <a:headEnd type="none" w="med" len="med"/>
                       <a:tailEnd type="none" w="med" len="med"/>
                     </a:lnT>
-                    <a:lnB w="19050" cap="flat" cmpd="sng" algn="ctr">
-                      <a:solidFill>
-                        <a:srgbClr val="FFFFFF"/>
+                    <a:lnB w="9525" cap="flat" cmpd="sng" algn="ctr">
+                      <a:solidFill>
+                        <a:srgbClr val="9AA5B8"/>
                       </a:solidFill>
                       <a:prstDash val="solid"/>
                       <a:round/>
@@ -9210,36 +9426,36 @@
                     </a:p>
                   </a:txBody>
                   <a:tcPr marL="36576" marR="36576" marT="18288" marB="18288" anchor="ctr">
-                    <a:lnL w="19050" cap="flat" cmpd="sng" algn="ctr">
-                      <a:solidFill>
-                        <a:srgbClr val="FFFFFF"/>
+                    <a:lnL w="9525" cap="flat" cmpd="sng" algn="ctr">
+                      <a:solidFill>
+                        <a:srgbClr val="9AA5B8"/>
                       </a:solidFill>
                       <a:prstDash val="solid"/>
                       <a:round/>
                       <a:headEnd type="none" w="med" len="med"/>
                       <a:tailEnd type="none" w="med" len="med"/>
                     </a:lnL>
-                    <a:lnR w="19050" cap="flat" cmpd="sng" algn="ctr">
-                      <a:solidFill>
-                        <a:srgbClr val="FFFFFF"/>
+                    <a:lnR w="9525" cap="flat" cmpd="sng" algn="ctr">
+                      <a:solidFill>
+                        <a:srgbClr val="9AA5B8"/>
                       </a:solidFill>
                       <a:prstDash val="solid"/>
                       <a:round/>
                       <a:headEnd type="none" w="med" len="med"/>
                       <a:tailEnd type="none" w="med" len="med"/>
                     </a:lnR>
-                    <a:lnT w="19050" cap="flat" cmpd="sng" algn="ctr">
-                      <a:solidFill>
-                        <a:srgbClr val="FFFFFF"/>
+                    <a:lnT w="9525" cap="flat" cmpd="sng" algn="ctr">
+                      <a:solidFill>
+                        <a:srgbClr val="9AA5B8"/>
                       </a:solidFill>
                       <a:prstDash val="solid"/>
                       <a:round/>
                       <a:headEnd type="none" w="med" len="med"/>
                       <a:tailEnd type="none" w="med" len="med"/>
                     </a:lnT>
-                    <a:lnB w="19050" cap="flat" cmpd="sng" algn="ctr">
-                      <a:solidFill>
-                        <a:srgbClr val="FFFFFF"/>
+                    <a:lnB w="9525" cap="flat" cmpd="sng" algn="ctr">
+                      <a:solidFill>
+                        <a:srgbClr val="9AA5B8"/>
                       </a:solidFill>
                       <a:prstDash val="solid"/>
                       <a:round/>
@@ -9278,36 +9494,36 @@
                     </a:p>
                   </a:txBody>
                   <a:tcPr marL="36576" marR="36576" marT="18288" marB="18288" anchor="ctr">
-                    <a:lnL w="19050" cap="flat" cmpd="sng" algn="ctr">
-                      <a:solidFill>
-                        <a:srgbClr val="FFFFFF"/>
+                    <a:lnL w="25400" cap="flat" cmpd="sng" algn="ctr">
+                      <a:solidFill>
+                        <a:srgbClr val="4A5568"/>
                       </a:solidFill>
                       <a:prstDash val="solid"/>
                       <a:round/>
                       <a:headEnd type="none" w="med" len="med"/>
                       <a:tailEnd type="none" w="med" len="med"/>
                     </a:lnL>
-                    <a:lnR w="19050" cap="flat" cmpd="sng" algn="ctr">
-                      <a:solidFill>
-                        <a:srgbClr val="FFFFFF"/>
+                    <a:lnR w="9525" cap="flat" cmpd="sng" algn="ctr">
+                      <a:solidFill>
+                        <a:srgbClr val="9AA5B8"/>
                       </a:solidFill>
                       <a:prstDash val="solid"/>
                       <a:round/>
                       <a:headEnd type="none" w="med" len="med"/>
                       <a:tailEnd type="none" w="med" len="med"/>
                     </a:lnR>
-                    <a:lnT w="19050" cap="flat" cmpd="sng" algn="ctr">
-                      <a:solidFill>
-                        <a:srgbClr val="FFFFFF"/>
+                    <a:lnT w="9525" cap="flat" cmpd="sng" algn="ctr">
+                      <a:solidFill>
+                        <a:srgbClr val="9AA5B8"/>
                       </a:solidFill>
                       <a:prstDash val="solid"/>
                       <a:round/>
                       <a:headEnd type="none" w="med" len="med"/>
                       <a:tailEnd type="none" w="med" len="med"/>
                     </a:lnT>
-                    <a:lnB w="19050" cap="flat" cmpd="sng" algn="ctr">
-                      <a:solidFill>
-                        <a:srgbClr val="FFFFFF"/>
+                    <a:lnB w="9525" cap="flat" cmpd="sng" algn="ctr">
+                      <a:solidFill>
+                        <a:srgbClr val="9AA5B8"/>
                       </a:solidFill>
                       <a:prstDash val="solid"/>
                       <a:round/>
@@ -9346,36 +9562,36 @@
                     </a:p>
                   </a:txBody>
                   <a:tcPr marL="36576" marR="36576" marT="18288" marB="18288" anchor="ctr">
-                    <a:lnL w="19050" cap="flat" cmpd="sng" algn="ctr">
-                      <a:solidFill>
-                        <a:srgbClr val="FFFFFF"/>
+                    <a:lnL w="9525" cap="flat" cmpd="sng" algn="ctr">
+                      <a:solidFill>
+                        <a:srgbClr val="9AA5B8"/>
                       </a:solidFill>
                       <a:prstDash val="solid"/>
                       <a:round/>
                       <a:headEnd type="none" w="med" len="med"/>
                       <a:tailEnd type="none" w="med" len="med"/>
                     </a:lnL>
-                    <a:lnR w="19050" cap="flat" cmpd="sng" algn="ctr">
-                      <a:solidFill>
-                        <a:srgbClr val="FFFFFF"/>
+                    <a:lnR w="9525" cap="flat" cmpd="sng" algn="ctr">
+                      <a:solidFill>
+                        <a:srgbClr val="9AA5B8"/>
                       </a:solidFill>
                       <a:prstDash val="solid"/>
                       <a:round/>
                       <a:headEnd type="none" w="med" len="med"/>
                       <a:tailEnd type="none" w="med" len="med"/>
                     </a:lnR>
-                    <a:lnT w="19050" cap="flat" cmpd="sng" algn="ctr">
-                      <a:solidFill>
-                        <a:srgbClr val="FFFFFF"/>
+                    <a:lnT w="9525" cap="flat" cmpd="sng" algn="ctr">
+                      <a:solidFill>
+                        <a:srgbClr val="9AA5B8"/>
                       </a:solidFill>
                       <a:prstDash val="solid"/>
                       <a:round/>
                       <a:headEnd type="none" w="med" len="med"/>
                       <a:tailEnd type="none" w="med" len="med"/>
                     </a:lnT>
-                    <a:lnB w="19050" cap="flat" cmpd="sng" algn="ctr">
-                      <a:solidFill>
-                        <a:srgbClr val="FFFFFF"/>
+                    <a:lnB w="9525" cap="flat" cmpd="sng" algn="ctr">
+                      <a:solidFill>
+                        <a:srgbClr val="9AA5B8"/>
                       </a:solidFill>
                       <a:prstDash val="solid"/>
                       <a:round/>
@@ -9749,38 +9965,6 @@
                 <a:ea typeface="Calibri" pitchFamily="34" charset="-122"/>
                 <a:cs typeface="Calibri" pitchFamily="34" charset="-120"/>
               </a:rPr>
-              <a:t>Within the tolerance from: </a:t>
-            </a:r>
-            <a:r>
-              <a:rPr lang="en-US" sz="1400" b="1" dirty="0">
-                <a:solidFill>
-                  <a:srgbClr val="1F2A44"/>
-                </a:solidFill>
-                <a:latin typeface="Calibri" pitchFamily="34" charset="0"/>
-                <a:ea typeface="Calibri" pitchFamily="34" charset="-122"/>
-                <a:cs typeface="Calibri" pitchFamily="34" charset="-120"/>
-              </a:rPr>
-              <a:t>1250 Hz → 2000 Hz</a:t>
-            </a:r>
-            <a:endParaRPr lang="en-US" sz="1400" dirty="0"/>
-          </a:p>
-          <a:p>
-            <a:pPr marL="342900" indent="-342900">
-              <a:spcAft>
-                <a:spcPts val="600"/>
-              </a:spcAft>
-              <a:buSzPct val="100000"/>
-              <a:buChar char="•"/>
-            </a:pPr>
-            <a:r>
-              <a:rPr lang="en-US" sz="1400" dirty="0">
-                <a:solidFill>
-                  <a:srgbClr val="1F2A44"/>
-                </a:solidFill>
-                <a:latin typeface="Calibri" pitchFamily="34" charset="0"/>
-                <a:ea typeface="Calibri" pitchFamily="34" charset="-122"/>
-                <a:cs typeface="Calibri" pitchFamily="34" charset="-120"/>
-              </a:rPr>
               <a:t>Bands clearly over: </a:t>
             </a:r>
             <a:r>
@@ -9863,7 +10047,7 @@
                 <a:ea typeface="Calibri" pitchFamily="34" charset="-122"/>
                 <a:cs typeface="Calibri" pitchFamily="34" charset="-120"/>
               </a:rPr>
-              <a:t>ISO anechoic tolerance values used as an analogue, not a qualification of the room. Same pair as slide 4 (25 Sep); the highest band evaluated is 2500 Hz.</a:t>
+              <a:t>ISO anechoic tolerance values used as an analogue, not a qualification of the room. Same pair as slide 4 (25 Sep). The highest band evaluated is 2500 Hz.</a:t>
             </a:r>
             <a:endParaRPr lang="en-US" sz="1200" dirty="0"/>
           </a:p>

</xml_diff>

<commit_message>
Slides: slide 5 table gets the partial 5000 and 6300 Hz bands, no bullet dots on its summary lines
Co-Authored-By: Claude Sonnet 5.5 <noreply@anthropic.com>
</commit_message>
<xml_diff>
--- a/docs/analysis/chamber-final-2026-10-01/slides/chamber-slides.pptx
+++ b/docs/analysis/chamber-final-2026-10-01/slides/chamber-slides.pptx
@@ -1270,7 +1270,7 @@
           <a:p>
             <a:r>
               <a:rPr lang="en-US" dirty="0"/>
-              <a:t>Same table as page 4 of the report. Each one-third-octave band is judged against the anechoic tolerance values of ISO 5305 Table 1 (also ISO 3745 as printed by Cunefare 2003): +-1.5 dB for 125-630 Hz, +-1.0 dB for 800-5000 Hz. The number is the worst microphone band-mean deviation from the arc mean, in dB; the colour is that number as a share of the limit. Cells in limit counts tone x microphone cells inside the limit (3 tones x 11 microphones = 33 cells at 250 Hz, where the grid starts at 257 Hz). This is an analogue: the standards use a traverse and test decay with distance, we use eleven fixed microphones at one radius. The room is treated and not qualified. Within the tolerance values from 1250 Hz at the start of day 3 and from 2000 Hz in the final state, up to 2500 Hz, the highest band evaluated. Caveat: the loudspeaker position was not documented across the day.</a:t>
+              <a:t>Same table as page 4 of the report. Each one-third-octave band is judged against the anechoic tolerance values of ISO 5305 Table 1 (also ISO 3745 as printed by Cunefare 2003): +-1.5 dB for 125-630 Hz, +-1.0 dB for 800-5000 Hz. The number is the worst microphone band-mean deviation from the arc mean, in dB; the colour is that number as a share of the limit. Cells in limit counts tone x microphone cells inside the limit (3 tones x 11 microphones = 33 cells at 250 Hz, where the grid starts at 257 Hz). This is an analogue: the standards use a traverse and test decay with distance, we use eleven fixed microphones at one radius. The room is treated and not qualified. Within the tolerance values from 1250 Hz at the start of day 3 and from 2000 Hz in the final state, up to 2500 Hz. The rows marked * (5000 and 6300 Hz) are partial: 4 and 5 tones above 5 kHz, the limit is +-1.0 dB at 5000 Hz and +-1.5 dB at 6300 Hz (ISO 5305 Table 1). Both are over the limit in both states (1.24 and 1.23 dB; 1.59 and 1.77 dB). The 3150 and 4000 Hz bands are not shown: no tones between 3 and 5 kHz because of the rocking mode of the sphere at about 4.4 kHz. Caveat: the loudspeaker position was not documented across the day.</a:t>
             </a:r>
             <a:endParaRPr lang="en-US" dirty="0"/>
           </a:p>
@@ -3655,7 +3655,7 @@
                 <a:gridCol w="1280160"/>
                 <a:gridCol w="1188720"/>
               </a:tblGrid>
-              <a:tr h="347472">
+              <a:tr h="329184">
                 <a:tc>
                   <a:txBody>
                     <a:bodyPr/>
@@ -3988,7 +3988,7 @@
                   <a:tcPr/>
                 </a:tc>
               </a:tr>
-              <a:tr h="310896">
+              <a:tr h="292608">
                 <a:tc>
                   <a:txBody>
                     <a:bodyPr/>
@@ -4445,7 +4445,7 @@
                   </a:tcPr>
                 </a:tc>
               </a:tr>
-              <a:tr h="420624">
+              <a:tr h="393192">
                 <a:tc>
                   <a:txBody>
                     <a:bodyPr/>
@@ -4914,7 +4914,7 @@
                   </a:tcPr>
                 </a:tc>
               </a:tr>
-              <a:tr h="420624">
+              <a:tr h="393192">
                 <a:tc>
                   <a:txBody>
                     <a:bodyPr/>
@@ -5383,7 +5383,7 @@
                   </a:tcPr>
                 </a:tc>
               </a:tr>
-              <a:tr h="420624">
+              <a:tr h="393192">
                 <a:tc>
                   <a:txBody>
                     <a:bodyPr/>
@@ -5852,7 +5852,7 @@
                   </a:tcPr>
                 </a:tc>
               </a:tr>
-              <a:tr h="420624">
+              <a:tr h="393192">
                 <a:tc>
                   <a:txBody>
                     <a:bodyPr/>
@@ -6321,7 +6321,7 @@
                   </a:tcPr>
                 </a:tc>
               </a:tr>
-              <a:tr h="420624">
+              <a:tr h="393192">
                 <a:tc>
                   <a:txBody>
                     <a:bodyPr/>
@@ -6790,7 +6790,7 @@
                   </a:tcPr>
                 </a:tc>
               </a:tr>
-              <a:tr h="420624">
+              <a:tr h="393192">
                 <a:tc>
                   <a:txBody>
                     <a:bodyPr/>
@@ -7259,7 +7259,7 @@
                   </a:tcPr>
                 </a:tc>
               </a:tr>
-              <a:tr h="420624">
+              <a:tr h="393192">
                 <a:tc>
                   <a:txBody>
                     <a:bodyPr/>
@@ -7728,7 +7728,7 @@
                   </a:tcPr>
                 </a:tc>
               </a:tr>
-              <a:tr h="420624">
+              <a:tr h="393192">
                 <a:tc>
                   <a:txBody>
                     <a:bodyPr/>
@@ -8197,7 +8197,7 @@
                   </a:tcPr>
                 </a:tc>
               </a:tr>
-              <a:tr h="420624">
+              <a:tr h="393192">
                 <a:tc>
                   <a:txBody>
                     <a:bodyPr/>
@@ -8666,7 +8666,7 @@
                   </a:tcPr>
                 </a:tc>
               </a:tr>
-              <a:tr h="420624">
+              <a:tr h="393192">
                 <a:tc>
                   <a:txBody>
                     <a:bodyPr/>
@@ -9135,7 +9135,7 @@
                   </a:tcPr>
                 </a:tc>
               </a:tr>
-              <a:tr h="420624">
+              <a:tr h="393192">
                 <a:tc>
                   <a:txBody>
                     <a:bodyPr/>
@@ -9600,6 +9600,944 @@
                     </a:lnB>
                     <a:solidFill>
                       <a:srgbClr val="D0D374"/>
+                    </a:solidFill>
+                  </a:tcPr>
+                </a:tc>
+              </a:tr>
+              <a:tr h="393192">
+                <a:tc>
+                  <a:txBody>
+                    <a:bodyPr/>
+                    <a:lstStyle/>
+                    <a:p>
+                      <a:pPr algn="ctr" indent="0" marL="0">
+                        <a:buNone/>
+                      </a:pPr>
+                      <a:r>
+                        <a:rPr lang="en-US" sz="1400" b="1" dirty="0">
+                          <a:solidFill>
+                            <a:srgbClr val="1F2A44"/>
+                          </a:solidFill>
+                          <a:latin typeface="Calibri" pitchFamily="34" charset="0"/>
+                          <a:ea typeface="Calibri" pitchFamily="34" charset="-122"/>
+                          <a:cs typeface="Calibri" pitchFamily="34" charset="-120"/>
+                        </a:rPr>
+                        <a:t>5000*</a:t>
+                      </a:r>
+                      <a:endParaRPr lang="en-US" sz="1400" dirty="0">
+                        <a:latin typeface="Calibri" charset="0"/>
+                        <a:ea typeface="Calibri" charset="0"/>
+                        <a:cs typeface="Calibri" charset="0"/>
+                      </a:endParaRPr>
+                    </a:p>
+                  </a:txBody>
+                  <a:tcPr marL="36576" marR="36576" marT="18288" marB="18288" anchor="ctr">
+                    <a:lnL w="9525" cap="flat" cmpd="sng" algn="ctr">
+                      <a:solidFill>
+                        <a:srgbClr val="9AA5B8"/>
+                      </a:solidFill>
+                      <a:prstDash val="solid"/>
+                      <a:round/>
+                      <a:headEnd type="none" w="med" len="med"/>
+                      <a:tailEnd type="none" w="med" len="med"/>
+                    </a:lnL>
+                    <a:lnR w="9525" cap="flat" cmpd="sng" algn="ctr">
+                      <a:solidFill>
+                        <a:srgbClr val="9AA5B8"/>
+                      </a:solidFill>
+                      <a:prstDash val="solid"/>
+                      <a:round/>
+                      <a:headEnd type="none" w="med" len="med"/>
+                      <a:tailEnd type="none" w="med" len="med"/>
+                    </a:lnR>
+                    <a:lnT w="9525" cap="flat" cmpd="sng" algn="ctr">
+                      <a:solidFill>
+                        <a:srgbClr val="9AA5B8"/>
+                      </a:solidFill>
+                      <a:prstDash val="solid"/>
+                      <a:round/>
+                      <a:headEnd type="none" w="med" len="med"/>
+                      <a:tailEnd type="none" w="med" len="med"/>
+                    </a:lnT>
+                    <a:lnB w="9525" cap="flat" cmpd="sng" algn="ctr">
+                      <a:solidFill>
+                        <a:srgbClr val="9AA5B8"/>
+                      </a:solidFill>
+                      <a:prstDash val="solid"/>
+                      <a:round/>
+                      <a:headEnd type="none" w="med" len="med"/>
+                      <a:tailEnd type="none" w="med" len="med"/>
+                    </a:lnB>
+                  </a:tcPr>
+                </a:tc>
+                <a:tc>
+                  <a:txBody>
+                    <a:bodyPr/>
+                    <a:lstStyle/>
+                    <a:p>
+                      <a:pPr algn="ctr" indent="0" marL="0">
+                        <a:buNone/>
+                      </a:pPr>
+                      <a:r>
+                        <a:rPr lang="en-US" sz="1400" dirty="0">
+                          <a:solidFill>
+                            <a:srgbClr val="1F2A44"/>
+                          </a:solidFill>
+                          <a:latin typeface="Calibri" pitchFamily="34" charset="0"/>
+                          <a:ea typeface="Calibri" pitchFamily="34" charset="-122"/>
+                          <a:cs typeface="Calibri" pitchFamily="34" charset="-120"/>
+                        </a:rPr>
+                        <a:t>1</a:t>
+                      </a:r>
+                      <a:endParaRPr lang="en-US" sz="1400" dirty="0">
+                        <a:latin typeface="Calibri" charset="0"/>
+                        <a:ea typeface="Calibri" charset="0"/>
+                        <a:cs typeface="Calibri" charset="0"/>
+                      </a:endParaRPr>
+                    </a:p>
+                  </a:txBody>
+                  <a:tcPr marL="36576" marR="36576" marT="18288" marB="18288" anchor="ctr">
+                    <a:lnL w="9525" cap="flat" cmpd="sng" algn="ctr">
+                      <a:solidFill>
+                        <a:srgbClr val="9AA5B8"/>
+                      </a:solidFill>
+                      <a:prstDash val="solid"/>
+                      <a:round/>
+                      <a:headEnd type="none" w="med" len="med"/>
+                      <a:tailEnd type="none" w="med" len="med"/>
+                    </a:lnL>
+                    <a:lnR w="9525" cap="flat" cmpd="sng" algn="ctr">
+                      <a:solidFill>
+                        <a:srgbClr val="9AA5B8"/>
+                      </a:solidFill>
+                      <a:prstDash val="solid"/>
+                      <a:round/>
+                      <a:headEnd type="none" w="med" len="med"/>
+                      <a:tailEnd type="none" w="med" len="med"/>
+                    </a:lnR>
+                    <a:lnT w="9525" cap="flat" cmpd="sng" algn="ctr">
+                      <a:solidFill>
+                        <a:srgbClr val="9AA5B8"/>
+                      </a:solidFill>
+                      <a:prstDash val="solid"/>
+                      <a:round/>
+                      <a:headEnd type="none" w="med" len="med"/>
+                      <a:tailEnd type="none" w="med" len="med"/>
+                    </a:lnT>
+                    <a:lnB w="9525" cap="flat" cmpd="sng" algn="ctr">
+                      <a:solidFill>
+                        <a:srgbClr val="9AA5B8"/>
+                      </a:solidFill>
+                      <a:prstDash val="solid"/>
+                      <a:round/>
+                      <a:headEnd type="none" w="med" len="med"/>
+                      <a:tailEnd type="none" w="med" len="med"/>
+                    </a:lnB>
+                  </a:tcPr>
+                </a:tc>
+                <a:tc>
+                  <a:txBody>
+                    <a:bodyPr/>
+                    <a:lstStyle/>
+                    <a:p>
+                      <a:pPr algn="ctr" indent="0" marL="0">
+                        <a:buNone/>
+                      </a:pPr>
+                      <a:r>
+                        <a:rPr lang="en-US" sz="1400" dirty="0">
+                          <a:solidFill>
+                            <a:srgbClr val="1F2A44"/>
+                          </a:solidFill>
+                          <a:latin typeface="Calibri" pitchFamily="34" charset="0"/>
+                          <a:ea typeface="Calibri" pitchFamily="34" charset="-122"/>
+                          <a:cs typeface="Calibri" pitchFamily="34" charset="-120"/>
+                        </a:rPr>
+                        <a:t>4</a:t>
+                      </a:r>
+                      <a:endParaRPr lang="en-US" sz="1400" dirty="0">
+                        <a:latin typeface="Calibri" charset="0"/>
+                        <a:ea typeface="Calibri" charset="0"/>
+                        <a:cs typeface="Calibri" charset="0"/>
+                      </a:endParaRPr>
+                    </a:p>
+                  </a:txBody>
+                  <a:tcPr marL="36576" marR="36576" marT="18288" marB="18288" anchor="ctr">
+                    <a:lnL w="9525" cap="flat" cmpd="sng" algn="ctr">
+                      <a:solidFill>
+                        <a:srgbClr val="9AA5B8"/>
+                      </a:solidFill>
+                      <a:prstDash val="solid"/>
+                      <a:round/>
+                      <a:headEnd type="none" w="med" len="med"/>
+                      <a:tailEnd type="none" w="med" len="med"/>
+                    </a:lnL>
+                    <a:lnR w="9525" cap="flat" cmpd="sng" algn="ctr">
+                      <a:solidFill>
+                        <a:srgbClr val="9AA5B8"/>
+                      </a:solidFill>
+                      <a:prstDash val="solid"/>
+                      <a:round/>
+                      <a:headEnd type="none" w="med" len="med"/>
+                      <a:tailEnd type="none" w="med" len="med"/>
+                    </a:lnR>
+                    <a:lnT w="9525" cap="flat" cmpd="sng" algn="ctr">
+                      <a:solidFill>
+                        <a:srgbClr val="9AA5B8"/>
+                      </a:solidFill>
+                      <a:prstDash val="solid"/>
+                      <a:round/>
+                      <a:headEnd type="none" w="med" len="med"/>
+                      <a:tailEnd type="none" w="med" len="med"/>
+                    </a:lnT>
+                    <a:lnB w="9525" cap="flat" cmpd="sng" algn="ctr">
+                      <a:solidFill>
+                        <a:srgbClr val="9AA5B8"/>
+                      </a:solidFill>
+                      <a:prstDash val="solid"/>
+                      <a:round/>
+                      <a:headEnd type="none" w="med" len="med"/>
+                      <a:tailEnd type="none" w="med" len="med"/>
+                    </a:lnB>
+                  </a:tcPr>
+                </a:tc>
+                <a:tc>
+                  <a:txBody>
+                    <a:bodyPr/>
+                    <a:lstStyle/>
+                    <a:p>
+                      <a:pPr algn="ctr" indent="0" marL="0">
+                        <a:buNone/>
+                      </a:pPr>
+                      <a:r>
+                        <a:rPr lang="en-US" sz="1400" b="1" dirty="0">
+                          <a:solidFill>
+                            <a:srgbClr val="1F2A44"/>
+                          </a:solidFill>
+                          <a:latin typeface="Calibri" pitchFamily="34" charset="0"/>
+                          <a:ea typeface="Calibri" pitchFamily="34" charset="-122"/>
+                          <a:cs typeface="Calibri" pitchFamily="34" charset="-120"/>
+                        </a:rPr>
+                        <a:t>1.24</a:t>
+                      </a:r>
+                      <a:endParaRPr lang="en-US" sz="1400" dirty="0">
+                        <a:latin typeface="Calibri" charset="0"/>
+                        <a:ea typeface="Calibri" charset="0"/>
+                        <a:cs typeface="Calibri" charset="0"/>
+                      </a:endParaRPr>
+                    </a:p>
+                  </a:txBody>
+                  <a:tcPr marL="36576" marR="36576" marT="18288" marB="18288" anchor="ctr">
+                    <a:lnL w="25400" cap="flat" cmpd="sng" algn="ctr">
+                      <a:solidFill>
+                        <a:srgbClr val="4A5568"/>
+                      </a:solidFill>
+                      <a:prstDash val="solid"/>
+                      <a:round/>
+                      <a:headEnd type="none" w="med" len="med"/>
+                      <a:tailEnd type="none" w="med" len="med"/>
+                    </a:lnL>
+                    <a:lnR w="9525" cap="flat" cmpd="sng" algn="ctr">
+                      <a:solidFill>
+                        <a:srgbClr val="9AA5B8"/>
+                      </a:solidFill>
+                      <a:prstDash val="solid"/>
+                      <a:round/>
+                      <a:headEnd type="none" w="med" len="med"/>
+                      <a:tailEnd type="none" w="med" len="med"/>
+                    </a:lnR>
+                    <a:lnT w="9525" cap="flat" cmpd="sng" algn="ctr">
+                      <a:solidFill>
+                        <a:srgbClr val="9AA5B8"/>
+                      </a:solidFill>
+                      <a:prstDash val="solid"/>
+                      <a:round/>
+                      <a:headEnd type="none" w="med" len="med"/>
+                      <a:tailEnd type="none" w="med" len="med"/>
+                    </a:lnT>
+                    <a:lnB w="9525" cap="flat" cmpd="sng" algn="ctr">
+                      <a:solidFill>
+                        <a:srgbClr val="9AA5B8"/>
+                      </a:solidFill>
+                      <a:prstDash val="solid"/>
+                      <a:round/>
+                      <a:headEnd type="none" w="med" len="med"/>
+                      <a:tailEnd type="none" w="med" len="med"/>
+                    </a:lnB>
+                    <a:solidFill>
+                      <a:srgbClr val="F0BF67"/>
+                    </a:solidFill>
+                  </a:tcPr>
+                </a:tc>
+                <a:tc>
+                  <a:txBody>
+                    <a:bodyPr/>
+                    <a:lstStyle/>
+                    <a:p>
+                      <a:pPr algn="ctr" indent="0" marL="0">
+                        <a:buNone/>
+                      </a:pPr>
+                      <a:r>
+                        <a:rPr lang="en-US" sz="1400" dirty="0">
+                          <a:solidFill>
+                            <a:srgbClr val="1F2A44"/>
+                          </a:solidFill>
+                          <a:latin typeface="Calibri" pitchFamily="34" charset="0"/>
+                          <a:ea typeface="Calibri" pitchFamily="34" charset="-122"/>
+                          <a:cs typeface="Calibri" pitchFamily="34" charset="-120"/>
+                        </a:rPr>
+                        <a:t>73 %</a:t>
+                      </a:r>
+                      <a:endParaRPr lang="en-US" sz="1400" dirty="0">
+                        <a:latin typeface="Calibri" charset="0"/>
+                        <a:ea typeface="Calibri" charset="0"/>
+                        <a:cs typeface="Calibri" charset="0"/>
+                      </a:endParaRPr>
+                    </a:p>
+                  </a:txBody>
+                  <a:tcPr marL="36576" marR="36576" marT="18288" marB="18288" anchor="ctr">
+                    <a:lnL w="9525" cap="flat" cmpd="sng" algn="ctr">
+                      <a:solidFill>
+                        <a:srgbClr val="9AA5B8"/>
+                      </a:solidFill>
+                      <a:prstDash val="solid"/>
+                      <a:round/>
+                      <a:headEnd type="none" w="med" len="med"/>
+                      <a:tailEnd type="none" w="med" len="med"/>
+                    </a:lnL>
+                    <a:lnR w="9525" cap="flat" cmpd="sng" algn="ctr">
+                      <a:solidFill>
+                        <a:srgbClr val="9AA5B8"/>
+                      </a:solidFill>
+                      <a:prstDash val="solid"/>
+                      <a:round/>
+                      <a:headEnd type="none" w="med" len="med"/>
+                      <a:tailEnd type="none" w="med" len="med"/>
+                    </a:lnR>
+                    <a:lnT w="9525" cap="flat" cmpd="sng" algn="ctr">
+                      <a:solidFill>
+                        <a:srgbClr val="9AA5B8"/>
+                      </a:solidFill>
+                      <a:prstDash val="solid"/>
+                      <a:round/>
+                      <a:headEnd type="none" w="med" len="med"/>
+                      <a:tailEnd type="none" w="med" len="med"/>
+                    </a:lnT>
+                    <a:lnB w="9525" cap="flat" cmpd="sng" algn="ctr">
+                      <a:solidFill>
+                        <a:srgbClr val="9AA5B8"/>
+                      </a:solidFill>
+                      <a:prstDash val="solid"/>
+                      <a:round/>
+                      <a:headEnd type="none" w="med" len="med"/>
+                      <a:tailEnd type="none" w="med" len="med"/>
+                    </a:lnB>
+                    <a:solidFill>
+                      <a:srgbClr val="BCCE77"/>
+                    </a:solidFill>
+                  </a:tcPr>
+                </a:tc>
+                <a:tc>
+                  <a:txBody>
+                    <a:bodyPr/>
+                    <a:lstStyle/>
+                    <a:p>
+                      <a:pPr algn="ctr" indent="0" marL="0">
+                        <a:buNone/>
+                      </a:pPr>
+                      <a:r>
+                        <a:rPr lang="en-US" sz="1400" b="1" dirty="0">
+                          <a:solidFill>
+                            <a:srgbClr val="1F2A44"/>
+                          </a:solidFill>
+                          <a:latin typeface="Calibri" pitchFamily="34" charset="0"/>
+                          <a:ea typeface="Calibri" pitchFamily="34" charset="-122"/>
+                          <a:cs typeface="Calibri" pitchFamily="34" charset="-120"/>
+                        </a:rPr>
+                        <a:t>1.23</a:t>
+                      </a:r>
+                      <a:endParaRPr lang="en-US" sz="1400" dirty="0">
+                        <a:latin typeface="Calibri" charset="0"/>
+                        <a:ea typeface="Calibri" charset="0"/>
+                        <a:cs typeface="Calibri" charset="0"/>
+                      </a:endParaRPr>
+                    </a:p>
+                  </a:txBody>
+                  <a:tcPr marL="36576" marR="36576" marT="18288" marB="18288" anchor="ctr">
+                    <a:lnL w="25400" cap="flat" cmpd="sng" algn="ctr">
+                      <a:solidFill>
+                        <a:srgbClr val="4A5568"/>
+                      </a:solidFill>
+                      <a:prstDash val="solid"/>
+                      <a:round/>
+                      <a:headEnd type="none" w="med" len="med"/>
+                      <a:tailEnd type="none" w="med" len="med"/>
+                    </a:lnL>
+                    <a:lnR w="9525" cap="flat" cmpd="sng" algn="ctr">
+                      <a:solidFill>
+                        <a:srgbClr val="9AA5B8"/>
+                      </a:solidFill>
+                      <a:prstDash val="solid"/>
+                      <a:round/>
+                      <a:headEnd type="none" w="med" len="med"/>
+                      <a:tailEnd type="none" w="med" len="med"/>
+                    </a:lnR>
+                    <a:lnT w="9525" cap="flat" cmpd="sng" algn="ctr">
+                      <a:solidFill>
+                        <a:srgbClr val="9AA5B8"/>
+                      </a:solidFill>
+                      <a:prstDash val="solid"/>
+                      <a:round/>
+                      <a:headEnd type="none" w="med" len="med"/>
+                      <a:tailEnd type="none" w="med" len="med"/>
+                    </a:lnT>
+                    <a:lnB w="9525" cap="flat" cmpd="sng" algn="ctr">
+                      <a:solidFill>
+                        <a:srgbClr val="9AA5B8"/>
+                      </a:solidFill>
+                      <a:prstDash val="solid"/>
+                      <a:round/>
+                      <a:headEnd type="none" w="med" len="med"/>
+                      <a:tailEnd type="none" w="med" len="med"/>
+                    </a:lnB>
+                    <a:solidFill>
+                      <a:srgbClr val="F0C067"/>
+                    </a:solidFill>
+                  </a:tcPr>
+                </a:tc>
+                <a:tc>
+                  <a:txBody>
+                    <a:bodyPr/>
+                    <a:lstStyle/>
+                    <a:p>
+                      <a:pPr algn="ctr" indent="0" marL="0">
+                        <a:buNone/>
+                      </a:pPr>
+                      <a:r>
+                        <a:rPr lang="en-US" sz="1400" dirty="0">
+                          <a:solidFill>
+                            <a:srgbClr val="1F2A44"/>
+                          </a:solidFill>
+                          <a:latin typeface="Calibri" pitchFamily="34" charset="0"/>
+                          <a:ea typeface="Calibri" pitchFamily="34" charset="-122"/>
+                          <a:cs typeface="Calibri" pitchFamily="34" charset="-120"/>
+                        </a:rPr>
+                        <a:t>64 %</a:t>
+                      </a:r>
+                      <a:endParaRPr lang="en-US" sz="1400" dirty="0">
+                        <a:latin typeface="Calibri" charset="0"/>
+                        <a:ea typeface="Calibri" charset="0"/>
+                        <a:cs typeface="Calibri" charset="0"/>
+                      </a:endParaRPr>
+                    </a:p>
+                  </a:txBody>
+                  <a:tcPr marL="36576" marR="36576" marT="18288" marB="18288" anchor="ctr">
+                    <a:lnL w="9525" cap="flat" cmpd="sng" algn="ctr">
+                      <a:solidFill>
+                        <a:srgbClr val="9AA5B8"/>
+                      </a:solidFill>
+                      <a:prstDash val="solid"/>
+                      <a:round/>
+                      <a:headEnd type="none" w="med" len="med"/>
+                      <a:tailEnd type="none" w="med" len="med"/>
+                    </a:lnL>
+                    <a:lnR w="9525" cap="flat" cmpd="sng" algn="ctr">
+                      <a:solidFill>
+                        <a:srgbClr val="9AA5B8"/>
+                      </a:solidFill>
+                      <a:prstDash val="solid"/>
+                      <a:round/>
+                      <a:headEnd type="none" w="med" len="med"/>
+                      <a:tailEnd type="none" w="med" len="med"/>
+                    </a:lnR>
+                    <a:lnT w="9525" cap="flat" cmpd="sng" algn="ctr">
+                      <a:solidFill>
+                        <a:srgbClr val="9AA5B8"/>
+                      </a:solidFill>
+                      <a:prstDash val="solid"/>
+                      <a:round/>
+                      <a:headEnd type="none" w="med" len="med"/>
+                      <a:tailEnd type="none" w="med" len="med"/>
+                    </a:lnT>
+                    <a:lnB w="9525" cap="flat" cmpd="sng" algn="ctr">
+                      <a:solidFill>
+                        <a:srgbClr val="9AA5B8"/>
+                      </a:solidFill>
+                      <a:prstDash val="solid"/>
+                      <a:round/>
+                      <a:headEnd type="none" w="med" len="med"/>
+                      <a:tailEnd type="none" w="med" len="med"/>
+                    </a:lnB>
+                    <a:solidFill>
+                      <a:srgbClr val="D3D473"/>
+                    </a:solidFill>
+                  </a:tcPr>
+                </a:tc>
+              </a:tr>
+              <a:tr h="393192">
+                <a:tc>
+                  <a:txBody>
+                    <a:bodyPr/>
+                    <a:lstStyle/>
+                    <a:p>
+                      <a:pPr algn="ctr" indent="0" marL="0">
+                        <a:buNone/>
+                      </a:pPr>
+                      <a:r>
+                        <a:rPr lang="en-US" sz="1400" b="1" dirty="0">
+                          <a:solidFill>
+                            <a:srgbClr val="1F2A44"/>
+                          </a:solidFill>
+                          <a:latin typeface="Calibri" pitchFamily="34" charset="0"/>
+                          <a:ea typeface="Calibri" pitchFamily="34" charset="-122"/>
+                          <a:cs typeface="Calibri" pitchFamily="34" charset="-120"/>
+                        </a:rPr>
+                        <a:t>6300*</a:t>
+                      </a:r>
+                      <a:endParaRPr lang="en-US" sz="1400" dirty="0">
+                        <a:latin typeface="Calibri" charset="0"/>
+                        <a:ea typeface="Calibri" charset="0"/>
+                        <a:cs typeface="Calibri" charset="0"/>
+                      </a:endParaRPr>
+                    </a:p>
+                  </a:txBody>
+                  <a:tcPr marL="36576" marR="36576" marT="18288" marB="18288" anchor="ctr">
+                    <a:lnL w="9525" cap="flat" cmpd="sng" algn="ctr">
+                      <a:solidFill>
+                        <a:srgbClr val="9AA5B8"/>
+                      </a:solidFill>
+                      <a:prstDash val="solid"/>
+                      <a:round/>
+                      <a:headEnd type="none" w="med" len="med"/>
+                      <a:tailEnd type="none" w="med" len="med"/>
+                    </a:lnL>
+                    <a:lnR w="9525" cap="flat" cmpd="sng" algn="ctr">
+                      <a:solidFill>
+                        <a:srgbClr val="9AA5B8"/>
+                      </a:solidFill>
+                      <a:prstDash val="solid"/>
+                      <a:round/>
+                      <a:headEnd type="none" w="med" len="med"/>
+                      <a:tailEnd type="none" w="med" len="med"/>
+                    </a:lnR>
+                    <a:lnT w="9525" cap="flat" cmpd="sng" algn="ctr">
+                      <a:solidFill>
+                        <a:srgbClr val="9AA5B8"/>
+                      </a:solidFill>
+                      <a:prstDash val="solid"/>
+                      <a:round/>
+                      <a:headEnd type="none" w="med" len="med"/>
+                      <a:tailEnd type="none" w="med" len="med"/>
+                    </a:lnT>
+                    <a:lnB w="9525" cap="flat" cmpd="sng" algn="ctr">
+                      <a:solidFill>
+                        <a:srgbClr val="9AA5B8"/>
+                      </a:solidFill>
+                      <a:prstDash val="solid"/>
+                      <a:round/>
+                      <a:headEnd type="none" w="med" len="med"/>
+                      <a:tailEnd type="none" w="med" len="med"/>
+                    </a:lnB>
+                  </a:tcPr>
+                </a:tc>
+                <a:tc>
+                  <a:txBody>
+                    <a:bodyPr/>
+                    <a:lstStyle/>
+                    <a:p>
+                      <a:pPr algn="ctr" indent="0" marL="0">
+                        <a:buNone/>
+                      </a:pPr>
+                      <a:r>
+                        <a:rPr lang="en-US" sz="1400" dirty="0">
+                          <a:solidFill>
+                            <a:srgbClr val="1F2A44"/>
+                          </a:solidFill>
+                          <a:latin typeface="Calibri" pitchFamily="34" charset="0"/>
+                          <a:ea typeface="Calibri" pitchFamily="34" charset="-122"/>
+                          <a:cs typeface="Calibri" pitchFamily="34" charset="-120"/>
+                        </a:rPr>
+                        <a:t>1.5</a:t>
+                      </a:r>
+                      <a:endParaRPr lang="en-US" sz="1400" dirty="0">
+                        <a:latin typeface="Calibri" charset="0"/>
+                        <a:ea typeface="Calibri" charset="0"/>
+                        <a:cs typeface="Calibri" charset="0"/>
+                      </a:endParaRPr>
+                    </a:p>
+                  </a:txBody>
+                  <a:tcPr marL="36576" marR="36576" marT="18288" marB="18288" anchor="ctr">
+                    <a:lnL w="9525" cap="flat" cmpd="sng" algn="ctr">
+                      <a:solidFill>
+                        <a:srgbClr val="9AA5B8"/>
+                      </a:solidFill>
+                      <a:prstDash val="solid"/>
+                      <a:round/>
+                      <a:headEnd type="none" w="med" len="med"/>
+                      <a:tailEnd type="none" w="med" len="med"/>
+                    </a:lnL>
+                    <a:lnR w="9525" cap="flat" cmpd="sng" algn="ctr">
+                      <a:solidFill>
+                        <a:srgbClr val="9AA5B8"/>
+                      </a:solidFill>
+                      <a:prstDash val="solid"/>
+                      <a:round/>
+                      <a:headEnd type="none" w="med" len="med"/>
+                      <a:tailEnd type="none" w="med" len="med"/>
+                    </a:lnR>
+                    <a:lnT w="9525" cap="flat" cmpd="sng" algn="ctr">
+                      <a:solidFill>
+                        <a:srgbClr val="9AA5B8"/>
+                      </a:solidFill>
+                      <a:prstDash val="solid"/>
+                      <a:round/>
+                      <a:headEnd type="none" w="med" len="med"/>
+                      <a:tailEnd type="none" w="med" len="med"/>
+                    </a:lnT>
+                    <a:lnB w="9525" cap="flat" cmpd="sng" algn="ctr">
+                      <a:solidFill>
+                        <a:srgbClr val="9AA5B8"/>
+                      </a:solidFill>
+                      <a:prstDash val="solid"/>
+                      <a:round/>
+                      <a:headEnd type="none" w="med" len="med"/>
+                      <a:tailEnd type="none" w="med" len="med"/>
+                    </a:lnB>
+                  </a:tcPr>
+                </a:tc>
+                <a:tc>
+                  <a:txBody>
+                    <a:bodyPr/>
+                    <a:lstStyle/>
+                    <a:p>
+                      <a:pPr algn="ctr" indent="0" marL="0">
+                        <a:buNone/>
+                      </a:pPr>
+                      <a:r>
+                        <a:rPr lang="en-US" sz="1400" dirty="0">
+                          <a:solidFill>
+                            <a:srgbClr val="1F2A44"/>
+                          </a:solidFill>
+                          <a:latin typeface="Calibri" pitchFamily="34" charset="0"/>
+                          <a:ea typeface="Calibri" pitchFamily="34" charset="-122"/>
+                          <a:cs typeface="Calibri" pitchFamily="34" charset="-120"/>
+                        </a:rPr>
+                        <a:t>5</a:t>
+                      </a:r>
+                      <a:endParaRPr lang="en-US" sz="1400" dirty="0">
+                        <a:latin typeface="Calibri" charset="0"/>
+                        <a:ea typeface="Calibri" charset="0"/>
+                        <a:cs typeface="Calibri" charset="0"/>
+                      </a:endParaRPr>
+                    </a:p>
+                  </a:txBody>
+                  <a:tcPr marL="36576" marR="36576" marT="18288" marB="18288" anchor="ctr">
+                    <a:lnL w="9525" cap="flat" cmpd="sng" algn="ctr">
+                      <a:solidFill>
+                        <a:srgbClr val="9AA5B8"/>
+                      </a:solidFill>
+                      <a:prstDash val="solid"/>
+                      <a:round/>
+                      <a:headEnd type="none" w="med" len="med"/>
+                      <a:tailEnd type="none" w="med" len="med"/>
+                    </a:lnL>
+                    <a:lnR w="9525" cap="flat" cmpd="sng" algn="ctr">
+                      <a:solidFill>
+                        <a:srgbClr val="9AA5B8"/>
+                      </a:solidFill>
+                      <a:prstDash val="solid"/>
+                      <a:round/>
+                      <a:headEnd type="none" w="med" len="med"/>
+                      <a:tailEnd type="none" w="med" len="med"/>
+                    </a:lnR>
+                    <a:lnT w="9525" cap="flat" cmpd="sng" algn="ctr">
+                      <a:solidFill>
+                        <a:srgbClr val="9AA5B8"/>
+                      </a:solidFill>
+                      <a:prstDash val="solid"/>
+                      <a:round/>
+                      <a:headEnd type="none" w="med" len="med"/>
+                      <a:tailEnd type="none" w="med" len="med"/>
+                    </a:lnT>
+                    <a:lnB w="9525" cap="flat" cmpd="sng" algn="ctr">
+                      <a:solidFill>
+                        <a:srgbClr val="9AA5B8"/>
+                      </a:solidFill>
+                      <a:prstDash val="solid"/>
+                      <a:round/>
+                      <a:headEnd type="none" w="med" len="med"/>
+                      <a:tailEnd type="none" w="med" len="med"/>
+                    </a:lnB>
+                  </a:tcPr>
+                </a:tc>
+                <a:tc>
+                  <a:txBody>
+                    <a:bodyPr/>
+                    <a:lstStyle/>
+                    <a:p>
+                      <a:pPr algn="ctr" indent="0" marL="0">
+                        <a:buNone/>
+                      </a:pPr>
+                      <a:r>
+                        <a:rPr lang="en-US" sz="1400" b="1" dirty="0">
+                          <a:solidFill>
+                            <a:srgbClr val="1F2A44"/>
+                          </a:solidFill>
+                          <a:latin typeface="Calibri" pitchFamily="34" charset="0"/>
+                          <a:ea typeface="Calibri" pitchFamily="34" charset="-122"/>
+                          <a:cs typeface="Calibri" pitchFamily="34" charset="-120"/>
+                        </a:rPr>
+                        <a:t>1.59</a:t>
+                      </a:r>
+                      <a:endParaRPr lang="en-US" sz="1400" dirty="0">
+                        <a:latin typeface="Calibri" charset="0"/>
+                        <a:ea typeface="Calibri" charset="0"/>
+                        <a:cs typeface="Calibri" charset="0"/>
+                      </a:endParaRPr>
+                    </a:p>
+                  </a:txBody>
+                  <a:tcPr marL="36576" marR="36576" marT="18288" marB="18288" anchor="ctr">
+                    <a:lnL w="25400" cap="flat" cmpd="sng" algn="ctr">
+                      <a:solidFill>
+                        <a:srgbClr val="4A5568"/>
+                      </a:solidFill>
+                      <a:prstDash val="solid"/>
+                      <a:round/>
+                      <a:headEnd type="none" w="med" len="med"/>
+                      <a:tailEnd type="none" w="med" len="med"/>
+                    </a:lnL>
+                    <a:lnR w="9525" cap="flat" cmpd="sng" algn="ctr">
+                      <a:solidFill>
+                        <a:srgbClr val="9AA5B8"/>
+                      </a:solidFill>
+                      <a:prstDash val="solid"/>
+                      <a:round/>
+                      <a:headEnd type="none" w="med" len="med"/>
+                      <a:tailEnd type="none" w="med" len="med"/>
+                    </a:lnR>
+                    <a:lnT w="9525" cap="flat" cmpd="sng" algn="ctr">
+                      <a:solidFill>
+                        <a:srgbClr val="9AA5B8"/>
+                      </a:solidFill>
+                      <a:prstDash val="solid"/>
+                      <a:round/>
+                      <a:headEnd type="none" w="med" len="med"/>
+                      <a:tailEnd type="none" w="med" len="med"/>
+                    </a:lnT>
+                    <a:lnB w="9525" cap="flat" cmpd="sng" algn="ctr">
+                      <a:solidFill>
+                        <a:srgbClr val="9AA5B8"/>
+                      </a:solidFill>
+                      <a:prstDash val="solid"/>
+                      <a:round/>
+                      <a:headEnd type="none" w="med" len="med"/>
+                      <a:tailEnd type="none" w="med" len="med"/>
+                    </a:lnB>
+                    <a:solidFill>
+                      <a:srgbClr val="F4D56C"/>
+                    </a:solidFill>
+                  </a:tcPr>
+                </a:tc>
+                <a:tc>
+                  <a:txBody>
+                    <a:bodyPr/>
+                    <a:lstStyle/>
+                    <a:p>
+                      <a:pPr algn="ctr" indent="0" marL="0">
+                        <a:buNone/>
+                      </a:pPr>
+                      <a:r>
+                        <a:rPr lang="en-US" sz="1400" dirty="0">
+                          <a:solidFill>
+                            <a:srgbClr val="1F2A44"/>
+                          </a:solidFill>
+                          <a:latin typeface="Calibri" pitchFamily="34" charset="0"/>
+                          <a:ea typeface="Calibri" pitchFamily="34" charset="-122"/>
+                          <a:cs typeface="Calibri" pitchFamily="34" charset="-120"/>
+                        </a:rPr>
+                        <a:t>78 %</a:t>
+                      </a:r>
+                      <a:endParaRPr lang="en-US" sz="1400" dirty="0">
+                        <a:latin typeface="Calibri" charset="0"/>
+                        <a:ea typeface="Calibri" charset="0"/>
+                        <a:cs typeface="Calibri" charset="0"/>
+                      </a:endParaRPr>
+                    </a:p>
+                  </a:txBody>
+                  <a:tcPr marL="36576" marR="36576" marT="18288" marB="18288" anchor="ctr">
+                    <a:lnL w="9525" cap="flat" cmpd="sng" algn="ctr">
+                      <a:solidFill>
+                        <a:srgbClr val="9AA5B8"/>
+                      </a:solidFill>
+                      <a:prstDash val="solid"/>
+                      <a:round/>
+                      <a:headEnd type="none" w="med" len="med"/>
+                      <a:tailEnd type="none" w="med" len="med"/>
+                    </a:lnL>
+                    <a:lnR w="9525" cap="flat" cmpd="sng" algn="ctr">
+                      <a:solidFill>
+                        <a:srgbClr val="9AA5B8"/>
+                      </a:solidFill>
+                      <a:prstDash val="solid"/>
+                      <a:round/>
+                      <a:headEnd type="none" w="med" len="med"/>
+                      <a:tailEnd type="none" w="med" len="med"/>
+                    </a:lnR>
+                    <a:lnT w="9525" cap="flat" cmpd="sng" algn="ctr">
+                      <a:solidFill>
+                        <a:srgbClr val="9AA5B8"/>
+                      </a:solidFill>
+                      <a:prstDash val="solid"/>
+                      <a:round/>
+                      <a:headEnd type="none" w="med" len="med"/>
+                      <a:tailEnd type="none" w="med" len="med"/>
+                    </a:lnT>
+                    <a:lnB w="9525" cap="flat" cmpd="sng" algn="ctr">
+                      <a:solidFill>
+                        <a:srgbClr val="9AA5B8"/>
+                      </a:solidFill>
+                      <a:prstDash val="solid"/>
+                      <a:round/>
+                      <a:headEnd type="none" w="med" len="med"/>
+                      <a:tailEnd type="none" w="med" len="med"/>
+                    </a:lnB>
+                    <a:solidFill>
+                      <a:srgbClr val="AFCB79"/>
+                    </a:solidFill>
+                  </a:tcPr>
+                </a:tc>
+                <a:tc>
+                  <a:txBody>
+                    <a:bodyPr/>
+                    <a:lstStyle/>
+                    <a:p>
+                      <a:pPr algn="ctr" indent="0" marL="0">
+                        <a:buNone/>
+                      </a:pPr>
+                      <a:r>
+                        <a:rPr lang="en-US" sz="1400" b="1" dirty="0">
+                          <a:solidFill>
+                            <a:srgbClr val="1F2A44"/>
+                          </a:solidFill>
+                          <a:latin typeface="Calibri" pitchFamily="34" charset="0"/>
+                          <a:ea typeface="Calibri" pitchFamily="34" charset="-122"/>
+                          <a:cs typeface="Calibri" pitchFamily="34" charset="-120"/>
+                        </a:rPr>
+                        <a:t>1.77</a:t>
+                      </a:r>
+                      <a:endParaRPr lang="en-US" sz="1400" dirty="0">
+                        <a:latin typeface="Calibri" charset="0"/>
+                        <a:ea typeface="Calibri" charset="0"/>
+                        <a:cs typeface="Calibri" charset="0"/>
+                      </a:endParaRPr>
+                    </a:p>
+                  </a:txBody>
+                  <a:tcPr marL="36576" marR="36576" marT="18288" marB="18288" anchor="ctr">
+                    <a:lnL w="25400" cap="flat" cmpd="sng" algn="ctr">
+                      <a:solidFill>
+                        <a:srgbClr val="4A5568"/>
+                      </a:solidFill>
+                      <a:prstDash val="solid"/>
+                      <a:round/>
+                      <a:headEnd type="none" w="med" len="med"/>
+                      <a:tailEnd type="none" w="med" len="med"/>
+                    </a:lnL>
+                    <a:lnR w="9525" cap="flat" cmpd="sng" algn="ctr">
+                      <a:solidFill>
+                        <a:srgbClr val="9AA5B8"/>
+                      </a:solidFill>
+                      <a:prstDash val="solid"/>
+                      <a:round/>
+                      <a:headEnd type="none" w="med" len="med"/>
+                      <a:tailEnd type="none" w="med" len="med"/>
+                    </a:lnR>
+                    <a:lnT w="9525" cap="flat" cmpd="sng" algn="ctr">
+                      <a:solidFill>
+                        <a:srgbClr val="9AA5B8"/>
+                      </a:solidFill>
+                      <a:prstDash val="solid"/>
+                      <a:round/>
+                      <a:headEnd type="none" w="med" len="med"/>
+                      <a:tailEnd type="none" w="med" len="med"/>
+                    </a:lnT>
+                    <a:lnB w="9525" cap="flat" cmpd="sng" algn="ctr">
+                      <a:solidFill>
+                        <a:srgbClr val="9AA5B8"/>
+                      </a:solidFill>
+                      <a:prstDash val="solid"/>
+                      <a:round/>
+                      <a:headEnd type="none" w="med" len="med"/>
+                      <a:tailEnd type="none" w="med" len="med"/>
+                    </a:lnB>
+                    <a:solidFill>
+                      <a:srgbClr val="F1C669"/>
+                    </a:solidFill>
+                  </a:tcPr>
+                </a:tc>
+                <a:tc>
+                  <a:txBody>
+                    <a:bodyPr/>
+                    <a:lstStyle/>
+                    <a:p>
+                      <a:pPr algn="ctr" indent="0" marL="0">
+                        <a:buNone/>
+                      </a:pPr>
+                      <a:r>
+                        <a:rPr lang="en-US" sz="1400" dirty="0">
+                          <a:solidFill>
+                            <a:srgbClr val="1F2A44"/>
+                          </a:solidFill>
+                          <a:latin typeface="Calibri" pitchFamily="34" charset="0"/>
+                          <a:ea typeface="Calibri" pitchFamily="34" charset="-122"/>
+                          <a:cs typeface="Calibri" pitchFamily="34" charset="-120"/>
+                        </a:rPr>
+                        <a:t>76 %</a:t>
+                      </a:r>
+                      <a:endParaRPr lang="en-US" sz="1400" dirty="0">
+                        <a:latin typeface="Calibri" charset="0"/>
+                        <a:ea typeface="Calibri" charset="0"/>
+                        <a:cs typeface="Calibri" charset="0"/>
+                      </a:endParaRPr>
+                    </a:p>
+                  </a:txBody>
+                  <a:tcPr marL="36576" marR="36576" marT="18288" marB="18288" anchor="ctr">
+                    <a:lnL w="9525" cap="flat" cmpd="sng" algn="ctr">
+                      <a:solidFill>
+                        <a:srgbClr val="9AA5B8"/>
+                      </a:solidFill>
+                      <a:prstDash val="solid"/>
+                      <a:round/>
+                      <a:headEnd type="none" w="med" len="med"/>
+                      <a:tailEnd type="none" w="med" len="med"/>
+                    </a:lnL>
+                    <a:lnR w="9525" cap="flat" cmpd="sng" algn="ctr">
+                      <a:solidFill>
+                        <a:srgbClr val="9AA5B8"/>
+                      </a:solidFill>
+                      <a:prstDash val="solid"/>
+                      <a:round/>
+                      <a:headEnd type="none" w="med" len="med"/>
+                      <a:tailEnd type="none" w="med" len="med"/>
+                    </a:lnR>
+                    <a:lnT w="9525" cap="flat" cmpd="sng" algn="ctr">
+                      <a:solidFill>
+                        <a:srgbClr val="9AA5B8"/>
+                      </a:solidFill>
+                      <a:prstDash val="solid"/>
+                      <a:round/>
+                      <a:headEnd type="none" w="med" len="med"/>
+                      <a:tailEnd type="none" w="med" len="med"/>
+                    </a:lnT>
+                    <a:lnB w="9525" cap="flat" cmpd="sng" algn="ctr">
+                      <a:solidFill>
+                        <a:srgbClr val="9AA5B8"/>
+                      </a:solidFill>
+                      <a:prstDash val="solid"/>
+                      <a:round/>
+                      <a:headEnd type="none" w="med" len="med"/>
+                      <a:tailEnd type="none" w="med" len="med"/>
+                    </a:lnB>
+                    <a:solidFill>
+                      <a:srgbClr val="B3CC79"/>
                     </a:solidFill>
                   </a:tcPr>
                 </a:tc>
@@ -9949,12 +10887,11 @@
           <a:bodyPr wrap="square" lIns="0" tIns="0" rIns="0" bIns="0" rtlCol="0" anchor="t"/>
           <a:lstStyle/>
           <a:p>
-            <a:pPr marL="342900" indent="-342900">
+            <a:pPr indent="0" marL="0">
               <a:spcAft>
                 <a:spcPts val="600"/>
               </a:spcAft>
-              <a:buSzPct val="100000"/>
-              <a:buChar char="•"/>
+              <a:buNone/>
             </a:pPr>
             <a:r>
               <a:rPr lang="en-US" sz="1400" dirty="0">
@@ -9965,7 +10902,7 @@
                 <a:ea typeface="Calibri" pitchFamily="34" charset="-122"/>
                 <a:cs typeface="Calibri" pitchFamily="34" charset="-120"/>
               </a:rPr>
-              <a:t>Bands clearly over: </a:t>
+              <a:t>Bands clearly over (of 11): </a:t>
             </a:r>
             <a:r>
               <a:rPr lang="en-US" sz="1400" b="1" dirty="0">
@@ -9981,12 +10918,11 @@
             <a:endParaRPr lang="en-US" sz="1400" dirty="0"/>
           </a:p>
           <a:p>
-            <a:pPr marL="342900" indent="-342900">
+            <a:pPr indent="0" marL="0">
               <a:spcAft>
                 <a:spcPts val="600"/>
               </a:spcAft>
-              <a:buSzPct val="100000"/>
-              <a:buChar char="•"/>
+              <a:buNone/>
             </a:pPr>
             <a:r>
               <a:rPr lang="en-US" sz="1400" dirty="0">
@@ -9997,7 +10933,7 @@
                 <a:ea typeface="Calibri" pitchFamily="34" charset="-122"/>
                 <a:cs typeface="Calibri" pitchFamily="34" charset="-120"/>
               </a:rPr>
-              <a:t>Cells inside the limit: </a:t>
+              <a:t>Cells in limit (11 bands): </a:t>
             </a:r>
             <a:r>
               <a:rPr lang="en-US" sz="1400" b="1" dirty="0">
@@ -10047,7 +10983,7 @@
                 <a:ea typeface="Calibri" pitchFamily="34" charset="-122"/>
                 <a:cs typeface="Calibri" pitchFamily="34" charset="-120"/>
               </a:rPr>
-              <a:t>ISO anechoic tolerance values used as an analogue, not a qualification of the room. Same pair as slide 4 (25 Sep). The highest band evaluated is 2500 Hz.</a:t>
+              <a:t>* Partial bands: only the tones above 5 kHz are measured (4 and 5 tones), none between 3 and 5 kHz. ISO tolerance values used as an analogue, not a qualification of the room. Same pair as slide 4 (25 Sep).</a:t>
             </a:r>
             <a:endParaRPr lang="en-US" sz="1200" dirty="0"/>
           </a:p>

</xml_diff>

<commit_message>
Slides: slide 5 footnote says the 3-5 kHz gap is due to the loudspeaker
Co-Authored-By: Claude Sonnet 5.5 <noreply@anthropic.com>
</commit_message>
<xml_diff>
--- a/docs/analysis/chamber-final-2026-10-01/slides/chamber-slides.pptx
+++ b/docs/analysis/chamber-final-2026-10-01/slides/chamber-slides.pptx
@@ -10958,8 +10958,8 @@
         </p:nvSpPr>
         <p:spPr>
           <a:xfrm>
-            <a:off x="8183880" y="5349240"/>
-            <a:ext cx="3566160" cy="868680"/>
+            <a:off x="8183880" y="5257800"/>
+            <a:ext cx="3566160" cy="1051560"/>
           </a:xfrm>
           <a:prstGeom prst="rect">
             <a:avLst/>
@@ -10983,7 +10983,7 @@
                 <a:ea typeface="Calibri" pitchFamily="34" charset="-122"/>
                 <a:cs typeface="Calibri" pitchFamily="34" charset="-120"/>
               </a:rPr>
-              <a:t>* Partial bands: only the tones above 5 kHz are measured (4 and 5 tones), none between 3 and 5 kHz. ISO tolerance values used as an analogue, not a qualification of the room. Same pair as slide 4 (25 Sep).</a:t>
+              <a:t>* Partial bands: only the tones above 5 kHz are measured (4 and 5 tones). 3–5 kHz is left out because of the loudspeaker: its cone rocks near 4.4 kHz. ISO values are an analogue, not a qualification of the room.</a:t>
             </a:r>
             <a:endParaRPr lang="en-US" sz="1200" dirty="0"/>
           </a:p>

</xml_diff>

<commit_message>
Slides: slide 5 summary counts all 13 table rows (7 to 6 bands over, 60 to 66 % cells)
Co-Authored-By: Claude Sonnet 5.5 <noreply@anthropic.com>
</commit_message>
<xml_diff>
--- a/docs/analysis/chamber-final-2026-10-01/slides/chamber-slides.pptx
+++ b/docs/analysis/chamber-final-2026-10-01/slides/chamber-slides.pptx
@@ -10902,7 +10902,7 @@
                 <a:ea typeface="Calibri" pitchFamily="34" charset="-122"/>
                 <a:cs typeface="Calibri" pitchFamily="34" charset="-120"/>
               </a:rPr>
-              <a:t>Bands clearly over (of 11): </a:t>
+              <a:t>Bands clearly over (of 13): </a:t>
             </a:r>
             <a:r>
               <a:rPr lang="en-US" sz="1400" b="1" dirty="0">
@@ -10913,7 +10913,7 @@
                 <a:ea typeface="Calibri" pitchFamily="34" charset="-122"/>
                 <a:cs typeface="Calibri" pitchFamily="34" charset="-120"/>
               </a:rPr>
-              <a:t>5 → 4</a:t>
+              <a:t>7 → 6</a:t>
             </a:r>
             <a:endParaRPr lang="en-US" sz="1400" dirty="0"/>
           </a:p>
@@ -10933,7 +10933,7 @@
                 <a:ea typeface="Calibri" pitchFamily="34" charset="-122"/>
                 <a:cs typeface="Calibri" pitchFamily="34" charset="-120"/>
               </a:rPr>
-              <a:t>Cells in limit (11 bands): </a:t>
+              <a:t>Cells in limit (13 bands): </a:t>
             </a:r>
             <a:r>
               <a:rPr lang="en-US" sz="1400" b="1" dirty="0">
@@ -10944,7 +10944,7 @@
                 <a:ea typeface="Calibri" pitchFamily="34" charset="-122"/>
                 <a:cs typeface="Calibri" pitchFamily="34" charset="-120"/>
               </a:rPr>
-              <a:t>58 % → 65 %</a:t>
+              <a:t>60 % → 66 %</a:t>
             </a:r>
             <a:endParaRPr lang="en-US" sz="1400" dirty="0"/>
           </a:p>

</xml_diff>

<commit_message>
Slides: slide 7, the five material set-ups overlaid on one polar at 2000 us
Co-Authored-By: Claude Sonnet 5.5 <noreply@anthropic.com>
</commit_message>
<xml_diff>
--- a/docs/analysis/chamber-final-2026-10-01/slides/chamber-slides.pptx
+++ b/docs/analysis/chamber-final-2026-10-01/slides/chamber-slides.pptx
@@ -11,9 +11,10 @@
     <p:sldId id="259" r:id="rId5"/>
     <p:sldId id="260" r:id="rId6"/>
     <p:sldId id="261" r:id="rId7"/>
+    <p:sldId id="262" r:id="rId8"/>
   </p:sldIdLst>
   <p:notesMasterIdLst>
-    <p:notesMasterId r:id="rId8"/>
+    <p:notesMasterId r:id="rId9"/>
   </p:notesMasterIdLst>
   <p:sldSz cx="12192000" cy="6858000"/>
   <p:notesSz cx="6858000" cy="12192000"/>
@@ -1382,6 +1383,94 @@
             <a:fld id="{F7021451-1387-4CA6-816F-3879F97B5CBC}" type="slidenum">
               <a:rPr lang="en-US"/>
               <a:t>6</a:t>
+            </a:fld>
+            <a:endParaRPr lang="en-US"/>
+          </a:p>
+        </p:txBody>
+      </p:sp>
+    </p:spTree>
+    <p:extLst>
+      <p:ext uri="{BB962C8B-B14F-4D97-AF65-F5344CB8AC3E}">
+        <p14:creationId xmlns:p14="http://schemas.microsoft.com/office/powerpoint/2010/main" val="1024086991"/>
+      </p:ext>
+    </p:extLst>
+  </p:cSld>
+  <p:clrMapOvr>
+    <a:masterClrMapping/>
+  </p:clrMapOvr>
+</p:notes>
+</file>
+
+<file path=ppt/notesSlides/notesSlide7.xml><?xml version="1.0" encoding="utf-8"?>
+<p:notes xmlns:a="http://schemas.openxmlformats.org/drawingml/2006/main" xmlns:r="http://schemas.openxmlformats.org/officeDocument/2006/relationships" xmlns:p="http://schemas.openxmlformats.org/presentationml/2006/main">
+  <p:cSld>
+    <p:spTree>
+      <p:nvGrpSpPr>
+        <p:cNvPr id="1" name=""/>
+        <p:cNvGrpSpPr/>
+        <p:nvPr/>
+      </p:nvGrpSpPr>
+      <p:grpSpPr>
+        <a:xfrm>
+          <a:off x="0" y="0"/>
+          <a:ext cx="0" cy="0"/>
+          <a:chOff x="0" y="0"/>
+          <a:chExt cx="0" cy="0"/>
+        </a:xfrm>
+      </p:grpSpPr>
+      <p:sp>
+        <p:nvSpPr>
+          <p:cNvPr id="2" name="Slide Image Placeholder 1"/>
+          <p:cNvSpPr>
+            <a:spLocks noGrp="1" noRot="1" noChangeAspect="1"/>
+          </p:cNvSpPr>
+          <p:nvPr>
+            <p:ph type="sldImg"/>
+          </p:nvPr>
+        </p:nvSpPr>
+        <p:spPr/>
+      </p:sp>
+      <p:sp>
+        <p:nvSpPr>
+          <p:cNvPr id="3" name="Notes Placeholder 2"/>
+          <p:cNvSpPr>
+            <a:spLocks noGrp="1"/>
+          </p:cNvSpPr>
+          <p:nvPr>
+            <p:ph type="body" idx="1"/>
+          </p:nvPr>
+        </p:nvSpPr>
+        <p:spPr/>
+        <p:txBody>
+          <a:bodyPr/>
+          <a:lstStyle/>
+          <a:p>
+            <a:r>
+              <a:rPr lang="en-US" dirty="0"/>
+              <a:t>Bases of 2 Oct 2026 in the data repo: 2004__5in3b__unset__v1-naked-horizontal, ...cork__v1-cork-horizontal, ...rubber__v1-rubber, ...felt__v1-felt, ...felt-rubber__v1-felt-rubber. Each capture is the PWM 2000 step; level per microphone is the total level 100 Hz to 10 kHz in dB SPL, read with the corrected microphone files (all after 16 Sep). The polar is mirrored to 360 degrees. Mean over the eleven positions: naked 74.2, cork 78.7, rubber 80.6, felt 79.5, felt plus rubber 78.7 dB. At -90 degrees (the outflow) all five are 93.7 to 98.3 dB. The slide shows levels as measured; operating points (voltage, thrust) were not compared here.</a:t>
+            </a:r>
+            <a:endParaRPr lang="en-US" dirty="0"/>
+          </a:p>
+        </p:txBody>
+      </p:sp>
+      <p:sp>
+        <p:nvSpPr>
+          <p:cNvPr id="4" name="Slide Number Placeholder 3"/>
+          <p:cNvSpPr>
+            <a:spLocks noGrp="1"/>
+          </p:cNvSpPr>
+          <p:nvPr>
+            <p:ph type="sldNum" sz="quarter" idx="10"/>
+          </p:nvPr>
+        </p:nvSpPr>
+        <p:spPr/>
+        <p:txBody>
+          <a:bodyPr/>
+          <a:lstStyle/>
+          <a:p>
+            <a:fld id="{F7021451-1387-4CA6-816F-3879F97B5CBC}" type="slidenum">
+              <a:rPr lang="en-US"/>
+              <a:t>7</a:t>
             </a:fld>
             <a:endParaRPr lang="en-US"/>
           </a:p>
@@ -11433,6 +11522,811 @@
 </p:sld>
 </file>
 
+<file path=ppt/slides/slide7.xml><?xml version="1.0" encoding="utf-8"?>
+<p:sld xmlns:a="http://schemas.openxmlformats.org/drawingml/2006/main" xmlns:r="http://schemas.openxmlformats.org/officeDocument/2006/relationships" xmlns:p="http://schemas.openxmlformats.org/presentationml/2006/main">
+  <p:cSld name="Slide 7">
+    <p:bg>
+      <p:bgPr>
+        <a:solidFill>
+          <a:srgbClr val="FFFFFF"/>
+        </a:solidFill>
+      </p:bgPr>
+    </p:bg>
+    <p:spTree>
+      <p:nvGrpSpPr>
+        <p:cNvPr id="1" name=""/>
+        <p:cNvGrpSpPr/>
+        <p:nvPr/>
+      </p:nvGrpSpPr>
+      <p:grpSpPr>
+        <a:xfrm>
+          <a:off x="0" y="0"/>
+          <a:ext cx="0" cy="0"/>
+          <a:chOff x="0" y="0"/>
+          <a:chExt cx="0" cy="0"/>
+        </a:xfrm>
+      </p:grpSpPr>
+      <p:pic>
+        <p:nvPicPr>
+          <p:cNvPr id="2" name="Image 0" descr="Polar plot of five material set-ups at 2000 microseconds: naked, cork, rubber, felt and felt with rubber">    </p:cNvPr>
+          <p:cNvPicPr>
+            <a:picLocks noChangeAspect="1"/>
+          </p:cNvPicPr>
+          <p:nvPr/>
+        </p:nvPicPr>
+        <p:blipFill>
+          <a:blip r:embed="rId1"/>
+          <a:stretch>
+            <a:fillRect/>
+          </a:stretch>
+        </p:blipFill>
+        <p:spPr>
+          <a:xfrm>
+            <a:off x="457200" y="411480"/>
+            <a:ext cx="5806440" cy="5806440"/>
+          </a:xfrm>
+          <a:prstGeom prst="rect">
+            <a:avLst/>
+          </a:prstGeom>
+        </p:spPr>
+      </p:pic>
+      <p:sp>
+        <p:nvSpPr>
+          <p:cNvPr id="3" name="Text 0"/>
+          <p:cNvSpPr txBox="1"/>
+          <p:nvPr/>
+        </p:nvSpPr>
+        <p:spPr>
+          <a:xfrm>
+            <a:off x="6949440" y="640080"/>
+            <a:ext cx="4754880" cy="320040"/>
+          </a:xfrm>
+          <a:prstGeom prst="rect">
+            <a:avLst/>
+          </a:prstGeom>
+          <a:noFill/>
+          <a:ln/>
+        </p:spPr>
+        <p:txBody>
+          <a:bodyPr wrap="square" lIns="0" tIns="0" rIns="0" bIns="0" rtlCol="0" anchor="ctr"/>
+          <a:lstStyle/>
+          <a:p>
+            <a:pPr indent="0" marL="0">
+              <a:buNone/>
+            </a:pPr>
+            <a:r>
+              <a:rPr lang="en-US" sz="1400" b="1" spc="300" kern="0" dirty="0">
+                <a:solidFill>
+                  <a:srgbClr val="2B6CB0"/>
+                </a:solidFill>
+                <a:latin typeface="Calibri" pitchFamily="34" charset="0"/>
+                <a:ea typeface="Calibri" pitchFamily="34" charset="-122"/>
+                <a:cs typeface="Calibri" pitchFamily="34" charset="-120"/>
+              </a:rPr>
+              <a:t>THE MATERIALS</a:t>
+            </a:r>
+            <a:endParaRPr lang="en-US" sz="1400" dirty="0"/>
+          </a:p>
+        </p:txBody>
+      </p:sp>
+      <p:sp>
+        <p:nvSpPr>
+          <p:cNvPr id="4" name="Text 1"/>
+          <p:cNvSpPr txBox="1"/>
+          <p:nvPr/>
+        </p:nvSpPr>
+        <p:spPr>
+          <a:xfrm>
+            <a:off x="6949440" y="960120"/>
+            <a:ext cx="4754880" cy="1188720"/>
+          </a:xfrm>
+          <a:prstGeom prst="rect">
+            <a:avLst/>
+          </a:prstGeom>
+          <a:noFill/>
+          <a:ln/>
+        </p:spPr>
+        <p:txBody>
+          <a:bodyPr wrap="square" lIns="0" tIns="0" rIns="0" bIns="0" rtlCol="0" anchor="t"/>
+          <a:lstStyle/>
+          <a:p>
+            <a:pPr indent="0" marL="0">
+              <a:buNone/>
+            </a:pPr>
+            <a:r>
+              <a:rPr lang="en-US" sz="3000" b="1" dirty="0">
+                <a:solidFill>
+                  <a:srgbClr val="1F2A44"/>
+                </a:solidFill>
+                <a:latin typeface="Cambria" pitchFamily="34" charset="0"/>
+                <a:ea typeface="Cambria" pitchFamily="34" charset="-122"/>
+                <a:cs typeface="Cambria" pitchFamily="34" charset="-120"/>
+              </a:rPr>
+              <a:t>Material measurements at 2000 µs</a:t>
+            </a:r>
+            <a:endParaRPr lang="en-US" sz="3000" dirty="0"/>
+          </a:p>
+        </p:txBody>
+      </p:sp>
+      <p:sp>
+        <p:nvSpPr>
+          <p:cNvPr id="5" name="Text 2"/>
+          <p:cNvSpPr txBox="1"/>
+          <p:nvPr/>
+        </p:nvSpPr>
+        <p:spPr>
+          <a:xfrm>
+            <a:off x="6949440" y="2331720"/>
+            <a:ext cx="4754880" cy="274320"/>
+          </a:xfrm>
+          <a:prstGeom prst="rect">
+            <a:avLst/>
+          </a:prstGeom>
+          <a:noFill/>
+          <a:ln/>
+        </p:spPr>
+        <p:txBody>
+          <a:bodyPr wrap="square" lIns="0" tIns="0" rIns="0" bIns="0" rtlCol="0" anchor="ctr"/>
+          <a:lstStyle/>
+          <a:p>
+            <a:pPr indent="0" marL="0">
+              <a:buNone/>
+            </a:pPr>
+            <a:r>
+              <a:rPr lang="en-US" sz="1200" dirty="0">
+                <a:solidFill>
+                  <a:srgbClr val="5B6578"/>
+                </a:solidFill>
+                <a:latin typeface="Calibri" pitchFamily="34" charset="0"/>
+                <a:ea typeface="Calibri" pitchFamily="34" charset="-122"/>
+                <a:cs typeface="Calibri" pitchFamily="34" charset="-120"/>
+              </a:rPr>
+              <a:t>Mean level over the eleven microphones</a:t>
+            </a:r>
+            <a:endParaRPr lang="en-US" sz="1200" dirty="0"/>
+          </a:p>
+        </p:txBody>
+      </p:sp>
+      <p:sp>
+        <p:nvSpPr>
+          <p:cNvPr id="6" name="Shape 3"/>
+          <p:cNvSpPr/>
+          <p:nvPr/>
+        </p:nvSpPr>
+        <p:spPr>
+          <a:xfrm>
+            <a:off x="6949440" y="2761488"/>
+            <a:ext cx="237744" cy="237744"/>
+          </a:xfrm>
+          <a:prstGeom prst="ellipse">
+            <a:avLst/>
+          </a:prstGeom>
+          <a:solidFill>
+            <a:srgbClr val="1F2A44"/>
+          </a:solidFill>
+          <a:ln w="12700">
+            <a:solidFill>
+              <a:srgbClr val="1F2A44"/>
+            </a:solidFill>
+            <a:prstDash val="solid"/>
+          </a:ln>
+        </p:spPr>
+      </p:sp>
+      <p:sp>
+        <p:nvSpPr>
+          <p:cNvPr id="7" name="Text 4"/>
+          <p:cNvSpPr txBox="1"/>
+          <p:nvPr/>
+        </p:nvSpPr>
+        <p:spPr>
+          <a:xfrm>
+            <a:off x="7360920" y="2697480"/>
+            <a:ext cx="2377440" cy="365760"/>
+          </a:xfrm>
+          <a:prstGeom prst="rect">
+            <a:avLst/>
+          </a:prstGeom>
+          <a:noFill/>
+          <a:ln/>
+        </p:spPr>
+        <p:txBody>
+          <a:bodyPr wrap="square" lIns="0" tIns="0" rIns="0" bIns="0" rtlCol="0" anchor="ctr"/>
+          <a:lstStyle/>
+          <a:p>
+            <a:pPr indent="0" marL="0">
+              <a:buNone/>
+            </a:pPr>
+            <a:r>
+              <a:rPr lang="en-US" sz="1800" b="1" dirty="0">
+                <a:solidFill>
+                  <a:srgbClr val="1F2A44"/>
+                </a:solidFill>
+                <a:latin typeface="Calibri" pitchFamily="34" charset="0"/>
+                <a:ea typeface="Calibri" pitchFamily="34" charset="-122"/>
+                <a:cs typeface="Calibri" pitchFamily="34" charset="-120"/>
+              </a:rPr>
+              <a:t>Naked</a:t>
+            </a:r>
+            <a:endParaRPr lang="en-US" sz="1800" dirty="0"/>
+          </a:p>
+        </p:txBody>
+      </p:sp>
+      <p:sp>
+        <p:nvSpPr>
+          <p:cNvPr id="8" name="Text 5"/>
+          <p:cNvSpPr txBox="1"/>
+          <p:nvPr/>
+        </p:nvSpPr>
+        <p:spPr>
+          <a:xfrm>
+            <a:off x="9692640" y="2697480"/>
+            <a:ext cx="2011680" cy="365760"/>
+          </a:xfrm>
+          <a:prstGeom prst="rect">
+            <a:avLst/>
+          </a:prstGeom>
+          <a:noFill/>
+          <a:ln/>
+        </p:spPr>
+        <p:txBody>
+          <a:bodyPr wrap="square" lIns="0" tIns="0" rIns="0" bIns="0" rtlCol="0" anchor="ctr"/>
+          <a:lstStyle/>
+          <a:p>
+            <a:pPr algn="r" indent="0" marL="0">
+              <a:buNone/>
+            </a:pPr>
+            <a:r>
+              <a:rPr lang="en-US" sz="1800" dirty="0">
+                <a:solidFill>
+                  <a:srgbClr val="1F2A44"/>
+                </a:solidFill>
+                <a:latin typeface="Calibri" pitchFamily="34" charset="0"/>
+                <a:ea typeface="Calibri" pitchFamily="34" charset="-122"/>
+                <a:cs typeface="Calibri" pitchFamily="34" charset="-120"/>
+              </a:rPr>
+              <a:t>74.2 dB</a:t>
+            </a:r>
+            <a:endParaRPr lang="en-US" sz="1800" dirty="0"/>
+          </a:p>
+        </p:txBody>
+      </p:sp>
+      <p:sp>
+        <p:nvSpPr>
+          <p:cNvPr id="9" name="Shape 6"/>
+          <p:cNvSpPr/>
+          <p:nvPr/>
+        </p:nvSpPr>
+        <p:spPr>
+          <a:xfrm>
+            <a:off x="6949440" y="3218688"/>
+            <a:ext cx="237744" cy="237744"/>
+          </a:xfrm>
+          <a:prstGeom prst="ellipse">
+            <a:avLst/>
+          </a:prstGeom>
+          <a:solidFill>
+            <a:srgbClr val="2F9E44"/>
+          </a:solidFill>
+          <a:ln w="12700">
+            <a:solidFill>
+              <a:srgbClr val="2F9E44"/>
+            </a:solidFill>
+            <a:prstDash val="solid"/>
+          </a:ln>
+        </p:spPr>
+      </p:sp>
+      <p:sp>
+        <p:nvSpPr>
+          <p:cNvPr id="10" name="Text 7"/>
+          <p:cNvSpPr txBox="1"/>
+          <p:nvPr/>
+        </p:nvSpPr>
+        <p:spPr>
+          <a:xfrm>
+            <a:off x="7360920" y="3154680"/>
+            <a:ext cx="2377440" cy="365760"/>
+          </a:xfrm>
+          <a:prstGeom prst="rect">
+            <a:avLst/>
+          </a:prstGeom>
+          <a:noFill/>
+          <a:ln/>
+        </p:spPr>
+        <p:txBody>
+          <a:bodyPr wrap="square" lIns="0" tIns="0" rIns="0" bIns="0" rtlCol="0" anchor="ctr"/>
+          <a:lstStyle/>
+          <a:p>
+            <a:pPr indent="0" marL="0">
+              <a:buNone/>
+            </a:pPr>
+            <a:r>
+              <a:rPr lang="en-US" sz="1800" b="1" dirty="0">
+                <a:solidFill>
+                  <a:srgbClr val="1F2A44"/>
+                </a:solidFill>
+                <a:latin typeface="Calibri" pitchFamily="34" charset="0"/>
+                <a:ea typeface="Calibri" pitchFamily="34" charset="-122"/>
+                <a:cs typeface="Calibri" pitchFamily="34" charset="-120"/>
+              </a:rPr>
+              <a:t>Cork</a:t>
+            </a:r>
+            <a:endParaRPr lang="en-US" sz="1800" dirty="0"/>
+          </a:p>
+        </p:txBody>
+      </p:sp>
+      <p:sp>
+        <p:nvSpPr>
+          <p:cNvPr id="11" name="Text 8"/>
+          <p:cNvSpPr txBox="1"/>
+          <p:nvPr/>
+        </p:nvSpPr>
+        <p:spPr>
+          <a:xfrm>
+            <a:off x="9692640" y="3154680"/>
+            <a:ext cx="2011680" cy="365760"/>
+          </a:xfrm>
+          <a:prstGeom prst="rect">
+            <a:avLst/>
+          </a:prstGeom>
+          <a:noFill/>
+          <a:ln/>
+        </p:spPr>
+        <p:txBody>
+          <a:bodyPr wrap="square" lIns="0" tIns="0" rIns="0" bIns="0" rtlCol="0" anchor="ctr"/>
+          <a:lstStyle/>
+          <a:p>
+            <a:pPr algn="r" indent="0" marL="0">
+              <a:buNone/>
+            </a:pPr>
+            <a:r>
+              <a:rPr lang="en-US" sz="1800" dirty="0">
+                <a:solidFill>
+                  <a:srgbClr val="1F2A44"/>
+                </a:solidFill>
+                <a:latin typeface="Calibri" pitchFamily="34" charset="0"/>
+                <a:ea typeface="Calibri" pitchFamily="34" charset="-122"/>
+                <a:cs typeface="Calibri" pitchFamily="34" charset="-120"/>
+              </a:rPr>
+              <a:t>78.7 dB</a:t>
+            </a:r>
+            <a:endParaRPr lang="en-US" sz="1800" dirty="0"/>
+          </a:p>
+        </p:txBody>
+      </p:sp>
+      <p:sp>
+        <p:nvSpPr>
+          <p:cNvPr id="12" name="Shape 9"/>
+          <p:cNvSpPr/>
+          <p:nvPr/>
+        </p:nvSpPr>
+        <p:spPr>
+          <a:xfrm>
+            <a:off x="6949440" y="3675888"/>
+            <a:ext cx="237744" cy="237744"/>
+          </a:xfrm>
+          <a:prstGeom prst="ellipse">
+            <a:avLst/>
+          </a:prstGeom>
+          <a:solidFill>
+            <a:srgbClr val="F08C00"/>
+          </a:solidFill>
+          <a:ln w="12700">
+            <a:solidFill>
+              <a:srgbClr val="F08C00"/>
+            </a:solidFill>
+            <a:prstDash val="solid"/>
+          </a:ln>
+        </p:spPr>
+      </p:sp>
+      <p:sp>
+        <p:nvSpPr>
+          <p:cNvPr id="13" name="Text 10"/>
+          <p:cNvSpPr txBox="1"/>
+          <p:nvPr/>
+        </p:nvSpPr>
+        <p:spPr>
+          <a:xfrm>
+            <a:off x="7360920" y="3611880"/>
+            <a:ext cx="2377440" cy="365760"/>
+          </a:xfrm>
+          <a:prstGeom prst="rect">
+            <a:avLst/>
+          </a:prstGeom>
+          <a:noFill/>
+          <a:ln/>
+        </p:spPr>
+        <p:txBody>
+          <a:bodyPr wrap="square" lIns="0" tIns="0" rIns="0" bIns="0" rtlCol="0" anchor="ctr"/>
+          <a:lstStyle/>
+          <a:p>
+            <a:pPr indent="0" marL="0">
+              <a:buNone/>
+            </a:pPr>
+            <a:r>
+              <a:rPr lang="en-US" sz="1800" b="1" dirty="0">
+                <a:solidFill>
+                  <a:srgbClr val="1F2A44"/>
+                </a:solidFill>
+                <a:latin typeface="Calibri" pitchFamily="34" charset="0"/>
+                <a:ea typeface="Calibri" pitchFamily="34" charset="-122"/>
+                <a:cs typeface="Calibri" pitchFamily="34" charset="-120"/>
+              </a:rPr>
+              <a:t>Rubber</a:t>
+            </a:r>
+            <a:endParaRPr lang="en-US" sz="1800" dirty="0"/>
+          </a:p>
+        </p:txBody>
+      </p:sp>
+      <p:sp>
+        <p:nvSpPr>
+          <p:cNvPr id="14" name="Text 11"/>
+          <p:cNvSpPr txBox="1"/>
+          <p:nvPr/>
+        </p:nvSpPr>
+        <p:spPr>
+          <a:xfrm>
+            <a:off x="9692640" y="3611880"/>
+            <a:ext cx="2011680" cy="365760"/>
+          </a:xfrm>
+          <a:prstGeom prst="rect">
+            <a:avLst/>
+          </a:prstGeom>
+          <a:noFill/>
+          <a:ln/>
+        </p:spPr>
+        <p:txBody>
+          <a:bodyPr wrap="square" lIns="0" tIns="0" rIns="0" bIns="0" rtlCol="0" anchor="ctr"/>
+          <a:lstStyle/>
+          <a:p>
+            <a:pPr algn="r" indent="0" marL="0">
+              <a:buNone/>
+            </a:pPr>
+            <a:r>
+              <a:rPr lang="en-US" sz="1800" dirty="0">
+                <a:solidFill>
+                  <a:srgbClr val="1F2A44"/>
+                </a:solidFill>
+                <a:latin typeface="Calibri" pitchFamily="34" charset="0"/>
+                <a:ea typeface="Calibri" pitchFamily="34" charset="-122"/>
+                <a:cs typeface="Calibri" pitchFamily="34" charset="-120"/>
+              </a:rPr>
+              <a:t>80.6 dB</a:t>
+            </a:r>
+            <a:endParaRPr lang="en-US" sz="1800" dirty="0"/>
+          </a:p>
+        </p:txBody>
+      </p:sp>
+      <p:sp>
+        <p:nvSpPr>
+          <p:cNvPr id="15" name="Shape 12"/>
+          <p:cNvSpPr/>
+          <p:nvPr/>
+        </p:nvSpPr>
+        <p:spPr>
+          <a:xfrm>
+            <a:off x="6949440" y="4133088"/>
+            <a:ext cx="237744" cy="237744"/>
+          </a:xfrm>
+          <a:prstGeom prst="ellipse">
+            <a:avLst/>
+          </a:prstGeom>
+          <a:solidFill>
+            <a:srgbClr val="D6336C"/>
+          </a:solidFill>
+          <a:ln w="12700">
+            <a:solidFill>
+              <a:srgbClr val="D6336C"/>
+            </a:solidFill>
+            <a:prstDash val="solid"/>
+          </a:ln>
+        </p:spPr>
+      </p:sp>
+      <p:sp>
+        <p:nvSpPr>
+          <p:cNvPr id="16" name="Text 13"/>
+          <p:cNvSpPr txBox="1"/>
+          <p:nvPr/>
+        </p:nvSpPr>
+        <p:spPr>
+          <a:xfrm>
+            <a:off x="7360920" y="4069080"/>
+            <a:ext cx="2377440" cy="365760"/>
+          </a:xfrm>
+          <a:prstGeom prst="rect">
+            <a:avLst/>
+          </a:prstGeom>
+          <a:noFill/>
+          <a:ln/>
+        </p:spPr>
+        <p:txBody>
+          <a:bodyPr wrap="square" lIns="0" tIns="0" rIns="0" bIns="0" rtlCol="0" anchor="ctr"/>
+          <a:lstStyle/>
+          <a:p>
+            <a:pPr indent="0" marL="0">
+              <a:buNone/>
+            </a:pPr>
+            <a:r>
+              <a:rPr lang="en-US" sz="1800" b="1" dirty="0">
+                <a:solidFill>
+                  <a:srgbClr val="1F2A44"/>
+                </a:solidFill>
+                <a:latin typeface="Calibri" pitchFamily="34" charset="0"/>
+                <a:ea typeface="Calibri" pitchFamily="34" charset="-122"/>
+                <a:cs typeface="Calibri" pitchFamily="34" charset="-120"/>
+              </a:rPr>
+              <a:t>Felt</a:t>
+            </a:r>
+            <a:endParaRPr lang="en-US" sz="1800" dirty="0"/>
+          </a:p>
+        </p:txBody>
+      </p:sp>
+      <p:sp>
+        <p:nvSpPr>
+          <p:cNvPr id="17" name="Text 14"/>
+          <p:cNvSpPr txBox="1"/>
+          <p:nvPr/>
+        </p:nvSpPr>
+        <p:spPr>
+          <a:xfrm>
+            <a:off x="9692640" y="4069080"/>
+            <a:ext cx="2011680" cy="365760"/>
+          </a:xfrm>
+          <a:prstGeom prst="rect">
+            <a:avLst/>
+          </a:prstGeom>
+          <a:noFill/>
+          <a:ln/>
+        </p:spPr>
+        <p:txBody>
+          <a:bodyPr wrap="square" lIns="0" tIns="0" rIns="0" bIns="0" rtlCol="0" anchor="ctr"/>
+          <a:lstStyle/>
+          <a:p>
+            <a:pPr algn="r" indent="0" marL="0">
+              <a:buNone/>
+            </a:pPr>
+            <a:r>
+              <a:rPr lang="en-US" sz="1800" dirty="0">
+                <a:solidFill>
+                  <a:srgbClr val="1F2A44"/>
+                </a:solidFill>
+                <a:latin typeface="Calibri" pitchFamily="34" charset="0"/>
+                <a:ea typeface="Calibri" pitchFamily="34" charset="-122"/>
+                <a:cs typeface="Calibri" pitchFamily="34" charset="-120"/>
+              </a:rPr>
+              <a:t>79.5 dB</a:t>
+            </a:r>
+            <a:endParaRPr lang="en-US" sz="1800" dirty="0"/>
+          </a:p>
+        </p:txBody>
+      </p:sp>
+      <p:sp>
+        <p:nvSpPr>
+          <p:cNvPr id="18" name="Shape 15"/>
+          <p:cNvSpPr/>
+          <p:nvPr/>
+        </p:nvSpPr>
+        <p:spPr>
+          <a:xfrm>
+            <a:off x="6949440" y="4590288"/>
+            <a:ext cx="237744" cy="237744"/>
+          </a:xfrm>
+          <a:prstGeom prst="ellipse">
+            <a:avLst/>
+          </a:prstGeom>
+          <a:solidFill>
+            <a:srgbClr val="7048E8"/>
+          </a:solidFill>
+          <a:ln w="12700">
+            <a:solidFill>
+              <a:srgbClr val="7048E8"/>
+            </a:solidFill>
+            <a:prstDash val="solid"/>
+          </a:ln>
+        </p:spPr>
+      </p:sp>
+      <p:sp>
+        <p:nvSpPr>
+          <p:cNvPr id="19" name="Text 16"/>
+          <p:cNvSpPr txBox="1"/>
+          <p:nvPr/>
+        </p:nvSpPr>
+        <p:spPr>
+          <a:xfrm>
+            <a:off x="7360920" y="4526280"/>
+            <a:ext cx="2377440" cy="365760"/>
+          </a:xfrm>
+          <a:prstGeom prst="rect">
+            <a:avLst/>
+          </a:prstGeom>
+          <a:noFill/>
+          <a:ln/>
+        </p:spPr>
+        <p:txBody>
+          <a:bodyPr wrap="square" lIns="0" tIns="0" rIns="0" bIns="0" rtlCol="0" anchor="ctr"/>
+          <a:lstStyle/>
+          <a:p>
+            <a:pPr indent="0" marL="0">
+              <a:buNone/>
+            </a:pPr>
+            <a:r>
+              <a:rPr lang="en-US" sz="1800" b="1" dirty="0">
+                <a:solidFill>
+                  <a:srgbClr val="1F2A44"/>
+                </a:solidFill>
+                <a:latin typeface="Calibri" pitchFamily="34" charset="0"/>
+                <a:ea typeface="Calibri" pitchFamily="34" charset="-122"/>
+                <a:cs typeface="Calibri" pitchFamily="34" charset="-120"/>
+              </a:rPr>
+              <a:t>Felt + rubber</a:t>
+            </a:r>
+            <a:endParaRPr lang="en-US" sz="1800" dirty="0"/>
+          </a:p>
+        </p:txBody>
+      </p:sp>
+      <p:sp>
+        <p:nvSpPr>
+          <p:cNvPr id="20" name="Text 17"/>
+          <p:cNvSpPr txBox="1"/>
+          <p:nvPr/>
+        </p:nvSpPr>
+        <p:spPr>
+          <a:xfrm>
+            <a:off x="9692640" y="4526280"/>
+            <a:ext cx="2011680" cy="365760"/>
+          </a:xfrm>
+          <a:prstGeom prst="rect">
+            <a:avLst/>
+          </a:prstGeom>
+          <a:noFill/>
+          <a:ln/>
+        </p:spPr>
+        <p:txBody>
+          <a:bodyPr wrap="square" lIns="0" tIns="0" rIns="0" bIns="0" rtlCol="0" anchor="ctr"/>
+          <a:lstStyle/>
+          <a:p>
+            <a:pPr algn="r" indent="0" marL="0">
+              <a:buNone/>
+            </a:pPr>
+            <a:r>
+              <a:rPr lang="en-US" sz="1800" dirty="0">
+                <a:solidFill>
+                  <a:srgbClr val="1F2A44"/>
+                </a:solidFill>
+                <a:latin typeface="Calibri" pitchFamily="34" charset="0"/>
+                <a:ea typeface="Calibri" pitchFamily="34" charset="-122"/>
+                <a:cs typeface="Calibri" pitchFamily="34" charset="-120"/>
+              </a:rPr>
+              <a:t>78.7 dB</a:t>
+            </a:r>
+            <a:endParaRPr lang="en-US" sz="1800" dirty="0"/>
+          </a:p>
+        </p:txBody>
+      </p:sp>
+      <p:sp>
+        <p:nvSpPr>
+          <p:cNvPr id="21" name="Text 18"/>
+          <p:cNvSpPr txBox="1"/>
+          <p:nvPr/>
+        </p:nvSpPr>
+        <p:spPr>
+          <a:xfrm>
+            <a:off x="6949440" y="5120640"/>
+            <a:ext cx="4754880" cy="914400"/>
+          </a:xfrm>
+          <a:prstGeom prst="rect">
+            <a:avLst/>
+          </a:prstGeom>
+          <a:noFill/>
+          <a:ln/>
+        </p:spPr>
+        <p:txBody>
+          <a:bodyPr wrap="square" lIns="0" tIns="0" rIns="0" bIns="0" rtlCol="0" anchor="t"/>
+          <a:lstStyle/>
+          <a:p>
+            <a:pPr indent="0" marL="0">
+              <a:buNone/>
+            </a:pPr>
+            <a:r>
+              <a:rPr lang="en-US" sz="1400" dirty="0">
+                <a:solidFill>
+                  <a:srgbClr val="1F2A44"/>
+                </a:solidFill>
+                <a:latin typeface="Calibri" pitchFamily="34" charset="0"/>
+                <a:ea typeface="Calibri" pitchFamily="34" charset="-122"/>
+                <a:cs typeface="Calibri" pitchFamily="34" charset="-120"/>
+              </a:rPr>
+              <a:t>At −90°, in the outflow, all five meet at 94–98 dB. Every lined set-up reads 4.5–6.4 dB higher on average than the naked one.</a:t>
+            </a:r>
+            <a:endParaRPr lang="en-US" sz="1400" dirty="0"/>
+          </a:p>
+        </p:txBody>
+      </p:sp>
+      <p:sp>
+        <p:nvSpPr>
+          <p:cNvPr id="22" name="Text 19"/>
+          <p:cNvSpPr txBox="1"/>
+          <p:nvPr/>
+        </p:nvSpPr>
+        <p:spPr>
+          <a:xfrm>
+            <a:off x="548640" y="6355080"/>
+            <a:ext cx="10332720" cy="274320"/>
+          </a:xfrm>
+          <a:prstGeom prst="rect">
+            <a:avLst/>
+          </a:prstGeom>
+          <a:noFill/>
+          <a:ln/>
+        </p:spPr>
+        <p:txBody>
+          <a:bodyPr wrap="square" lIns="0" tIns="0" rIns="0" bIns="0" rtlCol="0" anchor="ctr"/>
+          <a:lstStyle/>
+          <a:p>
+            <a:pPr indent="0" marL="0">
+              <a:buNone/>
+            </a:pPr>
+            <a:r>
+              <a:rPr lang="en-US" sz="1100" dirty="0">
+                <a:solidFill>
+                  <a:srgbClr val="5B6578"/>
+                </a:solidFill>
+                <a:latin typeface="Calibri" pitchFamily="34" charset="0"/>
+                <a:ea typeface="Calibri" pitchFamily="34" charset="-122"/>
+                <a:cs typeface="Calibri" pitchFamily="34" charset="-120"/>
+              </a:rPr>
+              <a:t>2 Oct 2026, 5-inch 3-blade propeller, total level 100 Hz–10 kHz, motor at 2000 µs, corrected microphone files.</a:t>
+            </a:r>
+            <a:endParaRPr lang="en-US" sz="1100" dirty="0"/>
+          </a:p>
+        </p:txBody>
+      </p:sp>
+      <p:sp>
+        <p:nvSpPr>
+          <p:cNvPr id="23" name="Text 20"/>
+          <p:cNvSpPr txBox="1"/>
+          <p:nvPr/>
+        </p:nvSpPr>
+        <p:spPr>
+          <a:xfrm>
+            <a:off x="11155680" y="6355080"/>
+            <a:ext cx="457200" cy="274320"/>
+          </a:xfrm>
+          <a:prstGeom prst="rect">
+            <a:avLst/>
+          </a:prstGeom>
+          <a:noFill/>
+          <a:ln/>
+        </p:spPr>
+        <p:txBody>
+          <a:bodyPr wrap="square" lIns="0" tIns="0" rIns="0" bIns="0" rtlCol="0" anchor="ctr"/>
+          <a:lstStyle/>
+          <a:p>
+            <a:pPr algn="r" indent="0" marL="0">
+              <a:buNone/>
+            </a:pPr>
+            <a:r>
+              <a:rPr lang="en-US" sz="1200" dirty="0">
+                <a:solidFill>
+                  <a:srgbClr val="5B6578"/>
+                </a:solidFill>
+                <a:latin typeface="Calibri" pitchFamily="34" charset="0"/>
+                <a:ea typeface="Calibri" pitchFamily="34" charset="-122"/>
+                <a:cs typeface="Calibri" pitchFamily="34" charset="-120"/>
+              </a:rPr>
+              <a:t>7</a:t>
+            </a:r>
+            <a:endParaRPr lang="en-US" sz="1200" dirty="0"/>
+          </a:p>
+        </p:txBody>
+      </p:sp>
+    </p:spTree>
+  </p:cSld>
+  <p:clrMapOvr>
+    <a:masterClrMapping/>
+  </p:clrMapOvr>
+</p:sld>
+</file>
+
 <file path=ppt/theme/theme1.xml><?xml version="1.0" encoding="utf-8"?>
 <a:theme xmlns:a="http://schemas.openxmlformats.org/drawingml/2006/main" name="Office Theme">
   <a:themeElements>

</xml_diff>

<commit_message>
Slides: slide 4 line says in plain words that the low end improved by 1.2 dB
Co-Authored-By: Claude Sonnet 5.5 <noreply@anthropic.com>
</commit_message>
<xml_diff>
--- a/docs/analysis/chamber-final-2026-10-01/slides/chamber-slides.pptx
+++ b/docs/analysis/chamber-final-2026-10-01/slides/chamber-slides.pptx
@@ -1183,7 +1183,7 @@
           <a:p>
             <a:r>
               <a:rPr lang="en-US" dirty="0"/>
-              <a:t>Same pair as page 3 of the report (day3-a at 13:17, carpet-reordered at 19:15, both 25 Sep), read with the corrected microphone files. Room error is the rms deviation of the eleven microphones from their mean, per band. Start of day 3: 3.33, 2.57, 1.57, 0.80, 0.87, 1.04 dB; final: 1.99, 1.52, 1.47, 0.85, 0.96, 1.17 dB for the bands 250-400, 400-630, 630-1000, 1000-1600, 1600-3000 and 5000-6400 Hz. Caveat from the report: the loudspeaker was moved on purpose during the day (20 cm closer, into the ring plane, 5 cm back) and then returned to about its starting mounting point, which was not recorded. The tilt of the map changed from -0.41 to -0.63 and the mean level rose 1.16 dB, so the gain is the treatments plus a small unknown difference in source position, and part of it may be the louder direct sound. The clean pair with an unmoved source is 24 Sep: empty floor 2.054 to carpet 1.317 dB.</a:t>
+              <a:t>Same pair as page 3 of the report (day3-a at 13:17, carpet-reordered at 19:15, both 25 Sep), read with the corrected microphone files. Room error is the rms deviation of the eleven microphones from their mean, per band. Below 630 Hz the rms room error fell from 2.98 to 1.78 dB (1.2 dB, 40 %); between 1 and 3 kHz it went 0.84 to 0.91 dB. Start of day 3: 3.33, 2.57, 1.57, 0.80, 0.87, 1.04 dB; final: 1.99, 1.52, 1.47, 0.85, 0.96, 1.17 dB for the bands 250-400, 400-630, 630-1000, 1000-1600, 1600-3000 and 5000-6400 Hz. Caveat from the report: the loudspeaker was moved on purpose during the day (20 cm closer, into the ring plane, 5 cm back) and then returned to about its starting mounting point, which was not recorded. The tilt of the map changed from -0.41 to -0.63 and the mean level rose 1.16 dB, so the gain is the treatments plus a small unknown difference in source position, and part of it may be the louder direct sound. The clean pair with an unmoved source is 24 Sep: empty floor 2.054 to carpet 1.317 dB.</a:t>
             </a:r>
             <a:endParaRPr lang="en-US" dirty="0"/>
           </a:p>
@@ -3519,7 +3519,7 @@
                 <a:ea typeface="Calibri" pitchFamily="34" charset="-122"/>
                 <a:cs typeface="Calibri" pitchFamily="34" charset="-120"/>
               </a:rPr>
-              <a:t>Below 630 Hz the error falls by 1.3 and 1.0 dB. Above 1 kHz it does not improve.</a:t>
+              <a:t>We improved the low end (below 630 Hz) by 1.2 dB: the error fell from 3.0 to 1.8 dB, 40 % lower. Above 1 kHz nothing changed.</a:t>
             </a:r>
             <a:endParaRPr lang="en-US" sz="1400" dirty="0"/>
           </a:p>

</xml_diff>

<commit_message>
Slides: material polar scale cut at 88 dB so the curves fill the plot; the -90 deg lobe is marked as off the scale
Co-Authored-By: Claude Sonnet 5.5 <noreply@anthropic.com>
</commit_message>
<xml_diff>
--- a/docs/analysis/chamber-final-2026-10-01/slides/chamber-slides.pptx
+++ b/docs/analysis/chamber-final-2026-10-01/slides/chamber-slides.pptx
@@ -11562,8 +11562,8 @@
         </p:blipFill>
         <p:spPr>
           <a:xfrm>
-            <a:off x="457200" y="411480"/>
-            <a:ext cx="5806440" cy="5806440"/>
+            <a:off x="411480" y="411480"/>
+            <a:ext cx="5824728" cy="5806440"/>
           </a:xfrm>
           <a:prstGeom prst="rect">
             <a:avLst/>
@@ -12235,7 +12235,7 @@
                 <a:ea typeface="Calibri" pitchFamily="34" charset="-122"/>
                 <a:cs typeface="Calibri" pitchFamily="34" charset="-120"/>
               </a:rPr>
-              <a:t>At −90°, in the outflow, all five meet at 94–98 dB. Every lined set-up reads 4.5–6.4 dB higher on average than the naked one.</a:t>
+              <a:t>At −90°, in the outflow (off the scale on the plot), all five meet at 94–98 dB. Every lined set-up reads 4.5–6.4 dB higher on average than the naked one.</a:t>
             </a:r>
             <a:endParaRPr lang="en-US" sz="1400" dirty="0"/>
           </a:p>

</xml_diff>

<commit_message>
Slides: material polar scale 69-84 dB, spike out of sight and marked
Co-Authored-By: Claude Sonnet 5.5 <noreply@anthropic.com>
</commit_message>
<xml_diff>
--- a/docs/analysis/chamber-final-2026-10-01/slides/chamber-slides.pptx
+++ b/docs/analysis/chamber-final-2026-10-01/slides/chamber-slides.pptx
@@ -11563,7 +11563,7 @@
         <p:spPr>
           <a:xfrm>
             <a:off x="411480" y="411480"/>
-            <a:ext cx="5824728" cy="5806440"/>
+            <a:ext cx="5769864" cy="5806440"/>
           </a:xfrm>
           <a:prstGeom prst="rect">
             <a:avLst/>
@@ -12274,7 +12274,7 @@
                 <a:ea typeface="Calibri" pitchFamily="34" charset="-122"/>
                 <a:cs typeface="Calibri" pitchFamily="34" charset="-120"/>
               </a:rPr>
-              <a:t>2 Oct 2026, 5-inch 3-blade propeller, total level 100 Hz–10 kHz, motor at 2000 µs, corrected microphone files.</a:t>
+              <a:t>2 Oct 2026, 5-inch 3-blade propeller, total level 100 Hz–10 kHz, motor at 2000 µs, corrected microphone files. Radial axis 69–84 dB.</a:t>
             </a:r>
             <a:endParaRPr lang="en-US" sz="1100" dirty="0"/>
           </a:p>

</xml_diff>

<commit_message>
Slides: material polar scale eased to 65-90 dB
Co-Authored-By: Claude Sonnet 5.5 <noreply@anthropic.com>
</commit_message>
<xml_diff>
--- a/docs/analysis/chamber-final-2026-10-01/slides/chamber-slides.pptx
+++ b/docs/analysis/chamber-final-2026-10-01/slides/chamber-slides.pptx
@@ -11563,7 +11563,7 @@
         <p:spPr>
           <a:xfrm>
             <a:off x="411480" y="411480"/>
-            <a:ext cx="5769864" cy="5806440"/>
+            <a:ext cx="5824728" cy="5806440"/>
           </a:xfrm>
           <a:prstGeom prst="rect">
             <a:avLst/>
@@ -12274,7 +12274,7 @@
                 <a:ea typeface="Calibri" pitchFamily="34" charset="-122"/>
                 <a:cs typeface="Calibri" pitchFamily="34" charset="-120"/>
               </a:rPr>
-              <a:t>2 Oct 2026, 5-inch 3-blade propeller, total level 100 Hz–10 kHz, motor at 2000 µs, corrected microphone files. Radial axis 69–84 dB.</a:t>
+              <a:t>2 Oct 2026, 5-inch 3-blade propeller, total level 100 Hz–10 kHz, motor at 2000 µs, corrected microphone files. Radial axis 65–90 dB.</a:t>
             </a:r>
             <a:endParaRPr lang="en-US" sz="1100" dirty="0"/>
           </a:p>

</xml_diff>

<commit_message>
Slides: slide 7 gets a large red +4.5 to +6.4 dB callout
Co-Authored-By: Claude Sonnet 5.5 <noreply@anthropic.com>
</commit_message>
<xml_diff>
--- a/docs/analysis/chamber-final-2026-10-01/slides/chamber-slides.pptx
+++ b/docs/analysis/chamber-final-2026-10-01/slides/chamber-slides.pptx
@@ -11695,7 +11695,7 @@
         </p:nvSpPr>
         <p:spPr>
           <a:xfrm>
-            <a:off x="6949440" y="2761488"/>
+            <a:off x="6949440" y="2715768"/>
             <a:ext cx="237744" cy="237744"/>
           </a:xfrm>
           <a:prstGeom prst="ellipse">
@@ -11720,7 +11720,7 @@
         </p:nvSpPr>
         <p:spPr>
           <a:xfrm>
-            <a:off x="7360920" y="2697480"/>
+            <a:off x="7360920" y="2651760"/>
             <a:ext cx="2377440" cy="365760"/>
           </a:xfrm>
           <a:prstGeom prst="rect">
@@ -11759,7 +11759,7 @@
         </p:nvSpPr>
         <p:spPr>
           <a:xfrm>
-            <a:off x="9692640" y="2697480"/>
+            <a:off x="9692640" y="2651760"/>
             <a:ext cx="2011680" cy="365760"/>
           </a:xfrm>
           <a:prstGeom prst="rect">
@@ -11798,7 +11798,7 @@
         </p:nvSpPr>
         <p:spPr>
           <a:xfrm>
-            <a:off x="6949440" y="3218688"/>
+            <a:off x="6949440" y="3136392"/>
             <a:ext cx="237744" cy="237744"/>
           </a:xfrm>
           <a:prstGeom prst="ellipse">
@@ -11823,7 +11823,7 @@
         </p:nvSpPr>
         <p:spPr>
           <a:xfrm>
-            <a:off x="7360920" y="3154680"/>
+            <a:off x="7360920" y="3072384"/>
             <a:ext cx="2377440" cy="365760"/>
           </a:xfrm>
           <a:prstGeom prst="rect">
@@ -11862,7 +11862,7 @@
         </p:nvSpPr>
         <p:spPr>
           <a:xfrm>
-            <a:off x="9692640" y="3154680"/>
+            <a:off x="9692640" y="3072384"/>
             <a:ext cx="2011680" cy="365760"/>
           </a:xfrm>
           <a:prstGeom prst="rect">
@@ -11901,7 +11901,7 @@
         </p:nvSpPr>
         <p:spPr>
           <a:xfrm>
-            <a:off x="6949440" y="3675888"/>
+            <a:off x="6949440" y="3557016"/>
             <a:ext cx="237744" cy="237744"/>
           </a:xfrm>
           <a:prstGeom prst="ellipse">
@@ -11926,7 +11926,7 @@
         </p:nvSpPr>
         <p:spPr>
           <a:xfrm>
-            <a:off x="7360920" y="3611880"/>
+            <a:off x="7360920" y="3493008"/>
             <a:ext cx="2377440" cy="365760"/>
           </a:xfrm>
           <a:prstGeom prst="rect">
@@ -11965,7 +11965,7 @@
         </p:nvSpPr>
         <p:spPr>
           <a:xfrm>
-            <a:off x="9692640" y="3611880"/>
+            <a:off x="9692640" y="3493008"/>
             <a:ext cx="2011680" cy="365760"/>
           </a:xfrm>
           <a:prstGeom prst="rect">
@@ -12004,7 +12004,7 @@
         </p:nvSpPr>
         <p:spPr>
           <a:xfrm>
-            <a:off x="6949440" y="4133088"/>
+            <a:off x="6949440" y="3977640"/>
             <a:ext cx="237744" cy="237744"/>
           </a:xfrm>
           <a:prstGeom prst="ellipse">
@@ -12029,7 +12029,7 @@
         </p:nvSpPr>
         <p:spPr>
           <a:xfrm>
-            <a:off x="7360920" y="4069080"/>
+            <a:off x="7360920" y="3913632"/>
             <a:ext cx="2377440" cy="365760"/>
           </a:xfrm>
           <a:prstGeom prst="rect">
@@ -12068,7 +12068,7 @@
         </p:nvSpPr>
         <p:spPr>
           <a:xfrm>
-            <a:off x="9692640" y="4069080"/>
+            <a:off x="9692640" y="3913632"/>
             <a:ext cx="2011680" cy="365760"/>
           </a:xfrm>
           <a:prstGeom prst="rect">
@@ -12107,7 +12107,7 @@
         </p:nvSpPr>
         <p:spPr>
           <a:xfrm>
-            <a:off x="6949440" y="4590288"/>
+            <a:off x="6949440" y="4398264"/>
             <a:ext cx="237744" cy="237744"/>
           </a:xfrm>
           <a:prstGeom prst="ellipse">
@@ -12132,7 +12132,7 @@
         </p:nvSpPr>
         <p:spPr>
           <a:xfrm>
-            <a:off x="7360920" y="4526280"/>
+            <a:off x="7360920" y="4334256"/>
             <a:ext cx="2377440" cy="365760"/>
           </a:xfrm>
           <a:prstGeom prst="rect">
@@ -12171,7 +12171,7 @@
         </p:nvSpPr>
         <p:spPr>
           <a:xfrm>
-            <a:off x="9692640" y="4526280"/>
+            <a:off x="9692640" y="4334256"/>
             <a:ext cx="2011680" cy="365760"/>
           </a:xfrm>
           <a:prstGeom prst="rect">
@@ -12210,8 +12210,8 @@
         </p:nvSpPr>
         <p:spPr>
           <a:xfrm>
-            <a:off x="6949440" y="5120640"/>
-            <a:ext cx="4754880" cy="914400"/>
+            <a:off x="6949440" y="4846320"/>
+            <a:ext cx="4754880" cy="731520"/>
           </a:xfrm>
           <a:prstGeom prst="rect">
             <a:avLst/>
@@ -12220,7 +12220,46 @@
           <a:ln/>
         </p:spPr>
         <p:txBody>
-          <a:bodyPr wrap="square" lIns="0" tIns="0" rIns="0" bIns="0" rtlCol="0" anchor="t"/>
+          <a:bodyPr wrap="square" lIns="0" tIns="0" rIns="0" bIns="0" rtlCol="0" anchor="ctr"/>
+          <a:lstStyle/>
+          <a:p>
+            <a:pPr indent="0" marL="0">
+              <a:buNone/>
+            </a:pPr>
+            <a:r>
+              <a:rPr lang="en-US" sz="4000" b="1" dirty="0">
+                <a:solidFill>
+                  <a:srgbClr val="D6336C"/>
+                </a:solidFill>
+                <a:latin typeface="Cambria" pitchFamily="34" charset="0"/>
+                <a:ea typeface="Cambria" pitchFamily="34" charset="-122"/>
+                <a:cs typeface="Cambria" pitchFamily="34" charset="-120"/>
+              </a:rPr>
+              <a:t>+4.5 to +6.4 dB</a:t>
+            </a:r>
+            <a:endParaRPr lang="en-US" sz="4000" dirty="0"/>
+          </a:p>
+        </p:txBody>
+      </p:sp>
+      <p:sp>
+        <p:nvSpPr>
+          <p:cNvPr id="22" name="Text 19"/>
+          <p:cNvSpPr txBox="1"/>
+          <p:nvPr/>
+        </p:nvSpPr>
+        <p:spPr>
+          <a:xfrm>
+            <a:off x="6949440" y="5559552"/>
+            <a:ext cx="4754880" cy="320040"/>
+          </a:xfrm>
+          <a:prstGeom prst="rect">
+            <a:avLst/>
+          </a:prstGeom>
+          <a:noFill/>
+          <a:ln/>
+        </p:spPr>
+        <p:txBody>
+          <a:bodyPr wrap="square" lIns="0" tIns="0" rIns="0" bIns="0" rtlCol="0" anchor="ctr"/>
           <a:lstStyle/>
           <a:p>
             <a:pPr indent="0" marL="0">
@@ -12235,7 +12274,7 @@
                 <a:ea typeface="Calibri" pitchFamily="34" charset="-122"/>
                 <a:cs typeface="Calibri" pitchFamily="34" charset="-120"/>
               </a:rPr>
-              <a:t>At −90°, in the outflow (off the scale on the plot), all five meet at 94–98 dB. Every lined set-up reads 4.5–6.4 dB higher on average than the naked one.</a:t>
+              <a:t>louder than naked, on average</a:t>
             </a:r>
             <a:endParaRPr lang="en-US" sz="1400" dirty="0"/>
           </a:p>
@@ -12243,7 +12282,46 @@
       </p:sp>
       <p:sp>
         <p:nvSpPr>
-          <p:cNvPr id="22" name="Text 19"/>
+          <p:cNvPr id="23" name="Text 20"/>
+          <p:cNvSpPr txBox="1"/>
+          <p:nvPr/>
+        </p:nvSpPr>
+        <p:spPr>
+          <a:xfrm>
+            <a:off x="6949440" y="5897880"/>
+            <a:ext cx="4754880" cy="274320"/>
+          </a:xfrm>
+          <a:prstGeom prst="rect">
+            <a:avLst/>
+          </a:prstGeom>
+          <a:noFill/>
+          <a:ln/>
+        </p:spPr>
+        <p:txBody>
+          <a:bodyPr wrap="square" lIns="0" tIns="0" rIns="0" bIns="0" rtlCol="0" anchor="ctr"/>
+          <a:lstStyle/>
+          <a:p>
+            <a:pPr indent="0" marL="0">
+              <a:buNone/>
+            </a:pPr>
+            <a:r>
+              <a:rPr lang="en-US" sz="1200" dirty="0">
+                <a:solidFill>
+                  <a:srgbClr val="5B6578"/>
+                </a:solidFill>
+                <a:latin typeface="Calibri" pitchFamily="34" charset="0"/>
+                <a:ea typeface="Calibri" pitchFamily="34" charset="-122"/>
+                <a:cs typeface="Calibri" pitchFamily="34" charset="-120"/>
+              </a:rPr>
+              <a:t>At −90°, in the outflow (off the plot), all five meet at 94–98 dB.</a:t>
+            </a:r>
+            <a:endParaRPr lang="en-US" sz="1200" dirty="0"/>
+          </a:p>
+        </p:txBody>
+      </p:sp>
+      <p:sp>
+        <p:nvSpPr>
+          <p:cNvPr id="24" name="Text 21"/>
           <p:cNvSpPr txBox="1"/>
           <p:nvPr/>
         </p:nvSpPr>
@@ -12282,7 +12360,7 @@
       </p:sp>
       <p:sp>
         <p:nvSpPr>
-          <p:cNvPr id="23" name="Text 20"/>
+          <p:cNvPr id="25" name="Text 22"/>
           <p:cNvSpPr txBox="1"/>
           <p:nvPr/>
         </p:nvSpPr>

</xml_diff>

<commit_message>
Slides: new intro slide with the chamber photo; the other slides are numbered 2 to 8
Co-Authored-By: Claude Sonnet 5.5 <noreply@anthropic.com>
</commit_message>
<xml_diff>
--- a/docs/analysis/chamber-final-2026-10-01/slides/chamber-slides.pptx
+++ b/docs/analysis/chamber-final-2026-10-01/slides/chamber-slides.pptx
@@ -12,9 +12,10 @@
     <p:sldId id="260" r:id="rId6"/>
     <p:sldId id="261" r:id="rId7"/>
     <p:sldId id="262" r:id="rId8"/>
+    <p:sldId id="263" r:id="rId9"/>
   </p:sldIdLst>
   <p:notesMasterIdLst>
-    <p:notesMasterId r:id="rId9"/>
+    <p:notesMasterId r:id="rId10"/>
   </p:notesMasterIdLst>
   <p:sldSz cx="12192000" cy="6858000"/>
   <p:notesSz cx="6858000" cy="12192000"/>
@@ -919,7 +920,7 @@
           <a:p>
             <a:r>
               <a:rPr lang="en-US" dirty="0"/>
-              <a:t>Data: the 31 Aug 2026 horizontal baseline (arc laid flat, propeller axis vertical), propeller at PWM 2000, total level 20-560 Hz per microphone, read with the factory calibration files as it was measured. Rms spread about the mean 2.05 dB, range 6.7 dB (63.9 to 70.6 dB SPL). The radial axis is 30-76 dB, the same as the report polars, so the same red curve can be shown against the 30 Sep measurement on a later slide. On a 0-80 dB axis the same curve looks rounder.</a:t>
+              <a:t>Intro slide. The photo (komora_05_10_26.jpg) shows the chamber in the final configuration (carpet-reordered): the microphone ring laid flat around the propeller rig at the hub, the loudspeaker tripod on the left, batting on the floor and ceiling, wedges and lined pillars on the walls. Ring diameter 1.68 m (radius 0.84 m), eleven UMIK-2 microphones.</a:t>
             </a:r>
             <a:endParaRPr lang="en-US" dirty="0"/>
           </a:p>
@@ -1007,7 +1008,7 @@
           <a:p>
             <a:r>
               <a:rPr lang="en-US" dirty="0"/>
-              <a:t>Procedure (calibrator/session.py, 2026-09-16 session): each of the eleven UMIK-2 capsules was plugged in at the same mounting point in front of the loudspeaker and measured over 97 stepped tones, 62 Hz to 16 kHz (about 12 per octave), amplitude 0.03, 48 kHz sampling, 0.7 s settle and 2 s capture per tone (6 s below 250 Hz). Capsule 810-8904 was measured three full times (18:21, 18:30, 20:43) as the reference. The difference of each capsule from the reference was folded into its calibration curve; Sens Factors kept as in the factory files. The datum is the mean of four capsules whose factory files agree with measurement (810-8900, 810-8903, 811-1896, 811-2321). Spread 4.01 to 0.02 dB and 7 of 11 files wrong by 0.6-3.6 dB are from the project notes. Seven capsules had a mean offset beyond 0.6 dB (811-1892 -2.6, 811-1897 -1.4, 811-2310 -0.8, 810-8897 +0.8, 810-8901 +0.8, 810-8904 +0.9, 810-8893 +1.3). Absolute level is not anchored: that needs a 94 dB calibrator.</a:t>
+              <a:t>Data: the 31 Aug 2026 horizontal baseline (arc laid flat, propeller axis vertical), propeller at PWM 2000, total level 20-560 Hz per microphone, read with the factory calibration files as it was measured. Rms spread about the mean 2.05 dB, range 6.7 dB (63.9 to 70.6 dB SPL). The radial axis is 30-76 dB, the same as the report polars, so the same red curve can be shown against the 30 Sep measurement on a later slide. On a 0-80 dB axis the same curve looks rounder.</a:t>
             </a:r>
             <a:endParaRPr lang="en-US" dirty="0"/>
           </a:p>
@@ -1095,7 +1096,7 @@
           <a:p>
             <a:r>
               <a:rPr lang="en-US" dirty="0"/>
-              <a:t>Same figure as chapter 1 of the report, redrawn larger. The same two captures were calibrated two ways: with the factory files and with the corrections measured on 16 Sep. The span is the range of the capsules mean levels: 4.3 to 0.8 dB at the start of day 3, 4.1 to 1.0 dB in the final configuration. Room error below 3 kHz: 2.277 to 1.997 dB and 1.736 to 1.387 dB. The change is mainly a per-capsule offset, so it mainly moves whole rows.</a:t>
+              <a:t>Procedure (calibrator/session.py, 2026-09-16 session): each of the eleven UMIK-2 capsules was plugged in at the same mounting point in front of the loudspeaker and measured over 97 stepped tones, 62 Hz to 16 kHz (about 12 per octave), amplitude 0.03, 48 kHz sampling, 0.7 s settle and 2 s capture per tone (6 s below 250 Hz). Capsule 810-8904 was measured three full times (18:21, 18:30, 20:43) as the reference. The difference of each capsule from the reference was folded into its calibration curve; Sens Factors kept as in the factory files. The datum is the mean of four capsules whose factory files agree with measurement (810-8900, 810-8903, 811-1896, 811-2321). Spread 4.01 to 0.02 dB and 7 of 11 files wrong by 0.6-3.6 dB are from the project notes. Seven capsules had a mean offset beyond 0.6 dB (811-1892 -2.6, 811-1897 -1.4, 811-2310 -0.8, 810-8897 +0.8, 810-8901 +0.8, 810-8904 +0.9, 810-8893 +1.3). Absolute level is not anchored: that needs a 94 dB calibrator.</a:t>
             </a:r>
             <a:endParaRPr lang="en-US" dirty="0"/>
           </a:p>
@@ -1183,7 +1184,7 @@
           <a:p>
             <a:r>
               <a:rPr lang="en-US" dirty="0"/>
-              <a:t>Same pair as page 3 of the report (day3-a at 13:17, carpet-reordered at 19:15, both 25 Sep), read with the corrected microphone files. Room error is the rms deviation of the eleven microphones from their mean, per band. Below 630 Hz the rms room error fell from 2.98 to 1.78 dB (1.2 dB, 40 %); between 1 and 3 kHz it went 0.84 to 0.91 dB. Start of day 3: 3.33, 2.57, 1.57, 0.80, 0.87, 1.04 dB; final: 1.99, 1.52, 1.47, 0.85, 0.96, 1.17 dB for the bands 250-400, 400-630, 630-1000, 1000-1600, 1600-3000 and 5000-6400 Hz. Caveat from the report: the loudspeaker was moved on purpose during the day (20 cm closer, into the ring plane, 5 cm back) and then returned to about its starting mounting point, which was not recorded. The tilt of the map changed from -0.41 to -0.63 and the mean level rose 1.16 dB, so the gain is the treatments plus a small unknown difference in source position, and part of it may be the louder direct sound. The clean pair with an unmoved source is 24 Sep: empty floor 2.054 to carpet 1.317 dB.</a:t>
+              <a:t>Same figure as chapter 1 of the report, redrawn larger. The same two captures were calibrated two ways: with the factory files and with the corrections measured on 16 Sep. The span is the range of the capsules mean levels: 4.3 to 0.8 dB at the start of day 3, 4.1 to 1.0 dB in the final configuration. Room error below 3 kHz: 2.277 to 1.997 dB and 1.736 to 1.387 dB. The change is mainly a per-capsule offset, so it mainly moves whole rows.</a:t>
             </a:r>
             <a:endParaRPr lang="en-US" dirty="0"/>
           </a:p>
@@ -1271,7 +1272,7 @@
           <a:p>
             <a:r>
               <a:rPr lang="en-US" dirty="0"/>
-              <a:t>Same table as page 4 of the report. Each one-third-octave band is judged against the anechoic tolerance values of ISO 5305 Table 1 (also ISO 3745 as printed by Cunefare 2003): +-1.5 dB for 125-630 Hz, +-1.0 dB for 800-5000 Hz. The number is the worst microphone band-mean deviation from the arc mean, in dB; the colour is that number as a share of the limit. Cells in limit counts tone x microphone cells inside the limit (3 tones x 11 microphones = 33 cells at 250 Hz, where the grid starts at 257 Hz). This is an analogue: the standards use a traverse and test decay with distance, we use eleven fixed microphones at one radius. The room is treated and not qualified. Within the tolerance values from 1250 Hz at the start of day 3 and from 2000 Hz in the final state, up to 2500 Hz. The rows marked * (5000 and 6300 Hz) are partial: 4 and 5 tones above 5 kHz, the limit is +-1.0 dB at 5000 Hz and +-1.5 dB at 6300 Hz (ISO 5305 Table 1). Both are over the limit in both states (1.24 and 1.23 dB; 1.59 and 1.77 dB). The 3150 and 4000 Hz bands are not shown: no tones between 3 and 5 kHz because of the rocking mode of the sphere at about 4.4 kHz. Caveat: the loudspeaker position was not documented across the day.</a:t>
+              <a:t>Same pair as page 3 of the report (day3-a at 13:17, carpet-reordered at 19:15, both 25 Sep), read with the corrected microphone files. Room error is the rms deviation of the eleven microphones from their mean, per band. Below 630 Hz the rms room error fell from 2.98 to 1.78 dB (1.2 dB, 40 %); between 1 and 3 kHz it went 0.84 to 0.91 dB. Start of day 3: 3.33, 2.57, 1.57, 0.80, 0.87, 1.04 dB; final: 1.99, 1.52, 1.47, 0.85, 0.96, 1.17 dB for the bands 250-400, 400-630, 630-1000, 1000-1600, 1600-3000 and 5000-6400 Hz. Caveat from the report: the loudspeaker was moved on purpose during the day (20 cm closer, into the ring plane, 5 cm back) and then returned to about its starting mounting point, which was not recorded. The tilt of the map changed from -0.41 to -0.63 and the mean level rose 1.16 dB, so the gain is the treatments plus a small unknown difference in source position, and part of it may be the louder direct sound. The clean pair with an unmoved source is 24 Sep: empty floor 2.054 to carpet 1.317 dB.</a:t>
             </a:r>
             <a:endParaRPr lang="en-US" dirty="0"/>
           </a:p>
@@ -1359,7 +1360,7 @@
           <a:p>
             <a:r>
               <a:rPr lang="en-US" dirty="0"/>
-              <a:t>Blue: 30 Sep propeller measurement (11.7 V, 7.3 A, thrust -4 N), read with the 16 Sep microphone corrections. Rms spread about the mean 1.45 dB against 2.05 dB for 31 Aug; range 4.0 dB (55.5 to 59.6 dB SPL) against 6.7 dB. The blue is about 11 dB lower because the motor ran at a different operating point. The 4 dB range of the blue is a bottom-louder trend. Honest caveat: with the same calibration applied to the 1-2 Sep runs, those are about as round as 30 Sep, so most of the improvement against the earlier baselines comes from the microphone calibration, not the room.</a:t>
+              <a:t>Same table as page 4 of the report. Each one-third-octave band is judged against the anechoic tolerance values of ISO 5305 Table 1 (also ISO 3745 as printed by Cunefare 2003): +-1.5 dB for 125-630 Hz, +-1.0 dB for 800-5000 Hz. The number is the worst microphone band-mean deviation from the arc mean, in dB; the colour is that number as a share of the limit. Cells in limit counts tone x microphone cells inside the limit (3 tones x 11 microphones = 33 cells at 250 Hz, where the grid starts at 257 Hz). This is an analogue: the standards use a traverse and test decay with distance, we use eleven fixed microphones at one radius. The room is treated and not qualified. Within the tolerance values from 1250 Hz at the start of day 3 and from 2000 Hz in the final state, up to 2500 Hz. The rows marked * (5000 and 6300 Hz) are partial: 4 and 5 tones above 5 kHz, the limit is +-1.0 dB at 5000 Hz and +-1.5 dB at 6300 Hz (ISO 5305 Table 1). Both are over the limit in both states (1.24 and 1.23 dB; 1.59 and 1.77 dB). The 3150 and 4000 Hz bands are not shown: no tones between 3 and 5 kHz because of the rocking mode of the sphere at about 4.4 kHz. Caveat: the loudspeaker position was not documented across the day.</a:t>
             </a:r>
             <a:endParaRPr lang="en-US" dirty="0"/>
           </a:p>
@@ -1447,6 +1448,94 @@
           <a:p>
             <a:r>
               <a:rPr lang="en-US" dirty="0"/>
+              <a:t>Blue: 30 Sep propeller measurement (11.7 V, 7.3 A, thrust -4 N), read with the 16 Sep microphone corrections. Rms spread about the mean 1.45 dB against 2.05 dB for 31 Aug; range 4.0 dB (55.5 to 59.6 dB SPL) against 6.7 dB. The blue is about 11 dB lower because the motor ran at a different operating point. The 4 dB range of the blue is a bottom-louder trend. Honest caveat: with the same calibration applied to the 1-2 Sep runs, those are about as round as 30 Sep, so most of the improvement against the earlier baselines comes from the microphone calibration, not the room.</a:t>
+            </a:r>
+            <a:endParaRPr lang="en-US" dirty="0"/>
+          </a:p>
+        </p:txBody>
+      </p:sp>
+      <p:sp>
+        <p:nvSpPr>
+          <p:cNvPr id="4" name="Slide Number Placeholder 3"/>
+          <p:cNvSpPr>
+            <a:spLocks noGrp="1"/>
+          </p:cNvSpPr>
+          <p:nvPr>
+            <p:ph type="sldNum" sz="quarter" idx="10"/>
+          </p:nvPr>
+        </p:nvSpPr>
+        <p:spPr/>
+        <p:txBody>
+          <a:bodyPr/>
+          <a:lstStyle/>
+          <a:p>
+            <a:fld id="{F7021451-1387-4CA6-816F-3879F97B5CBC}" type="slidenum">
+              <a:rPr lang="en-US"/>
+              <a:t>7</a:t>
+            </a:fld>
+            <a:endParaRPr lang="en-US"/>
+          </a:p>
+        </p:txBody>
+      </p:sp>
+    </p:spTree>
+    <p:extLst>
+      <p:ext uri="{BB962C8B-B14F-4D97-AF65-F5344CB8AC3E}">
+        <p14:creationId xmlns:p14="http://schemas.microsoft.com/office/powerpoint/2010/main" val="1024086991"/>
+      </p:ext>
+    </p:extLst>
+  </p:cSld>
+  <p:clrMapOvr>
+    <a:masterClrMapping/>
+  </p:clrMapOvr>
+</p:notes>
+</file>
+
+<file path=ppt/notesSlides/notesSlide8.xml><?xml version="1.0" encoding="utf-8"?>
+<p:notes xmlns:a="http://schemas.openxmlformats.org/drawingml/2006/main" xmlns:r="http://schemas.openxmlformats.org/officeDocument/2006/relationships" xmlns:p="http://schemas.openxmlformats.org/presentationml/2006/main">
+  <p:cSld>
+    <p:spTree>
+      <p:nvGrpSpPr>
+        <p:cNvPr id="1" name=""/>
+        <p:cNvGrpSpPr/>
+        <p:nvPr/>
+      </p:nvGrpSpPr>
+      <p:grpSpPr>
+        <a:xfrm>
+          <a:off x="0" y="0"/>
+          <a:ext cx="0" cy="0"/>
+          <a:chOff x="0" y="0"/>
+          <a:chExt cx="0" cy="0"/>
+        </a:xfrm>
+      </p:grpSpPr>
+      <p:sp>
+        <p:nvSpPr>
+          <p:cNvPr id="2" name="Slide Image Placeholder 1"/>
+          <p:cNvSpPr>
+            <a:spLocks noGrp="1" noRot="1" noChangeAspect="1"/>
+          </p:cNvSpPr>
+          <p:nvPr>
+            <p:ph type="sldImg"/>
+          </p:nvPr>
+        </p:nvSpPr>
+        <p:spPr/>
+      </p:sp>
+      <p:sp>
+        <p:nvSpPr>
+          <p:cNvPr id="3" name="Notes Placeholder 2"/>
+          <p:cNvSpPr>
+            <a:spLocks noGrp="1"/>
+          </p:cNvSpPr>
+          <p:nvPr>
+            <p:ph type="body" idx="1"/>
+          </p:nvPr>
+        </p:nvSpPr>
+        <p:spPr/>
+        <p:txBody>
+          <a:bodyPr/>
+          <a:lstStyle/>
+          <a:p>
+            <a:r>
+              <a:rPr lang="en-US" dirty="0"/>
               <a:t>Bases of 2 Oct 2026 in the data repo: 2004__5in3b__unset__v1-naked-horizontal, ...cork__v1-cork-horizontal, ...rubber__v1-rubber, ...felt__v1-felt, ...felt-rubber__v1-felt-rubber. Each capture is the PWM 2000 step; level per microphone is the total level 100 Hz to 10 kHz in dB SPL, read with the corrected microphone files (all after 16 Sep). The polar is mirrored to 360 degrees. Mean over the eleven positions: naked 74.2, cork 78.7, rubber 80.6, felt 79.5, felt plus rubber 78.7 dB. At -90 degrees (the outflow) all five are 93.7 to 98.3 dB. The slide shows levels as measured; operating points (voltage, thrust) were not compared here.</a:t>
             </a:r>
             <a:endParaRPr lang="en-US" dirty="0"/>
@@ -1470,7 +1559,7 @@
           <a:p>
             <a:fld id="{F7021451-1387-4CA6-816F-3879F97B5CBC}" type="slidenum">
               <a:rPr lang="en-US"/>
-              <a:t>7</a:t>
+              <a:t>8</a:t>
             </a:fld>
             <a:endParaRPr lang="en-US"/>
           </a:p>
@@ -1799,6 +1888,217 @@
 <file path=ppt/slides/slide1.xml><?xml version="1.0" encoding="utf-8"?>
 <p:sld xmlns:a="http://schemas.openxmlformats.org/drawingml/2006/main" xmlns:r="http://schemas.openxmlformats.org/officeDocument/2006/relationships" xmlns:p="http://schemas.openxmlformats.org/presentationml/2006/main">
   <p:cSld name="Slide 1">
+    <p:bg>
+      <p:bgPr>
+        <a:solidFill>
+          <a:srgbClr val="1F2A44"/>
+        </a:solidFill>
+      </p:bgPr>
+    </p:bg>
+    <p:spTree>
+      <p:nvGrpSpPr>
+        <p:cNvPr id="1" name=""/>
+        <p:cNvGrpSpPr/>
+        <p:nvPr/>
+      </p:nvGrpSpPr>
+      <p:grpSpPr>
+        <a:xfrm>
+          <a:off x="0" y="0"/>
+          <a:ext cx="0" cy="0"/>
+          <a:chOff x="0" y="0"/>
+          <a:chExt cx="0" cy="0"/>
+        </a:xfrm>
+      </p:grpSpPr>
+      <p:pic>
+        <p:nvPicPr>
+          <p:cNvPr id="2" name="Image 0" descr="The chamber in its current set-up: the microphone ring laid flat around the propeller rig, speaker tripod on the left, absorbing material on floor, ceiling and walls">    </p:cNvPr>
+          <p:cNvPicPr>
+            <a:picLocks noChangeAspect="1"/>
+          </p:cNvPicPr>
+          <p:nvPr/>
+        </p:nvPicPr>
+        <p:blipFill>
+          <a:blip r:embed="rId1"/>
+          <a:srcRect l="0" r="0" t="0" b="0"/>
+          <a:stretch/>
+        </p:blipFill>
+        <p:spPr>
+          <a:xfrm>
+            <a:off x="0" y="0"/>
+            <a:ext cx="5166360" cy="6858000"/>
+          </a:xfrm>
+          <a:prstGeom prst="rect">
+            <a:avLst/>
+          </a:prstGeom>
+        </p:spPr>
+      </p:pic>
+      <p:sp>
+        <p:nvSpPr>
+          <p:cNvPr id="3" name="Text 0"/>
+          <p:cNvSpPr txBox="1"/>
+          <p:nvPr/>
+        </p:nvSpPr>
+        <p:spPr>
+          <a:xfrm>
+            <a:off x="5760720" y="1554480"/>
+            <a:ext cx="5943600" cy="365760"/>
+          </a:xfrm>
+          <a:prstGeom prst="rect">
+            <a:avLst/>
+          </a:prstGeom>
+          <a:noFill/>
+          <a:ln/>
+        </p:spPr>
+        <p:txBody>
+          <a:bodyPr wrap="square" lIns="0" tIns="0" rIns="0" bIns="0" rtlCol="0" anchor="ctr"/>
+          <a:lstStyle/>
+          <a:p>
+            <a:pPr indent="0" marL="0">
+              <a:buNone/>
+            </a:pPr>
+            <a:r>
+              <a:rPr lang="en-US" sz="1400" b="1" spc="300" kern="0" dirty="0">
+                <a:solidFill>
+                  <a:srgbClr val="AFC3E3"/>
+                </a:solidFill>
+                <a:latin typeface="Calibri" pitchFamily="34" charset="0"/>
+                <a:ea typeface="Calibri" pitchFamily="34" charset="-122"/>
+                <a:cs typeface="Calibri" pitchFamily="34" charset="-120"/>
+              </a:rPr>
+              <a:t>CHAMBER MEASUREMENTS</a:t>
+            </a:r>
+            <a:endParaRPr lang="en-US" sz="1400" dirty="0"/>
+          </a:p>
+        </p:txBody>
+      </p:sp>
+      <p:sp>
+        <p:nvSpPr>
+          <p:cNvPr id="4" name="Text 1"/>
+          <p:cNvSpPr txBox="1"/>
+          <p:nvPr/>
+        </p:nvSpPr>
+        <p:spPr>
+          <a:xfrm>
+            <a:off x="5760720" y="1965960"/>
+            <a:ext cx="5943600" cy="1554480"/>
+          </a:xfrm>
+          <a:prstGeom prst="rect">
+            <a:avLst/>
+          </a:prstGeom>
+          <a:noFill/>
+          <a:ln/>
+        </p:spPr>
+        <p:txBody>
+          <a:bodyPr wrap="square" lIns="0" tIns="0" rIns="0" bIns="0" rtlCol="0" anchor="t"/>
+          <a:lstStyle/>
+          <a:p>
+            <a:pPr indent="0" marL="0">
+              <a:buNone/>
+            </a:pPr>
+            <a:r>
+              <a:rPr lang="en-US" sz="3800" b="1" dirty="0">
+                <a:solidFill>
+                  <a:srgbClr val="FFFFFF"/>
+                </a:solidFill>
+                <a:latin typeface="Cambria" pitchFamily="34" charset="0"/>
+                <a:ea typeface="Cambria" pitchFamily="34" charset="-122"/>
+                <a:cs typeface="Cambria" pitchFamily="34" charset="-120"/>
+              </a:rPr>
+              <a:t>Measuring a propeller in our chamber</a:t>
+            </a:r>
+            <a:endParaRPr lang="en-US" sz="3800" dirty="0"/>
+          </a:p>
+        </p:txBody>
+      </p:sp>
+      <p:sp>
+        <p:nvSpPr>
+          <p:cNvPr id="5" name="Text 2"/>
+          <p:cNvSpPr txBox="1"/>
+          <p:nvPr/>
+        </p:nvSpPr>
+        <p:spPr>
+          <a:xfrm>
+            <a:off x="5760720" y="3931920"/>
+            <a:ext cx="5669280" cy="1188720"/>
+          </a:xfrm>
+          <a:prstGeom prst="rect">
+            <a:avLst/>
+          </a:prstGeom>
+          <a:noFill/>
+          <a:ln/>
+        </p:spPr>
+        <p:txBody>
+          <a:bodyPr wrap="square" lIns="0" tIns="0" rIns="0" bIns="0" rtlCol="0" anchor="t"/>
+          <a:lstStyle/>
+          <a:p>
+            <a:pPr indent="0" marL="0">
+              <a:buNone/>
+            </a:pPr>
+            <a:r>
+              <a:rPr lang="en-US" sz="1800" dirty="0">
+                <a:solidFill>
+                  <a:srgbClr val="E3E9F4"/>
+                </a:solidFill>
+                <a:latin typeface="Calibri" pitchFamily="34" charset="0"/>
+                <a:ea typeface="Calibri" pitchFamily="34" charset="-122"/>
+                <a:cs typeface="Calibri" pitchFamily="34" charset="-120"/>
+              </a:rPr>
+              <a:t>The current set-up: eleven microphones on a 1.68 m ring around the source at the hub, absorbing material on floor, ceiling and walls.</a:t>
+            </a:r>
+            <a:endParaRPr lang="en-US" sz="1800" dirty="0"/>
+          </a:p>
+        </p:txBody>
+      </p:sp>
+      <p:sp>
+        <p:nvSpPr>
+          <p:cNvPr id="6" name="Text 3"/>
+          <p:cNvSpPr txBox="1"/>
+          <p:nvPr/>
+        </p:nvSpPr>
+        <p:spPr>
+          <a:xfrm>
+            <a:off x="5760720" y="6355080"/>
+            <a:ext cx="5669280" cy="274320"/>
+          </a:xfrm>
+          <a:prstGeom prst="rect">
+            <a:avLst/>
+          </a:prstGeom>
+          <a:noFill/>
+          <a:ln/>
+        </p:spPr>
+        <p:txBody>
+          <a:bodyPr wrap="square" lIns="0" tIns="0" rIns="0" bIns="0" rtlCol="0" anchor="ctr"/>
+          <a:lstStyle/>
+          <a:p>
+            <a:pPr indent="0" marL="0">
+              <a:buNone/>
+            </a:pPr>
+            <a:r>
+              <a:rPr lang="en-US" sz="1200" dirty="0">
+                <a:solidFill>
+                  <a:srgbClr val="AFC3E3"/>
+                </a:solidFill>
+                <a:latin typeface="Calibri" pitchFamily="34" charset="0"/>
+                <a:ea typeface="Calibri" pitchFamily="34" charset="-122"/>
+                <a:cs typeface="Calibri" pitchFamily="34" charset="-120"/>
+              </a:rPr>
+              <a:t>Photo of the final configuration, 5 Oct 2026</a:t>
+            </a:r>
+            <a:endParaRPr lang="en-US" sz="1200" dirty="0"/>
+          </a:p>
+        </p:txBody>
+      </p:sp>
+    </p:spTree>
+  </p:cSld>
+  <p:clrMapOvr>
+    <a:masterClrMapping/>
+  </p:clrMapOvr>
+</p:sld>
+</file>
+
+<file path=ppt/slides/slide2.xml><?xml version="1.0" encoding="utf-8"?>
+<p:sld xmlns:a="http://schemas.openxmlformats.org/drawingml/2006/main" xmlns:r="http://schemas.openxmlformats.org/officeDocument/2006/relationships" xmlns:p="http://schemas.openxmlformats.org/presentationml/2006/main">
+  <p:cSld name="Slide 2">
     <p:bg>
       <p:bgPr>
         <a:solidFill>
@@ -2157,7 +2457,7 @@
                 <a:ea typeface="Calibri" pitchFamily="34" charset="-122"/>
                 <a:cs typeface="Calibri" pitchFamily="34" charset="-120"/>
               </a:rPr>
-              <a:t>1</a:t>
+              <a:t>2</a:t>
             </a:r>
             <a:endParaRPr lang="en-US" sz="1200" dirty="0"/>
           </a:p>
@@ -2171,9 +2471,9 @@
 </p:sld>
 </file>
 
-<file path=ppt/slides/slide2.xml><?xml version="1.0" encoding="utf-8"?>
+<file path=ppt/slides/slide3.xml><?xml version="1.0" encoding="utf-8"?>
 <p:sld xmlns:a="http://schemas.openxmlformats.org/drawingml/2006/main" xmlns:r="http://schemas.openxmlformats.org/officeDocument/2006/relationships" xmlns:p="http://schemas.openxmlformats.org/presentationml/2006/main">
-  <p:cSld name="Slide 2">
+  <p:cSld name="Slide 3">
     <p:bg>
       <p:bgPr>
         <a:solidFill>
@@ -2778,7 +3078,7 @@
                 <a:ea typeface="Calibri" pitchFamily="34" charset="-122"/>
                 <a:cs typeface="Calibri" pitchFamily="34" charset="-120"/>
               </a:rPr>
-              <a:t>2</a:t>
+              <a:t>3</a:t>
             </a:r>
             <a:endParaRPr lang="en-US" sz="1200" dirty="0"/>
           </a:p>
@@ -2792,9 +3092,9 @@
 </p:sld>
 </file>
 
-<file path=ppt/slides/slide3.xml><?xml version="1.0" encoding="utf-8"?>
+<file path=ppt/slides/slide4.xml><?xml version="1.0" encoding="utf-8"?>
 <p:sld xmlns:a="http://schemas.openxmlformats.org/drawingml/2006/main" xmlns:r="http://schemas.openxmlformats.org/officeDocument/2006/relationships" xmlns:p="http://schemas.openxmlformats.org/presentationml/2006/main">
-  <p:cSld name="Slide 3">
+  <p:cSld name="Slide 4">
     <p:bg>
       <p:bgPr>
         <a:solidFill>
@@ -3230,7 +3530,7 @@
                 <a:ea typeface="Calibri" pitchFamily="34" charset="-122"/>
                 <a:cs typeface="Calibri" pitchFamily="34" charset="-120"/>
               </a:rPr>
-              <a:t>3</a:t>
+              <a:t>4</a:t>
             </a:r>
             <a:endParaRPr lang="en-US" sz="1200" dirty="0"/>
           </a:p>
@@ -3244,9 +3544,9 @@
 </p:sld>
 </file>
 
-<file path=ppt/slides/slide4.xml><?xml version="1.0" encoding="utf-8"?>
+<file path=ppt/slides/slide5.xml><?xml version="1.0" encoding="utf-8"?>
 <p:sld xmlns:a="http://schemas.openxmlformats.org/drawingml/2006/main" xmlns:r="http://schemas.openxmlformats.org/officeDocument/2006/relationships" xmlns:p="http://schemas.openxmlformats.org/presentationml/2006/main">
-  <p:cSld name="Slide 4">
+  <p:cSld name="Slide 5">
     <p:bg>
       <p:bgPr>
         <a:solidFill>
@@ -3597,7 +3897,7 @@
                 <a:ea typeface="Calibri" pitchFamily="34" charset="-122"/>
                 <a:cs typeface="Calibri" pitchFamily="34" charset="-120"/>
               </a:rPr>
-              <a:t>4</a:t>
+              <a:t>5</a:t>
             </a:r>
             <a:endParaRPr lang="en-US" sz="1200" dirty="0"/>
           </a:p>
@@ -3611,9 +3911,9 @@
 </p:sld>
 </file>
 
-<file path=ppt/slides/slide5.xml><?xml version="1.0" encoding="utf-8"?>
+<file path=ppt/slides/slide6.xml><?xml version="1.0" encoding="utf-8"?>
 <p:sld xmlns:a="http://schemas.openxmlformats.org/drawingml/2006/main" xmlns:r="http://schemas.openxmlformats.org/officeDocument/2006/relationships" xmlns:p="http://schemas.openxmlformats.org/presentationml/2006/main">
-  <p:cSld name="Slide 5">
+  <p:cSld name="Slide 6">
     <p:bg>
       <p:bgPr>
         <a:solidFill>
@@ -3715,7 +4015,7 @@
       </p:sp>
       <p:graphicFrame>
         <p:nvGraphicFramePr>
-          <p:cNvPr id="6" name="Table 0"/>
+          <p:cNvPr id="7" name="Table 0"/>
           <p:cNvGraphicFramePr>
             <a:graphicFrameLocks noGrp="1"/>
           </p:cNvGraphicFramePr>
@@ -11111,7 +11411,7 @@
                 <a:ea typeface="Calibri" pitchFamily="34" charset="-122"/>
                 <a:cs typeface="Calibri" pitchFamily="34" charset="-120"/>
               </a:rPr>
-              <a:t>5</a:t>
+              <a:t>6</a:t>
             </a:r>
             <a:endParaRPr lang="en-US" sz="1200" dirty="0"/>
           </a:p>
@@ -11125,9 +11425,9 @@
 </p:sld>
 </file>
 
-<file path=ppt/slides/slide6.xml><?xml version="1.0" encoding="utf-8"?>
+<file path=ppt/slides/slide7.xml><?xml version="1.0" encoding="utf-8"?>
 <p:sld xmlns:a="http://schemas.openxmlformats.org/drawingml/2006/main" xmlns:r="http://schemas.openxmlformats.org/officeDocument/2006/relationships" xmlns:p="http://schemas.openxmlformats.org/presentationml/2006/main">
-  <p:cSld name="Slide 6">
+  <p:cSld name="Slide 7">
     <p:bg>
       <p:bgPr>
         <a:solidFill>
@@ -11508,7 +11808,7 @@
                 <a:ea typeface="Calibri" pitchFamily="34" charset="-122"/>
                 <a:cs typeface="Calibri" pitchFamily="34" charset="-120"/>
               </a:rPr>
-              <a:t>6</a:t>
+              <a:t>7</a:t>
             </a:r>
             <a:endParaRPr lang="en-US" sz="1200" dirty="0"/>
           </a:p>
@@ -11522,9 +11822,9 @@
 </p:sld>
 </file>
 
-<file path=ppt/slides/slide7.xml><?xml version="1.0" encoding="utf-8"?>
+<file path=ppt/slides/slide8.xml><?xml version="1.0" encoding="utf-8"?>
 <p:sld xmlns:a="http://schemas.openxmlformats.org/drawingml/2006/main" xmlns:r="http://schemas.openxmlformats.org/officeDocument/2006/relationships" xmlns:p="http://schemas.openxmlformats.org/presentationml/2006/main">
-  <p:cSld name="Slide 7">
+  <p:cSld name="Slide 8">
     <p:bg>
       <p:bgPr>
         <a:solidFill>
@@ -12391,7 +12691,7 @@
                 <a:ea typeface="Calibri" pitchFamily="34" charset="-122"/>
                 <a:cs typeface="Calibri" pitchFamily="34" charset="-120"/>
               </a:rPr>
-              <a:t>7</a:t>
+              <a:t>8</a:t>
             </a:r>
             <a:endParaRPr lang="en-US" sz="1200" dirty="0"/>
           </a:p>

</xml_diff>

<commit_message>
Slides: minimal intro, title 'Chasing a round polar' and a caption under the photo
Co-Authored-By: Claude Sonnet 5.5 <noreply@anthropic.com>
</commit_message>
<xml_diff>
--- a/docs/analysis/chamber-final-2026-10-01/slides/chamber-slides.pptx
+++ b/docs/analysis/chamber-final-2026-10-01/slides/chamber-slides.pptx
@@ -1940,8 +1940,8 @@
         </p:nvSpPr>
         <p:spPr>
           <a:xfrm>
-            <a:off x="5760720" y="1554480"/>
-            <a:ext cx="5943600" cy="365760"/>
+            <a:off x="5760720" y="2651760"/>
+            <a:ext cx="6217920" cy="1280160"/>
           </a:xfrm>
           <a:prstGeom prst="rect">
             <a:avLst/>
@@ -1957,17 +1957,17 @@
               <a:buNone/>
             </a:pPr>
             <a:r>
-              <a:rPr lang="en-US" sz="1400" b="1" spc="300" kern="0" dirty="0">
+              <a:rPr lang="en-US" sz="4000" b="1" dirty="0">
                 <a:solidFill>
-                  <a:srgbClr val="AFC3E3"/>
+                  <a:srgbClr val="FFFFFF"/>
                 </a:solidFill>
-                <a:latin typeface="Calibri" pitchFamily="34" charset="0"/>
-                <a:ea typeface="Calibri" pitchFamily="34" charset="-122"/>
-                <a:cs typeface="Calibri" pitchFamily="34" charset="-120"/>
+                <a:latin typeface="Cambria" pitchFamily="34" charset="0"/>
+                <a:ea typeface="Cambria" pitchFamily="34" charset="-122"/>
+                <a:cs typeface="Cambria" pitchFamily="34" charset="-120"/>
               </a:rPr>
-              <a:t>CHAMBER MEASUREMENTS</a:t>
+              <a:t>Chasing a round polar</a:t>
             </a:r>
-            <a:endParaRPr lang="en-US" sz="1400" dirty="0"/>
+            <a:endParaRPr lang="en-US" sz="4000" dirty="0"/>
           </a:p>
         </p:txBody>
       </p:sp>
@@ -1979,8 +1979,8 @@
         </p:nvSpPr>
         <p:spPr>
           <a:xfrm>
-            <a:off x="5760720" y="1965960"/>
-            <a:ext cx="5943600" cy="1554480"/>
+            <a:off x="5760720" y="5760720"/>
+            <a:ext cx="5760720" cy="731520"/>
           </a:xfrm>
           <a:prstGeom prst="rect">
             <a:avLst/>
@@ -1996,85 +1996,7 @@
               <a:buNone/>
             </a:pPr>
             <a:r>
-              <a:rPr lang="en-US" sz="3800" b="1" dirty="0">
-                <a:solidFill>
-                  <a:srgbClr val="FFFFFF"/>
-                </a:solidFill>
-                <a:latin typeface="Cambria" pitchFamily="34" charset="0"/>
-                <a:ea typeface="Cambria" pitchFamily="34" charset="-122"/>
-                <a:cs typeface="Cambria" pitchFamily="34" charset="-120"/>
-              </a:rPr>
-              <a:t>Measuring a propeller in our chamber</a:t>
-            </a:r>
-            <a:endParaRPr lang="en-US" sz="3800" dirty="0"/>
-          </a:p>
-        </p:txBody>
-      </p:sp>
-      <p:sp>
-        <p:nvSpPr>
-          <p:cNvPr id="5" name="Text 2"/>
-          <p:cNvSpPr txBox="1"/>
-          <p:nvPr/>
-        </p:nvSpPr>
-        <p:spPr>
-          <a:xfrm>
-            <a:off x="5760720" y="3931920"/>
-            <a:ext cx="5669280" cy="1188720"/>
-          </a:xfrm>
-          <a:prstGeom prst="rect">
-            <a:avLst/>
-          </a:prstGeom>
-          <a:noFill/>
-          <a:ln/>
-        </p:spPr>
-        <p:txBody>
-          <a:bodyPr wrap="square" lIns="0" tIns="0" rIns="0" bIns="0" rtlCol="0" anchor="t"/>
-          <a:lstStyle/>
-          <a:p>
-            <a:pPr indent="0" marL="0">
-              <a:buNone/>
-            </a:pPr>
-            <a:r>
-              <a:rPr lang="en-US" sz="1800" dirty="0">
-                <a:solidFill>
-                  <a:srgbClr val="E3E9F4"/>
-                </a:solidFill>
-                <a:latin typeface="Calibri" pitchFamily="34" charset="0"/>
-                <a:ea typeface="Calibri" pitchFamily="34" charset="-122"/>
-                <a:cs typeface="Calibri" pitchFamily="34" charset="-120"/>
-              </a:rPr>
-              <a:t>The current set-up: eleven microphones on a ring around the source, absorbing material on floor, ceiling and walls.</a:t>
-            </a:r>
-            <a:endParaRPr lang="en-US" sz="1800" dirty="0"/>
-          </a:p>
-        </p:txBody>
-      </p:sp>
-      <p:sp>
-        <p:nvSpPr>
-          <p:cNvPr id="6" name="Text 3"/>
-          <p:cNvSpPr txBox="1"/>
-          <p:nvPr/>
-        </p:nvSpPr>
-        <p:spPr>
-          <a:xfrm>
-            <a:off x="5760720" y="6355080"/>
-            <a:ext cx="5669280" cy="274320"/>
-          </a:xfrm>
-          <a:prstGeom prst="rect">
-            <a:avLst/>
-          </a:prstGeom>
-          <a:noFill/>
-          <a:ln/>
-        </p:spPr>
-        <p:txBody>
-          <a:bodyPr wrap="square" lIns="0" tIns="0" rIns="0" bIns="0" rtlCol="0" anchor="ctr"/>
-          <a:lstStyle/>
-          <a:p>
-            <a:pPr indent="0" marL="0">
-              <a:buNone/>
-            </a:pPr>
-            <a:r>
-              <a:rPr lang="en-US" sz="1200" dirty="0">
+              <a:rPr lang="en-US" sz="1400" dirty="0">
                 <a:solidFill>
                   <a:srgbClr val="AFC3E3"/>
                 </a:solidFill>
@@ -2082,9 +2004,9 @@
                 <a:ea typeface="Calibri" pitchFamily="34" charset="-122"/>
                 <a:cs typeface="Calibri" pitchFamily="34" charset="-120"/>
               </a:rPr>
-              <a:t>Photo of the final configuration, 5 Oct 2026</a:t>
+              <a:t>Our chamber in its current set-up (5 Oct 2026): eleven microphones on a ring around the source, absorbing material on floor, ceiling and walls.</a:t>
             </a:r>
-            <a:endParaRPr lang="en-US" sz="1200" dirty="0"/>
+            <a:endParaRPr lang="en-US" sz="1400" dirty="0"/>
           </a:p>
         </p:txBody>
       </p:sp>

</xml_diff>

<commit_message>
Slides: new slide 6, how marginal the Thinsulate ring wrap is; later slides renumbered 7 to 9
Co-Authored-By: Claude Sonnet 5.5 <noreply@anthropic.com>
</commit_message>
<xml_diff>
--- a/docs/analysis/chamber-final-2026-10-01/slides/chamber-slides.pptx
+++ b/docs/analysis/chamber-final-2026-10-01/slides/chamber-slides.pptx
@@ -13,9 +13,10 @@
     <p:sldId id="261" r:id="rId7"/>
     <p:sldId id="262" r:id="rId8"/>
     <p:sldId id="263" r:id="rId9"/>
+    <p:sldId id="264" r:id="rId10"/>
   </p:sldIdLst>
   <p:notesMasterIdLst>
-    <p:notesMasterId r:id="rId10"/>
+    <p:notesMasterId r:id="rId11"/>
   </p:notesMasterIdLst>
   <p:sldSz cx="12192000" cy="6858000"/>
   <p:notesSz cx="6858000" cy="12192000"/>
@@ -509,6 +510,300 @@
         </a:p>
       </c:txPr>
     </c:legend>
+    <c:plotVisOnly val="1"/>
+    <c:dispBlanksAs val="span"/>
+  </c:chart>
+  <c:spPr>
+    <a:noFill/>
+    <a:ln>
+      <a:noFill/>
+    </a:ln>
+    <a:effectLst/>
+  </c:spPr>
+  <c:externalData r:id="rId1">
+    <c:autoUpdate val="0"/>
+  </c:externalData>
+</c:chartSpace>
+</file>
+
+<file path=ppt/charts/chart2.xml><?xml version="1.0" encoding="utf-8"?>
+<c:chartSpace xmlns:c="http://schemas.openxmlformats.org/drawingml/2006/chart" xmlns:a="http://schemas.openxmlformats.org/drawingml/2006/main" xmlns:r="http://schemas.openxmlformats.org/officeDocument/2006/relationships">
+  <c:date1904 val="0"/>
+  <c:roundedCorners val="1"/>
+  <c:chart>
+    <c:autoTitleDeleted val="1"/>
+    <c:plotArea>
+      <c:layout/>
+      <c:barChart>
+        <c:barDir val="bar"/>
+        <c:grouping val="clustered"/>
+        <c:varyColors val="0"/>
+        <c:ser>
+          <c:idx val="0"/>
+          <c:order val="0"/>
+          <c:tx>
+            <c:strRef>
+              <c:f>Sheet1!$B$1</c:f>
+              <c:strCache>
+                <c:ptCount val="1"/>
+                <c:pt idx="0">
+                  <c:v>Change in room error (dB)</c:v>
+                </c:pt>
+              </c:strCache>
+            </c:strRef>
+          </c:tx>
+          <c:spPr>
+            <a:solidFill>
+              <a:srgbClr val="9AA5B8"/>
+            </a:solidFill>
+            <a:effectLst/>
+          </c:spPr>
+          <c:invertIfNegative val="0"/>
+          <c:dLbls>
+            <c:numFmt formatCode="0.000" sourceLinked="0"/>
+            <c:txPr>
+              <a:bodyPr/>
+              <a:lstStyle/>
+              <a:p>
+                <a:pPr>
+                  <a:defRPr b="0" i="0" strike="noStrike" sz="1400" u="none">
+                    <a:solidFill>
+                      <a:srgbClr val="1F2A44"/>
+                    </a:solidFill>
+                    <a:latin typeface="Calibri"/>
+                  </a:defRPr>
+                </a:pPr>
+              </a:p>
+            </c:txPr>
+            <c:showLegendKey val="0"/>
+            <c:showVal val="1"/>
+            <c:showCatName val="0"/>
+            <c:showSerName val="0"/>
+            <c:showPercent val="0"/>
+            <c:showBubbleSize val="0"/>
+            <c:showLeaderLines val="0"/>
+          </c:dLbls>
+          <c:dPt>
+            <c:idx val="0"/>
+            <c:invertIfNegative val="0"/>
+            <c:bubble3D val="0"/>
+            <c:spPr>
+              <a:solidFill>
+                <a:srgbClr val="9AA5B8"/>
+              </a:solidFill>
+              <a:effectLst/>
+            </c:spPr>
+          </c:dPt>
+          <c:dPt>
+            <c:idx val="1"/>
+            <c:invertIfNegative val="0"/>
+            <c:bubble3D val="0"/>
+            <c:spPr>
+              <a:solidFill>
+                <a:srgbClr val="9AA5B8"/>
+              </a:solidFill>
+              <a:effectLst/>
+            </c:spPr>
+          </c:dPt>
+          <c:dPt>
+            <c:idx val="2"/>
+            <c:invertIfNegative val="0"/>
+            <c:bubble3D val="0"/>
+            <c:spPr>
+              <a:solidFill>
+                <a:srgbClr val="C9CFDA"/>
+              </a:solidFill>
+              <a:effectLst/>
+            </c:spPr>
+          </c:dPt>
+          <c:dPt>
+            <c:idx val="3"/>
+            <c:invertIfNegative val="0"/>
+            <c:bubble3D val="0"/>
+            <c:spPr>
+              <a:solidFill>
+                <a:srgbClr val="2B6CB0"/>
+              </a:solidFill>
+              <a:effectLst/>
+            </c:spPr>
+          </c:dPt>
+          <c:cat>
+            <c:multiLvlStrRef>
+              <c:f>Sheet1!$A$2:$A$5</c:f>
+              <c:multiLvlStrCache>
+                <c:ptCount val="4"/>
+                <c:lvl>
+                  <c:pt idx="0">
+                    <c:v>Ring wrap taken off, 24 Sep</c:v>
+                  </c:pt>
+                  <c:pt idx="1">
+                    <c:v>Part of ring wrap off, 23 Sep</c:v>
+                  </c:pt>
+                  <c:pt idx="2">
+                    <c:v>Handling alone (typical)</c:v>
+                  </c:pt>
+                  <c:pt idx="3">
+                    <c:v>Carpet on the empty floor, 24 Sep</c:v>
+                  </c:pt>
+                </c:lvl>
+              </c:multiLvlStrCache>
+            </c:multiLvlStrRef>
+          </c:cat>
+          <c:val>
+            <c:numRef>
+              <c:f>Sheet1!$B$2:$B$5</c:f>
+              <c:numCache>
+                <c:formatCode>General</c:formatCode>
+                <c:ptCount val="4"/>
+                <c:pt idx="0">
+                  <c:v>0.014</c:v>
+                </c:pt>
+                <c:pt idx="1">
+                  <c:v>0.018</c:v>
+                </c:pt>
+                <c:pt idx="2">
+                  <c:v>0.04</c:v>
+                </c:pt>
+                <c:pt idx="3">
+                  <c:v>0.737</c:v>
+                </c:pt>
+              </c:numCache>
+            </c:numRef>
+          </c:val>
+        </c:ser>
+        <c:dLbls>
+          <c:numFmt formatCode="0.000" sourceLinked="0"/>
+          <c:txPr>
+            <a:bodyPr/>
+            <a:lstStyle/>
+            <a:p>
+              <a:pPr>
+                <a:defRPr b="0" i="0" strike="noStrike" sz="1400" u="none">
+                  <a:solidFill>
+                    <a:srgbClr val="1F2A44"/>
+                  </a:solidFill>
+                  <a:latin typeface="Calibri"/>
+                </a:defRPr>
+              </a:pPr>
+            </a:p>
+          </c:txPr>
+          <c:showLegendKey val="0"/>
+          <c:showVal val="1"/>
+          <c:showCatName val="0"/>
+          <c:showSerName val="0"/>
+          <c:showPercent val="0"/>
+          <c:showBubbleSize val="0"/>
+          <c:showLeaderLines val="0"/>
+        </c:dLbls>
+        <c:gapWidth val="45"/>
+        <c:overlap val="0"/>
+        <c:axId val="2094734554"/>
+        <c:axId val="2094734552"/>
+        <c:axId val="2094734556"/>
+      </c:barChart>
+      <c:catAx>
+        <c:axId val="2094734554"/>
+        <c:scaling>
+          <c:orientation val="maxMin"/>
+        </c:scaling>
+        <c:delete val="0"/>
+        <c:axPos val="l"/>
+        <c:numFmt formatCode="General" sourceLinked="1"/>
+        <c:majorTickMark val="out"/>
+        <c:minorTickMark val="none"/>
+        <c:tickLblPos val="low"/>
+        <c:spPr>
+          <a:ln w="12700" cap="flat">
+            <a:solidFill>
+              <a:srgbClr val="888888"/>
+            </a:solidFill>
+            <a:prstDash val="solid"/>
+            <a:round/>
+          </a:ln>
+        </c:spPr>
+        <c:txPr>
+          <a:bodyPr/>
+          <a:lstStyle/>
+          <a:p>
+            <a:pPr>
+              <a:defRPr sz="1400" b="0" i="0" u="none" strike="noStrike">
+                <a:solidFill>
+                  <a:srgbClr val="1F2A44"/>
+                </a:solidFill>
+                <a:latin typeface="Calibri"/>
+              </a:defRPr>
+            </a:pPr>
+            <a:endParaRPr lang="en-US"/>
+          </a:p>
+        </c:txPr>
+        <c:crossAx val="2094734552"/>
+        <c:crosses val="autoZero"/>
+        <c:auto val="1"/>
+        <c:lblAlgn val="ctr"/>
+        <c:noMultiLvlLbl val="1"/>
+        <c:tickLblSkip val="1"/>
+      </c:catAx>
+      <c:valAx>
+        <c:axId val="2094734552"/>
+        <c:scaling>
+          <c:orientation val="minMax"/>
+          <c:max val="0.9"/>
+          <c:min val="0"/>
+        </c:scaling>
+        <c:delete val="0"/>
+        <c:axPos val="b"/>
+        <c:majorGridlines>
+          <c:spPr>
+            <a:ln w="6350" cap="flat">
+              <a:solidFill>
+                <a:srgbClr val="E3E7EE"/>
+              </a:solidFill>
+              <a:prstDash val="solid"/>
+              <a:round/>
+            </a:ln>
+          </c:spPr>
+        </c:majorGridlines>
+        <c:numFmt formatCode="0.0" sourceLinked="0"/>
+        <c:majorTickMark val="out"/>
+        <c:minorTickMark val="none"/>
+        <c:tickLblPos val="low"/>
+        <c:spPr>
+          <a:ln w="12700" cap="flat">
+            <a:solidFill>
+              <a:srgbClr val="888888"/>
+            </a:solidFill>
+            <a:prstDash val="solid"/>
+            <a:round/>
+          </a:ln>
+        </c:spPr>
+        <c:txPr>
+          <a:bodyPr/>
+          <a:lstStyle/>
+          <a:p>
+            <a:pPr>
+              <a:defRPr sz="1200" b="0" i="0" u="none" strike="noStrike">
+                <a:solidFill>
+                  <a:srgbClr val="5B6578"/>
+                </a:solidFill>
+                <a:latin typeface="Calibri"/>
+              </a:defRPr>
+            </a:pPr>
+            <a:endParaRPr lang="en-US"/>
+          </a:p>
+        </c:txPr>
+        <c:crossAx val="2094734554"/>
+        <c:crosses val="autoZero"/>
+        <c:crossBetween val="between"/>
+        <c:majorUnit val="0.3"/>
+      </c:valAx>
+      <c:spPr>
+        <a:noFill/>
+        <a:ln>
+          <a:noFill/>
+        </a:ln>
+        <a:effectLst/>
+      </c:spPr>
+    </c:plotArea>
     <c:plotVisOnly val="1"/>
     <c:dispBlanksAs val="span"/>
   </c:chart>
@@ -1360,7 +1655,7 @@
           <a:p>
             <a:r>
               <a:rPr lang="en-US" dirty="0"/>
-              <a:t>Same table as page 4 of the report. Each one-third-octave band is judged against the anechoic tolerance values of ISO 5305 Table 1 (also ISO 3745 as printed by Cunefare 2003): +-1.5 dB for 125-630 Hz, +-1.0 dB for 800-5000 Hz. The number is the worst microphone band-mean deviation from the arc mean, in dB; the colour is that number as a share of the limit. Cells in limit counts tone x microphone cells inside the limit (3 tones x 11 microphones = 33 cells at 250 Hz, where the grid starts at 257 Hz). This is an analogue: the standards use a traverse and test decay with distance, we use eleven fixed microphones at one radius. The room is treated and not qualified. Within the tolerance values from 1250 Hz at the start of day 3 and from 2000 Hz in the final state, up to 2500 Hz. The rows marked * (5000 and 6300 Hz) are partial: 4 and 5 tones above 5 kHz, the limit is +-1.0 dB at 5000 Hz and +-1.5 dB at 6300 Hz (ISO 5305 Table 1). Both are over the limit in both states (1.24 and 1.23 dB; 1.59 and 1.77 dB). The 3150 and 4000 Hz bands are not shown: no tones between 3 and 5 kHz because of the rocking mode of the sphere at about 4.4 kHz. Caveat: the loudspeaker position was not documented across the day.</a:t>
+              <a:t>Source: README of the chamber trials (docs/analysis/chamber-treatments-2026-09-23) and the loudspeaker sessions. 24 Sep: wall-direct-absorber (ring still wrapped) to ring-bare (the rest of the Thinsulate wrap removed from the ring), 10 minutes apart, speaker on the wall, nothing else changed: room error below 3 kHz 2.219 to 2.205 dB (-0.014); map change 0.36 dB spread over all capsules; 250-400 Hz -0.10, 1.6-3 kHz +0.04, 5-6.4 kHz +0.09. 23 Sep: tripod-unwrapped (ring wrapped) to ring-unwrapped (part removed): 1.387 to 1.406 dB (+0.018), map change 0.18 dB, a new hub mounting preset from there; ring-unwrapped to ring-unwrapped-2: +0.002. Repeat floor 0.006-0.015 dB, handling about 0.04 dB (README). Carpet on the empty floor: 24 Sep floor-no-wedges 2.054 to chaotic-carpet 1.317 dB (-0.737), source unmoved. 0.737 / 0.014 = 53, so about 50 times.</a:t>
             </a:r>
             <a:endParaRPr lang="en-US" dirty="0"/>
           </a:p>
@@ -1448,7 +1743,7 @@
           <a:p>
             <a:r>
               <a:rPr lang="en-US" dirty="0"/>
-              <a:t>Blue: 30 Sep propeller measurement (11.7 V, 7.3 A, thrust -4 N), read with the 16 Sep microphone corrections. Rms spread about the mean 1.45 dB against 2.05 dB for 31 Aug; range 4.0 dB (55.5 to 59.6 dB SPL) against 6.7 dB. The blue is about 11 dB lower because the motor ran at a different operating point. The 4 dB range of the blue is a bottom-louder trend. Honest caveat: with the same calibration applied to the 1-2 Sep runs, those are about as round as 30 Sep, so most of the improvement against the earlier baselines comes from the microphone calibration, not the room.</a:t>
+              <a:t>Same table as page 4 of the report. Each one-third-octave band is judged against the anechoic tolerance values of ISO 5305 Table 1 (also ISO 3745 as printed by Cunefare 2003): +-1.5 dB for 125-630 Hz, +-1.0 dB for 800-5000 Hz. The number is the worst microphone band-mean deviation from the arc mean, in dB; the colour is that number as a share of the limit. Cells in limit counts tone x microphone cells inside the limit (3 tones x 11 microphones = 33 cells at 250 Hz, where the grid starts at 257 Hz). This is an analogue: the standards use a traverse and test decay with distance, we use eleven fixed microphones at one radius. The room is treated and not qualified. Within the tolerance values from 1250 Hz at the start of day 3 and from 2000 Hz in the final state, up to 2500 Hz. The rows marked * (5000 and 6300 Hz) are partial: 4 and 5 tones above 5 kHz, the limit is +-1.0 dB at 5000 Hz and +-1.5 dB at 6300 Hz (ISO 5305 Table 1). Both are over the limit in both states (1.24 and 1.23 dB; 1.59 and 1.77 dB). The 3150 and 4000 Hz bands are not shown: no tones between 3 and 5 kHz because of the rocking mode of the sphere at about 4.4 kHz. Caveat: the loudspeaker position was not documented across the day.</a:t>
             </a:r>
             <a:endParaRPr lang="en-US" dirty="0"/>
           </a:p>
@@ -1536,6 +1831,94 @@
           <a:p>
             <a:r>
               <a:rPr lang="en-US" dirty="0"/>
+              <a:t>Blue: 30 Sep propeller measurement (11.7 V, 7.3 A, thrust -4 N), read with the 16 Sep microphone corrections. Rms spread about the mean 1.45 dB against 2.05 dB for 31 Aug; range 4.0 dB (55.5 to 59.6 dB SPL) against 6.7 dB. The blue is about 11 dB lower because the motor ran at a different operating point. The 4 dB range of the blue is a bottom-louder trend. Honest caveat: with the same calibration applied to the 1-2 Sep runs, those are about as round as 30 Sep, so most of the improvement against the earlier baselines comes from the microphone calibration, not the room.</a:t>
+            </a:r>
+            <a:endParaRPr lang="en-US" dirty="0"/>
+          </a:p>
+        </p:txBody>
+      </p:sp>
+      <p:sp>
+        <p:nvSpPr>
+          <p:cNvPr id="4" name="Slide Number Placeholder 3"/>
+          <p:cNvSpPr>
+            <a:spLocks noGrp="1"/>
+          </p:cNvSpPr>
+          <p:nvPr>
+            <p:ph type="sldNum" sz="quarter" idx="10"/>
+          </p:nvPr>
+        </p:nvSpPr>
+        <p:spPr/>
+        <p:txBody>
+          <a:bodyPr/>
+          <a:lstStyle/>
+          <a:p>
+            <a:fld id="{F7021451-1387-4CA6-816F-3879F97B5CBC}" type="slidenum">
+              <a:rPr lang="en-US"/>
+              <a:t>8</a:t>
+            </a:fld>
+            <a:endParaRPr lang="en-US"/>
+          </a:p>
+        </p:txBody>
+      </p:sp>
+    </p:spTree>
+    <p:extLst>
+      <p:ext uri="{BB962C8B-B14F-4D97-AF65-F5344CB8AC3E}">
+        <p14:creationId xmlns:p14="http://schemas.microsoft.com/office/powerpoint/2010/main" val="1024086991"/>
+      </p:ext>
+    </p:extLst>
+  </p:cSld>
+  <p:clrMapOvr>
+    <a:masterClrMapping/>
+  </p:clrMapOvr>
+</p:notes>
+</file>
+
+<file path=ppt/notesSlides/notesSlide9.xml><?xml version="1.0" encoding="utf-8"?>
+<p:notes xmlns:a="http://schemas.openxmlformats.org/drawingml/2006/main" xmlns:r="http://schemas.openxmlformats.org/officeDocument/2006/relationships" xmlns:p="http://schemas.openxmlformats.org/presentationml/2006/main">
+  <p:cSld>
+    <p:spTree>
+      <p:nvGrpSpPr>
+        <p:cNvPr id="1" name=""/>
+        <p:cNvGrpSpPr/>
+        <p:nvPr/>
+      </p:nvGrpSpPr>
+      <p:grpSpPr>
+        <a:xfrm>
+          <a:off x="0" y="0"/>
+          <a:ext cx="0" cy="0"/>
+          <a:chOff x="0" y="0"/>
+          <a:chExt cx="0" cy="0"/>
+        </a:xfrm>
+      </p:grpSpPr>
+      <p:sp>
+        <p:nvSpPr>
+          <p:cNvPr id="2" name="Slide Image Placeholder 1"/>
+          <p:cNvSpPr>
+            <a:spLocks noGrp="1" noRot="1" noChangeAspect="1"/>
+          </p:cNvSpPr>
+          <p:nvPr>
+            <p:ph type="sldImg"/>
+          </p:nvPr>
+        </p:nvSpPr>
+        <p:spPr/>
+      </p:sp>
+      <p:sp>
+        <p:nvSpPr>
+          <p:cNvPr id="3" name="Notes Placeholder 2"/>
+          <p:cNvSpPr>
+            <a:spLocks noGrp="1"/>
+          </p:cNvSpPr>
+          <p:nvPr>
+            <p:ph type="body" idx="1"/>
+          </p:nvPr>
+        </p:nvSpPr>
+        <p:spPr/>
+        <p:txBody>
+          <a:bodyPr/>
+          <a:lstStyle/>
+          <a:p>
+            <a:r>
+              <a:rPr lang="en-US" dirty="0"/>
               <a:t>Bases of 2 Oct 2026 in the data repo: 2004__5in3b__unset__v1-naked-horizontal, ...cork__v1-cork-horizontal, ...rubber__v1-rubber, ...felt__v1-felt, ...felt-rubber__v1-felt-rubber. Each capture is the PWM 2000 step; level per microphone is the total level 100 Hz to 10 kHz in dB SPL, read with the corrected microphone files (all after 16 Sep). The polar is mirrored to 360 degrees. Mean over the eleven positions: naked 74.2, cork 78.7, rubber 80.6, felt 79.5, felt plus rubber 78.7 dB. At -90 degrees (the outflow) all five are 93.7 to 98.3 dB. The slide shows levels as measured; operating points (voltage, thrust) were not compared here.</a:t>
             </a:r>
             <a:endParaRPr lang="en-US" dirty="0"/>
@@ -1559,7 +1942,7 @@
           <a:p>
             <a:fld id="{F7021451-1387-4CA6-816F-3879F97B5CBC}" type="slidenum">
               <a:rPr lang="en-US"/>
-              <a:t>8</a:t>
+              <a:t>9</a:t>
             </a:fld>
             <a:endParaRPr lang="en-US"/>
           </a:p>
@@ -3865,6 +4248,391 @@
         </p:nvSpPr>
         <p:spPr>
           <a:xfrm>
+            <a:off x="548640" y="457200"/>
+            <a:ext cx="5486400" cy="320040"/>
+          </a:xfrm>
+          <a:prstGeom prst="rect">
+            <a:avLst/>
+          </a:prstGeom>
+          <a:noFill/>
+          <a:ln/>
+        </p:spPr>
+        <p:txBody>
+          <a:bodyPr wrap="square" lIns="0" tIns="0" rIns="0" bIns="0" rtlCol="0" anchor="ctr"/>
+          <a:lstStyle/>
+          <a:p>
+            <a:pPr indent="0" marL="0">
+              <a:buNone/>
+            </a:pPr>
+            <a:r>
+              <a:rPr lang="en-US" sz="1400" b="1" spc="300" kern="0" dirty="0">
+                <a:solidFill>
+                  <a:srgbClr val="2B6CB0"/>
+                </a:solidFill>
+                <a:latin typeface="Calibri" pitchFamily="34" charset="0"/>
+                <a:ea typeface="Calibri" pitchFamily="34" charset="-122"/>
+                <a:cs typeface="Calibri" pitchFamily="34" charset="-120"/>
+              </a:rPr>
+              <a:t>THE RING WRAP</a:t>
+            </a:r>
+            <a:endParaRPr lang="en-US" sz="1400" dirty="0"/>
+          </a:p>
+        </p:txBody>
+      </p:sp>
+      <p:sp>
+        <p:nvSpPr>
+          <p:cNvPr id="3" name="Text 1"/>
+          <p:cNvSpPr txBox="1"/>
+          <p:nvPr/>
+        </p:nvSpPr>
+        <p:spPr>
+          <a:xfrm>
+            <a:off x="548640" y="777240"/>
+            <a:ext cx="11064240" cy="731520"/>
+          </a:xfrm>
+          <a:prstGeom prst="rect">
+            <a:avLst/>
+          </a:prstGeom>
+          <a:noFill/>
+          <a:ln/>
+        </p:spPr>
+        <p:txBody>
+          <a:bodyPr wrap="square" lIns="0" tIns="0" rIns="0" bIns="0" rtlCol="0" anchor="t"/>
+          <a:lstStyle/>
+          <a:p>
+            <a:pPr indent="0" marL="0">
+              <a:buNone/>
+            </a:pPr>
+            <a:r>
+              <a:rPr lang="en-US" sz="3200" b="1" dirty="0">
+                <a:solidFill>
+                  <a:srgbClr val="1F2A44"/>
+                </a:solidFill>
+                <a:latin typeface="Cambria" pitchFamily="34" charset="0"/>
+                <a:ea typeface="Cambria" pitchFamily="34" charset="-122"/>
+                <a:cs typeface="Cambria" pitchFamily="34" charset="-120"/>
+              </a:rPr>
+              <a:t>Thinsulate on the ring hardly matters</a:t>
+            </a:r>
+            <a:endParaRPr lang="en-US" sz="3200" dirty="0"/>
+          </a:p>
+        </p:txBody>
+      </p:sp>
+      <p:sp>
+        <p:nvSpPr>
+          <p:cNvPr id="4" name="Text 2"/>
+          <p:cNvSpPr txBox="1"/>
+          <p:nvPr/>
+        </p:nvSpPr>
+        <p:spPr>
+          <a:xfrm>
+            <a:off x="548640" y="1783080"/>
+            <a:ext cx="6583680" cy="320040"/>
+          </a:xfrm>
+          <a:prstGeom prst="rect">
+            <a:avLst/>
+          </a:prstGeom>
+          <a:noFill/>
+          <a:ln/>
+        </p:spPr>
+        <p:txBody>
+          <a:bodyPr wrap="square" lIns="0" tIns="0" rIns="0" bIns="0" rtlCol="0" anchor="ctr"/>
+          <a:lstStyle/>
+          <a:p>
+            <a:pPr indent="0" marL="0">
+              <a:buNone/>
+            </a:pPr>
+            <a:r>
+              <a:rPr lang="en-US" sz="1400" b="1" dirty="0">
+                <a:solidFill>
+                  <a:srgbClr val="1F2A44"/>
+                </a:solidFill>
+                <a:latin typeface="Calibri" pitchFamily="34" charset="0"/>
+                <a:ea typeface="Calibri" pitchFamily="34" charset="-122"/>
+                <a:cs typeface="Calibri" pitchFamily="34" charset="-120"/>
+              </a:rPr>
+              <a:t>Size of the change in room error (dB)</a:t>
+            </a:r>
+            <a:endParaRPr lang="en-US" sz="1400" dirty="0"/>
+          </a:p>
+        </p:txBody>
+      </p:sp>
+      <p:graphicFrame>
+        <p:nvGraphicFramePr>
+          <p:cNvPr id="5" name="Chart 0" descr=""/>
+          <p:cNvGraphicFramePr/>
+          <p:nvPr/>
+        </p:nvGraphicFramePr>
+        <p:xfrm>
+          <a:off x="457200" y="2103120"/>
+          <a:ext cx="6858000" cy="3931920"/>
+        </p:xfrm>
+        <a:graphic xmlns:a="http://schemas.openxmlformats.org/drawingml/2006/main">
+          <a:graphicData uri="http://schemas.openxmlformats.org/drawingml/2006/chart">
+            <c:chart xmlns:c="http://schemas.openxmlformats.org/drawingml/2006/chart" r:id="rId1"/>
+          </a:graphicData>
+        </a:graphic>
+      </p:graphicFrame>
+      <p:sp>
+        <p:nvSpPr>
+          <p:cNvPr id="6" name="Text 3"/>
+          <p:cNvSpPr txBox="1"/>
+          <p:nvPr/>
+        </p:nvSpPr>
+        <p:spPr>
+          <a:xfrm>
+            <a:off x="7863840" y="1828800"/>
+            <a:ext cx="3840480" cy="822960"/>
+          </a:xfrm>
+          <a:prstGeom prst="rect">
+            <a:avLst/>
+          </a:prstGeom>
+          <a:noFill/>
+          <a:ln/>
+        </p:spPr>
+        <p:txBody>
+          <a:bodyPr wrap="square" lIns="0" tIns="0" rIns="0" bIns="0" rtlCol="0" anchor="ctr"/>
+          <a:lstStyle/>
+          <a:p>
+            <a:pPr indent="0" marL="0">
+              <a:buNone/>
+            </a:pPr>
+            <a:r>
+              <a:rPr lang="en-US" sz="4800" b="1" dirty="0">
+                <a:solidFill>
+                  <a:srgbClr val="D6336C"/>
+                </a:solidFill>
+                <a:latin typeface="Cambria" pitchFamily="34" charset="0"/>
+                <a:ea typeface="Cambria" pitchFamily="34" charset="-122"/>
+                <a:cs typeface="Cambria" pitchFamily="34" charset="-120"/>
+              </a:rPr>
+              <a:t>0.014 dB</a:t>
+            </a:r>
+            <a:endParaRPr lang="en-US" sz="4800" dirty="0"/>
+          </a:p>
+        </p:txBody>
+      </p:sp>
+      <p:sp>
+        <p:nvSpPr>
+          <p:cNvPr id="7" name="Text 4"/>
+          <p:cNvSpPr txBox="1"/>
+          <p:nvPr/>
+        </p:nvSpPr>
+        <p:spPr>
+          <a:xfrm>
+            <a:off x="7863840" y="2697480"/>
+            <a:ext cx="3840480" cy="822960"/>
+          </a:xfrm>
+          <a:prstGeom prst="rect">
+            <a:avLst/>
+          </a:prstGeom>
+          <a:noFill/>
+          <a:ln/>
+        </p:spPr>
+        <p:txBody>
+          <a:bodyPr wrap="square" lIns="0" tIns="0" rIns="0" bIns="0" rtlCol="0" anchor="t"/>
+          <a:lstStyle/>
+          <a:p>
+            <a:pPr indent="0" marL="0">
+              <a:buNone/>
+            </a:pPr>
+            <a:r>
+              <a:rPr lang="en-US" sz="1400" dirty="0">
+                <a:solidFill>
+                  <a:srgbClr val="1F2A44"/>
+                </a:solidFill>
+                <a:latin typeface="Calibri" pitchFamily="34" charset="0"/>
+                <a:ea typeface="Calibri" pitchFamily="34" charset="-122"/>
+                <a:cs typeface="Calibri" pitchFamily="34" charset="-120"/>
+              </a:rPr>
+              <a:t>change in room error when the wrap came off (2.219 → 2.205 dB). Same day, loudspeaker unmoved.</a:t>
+            </a:r>
+            <a:endParaRPr lang="en-US" sz="1400" dirty="0"/>
+          </a:p>
+        </p:txBody>
+      </p:sp>
+      <p:sp>
+        <p:nvSpPr>
+          <p:cNvPr id="8" name="Text 5"/>
+          <p:cNvSpPr txBox="1"/>
+          <p:nvPr/>
+        </p:nvSpPr>
+        <p:spPr>
+          <a:xfrm>
+            <a:off x="7863840" y="3749040"/>
+            <a:ext cx="3840480" cy="2194560"/>
+          </a:xfrm>
+          <a:prstGeom prst="rect">
+            <a:avLst/>
+          </a:prstGeom>
+          <a:noFill/>
+          <a:ln/>
+        </p:spPr>
+        <p:txBody>
+          <a:bodyPr wrap="square" lIns="0" tIns="0" rIns="0" bIns="0" rtlCol="0" anchor="t"/>
+          <a:lstStyle/>
+          <a:p>
+            <a:pPr marL="342900" indent="-342900">
+              <a:spcAft>
+                <a:spcPts val="800"/>
+              </a:spcAft>
+              <a:buSzPct val="100000"/>
+              <a:buChar char="•"/>
+            </a:pPr>
+            <a:r>
+              <a:rPr lang="en-US" sz="1400" dirty="0">
+                <a:solidFill>
+                  <a:srgbClr val="1F2A44"/>
+                </a:solidFill>
+                <a:latin typeface="Calibri" pitchFamily="34" charset="0"/>
+                <a:ea typeface="Calibri" pitchFamily="34" charset="-122"/>
+                <a:cs typeface="Calibri" pitchFamily="34" charset="-120"/>
+              </a:rPr>
+              <a:t>That is the size of the noise: the same state measured twice differs by 0.006–0.015 dB, and handling by about 0.04 dB.</a:t>
+            </a:r>
+            <a:endParaRPr lang="en-US" sz="1400" dirty="0"/>
+          </a:p>
+          <a:p>
+            <a:pPr marL="342900" indent="-342900">
+              <a:spcAft>
+                <a:spcPts val="800"/>
+              </a:spcAft>
+              <a:buSzPct val="100000"/>
+              <a:buChar char="•"/>
+            </a:pPr>
+            <a:r>
+              <a:rPr lang="en-US" sz="1400" dirty="0">
+                <a:solidFill>
+                  <a:srgbClr val="1F2A44"/>
+                </a:solidFill>
+                <a:latin typeface="Calibri" pitchFamily="34" charset="0"/>
+                <a:ea typeface="Calibri" pitchFamily="34" charset="-122"/>
+                <a:cs typeface="Calibri" pitchFamily="34" charset="-120"/>
+              </a:rPr>
+              <a:t>The carpet on the empty floor changed the error 50 times more.</a:t>
+            </a:r>
+            <a:endParaRPr lang="en-US" sz="1400" dirty="0"/>
+          </a:p>
+        </p:txBody>
+      </p:sp>
+      <p:sp>
+        <p:nvSpPr>
+          <p:cNvPr id="9" name="Text 6"/>
+          <p:cNvSpPr txBox="1"/>
+          <p:nvPr/>
+        </p:nvSpPr>
+        <p:spPr>
+          <a:xfrm>
+            <a:off x="548640" y="6355080"/>
+            <a:ext cx="10332720" cy="274320"/>
+          </a:xfrm>
+          <a:prstGeom prst="rect">
+            <a:avLst/>
+          </a:prstGeom>
+          <a:noFill/>
+          <a:ln/>
+        </p:spPr>
+        <p:txBody>
+          <a:bodyPr wrap="square" lIns="0" tIns="0" rIns="0" bIns="0" rtlCol="0" anchor="ctr"/>
+          <a:lstStyle/>
+          <a:p>
+            <a:pPr indent="0" marL="0">
+              <a:buNone/>
+            </a:pPr>
+            <a:r>
+              <a:rPr lang="en-US" sz="1100" dirty="0">
+                <a:solidFill>
+                  <a:srgbClr val="5B6578"/>
+                </a:solidFill>
+                <a:latin typeface="Calibri" pitchFamily="34" charset="0"/>
+                <a:ea typeface="Calibri" pitchFamily="34" charset="-122"/>
+                <a:cs typeface="Calibri" pitchFamily="34" charset="-120"/>
+              </a:rPr>
+              <a:t>Ring wrap: 24 Sep wall-direct-absorber → ring-bare; 23 Sep tripod-unwrapped → ring-unwrapped. Carpet: 24 Sep, 2.054 → 1.317 dB.</a:t>
+            </a:r>
+            <a:endParaRPr lang="en-US" sz="1100" dirty="0"/>
+          </a:p>
+        </p:txBody>
+      </p:sp>
+      <p:sp>
+        <p:nvSpPr>
+          <p:cNvPr id="10" name="Text 7"/>
+          <p:cNvSpPr txBox="1"/>
+          <p:nvPr/>
+        </p:nvSpPr>
+        <p:spPr>
+          <a:xfrm>
+            <a:off x="11155680" y="6355080"/>
+            <a:ext cx="457200" cy="274320"/>
+          </a:xfrm>
+          <a:prstGeom prst="rect">
+            <a:avLst/>
+          </a:prstGeom>
+          <a:noFill/>
+          <a:ln/>
+        </p:spPr>
+        <p:txBody>
+          <a:bodyPr wrap="square" lIns="0" tIns="0" rIns="0" bIns="0" rtlCol="0" anchor="ctr"/>
+          <a:lstStyle/>
+          <a:p>
+            <a:pPr algn="r" indent="0" marL="0">
+              <a:buNone/>
+            </a:pPr>
+            <a:r>
+              <a:rPr lang="en-US" sz="1200" dirty="0">
+                <a:solidFill>
+                  <a:srgbClr val="5B6578"/>
+                </a:solidFill>
+                <a:latin typeface="Calibri" pitchFamily="34" charset="0"/>
+                <a:ea typeface="Calibri" pitchFamily="34" charset="-122"/>
+                <a:cs typeface="Calibri" pitchFamily="34" charset="-120"/>
+              </a:rPr>
+              <a:t>6</a:t>
+            </a:r>
+            <a:endParaRPr lang="en-US" sz="1200" dirty="0"/>
+          </a:p>
+        </p:txBody>
+      </p:sp>
+    </p:spTree>
+  </p:cSld>
+  <p:clrMapOvr>
+    <a:masterClrMapping/>
+  </p:clrMapOvr>
+</p:sld>
+</file>
+
+<file path=ppt/slides/slide7.xml><?xml version="1.0" encoding="utf-8"?>
+<p:sld xmlns:a="http://schemas.openxmlformats.org/drawingml/2006/main" xmlns:r="http://schemas.openxmlformats.org/officeDocument/2006/relationships" xmlns:p="http://schemas.openxmlformats.org/presentationml/2006/main">
+  <p:cSld name="Slide 7">
+    <p:bg>
+      <p:bgPr>
+        <a:solidFill>
+          <a:srgbClr val="FFFFFF"/>
+        </a:solidFill>
+      </p:bgPr>
+    </p:bg>
+    <p:spTree>
+      <p:nvGrpSpPr>
+        <p:cNvPr id="1" name=""/>
+        <p:cNvGrpSpPr/>
+        <p:nvPr/>
+      </p:nvGrpSpPr>
+      <p:grpSpPr>
+        <a:xfrm>
+          <a:off x="0" y="0"/>
+          <a:ext cx="0" cy="0"/>
+          <a:chOff x="0" y="0"/>
+          <a:chExt cx="0" cy="0"/>
+        </a:xfrm>
+      </p:grpSpPr>
+      <p:sp>
+        <p:nvSpPr>
+          <p:cNvPr id="2" name="Text 0"/>
+          <p:cNvSpPr txBox="1"/>
+          <p:nvPr/>
+        </p:nvSpPr>
+        <p:spPr>
+          <a:xfrm>
             <a:off x="8183880" y="457200"/>
             <a:ext cx="3566160" cy="320040"/>
           </a:xfrm>
@@ -3937,7 +4705,7 @@
       </p:sp>
       <p:graphicFrame>
         <p:nvGraphicFramePr>
-          <p:cNvPr id="7" name="Table 0"/>
+          <p:cNvPr id="8" name="Table 0"/>
           <p:cNvGraphicFramePr>
             <a:graphicFrameLocks noGrp="1"/>
           </p:cNvGraphicFramePr>
@@ -11333,7 +12101,7 @@
                 <a:ea typeface="Calibri" pitchFamily="34" charset="-122"/>
                 <a:cs typeface="Calibri" pitchFamily="34" charset="-120"/>
               </a:rPr>
-              <a:t>6</a:t>
+              <a:t>7</a:t>
             </a:r>
             <a:endParaRPr lang="en-US" sz="1200" dirty="0"/>
           </a:p>
@@ -11347,9 +12115,9 @@
 </p:sld>
 </file>
 
-<file path=ppt/slides/slide7.xml><?xml version="1.0" encoding="utf-8"?>
+<file path=ppt/slides/slide8.xml><?xml version="1.0" encoding="utf-8"?>
 <p:sld xmlns:a="http://schemas.openxmlformats.org/drawingml/2006/main" xmlns:r="http://schemas.openxmlformats.org/officeDocument/2006/relationships" xmlns:p="http://schemas.openxmlformats.org/presentationml/2006/main">
-  <p:cSld name="Slide 7">
+  <p:cSld name="Slide 8">
     <p:bg>
       <p:bgPr>
         <a:solidFill>
@@ -11730,7 +12498,7 @@
                 <a:ea typeface="Calibri" pitchFamily="34" charset="-122"/>
                 <a:cs typeface="Calibri" pitchFamily="34" charset="-120"/>
               </a:rPr>
-              <a:t>7</a:t>
+              <a:t>8</a:t>
             </a:r>
             <a:endParaRPr lang="en-US" sz="1200" dirty="0"/>
           </a:p>
@@ -11744,9 +12512,9 @@
 </p:sld>
 </file>
 
-<file path=ppt/slides/slide8.xml><?xml version="1.0" encoding="utf-8"?>
+<file path=ppt/slides/slide9.xml><?xml version="1.0" encoding="utf-8"?>
 <p:sld xmlns:a="http://schemas.openxmlformats.org/drawingml/2006/main" xmlns:r="http://schemas.openxmlformats.org/officeDocument/2006/relationships" xmlns:p="http://schemas.openxmlformats.org/presentationml/2006/main">
-  <p:cSld name="Slide 8">
+  <p:cSld name="Slide 9">
     <p:bg>
       <p:bgPr>
         <a:solidFill>
@@ -12613,7 +13381,7 @@
                 <a:ea typeface="Calibri" pitchFamily="34" charset="-122"/>
                 <a:cs typeface="Calibri" pitchFamily="34" charset="-120"/>
               </a:rPr>
-              <a:t>8</a:t>
+              <a:t>9</a:t>
             </a:r>
             <a:endParaRPr lang="en-US" sz="1200" dirty="0"/>
           </a:p>

</xml_diff>

<commit_message>
Slides: slide 6 shows all four Thinsulate wrap cases (largest change 0.02 dB)
Co-Authored-By: Claude Sonnet 5.5 <noreply@anthropic.com>
</commit_message>
<xml_diff>
--- a/docs/analysis/chamber-final-2026-10-01/slides/chamber-slides.pptx
+++ b/docs/analysis/chamber-final-2026-10-01/slides/chamber-slides.pptx
@@ -566,7 +566,7 @@
               <a:lstStyle/>
               <a:p>
                 <a:pPr>
-                  <a:defRPr b="0" i="0" strike="noStrike" sz="1400" u="none">
+                  <a:defRPr b="0" i="0" strike="noStrike" sz="1300" u="none">
                     <a:solidFill>
                       <a:srgbClr val="1F2A44"/>
                     </a:solidFill>
@@ -611,13 +611,35 @@
             <c:bubble3D val="0"/>
             <c:spPr>
               <a:solidFill>
+                <a:srgbClr val="9AA5B8"/>
+              </a:solidFill>
+              <a:effectLst/>
+            </c:spPr>
+          </c:dPt>
+          <c:dPt>
+            <c:idx val="3"/>
+            <c:invertIfNegative val="0"/>
+            <c:bubble3D val="0"/>
+            <c:spPr>
+              <a:solidFill>
+                <a:srgbClr val="9AA5B8"/>
+              </a:solidFill>
+              <a:effectLst/>
+            </c:spPr>
+          </c:dPt>
+          <c:dPt>
+            <c:idx val="4"/>
+            <c:invertIfNegative val="0"/>
+            <c:bubble3D val="0"/>
+            <c:spPr>
+              <a:solidFill>
                 <a:srgbClr val="C9CFDA"/>
               </a:solidFill>
               <a:effectLst/>
             </c:spPr>
           </c:dPt>
           <c:dPt>
-            <c:idx val="3"/>
+            <c:idx val="5"/>
             <c:invertIfNegative val="0"/>
             <c:bubble3D val="0"/>
             <c:spPr>
@@ -629,21 +651,27 @@
           </c:dPt>
           <c:cat>
             <c:multiLvlStrRef>
-              <c:f>Sheet1!$A$2:$A$5</c:f>
+              <c:f>Sheet1!$A$2:$A$7</c:f>
               <c:multiLvlStrCache>
-                <c:ptCount val="4"/>
+                <c:ptCount val="6"/>
                 <c:lvl>
                   <c:pt idx="0">
-                    <c:v>Ring wrap taken off, 24 Sep</c:v>
+                    <c:v>Tripod wrap partly off (23 Sep)</c:v>
                   </c:pt>
                   <c:pt idx="1">
-                    <c:v>Part of ring wrap off, 23 Sep</c:v>
+                    <c:v>Ring wrap, first part off (23 Sep)</c:v>
                   </c:pt>
                   <c:pt idx="2">
+                    <c:v>Ring wrap, more off (23 Sep)</c:v>
+                  </c:pt>
+                  <c:pt idx="3">
+                    <c:v>Rest of ring wrap off (24 Sep)</c:v>
+                  </c:pt>
+                  <c:pt idx="4">
                     <c:v>Handling alone (typical)</c:v>
                   </c:pt>
-                  <c:pt idx="3">
-                    <c:v>Carpet on the empty floor, 24 Sep</c:v>
+                  <c:pt idx="5">
+                    <c:v>Carpet on the empty floor (24 Sep)</c:v>
                   </c:pt>
                 </c:lvl>
               </c:multiLvlStrCache>
@@ -651,20 +679,26 @@
           </c:cat>
           <c:val>
             <c:numRef>
-              <c:f>Sheet1!$B$2:$B$5</c:f>
+              <c:f>Sheet1!$B$2:$B$7</c:f>
               <c:numCache>
                 <c:formatCode>General</c:formatCode>
-                <c:ptCount val="4"/>
+                <c:ptCount val="6"/>
                 <c:pt idx="0">
-                  <c:v>0.014</c:v>
+                  <c:v>0.004</c:v>
                 </c:pt>
                 <c:pt idx="1">
                   <c:v>0.018</c:v>
                 </c:pt>
                 <c:pt idx="2">
+                  <c:v>0.002</c:v>
+                </c:pt>
+                <c:pt idx="3">
+                  <c:v>0.014</c:v>
+                </c:pt>
+                <c:pt idx="4">
                   <c:v>0.04</c:v>
                 </c:pt>
-                <c:pt idx="3">
+                <c:pt idx="5">
                   <c:v>0.737</c:v>
                 </c:pt>
               </c:numCache>
@@ -678,7 +712,7 @@
             <a:lstStyle/>
             <a:p>
               <a:pPr>
-                <a:defRPr b="0" i="0" strike="noStrike" sz="1400" u="none">
+                <a:defRPr b="0" i="0" strike="noStrike" sz="1300" u="none">
                   <a:solidFill>
                     <a:srgbClr val="1F2A44"/>
                   </a:solidFill>
@@ -726,7 +760,7 @@
           <a:lstStyle/>
           <a:p>
             <a:pPr>
-              <a:defRPr sz="1400" b="0" i="0" u="none" strike="noStrike">
+              <a:defRPr sz="1300" b="0" i="0" u="none" strike="noStrike">
                 <a:solidFill>
                   <a:srgbClr val="1F2A44"/>
                 </a:solidFill>
@@ -1655,7 +1689,7 @@
           <a:p>
             <a:r>
               <a:rPr lang="en-US" dirty="0"/>
-              <a:t>Source: README of the chamber trials (docs/analysis/chamber-treatments-2026-09-23) and the loudspeaker sessions. 24 Sep: wall-direct-absorber (ring still wrapped) to ring-bare (the rest of the Thinsulate wrap removed from the ring), 10 minutes apart, speaker on the wall, nothing else changed: room error below 3 kHz 2.219 to 2.205 dB (-0.014); map change 0.36 dB spread over all capsules; 250-400 Hz -0.10, 1.6-3 kHz +0.04, 5-6.4 kHz +0.09. 23 Sep: tripod-unwrapped (ring wrapped) to ring-unwrapped (part removed): 1.387 to 1.406 dB (+0.018), map change 0.18 dB, a new hub mounting preset from there; ring-unwrapped to ring-unwrapped-2: +0.002. Repeat floor 0.006-0.015 dB, handling about 0.04 dB (README). Carpet on the empty floor: 24 Sep floor-no-wedges 2.054 to chaotic-carpet 1.317 dB (-0.737), source unmoved. 0.737 / 0.014 = 53, so about 50 times.</a:t>
+              <a:t>Source: README of the chamber trials (docs/analysis/chamber-treatments-2026-09-23) and the loudspeaker sessions, room error below 3 kHz. 23 Sep: foam-out 1.3837 to tripod-unwrapped 1.3874 (+0.004, some wrapping off the tripod legs); to ring-unwrapped 1.4057 (+0.018, part of the ring wrapping removed; a new hub mounting preset from there); to ring-unwrapped-2 1.4076 (+0.002, more of the ring unwrapped). 24 Sep, speaker on the wall (a different geometry): wall-direct-absorber 2.2193 to ring-bare 2.2054 (-0.014), the rest of the ring wrap removed, 10 minutes apart; map change 0.36 dB spread over all capsules. Three of the four changes are slightly worse, one slightly better. The README concludes the ring wrap is worth a little only at the high end, and that the best state measured was tripod bare and ring wrapped. Repeat floor 0.006-0.015 dB, handling about 0.04 dB (README). Carpet on the empty floor: 24 Sep floor-no-wedges 2.054 to chaotic-carpet 1.317 dB (-0.737), source unmoved. 0.737 / 0.018 = 40.</a:t>
             </a:r>
             <a:endParaRPr lang="en-US" dirty="0"/>
           </a:p>
@@ -4326,7 +4360,7 @@
         </p:nvSpPr>
         <p:spPr>
           <a:xfrm>
-            <a:off x="548640" y="1783080"/>
+            <a:off x="548640" y="1737360"/>
             <a:ext cx="6583680" cy="320040"/>
           </a:xfrm>
           <a:prstGeom prst="rect">
@@ -4364,8 +4398,8 @@
           <p:nvPr/>
         </p:nvGraphicFramePr>
         <p:xfrm>
-          <a:off x="457200" y="2103120"/>
-          <a:ext cx="6858000" cy="3931920"/>
+          <a:off x="457200" y="2057400"/>
+          <a:ext cx="7040880" cy="4160520"/>
         </p:xfrm>
         <a:graphic xmlns:a="http://schemas.openxmlformats.org/drawingml/2006/main">
           <a:graphicData uri="http://schemas.openxmlformats.org/drawingml/2006/chart">
@@ -4381,7 +4415,7 @@
         </p:nvSpPr>
         <p:spPr>
           <a:xfrm>
-            <a:off x="7863840" y="1828800"/>
+            <a:off x="7863840" y="1783080"/>
             <a:ext cx="3840480" cy="822960"/>
           </a:xfrm>
           <a:prstGeom prst="rect">
@@ -4406,7 +4440,7 @@
                 <a:ea typeface="Cambria" pitchFamily="34" charset="-122"/>
                 <a:cs typeface="Cambria" pitchFamily="34" charset="-120"/>
               </a:rPr>
-              <a:t>0.014 dB</a:t>
+              <a:t>0.02 dB</a:t>
             </a:r>
             <a:endParaRPr lang="en-US" sz="4800" dirty="0"/>
           </a:p>
@@ -4420,8 +4454,8 @@
         </p:nvSpPr>
         <p:spPr>
           <a:xfrm>
-            <a:off x="7863840" y="2697480"/>
-            <a:ext cx="3840480" cy="822960"/>
+            <a:off x="7863840" y="2651760"/>
+            <a:ext cx="3840480" cy="914400"/>
           </a:xfrm>
           <a:prstGeom prst="rect">
             <a:avLst/>
@@ -4445,7 +4479,7 @@
                 <a:ea typeface="Calibri" pitchFamily="34" charset="-122"/>
                 <a:cs typeface="Calibri" pitchFamily="34" charset="-120"/>
               </a:rPr>
-              <a:t>change in room error when the wrap came off (2.219 → 2.205 dB). Same day, loudspeaker unmoved.</a:t>
+              <a:t>at most: the largest change in room error from taking any Thinsulate wrap off the ring or the tripod, in four cases.</a:t>
             </a:r>
             <a:endParaRPr lang="en-US" sz="1400" dirty="0"/>
           </a:p>
@@ -4460,7 +4494,7 @@
         <p:spPr>
           <a:xfrm>
             <a:off x="7863840" y="3749040"/>
-            <a:ext cx="3840480" cy="2194560"/>
+            <a:ext cx="3840480" cy="2377440"/>
           </a:xfrm>
           <a:prstGeom prst="rect">
             <a:avLst/>
@@ -4488,7 +4522,7 @@
                 <a:ea typeface="Calibri" pitchFamily="34" charset="-122"/>
                 <a:cs typeface="Calibri" pitchFamily="34" charset="-120"/>
               </a:rPr>
-              <a:t>That is the size of the noise: the same state measured twice differs by 0.006–0.015 dB, and handling by about 0.04 dB.</a:t>
+              <a:t>Three cases got slightly worse, one slightly better: no clear effect.</a:t>
             </a:r>
             <a:endParaRPr lang="en-US" sz="1400" dirty="0"/>
           </a:p>
@@ -4509,7 +4543,28 @@
                 <a:ea typeface="Calibri" pitchFamily="34" charset="-122"/>
                 <a:cs typeface="Calibri" pitchFamily="34" charset="-120"/>
               </a:rPr>
-              <a:t>The carpet on the empty floor changed the error 50 times more.</a:t>
+              <a:t>The same state measured twice differs by 0.006–0.015 dB, and handling by about 0.04 dB.</a:t>
+            </a:r>
+            <a:endParaRPr lang="en-US" sz="1400" dirty="0"/>
+          </a:p>
+          <a:p>
+            <a:pPr marL="342900" indent="-342900">
+              <a:spcAft>
+                <a:spcPts val="800"/>
+              </a:spcAft>
+              <a:buSzPct val="100000"/>
+              <a:buChar char="•"/>
+            </a:pPr>
+            <a:r>
+              <a:rPr lang="en-US" sz="1400" dirty="0">
+                <a:solidFill>
+                  <a:srgbClr val="1F2A44"/>
+                </a:solidFill>
+                <a:latin typeface="Calibri" pitchFamily="34" charset="0"/>
+                <a:ea typeface="Calibri" pitchFamily="34" charset="-122"/>
+                <a:cs typeface="Calibri" pitchFamily="34" charset="-120"/>
+              </a:rPr>
+              <a:t>The carpet on the empty floor changed the error 40 times more.</a:t>
             </a:r>
             <a:endParaRPr lang="en-US" sz="1400" dirty="0"/>
           </a:p>
@@ -4548,7 +4603,7 @@
                 <a:ea typeface="Calibri" pitchFamily="34" charset="-122"/>
                 <a:cs typeface="Calibri" pitchFamily="34" charset="-120"/>
               </a:rPr>
-              <a:t>Ring wrap: 24 Sep wall-direct-absorber → ring-bare; 23 Sep tripod-unwrapped → ring-unwrapped. Carpet: 24 Sep, 2.054 → 1.317 dB.</a:t>
+              <a:t>Runs: foam-out → tripod-unwrapped → ring-unwrapped → -2 (23 Sep); wall-direct-absorber → ring-bare (24 Sep). Carpet: 2.054 → 1.317 dB.</a:t>
             </a:r>
             <a:endParaRPr lang="en-US" sz="1100" dirty="0"/>
           </a:p>

</xml_diff>

<commit_message>
Slides: Thinsulate slide left out of the deck, slide 7 relabelled a comparison, slide 3 numbers corrected (0.8-2.6 dB on average), polish fixes; report page 1 same correction
Co-Authored-By: Claude Sonnet 5.5 <noreply@anthropic.com>
</commit_message>
<xml_diff>
--- a/docs/analysis/chamber-final-2026-10-01/slides/chamber-slides.pptx
+++ b/docs/analysis/chamber-final-2026-10-01/slides/chamber-slides.pptx
@@ -13,10 +13,9 @@
     <p:sldId id="261" r:id="rId7"/>
     <p:sldId id="262" r:id="rId8"/>
     <p:sldId id="263" r:id="rId9"/>
-    <p:sldId id="264" r:id="rId10"/>
   </p:sldIdLst>
   <p:notesMasterIdLst>
-    <p:notesMasterId r:id="rId11"/>
+    <p:notesMasterId r:id="rId10"/>
   </p:notesMasterIdLst>
   <p:sldSz cx="12192000" cy="6858000"/>
   <p:notesSz cx="6858000" cy="12192000"/>
@@ -172,7 +171,7 @@
           </c:tx>
           <c:spPr>
             <a:solidFill>
-              <a:srgbClr val="9AA5B8"/>
+              <a:srgbClr val="D6336C"/>
             </a:solidFill>
             <a:effectLst/>
           </c:spPr>
@@ -273,7 +272,7 @@
           </c:tx>
           <c:spPr>
             <a:solidFill>
-              <a:srgbClr val="1F2A44"/>
+              <a:srgbClr val="2B6CB0"/>
             </a:solidFill>
             <a:effectLst/>
           </c:spPr>
@@ -510,334 +509,6 @@
         </a:p>
       </c:txPr>
     </c:legend>
-    <c:plotVisOnly val="1"/>
-    <c:dispBlanksAs val="span"/>
-  </c:chart>
-  <c:spPr>
-    <a:noFill/>
-    <a:ln>
-      <a:noFill/>
-    </a:ln>
-    <a:effectLst/>
-  </c:spPr>
-  <c:externalData r:id="rId1">
-    <c:autoUpdate val="0"/>
-  </c:externalData>
-</c:chartSpace>
-</file>
-
-<file path=ppt/charts/chart2.xml><?xml version="1.0" encoding="utf-8"?>
-<c:chartSpace xmlns:c="http://schemas.openxmlformats.org/drawingml/2006/chart" xmlns:a="http://schemas.openxmlformats.org/drawingml/2006/main" xmlns:r="http://schemas.openxmlformats.org/officeDocument/2006/relationships">
-  <c:date1904 val="0"/>
-  <c:roundedCorners val="1"/>
-  <c:chart>
-    <c:autoTitleDeleted val="1"/>
-    <c:plotArea>
-      <c:layout/>
-      <c:barChart>
-        <c:barDir val="bar"/>
-        <c:grouping val="clustered"/>
-        <c:varyColors val="0"/>
-        <c:ser>
-          <c:idx val="0"/>
-          <c:order val="0"/>
-          <c:tx>
-            <c:strRef>
-              <c:f>Sheet1!$B$1</c:f>
-              <c:strCache>
-                <c:ptCount val="1"/>
-                <c:pt idx="0">
-                  <c:v>Change in room error (dB)</c:v>
-                </c:pt>
-              </c:strCache>
-            </c:strRef>
-          </c:tx>
-          <c:spPr>
-            <a:solidFill>
-              <a:srgbClr val="9AA5B8"/>
-            </a:solidFill>
-            <a:effectLst/>
-          </c:spPr>
-          <c:invertIfNegative val="0"/>
-          <c:dLbls>
-            <c:numFmt formatCode="0.000" sourceLinked="0"/>
-            <c:txPr>
-              <a:bodyPr/>
-              <a:lstStyle/>
-              <a:p>
-                <a:pPr>
-                  <a:defRPr b="0" i="0" strike="noStrike" sz="1300" u="none">
-                    <a:solidFill>
-                      <a:srgbClr val="1F2A44"/>
-                    </a:solidFill>
-                    <a:latin typeface="Calibri"/>
-                  </a:defRPr>
-                </a:pPr>
-              </a:p>
-            </c:txPr>
-            <c:showLegendKey val="0"/>
-            <c:showVal val="1"/>
-            <c:showCatName val="0"/>
-            <c:showSerName val="0"/>
-            <c:showPercent val="0"/>
-            <c:showBubbleSize val="0"/>
-            <c:showLeaderLines val="0"/>
-          </c:dLbls>
-          <c:dPt>
-            <c:idx val="0"/>
-            <c:invertIfNegative val="0"/>
-            <c:bubble3D val="0"/>
-            <c:spPr>
-              <a:solidFill>
-                <a:srgbClr val="9AA5B8"/>
-              </a:solidFill>
-              <a:effectLst/>
-            </c:spPr>
-          </c:dPt>
-          <c:dPt>
-            <c:idx val="1"/>
-            <c:invertIfNegative val="0"/>
-            <c:bubble3D val="0"/>
-            <c:spPr>
-              <a:solidFill>
-                <a:srgbClr val="9AA5B8"/>
-              </a:solidFill>
-              <a:effectLst/>
-            </c:spPr>
-          </c:dPt>
-          <c:dPt>
-            <c:idx val="2"/>
-            <c:invertIfNegative val="0"/>
-            <c:bubble3D val="0"/>
-            <c:spPr>
-              <a:solidFill>
-                <a:srgbClr val="9AA5B8"/>
-              </a:solidFill>
-              <a:effectLst/>
-            </c:spPr>
-          </c:dPt>
-          <c:dPt>
-            <c:idx val="3"/>
-            <c:invertIfNegative val="0"/>
-            <c:bubble3D val="0"/>
-            <c:spPr>
-              <a:solidFill>
-                <a:srgbClr val="9AA5B8"/>
-              </a:solidFill>
-              <a:effectLst/>
-            </c:spPr>
-          </c:dPt>
-          <c:dPt>
-            <c:idx val="4"/>
-            <c:invertIfNegative val="0"/>
-            <c:bubble3D val="0"/>
-            <c:spPr>
-              <a:solidFill>
-                <a:srgbClr val="C9CFDA"/>
-              </a:solidFill>
-              <a:effectLst/>
-            </c:spPr>
-          </c:dPt>
-          <c:dPt>
-            <c:idx val="5"/>
-            <c:invertIfNegative val="0"/>
-            <c:bubble3D val="0"/>
-            <c:spPr>
-              <a:solidFill>
-                <a:srgbClr val="2B6CB0"/>
-              </a:solidFill>
-              <a:effectLst/>
-            </c:spPr>
-          </c:dPt>
-          <c:cat>
-            <c:multiLvlStrRef>
-              <c:f>Sheet1!$A$2:$A$7</c:f>
-              <c:multiLvlStrCache>
-                <c:ptCount val="6"/>
-                <c:lvl>
-                  <c:pt idx="0">
-                    <c:v>Tripod wrap partly off (23 Sep)</c:v>
-                  </c:pt>
-                  <c:pt idx="1">
-                    <c:v>Ring wrap, first part off (23 Sep)</c:v>
-                  </c:pt>
-                  <c:pt idx="2">
-                    <c:v>Ring wrap, more off (23 Sep)</c:v>
-                  </c:pt>
-                  <c:pt idx="3">
-                    <c:v>Rest of ring wrap off (24 Sep)</c:v>
-                  </c:pt>
-                  <c:pt idx="4">
-                    <c:v>Handling alone (typical)</c:v>
-                  </c:pt>
-                  <c:pt idx="5">
-                    <c:v>Carpet on the empty floor (24 Sep)</c:v>
-                  </c:pt>
-                </c:lvl>
-              </c:multiLvlStrCache>
-            </c:multiLvlStrRef>
-          </c:cat>
-          <c:val>
-            <c:numRef>
-              <c:f>Sheet1!$B$2:$B$7</c:f>
-              <c:numCache>
-                <c:formatCode>General</c:formatCode>
-                <c:ptCount val="6"/>
-                <c:pt idx="0">
-                  <c:v>0.004</c:v>
-                </c:pt>
-                <c:pt idx="1">
-                  <c:v>0.018</c:v>
-                </c:pt>
-                <c:pt idx="2">
-                  <c:v>0.002</c:v>
-                </c:pt>
-                <c:pt idx="3">
-                  <c:v>0.014</c:v>
-                </c:pt>
-                <c:pt idx="4">
-                  <c:v>0.04</c:v>
-                </c:pt>
-                <c:pt idx="5">
-                  <c:v>0.737</c:v>
-                </c:pt>
-              </c:numCache>
-            </c:numRef>
-          </c:val>
-        </c:ser>
-        <c:dLbls>
-          <c:numFmt formatCode="0.000" sourceLinked="0"/>
-          <c:txPr>
-            <a:bodyPr/>
-            <a:lstStyle/>
-            <a:p>
-              <a:pPr>
-                <a:defRPr b="0" i="0" strike="noStrike" sz="1300" u="none">
-                  <a:solidFill>
-                    <a:srgbClr val="1F2A44"/>
-                  </a:solidFill>
-                  <a:latin typeface="Calibri"/>
-                </a:defRPr>
-              </a:pPr>
-            </a:p>
-          </c:txPr>
-          <c:showLegendKey val="0"/>
-          <c:showVal val="1"/>
-          <c:showCatName val="0"/>
-          <c:showSerName val="0"/>
-          <c:showPercent val="0"/>
-          <c:showBubbleSize val="0"/>
-          <c:showLeaderLines val="0"/>
-        </c:dLbls>
-        <c:gapWidth val="45"/>
-        <c:overlap val="0"/>
-        <c:axId val="2094734554"/>
-        <c:axId val="2094734552"/>
-        <c:axId val="2094734556"/>
-      </c:barChart>
-      <c:catAx>
-        <c:axId val="2094734554"/>
-        <c:scaling>
-          <c:orientation val="maxMin"/>
-        </c:scaling>
-        <c:delete val="0"/>
-        <c:axPos val="l"/>
-        <c:numFmt formatCode="General" sourceLinked="1"/>
-        <c:majorTickMark val="out"/>
-        <c:minorTickMark val="none"/>
-        <c:tickLblPos val="low"/>
-        <c:spPr>
-          <a:ln w="12700" cap="flat">
-            <a:solidFill>
-              <a:srgbClr val="888888"/>
-            </a:solidFill>
-            <a:prstDash val="solid"/>
-            <a:round/>
-          </a:ln>
-        </c:spPr>
-        <c:txPr>
-          <a:bodyPr/>
-          <a:lstStyle/>
-          <a:p>
-            <a:pPr>
-              <a:defRPr sz="1300" b="0" i="0" u="none" strike="noStrike">
-                <a:solidFill>
-                  <a:srgbClr val="1F2A44"/>
-                </a:solidFill>
-                <a:latin typeface="Calibri"/>
-              </a:defRPr>
-            </a:pPr>
-            <a:endParaRPr lang="en-US"/>
-          </a:p>
-        </c:txPr>
-        <c:crossAx val="2094734552"/>
-        <c:crosses val="autoZero"/>
-        <c:auto val="1"/>
-        <c:lblAlgn val="ctr"/>
-        <c:noMultiLvlLbl val="1"/>
-        <c:tickLblSkip val="1"/>
-      </c:catAx>
-      <c:valAx>
-        <c:axId val="2094734552"/>
-        <c:scaling>
-          <c:orientation val="minMax"/>
-          <c:max val="0.9"/>
-          <c:min val="0"/>
-        </c:scaling>
-        <c:delete val="0"/>
-        <c:axPos val="b"/>
-        <c:majorGridlines>
-          <c:spPr>
-            <a:ln w="6350" cap="flat">
-              <a:solidFill>
-                <a:srgbClr val="E3E7EE"/>
-              </a:solidFill>
-              <a:prstDash val="solid"/>
-              <a:round/>
-            </a:ln>
-          </c:spPr>
-        </c:majorGridlines>
-        <c:numFmt formatCode="0.0" sourceLinked="0"/>
-        <c:majorTickMark val="out"/>
-        <c:minorTickMark val="none"/>
-        <c:tickLblPos val="low"/>
-        <c:spPr>
-          <a:ln w="12700" cap="flat">
-            <a:solidFill>
-              <a:srgbClr val="888888"/>
-            </a:solidFill>
-            <a:prstDash val="solid"/>
-            <a:round/>
-          </a:ln>
-        </c:spPr>
-        <c:txPr>
-          <a:bodyPr/>
-          <a:lstStyle/>
-          <a:p>
-            <a:pPr>
-              <a:defRPr sz="1200" b="0" i="0" u="none" strike="noStrike">
-                <a:solidFill>
-                  <a:srgbClr val="5B6578"/>
-                </a:solidFill>
-                <a:latin typeface="Calibri"/>
-              </a:defRPr>
-            </a:pPr>
-            <a:endParaRPr lang="en-US"/>
-          </a:p>
-        </c:txPr>
-        <c:crossAx val="2094734554"/>
-        <c:crosses val="autoZero"/>
-        <c:crossBetween val="between"/>
-        <c:majorUnit val="0.3"/>
-      </c:valAx>
-      <c:spPr>
-        <a:noFill/>
-        <a:ln>
-          <a:noFill/>
-        </a:ln>
-        <a:effectLst/>
-      </c:spPr>
-    </c:plotArea>
     <c:plotVisOnly val="1"/>
     <c:dispBlanksAs val="span"/>
   </c:chart>
@@ -1425,7 +1096,7 @@
           <a:p>
             <a:r>
               <a:rPr lang="en-US" dirty="0"/>
-              <a:t>Procedure (calibrator/session.py, 2026-09-16 session): each of the eleven UMIK-2 capsules was plugged in at the same mounting point in front of the loudspeaker and measured over 97 stepped tones, 62 Hz to 16 kHz (about 12 per octave), amplitude 0.03, 48 kHz sampling, 0.7 s settle and 2 s capture per tone (6 s below 250 Hz). Capsule 810-8904 was measured three full times (18:21, 18:30, 20:43) as the reference. The difference of each capsule from the reference was folded into its calibration curve; Sens Factors kept as in the factory files. The datum is the mean of four capsules whose factory files agree with measurement (810-8900, 810-8903, 811-1896, 811-2321). Spread 4.01 to 0.02 dB and 7 of 11 files wrong by 0.6-3.6 dB are from the project notes. Seven capsules had a mean offset beyond 0.6 dB (811-1892 -2.6, 811-1897 -1.4, 811-2310 -0.8, 810-8897 +0.8, 810-8901 +0.8, 810-8904 +0.9, 810-8893 +1.3). Absolute level is not anchored: that needs a 94 dB calibrator.</a:t>
+              <a:t>Procedure (calibrator/session.py, 2026-09-16 session): each of the eleven UMIK-2 capsules was plugged in at the same mounting point in front of the loudspeaker and measured over 97 stepped tones, 62 Hz to 16 kHz (about 12 per octave), amplitude 0.03, 48 kHz sampling, 0.7 s settle and 2 s capture per tone (6 s below 250 Hz). Capsule 810-8904 was measured three full times (18:21, 18:30, 20:43) as the reference. The difference of each capsule from the reference was folded into its calibration curve; Sens Factors kept as in the factory files. The datum is the mean of four capsules whose factory files agree with measurement (810-8900, 810-8903, 811-1896, 811-2321). Spread 4.01 to 0.02 dB is from the project notes: a same-session check, since the corrections come from this session, and the absolute level is not anchored (that needs a 94 dB calibrator). Seven capsules have a mean offset beyond 0.6 dB over frequency, between 0.76 and 2.59 dB; the worst single frequency is 3.48 dB (811-1892), from CORRECTIONS-2026-09-16.csv. Seven capsules had a mean offset beyond 0.6 dB (811-1892 -2.6, 811-1897 -1.4, 811-2310 -0.8, 810-8897 +0.8, 810-8901 +0.8, 810-8904 +0.9, 810-8893 +1.3). Absolute level is not anchored: that needs a 94 dB calibrator.</a:t>
             </a:r>
             <a:endParaRPr lang="en-US" dirty="0"/>
           </a:p>
@@ -1689,7 +1360,7 @@
           <a:p>
             <a:r>
               <a:rPr lang="en-US" dirty="0"/>
-              <a:t>Source: README of the chamber trials (docs/analysis/chamber-treatments-2026-09-23) and the loudspeaker sessions, room error below 3 kHz. 23 Sep: foam-out 1.3837 to tripod-unwrapped 1.3874 (+0.004, some wrapping off the tripod legs); to ring-unwrapped 1.4057 (+0.018, part of the ring wrapping removed; a new hub mounting preset from there); to ring-unwrapped-2 1.4076 (+0.002, more of the ring unwrapped). 24 Sep, speaker on the wall (a different geometry): wall-direct-absorber 2.2193 to ring-bare 2.2054 (-0.014), the rest of the ring wrap removed, 10 minutes apart; map change 0.36 dB spread over all capsules. Three of the four changes are slightly worse, one slightly better. The README concludes the ring wrap is worth a little only at the high end, and that the best state measured was tripod bare and ring wrapped. Repeat floor 0.006-0.015 dB, handling about 0.04 dB (README). Carpet on the empty floor: 24 Sep floor-no-wedges 2.054 to chaotic-carpet 1.317 dB (-0.737), source unmoved. 0.737 / 0.018 = 40.</a:t>
+              <a:t>Same table as page 4 of the report. Each one-third-octave band is judged against the anechoic tolerance values of ISO 5305 Table 1 (also ISO 3745 as printed by Cunefare 2003): +-1.5 dB for 125-630 Hz, +-1.0 dB for 800-5000 Hz. The number is the worst microphone band-mean deviation from the arc mean, in dB; the colour is that number as a share of the limit. Cells in limit counts tone x microphone cells inside the limit (3 tones x 11 microphones = 33 cells at 250 Hz, where the grid starts at 257 Hz). This is an analogue: the standards use a traverse and test decay with distance, we use eleven fixed microphones at one radius. The room is treated and not qualified. Within the tolerance values from 1250 Hz at the start of day 3 and from 2000 Hz in the final state, up to 2500 Hz. The rows marked * (5000 and 6300 Hz) are partial: 4 and 5 tones above 5 kHz, the limit is +-1.0 dB at 5000 Hz and +-1.5 dB at 6300 Hz (ISO 5305 Table 1). Both are over the limit in both states (1.24 and 1.23 dB; 1.59 and 1.77 dB). The 3150 and 4000 Hz bands are not shown: no tones between 3 and 5 kHz because of the rocking mode of the sphere at about 4.4 kHz. Caveat: the loudspeaker position was not documented across the day.</a:t>
             </a:r>
             <a:endParaRPr lang="en-US" dirty="0"/>
           </a:p>
@@ -1777,7 +1448,7 @@
           <a:p>
             <a:r>
               <a:rPr lang="en-US" dirty="0"/>
-              <a:t>Same table as page 4 of the report. Each one-third-octave band is judged against the anechoic tolerance values of ISO 5305 Table 1 (also ISO 3745 as printed by Cunefare 2003): +-1.5 dB for 125-630 Hz, +-1.0 dB for 800-5000 Hz. The number is the worst microphone band-mean deviation from the arc mean, in dB; the colour is that number as a share of the limit. Cells in limit counts tone x microphone cells inside the limit (3 tones x 11 microphones = 33 cells at 250 Hz, where the grid starts at 257 Hz). This is an analogue: the standards use a traverse and test decay with distance, we use eleven fixed microphones at one radius. The room is treated and not qualified. Within the tolerance values from 1250 Hz at the start of day 3 and from 2000 Hz in the final state, up to 2500 Hz. The rows marked * (5000 and 6300 Hz) are partial: 4 and 5 tones above 5 kHz, the limit is +-1.0 dB at 5000 Hz and +-1.5 dB at 6300 Hz (ISO 5305 Table 1). Both are over the limit in both states (1.24 and 1.23 dB; 1.59 and 1.77 dB). The 3150 and 4000 Hz bands are not shown: no tones between 3 and 5 kHz because of the rocking mode of the sphere at about 4.4 kHz. Caveat: the loudspeaker position was not documented across the day.</a:t>
+              <a:t>Blue: 30 Sep propeller measurement (11.7 V, 7.3 A, thrust -4 N), read with the 16 Sep microphone corrections. Rms spread about the mean 1.45 dB against 2.05 dB for 31 Aug; range 4.0 dB (55.5 to 59.6 dB SPL) against 6.7 dB. The blue is about 11 dB lower because the motor ran at a different operating point. The 4 dB range of the blue is a bottom-louder trend. Honest caveat: with the same calibration applied to the 1-2 Sep runs, those are about as round as 30 Sep, so most of the improvement against the earlier baselines comes from the microphone calibration, not the room.</a:t>
             </a:r>
             <a:endParaRPr lang="en-US" dirty="0"/>
           </a:p>
@@ -1865,7 +1536,7 @@
           <a:p>
             <a:r>
               <a:rPr lang="en-US" dirty="0"/>
-              <a:t>Blue: 30 Sep propeller measurement (11.7 V, 7.3 A, thrust -4 N), read with the 16 Sep microphone corrections. Rms spread about the mean 1.45 dB against 2.05 dB for 31 Aug; range 4.0 dB (55.5 to 59.6 dB SPL) against 6.7 dB. The blue is about 11 dB lower because the motor ran at a different operating point. The 4 dB range of the blue is a bottom-louder trend. Honest caveat: with the same calibration applied to the 1-2 Sep runs, those are about as round as 30 Sep, so most of the improvement against the earlier baselines comes from the microphone calibration, not the room.</a:t>
+              <a:t>Bases of 2 Oct 2026 in the data repo: 2004__5in3b__unset__v1-naked-horizontal, ...cork__v1-cork-horizontal, ...rubber__v1-rubber, ...felt__v1-felt, ...felt-rubber__v1-felt-rubber. Each capture is the PWM 2000 step; level per microphone is the total level 100 Hz to 10 kHz in dB SPL, read with the corrected microphone files (all after 16 Sep). The polar is mirrored to 360 degrees. Mean over the eleven positions: naked 74.2, cork 78.7, rubber 80.6, felt 79.5, felt plus rubber 78.7 dB. At -90 degrees (the outflow) all five are 93.7 to 98.3 dB. The slide shows levels as measured; operating points (voltage, thrust) were not compared here.</a:t>
             </a:r>
             <a:endParaRPr lang="en-US" dirty="0"/>
           </a:p>
@@ -1889,94 +1560,6 @@
             <a:fld id="{F7021451-1387-4CA6-816F-3879F97B5CBC}" type="slidenum">
               <a:rPr lang="en-US"/>
               <a:t>8</a:t>
-            </a:fld>
-            <a:endParaRPr lang="en-US"/>
-          </a:p>
-        </p:txBody>
-      </p:sp>
-    </p:spTree>
-    <p:extLst>
-      <p:ext uri="{BB962C8B-B14F-4D97-AF65-F5344CB8AC3E}">
-        <p14:creationId xmlns:p14="http://schemas.microsoft.com/office/powerpoint/2010/main" val="1024086991"/>
-      </p:ext>
-    </p:extLst>
-  </p:cSld>
-  <p:clrMapOvr>
-    <a:masterClrMapping/>
-  </p:clrMapOvr>
-</p:notes>
-</file>
-
-<file path=ppt/notesSlides/notesSlide9.xml><?xml version="1.0" encoding="utf-8"?>
-<p:notes xmlns:a="http://schemas.openxmlformats.org/drawingml/2006/main" xmlns:r="http://schemas.openxmlformats.org/officeDocument/2006/relationships" xmlns:p="http://schemas.openxmlformats.org/presentationml/2006/main">
-  <p:cSld>
-    <p:spTree>
-      <p:nvGrpSpPr>
-        <p:cNvPr id="1" name=""/>
-        <p:cNvGrpSpPr/>
-        <p:nvPr/>
-      </p:nvGrpSpPr>
-      <p:grpSpPr>
-        <a:xfrm>
-          <a:off x="0" y="0"/>
-          <a:ext cx="0" cy="0"/>
-          <a:chOff x="0" y="0"/>
-          <a:chExt cx="0" cy="0"/>
-        </a:xfrm>
-      </p:grpSpPr>
-      <p:sp>
-        <p:nvSpPr>
-          <p:cNvPr id="2" name="Slide Image Placeholder 1"/>
-          <p:cNvSpPr>
-            <a:spLocks noGrp="1" noRot="1" noChangeAspect="1"/>
-          </p:cNvSpPr>
-          <p:nvPr>
-            <p:ph type="sldImg"/>
-          </p:nvPr>
-        </p:nvSpPr>
-        <p:spPr/>
-      </p:sp>
-      <p:sp>
-        <p:nvSpPr>
-          <p:cNvPr id="3" name="Notes Placeholder 2"/>
-          <p:cNvSpPr>
-            <a:spLocks noGrp="1"/>
-          </p:cNvSpPr>
-          <p:nvPr>
-            <p:ph type="body" idx="1"/>
-          </p:nvPr>
-        </p:nvSpPr>
-        <p:spPr/>
-        <p:txBody>
-          <a:bodyPr/>
-          <a:lstStyle/>
-          <a:p>
-            <a:r>
-              <a:rPr lang="en-US" dirty="0"/>
-              <a:t>Bases of 2 Oct 2026 in the data repo: 2004__5in3b__unset__v1-naked-horizontal, ...cork__v1-cork-horizontal, ...rubber__v1-rubber, ...felt__v1-felt, ...felt-rubber__v1-felt-rubber. Each capture is the PWM 2000 step; level per microphone is the total level 100 Hz to 10 kHz in dB SPL, read with the corrected microphone files (all after 16 Sep). The polar is mirrored to 360 degrees. Mean over the eleven positions: naked 74.2, cork 78.7, rubber 80.6, felt 79.5, felt plus rubber 78.7 dB. At -90 degrees (the outflow) all five are 93.7 to 98.3 dB. The slide shows levels as measured; operating points (voltage, thrust) were not compared here.</a:t>
-            </a:r>
-            <a:endParaRPr lang="en-US" dirty="0"/>
-          </a:p>
-        </p:txBody>
-      </p:sp>
-      <p:sp>
-        <p:nvSpPr>
-          <p:cNvPr id="4" name="Slide Number Placeholder 3"/>
-          <p:cNvSpPr>
-            <a:spLocks noGrp="1"/>
-          </p:cNvSpPr>
-          <p:nvPr>
-            <p:ph type="sldNum" sz="quarter" idx="10"/>
-          </p:nvPr>
-        </p:nvSpPr>
-        <p:spPr/>
-        <p:txBody>
-          <a:bodyPr/>
-          <a:lstStyle/>
-          <a:p>
-            <a:fld id="{F7021451-1387-4CA6-816F-3879F97B5CBC}" type="slidenum">
-              <a:rPr lang="en-US"/>
-              <a:t>9</a:t>
             </a:fld>
             <a:endParaRPr lang="en-US"/>
           </a:p>
@@ -3339,7 +2922,7 @@
                 <a:ea typeface="Calibri" pitchFamily="34" charset="-122"/>
                 <a:cs typeface="Calibri" pitchFamily="34" charset="-120"/>
               </a:rPr>
-              <a:t>7 of 11 factory files were wrong by 0.6–3.6 dB</a:t>
+              <a:t>7 of 11 factory files were off by 0.8–2.6 dB on average</a:t>
             </a:r>
             <a:endParaRPr lang="en-US" sz="1400" dirty="0"/>
           </a:p>
@@ -3471,8 +3054,8 @@
         </p:blipFill>
         <p:spPr>
           <a:xfrm>
-            <a:off x="320040" y="274320"/>
-            <a:ext cx="7498080" cy="5833872"/>
+            <a:off x="274320" y="274320"/>
+            <a:ext cx="7370064" cy="5852160"/>
           </a:xfrm>
           <a:prstGeom prst="rect">
             <a:avLst/>
@@ -3830,7 +3413,7 @@
                 <a:ea typeface="Calibri" pitchFamily="34" charset="-122"/>
                 <a:cs typeface="Calibri" pitchFamily="34" charset="-120"/>
               </a:rPr>
-              <a:t>Captures from 25 Sep 2026: day3-a (left) and carpet-reordered (right).</a:t>
+              <a:t>Two captures from 25 Sep 2026: the start of day 3 (left) and the final configuration (right).</a:t>
             </a:r>
             <a:endParaRPr lang="en-US" sz="1100" dirty="0"/>
           </a:p>
@@ -3923,8 +3506,8 @@
         </p:blipFill>
         <p:spPr>
           <a:xfrm>
-            <a:off x="320040" y="274320"/>
-            <a:ext cx="6958584" cy="5897880"/>
+            <a:off x="274320" y="274320"/>
+            <a:ext cx="6940296" cy="5897880"/>
           </a:xfrm>
           <a:prstGeom prst="rect">
             <a:avLst/>
@@ -4172,8 +3755,8 @@
         </p:nvSpPr>
         <p:spPr>
           <a:xfrm>
-            <a:off x="548640" y="6355080"/>
-            <a:ext cx="10332720" cy="274320"/>
+            <a:off x="548640" y="6263640"/>
+            <a:ext cx="10424160" cy="411480"/>
           </a:xfrm>
           <a:prstGeom prst="rect">
             <a:avLst/>
@@ -4182,7 +3765,7 @@
           <a:ln/>
         </p:spPr>
         <p:txBody>
-          <a:bodyPr wrap="square" lIns="0" tIns="0" rIns="0" bIns="0" rtlCol="0" anchor="ctr"/>
+          <a:bodyPr wrap="square" lIns="0" tIns="0" rIns="0" bIns="0" rtlCol="0" anchor="t"/>
           <a:lstStyle/>
           <a:p>
             <a:pPr indent="0" marL="0">
@@ -4197,7 +3780,7 @@
                 <a:ea typeface="Calibri" pitchFamily="34" charset="-122"/>
                 <a:cs typeface="Calibri" pitchFamily="34" charset="-120"/>
               </a:rPr>
-              <a:t>25 Sep 2026. The loudspeaker was moved during the day and returned to about its starting point; the position was not documented.</a:t>
+              <a:t>25 Sep 2026. The loudspeaker was moved during the day and returned to about its starting point; the position was not documented. Room error: rms difference of the eleven microphones from their average.</a:t>
             </a:r>
             <a:endParaRPr lang="en-US" sz="1100" dirty="0"/>
           </a:p>
@@ -4253,412 +3836,6 @@
 <file path=ppt/slides/slide6.xml><?xml version="1.0" encoding="utf-8"?>
 <p:sld xmlns:a="http://schemas.openxmlformats.org/drawingml/2006/main" xmlns:r="http://schemas.openxmlformats.org/officeDocument/2006/relationships" xmlns:p="http://schemas.openxmlformats.org/presentationml/2006/main">
   <p:cSld name="Slide 6">
-    <p:bg>
-      <p:bgPr>
-        <a:solidFill>
-          <a:srgbClr val="FFFFFF"/>
-        </a:solidFill>
-      </p:bgPr>
-    </p:bg>
-    <p:spTree>
-      <p:nvGrpSpPr>
-        <p:cNvPr id="1" name=""/>
-        <p:cNvGrpSpPr/>
-        <p:nvPr/>
-      </p:nvGrpSpPr>
-      <p:grpSpPr>
-        <a:xfrm>
-          <a:off x="0" y="0"/>
-          <a:ext cx="0" cy="0"/>
-          <a:chOff x="0" y="0"/>
-          <a:chExt cx="0" cy="0"/>
-        </a:xfrm>
-      </p:grpSpPr>
-      <p:sp>
-        <p:nvSpPr>
-          <p:cNvPr id="2" name="Text 0"/>
-          <p:cNvSpPr txBox="1"/>
-          <p:nvPr/>
-        </p:nvSpPr>
-        <p:spPr>
-          <a:xfrm>
-            <a:off x="548640" y="457200"/>
-            <a:ext cx="5486400" cy="320040"/>
-          </a:xfrm>
-          <a:prstGeom prst="rect">
-            <a:avLst/>
-          </a:prstGeom>
-          <a:noFill/>
-          <a:ln/>
-        </p:spPr>
-        <p:txBody>
-          <a:bodyPr wrap="square" lIns="0" tIns="0" rIns="0" bIns="0" rtlCol="0" anchor="ctr"/>
-          <a:lstStyle/>
-          <a:p>
-            <a:pPr indent="0" marL="0">
-              <a:buNone/>
-            </a:pPr>
-            <a:r>
-              <a:rPr lang="en-US" sz="1400" b="1" spc="300" kern="0" dirty="0">
-                <a:solidFill>
-                  <a:srgbClr val="2B6CB0"/>
-                </a:solidFill>
-                <a:latin typeface="Calibri" pitchFamily="34" charset="0"/>
-                <a:ea typeface="Calibri" pitchFamily="34" charset="-122"/>
-                <a:cs typeface="Calibri" pitchFamily="34" charset="-120"/>
-              </a:rPr>
-              <a:t>THE RING WRAP</a:t>
-            </a:r>
-            <a:endParaRPr lang="en-US" sz="1400" dirty="0"/>
-          </a:p>
-        </p:txBody>
-      </p:sp>
-      <p:sp>
-        <p:nvSpPr>
-          <p:cNvPr id="3" name="Text 1"/>
-          <p:cNvSpPr txBox="1"/>
-          <p:nvPr/>
-        </p:nvSpPr>
-        <p:spPr>
-          <a:xfrm>
-            <a:off x="548640" y="777240"/>
-            <a:ext cx="11064240" cy="731520"/>
-          </a:xfrm>
-          <a:prstGeom prst="rect">
-            <a:avLst/>
-          </a:prstGeom>
-          <a:noFill/>
-          <a:ln/>
-        </p:spPr>
-        <p:txBody>
-          <a:bodyPr wrap="square" lIns="0" tIns="0" rIns="0" bIns="0" rtlCol="0" anchor="t"/>
-          <a:lstStyle/>
-          <a:p>
-            <a:pPr indent="0" marL="0">
-              <a:buNone/>
-            </a:pPr>
-            <a:r>
-              <a:rPr lang="en-US" sz="3200" b="1" dirty="0">
-                <a:solidFill>
-                  <a:srgbClr val="1F2A44"/>
-                </a:solidFill>
-                <a:latin typeface="Cambria" pitchFamily="34" charset="0"/>
-                <a:ea typeface="Cambria" pitchFamily="34" charset="-122"/>
-                <a:cs typeface="Cambria" pitchFamily="34" charset="-120"/>
-              </a:rPr>
-              <a:t>Thinsulate on the ring hardly matters</a:t>
-            </a:r>
-            <a:endParaRPr lang="en-US" sz="3200" dirty="0"/>
-          </a:p>
-        </p:txBody>
-      </p:sp>
-      <p:sp>
-        <p:nvSpPr>
-          <p:cNvPr id="4" name="Text 2"/>
-          <p:cNvSpPr txBox="1"/>
-          <p:nvPr/>
-        </p:nvSpPr>
-        <p:spPr>
-          <a:xfrm>
-            <a:off x="548640" y="1737360"/>
-            <a:ext cx="6583680" cy="320040"/>
-          </a:xfrm>
-          <a:prstGeom prst="rect">
-            <a:avLst/>
-          </a:prstGeom>
-          <a:noFill/>
-          <a:ln/>
-        </p:spPr>
-        <p:txBody>
-          <a:bodyPr wrap="square" lIns="0" tIns="0" rIns="0" bIns="0" rtlCol="0" anchor="ctr"/>
-          <a:lstStyle/>
-          <a:p>
-            <a:pPr indent="0" marL="0">
-              <a:buNone/>
-            </a:pPr>
-            <a:r>
-              <a:rPr lang="en-US" sz="1400" b="1" dirty="0">
-                <a:solidFill>
-                  <a:srgbClr val="1F2A44"/>
-                </a:solidFill>
-                <a:latin typeface="Calibri" pitchFamily="34" charset="0"/>
-                <a:ea typeface="Calibri" pitchFamily="34" charset="-122"/>
-                <a:cs typeface="Calibri" pitchFamily="34" charset="-120"/>
-              </a:rPr>
-              <a:t>Size of the change in room error (dB)</a:t>
-            </a:r>
-            <a:endParaRPr lang="en-US" sz="1400" dirty="0"/>
-          </a:p>
-        </p:txBody>
-      </p:sp>
-      <p:graphicFrame>
-        <p:nvGraphicFramePr>
-          <p:cNvPr id="5" name="Chart 0" descr=""/>
-          <p:cNvGraphicFramePr/>
-          <p:nvPr/>
-        </p:nvGraphicFramePr>
-        <p:xfrm>
-          <a:off x="457200" y="2057400"/>
-          <a:ext cx="7040880" cy="4160520"/>
-        </p:xfrm>
-        <a:graphic xmlns:a="http://schemas.openxmlformats.org/drawingml/2006/main">
-          <a:graphicData uri="http://schemas.openxmlformats.org/drawingml/2006/chart">
-            <c:chart xmlns:c="http://schemas.openxmlformats.org/drawingml/2006/chart" r:id="rId1"/>
-          </a:graphicData>
-        </a:graphic>
-      </p:graphicFrame>
-      <p:sp>
-        <p:nvSpPr>
-          <p:cNvPr id="6" name="Text 3"/>
-          <p:cNvSpPr txBox="1"/>
-          <p:nvPr/>
-        </p:nvSpPr>
-        <p:spPr>
-          <a:xfrm>
-            <a:off x="7863840" y="1783080"/>
-            <a:ext cx="3840480" cy="822960"/>
-          </a:xfrm>
-          <a:prstGeom prst="rect">
-            <a:avLst/>
-          </a:prstGeom>
-          <a:noFill/>
-          <a:ln/>
-        </p:spPr>
-        <p:txBody>
-          <a:bodyPr wrap="square" lIns="0" tIns="0" rIns="0" bIns="0" rtlCol="0" anchor="ctr"/>
-          <a:lstStyle/>
-          <a:p>
-            <a:pPr indent="0" marL="0">
-              <a:buNone/>
-            </a:pPr>
-            <a:r>
-              <a:rPr lang="en-US" sz="4800" b="1" dirty="0">
-                <a:solidFill>
-                  <a:srgbClr val="D6336C"/>
-                </a:solidFill>
-                <a:latin typeface="Cambria" pitchFamily="34" charset="0"/>
-                <a:ea typeface="Cambria" pitchFamily="34" charset="-122"/>
-                <a:cs typeface="Cambria" pitchFamily="34" charset="-120"/>
-              </a:rPr>
-              <a:t>0.02 dB</a:t>
-            </a:r>
-            <a:endParaRPr lang="en-US" sz="4800" dirty="0"/>
-          </a:p>
-        </p:txBody>
-      </p:sp>
-      <p:sp>
-        <p:nvSpPr>
-          <p:cNvPr id="7" name="Text 4"/>
-          <p:cNvSpPr txBox="1"/>
-          <p:nvPr/>
-        </p:nvSpPr>
-        <p:spPr>
-          <a:xfrm>
-            <a:off x="7863840" y="2651760"/>
-            <a:ext cx="3840480" cy="914400"/>
-          </a:xfrm>
-          <a:prstGeom prst="rect">
-            <a:avLst/>
-          </a:prstGeom>
-          <a:noFill/>
-          <a:ln/>
-        </p:spPr>
-        <p:txBody>
-          <a:bodyPr wrap="square" lIns="0" tIns="0" rIns="0" bIns="0" rtlCol="0" anchor="t"/>
-          <a:lstStyle/>
-          <a:p>
-            <a:pPr indent="0" marL="0">
-              <a:buNone/>
-            </a:pPr>
-            <a:r>
-              <a:rPr lang="en-US" sz="1400" dirty="0">
-                <a:solidFill>
-                  <a:srgbClr val="1F2A44"/>
-                </a:solidFill>
-                <a:latin typeface="Calibri" pitchFamily="34" charset="0"/>
-                <a:ea typeface="Calibri" pitchFamily="34" charset="-122"/>
-                <a:cs typeface="Calibri" pitchFamily="34" charset="-120"/>
-              </a:rPr>
-              <a:t>at most: the largest change in room error from taking any Thinsulate wrap off the ring or the tripod, in four cases.</a:t>
-            </a:r>
-            <a:endParaRPr lang="en-US" sz="1400" dirty="0"/>
-          </a:p>
-        </p:txBody>
-      </p:sp>
-      <p:sp>
-        <p:nvSpPr>
-          <p:cNvPr id="8" name="Text 5"/>
-          <p:cNvSpPr txBox="1"/>
-          <p:nvPr/>
-        </p:nvSpPr>
-        <p:spPr>
-          <a:xfrm>
-            <a:off x="7863840" y="3749040"/>
-            <a:ext cx="3840480" cy="2377440"/>
-          </a:xfrm>
-          <a:prstGeom prst="rect">
-            <a:avLst/>
-          </a:prstGeom>
-          <a:noFill/>
-          <a:ln/>
-        </p:spPr>
-        <p:txBody>
-          <a:bodyPr wrap="square" lIns="0" tIns="0" rIns="0" bIns="0" rtlCol="0" anchor="t"/>
-          <a:lstStyle/>
-          <a:p>
-            <a:pPr marL="342900" indent="-342900">
-              <a:spcAft>
-                <a:spcPts val="800"/>
-              </a:spcAft>
-              <a:buSzPct val="100000"/>
-              <a:buChar char="•"/>
-            </a:pPr>
-            <a:r>
-              <a:rPr lang="en-US" sz="1400" dirty="0">
-                <a:solidFill>
-                  <a:srgbClr val="1F2A44"/>
-                </a:solidFill>
-                <a:latin typeface="Calibri" pitchFamily="34" charset="0"/>
-                <a:ea typeface="Calibri" pitchFamily="34" charset="-122"/>
-                <a:cs typeface="Calibri" pitchFamily="34" charset="-120"/>
-              </a:rPr>
-              <a:t>Three cases got slightly worse, one slightly better: no clear effect.</a:t>
-            </a:r>
-            <a:endParaRPr lang="en-US" sz="1400" dirty="0"/>
-          </a:p>
-          <a:p>
-            <a:pPr marL="342900" indent="-342900">
-              <a:spcAft>
-                <a:spcPts val="800"/>
-              </a:spcAft>
-              <a:buSzPct val="100000"/>
-              <a:buChar char="•"/>
-            </a:pPr>
-            <a:r>
-              <a:rPr lang="en-US" sz="1400" dirty="0">
-                <a:solidFill>
-                  <a:srgbClr val="1F2A44"/>
-                </a:solidFill>
-                <a:latin typeface="Calibri" pitchFamily="34" charset="0"/>
-                <a:ea typeface="Calibri" pitchFamily="34" charset="-122"/>
-                <a:cs typeface="Calibri" pitchFamily="34" charset="-120"/>
-              </a:rPr>
-              <a:t>The same state measured twice differs by 0.006–0.015 dB, and handling by about 0.04 dB.</a:t>
-            </a:r>
-            <a:endParaRPr lang="en-US" sz="1400" dirty="0"/>
-          </a:p>
-          <a:p>
-            <a:pPr marL="342900" indent="-342900">
-              <a:spcAft>
-                <a:spcPts val="800"/>
-              </a:spcAft>
-              <a:buSzPct val="100000"/>
-              <a:buChar char="•"/>
-            </a:pPr>
-            <a:r>
-              <a:rPr lang="en-US" sz="1400" dirty="0">
-                <a:solidFill>
-                  <a:srgbClr val="1F2A44"/>
-                </a:solidFill>
-                <a:latin typeface="Calibri" pitchFamily="34" charset="0"/>
-                <a:ea typeface="Calibri" pitchFamily="34" charset="-122"/>
-                <a:cs typeface="Calibri" pitchFamily="34" charset="-120"/>
-              </a:rPr>
-              <a:t>The carpet on the empty floor changed the error 40 times more.</a:t>
-            </a:r>
-            <a:endParaRPr lang="en-US" sz="1400" dirty="0"/>
-          </a:p>
-        </p:txBody>
-      </p:sp>
-      <p:sp>
-        <p:nvSpPr>
-          <p:cNvPr id="9" name="Text 6"/>
-          <p:cNvSpPr txBox="1"/>
-          <p:nvPr/>
-        </p:nvSpPr>
-        <p:spPr>
-          <a:xfrm>
-            <a:off x="548640" y="6355080"/>
-            <a:ext cx="10332720" cy="274320"/>
-          </a:xfrm>
-          <a:prstGeom prst="rect">
-            <a:avLst/>
-          </a:prstGeom>
-          <a:noFill/>
-          <a:ln/>
-        </p:spPr>
-        <p:txBody>
-          <a:bodyPr wrap="square" lIns="0" tIns="0" rIns="0" bIns="0" rtlCol="0" anchor="ctr"/>
-          <a:lstStyle/>
-          <a:p>
-            <a:pPr indent="0" marL="0">
-              <a:buNone/>
-            </a:pPr>
-            <a:r>
-              <a:rPr lang="en-US" sz="1100" dirty="0">
-                <a:solidFill>
-                  <a:srgbClr val="5B6578"/>
-                </a:solidFill>
-                <a:latin typeface="Calibri" pitchFamily="34" charset="0"/>
-                <a:ea typeface="Calibri" pitchFamily="34" charset="-122"/>
-                <a:cs typeface="Calibri" pitchFamily="34" charset="-120"/>
-              </a:rPr>
-              <a:t>Runs: foam-out → tripod-unwrapped → ring-unwrapped → -2 (23 Sep); wall-direct-absorber → ring-bare (24 Sep). Carpet: 2.054 → 1.317 dB.</a:t>
-            </a:r>
-            <a:endParaRPr lang="en-US" sz="1100" dirty="0"/>
-          </a:p>
-        </p:txBody>
-      </p:sp>
-      <p:sp>
-        <p:nvSpPr>
-          <p:cNvPr id="10" name="Text 7"/>
-          <p:cNvSpPr txBox="1"/>
-          <p:nvPr/>
-        </p:nvSpPr>
-        <p:spPr>
-          <a:xfrm>
-            <a:off x="11155680" y="6355080"/>
-            <a:ext cx="457200" cy="274320"/>
-          </a:xfrm>
-          <a:prstGeom prst="rect">
-            <a:avLst/>
-          </a:prstGeom>
-          <a:noFill/>
-          <a:ln/>
-        </p:spPr>
-        <p:txBody>
-          <a:bodyPr wrap="square" lIns="0" tIns="0" rIns="0" bIns="0" rtlCol="0" anchor="ctr"/>
-          <a:lstStyle/>
-          <a:p>
-            <a:pPr algn="r" indent="0" marL="0">
-              <a:buNone/>
-            </a:pPr>
-            <a:r>
-              <a:rPr lang="en-US" sz="1200" dirty="0">
-                <a:solidFill>
-                  <a:srgbClr val="5B6578"/>
-                </a:solidFill>
-                <a:latin typeface="Calibri" pitchFamily="34" charset="0"/>
-                <a:ea typeface="Calibri" pitchFamily="34" charset="-122"/>
-                <a:cs typeface="Calibri" pitchFamily="34" charset="-120"/>
-              </a:rPr>
-              <a:t>6</a:t>
-            </a:r>
-            <a:endParaRPr lang="en-US" sz="1200" dirty="0"/>
-          </a:p>
-        </p:txBody>
-      </p:sp>
-    </p:spTree>
-  </p:cSld>
-  <p:clrMapOvr>
-    <a:masterClrMapping/>
-  </p:clrMapOvr>
-</p:sld>
-</file>
-
-<file path=ppt/slides/slide7.xml><?xml version="1.0" encoding="utf-8"?>
-<p:sld xmlns:a="http://schemas.openxmlformats.org/drawingml/2006/main" xmlns:r="http://schemas.openxmlformats.org/officeDocument/2006/relationships" xmlns:p="http://schemas.openxmlformats.org/presentationml/2006/main">
-  <p:cSld name="Slide 7">
     <p:bg>
       <p:bgPr>
         <a:solidFill>
@@ -4760,7 +3937,7 @@
       </p:sp>
       <p:graphicFrame>
         <p:nvGraphicFramePr>
-          <p:cNvPr id="8" name="Table 0"/>
+          <p:cNvPr id="7" name="Table 0"/>
           <p:cNvGraphicFramePr>
             <a:graphicFrameLocks noGrp="1"/>
           </p:cNvGraphicFramePr>
@@ -8007,7 +7184,7 @@
                           <a:ea typeface="Calibri" pitchFamily="34" charset="-122"/>
                           <a:cs typeface="Calibri" pitchFamily="34" charset="-120"/>
                         </a:rPr>
-                        <a:t>1</a:t>
+                        <a:t>1.0</a:t>
                       </a:r>
                       <a:endParaRPr lang="en-US" sz="1400" dirty="0">
                         <a:latin typeface="Calibri" charset="0"/>
@@ -8476,7 +7653,7 @@
                           <a:ea typeface="Calibri" pitchFamily="34" charset="-122"/>
                           <a:cs typeface="Calibri" pitchFamily="34" charset="-120"/>
                         </a:rPr>
-                        <a:t>1</a:t>
+                        <a:t>1.0</a:t>
                       </a:r>
                       <a:endParaRPr lang="en-US" sz="1400" dirty="0">
                         <a:latin typeface="Calibri" charset="0"/>
@@ -8945,7 +8122,7 @@
                           <a:ea typeface="Calibri" pitchFamily="34" charset="-122"/>
                           <a:cs typeface="Calibri" pitchFamily="34" charset="-120"/>
                         </a:rPr>
-                        <a:t>1</a:t>
+                        <a:t>1.0</a:t>
                       </a:r>
                       <a:endParaRPr lang="en-US" sz="1400" dirty="0">
                         <a:latin typeface="Calibri" charset="0"/>
@@ -9414,7 +8591,7 @@
                           <a:ea typeface="Calibri" pitchFamily="34" charset="-122"/>
                           <a:cs typeface="Calibri" pitchFamily="34" charset="-120"/>
                         </a:rPr>
-                        <a:t>1</a:t>
+                        <a:t>1.0</a:t>
                       </a:r>
                       <a:endParaRPr lang="en-US" sz="1400" dirty="0">
                         <a:latin typeface="Calibri" charset="0"/>
@@ -9883,7 +9060,7 @@
                           <a:ea typeface="Calibri" pitchFamily="34" charset="-122"/>
                           <a:cs typeface="Calibri" pitchFamily="34" charset="-120"/>
                         </a:rPr>
-                        <a:t>1</a:t>
+                        <a:t>1.0</a:t>
                       </a:r>
                       <a:endParaRPr lang="en-US" sz="1400" dirty="0">
                         <a:latin typeface="Calibri" charset="0"/>
@@ -10352,7 +9529,7 @@
                           <a:ea typeface="Calibri" pitchFamily="34" charset="-122"/>
                           <a:cs typeface="Calibri" pitchFamily="34" charset="-120"/>
                         </a:rPr>
-                        <a:t>1</a:t>
+                        <a:t>1.0</a:t>
                       </a:r>
                       <a:endParaRPr lang="en-US" sz="1400" dirty="0">
                         <a:latin typeface="Calibri" charset="0"/>
@@ -10821,7 +9998,7 @@
                           <a:ea typeface="Calibri" pitchFamily="34" charset="-122"/>
                           <a:cs typeface="Calibri" pitchFamily="34" charset="-120"/>
                         </a:rPr>
-                        <a:t>1</a:t>
+                        <a:t>1.0</a:t>
                       </a:r>
                       <a:endParaRPr lang="en-US" sz="1400" dirty="0">
                         <a:latin typeface="Calibri" charset="0"/>
@@ -12117,7 +11294,7 @@
                 <a:ea typeface="Calibri" pitchFamily="34" charset="-122"/>
                 <a:cs typeface="Calibri" pitchFamily="34" charset="-120"/>
               </a:rPr>
-              <a:t>* Partial bands: only the tones above 5 kHz are measured (4 and 5 tones). 3–5 kHz is left out because of the loudspeaker: its cone rocks near 4.4 kHz. ISO values are an analogue, not a qualification of the room.</a:t>
+              <a:t>* Partial bands: only the tones above 5 kHz are measured (4 and 5 tones). 3–5 kHz is left out because of the loudspeaker: its cone has a rocking mode near 4.4 kHz. ISO values are an analogue, not a qualification of the room.</a:t>
             </a:r>
             <a:endParaRPr lang="en-US" sz="1200" dirty="0"/>
           </a:p>
@@ -12156,7 +11333,7 @@
                 <a:ea typeface="Calibri" pitchFamily="34" charset="-122"/>
                 <a:cs typeface="Calibri" pitchFamily="34" charset="-120"/>
               </a:rPr>
-              <a:t>7</a:t>
+              <a:t>6</a:t>
             </a:r>
             <a:endParaRPr lang="en-US" sz="1200" dirty="0"/>
           </a:p>
@@ -12170,9 +11347,9 @@
 </p:sld>
 </file>
 
-<file path=ppt/slides/slide8.xml><?xml version="1.0" encoding="utf-8"?>
+<file path=ppt/slides/slide7.xml><?xml version="1.0" encoding="utf-8"?>
 <p:sld xmlns:a="http://schemas.openxmlformats.org/drawingml/2006/main" xmlns:r="http://schemas.openxmlformats.org/officeDocument/2006/relationships" xmlns:p="http://schemas.openxmlformats.org/presentationml/2006/main">
-  <p:cSld name="Slide 8">
+  <p:cSld name="Slide 7">
     <p:bg>
       <p:bgPr>
         <a:solidFill>
@@ -12251,7 +11428,7 @@
                 <a:ea typeface="Calibri" pitchFamily="34" charset="-122"/>
                 <a:cs typeface="Calibri" pitchFamily="34" charset="-120"/>
               </a:rPr>
-              <a:t>AFTER</a:t>
+              <a:t>COMPARISON</a:t>
             </a:r>
             <a:endParaRPr lang="en-US" sz="1400" dirty="0"/>
           </a:p>
@@ -12290,7 +11467,7 @@
                 <a:ea typeface="Cambria" pitchFamily="34" charset="-122"/>
                 <a:cs typeface="Cambria" pitchFamily="34" charset="-120"/>
               </a:rPr>
-              <a:t>The new polar is rounder</a:t>
+              <a:t>31 Aug and 30 Sep on the same axes</a:t>
             </a:r>
             <a:endParaRPr lang="en-US" sz="3400" dirty="0"/>
           </a:p>
@@ -12333,7 +11510,7 @@
                 <a:ea typeface="Calibri" pitchFamily="34" charset="-122"/>
                 <a:cs typeface="Calibri" pitchFamily="34" charset="-120"/>
               </a:rPr>
-              <a:t>Same kind of measurement, same axes, on 30 Sep.</a:t>
+              <a:t>Red: 31 Aug, factory microphone files, 7.35 V. Blue: 30 Sep, corrected files, 11.7 V.</a:t>
             </a:r>
             <a:endParaRPr lang="en-US" sz="1600" dirty="0"/>
           </a:p>
@@ -12354,7 +11531,7 @@
                 <a:ea typeface="Calibri" pitchFamily="34" charset="-122"/>
                 <a:cs typeface="Calibri" pitchFamily="34" charset="-120"/>
               </a:rPr>
-              <a:t>The microphones now carry their measured corrections, and the room has been treated.</a:t>
+              <a:t>The propeller was mounted the other way round between the two, so the thrust points the other way. We do not expect this to change the sound.</a:t>
             </a:r>
             <a:endParaRPr lang="en-US" sz="1600" dirty="0"/>
           </a:p>
@@ -12375,7 +11552,7 @@
                 <a:ea typeface="Calibri" pitchFamily="34" charset="-122"/>
                 <a:cs typeface="Calibri" pitchFamily="34" charset="-120"/>
               </a:rPr>
-              <a:t>The outline is smooth and close to a circle.</a:t>
+              <a:t>The 30 Sep outline is smoother.</a:t>
             </a:r>
             <a:endParaRPr lang="en-US" sz="1600" dirty="0"/>
           </a:p>
@@ -12553,7 +11730,7 @@
                 <a:ea typeface="Calibri" pitchFamily="34" charset="-122"/>
                 <a:cs typeface="Calibri" pitchFamily="34" charset="-120"/>
               </a:rPr>
-              <a:t>8</a:t>
+              <a:t>7</a:t>
             </a:r>
             <a:endParaRPr lang="en-US" sz="1200" dirty="0"/>
           </a:p>
@@ -12567,9 +11744,9 @@
 </p:sld>
 </file>
 
-<file path=ppt/slides/slide9.xml><?xml version="1.0" encoding="utf-8"?>
+<file path=ppt/slides/slide8.xml><?xml version="1.0" encoding="utf-8"?>
 <p:sld xmlns:a="http://schemas.openxmlformats.org/drawingml/2006/main" xmlns:r="http://schemas.openxmlformats.org/officeDocument/2006/relationships" xmlns:p="http://schemas.openxmlformats.org/presentationml/2006/main">
-  <p:cSld name="Slide 9">
+  <p:cSld name="Slide 8">
     <p:bg>
       <p:bgPr>
         <a:solidFill>
@@ -12790,7 +11967,7 @@
                 <a:ea typeface="Calibri" pitchFamily="34" charset="-122"/>
                 <a:cs typeface="Calibri" pitchFamily="34" charset="-120"/>
               </a:rPr>
-              <a:t>Naked</a:t>
+              <a:t>Bare</a:t>
             </a:r>
             <a:endParaRPr lang="en-US" sz="1800" dirty="0"/>
           </a:p>
@@ -13056,11 +12233,11 @@
             <a:avLst/>
           </a:prstGeom>
           <a:solidFill>
-            <a:srgbClr val="D6336C"/>
+            <a:srgbClr val="1098AD"/>
           </a:solidFill>
           <a:ln w="12700">
             <a:solidFill>
-              <a:srgbClr val="D6336C"/>
+              <a:srgbClr val="1098AD"/>
             </a:solidFill>
             <a:prstDash val="solid"/>
           </a:ln>
@@ -13319,7 +12496,7 @@
                 <a:ea typeface="Calibri" pitchFamily="34" charset="-122"/>
                 <a:cs typeface="Calibri" pitchFamily="34" charset="-120"/>
               </a:rPr>
-              <a:t>louder than naked, on average</a:t>
+              <a:t>louder than bare, on average</a:t>
             </a:r>
             <a:endParaRPr lang="en-US" sz="1400" dirty="0"/>
           </a:p>
@@ -13436,7 +12613,7 @@
                 <a:ea typeface="Calibri" pitchFamily="34" charset="-122"/>
                 <a:cs typeface="Calibri" pitchFamily="34" charset="-120"/>
               </a:rPr>
-              <a:t>9</a:t>
+              <a:t>8</a:t>
             </a:r>
             <a:endParaRPr lang="en-US" sz="1200" dirty="0"/>
           </a:p>

</xml_diff>